<commit_message>
feat(deck): simplify cover slide
- drop "최종 보고" from the top tag, the subtitle line and the KPI meta line
- move the applicant info to a compact horizontal card at the bottom right

Co-Authored-By: Claude Sonnet 5.5 <noreply@anthropic.com>
</commit_message>
<xml_diff>
--- a/outputs/pptx/puzzledata_repair_report.pptx
+++ b/outputs/pptx/puzzledata_repair_report.pptx
@@ -125,21 +125,21 @@
   <p:extLst>
     <p:ext uri="{521415D9-36F7-43E2-AB2F-B90AF26B5E84}">
       <p14:sectionLst xmlns:p14="http://schemas.microsoft.com/office/powerpoint/2010/main">
-        <p14:section name="Part 00 · 인트로" id="{68324E73-1E46-4B75-8283-026181378BD4}">
+        <p14:section name="Part 00 · 인트로" id="{09FA97E9-14FB-41DB-85EC-AD9B6D5E6925}">
           <p14:sldIdLst>
             <p14:sldId id="256"/>
             <p14:sldId id="257"/>
             <p14:sldId id="258"/>
           </p14:sldIdLst>
         </p14:section>
-        <p14:section name="Part 01 · 데이터 진단" id="{269640DF-18FA-44C5-9AF3-F3720A6B48B2}">
+        <p14:section name="Part 01 · 데이터 진단" id="{580976A9-3ADA-4B4F-A292-86F33A27E36C}">
           <p14:sldIdLst>
             <p14:sldId id="259"/>
             <p14:sldId id="260"/>
             <p14:sldId id="261"/>
           </p14:sldIdLst>
         </p14:section>
-        <p14:section name="Part 02 · 병목 규명" id="{76BC0F13-AE88-4498-826E-2E39D26895AA}">
+        <p14:section name="Part 02 · 병목 규명" id="{32A3815A-E26F-4AA4-B8D6-F37BD5FDCF20}">
           <p14:sldIdLst>
             <p14:sldId id="262"/>
             <p14:sldId id="263"/>
@@ -152,14 +152,14 @@
             <p14:sldId id="270"/>
           </p14:sldIdLst>
         </p14:section>
-        <p14:section name="Part 03 · 개선 전략" id="{B6D713F4-E1A6-4619-A2CF-8A147650B058}">
+        <p14:section name="Part 03 · 개선 전략" id="{BA40D4C9-D3D3-483A-B057-933186BFFEC3}">
           <p14:sldIdLst>
             <p14:sldId id="271"/>
             <p14:sldId id="272"/>
             <p14:sldId id="273"/>
           </p14:sldIdLst>
         </p14:section>
-        <p14:section name="Part 04 · Q&amp;A" id="{74809749-8C35-4CB1-9F29-7FE72F86C697}">
+        <p14:section name="Part 04 · Q&amp;A" id="{BE8DA081-32DE-4473-809B-7797A2B15EB0}">
           <p14:sldIdLst>
             <p14:sldId id="274"/>
           </p14:sldIdLst>
@@ -4885,7 +4885,7 @@
                 <a:ea typeface="맑은 고딕"/>
                 <a:cs typeface="Consolas"/>
               </a:rPr>
-              <a:t>[ 00 / 퍼즐데이터 채용 과제 최종 보고 ]</a:t>
+              <a:t>[ 00 / 퍼즐데이터 채용 과제 ]</a:t>
             </a:r>
           </a:p>
         </p:txBody>
@@ -5049,104 +5049,14 @@
       </p:sp>
       <p:sp>
         <p:nvSpPr>
-          <p:cNvPr id="6" name="sub:L1:sub"/>
-          <p:cNvSpPr txBox="1"/>
-          <p:nvPr/>
-        </p:nvSpPr>
-        <p:spPr>
-          <a:xfrm>
-            <a:off x="502920" y="3813048"/>
-            <a:ext cx="6675120" cy="231140"/>
-          </a:xfrm>
-          <a:prstGeom prst="rect">
-            <a:avLst/>
-          </a:prstGeom>
-          <a:noFill/>
-        </p:spPr>
-        <p:txBody>
-          <a:bodyPr wrap="square" lIns="0" tIns="0" rIns="0" bIns="0" anchor="t">
-            <a:noAutofit/>
-          </a:bodyPr>
-          <a:lstStyle/>
-          <a:p>
-            <a:pPr algn="l">
-              <a:lnSpc>
-                <a:spcPts val="1820"/>
-              </a:lnSpc>
-              <a:spcBef>
-                <a:spcPts val="0"/>
-              </a:spcBef>
-              <a:buNone/>
-            </a:pPr>
-            <a:r>
-              <a:rPr lang="ko-KR" sz="1300" b="0" dirty="0">
-                <a:solidFill>
-                  <a:srgbClr val="334155"/>
-                </a:solidFill>
-                <a:latin typeface="맑은 고딕"/>
-                <a:ea typeface="맑은 고딕"/>
-                <a:cs typeface="맑은 고딕"/>
-              </a:rPr>
-              <a:t>프로세스 마이닝 기반 · 무손실 전처리 · 대기 병목 규명 · TO-BE 전략</a:t>
-            </a:r>
-          </a:p>
-        </p:txBody>
-      </p:sp>
-      <p:sp>
-        <p:nvSpPr>
-          <p:cNvPr id="7" name="label:L1:meta"/>
-          <p:cNvSpPr txBox="1"/>
-          <p:nvPr/>
-        </p:nvSpPr>
-        <p:spPr>
-          <a:xfrm>
-            <a:off x="502920" y="5623560"/>
-            <a:ext cx="6675120" cy="176530"/>
-          </a:xfrm>
-          <a:prstGeom prst="rect">
-            <a:avLst/>
-          </a:prstGeom>
-          <a:noFill/>
-        </p:spPr>
-        <p:txBody>
-          <a:bodyPr wrap="square" lIns="0" tIns="0" rIns="0" bIns="0" anchor="t">
-            <a:noAutofit/>
-          </a:bodyPr>
-          <a:lstStyle/>
-          <a:p>
-            <a:pPr algn="l">
-              <a:lnSpc>
-                <a:spcPts val="1390"/>
-              </a:lnSpc>
-              <a:spcBef>
-                <a:spcPts val="0"/>
-              </a:spcBef>
-              <a:buNone/>
-            </a:pPr>
-            <a:r>
-              <a:rPr lang="ko-KR" sz="1050" b="1" dirty="0">
-                <a:solidFill>
-                  <a:srgbClr val="64748B"/>
-                </a:solidFill>
-                <a:latin typeface="Consolas"/>
-                <a:ea typeface="맑은 고딕"/>
-                <a:cs typeface="Consolas"/>
-              </a:rPr>
-              <a:t>13,262 EVENTS · 1,000 CASES · 927 ANALYSIS COHORT</a:t>
-            </a:r>
-          </a:p>
-        </p:txBody>
-      </p:sp>
-      <p:sp>
-        <p:nvSpPr>
-          <p:cNvPr id="8" name="applicant"/>
+          <p:cNvPr id="6" name="applicant"/>
           <p:cNvSpPr/>
           <p:nvPr/>
         </p:nvSpPr>
         <p:spPr>
           <a:xfrm>
-            <a:off x="7756855" y="1783080"/>
-            <a:ext cx="3931920" cy="4316476"/>
+            <a:off x="5653735" y="5257800"/>
+            <a:ext cx="6035040" cy="868680"/>
           </a:xfrm>
           <a:prstGeom prst="rect">
             <a:avLst/>
@@ -5185,14 +5095,14 @@
       </p:sp>
       <p:sp>
         <p:nvSpPr>
-          <p:cNvPr id="9" name="label:L1:t"/>
-          <p:cNvSpPr txBox="1"/>
-          <p:nvPr/>
-        </p:nvSpPr>
-        <p:spPr>
-          <a:xfrm>
-            <a:off x="8031175" y="2057400"/>
-            <a:ext cx="3383279" cy="158750"/>
+          <p:cNvPr id="7" name="label:L1:k-POSITION"/>
+          <p:cNvSpPr txBox="1"/>
+          <p:nvPr/>
+        </p:nvSpPr>
+        <p:spPr>
+          <a:xfrm>
+            <a:off x="5836615" y="5394960"/>
+            <a:ext cx="1280160" cy="158750"/>
           </a:xfrm>
           <a:prstGeom prst="rect">
             <a:avLst/>
@@ -5217,7 +5127,7 @@
             <a:r>
               <a:rPr lang="ko-KR" sz="950" b="1" dirty="0">
                 <a:solidFill>
-                  <a:srgbClr val="64748B"/>
+                  <a:srgbClr val="2563EB"/>
                 </a:solidFill>
                 <a:latin typeface="Consolas"/>
                 <a:ea typeface="맑은 고딕"/>
@@ -5230,37 +5140,37 @@
       </p:sp>
       <p:sp>
         <p:nvSpPr>
-          <p:cNvPr id="10" name="body:L1:v-POSITION"/>
-          <p:cNvSpPr txBox="1"/>
-          <p:nvPr/>
-        </p:nvSpPr>
-        <p:spPr>
-          <a:xfrm>
-            <a:off x="8031175" y="2298446"/>
-            <a:ext cx="3383279" cy="391160"/>
-          </a:xfrm>
-          <a:prstGeom prst="rect">
-            <a:avLst/>
-          </a:prstGeom>
-          <a:noFill/>
-        </p:spPr>
-        <p:txBody>
-          <a:bodyPr wrap="square" lIns="0" tIns="0" rIns="0" bIns="0" anchor="t">
-            <a:noAutofit/>
-          </a:bodyPr>
-          <a:lstStyle/>
-          <a:p>
-            <a:pPr algn="l">
-              <a:lnSpc>
-                <a:spcPts val="3080"/>
-              </a:lnSpc>
-              <a:spcBef>
-                <a:spcPts val="0"/>
-              </a:spcBef>
-              <a:buNone/>
-            </a:pPr>
-            <a:r>
-              <a:rPr lang="ko-KR" sz="2200" b="1" dirty="0">
+          <p:cNvPr id="8" name="body:L1:v-POSITION"/>
+          <p:cNvSpPr txBox="1"/>
+          <p:nvPr/>
+        </p:nvSpPr>
+        <p:spPr>
+          <a:xfrm>
+            <a:off x="5836615" y="5669280"/>
+            <a:ext cx="1280160" cy="266700"/>
+          </a:xfrm>
+          <a:prstGeom prst="rect">
+            <a:avLst/>
+          </a:prstGeom>
+          <a:noFill/>
+        </p:spPr>
+        <p:txBody>
+          <a:bodyPr wrap="square" lIns="0" tIns="0" rIns="0" bIns="0" anchor="t">
+            <a:noAutofit/>
+          </a:bodyPr>
+          <a:lstStyle/>
+          <a:p>
+            <a:pPr algn="l">
+              <a:lnSpc>
+                <a:spcPts val="2100"/>
+              </a:lnSpc>
+              <a:spcBef>
+                <a:spcPts val="0"/>
+              </a:spcBef>
+              <a:buNone/>
+            </a:pPr>
+            <a:r>
+              <a:rPr lang="ko-KR" sz="1500" b="1" dirty="0">
                 <a:solidFill>
                   <a:srgbClr val="0F172A"/>
                 </a:solidFill>
@@ -5269,20 +5179,290 @@
                 <a:cs typeface="맑은 고딕"/>
               </a:rPr>
               <a:t>데이터 분석가</a:t>
+            </a:r>
+          </a:p>
+        </p:txBody>
+      </p:sp>
+      <p:sp>
+        <p:nvSpPr>
+          <p:cNvPr id="9" name="label:L1:k-LEVEL"/>
+          <p:cNvSpPr txBox="1"/>
+          <p:nvPr/>
+        </p:nvSpPr>
+        <p:spPr>
+          <a:xfrm>
+            <a:off x="7345375" y="5394960"/>
+            <a:ext cx="1280160" cy="158750"/>
+          </a:xfrm>
+          <a:prstGeom prst="rect">
+            <a:avLst/>
+          </a:prstGeom>
+          <a:noFill/>
+        </p:spPr>
+        <p:txBody>
+          <a:bodyPr wrap="square" lIns="0" tIns="0" rIns="0" bIns="0" anchor="t">
+            <a:noAutofit/>
+          </a:bodyPr>
+          <a:lstStyle/>
+          <a:p>
+            <a:pPr algn="l">
+              <a:lnSpc>
+                <a:spcPts val="1250"/>
+              </a:lnSpc>
+              <a:spcBef>
+                <a:spcPts val="0"/>
+              </a:spcBef>
+              <a:buNone/>
+            </a:pPr>
+            <a:r>
+              <a:rPr lang="ko-KR" sz="950" b="1" dirty="0">
+                <a:solidFill>
+                  <a:srgbClr val="2563EB"/>
+                </a:solidFill>
+                <a:latin typeface="Consolas"/>
+                <a:ea typeface="맑은 고딕"/>
+                <a:cs typeface="Consolas"/>
+              </a:rPr>
+              <a:t>LEVEL</a:t>
+            </a:r>
+          </a:p>
+        </p:txBody>
+      </p:sp>
+      <p:sp>
+        <p:nvSpPr>
+          <p:cNvPr id="10" name="body:L1:v-LEVEL"/>
+          <p:cNvSpPr txBox="1"/>
+          <p:nvPr/>
+        </p:nvSpPr>
+        <p:spPr>
+          <a:xfrm>
+            <a:off x="7345375" y="5669280"/>
+            <a:ext cx="1280160" cy="266700"/>
+          </a:xfrm>
+          <a:prstGeom prst="rect">
+            <a:avLst/>
+          </a:prstGeom>
+          <a:noFill/>
+        </p:spPr>
+        <p:txBody>
+          <a:bodyPr wrap="square" lIns="0" tIns="0" rIns="0" bIns="0" anchor="t">
+            <a:noAutofit/>
+          </a:bodyPr>
+          <a:lstStyle/>
+          <a:p>
+            <a:pPr algn="l">
+              <a:lnSpc>
+                <a:spcPts val="2100"/>
+              </a:lnSpc>
+              <a:spcBef>
+                <a:spcPts val="0"/>
+              </a:spcBef>
+              <a:buNone/>
+            </a:pPr>
+            <a:r>
+              <a:rPr lang="ko-KR" sz="1500" b="1" dirty="0">
+                <a:solidFill>
+                  <a:srgbClr val="0F172A"/>
+                </a:solidFill>
+                <a:latin typeface="맑은 고딕"/>
+                <a:ea typeface="맑은 고딕"/>
+                <a:cs typeface="맑은 고딕"/>
+              </a:rPr>
+              <a:t>신입</a:t>
+            </a:r>
+          </a:p>
+        </p:txBody>
+      </p:sp>
+      <p:sp>
+        <p:nvSpPr>
+          <p:cNvPr id="11" name="label:L1:k-NAME"/>
+          <p:cNvSpPr txBox="1"/>
+          <p:nvPr/>
+        </p:nvSpPr>
+        <p:spPr>
+          <a:xfrm>
+            <a:off x="8854135" y="5394960"/>
+            <a:ext cx="1280160" cy="158750"/>
+          </a:xfrm>
+          <a:prstGeom prst="rect">
+            <a:avLst/>
+          </a:prstGeom>
+          <a:noFill/>
+        </p:spPr>
+        <p:txBody>
+          <a:bodyPr wrap="square" lIns="0" tIns="0" rIns="0" bIns="0" anchor="t">
+            <a:noAutofit/>
+          </a:bodyPr>
+          <a:lstStyle/>
+          <a:p>
+            <a:pPr algn="l">
+              <a:lnSpc>
+                <a:spcPts val="1250"/>
+              </a:lnSpc>
+              <a:spcBef>
+                <a:spcPts val="0"/>
+              </a:spcBef>
+              <a:buNone/>
+            </a:pPr>
+            <a:r>
+              <a:rPr lang="ko-KR" sz="950" b="1" dirty="0">
+                <a:solidFill>
+                  <a:srgbClr val="2563EB"/>
+                </a:solidFill>
+                <a:latin typeface="Consolas"/>
+                <a:ea typeface="맑은 고딕"/>
+                <a:cs typeface="Consolas"/>
+              </a:rPr>
+              <a:t>NAME</a:t>
+            </a:r>
+          </a:p>
+        </p:txBody>
+      </p:sp>
+      <p:sp>
+        <p:nvSpPr>
+          <p:cNvPr id="12" name="body:L1:v-NAME"/>
+          <p:cNvSpPr txBox="1"/>
+          <p:nvPr/>
+        </p:nvSpPr>
+        <p:spPr>
+          <a:xfrm>
+            <a:off x="8854135" y="5669280"/>
+            <a:ext cx="1280160" cy="266700"/>
+          </a:xfrm>
+          <a:prstGeom prst="rect">
+            <a:avLst/>
+          </a:prstGeom>
+          <a:noFill/>
+        </p:spPr>
+        <p:txBody>
+          <a:bodyPr wrap="square" lIns="0" tIns="0" rIns="0" bIns="0" anchor="t">
+            <a:noAutofit/>
+          </a:bodyPr>
+          <a:lstStyle/>
+          <a:p>
+            <a:pPr algn="l">
+              <a:lnSpc>
+                <a:spcPts val="2100"/>
+              </a:lnSpc>
+              <a:spcBef>
+                <a:spcPts val="0"/>
+              </a:spcBef>
+              <a:buNone/>
+            </a:pPr>
+            <a:r>
+              <a:rPr lang="ko-KR" sz="1500" b="1" dirty="0">
+                <a:solidFill>
+                  <a:srgbClr val="0F172A"/>
+                </a:solidFill>
+                <a:latin typeface="맑은 고딕"/>
+                <a:ea typeface="맑은 고딕"/>
+                <a:cs typeface="맑은 고딕"/>
+              </a:rPr>
+              <a:t>조승훈</a:t>
+            </a:r>
+          </a:p>
+        </p:txBody>
+      </p:sp>
+      <p:sp>
+        <p:nvSpPr>
+          <p:cNvPr id="13" name="label:L1:k-DATE"/>
+          <p:cNvSpPr txBox="1"/>
+          <p:nvPr/>
+        </p:nvSpPr>
+        <p:spPr>
+          <a:xfrm>
+            <a:off x="10362895" y="5394960"/>
+            <a:ext cx="1280160" cy="158750"/>
+          </a:xfrm>
+          <a:prstGeom prst="rect">
+            <a:avLst/>
+          </a:prstGeom>
+          <a:noFill/>
+        </p:spPr>
+        <p:txBody>
+          <a:bodyPr wrap="square" lIns="0" tIns="0" rIns="0" bIns="0" anchor="t">
+            <a:noAutofit/>
+          </a:bodyPr>
+          <a:lstStyle/>
+          <a:p>
+            <a:pPr algn="l">
+              <a:lnSpc>
+                <a:spcPts val="1250"/>
+              </a:lnSpc>
+              <a:spcBef>
+                <a:spcPts val="0"/>
+              </a:spcBef>
+              <a:buNone/>
+            </a:pPr>
+            <a:r>
+              <a:rPr lang="ko-KR" sz="950" b="1" dirty="0">
+                <a:solidFill>
+                  <a:srgbClr val="2563EB"/>
+                </a:solidFill>
+                <a:latin typeface="Consolas"/>
+                <a:ea typeface="맑은 고딕"/>
+                <a:cs typeface="Consolas"/>
+              </a:rPr>
+              <a:t>DATE</a:t>
+            </a:r>
+          </a:p>
+        </p:txBody>
+      </p:sp>
+      <p:sp>
+        <p:nvSpPr>
+          <p:cNvPr id="14" name="body:L1:v-DATE"/>
+          <p:cNvSpPr txBox="1"/>
+          <p:nvPr/>
+        </p:nvSpPr>
+        <p:spPr>
+          <a:xfrm>
+            <a:off x="10362895" y="5669280"/>
+            <a:ext cx="1280160" cy="251460"/>
+          </a:xfrm>
+          <a:prstGeom prst="rect">
+            <a:avLst/>
+          </a:prstGeom>
+          <a:noFill/>
+        </p:spPr>
+        <p:txBody>
+          <a:bodyPr wrap="square" lIns="0" tIns="0" rIns="0" bIns="0" anchor="t">
+            <a:noAutofit/>
+          </a:bodyPr>
+          <a:lstStyle/>
+          <a:p>
+            <a:pPr algn="l">
+              <a:lnSpc>
+                <a:spcPts val="1980"/>
+              </a:lnSpc>
+              <a:spcBef>
+                <a:spcPts val="0"/>
+              </a:spcBef>
+              <a:buNone/>
+            </a:pPr>
+            <a:r>
+              <a:rPr lang="ko-KR" sz="1500" b="1" dirty="0">
+                <a:solidFill>
+                  <a:srgbClr val="0F172A"/>
+                </a:solidFill>
+                <a:latin typeface="Consolas"/>
+                <a:ea typeface="맑은 고딕"/>
+                <a:cs typeface="Consolas"/>
+              </a:rPr>
+              <a:t>2026.10.27</a:t>
             </a:r>
           </a:p>
         </p:txBody>
       </p:sp>
       <p:cxnSp>
         <p:nvCxnSpPr>
-          <p:cNvPr id="11" name="rule"/>
+          <p:cNvPr id="15" name="foot-rule"/>
           <p:cNvCxnSpPr/>
           <p:nvPr/>
         </p:nvCxnSpPr>
         <p:spPr>
           <a:xfrm>
-            <a:off x="8031175" y="2899917"/>
-            <a:ext cx="3383280" cy="0"/>
+            <a:off x="502920" y="6382512"/>
+            <a:ext cx="11185855" cy="0"/>
           </a:xfrm>
           <a:prstGeom prst="line">
             <a:avLst/>
@@ -5296,340 +5476,7 @@
       </p:cxnSp>
       <p:sp>
         <p:nvSpPr>
-          <p:cNvPr id="12" name="label:L1:t"/>
-          <p:cNvSpPr txBox="1"/>
-          <p:nvPr/>
-        </p:nvSpPr>
-        <p:spPr>
-          <a:xfrm>
-            <a:off x="8031175" y="3110229"/>
-            <a:ext cx="3383279" cy="158750"/>
-          </a:xfrm>
-          <a:prstGeom prst="rect">
-            <a:avLst/>
-          </a:prstGeom>
-          <a:noFill/>
-        </p:spPr>
-        <p:txBody>
-          <a:bodyPr wrap="square" lIns="0" tIns="0" rIns="0" bIns="0" anchor="t">
-            <a:noAutofit/>
-          </a:bodyPr>
-          <a:lstStyle/>
-          <a:p>
-            <a:pPr algn="l">
-              <a:lnSpc>
-                <a:spcPts val="1250"/>
-              </a:lnSpc>
-              <a:spcBef>
-                <a:spcPts val="0"/>
-              </a:spcBef>
-              <a:buNone/>
-            </a:pPr>
-            <a:r>
-              <a:rPr lang="ko-KR" sz="950" b="1" dirty="0">
-                <a:solidFill>
-                  <a:srgbClr val="64748B"/>
-                </a:solidFill>
-                <a:latin typeface="Consolas"/>
-                <a:ea typeface="맑은 고딕"/>
-                <a:cs typeface="Consolas"/>
-              </a:rPr>
-              <a:t>LEVEL</a:t>
-            </a:r>
-          </a:p>
-        </p:txBody>
-      </p:sp>
-      <p:sp>
-        <p:nvSpPr>
-          <p:cNvPr id="13" name="body:L1:v-LEVEL"/>
-          <p:cNvSpPr txBox="1"/>
-          <p:nvPr/>
-        </p:nvSpPr>
-        <p:spPr>
-          <a:xfrm>
-            <a:off x="8031175" y="3351275"/>
-            <a:ext cx="3383279" cy="391160"/>
-          </a:xfrm>
-          <a:prstGeom prst="rect">
-            <a:avLst/>
-          </a:prstGeom>
-          <a:noFill/>
-        </p:spPr>
-        <p:txBody>
-          <a:bodyPr wrap="square" lIns="0" tIns="0" rIns="0" bIns="0" anchor="t">
-            <a:noAutofit/>
-          </a:bodyPr>
-          <a:lstStyle/>
-          <a:p>
-            <a:pPr algn="l">
-              <a:lnSpc>
-                <a:spcPts val="3080"/>
-              </a:lnSpc>
-              <a:spcBef>
-                <a:spcPts val="0"/>
-              </a:spcBef>
-              <a:buNone/>
-            </a:pPr>
-            <a:r>
-              <a:rPr lang="ko-KR" sz="2200" b="1" dirty="0">
-                <a:solidFill>
-                  <a:srgbClr val="0F172A"/>
-                </a:solidFill>
-                <a:latin typeface="맑은 고딕"/>
-                <a:ea typeface="맑은 고딕"/>
-                <a:cs typeface="맑은 고딕"/>
-              </a:rPr>
-              <a:t>신입</a:t>
-            </a:r>
-          </a:p>
-        </p:txBody>
-      </p:sp>
-      <p:cxnSp>
-        <p:nvCxnSpPr>
-          <p:cNvPr id="14" name="rule"/>
-          <p:cNvCxnSpPr/>
-          <p:nvPr/>
-        </p:nvCxnSpPr>
-        <p:spPr>
-          <a:xfrm>
-            <a:off x="8031175" y="3952747"/>
-            <a:ext cx="3383280" cy="0"/>
-          </a:xfrm>
-          <a:prstGeom prst="line">
-            <a:avLst/>
-          </a:prstGeom>
-          <a:ln w="9525">
-            <a:solidFill>
-              <a:srgbClr val="E2E8F0"/>
-            </a:solidFill>
-          </a:ln>
-        </p:spPr>
-      </p:cxnSp>
-      <p:sp>
-        <p:nvSpPr>
-          <p:cNvPr id="15" name="label:L1:t"/>
-          <p:cNvSpPr txBox="1"/>
-          <p:nvPr/>
-        </p:nvSpPr>
-        <p:spPr>
-          <a:xfrm>
-            <a:off x="8031175" y="4163059"/>
-            <a:ext cx="3383279" cy="158750"/>
-          </a:xfrm>
-          <a:prstGeom prst="rect">
-            <a:avLst/>
-          </a:prstGeom>
-          <a:noFill/>
-        </p:spPr>
-        <p:txBody>
-          <a:bodyPr wrap="square" lIns="0" tIns="0" rIns="0" bIns="0" anchor="t">
-            <a:noAutofit/>
-          </a:bodyPr>
-          <a:lstStyle/>
-          <a:p>
-            <a:pPr algn="l">
-              <a:lnSpc>
-                <a:spcPts val="1250"/>
-              </a:lnSpc>
-              <a:spcBef>
-                <a:spcPts val="0"/>
-              </a:spcBef>
-              <a:buNone/>
-            </a:pPr>
-            <a:r>
-              <a:rPr lang="ko-KR" sz="950" b="1" dirty="0">
-                <a:solidFill>
-                  <a:srgbClr val="64748B"/>
-                </a:solidFill>
-                <a:latin typeface="Consolas"/>
-                <a:ea typeface="맑은 고딕"/>
-                <a:cs typeface="Consolas"/>
-              </a:rPr>
-              <a:t>NAME</a:t>
-            </a:r>
-          </a:p>
-        </p:txBody>
-      </p:sp>
-      <p:sp>
-        <p:nvSpPr>
-          <p:cNvPr id="16" name="body:L1:v-NAME"/>
-          <p:cNvSpPr txBox="1"/>
-          <p:nvPr/>
-        </p:nvSpPr>
-        <p:spPr>
-          <a:xfrm>
-            <a:off x="8031175" y="4404106"/>
-            <a:ext cx="3383279" cy="391160"/>
-          </a:xfrm>
-          <a:prstGeom prst="rect">
-            <a:avLst/>
-          </a:prstGeom>
-          <a:noFill/>
-        </p:spPr>
-        <p:txBody>
-          <a:bodyPr wrap="square" lIns="0" tIns="0" rIns="0" bIns="0" anchor="t">
-            <a:noAutofit/>
-          </a:bodyPr>
-          <a:lstStyle/>
-          <a:p>
-            <a:pPr algn="l">
-              <a:lnSpc>
-                <a:spcPts val="3080"/>
-              </a:lnSpc>
-              <a:spcBef>
-                <a:spcPts val="0"/>
-              </a:spcBef>
-              <a:buNone/>
-            </a:pPr>
-            <a:r>
-              <a:rPr lang="ko-KR" sz="2200" b="1" dirty="0">
-                <a:solidFill>
-                  <a:srgbClr val="0F172A"/>
-                </a:solidFill>
-                <a:latin typeface="맑은 고딕"/>
-                <a:ea typeface="맑은 고딕"/>
-                <a:cs typeface="맑은 고딕"/>
-              </a:rPr>
-              <a:t>조승훈</a:t>
-            </a:r>
-          </a:p>
-        </p:txBody>
-      </p:sp>
-      <p:cxnSp>
-        <p:nvCxnSpPr>
-          <p:cNvPr id="17" name="rule"/>
-          <p:cNvCxnSpPr/>
-          <p:nvPr/>
-        </p:nvCxnSpPr>
-        <p:spPr>
-          <a:xfrm>
-            <a:off x="8031175" y="5005578"/>
-            <a:ext cx="3383280" cy="0"/>
-          </a:xfrm>
-          <a:prstGeom prst="line">
-            <a:avLst/>
-          </a:prstGeom>
-          <a:ln w="9525">
-            <a:solidFill>
-              <a:srgbClr val="E2E8F0"/>
-            </a:solidFill>
-          </a:ln>
-        </p:spPr>
-      </p:cxnSp>
-      <p:sp>
-        <p:nvSpPr>
-          <p:cNvPr id="18" name="label:L1:t"/>
-          <p:cNvSpPr txBox="1"/>
-          <p:nvPr/>
-        </p:nvSpPr>
-        <p:spPr>
-          <a:xfrm>
-            <a:off x="8031175" y="5215890"/>
-            <a:ext cx="3383279" cy="158750"/>
-          </a:xfrm>
-          <a:prstGeom prst="rect">
-            <a:avLst/>
-          </a:prstGeom>
-          <a:noFill/>
-        </p:spPr>
-        <p:txBody>
-          <a:bodyPr wrap="square" lIns="0" tIns="0" rIns="0" bIns="0" anchor="t">
-            <a:noAutofit/>
-          </a:bodyPr>
-          <a:lstStyle/>
-          <a:p>
-            <a:pPr algn="l">
-              <a:lnSpc>
-                <a:spcPts val="1250"/>
-              </a:lnSpc>
-              <a:spcBef>
-                <a:spcPts val="0"/>
-              </a:spcBef>
-              <a:buNone/>
-            </a:pPr>
-            <a:r>
-              <a:rPr lang="ko-KR" sz="950" b="1" dirty="0">
-                <a:solidFill>
-                  <a:srgbClr val="64748B"/>
-                </a:solidFill>
-                <a:latin typeface="Consolas"/>
-                <a:ea typeface="맑은 고딕"/>
-                <a:cs typeface="Consolas"/>
-              </a:rPr>
-              <a:t>DATE</a:t>
-            </a:r>
-          </a:p>
-        </p:txBody>
-      </p:sp>
-      <p:sp>
-        <p:nvSpPr>
-          <p:cNvPr id="19" name="body:L1:v-date"/>
-          <p:cNvSpPr txBox="1"/>
-          <p:nvPr/>
-        </p:nvSpPr>
-        <p:spPr>
-          <a:xfrm>
-            <a:off x="8031175" y="5456936"/>
-            <a:ext cx="3383279" cy="368300"/>
-          </a:xfrm>
-          <a:prstGeom prst="rect">
-            <a:avLst/>
-          </a:prstGeom>
-          <a:noFill/>
-        </p:spPr>
-        <p:txBody>
-          <a:bodyPr wrap="square" lIns="0" tIns="0" rIns="0" bIns="0" anchor="t">
-            <a:noAutofit/>
-          </a:bodyPr>
-          <a:lstStyle/>
-          <a:p>
-            <a:pPr algn="l">
-              <a:lnSpc>
-                <a:spcPts val="2900"/>
-              </a:lnSpc>
-              <a:spcBef>
-                <a:spcPts val="0"/>
-              </a:spcBef>
-              <a:buNone/>
-            </a:pPr>
-            <a:r>
-              <a:rPr lang="ko-KR" sz="2200" b="1" dirty="0">
-                <a:solidFill>
-                  <a:srgbClr val="0F172A"/>
-                </a:solidFill>
-                <a:latin typeface="Consolas"/>
-                <a:ea typeface="맑은 고딕"/>
-                <a:cs typeface="Consolas"/>
-              </a:rPr>
-              <a:t>2026.10.27</a:t>
-            </a:r>
-          </a:p>
-        </p:txBody>
-      </p:sp>
-      <p:cxnSp>
-        <p:nvCxnSpPr>
-          <p:cNvPr id="20" name="foot-rule"/>
-          <p:cNvCxnSpPr/>
-          <p:nvPr/>
-        </p:nvCxnSpPr>
-        <p:spPr>
-          <a:xfrm>
-            <a:off x="502920" y="6382512"/>
-            <a:ext cx="11185855" cy="0"/>
-          </a:xfrm>
-          <a:prstGeom prst="line">
-            <a:avLst/>
-          </a:prstGeom>
-          <a:ln w="9525">
-            <a:solidFill>
-              <a:srgbClr val="E2E8F0"/>
-            </a:solidFill>
-          </a:ln>
-        </p:spPr>
-      </p:cxnSp>
-      <p:sp>
-        <p:nvSpPr>
-          <p:cNvPr id="21" name="foot:L1:source"/>
+          <p:cNvPr id="16" name="foot:L1:source"/>
           <p:cNvSpPr txBox="1"/>
           <p:nvPr/>
         </p:nvSpPr>

</xml_diff>

<commit_message>
style(deck): balance cover title block and applicant card spacing
Co-Authored-By: Claude Sonnet 5.5 <noreply@anthropic.com>
</commit_message>
<xml_diff>
--- a/outputs/pptx/puzzledata_repair_report.pptx
+++ b/outputs/pptx/puzzledata_repair_report.pptx
@@ -125,21 +125,21 @@
   <p:extLst>
     <p:ext uri="{521415D9-36F7-43E2-AB2F-B90AF26B5E84}">
       <p14:sectionLst xmlns:p14="http://schemas.microsoft.com/office/powerpoint/2010/main">
-        <p14:section name="Part 00 · 인트로" id="{09FA97E9-14FB-41DB-85EC-AD9B6D5E6925}">
+        <p14:section name="Part 00 · 인트로" id="{5B523927-E4E4-4422-BCEC-C9FDC666A0A7}">
           <p14:sldIdLst>
             <p14:sldId id="256"/>
             <p14:sldId id="257"/>
             <p14:sldId id="258"/>
           </p14:sldIdLst>
         </p14:section>
-        <p14:section name="Part 01 · 데이터 진단" id="{580976A9-3ADA-4B4F-A292-86F33A27E36C}">
+        <p14:section name="Part 01 · 데이터 진단" id="{17EBD136-6EDA-4F92-86DD-662D997C1A01}">
           <p14:sldIdLst>
             <p14:sldId id="259"/>
             <p14:sldId id="260"/>
             <p14:sldId id="261"/>
           </p14:sldIdLst>
         </p14:section>
-        <p14:section name="Part 02 · 병목 규명" id="{32A3815A-E26F-4AA4-B8D6-F37BD5FDCF20}">
+        <p14:section name="Part 02 · 병목 규명" id="{FDDA25BC-38BA-44FC-81F8-B50CA1235E6F}">
           <p14:sldIdLst>
             <p14:sldId id="262"/>
             <p14:sldId id="263"/>
@@ -152,14 +152,14 @@
             <p14:sldId id="270"/>
           </p14:sldIdLst>
         </p14:section>
-        <p14:section name="Part 03 · 개선 전략" id="{BA40D4C9-D3D3-483A-B057-933186BFFEC3}">
+        <p14:section name="Part 03 · 개선 전략" id="{EFBC3812-2082-4322-AA05-C1E482810F3A}">
           <p14:sldIdLst>
             <p14:sldId id="271"/>
             <p14:sldId id="272"/>
             <p14:sldId id="273"/>
           </p14:sldIdLst>
         </p14:section>
-        <p14:section name="Part 04 · Q&amp;A" id="{BE8DA081-32DE-4473-809B-7797A2B15EB0}">
+        <p14:section name="Part 04 · Q&amp;A" id="{244400EB-CDF1-4A9F-970A-8CAD724F0572}">
           <p14:sldIdLst>
             <p14:sldId id="274"/>
           </p14:sldIdLst>
@@ -4943,7 +4943,7 @@
         </p:nvSpPr>
         <p:spPr>
           <a:xfrm>
-            <a:off x="502920" y="1874519"/>
+            <a:off x="502920" y="2286000"/>
             <a:ext cx="6675120" cy="176530"/>
           </a:xfrm>
           <a:prstGeom prst="rect">
@@ -4988,7 +4988,7 @@
         </p:nvSpPr>
         <p:spPr>
           <a:xfrm>
-            <a:off x="502920" y="2258568"/>
+            <a:off x="502920" y="2670048"/>
             <a:ext cx="6675120" cy="1280160"/>
           </a:xfrm>
           <a:prstGeom prst="rect">
@@ -5055,7 +5055,7 @@
         </p:nvSpPr>
         <p:spPr>
           <a:xfrm>
-            <a:off x="5653735" y="5257800"/>
+            <a:off x="5653735" y="5303520"/>
             <a:ext cx="6035040" cy="868680"/>
           </a:xfrm>
           <a:prstGeom prst="rect">
@@ -5101,7 +5101,7 @@
         </p:nvSpPr>
         <p:spPr>
           <a:xfrm>
-            <a:off x="5836615" y="5394960"/>
+            <a:off x="5836615" y="5440680"/>
             <a:ext cx="1280160" cy="158750"/>
           </a:xfrm>
           <a:prstGeom prst="rect">
@@ -5146,7 +5146,7 @@
         </p:nvSpPr>
         <p:spPr>
           <a:xfrm>
-            <a:off x="5836615" y="5669280"/>
+            <a:off x="5836615" y="5715000"/>
             <a:ext cx="1280160" cy="266700"/>
           </a:xfrm>
           <a:prstGeom prst="rect">
@@ -5191,7 +5191,7 @@
         </p:nvSpPr>
         <p:spPr>
           <a:xfrm>
-            <a:off x="7345375" y="5394960"/>
+            <a:off x="7345375" y="5440680"/>
             <a:ext cx="1280160" cy="158750"/>
           </a:xfrm>
           <a:prstGeom prst="rect">
@@ -5236,7 +5236,7 @@
         </p:nvSpPr>
         <p:spPr>
           <a:xfrm>
-            <a:off x="7345375" y="5669280"/>
+            <a:off x="7345375" y="5715000"/>
             <a:ext cx="1280160" cy="266700"/>
           </a:xfrm>
           <a:prstGeom prst="rect">
@@ -5281,7 +5281,7 @@
         </p:nvSpPr>
         <p:spPr>
           <a:xfrm>
-            <a:off x="8854135" y="5394960"/>
+            <a:off x="8854135" y="5440680"/>
             <a:ext cx="1280160" cy="158750"/>
           </a:xfrm>
           <a:prstGeom prst="rect">
@@ -5326,7 +5326,7 @@
         </p:nvSpPr>
         <p:spPr>
           <a:xfrm>
-            <a:off x="8854135" y="5669280"/>
+            <a:off x="8854135" y="5715000"/>
             <a:ext cx="1280160" cy="266700"/>
           </a:xfrm>
           <a:prstGeom prst="rect">
@@ -5371,7 +5371,7 @@
         </p:nvSpPr>
         <p:spPr>
           <a:xfrm>
-            <a:off x="10362895" y="5394960"/>
+            <a:off x="10362895" y="5440680"/>
             <a:ext cx="1280160" cy="158750"/>
           </a:xfrm>
           <a:prstGeom prst="rect">
@@ -5416,7 +5416,7 @@
         </p:nvSpPr>
         <p:spPr>
           <a:xfrm>
-            <a:off x="10362895" y="5669280"/>
+            <a:off x="10362895" y="5715000"/>
             <a:ext cx="1280160" cy="251460"/>
           </a:xfrm>
           <a:prstGeom prst="rect">

</xml_diff>

<commit_message>
feat(deck): show e-mail instead of date on the cover card
Co-Authored-By: Claude Sonnet 5.5 <noreply@anthropic.com>
</commit_message>
<xml_diff>
--- a/outputs/pptx/puzzledata_repair_report.pptx
+++ b/outputs/pptx/puzzledata_repair_report.pptx
@@ -125,21 +125,21 @@
   <p:extLst>
     <p:ext uri="{521415D9-36F7-43E2-AB2F-B90AF26B5E84}">
       <p14:sectionLst xmlns:p14="http://schemas.microsoft.com/office/powerpoint/2010/main">
-        <p14:section name="Part 00 · 인트로" id="{5B523927-E4E4-4422-BCEC-C9FDC666A0A7}">
+        <p14:section name="Part 00 · 인트로" id="{EE421D70-6EFB-400B-9B17-D6F47418ABB7}">
           <p14:sldIdLst>
             <p14:sldId id="256"/>
             <p14:sldId id="257"/>
             <p14:sldId id="258"/>
           </p14:sldIdLst>
         </p14:section>
-        <p14:section name="Part 01 · 데이터 진단" id="{17EBD136-6EDA-4F92-86DD-662D997C1A01}">
+        <p14:section name="Part 01 · 데이터 진단" id="{6343ADAA-22C3-4D43-8EDA-C17917663FD0}">
           <p14:sldIdLst>
             <p14:sldId id="259"/>
             <p14:sldId id="260"/>
             <p14:sldId id="261"/>
           </p14:sldIdLst>
         </p14:section>
-        <p14:section name="Part 02 · 병목 규명" id="{FDDA25BC-38BA-44FC-81F8-B50CA1235E6F}">
+        <p14:section name="Part 02 · 병목 규명" id="{933D272C-7330-48A4-B90A-074CD7AD239D}">
           <p14:sldIdLst>
             <p14:sldId id="262"/>
             <p14:sldId id="263"/>
@@ -152,14 +152,14 @@
             <p14:sldId id="270"/>
           </p14:sldIdLst>
         </p14:section>
-        <p14:section name="Part 03 · 개선 전략" id="{EFBC3812-2082-4322-AA05-C1E482810F3A}">
+        <p14:section name="Part 03 · 개선 전략" id="{BE360CB3-008B-4D6C-87C5-39E6FA876E04}">
           <p14:sldIdLst>
             <p14:sldId id="271"/>
             <p14:sldId id="272"/>
             <p14:sldId id="273"/>
           </p14:sldIdLst>
         </p14:section>
-        <p14:section name="Part 04 · Q&amp;A" id="{244400EB-CDF1-4A9F-970A-8CAD724F0572}">
+        <p14:section name="Part 04 · Q&amp;A" id="{33B58C41-F34F-481B-8177-A471958A1F3E}">
           <p14:sldIdLst>
             <p14:sldId id="274"/>
           </p14:sldIdLst>
@@ -5102,7 +5102,7 @@
         <p:spPr>
           <a:xfrm>
             <a:off x="5836615" y="5440680"/>
-            <a:ext cx="1280160" cy="158750"/>
+            <a:ext cx="1371600" cy="158750"/>
           </a:xfrm>
           <a:prstGeom prst="rect">
             <a:avLst/>
@@ -5147,7 +5147,7 @@
         <p:spPr>
           <a:xfrm>
             <a:off x="5836615" y="5715000"/>
-            <a:ext cx="1280160" cy="266700"/>
+            <a:ext cx="1417320" cy="266700"/>
           </a:xfrm>
           <a:prstGeom prst="rect">
             <a:avLst/>
@@ -5191,8 +5191,8 @@
         </p:nvSpPr>
         <p:spPr>
           <a:xfrm>
-            <a:off x="7345375" y="5440680"/>
-            <a:ext cx="1280160" cy="158750"/>
+            <a:off x="7299655" y="5440680"/>
+            <a:ext cx="731520" cy="158750"/>
           </a:xfrm>
           <a:prstGeom prst="rect">
             <a:avLst/>
@@ -5236,8 +5236,8 @@
         </p:nvSpPr>
         <p:spPr>
           <a:xfrm>
-            <a:off x="7345375" y="5715000"/>
-            <a:ext cx="1280160" cy="266700"/>
+            <a:off x="7299655" y="5715000"/>
+            <a:ext cx="777240" cy="266700"/>
           </a:xfrm>
           <a:prstGeom prst="rect">
             <a:avLst/>
@@ -5281,8 +5281,8 @@
         </p:nvSpPr>
         <p:spPr>
           <a:xfrm>
-            <a:off x="8854135" y="5440680"/>
-            <a:ext cx="1280160" cy="158750"/>
+            <a:off x="8122615" y="5440680"/>
+            <a:ext cx="914400" cy="158750"/>
           </a:xfrm>
           <a:prstGeom prst="rect">
             <a:avLst/>
@@ -5326,8 +5326,8 @@
         </p:nvSpPr>
         <p:spPr>
           <a:xfrm>
-            <a:off x="8854135" y="5715000"/>
-            <a:ext cx="1280160" cy="266700"/>
+            <a:off x="8122615" y="5715000"/>
+            <a:ext cx="960120" cy="266700"/>
           </a:xfrm>
           <a:prstGeom prst="rect">
             <a:avLst/>
@@ -5365,14 +5365,14 @@
       </p:sp>
       <p:sp>
         <p:nvSpPr>
-          <p:cNvPr id="13" name="label:L1:k-DATE"/>
-          <p:cNvSpPr txBox="1"/>
-          <p:nvPr/>
-        </p:nvSpPr>
-        <p:spPr>
-          <a:xfrm>
-            <a:off x="10362895" y="5440680"/>
-            <a:ext cx="1280160" cy="158750"/>
+          <p:cNvPr id="13" name="label:L1:k-E.MAIL"/>
+          <p:cNvSpPr txBox="1"/>
+          <p:nvPr/>
+        </p:nvSpPr>
+        <p:spPr>
+          <a:xfrm>
+            <a:off x="9128455" y="5440680"/>
+            <a:ext cx="2286000" cy="158750"/>
           </a:xfrm>
           <a:prstGeom prst="rect">
             <a:avLst/>
@@ -5403,44 +5403,44 @@
                 <a:ea typeface="맑은 고딕"/>
                 <a:cs typeface="Consolas"/>
               </a:rPr>
-              <a:t>DATE</a:t>
-            </a:r>
-          </a:p>
-        </p:txBody>
-      </p:sp>
-      <p:sp>
-        <p:nvSpPr>
-          <p:cNvPr id="14" name="body:L1:v-DATE"/>
-          <p:cNvSpPr txBox="1"/>
-          <p:nvPr/>
-        </p:nvSpPr>
-        <p:spPr>
-          <a:xfrm>
-            <a:off x="10362895" y="5715000"/>
-            <a:ext cx="1280160" cy="251460"/>
-          </a:xfrm>
-          <a:prstGeom prst="rect">
-            <a:avLst/>
-          </a:prstGeom>
-          <a:noFill/>
-        </p:spPr>
-        <p:txBody>
-          <a:bodyPr wrap="square" lIns="0" tIns="0" rIns="0" bIns="0" anchor="t">
-            <a:noAutofit/>
-          </a:bodyPr>
-          <a:lstStyle/>
-          <a:p>
-            <a:pPr algn="l">
-              <a:lnSpc>
-                <a:spcPts val="1980"/>
-              </a:lnSpc>
-              <a:spcBef>
-                <a:spcPts val="0"/>
-              </a:spcBef>
-              <a:buNone/>
-            </a:pPr>
-            <a:r>
-              <a:rPr lang="ko-KR" sz="1500" b="1" dirty="0">
+              <a:t>E.MAIL</a:t>
+            </a:r>
+          </a:p>
+        </p:txBody>
+      </p:sp>
+      <p:sp>
+        <p:nvSpPr>
+          <p:cNvPr id="14" name="body:L1:v-E.MAIL"/>
+          <p:cNvSpPr txBox="1"/>
+          <p:nvPr/>
+        </p:nvSpPr>
+        <p:spPr>
+          <a:xfrm>
+            <a:off x="9128455" y="5715000"/>
+            <a:ext cx="2331720" cy="218439"/>
+          </a:xfrm>
+          <a:prstGeom prst="rect">
+            <a:avLst/>
+          </a:prstGeom>
+          <a:noFill/>
+        </p:spPr>
+        <p:txBody>
+          <a:bodyPr wrap="square" lIns="0" tIns="0" rIns="0" bIns="0" anchor="t">
+            <a:noAutofit/>
+          </a:bodyPr>
+          <a:lstStyle/>
+          <a:p>
+            <a:pPr algn="l">
+              <a:lnSpc>
+                <a:spcPts val="1720"/>
+              </a:lnSpc>
+              <a:spcBef>
+                <a:spcPts val="0"/>
+              </a:spcBef>
+              <a:buNone/>
+            </a:pPr>
+            <a:r>
+              <a:rPr lang="ko-KR" sz="1300" b="1" dirty="0">
                 <a:solidFill>
                   <a:srgbClr val="0F172A"/>
                 </a:solidFill>
@@ -5448,7 +5448,7 @@
                 <a:ea typeface="맑은 고딕"/>
                 <a:cs typeface="Consolas"/>
               </a:rPr>
-              <a:t>2026.10.27</a:t>
+              <a:t>nextbus1245@gmail.com</a:t>
             </a:r>
           </a:p>
         </p:txBody>

</xml_diff>

<commit_message>
feat(deck): revise agenda slide wording
Co-Authored-By: Claude Sonnet 5.5 <noreply@anthropic.com>
</commit_message>
<xml_diff>
--- a/outputs/pptx/puzzledata_repair_report.pptx
+++ b/outputs/pptx/puzzledata_repair_report.pptx
@@ -125,21 +125,21 @@
   <p:extLst>
     <p:ext uri="{521415D9-36F7-43E2-AB2F-B90AF26B5E84}">
       <p14:sectionLst xmlns:p14="http://schemas.microsoft.com/office/powerpoint/2010/main">
-        <p14:section name="Part 00 · 인트로" id="{EE421D70-6EFB-400B-9B17-D6F47418ABB7}">
+        <p14:section name="Part 00 · 인트로" id="{B018C501-5E41-4DB2-9C5C-91E69DE73BB6}">
           <p14:sldIdLst>
             <p14:sldId id="256"/>
             <p14:sldId id="257"/>
             <p14:sldId id="258"/>
           </p14:sldIdLst>
         </p14:section>
-        <p14:section name="Part 01 · 데이터 진단" id="{6343ADAA-22C3-4D43-8EDA-C17917663FD0}">
+        <p14:section name="Part 01 · 데이터 진단" id="{32B29D33-18AA-4790-8D25-2D1D0368D89E}">
           <p14:sldIdLst>
             <p14:sldId id="259"/>
             <p14:sldId id="260"/>
             <p14:sldId id="261"/>
           </p14:sldIdLst>
         </p14:section>
-        <p14:section name="Part 02 · 병목 규명" id="{933D272C-7330-48A4-B90A-074CD7AD239D}">
+        <p14:section name="Part 02 · 병목 규명" id="{777B9A54-F9FE-42FE-9A54-36CC49125183}">
           <p14:sldIdLst>
             <p14:sldId id="262"/>
             <p14:sldId id="263"/>
@@ -152,14 +152,14 @@
             <p14:sldId id="270"/>
           </p14:sldIdLst>
         </p14:section>
-        <p14:section name="Part 03 · 개선 전략" id="{BE360CB3-008B-4D6C-87C5-39E6FA876E04}">
+        <p14:section name="Part 03 · 개선 전략" id="{25977763-2AEA-43BF-BC88-4A9A959C5D2B}">
           <p14:sldIdLst>
             <p14:sldId id="271"/>
             <p14:sldId id="272"/>
             <p14:sldId id="273"/>
           </p14:sldIdLst>
         </p14:section>
-        <p14:section name="Part 04 · Q&amp;A" id="{33B58C41-F34F-481B-8177-A471958A1F3E}">
+        <p14:section name="Part 04 · Q&amp;A" id="{0D7ED2F5-6D75-4354-B528-4ED6509C4C20}">
           <p14:sldIdLst>
             <p14:sldId id="274"/>
           </p14:sldIdLst>
@@ -20573,7 +20573,7 @@
                 <a:ea typeface="맑은 고딕"/>
                 <a:cs typeface="맑은 고딕"/>
               </a:rPr>
-              <a:t>전처리부터 TO-BE까지, 4개 파트로 보고합니다</a:t>
+              <a:t>목차 소개</a:t>
             </a:r>
           </a:p>
         </p:txBody>
@@ -20918,14 +20918,14 @@
       </p:sp>
       <p:sp>
         <p:nvSpPr>
-          <p:cNvPr id="13" name="body:L6:t"/>
+          <p:cNvPr id="13" name="body:L5:t"/>
           <p:cNvSpPr txBox="1"/>
           <p:nvPr/>
         </p:nvSpPr>
         <p:spPr>
           <a:xfrm>
             <a:off x="722376" y="3487928"/>
-            <a:ext cx="2220391" cy="1303020"/>
+            <a:ext cx="2220391" cy="1098550"/>
           </a:xfrm>
           <a:prstGeom prst="rect">
             <a:avLst/>
@@ -21007,28 +21007,7 @@
                 <a:ea typeface="맑은 고딕"/>
                 <a:cs typeface="맑은 고딕"/>
               </a:rPr>
-              <a:t>업무 인과 기반 결측</a:t>
-            </a:r>
-            <a:br>
-              <a:rPr lang="ko-KR" sz="1150" b="0" dirty="0">
-                <a:solidFill>
-                  <a:srgbClr val="334155"/>
-                </a:solidFill>
-                <a:latin typeface="맑은 고딕"/>
-                <a:ea typeface="맑은 고딕"/>
-                <a:cs typeface="맑은 고딕"/>
-              </a:rPr>
-            </a:br>
-            <a:r>
-              <a:rPr lang="ko-KR" sz="1150" b="0" dirty="0">
-                <a:solidFill>
-                  <a:srgbClr val="334155"/>
-                </a:solidFill>
-                <a:latin typeface="맑은 고딕"/>
-                <a:ea typeface="맑은 고딕"/>
-                <a:cs typeface="맑은 고딕"/>
-              </a:rPr>
-              <a:t>복원, 삭제 0건</a:t>
+              <a:t>순서 기반 결측 복원, 삭제 0건</a:t>
             </a:r>
           </a:p>
           <a:p>
@@ -21369,7 +21348,7 @@
                 <a:ea typeface="맑은 고딕"/>
                 <a:cs typeface="맑은 고딕"/>
               </a:rPr>
-              <a:t>프로세스 심층 분석</a:t>
+              <a:t>AS-IS 심층 분석</a:t>
             </a:r>
           </a:p>
         </p:txBody>
@@ -21383,7 +21362,7 @@
         <p:spPr>
           <a:xfrm>
             <a:off x="3564559" y="3487928"/>
-            <a:ext cx="2220391" cy="1098550"/>
+            <a:ext cx="2220391" cy="1136650"/>
           </a:xfrm>
           <a:prstGeom prst="rect">
             <a:avLst/>
@@ -21444,9 +21423,24 @@
                 <a:ea typeface="맑은 고딕"/>
                 <a:cs typeface="맑은 고딕"/>
               </a:rPr>
-              <a:t>3대 병목: 접수 · 실사 ·</a:t>
-            </a:r>
-            <a:br>
+              <a:t>2대 병목: 접수 · 실사</a:t>
+            </a:r>
+          </a:p>
+          <a:p>
+            <a:pPr algn="l" marL="164592" indent="-164592">
+              <a:lnSpc>
+                <a:spcPts val="1610"/>
+              </a:lnSpc>
+              <a:spcBef>
+                <a:spcPts val="300"/>
+              </a:spcBef>
+              <a:buClr>
+                <a:srgbClr val="2563EB"/>
+              </a:buClr>
+              <a:buFont typeface="맑은 고딕"/>
+              <a:buChar char="•"/>
+            </a:pPr>
+            <a:r>
               <a:rPr lang="ko-KR" sz="1150" b="0" dirty="0">
                 <a:solidFill>
                   <a:srgbClr val="334155"/>
@@ -21455,17 +21449,7 @@
                 <a:ea typeface="맑은 고딕"/>
                 <a:cs typeface="맑은 고딕"/>
               </a:rPr>
-            </a:br>
-            <a:r>
-              <a:rPr lang="ko-KR" sz="1150" b="0" dirty="0">
-                <a:solidFill>
-                  <a:srgbClr val="334155"/>
-                </a:solidFill>
-                <a:latin typeface="맑은 고딕"/>
-                <a:ea typeface="맑은 고딕"/>
-                <a:cs typeface="맑은 고딕"/>
-              </a:rPr>
-              <a:t>수리 착수</a:t>
+              <a:t>1대 반복: 반복 수리</a:t>
             </a:r>
           </a:p>
           <a:p>
@@ -21806,7 +21790,7 @@
                 <a:ea typeface="맑은 고딕"/>
                 <a:cs typeface="맑은 고딕"/>
               </a:rPr>
-              <a:t>최적화 방안</a:t>
+              <a:t>TO-BE 개선 방안</a:t>
             </a:r>
           </a:p>
         </p:txBody>

</xml_diff>

<commit_message>
feat(deck): agenda bullets use '2개 병목 구간, 1개 반복 작업'
Co-Authored-By: Claude Sonnet 5.5 <noreply@anthropic.com>
</commit_message>
<xml_diff>
--- a/outputs/pptx/puzzledata_repair_report.pptx
+++ b/outputs/pptx/puzzledata_repair_report.pptx
@@ -125,21 +125,21 @@
   <p:extLst>
     <p:ext uri="{521415D9-36F7-43E2-AB2F-B90AF26B5E84}">
       <p14:sectionLst xmlns:p14="http://schemas.microsoft.com/office/powerpoint/2010/main">
-        <p14:section name="Part 00 · 인트로" id="{B018C501-5E41-4DB2-9C5C-91E69DE73BB6}">
+        <p14:section name="Part 00 · 인트로" id="{9CC29F78-2443-4747-81DE-81E8A505F779}">
           <p14:sldIdLst>
             <p14:sldId id="256"/>
             <p14:sldId id="257"/>
             <p14:sldId id="258"/>
           </p14:sldIdLst>
         </p14:section>
-        <p14:section name="Part 01 · 데이터 진단" id="{32B29D33-18AA-4790-8D25-2D1D0368D89E}">
+        <p14:section name="Part 01 · 데이터 진단" id="{16C38FE0-3941-4E89-AF16-502D738FA1C2}">
           <p14:sldIdLst>
             <p14:sldId id="259"/>
             <p14:sldId id="260"/>
             <p14:sldId id="261"/>
           </p14:sldIdLst>
         </p14:section>
-        <p14:section name="Part 02 · 병목 규명" id="{777B9A54-F9FE-42FE-9A54-36CC49125183}">
+        <p14:section name="Part 02 · 병목 규명" id="{6BDBC665-C131-4FBA-AB96-600A1ECBBCAA}">
           <p14:sldIdLst>
             <p14:sldId id="262"/>
             <p14:sldId id="263"/>
@@ -152,14 +152,14 @@
             <p14:sldId id="270"/>
           </p14:sldIdLst>
         </p14:section>
-        <p14:section name="Part 03 · 개선 전략" id="{25977763-2AEA-43BF-BC88-4A9A959C5D2B}">
+        <p14:section name="Part 03 · 개선 전략" id="{E4C4859E-A447-4C80-9753-08F17C792C68}">
           <p14:sldIdLst>
             <p14:sldId id="271"/>
             <p14:sldId id="272"/>
             <p14:sldId id="273"/>
           </p14:sldIdLst>
         </p14:section>
-        <p14:section name="Part 04 · Q&amp;A" id="{0D7ED2F5-6D75-4354-B528-4ED6509C4C20}">
+        <p14:section name="Part 04 · Q&amp;A" id="{7202C104-D37D-458A-A9CA-6C1B7F185703}">
           <p14:sldIdLst>
             <p14:sldId id="274"/>
           </p14:sldIdLst>
@@ -21423,7 +21423,7 @@
                 <a:ea typeface="맑은 고딕"/>
                 <a:cs typeface="맑은 고딕"/>
               </a:rPr>
-              <a:t>2대 병목: 접수 · 실사</a:t>
+              <a:t>2개 병목 구간: 접수 · 실사</a:t>
             </a:r>
           </a:p>
           <a:p>
@@ -21449,7 +21449,7 @@
                 <a:ea typeface="맑은 고딕"/>
                 <a:cs typeface="맑은 고딕"/>
               </a:rPr>
-              <a:t>1대 반복: 반복 수리</a:t>
+              <a:t>1개 반복 작업: 반복 수리</a:t>
             </a:r>
           </a:p>
           <a:p>

</xml_diff>

<commit_message>
feat(deck): agenda uses '사전 분류 적중률' instead of '사전 적합도'
Co-Authored-By: Claude Sonnet 5.5 <noreply@anthropic.com>
</commit_message>
<xml_diff>
--- a/outputs/pptx/puzzledata_repair_report.pptx
+++ b/outputs/pptx/puzzledata_repair_report.pptx
@@ -125,21 +125,21 @@
   <p:extLst>
     <p:ext uri="{521415D9-36F7-43E2-AB2F-B90AF26B5E84}">
       <p14:sectionLst xmlns:p14="http://schemas.microsoft.com/office/powerpoint/2010/main">
-        <p14:section name="Part 00 · 인트로" id="{9CC29F78-2443-4747-81DE-81E8A505F779}">
+        <p14:section name="Part 00 · 인트로" id="{F4ECEBBC-4CE0-4A36-8F21-5916639DB482}">
           <p14:sldIdLst>
             <p14:sldId id="256"/>
             <p14:sldId id="257"/>
             <p14:sldId id="258"/>
           </p14:sldIdLst>
         </p14:section>
-        <p14:section name="Part 01 · 데이터 진단" id="{16C38FE0-3941-4E89-AF16-502D738FA1C2}">
+        <p14:section name="Part 01 · 데이터 진단" id="{64F2A1E8-0569-4018-8649-D570D6446A14}">
           <p14:sldIdLst>
             <p14:sldId id="259"/>
             <p14:sldId id="260"/>
             <p14:sldId id="261"/>
           </p14:sldIdLst>
         </p14:section>
-        <p14:section name="Part 02 · 병목 규명" id="{6BDBC665-C131-4FBA-AB96-600A1ECBBCAA}">
+        <p14:section name="Part 02 · 병목 규명" id="{6822DB06-2F4D-4D21-A734-D25818581F0F}">
           <p14:sldIdLst>
             <p14:sldId id="262"/>
             <p14:sldId id="263"/>
@@ -152,14 +152,14 @@
             <p14:sldId id="270"/>
           </p14:sldIdLst>
         </p14:section>
-        <p14:section name="Part 03 · 개선 전략" id="{E4C4859E-A447-4C80-9753-08F17C792C68}">
+        <p14:section name="Part 03 · 개선 전략" id="{41160668-9926-46F1-AB14-CE52E1B8DA2B}">
           <p14:sldIdLst>
             <p14:sldId id="271"/>
             <p14:sldId id="272"/>
             <p14:sldId id="273"/>
           </p14:sldIdLst>
         </p14:section>
-        <p14:section name="Part 04 · Q&amp;A" id="{7202C104-D37D-458A-A9CA-6C1B7F185703}">
+        <p14:section name="Part 04 · Q&amp;A" id="{BC849EE1-2F02-4F2C-8B91-1303B1A10E37}">
           <p14:sldIdLst>
             <p14:sldId id="274"/>
           </p14:sldIdLst>
@@ -21839,7 +21839,7 @@
                 <a:ea typeface="맑은 고딕"/>
                 <a:cs typeface="맑은 고딕"/>
               </a:rPr>
-              <a:t>사전 적합도 87.3%와</a:t>
+              <a:t>사전 분류 적중률 87.3%와</a:t>
             </a:r>
             <a:br>
               <a:rPr lang="ko-KR" sz="1150" b="0" dirty="0">

</xml_diff>

<commit_message>
feat(deck): agenda tag becomes '프리뷰'
Co-Authored-By: Claude Sonnet 5.5 <noreply@anthropic.com>
</commit_message>
<xml_diff>
--- a/outputs/pptx/puzzledata_repair_report.pptx
+++ b/outputs/pptx/puzzledata_repair_report.pptx
@@ -125,21 +125,21 @@
   <p:extLst>
     <p:ext uri="{521415D9-36F7-43E2-AB2F-B90AF26B5E84}">
       <p14:sectionLst xmlns:p14="http://schemas.microsoft.com/office/powerpoint/2010/main">
-        <p14:section name="Part 00 · 인트로" id="{F4ECEBBC-4CE0-4A36-8F21-5916639DB482}">
+        <p14:section name="Part 00 · 인트로" id="{A584B621-BCC6-4A6F-9CE7-02A5C1B19054}">
           <p14:sldIdLst>
             <p14:sldId id="256"/>
             <p14:sldId id="257"/>
             <p14:sldId id="258"/>
           </p14:sldIdLst>
         </p14:section>
-        <p14:section name="Part 01 · 데이터 진단" id="{64F2A1E8-0569-4018-8649-D570D6446A14}">
+        <p14:section name="Part 01 · 데이터 진단" id="{AF924733-8BB6-4109-8D5C-E0B0F4735A97}">
           <p14:sldIdLst>
             <p14:sldId id="259"/>
             <p14:sldId id="260"/>
             <p14:sldId id="261"/>
           </p14:sldIdLst>
         </p14:section>
-        <p14:section name="Part 02 · 병목 규명" id="{6822DB06-2F4D-4D21-A734-D25818581F0F}">
+        <p14:section name="Part 02 · 병목 규명" id="{FA164D33-FF2E-489F-8699-3BA0A8A86CC3}">
           <p14:sldIdLst>
             <p14:sldId id="262"/>
             <p14:sldId id="263"/>
@@ -152,14 +152,14 @@
             <p14:sldId id="270"/>
           </p14:sldIdLst>
         </p14:section>
-        <p14:section name="Part 03 · 개선 전략" id="{41160668-9926-46F1-AB14-CE52E1B8DA2B}">
+        <p14:section name="Part 03 · 개선 전략" id="{0D18B818-C751-4952-8151-19408923C44B}">
           <p14:sldIdLst>
             <p14:sldId id="271"/>
             <p14:sldId id="272"/>
             <p14:sldId id="273"/>
           </p14:sldIdLst>
         </p14:section>
-        <p14:section name="Part 04 · Q&amp;A" id="{BC849EE1-2F02-4F2C-8B91-1303B1A10E37}">
+        <p14:section name="Part 04 · Q&amp;A" id="{F96B7694-534C-4308-A9B3-63F50BC7CD72}">
           <p14:sldIdLst>
             <p14:sldId id="274"/>
           </p14:sldIdLst>
@@ -20483,7 +20483,7 @@
                 <a:ea typeface="맑은 고딕"/>
                 <a:cs typeface="Consolas"/>
               </a:rPr>
-              <a:t>[ 02 / AGENDA ]</a:t>
+              <a:t>[ 02 / 프리뷰 ]</a:t>
             </a:r>
           </a:p>
         </p:txBody>

</xml_diff>

<commit_message>
feat(deck): agenda tag in English (PREVIEW)
Co-Authored-By: Claude Sonnet 5.5 <noreply@anthropic.com>
</commit_message>
<xml_diff>
--- a/outputs/pptx/puzzledata_repair_report.pptx
+++ b/outputs/pptx/puzzledata_repair_report.pptx
@@ -125,21 +125,21 @@
   <p:extLst>
     <p:ext uri="{521415D9-36F7-43E2-AB2F-B90AF26B5E84}">
       <p14:sectionLst xmlns:p14="http://schemas.microsoft.com/office/powerpoint/2010/main">
-        <p14:section name="Part 00 · 인트로" id="{A584B621-BCC6-4A6F-9CE7-02A5C1B19054}">
+        <p14:section name="Part 00 · 인트로" id="{5976EBE5-07C9-49C5-B674-B9F1C3342674}">
           <p14:sldIdLst>
             <p14:sldId id="256"/>
             <p14:sldId id="257"/>
             <p14:sldId id="258"/>
           </p14:sldIdLst>
         </p14:section>
-        <p14:section name="Part 01 · 데이터 진단" id="{AF924733-8BB6-4109-8D5C-E0B0F4735A97}">
+        <p14:section name="Part 01 · 데이터 진단" id="{CFCCF548-9408-4E6B-AE71-0CD62D181E9C}">
           <p14:sldIdLst>
             <p14:sldId id="259"/>
             <p14:sldId id="260"/>
             <p14:sldId id="261"/>
           </p14:sldIdLst>
         </p14:section>
-        <p14:section name="Part 02 · 병목 규명" id="{FA164D33-FF2E-489F-8699-3BA0A8A86CC3}">
+        <p14:section name="Part 02 · 병목 규명" id="{6032B822-7C22-4866-96CC-52A2C530F18F}">
           <p14:sldIdLst>
             <p14:sldId id="262"/>
             <p14:sldId id="263"/>
@@ -152,14 +152,14 @@
             <p14:sldId id="270"/>
           </p14:sldIdLst>
         </p14:section>
-        <p14:section name="Part 03 · 개선 전략" id="{0D18B818-C751-4952-8151-19408923C44B}">
+        <p14:section name="Part 03 · 개선 전략" id="{624B7E8F-872A-410B-8EBF-B3803CD80C01}">
           <p14:sldIdLst>
             <p14:sldId id="271"/>
             <p14:sldId id="272"/>
             <p14:sldId id="273"/>
           </p14:sldIdLst>
         </p14:section>
-        <p14:section name="Part 04 · Q&amp;A" id="{F96B7694-534C-4308-A9B3-63F50BC7CD72}">
+        <p14:section name="Part 04 · Q&amp;A" id="{3B8FBC67-B980-43C9-851A-41934E68B499}">
           <p14:sldIdLst>
             <p14:sldId id="274"/>
           </p14:sldIdLst>
@@ -20483,7 +20483,7 @@
                 <a:ea typeface="맑은 고딕"/>
                 <a:cs typeface="Consolas"/>
               </a:rPr>
-              <a:t>[ 02 / 프리뷰 ]</a:t>
+              <a:t>[ 02 / PREVIEW ]</a:t>
             </a:r>
           </a:p>
         </p:txBody>

</xml_diff>

<commit_message>
feat(deck): agenda tile 04 becomes 핵심 요약 without Q&A footer
Co-Authored-By: Claude Sonnet 5.5 <noreply@anthropic.com>
</commit_message>
<xml_diff>
--- a/outputs/pptx/puzzledata_repair_report.pptx
+++ b/outputs/pptx/puzzledata_repair_report.pptx
@@ -125,21 +125,21 @@
   <p:extLst>
     <p:ext uri="{521415D9-36F7-43E2-AB2F-B90AF26B5E84}">
       <p14:sectionLst xmlns:p14="http://schemas.microsoft.com/office/powerpoint/2010/main">
-        <p14:section name="Part 00 · 인트로" id="{5976EBE5-07C9-49C5-B674-B9F1C3342674}">
+        <p14:section name="Part 00 · 인트로" id="{3F66B206-1293-421B-AD17-7BE51959AE43}">
           <p14:sldIdLst>
             <p14:sldId id="256"/>
             <p14:sldId id="257"/>
             <p14:sldId id="258"/>
           </p14:sldIdLst>
         </p14:section>
-        <p14:section name="Part 01 · 데이터 진단" id="{CFCCF548-9408-4E6B-AE71-0CD62D181E9C}">
+        <p14:section name="Part 01 · 데이터 진단" id="{42E93D83-6D6D-4C6C-8D46-D93725A2DC62}">
           <p14:sldIdLst>
             <p14:sldId id="259"/>
             <p14:sldId id="260"/>
             <p14:sldId id="261"/>
           </p14:sldIdLst>
         </p14:section>
-        <p14:section name="Part 02 · 병목 규명" id="{6032B822-7C22-4866-96CC-52A2C530F18F}">
+        <p14:section name="Part 02 · 병목 규명" id="{9D62A202-DA4F-4344-98DA-18FA2BC45F32}">
           <p14:sldIdLst>
             <p14:sldId id="262"/>
             <p14:sldId id="263"/>
@@ -152,14 +152,14 @@
             <p14:sldId id="270"/>
           </p14:sldIdLst>
         </p14:section>
-        <p14:section name="Part 03 · 개선 전략" id="{624B7E8F-872A-410B-8EBF-B3803CD80C01}">
+        <p14:section name="Part 03 · 개선 전략" id="{1EB4D7CB-B1D9-4998-BBDF-18DAA12649EA}">
           <p14:sldIdLst>
             <p14:sldId id="271"/>
             <p14:sldId id="272"/>
             <p14:sldId id="273"/>
           </p14:sldIdLst>
         </p14:section>
-        <p14:section name="Part 04 · Q&amp;A" id="{3B8FBC67-B980-43C9-851A-41934E68B499}">
+        <p14:section name="Part 04 · Q&amp;A" id="{389A30A7-811C-4FC2-A821-58D36900B97E}">
           <p14:sldIdLst>
             <p14:sldId id="274"/>
           </p14:sldIdLst>
@@ -1341,7 +1341,7 @@
           <a:lstStyle/>
           <a:p>
             <a:r>
-              <a:t>오늘 발표는 4개 파트입니다. 질문 1에서 데이터 진단과 전처리를, 질문 2에서 프로세스 병목과 원인을, 질문 3에서 개선안과 기대 효과를 보고드리고 질의응답으로 마치겠습니다. 각 타일을 클릭하면 해당 파트로 이동합니다.</a:t>
+              <a:t>오늘 발표는 4개 파트입니다. 질문 1에서 데이터 진단과 전처리를, 질문 2에서 프로세스 병목과 원인을, 질문 3에서 개선안과 기대 효과를 보고드리고 핵심 요약으로 마치겠습니다. 각 타일을 클릭하면 해당 파트로 이동합니다.</a:t>
             </a:r>
           </a:p>
         </p:txBody>
@@ -22248,21 +22248,21 @@
                 <a:ea typeface="맑은 고딕"/>
                 <a:cs typeface="맑은 고딕"/>
               </a:rPr>
-              <a:t>질의응답</a:t>
-            </a:r>
-          </a:p>
-        </p:txBody>
-      </p:sp>
-      <p:sp>
-        <p:nvSpPr>
-          <p:cNvPr id="34" name="body:L2:t"/>
+              <a:t>핵심 요약</a:t>
+            </a:r>
+          </a:p>
+        </p:txBody>
+      </p:sp>
+      <p:sp>
+        <p:nvSpPr>
+          <p:cNvPr id="34" name="body:L1:t"/>
           <p:cNvSpPr txBox="1"/>
           <p:nvPr/>
         </p:nvSpPr>
         <p:spPr>
           <a:xfrm>
             <a:off x="9248927" y="3487928"/>
-            <a:ext cx="2220391" cy="447040"/>
+            <a:ext cx="2220391" cy="204470"/>
           </a:xfrm>
           <a:prstGeom prst="rect">
             <a:avLst/>
@@ -22297,100 +22297,7 @@
                 <a:ea typeface="맑은 고딕"/>
                 <a:cs typeface="맑은 고딕"/>
               </a:rPr>
-              <a:t>프로젝트 핵심 요약</a:t>
-            </a:r>
-          </a:p>
-          <a:p>
-            <a:pPr algn="l" marL="164592" indent="-164592">
-              <a:lnSpc>
-                <a:spcPts val="1610"/>
-              </a:lnSpc>
-              <a:spcBef>
-                <a:spcPts val="300"/>
-              </a:spcBef>
-              <a:buClr>
-                <a:srgbClr val="2563EB"/>
-              </a:buClr>
-              <a:buFont typeface="맑은 고딕"/>
-              <a:buChar char="•"/>
-            </a:pPr>
-            <a:r>
-              <a:rPr lang="ko-KR" sz="1150" b="0" dirty="0">
-                <a:solidFill>
-                  <a:srgbClr val="334155"/>
-                </a:solidFill>
-                <a:latin typeface="맑은 고딕"/>
-                <a:ea typeface="맑은 고딕"/>
-                <a:cs typeface="맑은 고딕"/>
-              </a:rPr>
-              <a:t>질의응답</a:t>
-            </a:r>
-          </a:p>
-        </p:txBody>
-      </p:sp>
-      <p:sp>
-        <p:nvSpPr>
-          <p:cNvPr id="35" name="body:L2:key"/>
-          <p:cNvSpPr txBox="1"/>
-          <p:nvPr/>
-        </p:nvSpPr>
-        <p:spPr>
-          <a:xfrm>
-            <a:off x="9248927" y="5084064"/>
-            <a:ext cx="2220391" cy="594359"/>
-          </a:xfrm>
-          <a:prstGeom prst="rect">
-            <a:avLst/>
-          </a:prstGeom>
-          <a:noFill/>
-        </p:spPr>
-        <p:txBody>
-          <a:bodyPr wrap="square" lIns="0" tIns="0" rIns="0" bIns="0" anchor="t">
-            <a:noAutofit/>
-          </a:bodyPr>
-          <a:lstStyle/>
-          <a:p>
-            <a:pPr algn="l">
-              <a:lnSpc>
-                <a:spcPts val="3140"/>
-              </a:lnSpc>
-              <a:spcBef>
-                <a:spcPts val="0"/>
-              </a:spcBef>
-              <a:buNone/>
-            </a:pPr>
-            <a:r>
-              <a:rPr lang="ko-KR" sz="2800" b="1" dirty="0">
-                <a:solidFill>
-                  <a:srgbClr val="64748B"/>
-                </a:solidFill>
-                <a:latin typeface="Consolas"/>
-                <a:ea typeface="맑은 고딕"/>
-                <a:cs typeface="Consolas"/>
-              </a:rPr>
-              <a:t>Q&amp;A</a:t>
-            </a:r>
-          </a:p>
-          <a:p>
-            <a:pPr algn="l">
-              <a:lnSpc>
-                <a:spcPts val="1540"/>
-              </a:lnSpc>
-              <a:spcBef>
-                <a:spcPts val="0"/>
-              </a:spcBef>
-              <a:buNone/>
-            </a:pPr>
-            <a:r>
-              <a:rPr lang="ko-KR" sz="1100" b="0" dirty="0">
-                <a:solidFill>
-                  <a:srgbClr val="64748B"/>
-                </a:solidFill>
-                <a:latin typeface="맑은 고딕"/>
-                <a:ea typeface="맑은 고딕"/>
-                <a:cs typeface="맑은 고딕"/>
-              </a:rPr>
-              <a:t>자유 질의</a:t>
+              <a:t>파트별 핵심 결과 정리</a:t>
             </a:r>
           </a:p>
         </p:txBody>

</xml_diff>

<commit_message>
feat(deck): restore Q&A key figure on agenda tile 04
Co-Authored-By: Claude Sonnet 5.5 <noreply@anthropic.com>
</commit_message>
<xml_diff>
--- a/outputs/pptx/puzzledata_repair_report.pptx
+++ b/outputs/pptx/puzzledata_repair_report.pptx
@@ -125,21 +125,21 @@
   <p:extLst>
     <p:ext uri="{521415D9-36F7-43E2-AB2F-B90AF26B5E84}">
       <p14:sectionLst xmlns:p14="http://schemas.microsoft.com/office/powerpoint/2010/main">
-        <p14:section name="Part 00 · 인트로" id="{3F66B206-1293-421B-AD17-7BE51959AE43}">
+        <p14:section name="Part 00 · 인트로" id="{2D8A02C8-5A92-41E7-81FF-B3F07463D764}">
           <p14:sldIdLst>
             <p14:sldId id="256"/>
             <p14:sldId id="257"/>
             <p14:sldId id="258"/>
           </p14:sldIdLst>
         </p14:section>
-        <p14:section name="Part 01 · 데이터 진단" id="{42E93D83-6D6D-4C6C-8D46-D93725A2DC62}">
+        <p14:section name="Part 01 · 데이터 진단" id="{17C17712-6590-4579-9D60-84ED1D543FE2}">
           <p14:sldIdLst>
             <p14:sldId id="259"/>
             <p14:sldId id="260"/>
             <p14:sldId id="261"/>
           </p14:sldIdLst>
         </p14:section>
-        <p14:section name="Part 02 · 병목 규명" id="{9D62A202-DA4F-4344-98DA-18FA2BC45F32}">
+        <p14:section name="Part 02 · 병목 규명" id="{BF978BF8-2CBD-4EA6-8F9A-F9670D294768}">
           <p14:sldIdLst>
             <p14:sldId id="262"/>
             <p14:sldId id="263"/>
@@ -152,14 +152,14 @@
             <p14:sldId id="270"/>
           </p14:sldIdLst>
         </p14:section>
-        <p14:section name="Part 03 · 개선 전략" id="{1EB4D7CB-B1D9-4998-BBDF-18DAA12649EA}">
+        <p14:section name="Part 03 · 개선 전략" id="{CD68849C-1C28-491F-B376-B8B02C7334B6}">
           <p14:sldIdLst>
             <p14:sldId id="271"/>
             <p14:sldId id="272"/>
             <p14:sldId id="273"/>
           </p14:sldIdLst>
         </p14:section>
-        <p14:section name="Part 04 · Q&amp;A" id="{389A30A7-811C-4FC2-A821-58D36900B97E}">
+        <p14:section name="Part 04 · Q&amp;A" id="{490633EA-B0AB-4796-B7E2-6B4B91C74ED3}">
           <p14:sldIdLst>
             <p14:sldId id="274"/>
           </p14:sldIdLst>
@@ -22298,6 +22298,51 @@
                 <a:cs typeface="맑은 고딕"/>
               </a:rPr>
               <a:t>파트별 핵심 결과 정리</a:t>
+            </a:r>
+          </a:p>
+        </p:txBody>
+      </p:sp>
+      <p:sp>
+        <p:nvSpPr>
+          <p:cNvPr id="35" name="body:L1:key"/>
+          <p:cNvSpPr txBox="1"/>
+          <p:nvPr/>
+        </p:nvSpPr>
+        <p:spPr>
+          <a:xfrm>
+            <a:off x="9248927" y="5279644"/>
+            <a:ext cx="2220391" cy="398780"/>
+          </a:xfrm>
+          <a:prstGeom prst="rect">
+            <a:avLst/>
+          </a:prstGeom>
+          <a:noFill/>
+        </p:spPr>
+        <p:txBody>
+          <a:bodyPr wrap="square" lIns="0" tIns="0" rIns="0" bIns="0" anchor="t">
+            <a:noAutofit/>
+          </a:bodyPr>
+          <a:lstStyle/>
+          <a:p>
+            <a:pPr algn="l">
+              <a:lnSpc>
+                <a:spcPts val="3140"/>
+              </a:lnSpc>
+              <a:spcBef>
+                <a:spcPts val="0"/>
+              </a:spcBef>
+              <a:buNone/>
+            </a:pPr>
+            <a:r>
+              <a:rPr lang="ko-KR" sz="2800" b="1" dirty="0">
+                <a:solidFill>
+                  <a:srgbClr val="64748B"/>
+                </a:solidFill>
+                <a:latin typeface="Consolas"/>
+                <a:ea typeface="맑은 고딕"/>
+                <a:cs typeface="Consolas"/>
+              </a:rPr>
+              <a:t>Q&amp;A</a:t>
             </a:r>
           </a:p>
         </p:txBody>

</xml_diff>

<commit_message>
feat(deck): reword summary slide title
Co-Authored-By: Claude Sonnet 5.5 <noreply@anthropic.com>
</commit_message>
<xml_diff>
--- a/outputs/pptx/puzzledata_repair_report.pptx
+++ b/outputs/pptx/puzzledata_repair_report.pptx
@@ -125,21 +125,21 @@
   <p:extLst>
     <p:ext uri="{521415D9-36F7-43E2-AB2F-B90AF26B5E84}">
       <p14:sectionLst xmlns:p14="http://schemas.microsoft.com/office/powerpoint/2010/main">
-        <p14:section name="Part 00 · 인트로" id="{2D8A02C8-5A92-41E7-81FF-B3F07463D764}">
+        <p14:section name="Part 00 · 인트로" id="{A58FCD63-F2A5-4F19-998B-2A82DCC25323}">
           <p14:sldIdLst>
             <p14:sldId id="256"/>
             <p14:sldId id="257"/>
             <p14:sldId id="258"/>
           </p14:sldIdLst>
         </p14:section>
-        <p14:section name="Part 01 · 데이터 진단" id="{17C17712-6590-4579-9D60-84ED1D543FE2}">
+        <p14:section name="Part 01 · 데이터 진단" id="{F548335B-1A19-444D-B5FC-6B3894C362A5}">
           <p14:sldIdLst>
             <p14:sldId id="259"/>
             <p14:sldId id="260"/>
             <p14:sldId id="261"/>
           </p14:sldIdLst>
         </p14:section>
-        <p14:section name="Part 02 · 병목 규명" id="{BF978BF8-2CBD-4EA6-8F9A-F9670D294768}">
+        <p14:section name="Part 02 · 병목 규명" id="{DA8975E3-1517-413C-9122-3E0250410ECB}">
           <p14:sldIdLst>
             <p14:sldId id="262"/>
             <p14:sldId id="263"/>
@@ -152,14 +152,14 @@
             <p14:sldId id="270"/>
           </p14:sldIdLst>
         </p14:section>
-        <p14:section name="Part 03 · 개선 전략" id="{CD68849C-1C28-491F-B376-B8B02C7334B6}">
+        <p14:section name="Part 03 · 개선 전략" id="{8D6C34CA-5CA4-4913-AA12-A3C8F36B8CE0}">
           <p14:sldIdLst>
             <p14:sldId id="271"/>
             <p14:sldId id="272"/>
             <p14:sldId id="273"/>
           </p14:sldIdLst>
         </p14:section>
-        <p14:section name="Part 04 · Q&amp;A" id="{490633EA-B0AB-4796-B7E2-6B4B91C74ED3}">
+        <p14:section name="Part 04 · Q&amp;A" id="{E2F1D99E-7B03-4D2A-809B-63F6B3879BEA}">
           <p14:sldIdLst>
             <p14:sldId id="274"/>
           </p14:sldIdLst>
@@ -22503,7 +22503,7 @@
                 <a:ea typeface="맑은 고딕"/>
                 <a:cs typeface="맑은 고딕"/>
               </a:rPr>
-              <a:t>리드타임의 90.5%는 작업이 아닌 대기다</a:t>
+              <a:t>총 리드타임의 90.5%는 작업이 아닌 대기 시간이다</a:t>
             </a:r>
           </a:p>
         </p:txBody>

</xml_diff>

<commit_message>
feat(deck): replace '분석 코호트' with '분석 대상' and note excluded mis-routed cases
Co-Authored-By: Claude Sonnet 5.5 <noreply@anthropic.com>
</commit_message>
<xml_diff>
--- a/outputs/pptx/puzzledata_repair_report.pptx
+++ b/outputs/pptx/puzzledata_repair_report.pptx
@@ -125,21 +125,21 @@
   <p:extLst>
     <p:ext uri="{521415D9-36F7-43E2-AB2F-B90AF26B5E84}">
       <p14:sectionLst xmlns:p14="http://schemas.microsoft.com/office/powerpoint/2010/main">
-        <p14:section name="Part 00 · 인트로" id="{A58FCD63-F2A5-4F19-998B-2A82DCC25323}">
+        <p14:section name="Part 00 · 인트로" id="{60E41E42-EBE5-47C2-9A2A-34EBDBF0FE54}">
           <p14:sldIdLst>
             <p14:sldId id="256"/>
             <p14:sldId id="257"/>
             <p14:sldId id="258"/>
           </p14:sldIdLst>
         </p14:section>
-        <p14:section name="Part 01 · 데이터 진단" id="{F548335B-1A19-444D-B5FC-6B3894C362A5}">
+        <p14:section name="Part 01 · 데이터 진단" id="{F570A10B-8ED3-4DAE-BB98-D0872A09D18B}">
           <p14:sldIdLst>
             <p14:sldId id="259"/>
             <p14:sldId id="260"/>
             <p14:sldId id="261"/>
           </p14:sldIdLst>
         </p14:section>
-        <p14:section name="Part 02 · 병목 규명" id="{DA8975E3-1517-413C-9122-3E0250410ECB}">
+        <p14:section name="Part 02 · 병목 규명" id="{BAA7A95B-C505-450C-BC27-2FE6635A7933}">
           <p14:sldIdLst>
             <p14:sldId id="262"/>
             <p14:sldId id="263"/>
@@ -152,14 +152,14 @@
             <p14:sldId id="270"/>
           </p14:sldIdLst>
         </p14:section>
-        <p14:section name="Part 03 · 개선 전략" id="{8D6C34CA-5CA4-4913-AA12-A3C8F36B8CE0}">
+        <p14:section name="Part 03 · 개선 전략" id="{033933EB-F09A-4D84-A2B5-F019CBE98B51}">
           <p14:sldIdLst>
             <p14:sldId id="271"/>
             <p14:sldId id="272"/>
             <p14:sldId id="273"/>
           </p14:sldIdLst>
         </p14:section>
-        <p14:section name="Part 04 · Q&amp;A" id="{E2F1D99E-7B03-4D2A-809B-63F6B3879BEA}">
+        <p14:section name="Part 04 · Q&amp;A" id="{C1106BD9-5767-4298-AB07-E9F627CA1B0D}">
           <p14:sldIdLst>
             <p14:sldId id="274"/>
           </p14:sldIdLst>
@@ -19716,7 +19716,7 @@
                 <a:ea typeface="맑은 고딕"/>
                 <a:cs typeface="맑은 고딕"/>
               </a:rPr>
-              <a:t>삭제 0건 · 시간 역전 0건 · 분석 코호트 927건</a:t>
+              <a:t>삭제 0건 · 시간 역전 0건 · 분석 대상 927건</a:t>
             </a:r>
           </a:p>
         </p:txBody>
@@ -21054,7 +21054,7 @@
                 <a:ea typeface="맑은 고딕"/>
                 <a:cs typeface="맑은 고딕"/>
               </a:rPr>
-              <a:t>코호트 927건</a:t>
+              <a:t>대상 927건</a:t>
             </a:r>
           </a:p>
         </p:txBody>
@@ -23014,14 +23014,14 @@
       </p:sp>
       <p:sp>
         <p:nvSpPr>
-          <p:cNvPr id="15" name="body:L4:t"/>
+          <p:cNvPr id="15" name="body:L5:t"/>
           <p:cNvSpPr txBox="1"/>
           <p:nvPr/>
         </p:nvSpPr>
         <p:spPr>
           <a:xfrm>
             <a:off x="704088" y="4407154"/>
-            <a:ext cx="3204362" cy="929640"/>
+            <a:ext cx="3204362" cy="1143000"/>
           </a:xfrm>
           <a:prstGeom prst="rect">
             <a:avLst/>
@@ -23129,7 +23129,28 @@
                 <a:ea typeface="맑은 고딕"/>
                 <a:cs typeface="맑은 고딕"/>
               </a:rPr>
-              <a:t>시간 역전 0건, 분석 코호트 927건</a:t>
+              <a:t>시간 역전 0건, 분석 대상 927건</a:t>
+            </a:r>
+            <a:br>
+              <a:rPr lang="ko-KR" sz="1200" b="0" dirty="0">
+                <a:solidFill>
+                  <a:srgbClr val="334155"/>
+                </a:solidFill>
+                <a:latin typeface="맑은 고딕"/>
+                <a:ea typeface="맑은 고딕"/>
+                <a:cs typeface="맑은 고딕"/>
+              </a:rPr>
+            </a:br>
+            <a:r>
+              <a:rPr lang="ko-KR" sz="1200" b="0" dirty="0">
+                <a:solidFill>
+                  <a:srgbClr val="334155"/>
+                </a:solidFill>
+                <a:latin typeface="맑은 고딕"/>
+                <a:ea typeface="맑은 고딕"/>
+                <a:cs typeface="맑은 고딕"/>
+              </a:rPr>
+              <a:t>(오접수 73건 제외)</a:t>
             </a:r>
           </a:p>
         </p:txBody>
@@ -28981,7 +29002,7 @@
                 <a:ea typeface="맑은 고딕"/>
                 <a:cs typeface="맑은 고딕"/>
               </a:rPr>
-              <a:t>분석 코호트 </a:t>
+              <a:t>분석 대상 </a:t>
             </a:r>
             <a:r>
               <a:rPr lang="ko-KR" sz="1200" b="1" dirty="0">
@@ -30156,7 +30177,7 @@
                 <a:ea typeface="맑은 고딕"/>
                 <a:cs typeface="Consolas"/>
               </a:rPr>
-              <a:t>FIG.07 · E2E 기준 프로세스 맵 (접수 → 현장 → 정산) · 케이스 기준 927건 코호트</a:t>
+              <a:t>FIG.07 · E2E 기준 프로세스 맵 (접수 → 현장 → 정산) · 케이스 기준 927건</a:t>
             </a:r>
           </a:p>
         </p:txBody>
@@ -30348,7 +30369,7 @@
                 <a:ea typeface="맑은 고딕"/>
                 <a:cs typeface="맑은 고딕"/>
               </a:rPr>
-              <a:t>분석 코호트 </a:t>
+              <a:t>분석 대상 </a:t>
             </a:r>
             <a:r>
               <a:rPr lang="ko-KR" sz="1150" b="1" dirty="0">

</xml_diff>

<commit_message>
feat(deck): split normal (927) vs mis-routed (73) cases; frame TO-BE as a two-lane strategy
Co-Authored-By: Claude Sonnet 5.5 <noreply@anthropic.com>
</commit_message>
<xml_diff>
--- a/outputs/pptx/puzzledata_repair_report.pptx
+++ b/outputs/pptx/puzzledata_repair_report.pptx
@@ -125,21 +125,21 @@
   <p:extLst>
     <p:ext uri="{521415D9-36F7-43E2-AB2F-B90AF26B5E84}">
       <p14:sectionLst xmlns:p14="http://schemas.microsoft.com/office/powerpoint/2010/main">
-        <p14:section name="Part 00 · 인트로" id="{60E41E42-EBE5-47C2-9A2A-34EBDBF0FE54}">
+        <p14:section name="Part 00 · 인트로" id="{18ABB448-22C8-4251-AE8D-EBC404E69187}">
           <p14:sldIdLst>
             <p14:sldId id="256"/>
             <p14:sldId id="257"/>
             <p14:sldId id="258"/>
           </p14:sldIdLst>
         </p14:section>
-        <p14:section name="Part 01 · 데이터 진단" id="{F570A10B-8ED3-4DAE-BB98-D0872A09D18B}">
+        <p14:section name="Part 01 · 데이터 진단" id="{29154553-E35B-41BE-9ADF-592B38AC20D6}">
           <p14:sldIdLst>
             <p14:sldId id="259"/>
             <p14:sldId id="260"/>
             <p14:sldId id="261"/>
           </p14:sldIdLst>
         </p14:section>
-        <p14:section name="Part 02 · 병목 규명" id="{BAA7A95B-C505-450C-BC27-2FE6635A7933}">
+        <p14:section name="Part 02 · 병목 규명" id="{13668B20-F5C2-4C46-8DF6-61E2932CEDAD}">
           <p14:sldIdLst>
             <p14:sldId id="262"/>
             <p14:sldId id="263"/>
@@ -152,14 +152,14 @@
             <p14:sldId id="270"/>
           </p14:sldIdLst>
         </p14:section>
-        <p14:section name="Part 03 · 개선 전략" id="{033933EB-F09A-4D84-A2B5-F019CBE98B51}">
+        <p14:section name="Part 03 · 개선 전략" id="{4827C861-3A70-4C32-8D06-43593853BC69}">
           <p14:sldIdLst>
             <p14:sldId id="271"/>
             <p14:sldId id="272"/>
             <p14:sldId id="273"/>
           </p14:sldIdLst>
         </p14:section>
-        <p14:section name="Part 04 · Q&amp;A" id="{C1106BD9-5767-4298-AB07-E9F627CA1B0D}">
+        <p14:section name="Part 04 · Q&amp;A" id="{AB6E1429-F0E1-4BF1-A2C8-19CBDF0F7828}">
           <p14:sldIdLst>
             <p14:sldId id="274"/>
           </p14:sldIdLst>
@@ -19549,7 +19549,7 @@
         <p:spPr>
           <a:xfrm>
             <a:off x="502920" y="1554480"/>
-            <a:ext cx="5760720" cy="1291335"/>
+            <a:ext cx="5760720" cy="1362456"/>
           </a:xfrm>
           <a:prstGeom prst="rect">
             <a:avLst/>
@@ -19716,7 +19716,7 @@
                 <a:ea typeface="맑은 고딕"/>
                 <a:cs typeface="맑은 고딕"/>
               </a:rPr>
-              <a:t>삭제 0건 · 시간 역전 0건 · 분석 대상 927건</a:t>
+              <a:t>삭제 0건 · 시간 역전 0건 · 정상 접수 927건, 오접수 73건</a:t>
             </a:r>
           </a:p>
         </p:txBody>
@@ -19729,8 +19729,8 @@
         </p:nvSpPr>
         <p:spPr>
           <a:xfrm>
-            <a:off x="502920" y="2973832"/>
-            <a:ext cx="5760720" cy="1291335"/>
+            <a:off x="502920" y="3044952"/>
+            <a:ext cx="5760720" cy="1362456"/>
           </a:xfrm>
           <a:prstGeom prst="rect">
             <a:avLst/>
@@ -19775,7 +19775,7 @@
         </p:nvSpPr>
         <p:spPr>
           <a:xfrm>
-            <a:off x="704088" y="3175000"/>
+            <a:off x="704088" y="3246120"/>
             <a:ext cx="5358383" cy="158750"/>
           </a:xfrm>
           <a:prstGeom prst="rect">
@@ -19820,7 +19820,7 @@
         </p:nvSpPr>
         <p:spPr>
           <a:xfrm>
-            <a:off x="704088" y="3388614"/>
+            <a:off x="704088" y="3459734"/>
             <a:ext cx="5358383" cy="266700"/>
           </a:xfrm>
           <a:prstGeom prst="rect">
@@ -19865,7 +19865,7 @@
         </p:nvSpPr>
         <p:spPr>
           <a:xfrm>
-            <a:off x="704088" y="3710178"/>
+            <a:off x="704088" y="3781298"/>
             <a:ext cx="5358383" cy="213360"/>
           </a:xfrm>
           <a:prstGeom prst="rect">
@@ -19910,8 +19910,8 @@
         </p:nvSpPr>
         <p:spPr>
           <a:xfrm>
-            <a:off x="502920" y="4393184"/>
-            <a:ext cx="5760720" cy="1504696"/>
+            <a:off x="502920" y="4535424"/>
+            <a:ext cx="5760720" cy="1362456"/>
           </a:xfrm>
           <a:prstGeom prst="rect">
             <a:avLst/>
@@ -19956,7 +19956,7 @@
         </p:nvSpPr>
         <p:spPr>
           <a:xfrm>
-            <a:off x="704088" y="4594351"/>
+            <a:off x="704088" y="4736592"/>
             <a:ext cx="5358383" cy="158750"/>
           </a:xfrm>
           <a:prstGeom prst="rect">
@@ -20001,7 +20001,7 @@
         </p:nvSpPr>
         <p:spPr>
           <a:xfrm>
-            <a:off x="704088" y="4807965"/>
+            <a:off x="704088" y="4950206"/>
             <a:ext cx="5358383" cy="266700"/>
           </a:xfrm>
           <a:prstGeom prst="rect">
@@ -20040,14 +20040,14 @@
       </p:sp>
       <p:sp>
         <p:nvSpPr>
-          <p:cNvPr id="19" name="body:L2:t"/>
-          <p:cNvSpPr txBox="1"/>
-          <p:nvPr/>
-        </p:nvSpPr>
-        <p:spPr>
-          <a:xfrm>
-            <a:off x="704088" y="5129529"/>
-            <a:ext cx="5358383" cy="426720"/>
+          <p:cNvPr id="19" name="body:L1:t"/>
+          <p:cNvSpPr txBox="1"/>
+          <p:nvPr/>
+        </p:nvSpPr>
+        <p:spPr>
+          <a:xfrm>
+            <a:off x="704088" y="5271770"/>
+            <a:ext cx="5358383" cy="213360"/>
           </a:xfrm>
           <a:prstGeom prst="rect">
             <a:avLst/>
@@ -20078,28 +20078,7 @@
                 <a:ea typeface="맑은 고딕"/>
                 <a:cs typeface="맑은 고딕"/>
               </a:rPr>
-              <a:t>접수 사전 필터 고도화(Direct Booking) 한 전략 ·</a:t>
-            </a:r>
-            <a:br>
-              <a:rPr lang="ko-KR" sz="1200" b="0" dirty="0">
-                <a:solidFill>
-                  <a:srgbClr val="334155"/>
-                </a:solidFill>
-                <a:latin typeface="맑은 고딕"/>
-                <a:ea typeface="맑은 고딕"/>
-                <a:cs typeface="맑은 고딕"/>
-              </a:rPr>
-            </a:br>
-            <a:r>
-              <a:rPr lang="ko-KR" sz="1200" b="0" dirty="0">
-                <a:solidFill>
-                  <a:srgbClr val="334155"/>
-                </a:solidFill>
-                <a:latin typeface="맑은 고딕"/>
-                <a:ea typeface="맑은 고딕"/>
-                <a:cs typeface="맑은 고딕"/>
-              </a:rPr>
-              <a:t>단축률 가정 + 파일럿 검증</a:t>
+              <a:t>줄을 2갈래로 세우는 전략 · 단축률 가정 + 파일럿 검증</a:t>
             </a:r>
           </a:p>
         </p:txBody>
@@ -21033,7 +21012,7 @@
                 <a:ea typeface="맑은 고딕"/>
                 <a:cs typeface="맑은 고딕"/>
               </a:rPr>
-              <a:t>시간 역전 0건, 분석</a:t>
+              <a:t>시간 역전 0건, 정상 접수</a:t>
             </a:r>
             <a:br>
               <a:rPr lang="ko-KR" sz="1150" b="0" dirty="0">
@@ -21054,7 +21033,7 @@
                 <a:ea typeface="맑은 고딕"/>
                 <a:cs typeface="맑은 고딕"/>
               </a:rPr>
-              <a:t>대상 927건</a:t>
+              <a:t>927건, 오접수 73건</a:t>
             </a:r>
           </a:p>
         </p:txBody>
@@ -23129,7 +23108,7 @@
                 <a:ea typeface="맑은 고딕"/>
                 <a:cs typeface="맑은 고딕"/>
               </a:rPr>
-              <a:t>시간 역전 0건, 분석 대상 927건</a:t>
+              <a:t>시간 역전 0건, 정상 접수 927건,</a:t>
             </a:r>
             <a:br>
               <a:rPr lang="ko-KR" sz="1200" b="0" dirty="0">
@@ -23150,7 +23129,7 @@
                 <a:ea typeface="맑은 고딕"/>
                 <a:cs typeface="맑은 고딕"/>
               </a:rPr>
-              <a:t>(오접수 73건 제외)</a:t>
+              <a:t>오접수 73건</a:t>
             </a:r>
           </a:p>
         </p:txBody>
@@ -23827,7 +23806,7 @@
                 <a:ea typeface="맑은 고딕"/>
                 <a:cs typeface="맑은 고딕"/>
               </a:rPr>
-              <a:t>Direct Booking 한 전략 — 즉시</a:t>
+              <a:t>줄을 2갈래로 세우는 전략 — 즉시</a:t>
             </a:r>
             <a:br>
               <a:rPr lang="ko-KR" sz="1200" b="0" dirty="0">
@@ -29002,7 +28981,7 @@
                 <a:ea typeface="맑은 고딕"/>
                 <a:cs typeface="맑은 고딕"/>
               </a:rPr>
-              <a:t>분석 대상 </a:t>
+              <a:t>정상 접수 </a:t>
             </a:r>
             <a:r>
               <a:rPr lang="ko-KR" sz="1200" b="1" dirty="0">
@@ -29024,7 +29003,7 @@
                 <a:ea typeface="맑은 고딕"/>
                 <a:cs typeface="맑은 고딕"/>
               </a:rPr>
-              <a:t>확립 — 오접수 73건(7.3%) 제외</a:t>
+              <a:t>· 오접수 73건(7.3%)으로 구분</a:t>
             </a:r>
           </a:p>
         </p:txBody>
@@ -30369,7 +30348,7 @@
                 <a:ea typeface="맑은 고딕"/>
                 <a:cs typeface="맑은 고딕"/>
               </a:rPr>
-              <a:t>분석 대상 </a:t>
+              <a:t>정상 접수 </a:t>
             </a:r>
             <a:r>
               <a:rPr lang="ko-KR" sz="1150" b="1" dirty="0">

</xml_diff>

<commit_message>
feat(deck): name the strategy 'Direct Booking: split the bottleneck queue in two'
Co-Authored-By: Claude Sonnet 5.5 <noreply@anthropic.com>
</commit_message>
<xml_diff>
--- a/outputs/pptx/puzzledata_repair_report.pptx
+++ b/outputs/pptx/puzzledata_repair_report.pptx
@@ -125,21 +125,21 @@
   <p:extLst>
     <p:ext uri="{521415D9-36F7-43E2-AB2F-B90AF26B5E84}">
       <p14:sectionLst xmlns:p14="http://schemas.microsoft.com/office/powerpoint/2010/main">
-        <p14:section name="Part 00 · 인트로" id="{18ABB448-22C8-4251-AE8D-EBC404E69187}">
+        <p14:section name="Part 00 · 인트로" id="{8B3CDFEA-4E75-49B9-8003-8339E970EC31}">
           <p14:sldIdLst>
             <p14:sldId id="256"/>
             <p14:sldId id="257"/>
             <p14:sldId id="258"/>
           </p14:sldIdLst>
         </p14:section>
-        <p14:section name="Part 01 · 데이터 진단" id="{29154553-E35B-41BE-9ADF-592B38AC20D6}">
+        <p14:section name="Part 01 · 데이터 진단" id="{F8DB22AB-1E6D-4477-BD09-D91D986B753C}">
           <p14:sldIdLst>
             <p14:sldId id="259"/>
             <p14:sldId id="260"/>
             <p14:sldId id="261"/>
           </p14:sldIdLst>
         </p14:section>
-        <p14:section name="Part 02 · 병목 규명" id="{13668B20-F5C2-4C46-8DF6-61E2932CEDAD}">
+        <p14:section name="Part 02 · 병목 규명" id="{C3FC46A4-8DE6-4702-8EA2-099319C1A870}">
           <p14:sldIdLst>
             <p14:sldId id="262"/>
             <p14:sldId id="263"/>
@@ -152,14 +152,14 @@
             <p14:sldId id="270"/>
           </p14:sldIdLst>
         </p14:section>
-        <p14:section name="Part 03 · 개선 전략" id="{4827C861-3A70-4C32-8D06-43593853BC69}">
+        <p14:section name="Part 03 · 개선 전략" id="{87EA2D27-BE8B-4662-B32C-083BF7835EC7}">
           <p14:sldIdLst>
             <p14:sldId id="271"/>
             <p14:sldId id="272"/>
             <p14:sldId id="273"/>
           </p14:sldIdLst>
         </p14:section>
-        <p14:section name="Part 04 · Q&amp;A" id="{AB6E1429-F0E1-4BF1-A2C8-19CBDF0F7828}">
+        <p14:section name="Part 04 · Q&amp;A" id="{626BD769-5658-4B70-A24C-370D85E43A10}">
           <p14:sldIdLst>
             <p14:sldId id="274"/>
           </p14:sldIdLst>
@@ -14896,7 +14896,7 @@
                 <a:ea typeface="맑은 고딕"/>
                 <a:cs typeface="맑은 고딕"/>
               </a:rPr>
-              <a:t>접수 사전 필터를 높이는 Direct Booking</a:t>
+              <a:t>Direct Booking 전략: 병목 줄을 2갈래로 만든다</a:t>
             </a:r>
           </a:p>
         </p:txBody>
@@ -20078,7 +20078,7 @@
                 <a:ea typeface="맑은 고딕"/>
                 <a:cs typeface="맑은 고딕"/>
               </a:rPr>
-              <a:t>줄을 2갈래로 세우는 전략 · 단축률 가정 + 파일럿 검증</a:t>
+              <a:t>Direct Booking 전략 · 병목 줄을 2갈래로 · 단축률 가정 + 파일럿</a:t>
             </a:r>
           </a:p>
         </p:txBody>
@@ -21865,7 +21865,7 @@
                 <a:ea typeface="맑은 고딕"/>
                 <a:cs typeface="맑은 고딕"/>
               </a:rPr>
-              <a:t>접수 사전 필터 고도화(Direct</a:t>
+              <a:t>Direct Booking: 병목</a:t>
             </a:r>
             <a:br>
               <a:rPr lang="ko-KR" sz="1150" b="0" dirty="0">
@@ -21886,7 +21886,7 @@
                 <a:ea typeface="맑은 고딕"/>
                 <a:cs typeface="맑은 고딕"/>
               </a:rPr>
-              <a:t>Booking)</a:t>
+              <a:t>줄을 2갈래로</a:t>
             </a:r>
           </a:p>
           <a:p>
@@ -23806,7 +23806,7 @@
                 <a:ea typeface="맑은 고딕"/>
                 <a:cs typeface="맑은 고딕"/>
               </a:rPr>
-              <a:t>줄을 2갈래로 세우는 전략 — 즉시</a:t>
+              <a:t>Direct Booking 전략 — 병목 줄을</a:t>
             </a:r>
             <a:br>
               <a:rPr lang="ko-KR" sz="1200" b="0" dirty="0">
@@ -23827,7 +23827,7 @@
                 <a:ea typeface="맑은 고딕"/>
                 <a:cs typeface="맑은 고딕"/>
               </a:rPr>
-              <a:t>수리 365건을 별도 줄로</a:t>
+              <a:t>2갈래로, 즉시 수리 365건 분리</a:t>
             </a:r>
           </a:p>
           <a:p>

</xml_diff>

<commit_message>
feat(deck): summary strategy bullet fits one line
Co-Authored-By: Claude Sonnet 5.5 <noreply@anthropic.com>
</commit_message>
<xml_diff>
--- a/outputs/pptx/puzzledata_repair_report.pptx
+++ b/outputs/pptx/puzzledata_repair_report.pptx
@@ -125,21 +125,21 @@
   <p:extLst>
     <p:ext uri="{521415D9-36F7-43E2-AB2F-B90AF26B5E84}">
       <p14:sectionLst xmlns:p14="http://schemas.microsoft.com/office/powerpoint/2010/main">
-        <p14:section name="Part 00 · 인트로" id="{8B3CDFEA-4E75-49B9-8003-8339E970EC31}">
+        <p14:section name="Part 00 · 인트로" id="{6CF4585D-617E-4BCA-8A3E-DD73A2A2DD4C}">
           <p14:sldIdLst>
             <p14:sldId id="256"/>
             <p14:sldId id="257"/>
             <p14:sldId id="258"/>
           </p14:sldIdLst>
         </p14:section>
-        <p14:section name="Part 01 · 데이터 진단" id="{F8DB22AB-1E6D-4477-BD09-D91D986B753C}">
+        <p14:section name="Part 01 · 데이터 진단" id="{AA2A0389-2EF7-4B68-ABAF-319FE6C80791}">
           <p14:sldIdLst>
             <p14:sldId id="259"/>
             <p14:sldId id="260"/>
             <p14:sldId id="261"/>
           </p14:sldIdLst>
         </p14:section>
-        <p14:section name="Part 02 · 병목 규명" id="{C3FC46A4-8DE6-4702-8EA2-099319C1A870}">
+        <p14:section name="Part 02 · 병목 규명" id="{3C947086-3AB9-479E-844E-DE1739D62236}">
           <p14:sldIdLst>
             <p14:sldId id="262"/>
             <p14:sldId id="263"/>
@@ -152,14 +152,14 @@
             <p14:sldId id="270"/>
           </p14:sldIdLst>
         </p14:section>
-        <p14:section name="Part 03 · 개선 전략" id="{87EA2D27-BE8B-4662-B32C-083BF7835EC7}">
+        <p14:section name="Part 03 · 개선 전략" id="{2B47C0D4-C69A-40D5-9D2C-FF58ED8F7CA4}">
           <p14:sldIdLst>
             <p14:sldId id="271"/>
             <p14:sldId id="272"/>
             <p14:sldId id="273"/>
           </p14:sldIdLst>
         </p14:section>
-        <p14:section name="Part 04 · Q&amp;A" id="{626BD769-5658-4B70-A24C-370D85E43A10}">
+        <p14:section name="Part 04 · Q&amp;A" id="{72C01FB5-24E4-446F-B2E3-E5CB4F178147}">
           <p14:sldIdLst>
             <p14:sldId id="274"/>
           </p14:sldIdLst>
@@ -23764,14 +23764,14 @@
       </p:sp>
       <p:sp>
         <p:nvSpPr>
-          <p:cNvPr id="27" name="body:L5:t"/>
+          <p:cNvPr id="27" name="body:L4:t"/>
           <p:cNvSpPr txBox="1"/>
           <p:nvPr/>
         </p:nvSpPr>
         <p:spPr>
           <a:xfrm>
             <a:off x="8283244" y="4407154"/>
-            <a:ext cx="3204362" cy="1143000"/>
+            <a:ext cx="3204362" cy="929640"/>
           </a:xfrm>
           <a:prstGeom prst="rect">
             <a:avLst/>
@@ -23806,28 +23806,7 @@
                 <a:ea typeface="맑은 고딕"/>
                 <a:cs typeface="맑은 고딕"/>
               </a:rPr>
-              <a:t>Direct Booking 전략 — 병목 줄을</a:t>
-            </a:r>
-            <a:br>
-              <a:rPr lang="ko-KR" sz="1200" b="0" dirty="0">
-                <a:solidFill>
-                  <a:srgbClr val="334155"/>
-                </a:solidFill>
-                <a:latin typeface="맑은 고딕"/>
-                <a:ea typeface="맑은 고딕"/>
-                <a:cs typeface="맑은 고딕"/>
-              </a:rPr>
-            </a:br>
-            <a:r>
-              <a:rPr lang="ko-KR" sz="1200" b="0" dirty="0">
-                <a:solidFill>
-                  <a:srgbClr val="334155"/>
-                </a:solidFill>
-                <a:latin typeface="맑은 고딕"/>
-                <a:ea typeface="맑은 고딕"/>
-                <a:cs typeface="맑은 고딕"/>
-              </a:rPr>
-              <a:t>2갈래로, 즉시 수리 365건 분리</a:t>
+              <a:t>Direct Booking 전략: 병목 줄을 2갈래로</a:t>
             </a:r>
           </a:p>
           <a:p>

</xml_diff>

<commit_message>
feat(deck): strategy wording '하나의 병목 줄을 두 갈래로'
Co-Authored-By: Claude Sonnet 5.5 <noreply@anthropic.com>
</commit_message>
<xml_diff>
--- a/outputs/pptx/puzzledata_repair_report.pptx
+++ b/outputs/pptx/puzzledata_repair_report.pptx
@@ -125,21 +125,21 @@
   <p:extLst>
     <p:ext uri="{521415D9-36F7-43E2-AB2F-B90AF26B5E84}">
       <p14:sectionLst xmlns:p14="http://schemas.microsoft.com/office/powerpoint/2010/main">
-        <p14:section name="Part 00 · 인트로" id="{6CF4585D-617E-4BCA-8A3E-DD73A2A2DD4C}">
+        <p14:section name="Part 00 · 인트로" id="{75F0AB8F-4225-4AA6-9E01-F62A4ACA105F}">
           <p14:sldIdLst>
             <p14:sldId id="256"/>
             <p14:sldId id="257"/>
             <p14:sldId id="258"/>
           </p14:sldIdLst>
         </p14:section>
-        <p14:section name="Part 01 · 데이터 진단" id="{AA2A0389-2EF7-4B68-ABAF-319FE6C80791}">
+        <p14:section name="Part 01 · 데이터 진단" id="{792E82EB-7B93-456E-B995-65BC72BBE871}">
           <p14:sldIdLst>
             <p14:sldId id="259"/>
             <p14:sldId id="260"/>
             <p14:sldId id="261"/>
           </p14:sldIdLst>
         </p14:section>
-        <p14:section name="Part 02 · 병목 규명" id="{3C947086-3AB9-479E-844E-DE1739D62236}">
+        <p14:section name="Part 02 · 병목 규명" id="{7E681A25-8BD4-4A87-926C-31AB3BE12F24}">
           <p14:sldIdLst>
             <p14:sldId id="262"/>
             <p14:sldId id="263"/>
@@ -152,14 +152,14 @@
             <p14:sldId id="270"/>
           </p14:sldIdLst>
         </p14:section>
-        <p14:section name="Part 03 · 개선 전략" id="{2B47C0D4-C69A-40D5-9D2C-FF58ED8F7CA4}">
+        <p14:section name="Part 03 · 개선 전략" id="{C930BF81-AF20-49EA-92A8-B65AE9A9AA5C}">
           <p14:sldIdLst>
             <p14:sldId id="271"/>
             <p14:sldId id="272"/>
             <p14:sldId id="273"/>
           </p14:sldIdLst>
         </p14:section>
-        <p14:section name="Part 04 · Q&amp;A" id="{72C01FB5-24E4-446F-B2E3-E5CB4F178147}">
+        <p14:section name="Part 04 · Q&amp;A" id="{005C3F53-9451-49C7-B63E-62FB468340DE}">
           <p14:sldIdLst>
             <p14:sldId id="274"/>
           </p14:sldIdLst>
@@ -14896,7 +14896,7 @@
                 <a:ea typeface="맑은 고딕"/>
                 <a:cs typeface="맑은 고딕"/>
               </a:rPr>
-              <a:t>Direct Booking 전략: 병목 줄을 2갈래로 만든다</a:t>
+              <a:t>Direct Booking 전략: 하나의 병목 줄을 두 갈래로</a:t>
             </a:r>
           </a:p>
         </p:txBody>
@@ -20078,7 +20078,7 @@
                 <a:ea typeface="맑은 고딕"/>
                 <a:cs typeface="맑은 고딕"/>
               </a:rPr>
-              <a:t>Direct Booking 전략 · 병목 줄을 2갈래로 · 단축률 가정 + 파일럿</a:t>
+              <a:t>Direct Booking 전략 · 하나의 병목 줄을 두 갈래로 · 단축률 가정 + 파일럿</a:t>
             </a:r>
           </a:p>
         </p:txBody>
@@ -21865,7 +21865,7 @@
                 <a:ea typeface="맑은 고딕"/>
                 <a:cs typeface="맑은 고딕"/>
               </a:rPr>
-              <a:t>Direct Booking: 병목</a:t>
+              <a:t>Direct Booking 전략: 하나의</a:t>
             </a:r>
             <a:br>
               <a:rPr lang="ko-KR" sz="1150" b="0" dirty="0">
@@ -21886,7 +21886,7 @@
                 <a:ea typeface="맑은 고딕"/>
                 <a:cs typeface="맑은 고딕"/>
               </a:rPr>
-              <a:t>줄을 2갈래로</a:t>
+              <a:t>병목 줄을 두 갈래로</a:t>
             </a:r>
           </a:p>
           <a:p>
@@ -23764,14 +23764,14 @@
       </p:sp>
       <p:sp>
         <p:nvSpPr>
-          <p:cNvPr id="27" name="body:L4:t"/>
+          <p:cNvPr id="27" name="body:L5:t"/>
           <p:cNvSpPr txBox="1"/>
           <p:nvPr/>
         </p:nvSpPr>
         <p:spPr>
           <a:xfrm>
             <a:off x="8283244" y="4407154"/>
-            <a:ext cx="3204362" cy="929640"/>
+            <a:ext cx="3204362" cy="1143000"/>
           </a:xfrm>
           <a:prstGeom prst="rect">
             <a:avLst/>
@@ -23806,7 +23806,28 @@
                 <a:ea typeface="맑은 고딕"/>
                 <a:cs typeface="맑은 고딕"/>
               </a:rPr>
-              <a:t>Direct Booking 전략: 병목 줄을 2갈래로</a:t>
+              <a:t>Direct Booking 전략: 하나의</a:t>
+            </a:r>
+            <a:br>
+              <a:rPr lang="ko-KR" sz="1200" b="0" dirty="0">
+                <a:solidFill>
+                  <a:srgbClr val="334155"/>
+                </a:solidFill>
+                <a:latin typeface="맑은 고딕"/>
+                <a:ea typeface="맑은 고딕"/>
+                <a:cs typeface="맑은 고딕"/>
+              </a:rPr>
+            </a:br>
+            <a:r>
+              <a:rPr lang="ko-KR" sz="1200" b="0" dirty="0">
+                <a:solidFill>
+                  <a:srgbClr val="334155"/>
+                </a:solidFill>
+                <a:latin typeface="맑은 고딕"/>
+                <a:ea typeface="맑은 고딕"/>
+                <a:cs typeface="맑은 고딕"/>
+              </a:rPr>
+              <a:t>병목 줄을 두 갈래로</a:t>
             </a:r>
           </a:p>
           <a:p>

</xml_diff>

<commit_message>
feat(deck): express inflow cut as '39.4% 감소'
Co-Authored-By: Claude Sonnet 5.5 <noreply@anthropic.com>
</commit_message>
<xml_diff>
--- a/outputs/pptx/puzzledata_repair_report.pptx
+++ b/outputs/pptx/puzzledata_repair_report.pptx
@@ -125,21 +125,21 @@
   <p:extLst>
     <p:ext uri="{521415D9-36F7-43E2-AB2F-B90AF26B5E84}">
       <p14:sectionLst xmlns:p14="http://schemas.microsoft.com/office/powerpoint/2010/main">
-        <p14:section name="Part 00 · 인트로" id="{75F0AB8F-4225-4AA6-9E01-F62A4ACA105F}">
+        <p14:section name="Part 00 · 인트로" id="{40EF2157-F283-4ECB-A235-70EB203CDB59}">
           <p14:sldIdLst>
             <p14:sldId id="256"/>
             <p14:sldId id="257"/>
             <p14:sldId id="258"/>
           </p14:sldIdLst>
         </p14:section>
-        <p14:section name="Part 01 · 데이터 진단" id="{792E82EB-7B93-456E-B995-65BC72BBE871}">
+        <p14:section name="Part 01 · 데이터 진단" id="{9C9A3328-9061-4004-9D3D-0020B8F2FBBA}">
           <p14:sldIdLst>
             <p14:sldId id="259"/>
             <p14:sldId id="260"/>
             <p14:sldId id="261"/>
           </p14:sldIdLst>
         </p14:section>
-        <p14:section name="Part 02 · 병목 규명" id="{7E681A25-8BD4-4A87-926C-31AB3BE12F24}">
+        <p14:section name="Part 02 · 병목 규명" id="{DA1EE50E-3221-4EE5-A225-218DB7F50A49}">
           <p14:sldIdLst>
             <p14:sldId id="262"/>
             <p14:sldId id="263"/>
@@ -152,14 +152,14 @@
             <p14:sldId id="270"/>
           </p14:sldIdLst>
         </p14:section>
-        <p14:section name="Part 03 · 개선 전략" id="{C930BF81-AF20-49EA-92A8-B65AE9A9AA5C}">
+        <p14:section name="Part 03 · 개선 전략" id="{15523D49-A611-4353-88FD-34D274A65E07}">
           <p14:sldIdLst>
             <p14:sldId id="271"/>
             <p14:sldId id="272"/>
             <p14:sldId id="273"/>
           </p14:sldIdLst>
         </p14:section>
-        <p14:section name="Part 04 · Q&amp;A" id="{005C3F53-9451-49C7-B63E-62FB468340DE}">
+        <p14:section name="Part 04 · Q&amp;A" id="{45DCF79D-D0AF-4B39-AEE6-0B18C0CB58C9}">
           <p14:sldIdLst>
             <p14:sldId id="274"/>
           </p14:sldIdLst>
@@ -16884,7 +16884,7 @@
                 <a:ea typeface="맑은 고딕"/>
                 <a:cs typeface="맑은 고딕"/>
               </a:rPr>
-              <a:t>— 일 유입 134.3→81.4건(−39.4%)</a:t>
+              <a:t>— 일 유입 134.3→81.4건(39.4% 감소)</a:t>
             </a:r>
           </a:p>
           <a:p>
@@ -23853,7 +23853,7 @@
                 <a:ea typeface="맑은 고딕"/>
                 <a:cs typeface="맑은 고딕"/>
               </a:rPr>
-              <a:t>실사 줄 유입 −39.4%, 실사 대기</a:t>
+              <a:t>실사 줄 유입 39.4% 감소, 실사</a:t>
             </a:r>
             <a:br>
               <a:rPr lang="ko-KR" sz="1200" b="0" dirty="0">
@@ -23874,7 +23874,7 @@
                 <a:ea typeface="맑은 고딕"/>
                 <a:cs typeface="맑은 고딕"/>
               </a:rPr>
-              <a:t>20% 단축 −15.4h</a:t>
+              <a:t>대기 20% 단축 (−15.4h)</a:t>
             </a:r>
           </a:p>
           <a:p>

</xml_diff>

<commit_message>
feat(deck): summary step 3 shows assumed-cut effect; drop pilot wording from S02/S03/S19
Co-Authored-By: Claude Sonnet 5.5 <noreply@anthropic.com>
</commit_message>
<xml_diff>
--- a/outputs/pptx/puzzledata_repair_report.pptx
+++ b/outputs/pptx/puzzledata_repair_report.pptx
@@ -125,21 +125,21 @@
   <p:extLst>
     <p:ext uri="{521415D9-36F7-43E2-AB2F-B90AF26B5E84}">
       <p14:sectionLst xmlns:p14="http://schemas.microsoft.com/office/powerpoint/2010/main">
-        <p14:section name="Part 00 · 인트로" id="{40EF2157-F283-4ECB-A235-70EB203CDB59}">
+        <p14:section name="Part 00 · 인트로" id="{F3447AD2-95B9-4470-A6D0-DD0DFF1D455A}">
           <p14:sldIdLst>
             <p14:sldId id="256"/>
             <p14:sldId id="257"/>
             <p14:sldId id="258"/>
           </p14:sldIdLst>
         </p14:section>
-        <p14:section name="Part 01 · 데이터 진단" id="{9C9A3328-9061-4004-9D3D-0020B8F2FBBA}">
+        <p14:section name="Part 01 · 데이터 진단" id="{2AB8FC56-37DA-497B-AE65-06D9513EC409}">
           <p14:sldIdLst>
             <p14:sldId id="259"/>
             <p14:sldId id="260"/>
             <p14:sldId id="261"/>
           </p14:sldIdLst>
         </p14:section>
-        <p14:section name="Part 02 · 병목 규명" id="{DA1EE50E-3221-4EE5-A225-218DB7F50A49}">
+        <p14:section name="Part 02 · 병목 규명" id="{F695F216-1BCF-43AC-A440-05A875D49F32}">
           <p14:sldIdLst>
             <p14:sldId id="262"/>
             <p14:sldId id="263"/>
@@ -152,14 +152,14 @@
             <p14:sldId id="270"/>
           </p14:sldIdLst>
         </p14:section>
-        <p14:section name="Part 03 · 개선 전략" id="{15523D49-A611-4353-88FD-34D274A65E07}">
+        <p14:section name="Part 03 · 개선 전략" id="{E75F4561-BCF3-4FE4-B445-ABFBD2E07C71}">
           <p14:sldIdLst>
             <p14:sldId id="271"/>
             <p14:sldId id="272"/>
             <p14:sldId id="273"/>
           </p14:sldIdLst>
         </p14:section>
-        <p14:section name="Part 04 · Q&amp;A" id="{45DCF79D-D0AF-4B39-AEE6-0B18C0CB58C9}">
+        <p14:section name="Part 04 · Q&amp;A" id="{64ED34BD-A6E9-47A2-B09D-9E43130B76E3}">
           <p14:sldIdLst>
             <p14:sldId id="274"/>
           </p14:sldIdLst>
@@ -20078,7 +20078,7 @@
                 <a:ea typeface="맑은 고딕"/>
                 <a:cs typeface="맑은 고딕"/>
               </a:rPr>
-              <a:t>Direct Booking 전략 · 하나의 병목 줄을 두 갈래로 · 단축률 가정 + 파일럿</a:t>
+              <a:t>Direct Booking 전략 · 하나의 병목 줄을 두 갈래로 · 단축률 가정</a:t>
             </a:r>
           </a:p>
         </p:txBody>
@@ -21776,14 +21776,14 @@
       </p:sp>
       <p:sp>
         <p:nvSpPr>
-          <p:cNvPr id="27" name="body:L6:t"/>
+          <p:cNvPr id="27" name="body:L5:t"/>
           <p:cNvSpPr txBox="1"/>
           <p:nvPr/>
         </p:nvSpPr>
         <p:spPr>
           <a:xfrm>
             <a:off x="6406743" y="3487928"/>
-            <a:ext cx="2220391" cy="1303020"/>
+            <a:ext cx="2220391" cy="1098550"/>
           </a:xfrm>
           <a:prstGeom prst="rect">
             <a:avLst/>
@@ -21912,28 +21912,7 @@
                 <a:ea typeface="맑은 고딕"/>
                 <a:cs typeface="맑은 고딕"/>
               </a:rPr>
-              <a:t>단축률 가정과 파일럿</a:t>
-            </a:r>
-            <a:br>
-              <a:rPr lang="ko-KR" sz="1150" b="0" dirty="0">
-                <a:solidFill>
-                  <a:srgbClr val="334155"/>
-                </a:solidFill>
-                <a:latin typeface="맑은 고딕"/>
-                <a:ea typeface="맑은 고딕"/>
-                <a:cs typeface="맑은 고딕"/>
-              </a:rPr>
-            </a:br>
-            <a:r>
-              <a:rPr lang="ko-KR" sz="1150" b="0" dirty="0">
-                <a:solidFill>
-                  <a:srgbClr val="334155"/>
-                </a:solidFill>
-                <a:latin typeface="맑은 고딕"/>
-                <a:ea typeface="맑은 고딕"/>
-                <a:cs typeface="맑은 고딕"/>
-              </a:rPr>
-              <a:t>검증 설계</a:t>
+              <a:t>단축률 가정 시 감축 효과</a:t>
             </a:r>
           </a:p>
         </p:txBody>
@@ -23853,28 +23832,7 @@
                 <a:ea typeface="맑은 고딕"/>
                 <a:cs typeface="맑은 고딕"/>
               </a:rPr>
-              <a:t>실사 줄 유입 39.4% 감소, 실사</a:t>
-            </a:r>
-            <a:br>
-              <a:rPr lang="ko-KR" sz="1200" b="0" dirty="0">
-                <a:solidFill>
-                  <a:srgbClr val="334155"/>
-                </a:solidFill>
-                <a:latin typeface="맑은 고딕"/>
-                <a:ea typeface="맑은 고딕"/>
-                <a:cs typeface="맑은 고딕"/>
-              </a:rPr>
-            </a:br>
-            <a:r>
-              <a:rPr lang="ko-KR" sz="1200" b="0" dirty="0">
-                <a:solidFill>
-                  <a:srgbClr val="334155"/>
-                </a:solidFill>
-                <a:latin typeface="맑은 고딕"/>
-                <a:ea typeface="맑은 고딕"/>
-                <a:cs typeface="맑은 고딕"/>
-              </a:rPr>
-              <a:t>대기 20% 단축 (−15.4h)</a:t>
+              <a:t>실사 줄 유입 39.4% 감소</a:t>
             </a:r>
           </a:p>
           <a:p>
@@ -23900,7 +23858,28 @@
                 <a:ea typeface="맑은 고딕"/>
                 <a:cs typeface="맑은 고딕"/>
               </a:rPr>
-              <a:t>단축률은 가정, 파일럿으로 검증</a:t>
+              <a:t>가정 단축률(실사 대기 20% 감소)</a:t>
+            </a:r>
+            <a:br>
+              <a:rPr lang="ko-KR" sz="1200" b="0" dirty="0">
+                <a:solidFill>
+                  <a:srgbClr val="334155"/>
+                </a:solidFill>
+                <a:latin typeface="맑은 고딕"/>
+                <a:ea typeface="맑은 고딕"/>
+                <a:cs typeface="맑은 고딕"/>
+              </a:rPr>
+            </a:br>
+            <a:r>
+              <a:rPr lang="ko-KR" sz="1200" b="0" dirty="0">
+                <a:solidFill>
+                  <a:srgbClr val="334155"/>
+                </a:solidFill>
+                <a:latin typeface="맑은 고딕"/>
+                <a:ea typeface="맑은 고딕"/>
+                <a:cs typeface="맑은 고딕"/>
+              </a:rPr>
+              <a:t>적용 시 −15.4h</a:t>
             </a:r>
           </a:p>
         </p:txBody>

</xml_diff>

<commit_message>
feat(deck): slide 4 uses 정상/비정상 결측 wording and event-specific explanation
Co-Authored-By: Claude Sonnet 5.5 <noreply@anthropic.com>
</commit_message>
<xml_diff>
--- a/outputs/pptx/puzzledata_repair_report.pptx
+++ b/outputs/pptx/puzzledata_repair_report.pptx
@@ -125,21 +125,21 @@
   <p:extLst>
     <p:ext uri="{521415D9-36F7-43E2-AB2F-B90AF26B5E84}">
       <p14:sectionLst xmlns:p14="http://schemas.microsoft.com/office/powerpoint/2010/main">
-        <p14:section name="Part 00 · 인트로" id="{F3447AD2-95B9-4470-A6D0-DD0DFF1D455A}">
+        <p14:section name="Part 00 · 인트로" id="{15EB75BF-609F-4467-B098-A2A0566D428A}">
           <p14:sldIdLst>
             <p14:sldId id="256"/>
             <p14:sldId id="257"/>
             <p14:sldId id="258"/>
           </p14:sldIdLst>
         </p14:section>
-        <p14:section name="Part 01 · 데이터 진단" id="{2AB8FC56-37DA-497B-AE65-06D9513EC409}">
+        <p14:section name="Part 01 · 데이터 진단" id="{368E100D-9793-4474-A28A-078ED4265558}">
           <p14:sldIdLst>
             <p14:sldId id="259"/>
             <p14:sldId id="260"/>
             <p14:sldId id="261"/>
           </p14:sldIdLst>
         </p14:section>
-        <p14:section name="Part 02 · 병목 규명" id="{F695F216-1BCF-43AC-A440-05A875D49F32}">
+        <p14:section name="Part 02 · 병목 규명" id="{EC8E5F98-8BCD-47AA-A940-AADB5A1A809D}">
           <p14:sldIdLst>
             <p14:sldId id="262"/>
             <p14:sldId id="263"/>
@@ -152,14 +152,14 @@
             <p14:sldId id="270"/>
           </p14:sldIdLst>
         </p14:section>
-        <p14:section name="Part 03 · 개선 전략" id="{E75F4561-BCF3-4FE4-B445-ABFBD2E07C71}">
+        <p14:section name="Part 03 · 개선 전략" id="{C5B25AA4-C68A-455B-A7BE-B642CF356794}">
           <p14:sldIdLst>
             <p14:sldId id="271"/>
             <p14:sldId id="272"/>
             <p14:sldId id="273"/>
           </p14:sldIdLst>
         </p14:section>
-        <p14:section name="Part 04 · Q&amp;A" id="{64ED34BD-A6E9-47A2-B09D-9E43130B76E3}">
+        <p14:section name="Part 04 · Q&amp;A" id="{14124B92-D0F2-4787-98CE-09D23D98F60D}">
           <p14:sldIdLst>
             <p14:sldId id="274"/>
           </p14:sldIdLst>
@@ -1481,7 +1481,7 @@
           <a:lstStyle/>
           <a:p>
             <a:r>
-              <a:t>데이터를 열어 가장 먼저 확인한 것은 구조였습니다. 이 데이터는 공정마다 행이 쌓이는 이벤트 로그이고, 약 86.0~93.0%의 결측은 후속 수리가 없어 생긴 정상 결측입니다. 반면 필수 속성이 비어 있는 행은 13,262행 중 20행(18개 케이스)뿐이어서 이 행만 복원 대상으로 특정했습니다. 0.1~86.0% 구간에는 속성이 하나도 없어 판별 기준이 명확합니다.</a:t>
+              <a:t>데이터를 열어 가장 먼저 확인한 것은 구조였습니다. 이 데이터는 공정마다 행이 쌓이는 이벤트 로그이고, 약 86.0~93.0%의 결측은 접수·실사·수리 완료 등 특정 이벤트에서만 기록되는 속성이라 구조적으로 비는 정상 결측입니다. 반면 필수 속성이 비어 있는 비정상 결측 행은 13,262행 중 20행(18개 케이스)뿐이어서 이 행만 복원 대상으로 특정했습니다. 0.1~86.0% 구간에는 속성이 하나도 없어 판별 기준이 명확합니다.</a:t>
             </a:r>
           </a:p>
         </p:txBody>
@@ -24085,7 +24085,7 @@
                 <a:ea typeface="맑은 고딕"/>
                 <a:cs typeface="맑은 고딕"/>
               </a:rPr>
-              <a:t>정상 결측은 보존, 에러 20행만 복원 대상</a:t>
+              <a:t>정상 결측은 보존, 비정상 결측 20행만 복원 대상</a:t>
             </a:r>
           </a:p>
         </p:txBody>
@@ -24130,7 +24130,7 @@
                 <a:ea typeface="맑은 고딕"/>
                 <a:cs typeface="맑은 고딕"/>
               </a:rPr>
-              <a:t>결측치를 '정상 결측'과 '시스템 에러'로 2원화하고, 복원 대상을 최소로 특정했다</a:t>
+              <a:t>결측치를 '정상 결측'과 '비정상 결측'으로 2원화하고, 복원 대상을 최소로 특정했다</a:t>
             </a:r>
           </a:p>
         </p:txBody>
@@ -24196,7 +24196,7 @@
                 <a:ea typeface="맑은 고딕"/>
                 <a:cs typeface="Consolas"/>
               </a:rPr>
-              <a:t>출처: repair2.csv 프로파일링 (EDA-01) · 에러 20행 = 5개 속성 결측이 포함된 18개 케이스의 실제 행</a:t>
+              <a:t>출처: repair2.csv 프로파일링 (EDA-01) · 비정상 결측 20행 = 5개 속성 결측이 포함된 18개 케이스의 실제 행</a:t>
             </a:r>
           </a:p>
         </p:txBody>
@@ -24978,7 +24978,7 @@
                 <a:ea typeface="맑은 고딕"/>
                 <a:cs typeface="맑은 고딕"/>
               </a:rPr>
-              <a:t>후속 공정이 없는 값, 대체 없이 보존</a:t>
+              <a:t>특정 이벤트에서만 기록되는 값, 대체 없이 보존</a:t>
             </a:r>
           </a:p>
         </p:txBody>
@@ -25069,7 +25069,7 @@
                 <a:ea typeface="맑은 고딕"/>
                 <a:cs typeface="Consolas"/>
               </a:rPr>
-              <a:t>시스템 에러 · 복원 대상</a:t>
+              <a:t>비정상 결측 · 복원 대상</a:t>
             </a:r>
           </a:p>
         </p:txBody>

</xml_diff>

<commit_message>
feat(deck): slide 4 drops '대체 없이 보존' and renames the 진공 구간 chip
Co-Authored-By: Claude Sonnet 5.5 <noreply@anthropic.com>
</commit_message>
<xml_diff>
--- a/outputs/pptx/puzzledata_repair_report.pptx
+++ b/outputs/pptx/puzzledata_repair_report.pptx
@@ -125,21 +125,21 @@
   <p:extLst>
     <p:ext uri="{521415D9-36F7-43E2-AB2F-B90AF26B5E84}">
       <p14:sectionLst xmlns:p14="http://schemas.microsoft.com/office/powerpoint/2010/main">
-        <p14:section name="Part 00 · 인트로" id="{15EB75BF-609F-4467-B098-A2A0566D428A}">
+        <p14:section name="Part 00 · 인트로" id="{8F5A4909-C462-4D28-AF72-E67FEFFA8277}">
           <p14:sldIdLst>
             <p14:sldId id="256"/>
             <p14:sldId id="257"/>
             <p14:sldId id="258"/>
           </p14:sldIdLst>
         </p14:section>
-        <p14:section name="Part 01 · 데이터 진단" id="{368E100D-9793-4474-A28A-078ED4265558}">
+        <p14:section name="Part 01 · 데이터 진단" id="{8B81FFC9-BC90-40B5-AEEC-88904B1B931D}">
           <p14:sldIdLst>
             <p14:sldId id="259"/>
             <p14:sldId id="260"/>
             <p14:sldId id="261"/>
           </p14:sldIdLst>
         </p14:section>
-        <p14:section name="Part 02 · 병목 규명" id="{EC8E5F98-8BCD-47AA-A940-AADB5A1A809D}">
+        <p14:section name="Part 02 · 병목 규명" id="{DE11BE6D-601E-4146-84F5-30EAFD5C228D}">
           <p14:sldIdLst>
             <p14:sldId id="262"/>
             <p14:sldId id="263"/>
@@ -152,14 +152,14 @@
             <p14:sldId id="270"/>
           </p14:sldIdLst>
         </p14:section>
-        <p14:section name="Part 03 · 개선 전략" id="{C5B25AA4-C68A-455B-A7BE-B642CF356794}">
+        <p14:section name="Part 03 · 개선 전략" id="{3907984C-15AB-4E63-80FF-4F520047F771}">
           <p14:sldIdLst>
             <p14:sldId id="271"/>
             <p14:sldId id="272"/>
             <p14:sldId id="273"/>
           </p14:sldIdLst>
         </p14:section>
-        <p14:section name="Part 04 · Q&amp;A" id="{14124B92-D0F2-4787-98CE-09D23D98F60D}">
+        <p14:section name="Part 04 · Q&amp;A" id="{328BD155-0D22-408B-A720-376BDEB494C1}">
           <p14:sldIdLst>
             <p14:sldId id="274"/>
           </p14:sldIdLst>
@@ -24978,7 +24978,7 @@
                 <a:ea typeface="맑은 고딕"/>
                 <a:cs typeface="맑은 고딕"/>
               </a:rPr>
-              <a:t>특정 이벤트에서만 기록되는 값, 대체 없이 보존</a:t>
+              <a:t>특정 이벤트에서만 기록되는 값</a:t>
             </a:r>
           </a:p>
         </p:txBody>
@@ -25250,7 +25250,7 @@
                 <a:ea typeface="맑은 고딕"/>
                 <a:cs typeface="Consolas"/>
               </a:rPr>
-              <a:t>진공 구간 · 판별 객관성</a:t>
+              <a:t>결측률 분포 · 판별 기준</a:t>
             </a:r>
           </a:p>
         </p:txBody>
@@ -25295,7 +25295,7 @@
                 <a:ea typeface="맑은 고딕"/>
                 <a:cs typeface="맑은 고딕"/>
               </a:rPr>
-              <a:t>0.1~86.0% 구간 속성 0개</a:t>
+              <a:t>0.1~86.0% 사이 속성 0개</a:t>
             </a:r>
           </a:p>
         </p:txBody>
@@ -25340,7 +25340,7 @@
                 <a:ea typeface="맑은 고딕"/>
                 <a:cs typeface="맑은 고딕"/>
               </a:rPr>
-              <a:t>이봉 분포라 정상/비정상 판별이 명확</a:t>
+              <a:t>결측률이 양극단이라 판별이 명확</a:t>
             </a:r>
           </a:p>
         </p:txBody>

</xml_diff>

<commit_message>
feat(deck): slide 5 title and related wording use 업무 순서 and 비정상 결측
Co-Authored-By: Claude Sonnet 5.5 <noreply@anthropic.com>
</commit_message>
<xml_diff>
--- a/outputs/pptx/puzzledata_repair_report.pptx
+++ b/outputs/pptx/puzzledata_repair_report.pptx
@@ -125,21 +125,21 @@
   <p:extLst>
     <p:ext uri="{521415D9-36F7-43E2-AB2F-B90AF26B5E84}">
       <p14:sectionLst xmlns:p14="http://schemas.microsoft.com/office/powerpoint/2010/main">
-        <p14:section name="Part 00 · 인트로" id="{8F5A4909-C462-4D28-AF72-E67FEFFA8277}">
+        <p14:section name="Part 00 · 인트로" id="{F6D565A2-DC20-4CE9-A67C-5A1552C26772}">
           <p14:sldIdLst>
             <p14:sldId id="256"/>
             <p14:sldId id="257"/>
             <p14:sldId id="258"/>
           </p14:sldIdLst>
         </p14:section>
-        <p14:section name="Part 01 · 데이터 진단" id="{8B81FFC9-BC90-40B5-AEEC-88904B1B931D}">
+        <p14:section name="Part 01 · 데이터 진단" id="{224331BD-D628-4349-8550-0FA3E2431B6A}">
           <p14:sldIdLst>
             <p14:sldId id="259"/>
             <p14:sldId id="260"/>
             <p14:sldId id="261"/>
           </p14:sldIdLst>
         </p14:section>
-        <p14:section name="Part 02 · 병목 규명" id="{DE11BE6D-601E-4146-84F5-30EAFD5C228D}">
+        <p14:section name="Part 02 · 병목 규명" id="{FB71BE5D-89FD-44EE-B852-DC1893B1F66A}">
           <p14:sldIdLst>
             <p14:sldId id="262"/>
             <p14:sldId id="263"/>
@@ -152,14 +152,14 @@
             <p14:sldId id="270"/>
           </p14:sldIdLst>
         </p14:section>
-        <p14:section name="Part 03 · 개선 전략" id="{3907984C-15AB-4E63-80FF-4F520047F771}">
+        <p14:section name="Part 03 · 개선 전략" id="{8A20A2C8-4C56-4320-913F-ED1870C90B65}">
           <p14:sldIdLst>
             <p14:sldId id="271"/>
             <p14:sldId id="272"/>
             <p14:sldId id="273"/>
           </p14:sldIdLst>
         </p14:section>
-        <p14:section name="Part 04 · Q&amp;A" id="{328BD155-0D22-408B-A720-376BDEB494C1}">
+        <p14:section name="Part 04 · Q&amp;A" id="{F42A4F57-B2F6-43FF-A670-E806F47CBCF3}">
           <p14:sldIdLst>
             <p14:sldId id="274"/>
           </p14:sldIdLst>
@@ -23014,7 +23014,7 @@
                 <a:ea typeface="맑은 고딕"/>
                 <a:cs typeface="맑은 고딕"/>
               </a:rPr>
-              <a:t>결측 20행(0.15%)을 업무 인과로 복원</a:t>
+              <a:t>결측 20행(0.15%)을 업무 순서로 복원</a:t>
             </a:r>
           </a:p>
           <a:p>
@@ -25501,7 +25501,7 @@
                 <a:ea typeface="맑은 고딕"/>
                 <a:cs typeface="맑은 고딕"/>
               </a:rPr>
-              <a:t>삭제 없이, 업무 인과로 결측을 복원했다</a:t>
+              <a:t>업무 순서로 결측과 오기입을 교정 복원했다</a:t>
             </a:r>
           </a:p>
         </p:txBody>
@@ -25546,7 +25546,7 @@
                 <a:ea typeface="맑은 고딕"/>
                 <a:cs typeface="맑은 고딕"/>
               </a:rPr>
-              <a:t>결측 20행에 더해 날짜 오기입 866건·더미 시각 15건까지 5개 유형을 근거 기반으로 복원</a:t>
+              <a:t>비정상 결측 20행에 더해 날짜 오기입 866건·더미 시각 15건까지 5개 유형을 근거 기반으로 복원</a:t>
             </a:r>
           </a:p>
         </p:txBody>
@@ -28447,7 +28447,7 @@
                 <a:ea typeface="맑은 고딕"/>
                 <a:cs typeface="맑은 고딕"/>
               </a:rPr>
-              <a:t>0건 · 업무 인과 복원</a:t>
+              <a:t>0건 · 업무 순서 복원</a:t>
             </a:r>
           </a:p>
         </p:txBody>

</xml_diff>

<commit_message>
feat(deck): slide 5 states row vs case units, adds unit legend, title keeps 삭제 없이
Co-Authored-By: Claude Sonnet 5.5 <noreply@anthropic.com>
</commit_message>
<xml_diff>
--- a/outputs/pptx/puzzledata_repair_report.pptx
+++ b/outputs/pptx/puzzledata_repair_report.pptx
@@ -125,21 +125,21 @@
   <p:extLst>
     <p:ext uri="{521415D9-36F7-43E2-AB2F-B90AF26B5E84}">
       <p14:sectionLst xmlns:p14="http://schemas.microsoft.com/office/powerpoint/2010/main">
-        <p14:section name="Part 00 · 인트로" id="{F6D565A2-DC20-4CE9-A67C-5A1552C26772}">
+        <p14:section name="Part 00 · 인트로" id="{264FE79F-2246-48D8-85F2-42A8C3BC2AEA}">
           <p14:sldIdLst>
             <p14:sldId id="256"/>
             <p14:sldId id="257"/>
             <p14:sldId id="258"/>
           </p14:sldIdLst>
         </p14:section>
-        <p14:section name="Part 01 · 데이터 진단" id="{224331BD-D628-4349-8550-0FA3E2431B6A}">
+        <p14:section name="Part 01 · 데이터 진단" id="{DAE6320F-83F3-4285-8E63-ED0FC2257F34}">
           <p14:sldIdLst>
             <p14:sldId id="259"/>
             <p14:sldId id="260"/>
             <p14:sldId id="261"/>
           </p14:sldIdLst>
         </p14:section>
-        <p14:section name="Part 02 · 병목 규명" id="{FB71BE5D-89FD-44EE-B852-DC1893B1F66A}">
+        <p14:section name="Part 02 · 병목 규명" id="{3E8ACA7F-D85F-410A-BB03-6313DE506532}">
           <p14:sldIdLst>
             <p14:sldId id="262"/>
             <p14:sldId id="263"/>
@@ -152,14 +152,14 @@
             <p14:sldId id="270"/>
           </p14:sldIdLst>
         </p14:section>
-        <p14:section name="Part 03 · 개선 전략" id="{8A20A2C8-4C56-4320-913F-ED1870C90B65}">
+        <p14:section name="Part 03 · 개선 전략" id="{32929D4B-6F64-48E0-B4D1-F8CA37658EE0}">
           <p14:sldIdLst>
             <p14:sldId id="271"/>
             <p14:sldId id="272"/>
             <p14:sldId id="273"/>
           </p14:sldIdLst>
         </p14:section>
-        <p14:section name="Part 04 · Q&amp;A" id="{F42A4F57-B2F6-43FF-A670-E806F47CBCF3}">
+        <p14:section name="Part 04 · Q&amp;A" id="{542A7148-5041-4CB3-873E-517D2BB80ACD}">
           <p14:sldIdLst>
             <p14:sldId id="274"/>
           </p14:sldIdLst>
@@ -1551,7 +1551,7 @@
           <a:lstStyle/>
           <a:p>
             <a:r>
-              <a:t>복원 과정에서 단 한 행도 버리지 않았습니다. 시작·완료 담당자의 일치율 100%와 태스크 고유 속성을 근거로 CASE 1~3을 복원했고, 날짜는 시각이 정상인 859행에 순서 제약을 걸어 복원했습니다. 시각은 정상 접수 표본 754건의 중앙값 4.0분을 앵커로 역산했습니다. 그 결과 시간 역전이 0건인 데이터셋을 확보했습니다. [예상 질문] 표본 수가 751건이 아닌가? → 현재 노트북(Cell 63) 재실행 기준 754건(기준 케이스 755건)입니다.</a:t>
+              <a:t>복원 과정에서 단 한 행도 버리지 않았습니다. 시작·완료 담당자의 일치율 100%와 태스크 고유 속성을 근거로 CASE 1~3을 복원했고, 날짜는 시각이 정상인 859행에 순서 제약을 걸어 복원했습니다. 시각은 정상 접수 표본 754케이스의 중앙값 4.0분을 앵커로 역산했습니다. 그 결과 시간 역전이 0건인 데이터셋을 확보했습니다. [예상 질문] 표본 수가 751건이 아닌가? → 현재 노트북(Cell 63) 재실행 기준 754건(기준 케이스 755건)입니다.</a:t>
             </a:r>
           </a:p>
         </p:txBody>
@@ -23040,7 +23040,7 @@
                 <a:ea typeface="맑은 고딕"/>
                 <a:cs typeface="맑은 고딕"/>
               </a:rPr>
-              <a:t>정상 접수 표본 754건(75.4%)으로</a:t>
+              <a:t>정상 접수 표본 754케이스(75.4%)로</a:t>
             </a:r>
             <a:br>
               <a:rPr lang="ko-KR" sz="1200" b="0" dirty="0">
@@ -25501,7 +25501,7 @@
                 <a:ea typeface="맑은 고딕"/>
                 <a:cs typeface="맑은 고딕"/>
               </a:rPr>
-              <a:t>업무 순서로 결측과 오기입을 교정 복원했다</a:t>
+              <a:t>삭제 없이, 업무 순서로 결측과 오기입을 교정 복원했다</a:t>
             </a:r>
           </a:p>
         </p:txBody>
@@ -25546,7 +25546,7 @@
                 <a:ea typeface="맑은 고딕"/>
                 <a:cs typeface="맑은 고딕"/>
               </a:rPr>
-              <a:t>비정상 결측 20행에 더해 날짜 오기입 866건·더미 시각 15건까지 5개 유형을 근거 기반으로 복원</a:t>
+              <a:t>비정상 결측 20행에 더해 날짜 오기입 866행·더미 시각 15행까지 5개 유형을 근거 기반으로 복원</a:t>
             </a:r>
           </a:p>
         </p:txBody>
@@ -25664,14 +25664,59 @@
       </p:sp>
       <p:sp>
         <p:nvSpPr>
-          <p:cNvPr id="9" name="cases-card"/>
+          <p:cNvPr id="9" name="label:L1:unit-legend"/>
+          <p:cNvSpPr txBox="1"/>
+          <p:nvPr/>
+        </p:nvSpPr>
+        <p:spPr>
+          <a:xfrm>
+            <a:off x="5287975" y="1499616"/>
+            <a:ext cx="6400800" cy="167640"/>
+          </a:xfrm>
+          <a:prstGeom prst="rect">
+            <a:avLst/>
+          </a:prstGeom>
+          <a:noFill/>
+        </p:spPr>
+        <p:txBody>
+          <a:bodyPr wrap="square" lIns="0" tIns="0" rIns="0" bIns="0" anchor="t">
+            <a:noAutofit/>
+          </a:bodyPr>
+          <a:lstStyle/>
+          <a:p>
+            <a:pPr algn="r">
+              <a:lnSpc>
+                <a:spcPts val="1320"/>
+              </a:lnSpc>
+              <a:spcBef>
+                <a:spcPts val="0"/>
+              </a:spcBef>
+              <a:buNone/>
+            </a:pPr>
+            <a:r>
+              <a:rPr lang="ko-KR" sz="1000" b="0" dirty="0">
+                <a:solidFill>
+                  <a:srgbClr val="64748B"/>
+                </a:solidFill>
+                <a:latin typeface="Consolas"/>
+                <a:ea typeface="맑은 고딕"/>
+                <a:cs typeface="Consolas"/>
+              </a:rPr>
+              <a:t>단위 · 행 = 이벤트 로그 1행 / 케이스 = 수리 요청 1건</a:t>
+            </a:r>
+          </a:p>
+        </p:txBody>
+      </p:sp>
+      <p:sp>
+        <p:nvSpPr>
+          <p:cNvPr id="10" name="cases-card"/>
           <p:cNvSpPr/>
           <p:nvPr/>
         </p:nvSpPr>
         <p:spPr>
           <a:xfrm>
-            <a:off x="502920" y="1554480"/>
-            <a:ext cx="11185855" cy="3196844"/>
+            <a:off x="502920" y="1792224"/>
+            <a:ext cx="11185855" cy="3013963"/>
           </a:xfrm>
           <a:prstGeom prst="rect">
             <a:avLst/>
@@ -25710,13 +25755,13 @@
       </p:sp>
       <p:sp>
         <p:nvSpPr>
-          <p:cNvPr id="10" name="label:L1:cases-h"/>
-          <p:cNvSpPr txBox="1"/>
-          <p:nvPr/>
-        </p:nvSpPr>
-        <p:spPr>
-          <a:xfrm>
-            <a:off x="758952" y="1755648"/>
+          <p:cNvPr id="11" name="label:L1:cases-h"/>
+          <p:cNvSpPr txBox="1"/>
+          <p:nvPr/>
+        </p:nvSpPr>
+        <p:spPr>
+          <a:xfrm>
+            <a:off x="758952" y="1993392"/>
             <a:ext cx="568735" cy="158750"/>
           </a:xfrm>
           <a:prstGeom prst="rect">
@@ -25755,13 +25800,13 @@
       </p:sp>
       <p:sp>
         <p:nvSpPr>
-          <p:cNvPr id="11" name="label:L1:cases-h"/>
-          <p:cNvSpPr txBox="1"/>
-          <p:nvPr/>
-        </p:nvSpPr>
-        <p:spPr>
-          <a:xfrm>
-            <a:off x="1510567" y="1755648"/>
+          <p:cNvPr id="12" name="label:L1:cases-h"/>
+          <p:cNvSpPr txBox="1"/>
+          <p:nvPr/>
+        </p:nvSpPr>
+        <p:spPr>
+          <a:xfrm>
+            <a:off x="1510567" y="1993392"/>
             <a:ext cx="2322505" cy="158750"/>
           </a:xfrm>
           <a:prstGeom prst="rect">
@@ -25800,13 +25845,13 @@
       </p:sp>
       <p:sp>
         <p:nvSpPr>
-          <p:cNvPr id="12" name="label:L1:cases-h"/>
-          <p:cNvSpPr txBox="1"/>
-          <p:nvPr/>
-        </p:nvSpPr>
-        <p:spPr>
-          <a:xfrm>
-            <a:off x="4015953" y="1755648"/>
+          <p:cNvPr id="13" name="label:L1:cases-h"/>
+          <p:cNvSpPr txBox="1"/>
+          <p:nvPr/>
+        </p:nvSpPr>
+        <p:spPr>
+          <a:xfrm>
+            <a:off x="4015953" y="1993392"/>
             <a:ext cx="3408172" cy="158750"/>
           </a:xfrm>
           <a:prstGeom prst="rect">
@@ -25845,13 +25890,13 @@
       </p:sp>
       <p:sp>
         <p:nvSpPr>
-          <p:cNvPr id="13" name="label:L1:cases-h"/>
-          <p:cNvSpPr txBox="1"/>
-          <p:nvPr/>
-        </p:nvSpPr>
-        <p:spPr>
-          <a:xfrm>
-            <a:off x="7607006" y="1755648"/>
+          <p:cNvPr id="14" name="label:L1:cases-h"/>
+          <p:cNvSpPr txBox="1"/>
+          <p:nvPr/>
+        </p:nvSpPr>
+        <p:spPr>
+          <a:xfrm>
+            <a:off x="7607006" y="1993392"/>
             <a:ext cx="3825737" cy="158750"/>
           </a:xfrm>
           <a:prstGeom prst="rect">
@@ -25890,13 +25935,13 @@
       </p:sp>
       <p:cxnSp>
         <p:nvCxnSpPr>
-          <p:cNvPr id="14" name="rule"/>
+          <p:cNvPr id="15" name="rule"/>
           <p:cNvCxnSpPr/>
           <p:nvPr/>
         </p:nvCxnSpPr>
         <p:spPr>
           <a:xfrm>
-            <a:off x="667512" y="1993392"/>
+            <a:off x="667512" y="2231136"/>
             <a:ext cx="10856671" cy="0"/>
           </a:xfrm>
           <a:prstGeom prst="line">
@@ -25911,13 +25956,13 @@
       </p:cxnSp>
       <p:sp>
         <p:nvSpPr>
-          <p:cNvPr id="15" name="label:L1:t"/>
-          <p:cNvSpPr txBox="1"/>
-          <p:nvPr/>
-        </p:nvSpPr>
-        <p:spPr>
-          <a:xfrm>
-            <a:off x="758952" y="2048256"/>
+          <p:cNvPr id="16" name="label:L1:t"/>
+          <p:cNvSpPr txBox="1"/>
+          <p:nvPr/>
+        </p:nvSpPr>
+        <p:spPr>
+          <a:xfrm>
+            <a:off x="758952" y="2267712"/>
             <a:ext cx="568735" cy="167640"/>
           </a:xfrm>
           <a:prstGeom prst="rect">
@@ -25956,13 +26001,13 @@
       </p:sp>
       <p:sp>
         <p:nvSpPr>
-          <p:cNvPr id="16" name="body:L2:t"/>
-          <p:cNvSpPr txBox="1"/>
-          <p:nvPr/>
-        </p:nvSpPr>
-        <p:spPr>
-          <a:xfrm>
-            <a:off x="1510567" y="2048256"/>
+          <p:cNvPr id="17" name="body:L2:t"/>
+          <p:cNvSpPr txBox="1"/>
+          <p:nvPr/>
+        </p:nvSpPr>
+        <p:spPr>
+          <a:xfrm>
+            <a:off x="1510567" y="2267712"/>
             <a:ext cx="2322505" cy="408940"/>
           </a:xfrm>
           <a:prstGeom prst="rect">
@@ -26016,20 +26061,20 @@
                 <a:ea typeface="맑은 고딕"/>
                 <a:cs typeface="맑은 고딕"/>
               </a:rPr>
-              <a:t>결측 2건</a:t>
-            </a:r>
-          </a:p>
-        </p:txBody>
-      </p:sp>
-      <p:sp>
-        <p:nvSpPr>
-          <p:cNvPr id="17" name="body:L2:t"/>
-          <p:cNvSpPr txBox="1"/>
-          <p:nvPr/>
-        </p:nvSpPr>
-        <p:spPr>
-          <a:xfrm>
-            <a:off x="4015953" y="2048256"/>
+              <a:t>결측 2행</a:t>
+            </a:r>
+          </a:p>
+        </p:txBody>
+      </p:sp>
+      <p:sp>
+        <p:nvSpPr>
+          <p:cNvPr id="18" name="body:L2:t"/>
+          <p:cNvSpPr txBox="1"/>
+          <p:nvPr/>
+        </p:nvSpPr>
+        <p:spPr>
+          <a:xfrm>
+            <a:off x="4015953" y="2267712"/>
             <a:ext cx="3408172" cy="408940"/>
           </a:xfrm>
           <a:prstGeom prst="rect">
@@ -26089,13 +26134,13 @@
       </p:sp>
       <p:sp>
         <p:nvSpPr>
-          <p:cNvPr id="18" name="body:L1:t"/>
-          <p:cNvSpPr txBox="1"/>
-          <p:nvPr/>
-        </p:nvSpPr>
-        <p:spPr>
-          <a:xfrm>
-            <a:off x="7607006" y="2048256"/>
+          <p:cNvPr id="19" name="body:L1:t"/>
+          <p:cNvSpPr txBox="1"/>
+          <p:nvPr/>
+        </p:nvSpPr>
+        <p:spPr>
+          <a:xfrm>
+            <a:off x="7607006" y="2267712"/>
             <a:ext cx="3825737" cy="204470"/>
           </a:xfrm>
           <a:prstGeom prst="rect">
@@ -26134,13 +26179,13 @@
       </p:sp>
       <p:cxnSp>
         <p:nvCxnSpPr>
-          <p:cNvPr id="19" name="rule"/>
+          <p:cNvPr id="20" name="rule"/>
           <p:cNvCxnSpPr/>
           <p:nvPr/>
         </p:nvCxnSpPr>
         <p:spPr>
           <a:xfrm>
-            <a:off x="667512" y="2512060"/>
+            <a:off x="667512" y="2713228"/>
             <a:ext cx="10856671" cy="0"/>
           </a:xfrm>
           <a:prstGeom prst="line">
@@ -26155,13 +26200,13 @@
       </p:cxnSp>
       <p:sp>
         <p:nvSpPr>
-          <p:cNvPr id="20" name="label:L1:t"/>
-          <p:cNvSpPr txBox="1"/>
-          <p:nvPr/>
-        </p:nvSpPr>
-        <p:spPr>
-          <a:xfrm>
-            <a:off x="758952" y="2566924"/>
+          <p:cNvPr id="21" name="label:L1:t"/>
+          <p:cNvSpPr txBox="1"/>
+          <p:nvPr/>
+        </p:nvSpPr>
+        <p:spPr>
+          <a:xfrm>
+            <a:off x="758952" y="2749804"/>
             <a:ext cx="568735" cy="167640"/>
           </a:xfrm>
           <a:prstGeom prst="rect">
@@ -26200,13 +26245,13 @@
       </p:sp>
       <p:sp>
         <p:nvSpPr>
-          <p:cNvPr id="21" name="body:L2:t"/>
-          <p:cNvSpPr txBox="1"/>
-          <p:nvPr/>
-        </p:nvSpPr>
-        <p:spPr>
-          <a:xfrm>
-            <a:off x="1510567" y="2566924"/>
+          <p:cNvPr id="22" name="body:L2:t"/>
+          <p:cNvSpPr txBox="1"/>
+          <p:nvPr/>
+        </p:nvSpPr>
+        <p:spPr>
+          <a:xfrm>
+            <a:off x="1510567" y="2749804"/>
             <a:ext cx="2322505" cy="408940"/>
           </a:xfrm>
           <a:prstGeom prst="rect">
@@ -26260,20 +26305,20 @@
                 <a:ea typeface="맑은 고딕"/>
                 <a:cs typeface="맑은 고딕"/>
               </a:rPr>
-              <a:t>결측 2건</a:t>
-            </a:r>
-          </a:p>
-        </p:txBody>
-      </p:sp>
-      <p:sp>
-        <p:nvSpPr>
-          <p:cNvPr id="22" name="body:L1:t"/>
-          <p:cNvSpPr txBox="1"/>
-          <p:nvPr/>
-        </p:nvSpPr>
-        <p:spPr>
-          <a:xfrm>
-            <a:off x="4015953" y="2566924"/>
+              <a:t>결측 2행</a:t>
+            </a:r>
+          </a:p>
+        </p:txBody>
+      </p:sp>
+      <p:sp>
+        <p:nvSpPr>
+          <p:cNvPr id="23" name="body:L1:t"/>
+          <p:cNvSpPr txBox="1"/>
+          <p:nvPr/>
+        </p:nvSpPr>
+        <p:spPr>
+          <a:xfrm>
+            <a:off x="4015953" y="2749804"/>
             <a:ext cx="3408172" cy="204470"/>
           </a:xfrm>
           <a:prstGeom prst="rect">
@@ -26312,13 +26357,13 @@
       </p:sp>
       <p:sp>
         <p:nvSpPr>
-          <p:cNvPr id="23" name="body:L1:t"/>
-          <p:cNvSpPr txBox="1"/>
-          <p:nvPr/>
-        </p:nvSpPr>
-        <p:spPr>
-          <a:xfrm>
-            <a:off x="7607006" y="2566924"/>
+          <p:cNvPr id="24" name="body:L1:t"/>
+          <p:cNvSpPr txBox="1"/>
+          <p:nvPr/>
+        </p:nvSpPr>
+        <p:spPr>
+          <a:xfrm>
+            <a:off x="7607006" y="2749804"/>
             <a:ext cx="3825737" cy="204470"/>
           </a:xfrm>
           <a:prstGeom prst="rect">
@@ -26357,13 +26402,13 @@
       </p:sp>
       <p:cxnSp>
         <p:nvCxnSpPr>
-          <p:cNvPr id="24" name="rule"/>
+          <p:cNvPr id="25" name="rule"/>
           <p:cNvCxnSpPr/>
           <p:nvPr/>
         </p:nvCxnSpPr>
         <p:spPr>
           <a:xfrm>
-            <a:off x="667512" y="3030728"/>
+            <a:off x="667512" y="3195320"/>
             <a:ext cx="10856671" cy="0"/>
           </a:xfrm>
           <a:prstGeom prst="line">
@@ -26378,13 +26423,13 @@
       </p:cxnSp>
       <p:sp>
         <p:nvSpPr>
-          <p:cNvPr id="25" name="label:L1:t"/>
-          <p:cNvSpPr txBox="1"/>
-          <p:nvPr/>
-        </p:nvSpPr>
-        <p:spPr>
-          <a:xfrm>
-            <a:off x="758952" y="3085592"/>
+          <p:cNvPr id="26" name="label:L1:t"/>
+          <p:cNvSpPr txBox="1"/>
+          <p:nvPr/>
+        </p:nvSpPr>
+        <p:spPr>
+          <a:xfrm>
+            <a:off x="758952" y="3231896"/>
             <a:ext cx="568735" cy="167640"/>
           </a:xfrm>
           <a:prstGeom prst="rect">
@@ -26423,13 +26468,13 @@
       </p:sp>
       <p:sp>
         <p:nvSpPr>
-          <p:cNvPr id="26" name="body:L2:t"/>
-          <p:cNvSpPr txBox="1"/>
-          <p:nvPr/>
-        </p:nvSpPr>
-        <p:spPr>
-          <a:xfrm>
-            <a:off x="1510567" y="3085592"/>
+          <p:cNvPr id="27" name="body:L2:t"/>
+          <p:cNvSpPr txBox="1"/>
+          <p:nvPr/>
+        </p:nvSpPr>
+        <p:spPr>
+          <a:xfrm>
+            <a:off x="1510567" y="3231896"/>
             <a:ext cx="2322505" cy="408940"/>
           </a:xfrm>
           <a:prstGeom prst="rect">
@@ -26483,20 +26528,20 @@
                 <a:ea typeface="맑은 고딕"/>
                 <a:cs typeface="맑은 고딕"/>
               </a:rPr>
-              <a:t>결측 5건</a:t>
-            </a:r>
-          </a:p>
-        </p:txBody>
-      </p:sp>
-      <p:sp>
-        <p:nvSpPr>
-          <p:cNvPr id="27" name="body:L1:t"/>
-          <p:cNvSpPr txBox="1"/>
-          <p:nvPr/>
-        </p:nvSpPr>
-        <p:spPr>
-          <a:xfrm>
-            <a:off x="4015953" y="3085592"/>
+              <a:t>결측 5행</a:t>
+            </a:r>
+          </a:p>
+        </p:txBody>
+      </p:sp>
+      <p:sp>
+        <p:nvSpPr>
+          <p:cNvPr id="28" name="body:L1:t"/>
+          <p:cNvSpPr txBox="1"/>
+          <p:nvPr/>
+        </p:nvSpPr>
+        <p:spPr>
+          <a:xfrm>
+            <a:off x="4015953" y="3231896"/>
             <a:ext cx="3408172" cy="204470"/>
           </a:xfrm>
           <a:prstGeom prst="rect">
@@ -26528,20 +26573,20 @@
                 <a:ea typeface="맑은 고딕"/>
                 <a:cs typeface="맑은 고딕"/>
               </a:rPr>
-              <a:t>기간 작업 1:1 페어 3건 + 마일스톤 단독 2건</a:t>
-            </a:r>
-          </a:p>
-        </p:txBody>
-      </p:sp>
-      <p:sp>
-        <p:nvSpPr>
-          <p:cNvPr id="28" name="body:L1:t"/>
-          <p:cNvSpPr txBox="1"/>
-          <p:nvPr/>
-        </p:nvSpPr>
-        <p:spPr>
-          <a:xfrm>
-            <a:off x="7607006" y="3085592"/>
+              <a:t>기간 작업 1:1 페어 3행 + 마일스톤 단독 2행</a:t>
+            </a:r>
+          </a:p>
+        </p:txBody>
+      </p:sp>
+      <p:sp>
+        <p:nvSpPr>
+          <p:cNvPr id="29" name="body:L1:t"/>
+          <p:cNvSpPr txBox="1"/>
+          <p:nvPr/>
+        </p:nvSpPr>
+        <p:spPr>
+          <a:xfrm>
+            <a:off x="7607006" y="3231896"/>
             <a:ext cx="3825737" cy="204470"/>
           </a:xfrm>
           <a:prstGeom prst="rect">
@@ -26573,20 +26618,20 @@
                 <a:ea typeface="맑은 고딕"/>
                 <a:cs typeface="맑은 고딕"/>
               </a:rPr>
-              <a:t>→ 짝 추적으로 5건 전수 복원</a:t>
+              <a:t>→ 짝 추적으로 5행 전수 복원</a:t>
             </a:r>
           </a:p>
         </p:txBody>
       </p:sp>
       <p:cxnSp>
         <p:nvCxnSpPr>
-          <p:cNvPr id="29" name="rule"/>
+          <p:cNvPr id="30" name="rule"/>
           <p:cNvCxnSpPr/>
           <p:nvPr/>
         </p:nvCxnSpPr>
         <p:spPr>
           <a:xfrm>
-            <a:off x="667512" y="3549396"/>
+            <a:off x="667512" y="3677412"/>
             <a:ext cx="10856671" cy="0"/>
           </a:xfrm>
           <a:prstGeom prst="line">
@@ -26601,13 +26646,13 @@
       </p:cxnSp>
       <p:sp>
         <p:nvSpPr>
-          <p:cNvPr id="30" name="label:L1:t"/>
-          <p:cNvSpPr txBox="1"/>
-          <p:nvPr/>
-        </p:nvSpPr>
-        <p:spPr>
-          <a:xfrm>
-            <a:off x="758952" y="3604260"/>
+          <p:cNvPr id="31" name="label:L1:t"/>
+          <p:cNvSpPr txBox="1"/>
+          <p:nvPr/>
+        </p:nvSpPr>
+        <p:spPr>
+          <a:xfrm>
+            <a:off x="758952" y="3713988"/>
             <a:ext cx="568735" cy="167640"/>
           </a:xfrm>
           <a:prstGeom prst="rect">
@@ -26646,13 +26691,13 @@
       </p:sp>
       <p:sp>
         <p:nvSpPr>
-          <p:cNvPr id="31" name="body:L2:t"/>
-          <p:cNvSpPr txBox="1"/>
-          <p:nvPr/>
-        </p:nvSpPr>
-        <p:spPr>
-          <a:xfrm>
-            <a:off x="1510567" y="3604260"/>
+          <p:cNvPr id="32" name="body:L2:t"/>
+          <p:cNvSpPr txBox="1"/>
+          <p:nvPr/>
+        </p:nvSpPr>
+        <p:spPr>
+          <a:xfrm>
+            <a:off x="1510567" y="3713988"/>
             <a:ext cx="2322505" cy="408940"/>
           </a:xfrm>
           <a:prstGeom prst="rect">
@@ -26706,20 +26751,20 @@
                 <a:ea typeface="맑은 고딕"/>
                 <a:cs typeface="맑은 고딕"/>
               </a:rPr>
-              <a:t>879건 (결측 13 + 오기입 866)</a:t>
-            </a:r>
-          </a:p>
-        </p:txBody>
-      </p:sp>
-      <p:sp>
-        <p:nvSpPr>
-          <p:cNvPr id="32" name="body:L2:t"/>
-          <p:cNvSpPr txBox="1"/>
-          <p:nvPr/>
-        </p:nvSpPr>
-        <p:spPr>
-          <a:xfrm>
-            <a:off x="4015953" y="3604260"/>
+              <a:t>879행 (결측 13 + 오기입 866)</a:t>
+            </a:r>
+          </a:p>
+        </p:txBody>
+      </p:sp>
+      <p:sp>
+        <p:nvSpPr>
+          <p:cNvPr id="33" name="body:L2:t"/>
+          <p:cNvSpPr txBox="1"/>
+          <p:nvPr/>
+        </p:nvSpPr>
+        <p:spPr>
+          <a:xfrm>
+            <a:off x="4015953" y="3713988"/>
             <a:ext cx="3408172" cy="408940"/>
           </a:xfrm>
           <a:prstGeom prst="rect">
@@ -26779,14 +26824,14 @@
       </p:sp>
       <p:sp>
         <p:nvSpPr>
-          <p:cNvPr id="33" name="body:L1:t"/>
-          <p:cNvSpPr txBox="1"/>
-          <p:nvPr/>
-        </p:nvSpPr>
-        <p:spPr>
-          <a:xfrm>
-            <a:off x="7607006" y="3604260"/>
-            <a:ext cx="3825737" cy="204470"/>
+          <p:cNvPr id="34" name="body:L2:t"/>
+          <p:cNvSpPr txBox="1"/>
+          <p:nvPr/>
+        </p:nvSpPr>
+        <p:spPr>
+          <a:xfrm>
+            <a:off x="7607006" y="3713988"/>
+            <a:ext cx="3825737" cy="408940"/>
           </a:xfrm>
           <a:prstGeom prst="rect">
             <a:avLst/>
@@ -26817,20 +26862,41 @@
                 <a:ea typeface="맑은 고딕"/>
                 <a:cs typeface="맑은 고딕"/>
               </a:rPr>
-              <a:t>→ 단일 후보 640 + 앵커 최근접 219 (1970년 통일)</a:t>
+              <a:t>→ 단일 후보 640행 + 앵커 최근접</a:t>
+            </a:r>
+            <a:br>
+              <a:rPr lang="ko-KR" sz="1150" b="1" dirty="0">
+                <a:solidFill>
+                  <a:srgbClr val="059669"/>
+                </a:solidFill>
+                <a:latin typeface="맑은 고딕"/>
+                <a:ea typeface="맑은 고딕"/>
+                <a:cs typeface="맑은 고딕"/>
+              </a:rPr>
+            </a:br>
+            <a:r>
+              <a:rPr lang="ko-KR" sz="1150" b="1" dirty="0">
+                <a:solidFill>
+                  <a:srgbClr val="059669"/>
+                </a:solidFill>
+                <a:latin typeface="맑은 고딕"/>
+                <a:ea typeface="맑은 고딕"/>
+                <a:cs typeface="맑은 고딕"/>
+              </a:rPr>
+              <a:t>219행 (1970년 통일)</a:t>
             </a:r>
           </a:p>
         </p:txBody>
       </p:sp>
       <p:cxnSp>
         <p:nvCxnSpPr>
-          <p:cNvPr id="34" name="rule"/>
+          <p:cNvPr id="35" name="rule"/>
           <p:cNvCxnSpPr/>
           <p:nvPr/>
         </p:nvCxnSpPr>
         <p:spPr>
           <a:xfrm>
-            <a:off x="667512" y="4068064"/>
+            <a:off x="667512" y="4159503"/>
             <a:ext cx="10856671" cy="0"/>
           </a:xfrm>
           <a:prstGeom prst="line">
@@ -26845,13 +26911,13 @@
       </p:cxnSp>
       <p:sp>
         <p:nvSpPr>
-          <p:cNvPr id="35" name="label:L1:t"/>
-          <p:cNvSpPr txBox="1"/>
-          <p:nvPr/>
-        </p:nvSpPr>
-        <p:spPr>
-          <a:xfrm>
-            <a:off x="758952" y="4122927"/>
+          <p:cNvPr id="36" name="label:L1:t"/>
+          <p:cNvSpPr txBox="1"/>
+          <p:nvPr/>
+        </p:nvSpPr>
+        <p:spPr>
+          <a:xfrm>
+            <a:off x="758952" y="4196080"/>
             <a:ext cx="568735" cy="167640"/>
           </a:xfrm>
           <a:prstGeom prst="rect">
@@ -26890,13 +26956,13 @@
       </p:sp>
       <p:sp>
         <p:nvSpPr>
-          <p:cNvPr id="36" name="body:L2:t"/>
-          <p:cNvSpPr txBox="1"/>
-          <p:nvPr/>
-        </p:nvSpPr>
-        <p:spPr>
-          <a:xfrm>
-            <a:off x="1510567" y="4122927"/>
+          <p:cNvPr id="37" name="body:L2:t"/>
+          <p:cNvSpPr txBox="1"/>
+          <p:nvPr/>
+        </p:nvSpPr>
+        <p:spPr>
+          <a:xfrm>
+            <a:off x="1510567" y="4196080"/>
             <a:ext cx="2322505" cy="408940"/>
           </a:xfrm>
           <a:prstGeom prst="rect">
@@ -26950,20 +27016,20 @@
                 <a:ea typeface="맑은 고딕"/>
                 <a:cs typeface="맑은 고딕"/>
               </a:rPr>
-              <a:t>28건 (결측 13 + 더미 15)</a:t>
-            </a:r>
-          </a:p>
-        </p:txBody>
-      </p:sp>
-      <p:sp>
-        <p:nvSpPr>
-          <p:cNvPr id="37" name="body:L2:t"/>
-          <p:cNvSpPr txBox="1"/>
-          <p:nvPr/>
-        </p:nvSpPr>
-        <p:spPr>
-          <a:xfrm>
-            <a:off x="4015953" y="4122927"/>
+              <a:t>28행 (결측 13 + 더미 15)</a:t>
+            </a:r>
+          </a:p>
+        </p:txBody>
+      </p:sp>
+      <p:sp>
+        <p:nvSpPr>
+          <p:cNvPr id="38" name="body:L2:t"/>
+          <p:cNvSpPr txBox="1"/>
+          <p:nvPr/>
+        </p:nvSpPr>
+        <p:spPr>
+          <a:xfrm>
+            <a:off x="4015953" y="4196080"/>
             <a:ext cx="3408172" cy="408940"/>
           </a:xfrm>
           <a:prstGeom prst="rect">
@@ -26995,7 +27061,7 @@
                 <a:ea typeface="맑은 고딕"/>
                 <a:cs typeface="맑은 고딕"/>
               </a:rPr>
-              <a:t>정상 접수 표본 754건의 중앙값</a:t>
+              <a:t>정상 접수 표본 754케이스의 중앙값</a:t>
             </a:r>
             <a:br>
               <a:rPr lang="ko-KR" sz="1150" b="0" dirty="0">
@@ -27023,13 +27089,13 @@
       </p:sp>
       <p:sp>
         <p:nvSpPr>
-          <p:cNvPr id="38" name="body:L1:t"/>
-          <p:cNvSpPr txBox="1"/>
-          <p:nvPr/>
-        </p:nvSpPr>
-        <p:spPr>
-          <a:xfrm>
-            <a:off x="7607006" y="4122927"/>
+          <p:cNvPr id="39" name="body:L1:t"/>
+          <p:cNvSpPr txBox="1"/>
+          <p:nvPr/>
+        </p:nvSpPr>
+        <p:spPr>
+          <a:xfrm>
+            <a:off x="7607006" y="4196080"/>
             <a:ext cx="3825737" cy="204470"/>
           </a:xfrm>
           <a:prstGeom prst="rect">
@@ -27061,20 +27127,20 @@
                 <a:ea typeface="맑은 고딕"/>
                 <a:cs typeface="맑은 고딕"/>
               </a:rPr>
-              <a:t>→ 정상 자정 7건 보존 + 역산 추정 21건</a:t>
-            </a:r>
-          </a:p>
-        </p:txBody>
-      </p:sp>
-      <p:sp>
-        <p:nvSpPr>
-          <p:cNvPr id="39" name="bd1"/>
+              <a:t>→ 정상 자정 7행 보존 + 역산 추정 21행</a:t>
+            </a:r>
+          </a:p>
+        </p:txBody>
+      </p:sp>
+      <p:sp>
+        <p:nvSpPr>
+          <p:cNvPr id="40" name="bd1"/>
           <p:cNvSpPr/>
           <p:nvPr/>
         </p:nvSpPr>
         <p:spPr>
           <a:xfrm>
-            <a:off x="502920" y="4915916"/>
+            <a:off x="502920" y="4943348"/>
             <a:ext cx="3606698" cy="1341627"/>
           </a:xfrm>
           <a:prstGeom prst="rect">
@@ -27114,13 +27180,13 @@
       </p:sp>
       <p:sp>
         <p:nvSpPr>
-          <p:cNvPr id="40" name="label:L1:t"/>
-          <p:cNvSpPr txBox="1"/>
-          <p:nvPr/>
-        </p:nvSpPr>
-        <p:spPr>
-          <a:xfrm>
-            <a:off x="685800" y="5098796"/>
+          <p:cNvPr id="41" name="label:L1:t"/>
+          <p:cNvSpPr txBox="1"/>
+          <p:nvPr/>
+        </p:nvSpPr>
+        <p:spPr>
+          <a:xfrm>
+            <a:off x="685800" y="5126228"/>
             <a:ext cx="3240938" cy="158750"/>
           </a:xfrm>
           <a:prstGeom prst="rect">
@@ -27159,13 +27225,13 @@
       </p:sp>
       <p:sp>
         <p:nvSpPr>
-          <p:cNvPr id="41" name="body:L1:b1"/>
-          <p:cNvSpPr txBox="1"/>
-          <p:nvPr/>
-        </p:nvSpPr>
-        <p:spPr>
-          <a:xfrm>
-            <a:off x="685800" y="5312410"/>
+          <p:cNvPr id="42" name="body:L1:b1"/>
+          <p:cNvSpPr txBox="1"/>
+          <p:nvPr/>
+        </p:nvSpPr>
+        <p:spPr>
+          <a:xfrm>
+            <a:off x="685800" y="5339842"/>
             <a:ext cx="3240938" cy="511810"/>
           </a:xfrm>
           <a:prstGeom prst="rect">
@@ -27215,13 +27281,13 @@
       </p:sp>
       <p:sp>
         <p:nvSpPr>
-          <p:cNvPr id="42" name="body:L1:t"/>
-          <p:cNvSpPr txBox="1"/>
-          <p:nvPr/>
-        </p:nvSpPr>
-        <p:spPr>
-          <a:xfrm>
-            <a:off x="685800" y="5879084"/>
+          <p:cNvPr id="43" name="body:L1:t"/>
+          <p:cNvSpPr txBox="1"/>
+          <p:nvPr/>
+        </p:nvSpPr>
+        <p:spPr>
+          <a:xfrm>
+            <a:off x="685800" y="5906516"/>
             <a:ext cx="3240938" cy="195580"/>
           </a:xfrm>
           <a:prstGeom prst="rect">
@@ -27260,13 +27326,13 @@
       </p:sp>
       <p:sp>
         <p:nvSpPr>
-          <p:cNvPr id="43" name="bd2"/>
+          <p:cNvPr id="44" name="bd2"/>
           <p:cNvSpPr/>
           <p:nvPr/>
         </p:nvSpPr>
         <p:spPr>
           <a:xfrm>
-            <a:off x="4292498" y="4915916"/>
+            <a:off x="4292498" y="4943348"/>
             <a:ext cx="3606698" cy="1341627"/>
           </a:xfrm>
           <a:prstGeom prst="rect">
@@ -27306,13 +27372,13 @@
       </p:sp>
       <p:sp>
         <p:nvSpPr>
-          <p:cNvPr id="44" name="label:L1:t"/>
-          <p:cNvSpPr txBox="1"/>
-          <p:nvPr/>
-        </p:nvSpPr>
-        <p:spPr>
-          <a:xfrm>
-            <a:off x="4475378" y="5098796"/>
+          <p:cNvPr id="45" name="label:L1:t"/>
+          <p:cNvSpPr txBox="1"/>
+          <p:nvPr/>
+        </p:nvSpPr>
+        <p:spPr>
+          <a:xfrm>
+            <a:off x="4475378" y="5126228"/>
             <a:ext cx="3240938" cy="158750"/>
           </a:xfrm>
           <a:prstGeom prst="rect">
@@ -27351,13 +27417,13 @@
       </p:sp>
       <p:sp>
         <p:nvSpPr>
-          <p:cNvPr id="45" name="body:L1:b2"/>
-          <p:cNvSpPr txBox="1"/>
-          <p:nvPr/>
-        </p:nvSpPr>
-        <p:spPr>
-          <a:xfrm>
-            <a:off x="4475378" y="5312410"/>
+          <p:cNvPr id="46" name="body:L1:b2"/>
+          <p:cNvSpPr txBox="1"/>
+          <p:nvPr/>
+        </p:nvSpPr>
+        <p:spPr>
+          <a:xfrm>
+            <a:off x="4475378" y="5339842"/>
             <a:ext cx="3240938" cy="511810"/>
           </a:xfrm>
           <a:prstGeom prst="rect">
@@ -27407,13 +27473,13 @@
       </p:sp>
       <p:sp>
         <p:nvSpPr>
-          <p:cNvPr id="46" name="body:L1:t"/>
-          <p:cNvSpPr txBox="1"/>
-          <p:nvPr/>
-        </p:nvSpPr>
-        <p:spPr>
-          <a:xfrm>
-            <a:off x="4475378" y="5879084"/>
+          <p:cNvPr id="47" name="body:L1:t"/>
+          <p:cNvSpPr txBox="1"/>
+          <p:nvPr/>
+        </p:nvSpPr>
+        <p:spPr>
+          <a:xfrm>
+            <a:off x="4475378" y="5906516"/>
             <a:ext cx="3240938" cy="195580"/>
           </a:xfrm>
           <a:prstGeom prst="rect">
@@ -27452,13 +27518,13 @@
       </p:sp>
       <p:sp>
         <p:nvSpPr>
-          <p:cNvPr id="47" name="bd3"/>
+          <p:cNvPr id="48" name="bd3"/>
           <p:cNvSpPr/>
           <p:nvPr/>
         </p:nvSpPr>
         <p:spPr>
           <a:xfrm>
-            <a:off x="8082076" y="4915916"/>
+            <a:off x="8082076" y="4943348"/>
             <a:ext cx="3606698" cy="1341627"/>
           </a:xfrm>
           <a:prstGeom prst="rect">
@@ -27498,13 +27564,13 @@
       </p:sp>
       <p:sp>
         <p:nvSpPr>
-          <p:cNvPr id="48" name="label:L1:t"/>
-          <p:cNvSpPr txBox="1"/>
-          <p:nvPr/>
-        </p:nvSpPr>
-        <p:spPr>
-          <a:xfrm>
-            <a:off x="8264956" y="5098796"/>
+          <p:cNvPr id="49" name="label:L1:t"/>
+          <p:cNvSpPr txBox="1"/>
+          <p:nvPr/>
+        </p:nvSpPr>
+        <p:spPr>
+          <a:xfrm>
+            <a:off x="8264956" y="5126228"/>
             <a:ext cx="3240938" cy="158750"/>
           </a:xfrm>
           <a:prstGeom prst="rect">
@@ -27543,13 +27609,13 @@
       </p:sp>
       <p:sp>
         <p:nvSpPr>
-          <p:cNvPr id="49" name="body:L1:b3"/>
-          <p:cNvSpPr txBox="1"/>
-          <p:nvPr/>
-        </p:nvSpPr>
-        <p:spPr>
-          <a:xfrm>
-            <a:off x="8264956" y="5312410"/>
+          <p:cNvPr id="50" name="body:L1:b3"/>
+          <p:cNvSpPr txBox="1"/>
+          <p:nvPr/>
+        </p:nvSpPr>
+        <p:spPr>
+          <a:xfrm>
+            <a:off x="8264956" y="5339842"/>
             <a:ext cx="3240938" cy="511810"/>
           </a:xfrm>
           <a:prstGeom prst="rect">
@@ -27592,20 +27658,20 @@
                 <a:ea typeface="맑은 고딕"/>
                 <a:cs typeface="맑은 고딕"/>
               </a:rPr>
-              <a:t>건</a:t>
-            </a:r>
-          </a:p>
-        </p:txBody>
-      </p:sp>
-      <p:sp>
-        <p:nvSpPr>
-          <p:cNvPr id="50" name="body:L1:t"/>
-          <p:cNvSpPr txBox="1"/>
-          <p:nvPr/>
-        </p:nvSpPr>
-        <p:spPr>
-          <a:xfrm>
-            <a:off x="8264956" y="5879084"/>
+              <a:t>케이스</a:t>
+            </a:r>
+          </a:p>
+        </p:txBody>
+      </p:sp>
+      <p:sp>
+        <p:nvSpPr>
+          <p:cNvPr id="51" name="body:L1:t"/>
+          <p:cNvSpPr txBox="1"/>
+          <p:nvPr/>
+        </p:nvSpPr>
+        <p:spPr>
+          <a:xfrm>
+            <a:off x="8264956" y="5906516"/>
             <a:ext cx="3240938" cy="195580"/>
           </a:xfrm>
           <a:prstGeom prst="rect">
@@ -28558,7 +28624,7 @@
                 <a:ea typeface="맑은 고딕"/>
                 <a:cs typeface="맑은 고딕"/>
               </a:rPr>
-              <a:t>866건</a:t>
+              <a:t>866행</a:t>
             </a:r>
           </a:p>
         </p:txBody>

</xml_diff>

<commit_message>
feat(deck): slide 5 title in noun-ending style
Co-Authored-By: Claude Sonnet 5.5 <noreply@anthropic.com>
</commit_message>
<xml_diff>
--- a/outputs/pptx/puzzledata_repair_report.pptx
+++ b/outputs/pptx/puzzledata_repair_report.pptx
@@ -125,21 +125,21 @@
   <p:extLst>
     <p:ext uri="{521415D9-36F7-43E2-AB2F-B90AF26B5E84}">
       <p14:sectionLst xmlns:p14="http://schemas.microsoft.com/office/powerpoint/2010/main">
-        <p14:section name="Part 00 · 인트로" id="{264FE79F-2246-48D8-85F2-42A8C3BC2AEA}">
+        <p14:section name="Part 00 · 인트로" id="{8ACF2DC8-38F7-4633-89C9-219D6B05644A}">
           <p14:sldIdLst>
             <p14:sldId id="256"/>
             <p14:sldId id="257"/>
             <p14:sldId id="258"/>
           </p14:sldIdLst>
         </p14:section>
-        <p14:section name="Part 01 · 데이터 진단" id="{DAE6320F-83F3-4285-8E63-ED0FC2257F34}">
+        <p14:section name="Part 01 · 데이터 진단" id="{66AE3A47-7690-4226-9480-FDE4D1FE5C3C}">
           <p14:sldIdLst>
             <p14:sldId id="259"/>
             <p14:sldId id="260"/>
             <p14:sldId id="261"/>
           </p14:sldIdLst>
         </p14:section>
-        <p14:section name="Part 02 · 병목 규명" id="{3E8ACA7F-D85F-410A-BB03-6313DE506532}">
+        <p14:section name="Part 02 · 병목 규명" id="{11087C9C-553D-449E-916D-CE85CA1AC492}">
           <p14:sldIdLst>
             <p14:sldId id="262"/>
             <p14:sldId id="263"/>
@@ -152,14 +152,14 @@
             <p14:sldId id="270"/>
           </p14:sldIdLst>
         </p14:section>
-        <p14:section name="Part 03 · 개선 전략" id="{32929D4B-6F64-48E0-B4D1-F8CA37658EE0}">
+        <p14:section name="Part 03 · 개선 전략" id="{9B8CBE4D-30CD-427A-A91C-DD15175DD41D}">
           <p14:sldIdLst>
             <p14:sldId id="271"/>
             <p14:sldId id="272"/>
             <p14:sldId id="273"/>
           </p14:sldIdLst>
         </p14:section>
-        <p14:section name="Part 04 · Q&amp;A" id="{542A7148-5041-4CB3-873E-517D2BB80ACD}">
+        <p14:section name="Part 04 · Q&amp;A" id="{9B9B5EBD-DED8-47C6-8329-FB2558C679E9}">
           <p14:sldIdLst>
             <p14:sldId id="274"/>
           </p14:sldIdLst>
@@ -25501,7 +25501,7 @@
                 <a:ea typeface="맑은 고딕"/>
                 <a:cs typeface="맑은 고딕"/>
               </a:rPr>
-              <a:t>삭제 없이, 업무 순서로 결측과 오기입을 교정 복원했다</a:t>
+              <a:t>삭제 없이, 업무 순서로 결측과 오기입 교정 복원</a:t>
             </a:r>
           </a:p>
         </p:txBody>

</xml_diff>

<commit_message>
feat(deck): slide 6 title wording
</commit_message>
<xml_diff>
--- a/outputs/pptx/puzzledata_repair_report.pptx
+++ b/outputs/pptx/puzzledata_repair_report.pptx
@@ -125,21 +125,21 @@
   <p:extLst>
     <p:ext uri="{521415D9-36F7-43E2-AB2F-B90AF26B5E84}">
       <p14:sectionLst xmlns:p14="http://schemas.microsoft.com/office/powerpoint/2010/main">
-        <p14:section name="Part 00 · 인트로" id="{8ACF2DC8-38F7-4633-89C9-219D6B05644A}">
+        <p14:section name="Part 00 · 인트로" id="{D1F1DE40-5DD7-459F-BD6C-7E747742319D}">
           <p14:sldIdLst>
             <p14:sldId id="256"/>
             <p14:sldId id="257"/>
             <p14:sldId id="258"/>
           </p14:sldIdLst>
         </p14:section>
-        <p14:section name="Part 01 · 데이터 진단" id="{66AE3A47-7690-4226-9480-FDE4D1FE5C3C}">
+        <p14:section name="Part 01 · 데이터 진단" id="{829CCD4A-FC9A-4EEC-94A3-52616E1E27A4}">
           <p14:sldIdLst>
             <p14:sldId id="259"/>
             <p14:sldId id="260"/>
             <p14:sldId id="261"/>
           </p14:sldIdLst>
         </p14:section>
-        <p14:section name="Part 02 · 병목 규명" id="{11087C9C-553D-449E-916D-CE85CA1AC492}">
+        <p14:section name="Part 02 · 병목 규명" id="{228C9861-99EB-4225-9CEB-FE71EF45BF2C}">
           <p14:sldIdLst>
             <p14:sldId id="262"/>
             <p14:sldId id="263"/>
@@ -152,14 +152,14 @@
             <p14:sldId id="270"/>
           </p14:sldIdLst>
         </p14:section>
-        <p14:section name="Part 03 · 개선 전략" id="{9B8CBE4D-30CD-427A-A91C-DD15175DD41D}">
+        <p14:section name="Part 03 · 개선 전략" id="{37E6017B-C0B1-4275-810C-24291889EAFE}">
           <p14:sldIdLst>
             <p14:sldId id="271"/>
             <p14:sldId id="272"/>
             <p14:sldId id="273"/>
           </p14:sldIdLst>
         </p14:section>
-        <p14:section name="Part 04 · Q&amp;A" id="{9B9B5EBD-DED8-47C6-8329-FB2558C679E9}">
+        <p14:section name="Part 04 · Q&amp;A" id="{EEDC6EF8-7B49-4C50-A7D9-45DAC1023068}">
           <p14:sldIdLst>
             <p14:sldId id="274"/>
           </p14:sldIdLst>
@@ -27864,7 +27864,7 @@
                 <a:ea typeface="맑은 고딕"/>
                 <a:cs typeface="맑은 고딕"/>
               </a:rPr>
-              <a:t>역전 0건 입증, 접수·현장 모두 단일 풀</a:t>
+              <a:t>시간 역전 0건, 접수·현장 모두 단일 풀</a:t>
             </a:r>
           </a:p>
         </p:txBody>

</xml_diff>

<commit_message>
feat(deck): slide 6 right cards wording and 46.9:53.1 definition
Co-Authored-By: Claude Sonnet 5.5 <noreply@anthropic.com>
</commit_message>
<xml_diff>
--- a/outputs/pptx/puzzledata_repair_report.pptx
+++ b/outputs/pptx/puzzledata_repair_report.pptx
@@ -125,21 +125,21 @@
   <p:extLst>
     <p:ext uri="{521415D9-36F7-43E2-AB2F-B90AF26B5E84}">
       <p14:sectionLst xmlns:p14="http://schemas.microsoft.com/office/powerpoint/2010/main">
-        <p14:section name="Part 00 · 인트로" id="{D1F1DE40-5DD7-459F-BD6C-7E747742319D}">
+        <p14:section name="Part 00 · 인트로" id="{77057D34-F8ED-40D9-9F31-77DAC404D753}">
           <p14:sldIdLst>
             <p14:sldId id="256"/>
             <p14:sldId id="257"/>
             <p14:sldId id="258"/>
           </p14:sldIdLst>
         </p14:section>
-        <p14:section name="Part 01 · 데이터 진단" id="{829CCD4A-FC9A-4EEC-94A3-52616E1E27A4}">
+        <p14:section name="Part 01 · 데이터 진단" id="{31AF45C2-1490-4738-BC3D-DA760216A75E}">
           <p14:sldIdLst>
             <p14:sldId id="259"/>
             <p14:sldId id="260"/>
             <p14:sldId id="261"/>
           </p14:sldIdLst>
         </p14:section>
-        <p14:section name="Part 02 · 병목 규명" id="{228C9861-99EB-4225-9CEB-FE71EF45BF2C}">
+        <p14:section name="Part 02 · 병목 규명" id="{DD7629BD-54C9-4935-ABF2-28806F1CDE4A}">
           <p14:sldIdLst>
             <p14:sldId id="262"/>
             <p14:sldId id="263"/>
@@ -152,14 +152,14 @@
             <p14:sldId id="270"/>
           </p14:sldIdLst>
         </p14:section>
-        <p14:section name="Part 03 · 개선 전략" id="{37E6017B-C0B1-4275-810C-24291889EAFE}">
+        <p14:section name="Part 03 · 개선 전략" id="{BE31F955-517E-450C-B51C-2C75DA81BFFD}">
           <p14:sldIdLst>
             <p14:sldId id="271"/>
             <p14:sldId id="272"/>
             <p14:sldId id="273"/>
           </p14:sldIdLst>
         </p14:section>
-        <p14:section name="Part 04 · Q&amp;A" id="{EEDC6EF8-7B49-4C50-A7D9-45DAC1023068}">
+        <p14:section name="Part 04 · Q&amp;A" id="{636ED417-3408-4485-B888-2E083E2EB144}">
           <p14:sldIdLst>
             <p14:sldId id="274"/>
           </p14:sldIdLst>
@@ -1621,7 +1621,7 @@
           <a:lstStyle/>
           <a:p>
             <a:r>
-              <a:t>전처리를 마친 결과, 행 손실 없이 시간 역전 0건인 13,262행 데이터셋을 확보했습니다. 이 과정에서 수리회사의 운영 특성 두 가지가 드러났습니다. 첫째, 접수 이벤트가 24개 시간대 모두에서 발생해 야간 방치 가설은 기각됩니다. 둘째, 1회 접수 주택이 96.1%라 지역 분담처럼 보이지만 재접수 35채 중 22채는 다른 상담원이 받았고, 현장 출동 비중도 46.9:53.1로 수렴해 접수와 현장 모두 구역 제한 없는 단일 풀입니다. 이 환경을 바탕으로 질문 2의 기준 프로세스 모델로 넘어가겠습니다.</a:t>
+              <a:t>전처리를 마친 결과, 행 손실 없이 시간 역전 0건인 13,262행 데이터셋을 확보했습니다. 이 과정에서 수리회사의 운영 특성 두 가지가 드러났습니다. 첫째, 접수 이벤트가 24개 시간대 모두에서 발생해 야간 방치 가설은 기각됩니다. 둘째, 1회 접수 주택이 96.1%라 지역 분담처럼 보이지만 재접수 35채 중 22채는 다른 상담원이 받았고, 현장 출동 케이스의 접수 담당 비중(Dian:Monica)도 46.9:53.1로 고르게 분산돼 접수와 현장 모두 구역 제한 없는 단일 풀입니다. 이 환경을 바탕으로 질문 2의 기준 프로세스 모델로 넘어가겠습니다.</a:t>
             </a:r>
           </a:p>
         </p:txBody>
@@ -29261,7 +29261,7 @@
         <p:spPr>
           <a:xfrm>
             <a:off x="6629400" y="1554480"/>
-            <a:ext cx="5059375" cy="2062226"/>
+            <a:ext cx="5059375" cy="2089658"/>
           </a:xfrm>
           <a:prstGeom prst="rect">
             <a:avLst/>
@@ -29446,14 +29446,14 @@
       </p:sp>
       <p:sp>
         <p:nvSpPr>
-          <p:cNvPr id="41" name="body:L2:t"/>
+          <p:cNvPr id="41" name="body:L1:t"/>
           <p:cNvSpPr txBox="1"/>
           <p:nvPr/>
         </p:nvSpPr>
         <p:spPr>
           <a:xfrm>
             <a:off x="6812280" y="2821432"/>
-            <a:ext cx="4693615" cy="408940"/>
+            <a:ext cx="4693615" cy="204470"/>
           </a:xfrm>
           <a:prstGeom prst="rect">
             <a:avLst/>
@@ -29484,9 +29484,43 @@
                 <a:ea typeface="맑은 고딕"/>
                 <a:cs typeface="맑은 고딕"/>
               </a:rPr>
-              <a:t>접수 이벤트가 0~23시 전 시간대에서 발생 — 지연 원인은</a:t>
-            </a:r>
-            <a:br>
+              <a:t>접수 이벤트 0~23시 전 시간대에서 발생</a:t>
+            </a:r>
+          </a:p>
+        </p:txBody>
+      </p:sp>
+      <p:sp>
+        <p:nvSpPr>
+          <p:cNvPr id="42" name="body:L1:t"/>
+          <p:cNvSpPr txBox="1"/>
+          <p:nvPr/>
+        </p:nvSpPr>
+        <p:spPr>
+          <a:xfrm>
+            <a:off x="6812280" y="3080766"/>
+            <a:ext cx="4693615" cy="204470"/>
+          </a:xfrm>
+          <a:prstGeom prst="rect">
+            <a:avLst/>
+          </a:prstGeom>
+          <a:noFill/>
+        </p:spPr>
+        <p:txBody>
+          <a:bodyPr wrap="square" lIns="0" tIns="0" rIns="0" bIns="0" anchor="t">
+            <a:noAutofit/>
+          </a:bodyPr>
+          <a:lstStyle/>
+          <a:p>
+            <a:pPr algn="l">
+              <a:lnSpc>
+                <a:spcPts val="1610"/>
+              </a:lnSpc>
+              <a:spcBef>
+                <a:spcPts val="0"/>
+              </a:spcBef>
+              <a:buNone/>
+            </a:pPr>
+            <a:r>
               <a:rPr lang="ko-KR" sz="1150" b="0" dirty="0">
                 <a:solidFill>
                   <a:srgbClr val="334155"/>
@@ -29495,31 +29529,21 @@
                 <a:ea typeface="맑은 고딕"/>
                 <a:cs typeface="맑은 고딕"/>
               </a:rPr>
-            </a:br>
-            <a:r>
-              <a:rPr lang="ko-KR" sz="1150" b="0" dirty="0">
-                <a:solidFill>
-                  <a:srgbClr val="334155"/>
-                </a:solidFill>
-                <a:latin typeface="맑은 고딕"/>
-                <a:ea typeface="맑은 고딕"/>
-                <a:cs typeface="맑은 고딕"/>
-              </a:rPr>
-              <a:t>영업 외 방치가 아니라 일정 조율 마찰</a:t>
-            </a:r>
-          </a:p>
-        </p:txBody>
-      </p:sp>
-      <p:sp>
-        <p:nvSpPr>
-          <p:cNvPr id="42" name="op2"/>
+              <a:t>지연 원인은 영업 외 방치가 아닌 일정 조율 마찰</a:t>
+            </a:r>
+          </a:p>
+        </p:txBody>
+      </p:sp>
+      <p:sp>
+        <p:nvSpPr>
+          <p:cNvPr id="43" name="op2"/>
           <p:cNvSpPr/>
           <p:nvPr/>
         </p:nvSpPr>
         <p:spPr>
           <a:xfrm>
-            <a:off x="6629400" y="3744722"/>
-            <a:ext cx="5059375" cy="2546349"/>
+            <a:off x="6629400" y="3772154"/>
+            <a:ext cx="5059375" cy="2518918"/>
           </a:xfrm>
           <a:prstGeom prst="rect">
             <a:avLst/>
@@ -29558,13 +29582,13 @@
       </p:sp>
       <p:sp>
         <p:nvSpPr>
-          <p:cNvPr id="43" name="label:L1:t"/>
-          <p:cNvSpPr txBox="1"/>
-          <p:nvPr/>
-        </p:nvSpPr>
-        <p:spPr>
-          <a:xfrm>
-            <a:off x="6812280" y="3927602"/>
+          <p:cNvPr id="44" name="label:L1:t"/>
+          <p:cNvSpPr txBox="1"/>
+          <p:nvPr/>
+        </p:nvSpPr>
+        <p:spPr>
+          <a:xfrm>
+            <a:off x="6812280" y="3955034"/>
             <a:ext cx="4693615" cy="158750"/>
           </a:xfrm>
           <a:prstGeom prst="rect">
@@ -29603,13 +29627,13 @@
       </p:sp>
       <p:sp>
         <p:nvSpPr>
-          <p:cNvPr id="44" name="body:L1:h2"/>
-          <p:cNvSpPr txBox="1"/>
-          <p:nvPr/>
-        </p:nvSpPr>
-        <p:spPr>
-          <a:xfrm>
-            <a:off x="6812280" y="4141216"/>
+          <p:cNvPr id="45" name="body:L1:h2"/>
+          <p:cNvSpPr txBox="1"/>
+          <p:nvPr/>
+        </p:nvSpPr>
+        <p:spPr>
+          <a:xfrm>
+            <a:off x="6812280" y="4168648"/>
             <a:ext cx="4693615" cy="248920"/>
           </a:xfrm>
           <a:prstGeom prst="rect">
@@ -29641,20 +29665,20 @@
                 <a:ea typeface="맑은 고딕"/>
                 <a:cs typeface="맑은 고딕"/>
               </a:rPr>
-              <a:t>지역 전담제 착시, 실제로는 단일 공유 풀</a:t>
-            </a:r>
-          </a:p>
-        </p:txBody>
-      </p:sp>
-      <p:sp>
-        <p:nvSpPr>
-          <p:cNvPr id="45" name="body:L1:n2"/>
-          <p:cNvSpPr txBox="1"/>
-          <p:nvPr/>
-        </p:nvSpPr>
-        <p:spPr>
-          <a:xfrm>
-            <a:off x="6812280" y="4445000"/>
+              <a:t>지역 전담제 X, 단일 공유 풀</a:t>
+            </a:r>
+          </a:p>
+        </p:txBody>
+      </p:sp>
+      <p:sp>
+        <p:nvSpPr>
+          <p:cNvPr id="46" name="body:L1:n2"/>
+          <p:cNvSpPr txBox="1"/>
+          <p:nvPr/>
+        </p:nvSpPr>
+        <p:spPr>
+          <a:xfrm>
+            <a:off x="6812280" y="4472432"/>
             <a:ext cx="4693615" cy="511810"/>
           </a:xfrm>
           <a:prstGeom prst="rect">
@@ -29704,13 +29728,13 @@
       </p:sp>
       <p:sp>
         <p:nvSpPr>
-          <p:cNvPr id="46" name="body:L2:t"/>
-          <p:cNvSpPr txBox="1"/>
-          <p:nvPr/>
-        </p:nvSpPr>
-        <p:spPr>
-          <a:xfrm>
-            <a:off x="6812280" y="5011674"/>
+          <p:cNvPr id="47" name="body:L2:t"/>
+          <p:cNvSpPr txBox="1"/>
+          <p:nvPr/>
+        </p:nvSpPr>
+        <p:spPr>
+          <a:xfrm>
+            <a:off x="6812280" y="5039106"/>
             <a:ext cx="4693615" cy="408940"/>
           </a:xfrm>
           <a:prstGeom prst="rect">
@@ -29742,7 +29766,7 @@
                 <a:ea typeface="맑은 고딕"/>
                 <a:cs typeface="맑은 고딕"/>
               </a:rPr>
-              <a:t>접수 담당(Dian : Monica)별 현장 출동 비중 — 1회</a:t>
+              <a:t>현장 출동 케이스의 접수 담당 비중(Dian : Monica) —</a:t>
             </a:r>
             <a:br>
               <a:rPr lang="ko-KR" sz="1150" b="0" dirty="0">
@@ -29763,20 +29787,20 @@
                 <a:ea typeface="맑은 고딕"/>
                 <a:cs typeface="맑은 고딕"/>
               </a:rPr>
-              <a:t>접수 주택 기준 평균에 수렴</a:t>
-            </a:r>
-          </a:p>
-        </p:txBody>
-      </p:sp>
-      <p:sp>
-        <p:nvSpPr>
-          <p:cNvPr id="47" name="body:L2:t"/>
-          <p:cNvSpPr txBox="1"/>
-          <p:nvPr/>
-        </p:nvSpPr>
-        <p:spPr>
-          <a:xfrm>
-            <a:off x="6812280" y="5475478"/>
+              <a:t>기사별로도 고르게 분산</a:t>
+            </a:r>
+          </a:p>
+        </p:txBody>
+      </p:sp>
+      <p:sp>
+        <p:nvSpPr>
+          <p:cNvPr id="48" name="body:L2:t"/>
+          <p:cNvSpPr txBox="1"/>
+          <p:nvPr/>
+        </p:nvSpPr>
+        <p:spPr>
+          <a:xfrm>
+            <a:off x="6812280" y="5502910"/>
             <a:ext cx="4693615" cy="429259"/>
           </a:xfrm>
           <a:prstGeom prst="rect">

</xml_diff>

<commit_message>
feat(deck): slide 6 card 02 lists two evidence bullets for the single pool
Co-Authored-By: Claude Sonnet 5.5 <noreply@anthropic.com>
</commit_message>
<xml_diff>
--- a/outputs/pptx/puzzledata_repair_report.pptx
+++ b/outputs/pptx/puzzledata_repair_report.pptx
@@ -125,21 +125,21 @@
   <p:extLst>
     <p:ext uri="{521415D9-36F7-43E2-AB2F-B90AF26B5E84}">
       <p14:sectionLst xmlns:p14="http://schemas.microsoft.com/office/powerpoint/2010/main">
-        <p14:section name="Part 00 · 인트로" id="{77057D34-F8ED-40D9-9F31-77DAC404D753}">
+        <p14:section name="Part 00 · 인트로" id="{58B2360F-6F49-4D5A-B7BE-A11219E7E986}">
           <p14:sldIdLst>
             <p14:sldId id="256"/>
             <p14:sldId id="257"/>
             <p14:sldId id="258"/>
           </p14:sldIdLst>
         </p14:section>
-        <p14:section name="Part 01 · 데이터 진단" id="{31AF45C2-1490-4738-BC3D-DA760216A75E}">
+        <p14:section name="Part 01 · 데이터 진단" id="{95DE0FE0-BCC0-4C20-9408-3EC614770F02}">
           <p14:sldIdLst>
             <p14:sldId id="259"/>
             <p14:sldId id="260"/>
             <p14:sldId id="261"/>
           </p14:sldIdLst>
         </p14:section>
-        <p14:section name="Part 02 · 병목 규명" id="{DD7629BD-54C9-4935-ABF2-28806F1CDE4A}">
+        <p14:section name="Part 02 · 병목 규명" id="{10F79AAB-4503-4F2D-A29C-A4054A738580}">
           <p14:sldIdLst>
             <p14:sldId id="262"/>
             <p14:sldId id="263"/>
@@ -152,14 +152,14 @@
             <p14:sldId id="270"/>
           </p14:sldIdLst>
         </p14:section>
-        <p14:section name="Part 03 · 개선 전략" id="{BE31F955-517E-450C-B51C-2C75DA81BFFD}">
+        <p14:section name="Part 03 · 개선 전략" id="{71A7C336-D8B1-4226-8049-E4FE7FCA15EE}">
           <p14:sldIdLst>
             <p14:sldId id="271"/>
             <p14:sldId id="272"/>
             <p14:sldId id="273"/>
           </p14:sldIdLst>
         </p14:section>
-        <p14:section name="Part 04 · Q&amp;A" id="{636ED417-3408-4485-B888-2E083E2EB144}">
+        <p14:section name="Part 04 · Q&amp;A" id="{80B71877-82F0-4AE2-9FBB-9DBAA225D100}">
           <p14:sldIdLst>
             <p14:sldId id="274"/>
           </p14:sldIdLst>
@@ -29261,7 +29261,7 @@
         <p:spPr>
           <a:xfrm>
             <a:off x="6629400" y="1554480"/>
-            <a:ext cx="5059375" cy="2089658"/>
+            <a:ext cx="5059375" cy="2094103"/>
           </a:xfrm>
           <a:prstGeom prst="rect">
             <a:avLst/>
@@ -29542,8 +29542,8 @@
         </p:nvSpPr>
         <p:spPr>
           <a:xfrm>
-            <a:off x="6629400" y="3772154"/>
-            <a:ext cx="5059375" cy="2518918"/>
+            <a:off x="6629400" y="3776599"/>
+            <a:ext cx="5059375" cy="2514472"/>
           </a:xfrm>
           <a:prstGeom prst="rect">
             <a:avLst/>
@@ -29588,7 +29588,7 @@
         </p:nvSpPr>
         <p:spPr>
           <a:xfrm>
-            <a:off x="6812280" y="3955034"/>
+            <a:off x="6812280" y="3959479"/>
             <a:ext cx="4693615" cy="158750"/>
           </a:xfrm>
           <a:prstGeom prst="rect">
@@ -29633,7 +29633,7 @@
         </p:nvSpPr>
         <p:spPr>
           <a:xfrm>
-            <a:off x="6812280" y="4168648"/>
+            <a:off x="6812280" y="4173093"/>
             <a:ext cx="4693615" cy="248920"/>
           </a:xfrm>
           <a:prstGeom prst="rect">
@@ -29678,7 +29678,7 @@
         </p:nvSpPr>
         <p:spPr>
           <a:xfrm>
-            <a:off x="6812280" y="4472432"/>
+            <a:off x="6812280" y="4476877"/>
             <a:ext cx="4693615" cy="511810"/>
           </a:xfrm>
           <a:prstGeom prst="rect">
@@ -29728,14 +29728,14 @@
       </p:sp>
       <p:sp>
         <p:nvSpPr>
-          <p:cNvPr id="47" name="body:L2:t"/>
-          <p:cNvSpPr txBox="1"/>
-          <p:nvPr/>
-        </p:nvSpPr>
-        <p:spPr>
-          <a:xfrm>
-            <a:off x="6812280" y="5039106"/>
-            <a:ext cx="4693615" cy="408940"/>
+          <p:cNvPr id="47" name="body:L1:t"/>
+          <p:cNvSpPr txBox="1"/>
+          <p:nvPr/>
+        </p:nvSpPr>
+        <p:spPr>
+          <a:xfrm>
+            <a:off x="6812280" y="5043551"/>
+            <a:ext cx="4693615" cy="204470"/>
           </a:xfrm>
           <a:prstGeom prst="rect">
             <a:avLst/>
@@ -29766,42 +29766,21 @@
                 <a:ea typeface="맑은 고딕"/>
                 <a:cs typeface="맑은 고딕"/>
               </a:rPr>
-              <a:t>현장 출동 케이스의 접수 담당 비중(Dian : Monica) —</a:t>
-            </a:r>
-            <a:br>
-              <a:rPr lang="ko-KR" sz="1150" b="0" dirty="0">
-                <a:solidFill>
-                  <a:srgbClr val="334155"/>
-                </a:solidFill>
-                <a:latin typeface="맑은 고딕"/>
-                <a:ea typeface="맑은 고딕"/>
-                <a:cs typeface="맑은 고딕"/>
-              </a:rPr>
-            </a:br>
-            <a:r>
-              <a:rPr lang="ko-KR" sz="1150" b="0" dirty="0">
-                <a:solidFill>
-                  <a:srgbClr val="334155"/>
-                </a:solidFill>
-                <a:latin typeface="맑은 고딕"/>
-                <a:ea typeface="맑은 고딕"/>
-                <a:cs typeface="맑은 고딕"/>
-              </a:rPr>
-              <a:t>기사별로도 고르게 분산</a:t>
-            </a:r>
-          </a:p>
-        </p:txBody>
-      </p:sp>
-      <p:sp>
-        <p:nvSpPr>
-          <p:cNvPr id="48" name="body:L2:t"/>
-          <p:cNvSpPr txBox="1"/>
-          <p:nvPr/>
-        </p:nvSpPr>
-        <p:spPr>
-          <a:xfrm>
-            <a:off x="6812280" y="5502910"/>
-            <a:ext cx="4693615" cy="429259"/>
+              <a:t>정상 접수 케이스 접수 비중 (Dian : Monica)</a:t>
+            </a:r>
+          </a:p>
+        </p:txBody>
+      </p:sp>
+      <p:sp>
+        <p:nvSpPr>
+          <p:cNvPr id="48" name="body:L3:t"/>
+          <p:cNvSpPr txBox="1"/>
+          <p:nvPr/>
+        </p:nvSpPr>
+        <p:spPr>
+          <a:xfrm>
+            <a:off x="6812280" y="5302885"/>
+            <a:ext cx="4693615" cy="624839"/>
           </a:xfrm>
           <a:prstGeom prst="rect">
             <a:avLst/>
@@ -29836,7 +29815,7 @@
                 <a:ea typeface="맑은 고딕"/>
                 <a:cs typeface="맑은 고딕"/>
               </a:rPr>
-              <a:t>1회 접수 주택 96.1%(855/890채)라 지역 분담처럼 보임</a:t>
+              <a:t>배정 현장 기사 고르게 분산</a:t>
             </a:r>
           </a:p>
           <a:p>
@@ -29862,7 +29841,28 @@
                 <a:ea typeface="맑은 고딕"/>
                 <a:cs typeface="맑은 고딕"/>
               </a:rPr>
-              <a:t>재접수 35채 중 62.9%(22채)는 다른 상담원이 접수</a:t>
+              <a:t>2회 이상 접수 주택 35채 중 62.9%(22채)는 초기</a:t>
+            </a:r>
+            <a:br>
+              <a:rPr lang="ko-KR" sz="1100" b="0" dirty="0">
+                <a:solidFill>
+                  <a:srgbClr val="334155"/>
+                </a:solidFill>
+                <a:latin typeface="맑은 고딕"/>
+                <a:ea typeface="맑은 고딕"/>
+                <a:cs typeface="맑은 고딕"/>
+              </a:rPr>
+            </a:br>
+            <a:r>
+              <a:rPr lang="ko-KR" sz="1100" b="0" dirty="0">
+                <a:solidFill>
+                  <a:srgbClr val="334155"/>
+                </a:solidFill>
+                <a:latin typeface="맑은 고딕"/>
+                <a:ea typeface="맑은 고딕"/>
+                <a:cs typeface="맑은 고딕"/>
+              </a:rPr>
+              <a:t>접수 담당자에게 비인계</a:t>
             </a:r>
           </a:p>
         </p:txBody>

</xml_diff>

<commit_message>
feat(deck): slide 6 bullet cites the SQL 46.9% dispatch ratio
Co-Authored-By: Claude Sonnet 5.5 <noreply@anthropic.com>
</commit_message>
<xml_diff>
--- a/outputs/pptx/puzzledata_repair_report.pptx
+++ b/outputs/pptx/puzzledata_repair_report.pptx
@@ -125,21 +125,21 @@
   <p:extLst>
     <p:ext uri="{521415D9-36F7-43E2-AB2F-B90AF26B5E84}">
       <p14:sectionLst xmlns:p14="http://schemas.microsoft.com/office/powerpoint/2010/main">
-        <p14:section name="Part 00 · 인트로" id="{58B2360F-6F49-4D5A-B7BE-A11219E7E986}">
+        <p14:section name="Part 00 · 인트로" id="{DFEFE0EA-82E9-46EF-B263-69B13006683D}">
           <p14:sldIdLst>
             <p14:sldId id="256"/>
             <p14:sldId id="257"/>
             <p14:sldId id="258"/>
           </p14:sldIdLst>
         </p14:section>
-        <p14:section name="Part 01 · 데이터 진단" id="{95DE0FE0-BCC0-4C20-9408-3EC614770F02}">
+        <p14:section name="Part 01 · 데이터 진단" id="{CBDA96C3-BCDB-442A-A157-80BC3A21201E}">
           <p14:sldIdLst>
             <p14:sldId id="259"/>
             <p14:sldId id="260"/>
             <p14:sldId id="261"/>
           </p14:sldIdLst>
         </p14:section>
-        <p14:section name="Part 02 · 병목 규명" id="{10F79AAB-4503-4F2D-A29C-A4054A738580}">
+        <p14:section name="Part 02 · 병목 규명" id="{80E4AA2D-C2D1-49F1-8CE9-BD9B66381632}">
           <p14:sldIdLst>
             <p14:sldId id="262"/>
             <p14:sldId id="263"/>
@@ -152,14 +152,14 @@
             <p14:sldId id="270"/>
           </p14:sldIdLst>
         </p14:section>
-        <p14:section name="Part 03 · 개선 전략" id="{71A7C336-D8B1-4226-8049-E4FE7FCA15EE}">
+        <p14:section name="Part 03 · 개선 전략" id="{817FB35F-E9D9-44A5-8D34-52D3DE4266E4}">
           <p14:sldIdLst>
             <p14:sldId id="271"/>
             <p14:sldId id="272"/>
             <p14:sldId id="273"/>
           </p14:sldIdLst>
         </p14:section>
-        <p14:section name="Part 04 · Q&amp;A" id="{80B71877-82F0-4AE2-9FBB-9DBAA225D100}">
+        <p14:section name="Part 04 · Q&amp;A" id="{FF327E23-1043-448F-A511-7B3D5C83F2F0}">
           <p14:sldIdLst>
             <p14:sldId id="274"/>
           </p14:sldIdLst>
@@ -29261,7 +29261,7 @@
         <p:spPr>
           <a:xfrm>
             <a:off x="6629400" y="1554480"/>
-            <a:ext cx="5059375" cy="2094103"/>
+            <a:ext cx="5059375" cy="1996313"/>
           </a:xfrm>
           <a:prstGeom prst="rect">
             <a:avLst/>
@@ -29542,8 +29542,8 @@
         </p:nvSpPr>
         <p:spPr>
           <a:xfrm>
-            <a:off x="6629400" y="3776599"/>
-            <a:ext cx="5059375" cy="2514472"/>
+            <a:off x="6629400" y="3678809"/>
+            <a:ext cx="5059375" cy="2612262"/>
           </a:xfrm>
           <a:prstGeom prst="rect">
             <a:avLst/>
@@ -29588,7 +29588,7 @@
         </p:nvSpPr>
         <p:spPr>
           <a:xfrm>
-            <a:off x="6812280" y="3959479"/>
+            <a:off x="6812280" y="3861689"/>
             <a:ext cx="4693615" cy="158750"/>
           </a:xfrm>
           <a:prstGeom prst="rect">
@@ -29633,7 +29633,7 @@
         </p:nvSpPr>
         <p:spPr>
           <a:xfrm>
-            <a:off x="6812280" y="4173093"/>
+            <a:off x="6812280" y="4075303"/>
             <a:ext cx="4693615" cy="248920"/>
           </a:xfrm>
           <a:prstGeom prst="rect">
@@ -29678,7 +29678,7 @@
         </p:nvSpPr>
         <p:spPr>
           <a:xfrm>
-            <a:off x="6812280" y="4476877"/>
+            <a:off x="6812280" y="4379087"/>
             <a:ext cx="4693615" cy="511810"/>
           </a:xfrm>
           <a:prstGeom prst="rect">
@@ -29734,7 +29734,7 @@
         </p:nvSpPr>
         <p:spPr>
           <a:xfrm>
-            <a:off x="6812280" y="5043551"/>
+            <a:off x="6812280" y="4945761"/>
             <a:ext cx="4693615" cy="204470"/>
           </a:xfrm>
           <a:prstGeom prst="rect">
@@ -29773,14 +29773,14 @@
       </p:sp>
       <p:sp>
         <p:nvSpPr>
-          <p:cNvPr id="48" name="body:L3:t"/>
-          <p:cNvSpPr txBox="1"/>
-          <p:nvPr/>
-        </p:nvSpPr>
-        <p:spPr>
-          <a:xfrm>
-            <a:off x="6812280" y="5302885"/>
-            <a:ext cx="4693615" cy="624839"/>
+          <p:cNvPr id="48" name="body:L4:t"/>
+          <p:cNvSpPr txBox="1"/>
+          <p:nvPr/>
+        </p:nvSpPr>
+        <p:spPr>
+          <a:xfrm>
+            <a:off x="6812280" y="5205095"/>
+            <a:ext cx="4693615" cy="820419"/>
           </a:xfrm>
           <a:prstGeom prst="rect">
             <a:avLst/>
@@ -29815,7 +29815,28 @@
                 <a:ea typeface="맑은 고딕"/>
                 <a:cs typeface="맑은 고딕"/>
               </a:rPr>
-              <a:t>배정 현장 기사 고르게 분산</a:t>
+              <a:t>배정 현장 기사 고르게 분산 (기사별 Dian 접수 건</a:t>
+            </a:r>
+            <a:br>
+              <a:rPr lang="ko-KR" sz="1100" b="0" dirty="0">
+                <a:solidFill>
+                  <a:srgbClr val="334155"/>
+                </a:solidFill>
+                <a:latin typeface="맑은 고딕"/>
+                <a:ea typeface="맑은 고딕"/>
+                <a:cs typeface="맑은 고딕"/>
+              </a:rPr>
+            </a:br>
+            <a:r>
+              <a:rPr lang="ko-KR" sz="1100" b="0" dirty="0">
+                <a:solidFill>
+                  <a:srgbClr val="334155"/>
+                </a:solidFill>
+                <a:latin typeface="맑은 고딕"/>
+                <a:ea typeface="맑은 고딕"/>
+                <a:cs typeface="맑은 고딕"/>
+              </a:rPr>
+              <a:t>출동 비율이 평균 46.9%에 수렴)</a:t>
             </a:r>
           </a:p>
           <a:p>

</xml_diff>

<commit_message>
feat(deck): slide 6 bullet shortened to one line
Co-Authored-By: Claude Sonnet 5.5 <noreply@anthropic.com>
</commit_message>
<xml_diff>
--- a/outputs/pptx/puzzledata_repair_report.pptx
+++ b/outputs/pptx/puzzledata_repair_report.pptx
@@ -125,21 +125,21 @@
   <p:extLst>
     <p:ext uri="{521415D9-36F7-43E2-AB2F-B90AF26B5E84}">
       <p14:sectionLst xmlns:p14="http://schemas.microsoft.com/office/powerpoint/2010/main">
-        <p14:section name="Part 00 · 인트로" id="{DFEFE0EA-82E9-46EF-B263-69B13006683D}">
+        <p14:section name="Part 00 · 인트로" id="{792766F5-2890-40F7-93E9-1E08E0017FF1}">
           <p14:sldIdLst>
             <p14:sldId id="256"/>
             <p14:sldId id="257"/>
             <p14:sldId id="258"/>
           </p14:sldIdLst>
         </p14:section>
-        <p14:section name="Part 01 · 데이터 진단" id="{CBDA96C3-BCDB-442A-A157-80BC3A21201E}">
+        <p14:section name="Part 01 · 데이터 진단" id="{109CE805-88F0-4455-B56A-C186E89C49FF}">
           <p14:sldIdLst>
             <p14:sldId id="259"/>
             <p14:sldId id="260"/>
             <p14:sldId id="261"/>
           </p14:sldIdLst>
         </p14:section>
-        <p14:section name="Part 02 · 병목 규명" id="{80E4AA2D-C2D1-49F1-8CE9-BD9B66381632}">
+        <p14:section name="Part 02 · 병목 규명" id="{55250693-F090-4DA2-814B-64CFA3781A29}">
           <p14:sldIdLst>
             <p14:sldId id="262"/>
             <p14:sldId id="263"/>
@@ -152,14 +152,14 @@
             <p14:sldId id="270"/>
           </p14:sldIdLst>
         </p14:section>
-        <p14:section name="Part 03 · 개선 전략" id="{817FB35F-E9D9-44A5-8D34-52D3DE4266E4}">
+        <p14:section name="Part 03 · 개선 전략" id="{BD398531-AE7C-4C94-B5F2-24458932D23C}">
           <p14:sldIdLst>
             <p14:sldId id="271"/>
             <p14:sldId id="272"/>
             <p14:sldId id="273"/>
           </p14:sldIdLst>
         </p14:section>
-        <p14:section name="Part 04 · Q&amp;A" id="{FF327E23-1043-448F-A511-7B3D5C83F2F0}">
+        <p14:section name="Part 04 · Q&amp;A" id="{884FD045-FAAC-48AC-88BE-F8A43D6F5721}">
           <p14:sldIdLst>
             <p14:sldId id="274"/>
           </p14:sldIdLst>
@@ -29261,7 +29261,7 @@
         <p:spPr>
           <a:xfrm>
             <a:off x="6629400" y="1554480"/>
-            <a:ext cx="5059375" cy="1996313"/>
+            <a:ext cx="5059375" cy="2094103"/>
           </a:xfrm>
           <a:prstGeom prst="rect">
             <a:avLst/>
@@ -29542,8 +29542,8 @@
         </p:nvSpPr>
         <p:spPr>
           <a:xfrm>
-            <a:off x="6629400" y="3678809"/>
-            <a:ext cx="5059375" cy="2612262"/>
+            <a:off x="6629400" y="3776599"/>
+            <a:ext cx="5059375" cy="2514472"/>
           </a:xfrm>
           <a:prstGeom prst="rect">
             <a:avLst/>
@@ -29588,7 +29588,7 @@
         </p:nvSpPr>
         <p:spPr>
           <a:xfrm>
-            <a:off x="6812280" y="3861689"/>
+            <a:off x="6812280" y="3959479"/>
             <a:ext cx="4693615" cy="158750"/>
           </a:xfrm>
           <a:prstGeom prst="rect">
@@ -29633,7 +29633,7 @@
         </p:nvSpPr>
         <p:spPr>
           <a:xfrm>
-            <a:off x="6812280" y="4075303"/>
+            <a:off x="6812280" y="4173093"/>
             <a:ext cx="4693615" cy="248920"/>
           </a:xfrm>
           <a:prstGeom prst="rect">
@@ -29678,7 +29678,7 @@
         </p:nvSpPr>
         <p:spPr>
           <a:xfrm>
-            <a:off x="6812280" y="4379087"/>
+            <a:off x="6812280" y="4476877"/>
             <a:ext cx="4693615" cy="511810"/>
           </a:xfrm>
           <a:prstGeom prst="rect">
@@ -29734,7 +29734,7 @@
         </p:nvSpPr>
         <p:spPr>
           <a:xfrm>
-            <a:off x="6812280" y="4945761"/>
+            <a:off x="6812280" y="5043551"/>
             <a:ext cx="4693615" cy="204470"/>
           </a:xfrm>
           <a:prstGeom prst="rect">
@@ -29773,14 +29773,14 @@
       </p:sp>
       <p:sp>
         <p:nvSpPr>
-          <p:cNvPr id="48" name="body:L4:t"/>
-          <p:cNvSpPr txBox="1"/>
-          <p:nvPr/>
-        </p:nvSpPr>
-        <p:spPr>
-          <a:xfrm>
-            <a:off x="6812280" y="5205095"/>
-            <a:ext cx="4693615" cy="820419"/>
+          <p:cNvPr id="48" name="body:L3:t"/>
+          <p:cNvSpPr txBox="1"/>
+          <p:nvPr/>
+        </p:nvSpPr>
+        <p:spPr>
+          <a:xfrm>
+            <a:off x="6812280" y="5302885"/>
+            <a:ext cx="4693615" cy="624839"/>
           </a:xfrm>
           <a:prstGeom prst="rect">
             <a:avLst/>
@@ -29815,28 +29815,7 @@
                 <a:ea typeface="맑은 고딕"/>
                 <a:cs typeface="맑은 고딕"/>
               </a:rPr>
-              <a:t>배정 현장 기사 고르게 분산 (기사별 Dian 접수 건</a:t>
-            </a:r>
-            <a:br>
-              <a:rPr lang="ko-KR" sz="1100" b="0" dirty="0">
-                <a:solidFill>
-                  <a:srgbClr val="334155"/>
-                </a:solidFill>
-                <a:latin typeface="맑은 고딕"/>
-                <a:ea typeface="맑은 고딕"/>
-                <a:cs typeface="맑은 고딕"/>
-              </a:rPr>
-            </a:br>
-            <a:r>
-              <a:rPr lang="ko-KR" sz="1100" b="0" dirty="0">
-                <a:solidFill>
-                  <a:srgbClr val="334155"/>
-                </a:solidFill>
-                <a:latin typeface="맑은 고딕"/>
-                <a:ea typeface="맑은 고딕"/>
-                <a:cs typeface="맑은 고딕"/>
-              </a:rPr>
-              <a:t>출동 비율이 평균 46.9%에 수렴)</a:t>
+              <a:t>배정 현장 기사 고르게 분산 (접수원별 기사 출동 비율: 평균 46.9%)</a:t>
             </a:r>
           </a:p>
           <a:p>

</xml_diff>

<commit_message>
feat(deck): slide 7 wording, centered 역행 line and settlement match with 2 one-minute exceptions
Co-Authored-By: Claude Sonnet 5.5 <noreply@anthropic.com>
</commit_message>
<xml_diff>
--- a/outputs/pptx/puzzledata_repair_report.pptx
+++ b/outputs/pptx/puzzledata_repair_report.pptx
@@ -125,21 +125,21 @@
   <p:extLst>
     <p:ext uri="{521415D9-36F7-43E2-AB2F-B90AF26B5E84}">
       <p14:sectionLst xmlns:p14="http://schemas.microsoft.com/office/powerpoint/2010/main">
-        <p14:section name="Part 00 · 인트로" id="{792766F5-2890-40F7-93E9-1E08E0017FF1}">
+        <p14:section name="Part 00 · 인트로" id="{FF3EE955-51F9-4002-95E7-E7C226FEC585}">
           <p14:sldIdLst>
             <p14:sldId id="256"/>
             <p14:sldId id="257"/>
             <p14:sldId id="258"/>
           </p14:sldIdLst>
         </p14:section>
-        <p14:section name="Part 01 · 데이터 진단" id="{109CE805-88F0-4455-B56A-C186E89C49FF}">
+        <p14:section name="Part 01 · 데이터 진단" id="{F2E608F2-D8B8-4B49-9A07-DEA19B5A5437}">
           <p14:sldIdLst>
             <p14:sldId id="259"/>
             <p14:sldId id="260"/>
             <p14:sldId id="261"/>
           </p14:sldIdLst>
         </p14:section>
-        <p14:section name="Part 02 · 병목 규명" id="{55250693-F090-4DA2-814B-64CFA3781A29}">
+        <p14:section name="Part 02 · 병목 규명" id="{8E44AB12-7B87-4EF1-912E-3382A8F2EEDE}">
           <p14:sldIdLst>
             <p14:sldId id="262"/>
             <p14:sldId id="263"/>
@@ -152,14 +152,14 @@
             <p14:sldId id="270"/>
           </p14:sldIdLst>
         </p14:section>
-        <p14:section name="Part 03 · 개선 전략" id="{BD398531-AE7C-4C94-B5F2-24458932D23C}">
+        <p14:section name="Part 03 · 개선 전략" id="{5A1E9D1C-3243-4D8B-99B7-58A839239036}">
           <p14:sldIdLst>
             <p14:sldId id="271"/>
             <p14:sldId id="272"/>
             <p14:sldId id="273"/>
           </p14:sldIdLst>
         </p14:section>
-        <p14:section name="Part 04 · Q&amp;A" id="{884FD045-FAAC-48AC-88BE-F8A43D6F5721}">
+        <p14:section name="Part 04 · Q&amp;A" id="{86249981-C785-4986-9B85-986F0EE3D53C}">
           <p14:sldIdLst>
             <p14:sldId id="274"/>
           </p14:sldIdLst>
@@ -1691,7 +1691,7 @@
           <a:lstStyle/>
           <a:p>
             <a:r>
-              <a:t>병목 분석 전에, 모든 분석의 기준선이 될 E2E 프로세스 모델입니다. 접수 단계에서 오접수 73건이 조기 이탈하고 927건이 코호트가 됩니다. 현장은 단방향 에스컬레이션입니다. 즉시수리에서 사내수리로 23건, 즉시수리에서 외주로 38건, 사내수리에서 외주로 35건, 총 96회 올라가기만 하고 외주 이후 되돌아간 전이는 0건입니다. 정산은 고객 통보 469건 : 재무 전송 456건(50.6% : 49.2%)으로 대칭 선행하는 병렬 구조이며, 티켓 마감은 늦게 끝난 작업과 99.8%(925건) 일치합니다. [근거 보강] 시각이 원본인 정상 표본 335건에서도 168:167로 대등합니다(노트북 Cell 75).</a:t>
+              <a:t>병목 분석 전에, 모든 분석의 기준선이 될 E2E 프로세스 모델입니다. 접수 단계에서 오접수 73건이 조기 이탈하고 927건이 정상 접수가 됩니다. 현장은 단방향 에스컬레이션입니다. 즉시수리에서 사내수리로 23건, 즉시수리에서 외주로 38건, 사내수리에서 외주로 35건, 총 96회 인계되기만 하고 외주 이후 되돌아간 전이는 0건입니다. 정산은 고객 통보 469건 : 재무 전송 456건(50.6% : 49.2%)으로 대칭 선행하는 병렬 구조이며, 고객 통보와 재무 전송은 병렬이고, 티켓 발행 시각은 늦게 끝난 쪽과 927건 중 925건(99.8%) 일치하며 나머지 2건은 1분 차이입니다. [근거 보강] 시각이 원본인 정상 표본 335건에서도 168:167로 대등합니다(노트북 Cell 75).</a:t>
             </a:r>
           </a:p>
         </p:txBody>
@@ -30023,7 +30023,7 @@
                 <a:ea typeface="맑은 고딕"/>
                 <a:cs typeface="맑은 고딕"/>
               </a:rPr>
-              <a:t>수리 프로세스(E2E) 라인 도출</a:t>
+              <a:t>수리 프로세스(E2E) 라인</a:t>
             </a:r>
           </a:p>
         </p:txBody>
@@ -30148,7 +30148,7 @@
         <p:spPr>
           <a:xfrm>
             <a:off x="502920" y="1527048"/>
-            <a:ext cx="11185855" cy="3395726"/>
+            <a:ext cx="11185855" cy="3167126"/>
           </a:xfrm>
           <a:prstGeom prst="rect">
             <a:avLst/>
@@ -30246,8 +30246,8 @@
         </p:blipFill>
         <p:spPr>
           <a:xfrm>
-            <a:off x="1315652" y="1868678"/>
-            <a:ext cx="9560390" cy="2926080"/>
+            <a:off x="1689105" y="1868678"/>
+            <a:ext cx="8813484" cy="2697480"/>
           </a:xfrm>
           <a:prstGeom prst="rect">
             <a:avLst/>
@@ -30262,8 +30262,8 @@
         </p:nvSpPr>
         <p:spPr>
           <a:xfrm>
-            <a:off x="502920" y="5059934"/>
-            <a:ext cx="3606698" cy="1192784"/>
+            <a:off x="502920" y="4831334"/>
+            <a:ext cx="3606698" cy="1397254"/>
           </a:xfrm>
           <a:prstGeom prst="rect">
             <a:avLst/>
@@ -30308,7 +30308,7 @@
         </p:nvSpPr>
         <p:spPr>
           <a:xfrm>
-            <a:off x="685800" y="5242814"/>
+            <a:off x="685800" y="5014214"/>
             <a:ext cx="3240938" cy="158750"/>
           </a:xfrm>
           <a:prstGeom prst="rect">
@@ -30340,7 +30340,7 @@
                 <a:ea typeface="맑은 고딕"/>
                 <a:cs typeface="Consolas"/>
               </a:rPr>
-              <a:t>01 · 접수 국면</a:t>
+              <a:t>01 · 접수</a:t>
             </a:r>
           </a:p>
         </p:txBody>
@@ -30353,7 +30353,7 @@
         </p:nvSpPr>
         <p:spPr>
           <a:xfrm>
-            <a:off x="685800" y="5456428"/>
+            <a:off x="685800" y="5227828"/>
             <a:ext cx="3240938" cy="408940"/>
           </a:xfrm>
           <a:prstGeom prst="rect">
@@ -30441,8 +30441,8 @@
         </p:nvSpPr>
         <p:spPr>
           <a:xfrm>
-            <a:off x="4292498" y="5059934"/>
-            <a:ext cx="3606698" cy="1192784"/>
+            <a:off x="4292498" y="4831334"/>
+            <a:ext cx="3606698" cy="1397254"/>
           </a:xfrm>
           <a:prstGeom prst="rect">
             <a:avLst/>
@@ -30487,7 +30487,7 @@
         </p:nvSpPr>
         <p:spPr>
           <a:xfrm>
-            <a:off x="4475378" y="5242814"/>
+            <a:off x="4475378" y="5014214"/>
             <a:ext cx="3240938" cy="158750"/>
           </a:xfrm>
           <a:prstGeom prst="rect">
@@ -30519,7 +30519,7 @@
                 <a:ea typeface="맑은 고딕"/>
                 <a:cs typeface="Consolas"/>
               </a:rPr>
-              <a:t>02 · 현장 국면 · 단방향 에스컬레이션</a:t>
+              <a:t>02 · 현장 · 단방향 에스컬레이션</a:t>
             </a:r>
           </a:p>
         </p:txBody>
@@ -30532,7 +30532,7 @@
         </p:nvSpPr>
         <p:spPr>
           <a:xfrm>
-            <a:off x="4475378" y="5456428"/>
+            <a:off x="4475378" y="5227828"/>
             <a:ext cx="3240938" cy="613410"/>
           </a:xfrm>
           <a:prstGeom prst="rect">
@@ -30575,7 +30575,7 @@
                 <a:ea typeface="맑은 고딕"/>
                 <a:cs typeface="맑은 고딕"/>
               </a:rPr>
-              <a:t>로만 올라가는 단방향</a:t>
+              <a:t>로만 인계되는 단방향</a:t>
             </a:r>
           </a:p>
           <a:p>
@@ -30597,9 +30597,20 @@
                 <a:ea typeface="맑은 고딕"/>
                 <a:cs typeface="맑은 고딕"/>
               </a:rPr>
-              <a:t>즉시→사내 23 · 즉시→외주 38 ·</a:t>
-            </a:r>
-            <a:br>
+              <a:t>즉시→사내 23 · 즉시→외주 38 · 사내→외주 35</a:t>
+            </a:r>
+          </a:p>
+          <a:p>
+            <a:pPr algn="ctr">
+              <a:lnSpc>
+                <a:spcPts val="1610"/>
+              </a:lnSpc>
+              <a:spcBef>
+                <a:spcPts val="0"/>
+              </a:spcBef>
+              <a:buNone/>
+            </a:pPr>
+            <a:r>
               <a:rPr lang="ko-KR" sz="1150" b="0" dirty="0">
                 <a:solidFill>
                   <a:srgbClr val="334155"/>
@@ -30608,17 +30619,7 @@
                 <a:ea typeface="맑은 고딕"/>
                 <a:cs typeface="맑은 고딕"/>
               </a:rPr>
-            </a:br>
-            <a:r>
-              <a:rPr lang="ko-KR" sz="1150" b="0" dirty="0">
-                <a:solidFill>
-                  <a:srgbClr val="334155"/>
-                </a:solidFill>
-                <a:latin typeface="맑은 고딕"/>
-                <a:ea typeface="맑은 고딕"/>
-                <a:cs typeface="맑은 고딕"/>
-              </a:rPr>
-              <a:t>사내→외주 35 (총 96회), </a:t>
+              <a:t>총 96회 · </a:t>
             </a:r>
             <a:r>
               <a:rPr lang="ko-KR" sz="1150" b="1" dirty="0">
@@ -30629,7 +30630,7 @@
                 <a:ea typeface="맑은 고딕"/>
                 <a:cs typeface="맑은 고딕"/>
               </a:rPr>
-              <a:t>역류 0건</a:t>
+              <a:t>역행 0건</a:t>
             </a:r>
           </a:p>
         </p:txBody>
@@ -30642,8 +30643,8 @@
         </p:nvSpPr>
         <p:spPr>
           <a:xfrm>
-            <a:off x="8082076" y="5059934"/>
-            <a:ext cx="3606698" cy="1192784"/>
+            <a:off x="8082076" y="4831334"/>
+            <a:ext cx="3606698" cy="1397254"/>
           </a:xfrm>
           <a:prstGeom prst="rect">
             <a:avLst/>
@@ -30688,7 +30689,7 @@
         </p:nvSpPr>
         <p:spPr>
           <a:xfrm>
-            <a:off x="8264956" y="5242814"/>
+            <a:off x="8264956" y="5014214"/>
             <a:ext cx="3240938" cy="158750"/>
           </a:xfrm>
           <a:prstGeom prst="rect">
@@ -30720,21 +30721,21 @@
                 <a:ea typeface="맑은 고딕"/>
                 <a:cs typeface="Consolas"/>
               </a:rPr>
-              <a:t>03 · 정산 국면</a:t>
-            </a:r>
-          </a:p>
-        </p:txBody>
-      </p:sp>
-      <p:sp>
-        <p:nvSpPr>
-          <p:cNvPr id="19" name="body:L2:t"/>
-          <p:cNvSpPr txBox="1"/>
-          <p:nvPr/>
-        </p:nvSpPr>
-        <p:spPr>
-          <a:xfrm>
-            <a:off x="8264956" y="5456428"/>
-            <a:ext cx="3240938" cy="408940"/>
+              <a:t>03 · 정산</a:t>
+            </a:r>
+          </a:p>
+        </p:txBody>
+      </p:sp>
+      <p:sp>
+        <p:nvSpPr>
+          <p:cNvPr id="19" name="body:L4:settle"/>
+          <p:cNvSpPr txBox="1"/>
+          <p:nvPr/>
+        </p:nvSpPr>
+        <p:spPr>
+          <a:xfrm>
+            <a:off x="8264956" y="5227828"/>
+            <a:ext cx="3240938" cy="817880"/>
           </a:xfrm>
           <a:prstGeom prst="rect">
             <a:avLst/>
@@ -30765,7 +30766,7 @@
                 <a:ea typeface="맑은 고딕"/>
                 <a:cs typeface="맑은 고딕"/>
               </a:rPr>
-              <a:t>고객 통보 </a:t>
+              <a:t>수리 완료 알림 후 </a:t>
             </a:r>
             <a:r>
               <a:rPr lang="ko-KR" sz="1150" b="1" dirty="0">
@@ -30776,7 +30777,28 @@
                 <a:ea typeface="맑은 고딕"/>
                 <a:cs typeface="맑은 고딕"/>
               </a:rPr>
-              <a:t>469 </a:t>
+              <a:t>고객 통보·재무</a:t>
+            </a:r>
+            <a:br>
+              <a:rPr lang="ko-KR" sz="1150" b="1" dirty="0">
+                <a:solidFill>
+                  <a:srgbClr val="2563EB"/>
+                </a:solidFill>
+                <a:latin typeface="맑은 고딕"/>
+                <a:ea typeface="맑은 고딕"/>
+                <a:cs typeface="맑은 고딕"/>
+              </a:rPr>
+            </a:br>
+            <a:r>
+              <a:rPr lang="ko-KR" sz="1150" b="1" dirty="0">
+                <a:solidFill>
+                  <a:srgbClr val="2563EB"/>
+                </a:solidFill>
+                <a:latin typeface="맑은 고딕"/>
+                <a:ea typeface="맑은 고딕"/>
+                <a:cs typeface="맑은 고딕"/>
+              </a:rPr>
+              <a:t>전송 </a:t>
             </a:r>
             <a:r>
               <a:rPr lang="ko-KR" sz="1150" b="0" dirty="0">
@@ -30787,9 +30809,31 @@
                 <a:ea typeface="맑은 고딕"/>
                 <a:cs typeface="맑은 고딕"/>
               </a:rPr>
-              <a:t>: 재무 전송 </a:t>
-            </a:r>
-            <a:r>
+              <a:t>시스템 병렬 시행</a:t>
+            </a:r>
+          </a:p>
+          <a:p>
+            <a:pPr algn="l">
+              <a:lnSpc>
+                <a:spcPts val="1610"/>
+              </a:lnSpc>
+              <a:spcBef>
+                <a:spcPts val="0"/>
+              </a:spcBef>
+              <a:buNone/>
+            </a:pPr>
+            <a:r>
+              <a:rPr lang="ko-KR" sz="1150" b="0" dirty="0">
+                <a:solidFill>
+                  <a:srgbClr val="334155"/>
+                </a:solidFill>
+                <a:latin typeface="맑은 고딕"/>
+                <a:ea typeface="맑은 고딕"/>
+                <a:cs typeface="맑은 고딕"/>
+              </a:rPr>
+              <a:t>병렬 수행 마지막 시각과 티켓 발행 시각 일치</a:t>
+            </a:r>
+            <a:br>
               <a:rPr lang="ko-KR" sz="1150" b="1" dirty="0">
                 <a:solidFill>
                   <a:srgbClr val="2563EB"/>
@@ -30798,7 +30842,17 @@
                 <a:ea typeface="맑은 고딕"/>
                 <a:cs typeface="맑은 고딕"/>
               </a:rPr>
-              <a:t>456건 </a:t>
+            </a:br>
+            <a:r>
+              <a:rPr lang="ko-KR" sz="1150" b="1" dirty="0">
+                <a:solidFill>
+                  <a:srgbClr val="2563EB"/>
+                </a:solidFill>
+                <a:latin typeface="맑은 고딕"/>
+                <a:ea typeface="맑은 고딕"/>
+                <a:cs typeface="맑은 고딕"/>
+              </a:rPr>
+              <a:t>925건(99.8%)</a:t>
             </a:r>
             <a:r>
               <a:rPr lang="ko-KR" sz="1150" b="0" dirty="0">
@@ -30809,39 +30863,7 @@
                 <a:ea typeface="맑은 고딕"/>
                 <a:cs typeface="맑은 고딕"/>
               </a:rPr>
-              <a:t>병렬(AND),</a:t>
-            </a:r>
-            <a:br>
-              <a:rPr lang="ko-KR" sz="1150" b="0" dirty="0">
-                <a:solidFill>
-                  <a:srgbClr val="334155"/>
-                </a:solidFill>
-                <a:latin typeface="맑은 고딕"/>
-                <a:ea typeface="맑은 고딕"/>
-                <a:cs typeface="맑은 고딕"/>
-              </a:rPr>
-            </a:br>
-            <a:r>
-              <a:rPr lang="ko-KR" sz="1150" b="0" dirty="0">
-                <a:solidFill>
-                  <a:srgbClr val="334155"/>
-                </a:solidFill>
-                <a:latin typeface="맑은 고딕"/>
-                <a:ea typeface="맑은 고딕"/>
-                <a:cs typeface="맑은 고딕"/>
-              </a:rPr>
-              <a:t>마감 일치 </a:t>
-            </a:r>
-            <a:r>
-              <a:rPr lang="ko-KR" sz="1150" b="1" dirty="0">
-                <a:solidFill>
-                  <a:srgbClr val="2563EB"/>
-                </a:solidFill>
-                <a:latin typeface="맑은 고딕"/>
-                <a:ea typeface="맑은 고딕"/>
-                <a:cs typeface="맑은 고딕"/>
-              </a:rPr>
-              <a:t>925건(99.8%)</a:t>
+              <a:t>, 나머지 2건은 1분 차이</a:t>
             </a:r>
           </a:p>
         </p:txBody>
@@ -31364,7 +31386,7 @@
                 <a:ea typeface="맑은 고딕"/>
                 <a:cs typeface="Consolas"/>
               </a:rPr>
-              <a:t>01 · 접수 국면</a:t>
+              <a:t>01 · 접수</a:t>
             </a:r>
           </a:p>
         </p:txBody>

</xml_diff>

<commit_message>
feat(deck): slide 7 chips condensed into terse bullets with weighted widths
Co-Authored-By: Claude Sonnet 5.5 <noreply@anthropic.com>
</commit_message>
<xml_diff>
--- a/outputs/pptx/puzzledata_repair_report.pptx
+++ b/outputs/pptx/puzzledata_repair_report.pptx
@@ -125,21 +125,21 @@
   <p:extLst>
     <p:ext uri="{521415D9-36F7-43E2-AB2F-B90AF26B5E84}">
       <p14:sectionLst xmlns:p14="http://schemas.microsoft.com/office/powerpoint/2010/main">
-        <p14:section name="Part 00 · 인트로" id="{FF3EE955-51F9-4002-95E7-E7C226FEC585}">
+        <p14:section name="Part 00 · 인트로" id="{B0C0A7DD-BAB1-43D8-92AE-BEC8D2638606}">
           <p14:sldIdLst>
             <p14:sldId id="256"/>
             <p14:sldId id="257"/>
             <p14:sldId id="258"/>
           </p14:sldIdLst>
         </p14:section>
-        <p14:section name="Part 01 · 데이터 진단" id="{F2E608F2-D8B8-4B49-9A07-DEA19B5A5437}">
+        <p14:section name="Part 01 · 데이터 진단" id="{ED67E2F4-32B2-451C-B952-7E140506BAC7}">
           <p14:sldIdLst>
             <p14:sldId id="259"/>
             <p14:sldId id="260"/>
             <p14:sldId id="261"/>
           </p14:sldIdLst>
         </p14:section>
-        <p14:section name="Part 02 · 병목 규명" id="{8E44AB12-7B87-4EF1-912E-3382A8F2EEDE}">
+        <p14:section name="Part 02 · 병목 규명" id="{5CD4A3E0-BB86-449D-BF35-7F19400AD5DF}">
           <p14:sldIdLst>
             <p14:sldId id="262"/>
             <p14:sldId id="263"/>
@@ -152,14 +152,14 @@
             <p14:sldId id="270"/>
           </p14:sldIdLst>
         </p14:section>
-        <p14:section name="Part 03 · 개선 전략" id="{5A1E9D1C-3243-4D8B-99B7-58A839239036}">
+        <p14:section name="Part 03 · 개선 전략" id="{EC3044CB-85F8-4862-B6AF-1A107F6EE7EA}">
           <p14:sldIdLst>
             <p14:sldId id="271"/>
             <p14:sldId id="272"/>
             <p14:sldId id="273"/>
           </p14:sldIdLst>
         </p14:section>
-        <p14:section name="Part 04 · Q&amp;A" id="{86249981-C785-4986-9B85-986F0EE3D53C}">
+        <p14:section name="Part 04 · Q&amp;A" id="{44DAB23A-B551-4344-9D32-EC86BB3749F2}">
           <p14:sldIdLst>
             <p14:sldId id="274"/>
           </p14:sldIdLst>
@@ -30148,7 +30148,7 @@
         <p:spPr>
           <a:xfrm>
             <a:off x="502920" y="1527048"/>
-            <a:ext cx="11185855" cy="3167126"/>
+            <a:ext cx="11185855" cy="3395726"/>
           </a:xfrm>
           <a:prstGeom prst="rect">
             <a:avLst/>
@@ -30246,8 +30246,8 @@
         </p:blipFill>
         <p:spPr>
           <a:xfrm>
-            <a:off x="1689105" y="1868678"/>
-            <a:ext cx="8813484" cy="2697480"/>
+            <a:off x="1315652" y="1868678"/>
+            <a:ext cx="9560390" cy="2926080"/>
           </a:xfrm>
           <a:prstGeom prst="rect">
             <a:avLst/>
@@ -30262,8 +30262,8 @@
         </p:nvSpPr>
         <p:spPr>
           <a:xfrm>
-            <a:off x="502920" y="4831334"/>
-            <a:ext cx="3606698" cy="1397254"/>
+            <a:off x="502920" y="5059934"/>
+            <a:ext cx="2885358" cy="1230884"/>
           </a:xfrm>
           <a:prstGeom prst="rect">
             <a:avLst/>
@@ -30308,8 +30308,8 @@
         </p:nvSpPr>
         <p:spPr>
           <a:xfrm>
-            <a:off x="685800" y="5014214"/>
-            <a:ext cx="3240938" cy="158750"/>
+            <a:off x="685800" y="5242814"/>
+            <a:ext cx="2519598" cy="158750"/>
           </a:xfrm>
           <a:prstGeom prst="rect">
             <a:avLst/>
@@ -30347,14 +30347,14 @@
       </p:sp>
       <p:sp>
         <p:nvSpPr>
-          <p:cNvPr id="13" name="body:L2:t"/>
-          <p:cNvSpPr txBox="1"/>
-          <p:nvPr/>
-        </p:nvSpPr>
-        <p:spPr>
-          <a:xfrm>
-            <a:off x="685800" y="5227828"/>
-            <a:ext cx="3240938" cy="408940"/>
+          <p:cNvPr id="13" name="body:L2:c1t"/>
+          <p:cNvSpPr txBox="1"/>
+          <p:nvPr/>
+        </p:nvSpPr>
+        <p:spPr>
+          <a:xfrm>
+            <a:off x="685800" y="5456428"/>
+            <a:ext cx="2519598" cy="408940"/>
           </a:xfrm>
           <a:prstGeom prst="rect">
             <a:avLst/>
@@ -30396,9 +30396,20 @@
                 <a:ea typeface="맑은 고딕"/>
                 <a:cs typeface="맑은 고딕"/>
               </a:rPr>
-              <a:t>오접수 조기 격리 →</a:t>
-            </a:r>
-            <a:br>
+              <a:t>오접수 격리</a:t>
+            </a:r>
+          </a:p>
+          <a:p>
+            <a:pPr algn="l">
+              <a:lnSpc>
+                <a:spcPts val="1610"/>
+              </a:lnSpc>
+              <a:spcBef>
+                <a:spcPts val="0"/>
+              </a:spcBef>
+              <a:buNone/>
+            </a:pPr>
+            <a:r>
               <a:rPr lang="ko-KR" sz="1150" b="0" dirty="0">
                 <a:solidFill>
                   <a:srgbClr val="334155"/>
@@ -30407,17 +30418,7 @@
                 <a:ea typeface="맑은 고딕"/>
                 <a:cs typeface="맑은 고딕"/>
               </a:rPr>
-            </a:br>
-            <a:r>
-              <a:rPr lang="ko-KR" sz="1150" b="0" dirty="0">
-                <a:solidFill>
-                  <a:srgbClr val="334155"/>
-                </a:solidFill>
-                <a:latin typeface="맑은 고딕"/>
-                <a:ea typeface="맑은 고딕"/>
-                <a:cs typeface="맑은 고딕"/>
-              </a:rPr>
-              <a:t>정상 접수 </a:t>
+              <a:t>→ 정상 접수 </a:t>
             </a:r>
             <a:r>
               <a:rPr lang="ko-KR" sz="1150" b="1" dirty="0">
@@ -30441,8 +30442,8 @@
         </p:nvSpPr>
         <p:spPr>
           <a:xfrm>
-            <a:off x="4292498" y="4831334"/>
-            <a:ext cx="3606698" cy="1397254"/>
+            <a:off x="3571158" y="5059934"/>
+            <a:ext cx="3967368" cy="1230884"/>
           </a:xfrm>
           <a:prstGeom prst="rect">
             <a:avLst/>
@@ -30487,8 +30488,8 @@
         </p:nvSpPr>
         <p:spPr>
           <a:xfrm>
-            <a:off x="4475378" y="5014214"/>
-            <a:ext cx="3240938" cy="158750"/>
+            <a:off x="3754038" y="5242814"/>
+            <a:ext cx="3601608" cy="158750"/>
           </a:xfrm>
           <a:prstGeom prst="rect">
             <a:avLst/>
@@ -30532,8 +30533,8 @@
         </p:nvSpPr>
         <p:spPr>
           <a:xfrm>
-            <a:off x="4475378" y="5227828"/>
-            <a:ext cx="3240938" cy="613410"/>
+            <a:off x="3754038" y="5456428"/>
+            <a:ext cx="3601608" cy="613410"/>
           </a:xfrm>
           <a:prstGeom prst="rect">
             <a:avLst/>
@@ -30643,8 +30644,8 @@
         </p:nvSpPr>
         <p:spPr>
           <a:xfrm>
-            <a:off x="8082076" y="4831334"/>
-            <a:ext cx="3606698" cy="1397254"/>
+            <a:off x="7721406" y="5059934"/>
+            <a:ext cx="3967368" cy="1230884"/>
           </a:xfrm>
           <a:prstGeom prst="rect">
             <a:avLst/>
@@ -30689,8 +30690,8 @@
         </p:nvSpPr>
         <p:spPr>
           <a:xfrm>
-            <a:off x="8264956" y="5014214"/>
-            <a:ext cx="3240938" cy="158750"/>
+            <a:off x="7904286" y="5242814"/>
+            <a:ext cx="3601608" cy="158750"/>
           </a:xfrm>
           <a:prstGeom prst="rect">
             <a:avLst/>
@@ -30728,34 +30729,38 @@
       </p:sp>
       <p:sp>
         <p:nvSpPr>
-          <p:cNvPr id="19" name="body:L4:settle"/>
-          <p:cNvSpPr txBox="1"/>
-          <p:nvPr/>
-        </p:nvSpPr>
-        <p:spPr>
-          <a:xfrm>
-            <a:off x="8264956" y="5227828"/>
-            <a:ext cx="3240938" cy="817880"/>
-          </a:xfrm>
-          <a:prstGeom prst="rect">
-            <a:avLst/>
-          </a:prstGeom>
-          <a:noFill/>
-        </p:spPr>
-        <p:txBody>
-          <a:bodyPr wrap="square" lIns="0" tIns="0" rIns="0" bIns="0" anchor="t">
-            <a:noAutofit/>
-          </a:bodyPr>
-          <a:lstStyle/>
-          <a:p>
-            <a:pPr algn="l">
+          <p:cNvPr id="19" name="body:L3:t"/>
+          <p:cNvSpPr txBox="1"/>
+          <p:nvPr/>
+        </p:nvSpPr>
+        <p:spPr>
+          <a:xfrm>
+            <a:off x="7904286" y="5456428"/>
+            <a:ext cx="3601608" cy="651510"/>
+          </a:xfrm>
+          <a:prstGeom prst="rect">
+            <a:avLst/>
+          </a:prstGeom>
+          <a:noFill/>
+        </p:spPr>
+        <p:txBody>
+          <a:bodyPr wrap="square" lIns="0" tIns="0" rIns="0" bIns="0" anchor="t">
+            <a:noAutofit/>
+          </a:bodyPr>
+          <a:lstStyle/>
+          <a:p>
+            <a:pPr algn="l" marL="164592" indent="-164592">
               <a:lnSpc>
                 <a:spcPts val="1610"/>
               </a:lnSpc>
               <a:spcBef>
                 <a:spcPts val="0"/>
               </a:spcBef>
-              <a:buNone/>
+              <a:buClr>
+                <a:srgbClr val="2563EB"/>
+              </a:buClr>
+              <a:buFont typeface="맑은 고딕"/>
+              <a:buChar char="•"/>
             </a:pPr>
             <a:r>
               <a:rPr lang="ko-KR" sz="1150" b="0" dirty="0">
@@ -30766,7 +30771,7 @@
                 <a:ea typeface="맑은 고딕"/>
                 <a:cs typeface="맑은 고딕"/>
               </a:rPr>
-              <a:t>수리 완료 알림 후 </a:t>
+              <a:t>수리 완료 후 </a:t>
             </a:r>
             <a:r>
               <a:rPr lang="ko-KR" sz="1150" b="1" dirty="0">
@@ -30777,12 +30782,60 @@
                 <a:ea typeface="맑은 고딕"/>
                 <a:cs typeface="맑은 고딕"/>
               </a:rPr>
-              <a:t>고객 통보·재무</a:t>
+              <a:t>고객 통보·재무 전송 </a:t>
+            </a:r>
+            <a:r>
+              <a:rPr lang="ko-KR" sz="1150" b="0" dirty="0">
+                <a:solidFill>
+                  <a:srgbClr val="334155"/>
+                </a:solidFill>
+                <a:latin typeface="맑은 고딕"/>
+                <a:ea typeface="맑은 고딕"/>
+                <a:cs typeface="맑은 고딕"/>
+              </a:rPr>
+              <a:t>병렬 시행</a:t>
+            </a:r>
+          </a:p>
+          <a:p>
+            <a:pPr algn="l" marL="164592" indent="-164592">
+              <a:lnSpc>
+                <a:spcPts val="1610"/>
+              </a:lnSpc>
+              <a:spcBef>
+                <a:spcPts val="300"/>
+              </a:spcBef>
+              <a:buClr>
+                <a:srgbClr val="2563EB"/>
+              </a:buClr>
+              <a:buFont typeface="맑은 고딕"/>
+              <a:buChar char="•"/>
+            </a:pPr>
+            <a:r>
+              <a:rPr lang="ko-KR" sz="1150" b="0" dirty="0">
+                <a:solidFill>
+                  <a:srgbClr val="334155"/>
+                </a:solidFill>
+                <a:latin typeface="맑은 고딕"/>
+                <a:ea typeface="맑은 고딕"/>
+                <a:cs typeface="맑은 고딕"/>
+              </a:rPr>
+              <a:t>티켓 발행 = 병렬 종료 시각: </a:t>
+            </a:r>
+            <a:r>
+              <a:rPr lang="ko-KR" sz="1150" b="1" dirty="0">
+                <a:solidFill>
+                  <a:srgbClr val="2563EB"/>
+                </a:solidFill>
+                <a:latin typeface="맑은 고딕"/>
+                <a:ea typeface="맑은 고딕"/>
+                <a:cs typeface="맑은 고딕"/>
+              </a:rPr>
+              <a:t>925건(99.8%)</a:t>
             </a:r>
             <a:br>
-              <a:rPr lang="ko-KR" sz="1150" b="1" dirty="0">
-                <a:solidFill>
-                  <a:srgbClr val="2563EB"/>
+              <a:rPr lang="ko-KR" sz="1150" b="0" dirty="0">
+                <a:solidFill>
+                  <a:srgbClr val="334155"/>
                 </a:solidFill>
                 <a:latin typeface="맑은 고딕"/>
                 <a:ea typeface="맑은 고딕"/>
@@ -30790,17 +30843,6 @@
               </a:rPr>
             </a:br>
             <a:r>
-              <a:rPr lang="ko-KR" sz="1150" b="1" dirty="0">
-                <a:solidFill>
-                  <a:srgbClr val="2563EB"/>
-                </a:solidFill>
-                <a:latin typeface="맑은 고딕"/>
-                <a:ea typeface="맑은 고딕"/>
-                <a:cs typeface="맑은 고딕"/>
-              </a:rPr>
-              <a:t>전송 </a:t>
-            </a:r>
-            <a:r>
               <a:rPr lang="ko-KR" sz="1150" b="0" dirty="0">
                 <a:solidFill>
                   <a:srgbClr val="334155"/>
@@ -30809,61 +30851,7 @@
                 <a:ea typeface="맑은 고딕"/>
                 <a:cs typeface="맑은 고딕"/>
               </a:rPr>
-              <a:t>시스템 병렬 시행</a:t>
-            </a:r>
-          </a:p>
-          <a:p>
-            <a:pPr algn="l">
-              <a:lnSpc>
-                <a:spcPts val="1610"/>
-              </a:lnSpc>
-              <a:spcBef>
-                <a:spcPts val="0"/>
-              </a:spcBef>
-              <a:buNone/>
-            </a:pPr>
-            <a:r>
-              <a:rPr lang="ko-KR" sz="1150" b="0" dirty="0">
-                <a:solidFill>
-                  <a:srgbClr val="334155"/>
-                </a:solidFill>
-                <a:latin typeface="맑은 고딕"/>
-                <a:ea typeface="맑은 고딕"/>
-                <a:cs typeface="맑은 고딕"/>
-              </a:rPr>
-              <a:t>병렬 수행 마지막 시각과 티켓 발행 시각 일치</a:t>
-            </a:r>
-            <a:br>
-              <a:rPr lang="ko-KR" sz="1150" b="1" dirty="0">
-                <a:solidFill>
-                  <a:srgbClr val="2563EB"/>
-                </a:solidFill>
-                <a:latin typeface="맑은 고딕"/>
-                <a:ea typeface="맑은 고딕"/>
-                <a:cs typeface="맑은 고딕"/>
-              </a:rPr>
-            </a:br>
-            <a:r>
-              <a:rPr lang="ko-KR" sz="1150" b="1" dirty="0">
-                <a:solidFill>
-                  <a:srgbClr val="2563EB"/>
-                </a:solidFill>
-                <a:latin typeface="맑은 고딕"/>
-                <a:ea typeface="맑은 고딕"/>
-                <a:cs typeface="맑은 고딕"/>
-              </a:rPr>
-              <a:t>925건(99.8%)</a:t>
-            </a:r>
-            <a:r>
-              <a:rPr lang="ko-KR" sz="1150" b="0" dirty="0">
-                <a:solidFill>
-                  <a:srgbClr val="334155"/>
-                </a:solidFill>
-                <a:latin typeface="맑은 고딕"/>
-                <a:ea typeface="맑은 고딕"/>
-                <a:cs typeface="맑은 고딕"/>
-              </a:rPr>
-              <a:t>, 나머지 2건은 1분 차이</a:t>
+              <a:t>일치, 2건은 1분 차이</a:t>
             </a:r>
           </a:p>
         </p:txBody>

</xml_diff>

<commit_message>
feat(deck): slide 9 caption uses fast-track wording; middle card as terse bullets
Co-Authored-By: Claude Sonnet 5.5 <noreply@anthropic.com>
</commit_message>
<xml_diff>
--- a/outputs/pptx/puzzledata_repair_report.pptx
+++ b/outputs/pptx/puzzledata_repair_report.pptx
@@ -125,21 +125,21 @@
   <p:extLst>
     <p:ext uri="{521415D9-36F7-43E2-AB2F-B90AF26B5E84}">
       <p14:sectionLst xmlns:p14="http://schemas.microsoft.com/office/powerpoint/2010/main">
-        <p14:section name="Part 00 · 인트로" id="{B0C0A7DD-BAB1-43D8-92AE-BEC8D2638606}">
+        <p14:section name="Part 00 · 인트로" id="{F8FE89AF-5C85-4EB2-B01B-0E3773FE92D4}">
           <p14:sldIdLst>
             <p14:sldId id="256"/>
             <p14:sldId id="257"/>
             <p14:sldId id="258"/>
           </p14:sldIdLst>
         </p14:section>
-        <p14:section name="Part 01 · 데이터 진단" id="{ED67E2F4-32B2-451C-B952-7E140506BAC7}">
+        <p14:section name="Part 01 · 데이터 진단" id="{4546087A-9EF3-4224-89BE-D81C36688F88}">
           <p14:sldIdLst>
             <p14:sldId id="259"/>
             <p14:sldId id="260"/>
             <p14:sldId id="261"/>
           </p14:sldIdLst>
         </p14:section>
-        <p14:section name="Part 02 · 병목 규명" id="{5CD4A3E0-BB86-449D-BF35-7F19400AD5DF}">
+        <p14:section name="Part 02 · 병목 규명" id="{4D15706F-7E41-4B76-A8AF-AAF063422BD4}">
           <p14:sldIdLst>
             <p14:sldId id="262"/>
             <p14:sldId id="263"/>
@@ -152,14 +152,14 @@
             <p14:sldId id="270"/>
           </p14:sldIdLst>
         </p14:section>
-        <p14:section name="Part 03 · 개선 전략" id="{EC3044CB-85F8-4862-B6AF-1A107F6EE7EA}">
+        <p14:section name="Part 03 · 개선 전략" id="{8CB8DF15-469B-4015-ACD5-E8E5BD60FB1B}">
           <p14:sldIdLst>
             <p14:sldId id="271"/>
             <p14:sldId id="272"/>
             <p14:sldId id="273"/>
           </p14:sldIdLst>
         </p14:section>
-        <p14:section name="Part 04 · Q&amp;A" id="{44DAB23A-B551-4344-9D32-EC86BB3749F2}">
+        <p14:section name="Part 04 · Q&amp;A" id="{72E47425-79B1-45E6-ADA6-4944DD94F2A6}">
           <p14:sldIdLst>
             <p14:sldId id="274"/>
           </p14:sldIdLst>
@@ -32267,7 +32267,7 @@
                 <a:ea typeface="맑은 고딕"/>
                 <a:cs typeface="Consolas"/>
               </a:rPr>
-              <a:t>FIG.09 · 접수 구간 3-Panel (인계 · 채널 · 15분 이내 평균)</a:t>
+              <a:t>FIG.09 · 접수 구간 3-Panel (인계 · 채널 · 패스트 트랙(15분 내) 평균)</a:t>
             </a:r>
           </a:p>
         </p:txBody>
@@ -32602,48 +32602,52 @@
       </p:sp>
       <p:sp>
         <p:nvSpPr>
-          <p:cNvPr id="18" name="body:L3:b1"/>
+          <p:cNvPr id="18" name="body:L4:bi"/>
           <p:cNvSpPr txBox="1"/>
           <p:nvPr/>
         </p:nvSpPr>
         <p:spPr>
           <a:xfrm>
             <a:off x="4475378" y="5136388"/>
-            <a:ext cx="3240938" cy="640080"/>
-          </a:xfrm>
-          <a:prstGeom prst="rect">
-            <a:avLst/>
-          </a:prstGeom>
-          <a:noFill/>
-        </p:spPr>
-        <p:txBody>
-          <a:bodyPr wrap="square" lIns="0" tIns="0" rIns="0" bIns="0" anchor="t">
-            <a:noAutofit/>
-          </a:bodyPr>
-          <a:lstStyle/>
-          <a:p>
-            <a:pPr algn="l">
-              <a:lnSpc>
-                <a:spcPts val="1680"/>
-              </a:lnSpc>
-              <a:spcBef>
-                <a:spcPts val="0"/>
-              </a:spcBef>
-              <a:buNone/>
-            </a:pPr>
-            <a:r>
-              <a:rPr lang="ko-KR" sz="1200" b="0" dirty="0">
-                <a:solidFill>
-                  <a:srgbClr val="0F172A"/>
-                </a:solidFill>
-                <a:latin typeface="맑은 고딕"/>
-                <a:ea typeface="맑은 고딕"/>
-                <a:cs typeface="맑은 고딕"/>
-              </a:rPr>
-              <a:t>웹·우편은 </a:t>
-            </a:r>
-            <a:r>
-              <a:rPr lang="ko-KR" sz="1200" b="1" dirty="0">
+            <a:ext cx="3240938" cy="932180"/>
+          </a:xfrm>
+          <a:prstGeom prst="rect">
+            <a:avLst/>
+          </a:prstGeom>
+          <a:noFill/>
+        </p:spPr>
+        <p:txBody>
+          <a:bodyPr wrap="square" lIns="0" tIns="0" rIns="0" bIns="0" anchor="t">
+            <a:noAutofit/>
+          </a:bodyPr>
+          <a:lstStyle/>
+          <a:p>
+            <a:pPr algn="l" marL="164592" indent="-164592">
+              <a:lnSpc>
+                <a:spcPts val="1610"/>
+              </a:lnSpc>
+              <a:spcBef>
+                <a:spcPts val="0"/>
+              </a:spcBef>
+              <a:buClr>
+                <a:srgbClr val="2563EB"/>
+              </a:buClr>
+              <a:buFont typeface="맑은 고딕"/>
+              <a:buChar char="•"/>
+            </a:pPr>
+            <a:r>
+              <a:rPr lang="ko-KR" sz="1150" b="0" dirty="0">
+                <a:solidFill>
+                  <a:srgbClr val="334155"/>
+                </a:solidFill>
+                <a:latin typeface="맑은 고딕"/>
+                <a:ea typeface="맑은 고딕"/>
+                <a:cs typeface="맑은 고딕"/>
+              </a:rPr>
+              <a:t>웹·우편 </a:t>
+            </a:r>
+            <a:r>
+              <a:rPr lang="ko-KR" sz="1150" b="1" dirty="0">
                 <a:solidFill>
                   <a:srgbClr val="E11D48"/>
                 </a:solidFill>
@@ -32651,31 +32655,36 @@
                 <a:ea typeface="맑은 고딕"/>
                 <a:cs typeface="맑은 고딕"/>
               </a:rPr>
-              <a:t>15분 이내 단기 접수(49.6%)</a:t>
-            </a:r>
-            <a:br>
-              <a:rPr lang="ko-KR" sz="1200" b="0" dirty="0">
-                <a:solidFill>
-                  <a:srgbClr val="0F172A"/>
-                </a:solidFill>
-                <a:latin typeface="맑은 고딕"/>
-                <a:ea typeface="맑은 고딕"/>
-                <a:cs typeface="맑은 고딕"/>
-              </a:rPr>
-            </a:br>
-            <a:r>
-              <a:rPr lang="ko-KR" sz="1200" b="0" dirty="0">
-                <a:solidFill>
-                  <a:srgbClr val="0F172A"/>
-                </a:solidFill>
-                <a:latin typeface="맑은 고딕"/>
-                <a:ea typeface="맑은 고딕"/>
-                <a:cs typeface="맑은 고딕"/>
-              </a:rPr>
-              <a:t>아니면 </a:t>
-            </a:r>
-            <a:r>
-              <a:rPr lang="ko-KR" sz="1200" b="1" dirty="0">
+              <a:t>패스트 트랙(15분 이내) 49.6%</a:t>
+            </a:r>
+          </a:p>
+          <a:p>
+            <a:pPr algn="l" marL="164592" indent="-164592">
+              <a:lnSpc>
+                <a:spcPts val="1610"/>
+              </a:lnSpc>
+              <a:spcBef>
+                <a:spcPts val="300"/>
+              </a:spcBef>
+              <a:buClr>
+                <a:srgbClr val="2563EB"/>
+              </a:buClr>
+              <a:buFont typeface="맑은 고딕"/>
+              <a:buChar char="•"/>
+            </a:pPr>
+            <a:r>
+              <a:rPr lang="ko-KR" sz="1150" b="0" dirty="0">
+                <a:solidFill>
+                  <a:srgbClr val="334155"/>
+                </a:solidFill>
+                <a:latin typeface="맑은 고딕"/>
+                <a:ea typeface="맑은 고딕"/>
+                <a:cs typeface="맑은 고딕"/>
+              </a:rPr>
+              <a:t>웹·우편 </a:t>
+            </a:r>
+            <a:r>
+              <a:rPr lang="ko-KR" sz="1150" b="1" dirty="0">
                 <a:solidFill>
                   <a:srgbClr val="E11D48"/>
                 </a:solidFill>
@@ -32683,73 +32692,22 @@
                 <a:ea typeface="맑은 고딕"/>
                 <a:cs typeface="맑은 고딕"/>
               </a:rPr>
-              <a:t>60분 초과 장기 대기(50.4%)</a:t>
-            </a:r>
-            <a:r>
-              <a:rPr lang="ko-KR" sz="1200" b="0" dirty="0">
-                <a:solidFill>
-                  <a:srgbClr val="0F172A"/>
-                </a:solidFill>
-                <a:latin typeface="맑은 고딕"/>
-                <a:ea typeface="맑은 고딕"/>
-                <a:cs typeface="맑은 고딕"/>
-              </a:rPr>
-              <a:t>로</a:t>
-            </a:r>
-            <a:br>
-              <a:rPr lang="ko-KR" sz="1200" b="0" dirty="0">
-                <a:solidFill>
-                  <a:srgbClr val="0F172A"/>
-                </a:solidFill>
-                <a:latin typeface="맑은 고딕"/>
-                <a:ea typeface="맑은 고딕"/>
-                <a:cs typeface="맑은 고딕"/>
-              </a:rPr>
-            </a:br>
-            <a:r>
-              <a:rPr lang="ko-KR" sz="1200" b="0" dirty="0">
-                <a:solidFill>
-                  <a:srgbClr val="0F172A"/>
-                </a:solidFill>
-                <a:latin typeface="맑은 고딕"/>
-                <a:ea typeface="맑은 고딕"/>
-                <a:cs typeface="맑은 고딕"/>
-              </a:rPr>
-              <a:t>일정이 확정된다. 15~60분 구간은 0건</a:t>
-            </a:r>
-          </a:p>
-        </p:txBody>
-      </p:sp>
-      <p:sp>
-        <p:nvSpPr>
-          <p:cNvPr id="19" name="body:L1:t"/>
-          <p:cNvSpPr txBox="1"/>
-          <p:nvPr/>
-        </p:nvSpPr>
-        <p:spPr>
-          <a:xfrm>
-            <a:off x="4475378" y="5831332"/>
-            <a:ext cx="3240938" cy="204470"/>
-          </a:xfrm>
-          <a:prstGeom prst="rect">
-            <a:avLst/>
-          </a:prstGeom>
-          <a:noFill/>
-        </p:spPr>
-        <p:txBody>
-          <a:bodyPr wrap="square" lIns="0" tIns="0" rIns="0" bIns="0" anchor="t">
-            <a:noAutofit/>
-          </a:bodyPr>
-          <a:lstStyle/>
-          <a:p>
-            <a:pPr algn="l">
+              <a:t>장기 대기(60분 초과) 50.4%</a:t>
+            </a:r>
+          </a:p>
+          <a:p>
+            <a:pPr algn="l" marL="164592" indent="-164592">
               <a:lnSpc>
                 <a:spcPts val="1610"/>
               </a:lnSpc>
               <a:spcBef>
-                <a:spcPts val="0"/>
-              </a:spcBef>
-              <a:buNone/>
+                <a:spcPts val="300"/>
+              </a:spcBef>
+              <a:buClr>
+                <a:srgbClr val="2563EB"/>
+              </a:buClr>
+              <a:buFont typeface="맑은 고딕"/>
+              <a:buChar char="•"/>
             </a:pPr>
             <a:r>
               <a:rPr lang="ko-KR" sz="1150" b="0" dirty="0">
@@ -32760,14 +32718,40 @@
                 <a:ea typeface="맑은 고딕"/>
                 <a:cs typeface="맑은 고딕"/>
               </a:rPr>
-              <a:t>인계 123건은 모두 60분 초과 (최소 72분)</a:t>
-            </a:r>
-          </a:p>
-        </p:txBody>
-      </p:sp>
-      <p:sp>
-        <p:nvSpPr>
-          <p:cNvPr id="20" name="c3"/>
+              <a:t>15~60분 구간 0건 — 단기 지연 아님</a:t>
+            </a:r>
+          </a:p>
+          <a:p>
+            <a:pPr algn="l" marL="164592" indent="-164592">
+              <a:lnSpc>
+                <a:spcPts val="1610"/>
+              </a:lnSpc>
+              <a:spcBef>
+                <a:spcPts val="300"/>
+              </a:spcBef>
+              <a:buClr>
+                <a:srgbClr val="2563EB"/>
+              </a:buClr>
+              <a:buFont typeface="맑은 고딕"/>
+              <a:buChar char="•"/>
+            </a:pPr>
+            <a:r>
+              <a:rPr lang="ko-KR" sz="1150" b="0" dirty="0">
+                <a:solidFill>
+                  <a:srgbClr val="334155"/>
+                </a:solidFill>
+                <a:latin typeface="맑은 고딕"/>
+                <a:ea typeface="맑은 고딕"/>
+                <a:cs typeface="맑은 고딕"/>
+              </a:rPr>
+              <a:t>인계 123건 전부 60분 초과 (최소 72분)</a:t>
+            </a:r>
+          </a:p>
+        </p:txBody>
+      </p:sp>
+      <p:sp>
+        <p:nvSpPr>
+          <p:cNvPr id="19" name="c3"/>
           <p:cNvSpPr/>
           <p:nvPr/>
         </p:nvSpPr>
@@ -32813,7 +32797,7 @@
       </p:sp>
       <p:sp>
         <p:nvSpPr>
-          <p:cNvPr id="21" name="label:L1:t"/>
+          <p:cNvPr id="20" name="label:L1:t"/>
           <p:cNvSpPr txBox="1"/>
           <p:nvPr/>
         </p:nvSpPr>
@@ -32858,7 +32842,7 @@
       </p:sp>
       <p:sp>
         <p:nvSpPr>
-          <p:cNvPr id="22" name="body:L1:c"/>
+          <p:cNvPr id="21" name="body:L1:c"/>
           <p:cNvSpPr txBox="1"/>
           <p:nvPr/>
         </p:nvSpPr>
@@ -32914,7 +32898,7 @@
       </p:sp>
       <p:sp>
         <p:nvSpPr>
-          <p:cNvPr id="23" name="body:L2:t"/>
+          <p:cNvPr id="22" name="body:L2:t"/>
           <p:cNvSpPr txBox="1"/>
           <p:nvPr/>
         </p:nvSpPr>

</xml_diff>

<commit_message>
feat(deck): slide 9 card wording (real-time channel average, 병목 = 일정 조율 공백)
</commit_message>
<xml_diff>
--- a/outputs/pptx/puzzledata_repair_report.pptx
+++ b/outputs/pptx/puzzledata_repair_report.pptx
@@ -125,21 +125,21 @@
   <p:extLst>
     <p:ext uri="{521415D9-36F7-43E2-AB2F-B90AF26B5E84}">
       <p14:sectionLst xmlns:p14="http://schemas.microsoft.com/office/powerpoint/2010/main">
-        <p14:section name="Part 00 · 인트로" id="{F8FE89AF-5C85-4EB2-B01B-0E3773FE92D4}">
+        <p14:section name="Part 00 · 인트로" id="{00FF2241-B287-4EFF-9953-4B9462685086}">
           <p14:sldIdLst>
             <p14:sldId id="256"/>
             <p14:sldId id="257"/>
             <p14:sldId id="258"/>
           </p14:sldIdLst>
         </p14:section>
-        <p14:section name="Part 01 · 데이터 진단" id="{4546087A-9EF3-4224-89BE-D81C36688F88}">
+        <p14:section name="Part 01 · 데이터 진단" id="{B3BA2E0A-EC6E-40FF-BAF6-4916CDE52EE1}">
           <p14:sldIdLst>
             <p14:sldId id="259"/>
             <p14:sldId id="260"/>
             <p14:sldId id="261"/>
           </p14:sldIdLst>
         </p14:section>
-        <p14:section name="Part 02 · 병목 규명" id="{4D15706F-7E41-4B76-A8AF-AAF063422BD4}">
+        <p14:section name="Part 02 · 병목 규명" id="{EAA466E1-0BD4-46D4-BE38-84C868CCAC46}">
           <p14:sldIdLst>
             <p14:sldId id="262"/>
             <p14:sldId id="263"/>
@@ -152,14 +152,14 @@
             <p14:sldId id="270"/>
           </p14:sldIdLst>
         </p14:section>
-        <p14:section name="Part 03 · 개선 전략" id="{8CB8DF15-469B-4015-ACD5-E8E5BD60FB1B}">
+        <p14:section name="Part 03 · 개선 전략" id="{515EAE6F-D83C-4EFA-B100-31AC936874E2}">
           <p14:sldIdLst>
             <p14:sldId id="271"/>
             <p14:sldId id="272"/>
             <p14:sldId id="273"/>
           </p14:sldIdLst>
         </p14:section>
-        <p14:section name="Part 04 · Q&amp;A" id="{72E47425-79B1-45E6-ADA6-4944DD94F2A6}">
+        <p14:section name="Part 04 · Q&amp;A" id="{731BA121-6C8C-4B18-BF8E-CB1A7C9A85BA}">
           <p14:sldIdLst>
             <p14:sldId id="274"/>
           </p14:sldIdLst>
@@ -32718,7 +32718,7 @@
                 <a:ea typeface="맑은 고딕"/>
                 <a:cs typeface="맑은 고딕"/>
               </a:rPr>
-              <a:t>15~60분 구간 0건 — 단기 지연 아님</a:t>
+              <a:t>15~60분 구간 0건</a:t>
             </a:r>
           </a:p>
           <a:p>
@@ -32936,7 +32936,7 @@
                 <a:ea typeface="맑은 고딕"/>
                 <a:cs typeface="맑은 고딕"/>
               </a:rPr>
-              <a:t>빠른 건의 평균: 웹 6.8분 &lt; 전화 8.2분.</a:t>
+              <a:t>빠른 건의 평균: 웹 6.8분 &lt; 실시간 채널</a:t>
             </a:r>
             <a:br>
               <a:rPr lang="ko-KR" sz="1150" b="0" dirty="0">
@@ -32957,7 +32957,7 @@
                 <a:ea typeface="맑은 고딕"/>
                 <a:cs typeface="맑은 고딕"/>
               </a:rPr>
-              <a:t>병목은 일정 조율 공백</a:t>
+              <a:t>8.3분. 병목 = 일정 조율 공백</a:t>
             </a:r>
           </a:p>
         </p:txBody>

</xml_diff>

<commit_message>
fix(deck): slide 9 fits body area after card text change (chart max height)
Co-Authored-By: Claude Sonnet 5.5 <noreply@anthropic.com>
</commit_message>
<xml_diff>
--- a/outputs/pptx/puzzledata_repair_report.pptx
+++ b/outputs/pptx/puzzledata_repair_report.pptx
@@ -125,21 +125,21 @@
   <p:extLst>
     <p:ext uri="{521415D9-36F7-43E2-AB2F-B90AF26B5E84}">
       <p14:sectionLst xmlns:p14="http://schemas.microsoft.com/office/powerpoint/2010/main">
-        <p14:section name="Part 00 · 인트로" id="{00FF2241-B287-4EFF-9953-4B9462685086}">
+        <p14:section name="Part 00 · 인트로" id="{F8A1AFF1-2640-4B02-A343-849596B75861}">
           <p14:sldIdLst>
             <p14:sldId id="256"/>
             <p14:sldId id="257"/>
             <p14:sldId id="258"/>
           </p14:sldIdLst>
         </p14:section>
-        <p14:section name="Part 01 · 데이터 진단" id="{B3BA2E0A-EC6E-40FF-BAF6-4916CDE52EE1}">
+        <p14:section name="Part 01 · 데이터 진단" id="{0A21F6CE-0077-4285-AFD2-B1201539FDC6}">
           <p14:sldIdLst>
             <p14:sldId id="259"/>
             <p14:sldId id="260"/>
             <p14:sldId id="261"/>
           </p14:sldIdLst>
         </p14:section>
-        <p14:section name="Part 02 · 병목 규명" id="{EAA466E1-0BD4-46D4-BE38-84C868CCAC46}">
+        <p14:section name="Part 02 · 병목 규명" id="{0D7C7424-2A32-4A7B-BDAD-25EB63983E01}">
           <p14:sldIdLst>
             <p14:sldId id="262"/>
             <p14:sldId id="263"/>
@@ -152,14 +152,14 @@
             <p14:sldId id="270"/>
           </p14:sldIdLst>
         </p14:section>
-        <p14:section name="Part 03 · 개선 전략" id="{515EAE6F-D83C-4EFA-B100-31AC936874E2}">
+        <p14:section name="Part 03 · 개선 전략" id="{AE18799B-409D-4F5E-9917-1927749BA86F}">
           <p14:sldIdLst>
             <p14:sldId id="271"/>
             <p14:sldId id="272"/>
             <p14:sldId id="273"/>
           </p14:sldIdLst>
         </p14:section>
-        <p14:section name="Part 04 · Q&amp;A" id="{731BA121-6C8C-4B18-BF8E-CB1A7C9A85BA}">
+        <p14:section name="Part 04 · Q&amp;A" id="{53C397E1-A832-48ED-AF24-75CC4DA794CE}">
           <p14:sldIdLst>
             <p14:sldId id="274"/>
           </p14:sldIdLst>
@@ -32190,7 +32190,7 @@
         <p:spPr>
           <a:xfrm>
             <a:off x="502920" y="1618488"/>
-            <a:ext cx="11185855" cy="2984246"/>
+            <a:ext cx="11185855" cy="2847086"/>
           </a:xfrm>
           <a:prstGeom prst="rect">
             <a:avLst/>
@@ -32288,8 +32288,8 @@
         </p:blipFill>
         <p:spPr>
           <a:xfrm>
-            <a:off x="1502853" y="1960118"/>
-            <a:ext cx="9185987" cy="2514600"/>
+            <a:off x="1753380" y="1960118"/>
+            <a:ext cx="8684933" cy="2377440"/>
           </a:xfrm>
           <a:prstGeom prst="rect">
             <a:avLst/>
@@ -32304,8 +32304,8 @@
         </p:nvSpPr>
         <p:spPr>
           <a:xfrm>
-            <a:off x="502920" y="4739894"/>
-            <a:ext cx="3606698" cy="1554987"/>
+            <a:off x="502920" y="4602734"/>
+            <a:ext cx="3606698" cy="1609852"/>
           </a:xfrm>
           <a:prstGeom prst="rect">
             <a:avLst/>
@@ -32350,7 +32350,7 @@
         </p:nvSpPr>
         <p:spPr>
           <a:xfrm>
-            <a:off x="685800" y="4922774"/>
+            <a:off x="685800" y="4785614"/>
             <a:ext cx="3240938" cy="158750"/>
           </a:xfrm>
           <a:prstGeom prst="rect">
@@ -32395,7 +32395,7 @@
         </p:nvSpPr>
         <p:spPr>
           <a:xfrm>
-            <a:off x="685800" y="5136388"/>
+            <a:off x="685800" y="4999228"/>
             <a:ext cx="3240938" cy="511810"/>
           </a:xfrm>
           <a:prstGeom prst="rect">
@@ -32451,7 +32451,7 @@
         </p:nvSpPr>
         <p:spPr>
           <a:xfrm>
-            <a:off x="685800" y="5703062"/>
+            <a:off x="685800" y="5565902"/>
             <a:ext cx="3240938" cy="408940"/>
           </a:xfrm>
           <a:prstGeom prst="rect">
@@ -32517,8 +32517,8 @@
         </p:nvSpPr>
         <p:spPr>
           <a:xfrm>
-            <a:off x="4292498" y="4739894"/>
-            <a:ext cx="3606698" cy="1554987"/>
+            <a:off x="4292498" y="4602734"/>
+            <a:ext cx="3606698" cy="1609852"/>
           </a:xfrm>
           <a:prstGeom prst="rect">
             <a:avLst/>
@@ -32563,7 +32563,7 @@
         </p:nvSpPr>
         <p:spPr>
           <a:xfrm>
-            <a:off x="4475378" y="4922774"/>
+            <a:off x="4475378" y="4785614"/>
             <a:ext cx="3240938" cy="158750"/>
           </a:xfrm>
           <a:prstGeom prst="rect">
@@ -32608,7 +32608,7 @@
         </p:nvSpPr>
         <p:spPr>
           <a:xfrm>
-            <a:off x="4475378" y="5136388"/>
+            <a:off x="4475378" y="4999228"/>
             <a:ext cx="3240938" cy="932180"/>
           </a:xfrm>
           <a:prstGeom prst="rect">
@@ -32757,8 +32757,8 @@
         </p:nvSpPr>
         <p:spPr>
           <a:xfrm>
-            <a:off x="8082076" y="4739894"/>
-            <a:ext cx="3606698" cy="1554987"/>
+            <a:off x="8082076" y="4602734"/>
+            <a:ext cx="3606698" cy="1609852"/>
           </a:xfrm>
           <a:prstGeom prst="rect">
             <a:avLst/>
@@ -32803,7 +32803,7 @@
         </p:nvSpPr>
         <p:spPr>
           <a:xfrm>
-            <a:off x="8264956" y="4922774"/>
+            <a:off x="8264956" y="4785614"/>
             <a:ext cx="3240938" cy="158750"/>
           </a:xfrm>
           <a:prstGeom prst="rect">
@@ -32848,7 +32848,7 @@
         </p:nvSpPr>
         <p:spPr>
           <a:xfrm>
-            <a:off x="8264956" y="5136388"/>
+            <a:off x="8264956" y="4999228"/>
             <a:ext cx="3240938" cy="511810"/>
           </a:xfrm>
           <a:prstGeom prst="rect">
@@ -32898,14 +32898,14 @@
       </p:sp>
       <p:sp>
         <p:nvSpPr>
-          <p:cNvPr id="22" name="body:L2:t"/>
-          <p:cNvSpPr txBox="1"/>
-          <p:nvPr/>
-        </p:nvSpPr>
-        <p:spPr>
-          <a:xfrm>
-            <a:off x="8264956" y="5703062"/>
-            <a:ext cx="3240938" cy="408940"/>
+          <p:cNvPr id="22" name="body:L1:t"/>
+          <p:cNvSpPr txBox="1"/>
+          <p:nvPr/>
+        </p:nvSpPr>
+        <p:spPr>
+          <a:xfrm>
+            <a:off x="8264956" y="5565902"/>
+            <a:ext cx="3240938" cy="204470"/>
           </a:xfrm>
           <a:prstGeom prst="rect">
             <a:avLst/>
@@ -32936,9 +32936,43 @@
                 <a:ea typeface="맑은 고딕"/>
                 <a:cs typeface="맑은 고딕"/>
               </a:rPr>
-              <a:t>빠른 건의 평균: 웹 6.8분 &lt; 실시간 채널</a:t>
-            </a:r>
-            <a:br>
+              <a:t>빠른 건 평균: 웹 6.8분 &lt; 실시간 채널 8.3분</a:t>
+            </a:r>
+          </a:p>
+        </p:txBody>
+      </p:sp>
+      <p:sp>
+        <p:nvSpPr>
+          <p:cNvPr id="23" name="body:L1:t"/>
+          <p:cNvSpPr txBox="1"/>
+          <p:nvPr/>
+        </p:nvSpPr>
+        <p:spPr>
+          <a:xfrm>
+            <a:off x="8264956" y="5825236"/>
+            <a:ext cx="3240938" cy="204470"/>
+          </a:xfrm>
+          <a:prstGeom prst="rect">
+            <a:avLst/>
+          </a:prstGeom>
+          <a:noFill/>
+        </p:spPr>
+        <p:txBody>
+          <a:bodyPr wrap="square" lIns="0" tIns="0" rIns="0" bIns="0" anchor="t">
+            <a:noAutofit/>
+          </a:bodyPr>
+          <a:lstStyle/>
+          <a:p>
+            <a:pPr algn="l">
+              <a:lnSpc>
+                <a:spcPts val="1610"/>
+              </a:lnSpc>
+              <a:spcBef>
+                <a:spcPts val="0"/>
+              </a:spcBef>
+              <a:buNone/>
+            </a:pPr>
+            <a:r>
               <a:rPr lang="ko-KR" sz="1150" b="0" dirty="0">
                 <a:solidFill>
                   <a:srgbClr val="334155"/>
@@ -32947,17 +32981,7 @@
                 <a:ea typeface="맑은 고딕"/>
                 <a:cs typeface="맑은 고딕"/>
               </a:rPr>
-            </a:br>
-            <a:r>
-              <a:rPr lang="ko-KR" sz="1150" b="0" dirty="0">
-                <a:solidFill>
-                  <a:srgbClr val="334155"/>
-                </a:solidFill>
-                <a:latin typeface="맑은 고딕"/>
-                <a:ea typeface="맑은 고딕"/>
-                <a:cs typeface="맑은 고딕"/>
-              </a:rPr>
-              <a:t>8.3분. 병목 = 일정 조율 공백</a:t>
+              <a:t>병목 = 일정 조율 공백</a:t>
             </a:r>
           </a:p>
         </p:txBody>

</xml_diff>

<commit_message>
feat(deck): slide 7 settlement claim restated as 0 inversions (927/927 TicketReady >= parallel end)
Co-Authored-By: Claude Sonnet 5.5 <noreply@anthropic.com>
</commit_message>
<xml_diff>
--- a/outputs/pptx/puzzledata_repair_report.pptx
+++ b/outputs/pptx/puzzledata_repair_report.pptx
@@ -125,21 +125,21 @@
   <p:extLst>
     <p:ext uri="{521415D9-36F7-43E2-AB2F-B90AF26B5E84}">
       <p14:sectionLst xmlns:p14="http://schemas.microsoft.com/office/powerpoint/2010/main">
-        <p14:section name="Part 00 · 인트로" id="{F8A1AFF1-2640-4B02-A343-849596B75861}">
+        <p14:section name="Part 00 · 인트로" id="{2B088D84-2E84-4A43-9541-8DB196A543C2}">
           <p14:sldIdLst>
             <p14:sldId id="256"/>
             <p14:sldId id="257"/>
             <p14:sldId id="258"/>
           </p14:sldIdLst>
         </p14:section>
-        <p14:section name="Part 01 · 데이터 진단" id="{0A21F6CE-0077-4285-AFD2-B1201539FDC6}">
+        <p14:section name="Part 01 · 데이터 진단" id="{C52B9310-38DC-40A3-BA20-7E2E678A9EA5}">
           <p14:sldIdLst>
             <p14:sldId id="259"/>
             <p14:sldId id="260"/>
             <p14:sldId id="261"/>
           </p14:sldIdLst>
         </p14:section>
-        <p14:section name="Part 02 · 병목 규명" id="{0D7C7424-2A32-4A7B-BDAD-25EB63983E01}">
+        <p14:section name="Part 02 · 병목 규명" id="{132C8163-713F-47EE-87CB-DEF0109F2EC0}">
           <p14:sldIdLst>
             <p14:sldId id="262"/>
             <p14:sldId id="263"/>
@@ -152,14 +152,14 @@
             <p14:sldId id="270"/>
           </p14:sldIdLst>
         </p14:section>
-        <p14:section name="Part 03 · 개선 전략" id="{AE18799B-409D-4F5E-9917-1927749BA86F}">
+        <p14:section name="Part 03 · 개선 전략" id="{B50A8125-D9E4-4A00-8C15-EF6E478920EA}">
           <p14:sldIdLst>
             <p14:sldId id="271"/>
             <p14:sldId id="272"/>
             <p14:sldId id="273"/>
           </p14:sldIdLst>
         </p14:section>
-        <p14:section name="Part 04 · Q&amp;A" id="{53C397E1-A832-48ED-AF24-75CC4DA794CE}">
+        <p14:section name="Part 04 · Q&amp;A" id="{EF70D3F9-E625-4588-9AF2-D44710ECAFE4}">
           <p14:sldIdLst>
             <p14:sldId id="274"/>
           </p14:sldIdLst>
@@ -1691,7 +1691,7 @@
           <a:lstStyle/>
           <a:p>
             <a:r>
-              <a:t>병목 분석 전에, 모든 분석의 기준선이 될 E2E 프로세스 모델입니다. 접수 단계에서 오접수 73건이 조기 이탈하고 927건이 정상 접수가 됩니다. 현장은 단방향 에스컬레이션입니다. 즉시수리에서 사내수리로 23건, 즉시수리에서 외주로 38건, 사내수리에서 외주로 35건, 총 96회 인계되기만 하고 외주 이후 되돌아간 전이는 0건입니다. 정산은 고객 통보 469건 : 재무 전송 456건(50.6% : 49.2%)으로 대칭 선행하는 병렬 구조이며, 고객 통보와 재무 전송은 병렬이고, 티켓 발행 시각은 늦게 끝난 쪽과 927건 중 925건(99.8%) 일치하며 나머지 2건은 1분 차이입니다. [근거 보강] 시각이 원본인 정상 표본 335건에서도 168:167로 대등합니다(노트북 Cell 75).</a:t>
+              <a:t>병목 분석 전에, 모든 분석의 기준선이 될 E2E 프로세스 모델입니다. 접수 단계에서 오접수 73건이 조기 이탈하고 927건이 정상 접수가 됩니다. 현장은 단방향 에스컬레이션입니다. 즉시수리에서 사내수리로 23건, 즉시수리에서 외주로 38건, 사내수리에서 외주로 35건, 총 96회 인계되기만 하고 외주 이후 되돌아간 전이는 0건입니다. 정산은 고객 통보 469건 : 재무 전송 456건(50.6% : 49.2%)으로 대칭 선행하는 병렬 구조이며, 고객 통보와 재무 전송은 병렬이고, 티켓 발행이 병렬 종료보다 앞선 역전은 927건 중 0건입니다. 925건(99.8%)은 병렬 종료와 동시에 마감됐고, 나머지 2건(케이스 154·959)은 원본 티켓 시각이 결측·더미여서 정상 표본 중앙값 1분을 앞선 작업 시각에 더해 복원한 순차 마감입니다. [근거 보강] 시각이 원본인 정상 표본 335건에서도 168:167로 대등합니다(노트북 Cell 75).</a:t>
             </a:r>
           </a:p>
         </p:txBody>
@@ -30819,7 +30819,7 @@
                 <a:ea typeface="맑은 고딕"/>
                 <a:cs typeface="맑은 고딕"/>
               </a:rPr>
-              <a:t>티켓 발행 = 병렬 종료 시각: </a:t>
+              <a:t>티켓 발행 ≥ 병렬 종료 시각 </a:t>
             </a:r>
             <a:r>
               <a:rPr lang="ko-KR" sz="1150" b="1" dirty="0">
@@ -30830,7 +30830,18 @@
                 <a:ea typeface="맑은 고딕"/>
                 <a:cs typeface="맑은 고딕"/>
               </a:rPr>
-              <a:t>925건(99.8%)</a:t>
+              <a:t>927건(100%)</a:t>
+            </a:r>
+            <a:r>
+              <a:rPr lang="ko-KR" sz="1150" b="0" dirty="0">
+                <a:solidFill>
+                  <a:srgbClr val="334155"/>
+                </a:solidFill>
+                <a:latin typeface="맑은 고딕"/>
+                <a:ea typeface="맑은 고딕"/>
+                <a:cs typeface="맑은 고딕"/>
+              </a:rPr>
+              <a:t>, 역전</a:t>
             </a:r>
             <a:br>
               <a:rPr lang="ko-KR" sz="1150" b="0" dirty="0">
@@ -30851,7 +30862,7 @@
                 <a:ea typeface="맑은 고딕"/>
                 <a:cs typeface="맑은 고딕"/>
               </a:rPr>
-              <a:t>일치, 2건은 1분 차이</a:t>
+              <a:t>0건 — 동시 925건 · 결측 복원 2건(+1분)</a:t>
             </a:r>
           </a:p>
         </p:txBody>

</xml_diff>

<commit_message>
feat(deck): slide 10 READING restated as handover x real-time channel r=-0.40 (123/123 handovers web/letter)
Co-Authored-By: Claude Sonnet 5.5 <noreply@anthropic.com>
</commit_message>
<xml_diff>
--- a/outputs/pptx/puzzledata_repair_report.pptx
+++ b/outputs/pptx/puzzledata_repair_report.pptx
@@ -125,21 +125,21 @@
   <p:extLst>
     <p:ext uri="{521415D9-36F7-43E2-AB2F-B90AF26B5E84}">
       <p14:sectionLst xmlns:p14="http://schemas.microsoft.com/office/powerpoint/2010/main">
-        <p14:section name="Part 00 · 인트로" id="{2B088D84-2E84-4A43-9541-8DB196A543C2}">
+        <p14:section name="Part 00 · 인트로" id="{2B6D37F4-683C-4C2C-8A8B-953A22F64977}">
           <p14:sldIdLst>
             <p14:sldId id="256"/>
             <p14:sldId id="257"/>
             <p14:sldId id="258"/>
           </p14:sldIdLst>
         </p14:section>
-        <p14:section name="Part 01 · 데이터 진단" id="{C52B9310-38DC-40A3-BA20-7E2E678A9EA5}">
+        <p14:section name="Part 01 · 데이터 진단" id="{C18C3221-E0DE-448C-8F07-783B5007FBB9}">
           <p14:sldIdLst>
             <p14:sldId id="259"/>
             <p14:sldId id="260"/>
             <p14:sldId id="261"/>
           </p14:sldIdLst>
         </p14:section>
-        <p14:section name="Part 02 · 병목 규명" id="{132C8163-713F-47EE-87CB-DEF0109F2EC0}">
+        <p14:section name="Part 02 · 병목 규명" id="{F795C5FE-5BDB-45FF-BF94-F041C8FAAED5}">
           <p14:sldIdLst>
             <p14:sldId id="262"/>
             <p14:sldId id="263"/>
@@ -152,14 +152,14 @@
             <p14:sldId id="270"/>
           </p14:sldIdLst>
         </p14:section>
-        <p14:section name="Part 03 · 개선 전략" id="{B50A8125-D9E4-4A00-8C15-EF6E478920EA}">
+        <p14:section name="Part 03 · 개선 전략" id="{DFAB933C-6253-4103-B56F-60603A183D10}">
           <p14:sldIdLst>
             <p14:sldId id="271"/>
             <p14:sldId id="272"/>
             <p14:sldId id="273"/>
           </p14:sldIdLst>
         </p14:section>
-        <p14:section name="Part 04 · Q&amp;A" id="{EF70D3F9-E625-4588-9AF2-D44710ECAFE4}">
+        <p14:section name="Part 04 · Q&amp;A" id="{96239EB7-DC39-4DA5-B32F-E22616D2FD8C}">
           <p14:sldIdLst>
             <p14:sldId id="274"/>
           </p14:sldIdLst>
@@ -635,7 +635,7 @@
           <a:lstStyle/>
           <a:p>
             <a:r>
-              <a:t>접수 구간에 영향을 줄 만한 9개 변수의 상관관계입니다. 접수 소요시간과 가장 강하게 같이 움직이는 것은 교차 인계(r=0.48)와 실시간 채널 여부(r=−0.43)입니다. 반면 일별 접수량은 r=0.01로 접수 시간과 무관하고, 오히려 현장 실사 대기와 r=0.17의 약한 양의 상관을 보입니다. 접수량은 접수창구가 아니라 뒤의 현장 대기열에 영향을 준다는 뜻입니다. 다만 상관은 변수 간 얽힘을 통제하지 못하므로, 다음 장에서 회귀분석으로 순수 효과를 분리합니다. [예상 질문] 상관이 인과인가? → 아닙니다. 그래서 OLS로 채널·인계·물량을 동시에 통제해 확인합니다.</a:t>
+              <a:t>접수 구간에 영향을 줄 만한 9개 변수의 상관관계입니다. 접수 소요시간과 가장 강하게 같이 움직이는 것은 교차 인계(r=0.48)와 실시간 채널 여부(r=−0.43)입니다. 반면 일별 접수량은 r=0.01로 접수 시간과 무관하고, 오히려 현장 실사 대기와 r=0.17의 약한 양의 상관을 보입니다. 접수량은 접수창구가 아니라 뒤의 현장 대기열에 영향을 준다는 뜻입니다. 그런데 교차 인계와 실시간 채널여부 사이에도 r=−0.40의 상관이 있습니다. 인계 123건이 전부 웹·우편 접수라서 두 변수가 겹쳐 움직이기 때문입니다. 상관은 이런 얽힘을 통제하지 못하므로, 다음 장에서 회귀분석으로 순수 효과를 분리합니다. [예상 질문] 상관이 인과인가? → 아닙니다. 그래서 OLS로 채널·인계·물량을 동시에 통제해 확인합니다.</a:t>
             </a:r>
           </a:p>
         </p:txBody>
@@ -6625,7 +6625,7 @@
                 <a:ea typeface="맑은 고딕"/>
                 <a:cs typeface="맑은 고딕"/>
               </a:rPr>
-              <a:t>상관은 방향만 보여준다. </a:t>
+              <a:t>교차 인계 ↔ 실시간 채널 </a:t>
             </a:r>
             <a:r>
               <a:rPr lang="ko-KR" sz="1250" b="1" dirty="0">
@@ -6636,7 +6636,18 @@
                 <a:ea typeface="맑은 고딕"/>
                 <a:cs typeface="맑은 고딕"/>
               </a:rPr>
-              <a:t>채널과 인계가 서로 얽혀 있어</a:t>
+              <a:t>r = −0.40 </a:t>
+            </a:r>
+            <a:r>
+              <a:rPr lang="ko-KR" sz="1250" b="0" dirty="0">
+                <a:solidFill>
+                  <a:srgbClr val="0F172A"/>
+                </a:solidFill>
+                <a:latin typeface="맑은 고딕"/>
+                <a:ea typeface="맑은 고딕"/>
+                <a:cs typeface="맑은 고딕"/>
+              </a:rPr>
+              <a:t>: 인계 123건 전부 웹·우편이라</a:t>
             </a:r>
             <a:br>
               <a:rPr lang="ko-KR" sz="1250" b="0" dirty="0">
@@ -6657,7 +6668,7 @@
                 <a:ea typeface="맑은 고딕"/>
                 <a:cs typeface="맑은 고딕"/>
               </a:rPr>
-              <a:t>순수 효과는 다음 장의 OLS로 분리한다.</a:t>
+              <a:t>두 변수가 얽힘 → 순수 효과는 다음 장 OLS로 분리</a:t>
             </a:r>
           </a:p>
         </p:txBody>

</xml_diff>

<commit_message>
feat(deck): slide 10 READING card converted to 4th stat card (handover x real-time channel r=-0.40) in same format
Co-Authored-By: Claude Sonnet 5.5 <noreply@anthropic.com>
</commit_message>
<xml_diff>
--- a/outputs/pptx/puzzledata_repair_report.pptx
+++ b/outputs/pptx/puzzledata_repair_report.pptx
@@ -125,21 +125,21 @@
   <p:extLst>
     <p:ext uri="{521415D9-36F7-43E2-AB2F-B90AF26B5E84}">
       <p14:sectionLst xmlns:p14="http://schemas.microsoft.com/office/powerpoint/2010/main">
-        <p14:section name="Part 00 · 인트로" id="{2B6D37F4-683C-4C2C-8A8B-953A22F64977}">
+        <p14:section name="Part 00 · 인트로" id="{AA22609A-F208-4F01-B140-5395F6DEC4DA}">
           <p14:sldIdLst>
             <p14:sldId id="256"/>
             <p14:sldId id="257"/>
             <p14:sldId id="258"/>
           </p14:sldIdLst>
         </p14:section>
-        <p14:section name="Part 01 · 데이터 진단" id="{C18C3221-E0DE-448C-8F07-783B5007FBB9}">
+        <p14:section name="Part 01 · 데이터 진단" id="{323D56AF-A49C-491E-8E74-7203C2394003}">
           <p14:sldIdLst>
             <p14:sldId id="259"/>
             <p14:sldId id="260"/>
             <p14:sldId id="261"/>
           </p14:sldIdLst>
         </p14:section>
-        <p14:section name="Part 02 · 병목 규명" id="{F795C5FE-5BDB-45FF-BF94-F041C8FAAED5}">
+        <p14:section name="Part 02 · 병목 규명" id="{D60FC93A-5654-4E31-A589-5BF9DF757546}">
           <p14:sldIdLst>
             <p14:sldId id="262"/>
             <p14:sldId id="263"/>
@@ -152,14 +152,14 @@
             <p14:sldId id="270"/>
           </p14:sldIdLst>
         </p14:section>
-        <p14:section name="Part 03 · 개선 전략" id="{DFAB933C-6253-4103-B56F-60603A183D10}">
+        <p14:section name="Part 03 · 개선 전략" id="{284EFB3E-DCC6-471C-ABB5-52360ACB1CAD}">
           <p14:sldIdLst>
             <p14:sldId id="271"/>
             <p14:sldId id="272"/>
             <p14:sldId id="273"/>
           </p14:sldIdLst>
         </p14:section>
-        <p14:section name="Part 04 · Q&amp;A" id="{96239EB7-DC39-4DA5-B32F-E22616D2FD8C}">
+        <p14:section name="Part 04 · Q&amp;A" id="{79603B60-C421-4FD9-BFC9-BB037D6FB0DA}">
           <p14:sldIdLst>
             <p14:sldId id="274"/>
           </p14:sldIdLst>
@@ -5960,7 +5960,7 @@
         <p:spPr>
           <a:xfrm>
             <a:off x="5943600" y="1554480"/>
-            <a:ext cx="5745175" cy="1130892"/>
+            <a:ext cx="5745175" cy="1094994"/>
           </a:xfrm>
           <a:prstGeom prst="rect">
             <a:avLst/>
@@ -6005,8 +6005,8 @@
         </p:nvSpPr>
         <p:spPr>
           <a:xfrm>
-            <a:off x="6099048" y="1709928"/>
-            <a:ext cx="5434279" cy="158750"/>
+            <a:off x="6071616" y="1682496"/>
+            <a:ext cx="5489143" cy="158750"/>
           </a:xfrm>
           <a:prstGeom prst="rect">
             <a:avLst/>
@@ -6050,8 +6050,8 @@
         </p:nvSpPr>
         <p:spPr>
           <a:xfrm>
-            <a:off x="6099048" y="1923542"/>
-            <a:ext cx="5434279" cy="341630"/>
+            <a:off x="6071616" y="1896110"/>
+            <a:ext cx="5489143" cy="341630"/>
           </a:xfrm>
           <a:prstGeom prst="rect">
             <a:avLst/>
@@ -6095,8 +6095,8 @@
         </p:nvSpPr>
         <p:spPr>
           <a:xfrm>
-            <a:off x="6099048" y="2320036"/>
-            <a:ext cx="5434279" cy="195580"/>
+            <a:off x="6071616" y="2292604"/>
+            <a:ext cx="5489143" cy="195580"/>
           </a:xfrm>
           <a:prstGeom prst="rect">
             <a:avLst/>
@@ -6140,8 +6140,8 @@
         </p:nvSpPr>
         <p:spPr>
           <a:xfrm>
-            <a:off x="5943600" y="2795100"/>
-            <a:ext cx="5745175" cy="1130892"/>
+            <a:off x="5943600" y="2759202"/>
+            <a:ext cx="5745175" cy="1094994"/>
           </a:xfrm>
           <a:prstGeom prst="rect">
             <a:avLst/>
@@ -6186,8 +6186,8 @@
         </p:nvSpPr>
         <p:spPr>
           <a:xfrm>
-            <a:off x="6099048" y="2950548"/>
-            <a:ext cx="5434279" cy="158750"/>
+            <a:off x="6071616" y="2887218"/>
+            <a:ext cx="5489143" cy="158750"/>
           </a:xfrm>
           <a:prstGeom prst="rect">
             <a:avLst/>
@@ -6231,8 +6231,8 @@
         </p:nvSpPr>
         <p:spPr>
           <a:xfrm>
-            <a:off x="6099048" y="3164162"/>
-            <a:ext cx="5434279" cy="341630"/>
+            <a:off x="6071616" y="3100832"/>
+            <a:ext cx="5489143" cy="341630"/>
           </a:xfrm>
           <a:prstGeom prst="rect">
             <a:avLst/>
@@ -6276,8 +6276,8 @@
         </p:nvSpPr>
         <p:spPr>
           <a:xfrm>
-            <a:off x="6099048" y="3560656"/>
-            <a:ext cx="5434279" cy="195580"/>
+            <a:off x="6071616" y="3497326"/>
+            <a:ext cx="5489143" cy="195580"/>
           </a:xfrm>
           <a:prstGeom prst="rect">
             <a:avLst/>
@@ -6321,8 +6321,8 @@
         </p:nvSpPr>
         <p:spPr>
           <a:xfrm>
-            <a:off x="5943600" y="4035721"/>
-            <a:ext cx="5745175" cy="1130892"/>
+            <a:off x="5943600" y="3963924"/>
+            <a:ext cx="5745175" cy="1094994"/>
           </a:xfrm>
           <a:prstGeom prst="rect">
             <a:avLst/>
@@ -6367,8 +6367,8 @@
         </p:nvSpPr>
         <p:spPr>
           <a:xfrm>
-            <a:off x="6099048" y="4191169"/>
-            <a:ext cx="5434279" cy="158750"/>
+            <a:off x="6071616" y="4091939"/>
+            <a:ext cx="5489143" cy="158750"/>
           </a:xfrm>
           <a:prstGeom prst="rect">
             <a:avLst/>
@@ -6412,8 +6412,8 @@
         </p:nvSpPr>
         <p:spPr>
           <a:xfrm>
-            <a:off x="6099048" y="4404783"/>
-            <a:ext cx="5434279" cy="341630"/>
+            <a:off x="6071616" y="4305554"/>
+            <a:ext cx="5489143" cy="341630"/>
           </a:xfrm>
           <a:prstGeom prst="rect">
             <a:avLst/>
@@ -6457,8 +6457,8 @@
         </p:nvSpPr>
         <p:spPr>
           <a:xfrm>
-            <a:off x="6099048" y="4801277"/>
-            <a:ext cx="5434279" cy="195580"/>
+            <a:off x="6071616" y="4702048"/>
+            <a:ext cx="5489143" cy="195580"/>
           </a:xfrm>
           <a:prstGeom prst="rect">
             <a:avLst/>
@@ -6496,14 +6496,14 @@
       </p:sp>
       <p:sp>
         <p:nvSpPr>
-          <p:cNvPr id="24" name="read-card"/>
+          <p:cNvPr id="24" name="s4"/>
           <p:cNvSpPr/>
           <p:nvPr/>
         </p:nvSpPr>
         <p:spPr>
           <a:xfrm>
-            <a:off x="5943600" y="5294630"/>
-            <a:ext cx="5745175" cy="969010"/>
+            <a:off x="5943600" y="5168646"/>
+            <a:ext cx="5745175" cy="1094994"/>
           </a:xfrm>
           <a:prstGeom prst="rect">
             <a:avLst/>
@@ -6548,8 +6548,8 @@
         </p:nvSpPr>
         <p:spPr>
           <a:xfrm>
-            <a:off x="6099048" y="5450078"/>
-            <a:ext cx="5434279" cy="158750"/>
+            <a:off x="6071616" y="5296662"/>
+            <a:ext cx="5489143" cy="158750"/>
           </a:xfrm>
           <a:prstGeom prst="rect">
             <a:avLst/>
@@ -6580,95 +6580,97 @@
                 <a:ea typeface="맑은 고딕"/>
                 <a:cs typeface="Consolas"/>
               </a:rPr>
-              <a:t>READING</a:t>
-            </a:r>
-          </a:p>
-        </p:txBody>
-      </p:sp>
-      <p:sp>
-        <p:nvSpPr>
-          <p:cNvPr id="26" name="body:L2:rd"/>
-          <p:cNvSpPr txBox="1"/>
-          <p:nvPr/>
-        </p:nvSpPr>
-        <p:spPr>
-          <a:xfrm>
-            <a:off x="6099048" y="5663692"/>
-            <a:ext cx="5434279" cy="444500"/>
-          </a:xfrm>
-          <a:prstGeom prst="rect">
-            <a:avLst/>
-          </a:prstGeom>
-          <a:noFill/>
-        </p:spPr>
-        <p:txBody>
-          <a:bodyPr wrap="square" lIns="0" tIns="0" rIns="0" bIns="0" anchor="t">
-            <a:noAutofit/>
-          </a:bodyPr>
-          <a:lstStyle/>
-          <a:p>
-            <a:pPr algn="l">
-              <a:lnSpc>
-                <a:spcPts val="1750"/>
-              </a:lnSpc>
-              <a:spcBef>
-                <a:spcPts val="0"/>
-              </a:spcBef>
-              <a:buNone/>
-            </a:pPr>
-            <a:r>
-              <a:rPr lang="ko-KR" sz="1250" b="0" dirty="0">
-                <a:solidFill>
-                  <a:srgbClr val="0F172A"/>
-                </a:solidFill>
-                <a:latin typeface="맑은 고딕"/>
-                <a:ea typeface="맑은 고딕"/>
-                <a:cs typeface="맑은 고딕"/>
-              </a:rPr>
-              <a:t>교차 인계 ↔ 실시간 채널 </a:t>
-            </a:r>
-            <a:r>
-              <a:rPr lang="ko-KR" sz="1250" b="1" dirty="0">
+              <a:t>교차 인계 ↔ 실시간 채널</a:t>
+            </a:r>
+          </a:p>
+        </p:txBody>
+      </p:sp>
+      <p:sp>
+        <p:nvSpPr>
+          <p:cNvPr id="26" name="body:L1:d"/>
+          <p:cNvSpPr txBox="1"/>
+          <p:nvPr/>
+        </p:nvSpPr>
+        <p:spPr>
+          <a:xfrm>
+            <a:off x="6071616" y="5510276"/>
+            <a:ext cx="5489143" cy="341630"/>
+          </a:xfrm>
+          <a:prstGeom prst="rect">
+            <a:avLst/>
+          </a:prstGeom>
+          <a:noFill/>
+        </p:spPr>
+        <p:txBody>
+          <a:bodyPr wrap="square" lIns="0" tIns="0" rIns="0" bIns="0" anchor="t">
+            <a:noAutofit/>
+          </a:bodyPr>
+          <a:lstStyle/>
+          <a:p>
+            <a:pPr algn="l">
+              <a:lnSpc>
+                <a:spcPts val="2690"/>
+              </a:lnSpc>
+              <a:spcBef>
+                <a:spcPts val="0"/>
+              </a:spcBef>
+              <a:buNone/>
+            </a:pPr>
+            <a:r>
+              <a:rPr lang="ko-KR" sz="2400" b="1" dirty="0">
                 <a:solidFill>
                   <a:srgbClr val="2563EB"/>
                 </a:solidFill>
-                <a:latin typeface="맑은 고딕"/>
-                <a:ea typeface="맑은 고딕"/>
-                <a:cs typeface="맑은 고딕"/>
-              </a:rPr>
-              <a:t>r = −0.40 </a:t>
-            </a:r>
-            <a:r>
-              <a:rPr lang="ko-KR" sz="1250" b="0" dirty="0">
-                <a:solidFill>
-                  <a:srgbClr val="0F172A"/>
-                </a:solidFill>
-                <a:latin typeface="맑은 고딕"/>
-                <a:ea typeface="맑은 고딕"/>
-                <a:cs typeface="맑은 고딕"/>
-              </a:rPr>
-              <a:t>: 인계 123건 전부 웹·우편이라</a:t>
-            </a:r>
-            <a:br>
-              <a:rPr lang="ko-KR" sz="1250" b="0" dirty="0">
-                <a:solidFill>
-                  <a:srgbClr val="0F172A"/>
-                </a:solidFill>
-                <a:latin typeface="맑은 고딕"/>
-                <a:ea typeface="맑은 고딕"/>
-                <a:cs typeface="맑은 고딕"/>
-              </a:rPr>
-            </a:br>
-            <a:r>
-              <a:rPr lang="ko-KR" sz="1250" b="0" dirty="0">
-                <a:solidFill>
-                  <a:srgbClr val="0F172A"/>
-                </a:solidFill>
-                <a:latin typeface="맑은 고딕"/>
-                <a:ea typeface="맑은 고딕"/>
-                <a:cs typeface="맑은 고딕"/>
-              </a:rPr>
-              <a:t>두 변수가 얽힘 → 순수 효과는 다음 장 OLS로 분리</a:t>
+                <a:latin typeface="Consolas"/>
+                <a:ea typeface="맑은 고딕"/>
+                <a:cs typeface="Consolas"/>
+              </a:rPr>
+              <a:t>r = −0.40</a:t>
+            </a:r>
+          </a:p>
+        </p:txBody>
+      </p:sp>
+      <p:sp>
+        <p:nvSpPr>
+          <p:cNvPr id="27" name="body:L1:t"/>
+          <p:cNvSpPr txBox="1"/>
+          <p:nvPr/>
+        </p:nvSpPr>
+        <p:spPr>
+          <a:xfrm>
+            <a:off x="6071616" y="5906770"/>
+            <a:ext cx="5489143" cy="195580"/>
+          </a:xfrm>
+          <a:prstGeom prst="rect">
+            <a:avLst/>
+          </a:prstGeom>
+          <a:noFill/>
+        </p:spPr>
+        <p:txBody>
+          <a:bodyPr wrap="square" lIns="0" tIns="0" rIns="0" bIns="0" anchor="t">
+            <a:noAutofit/>
+          </a:bodyPr>
+          <a:lstStyle/>
+          <a:p>
+            <a:pPr algn="l">
+              <a:lnSpc>
+                <a:spcPts val="1540"/>
+              </a:lnSpc>
+              <a:spcBef>
+                <a:spcPts val="0"/>
+              </a:spcBef>
+              <a:buNone/>
+            </a:pPr>
+            <a:r>
+              <a:rPr lang="ko-KR" sz="1100" b="0" dirty="0">
+                <a:solidFill>
+                  <a:srgbClr val="334155"/>
+                </a:solidFill>
+                <a:latin typeface="맑은 고딕"/>
+                <a:ea typeface="맑은 고딕"/>
+                <a:cs typeface="맑은 고딕"/>
+              </a:rPr>
+              <a:t>인계 123건 전부 웹·우편 — 두 변수가 얽혀 OLS로 분리</a:t>
             </a:r>
           </a:p>
         </p:txBody>

</xml_diff>

<commit_message>
feat(deck): slide 11 title in terse noun style, drop coefficient values
Co-Authored-By: Claude Sonnet 5.5 <noreply@anthropic.com>
</commit_message>
<xml_diff>
--- a/outputs/pptx/puzzledata_repair_report.pptx
+++ b/outputs/pptx/puzzledata_repair_report.pptx
@@ -125,21 +125,21 @@
   <p:extLst>
     <p:ext uri="{521415D9-36F7-43E2-AB2F-B90AF26B5E84}">
       <p14:sectionLst xmlns:p14="http://schemas.microsoft.com/office/powerpoint/2010/main">
-        <p14:section name="Part 00 · 인트로" id="{AA22609A-F208-4F01-B140-5395F6DEC4DA}">
+        <p14:section name="Part 00 · 인트로" id="{EC94B381-A53D-4BCB-BEBF-AFEFB8092414}">
           <p14:sldIdLst>
             <p14:sldId id="256"/>
             <p14:sldId id="257"/>
             <p14:sldId id="258"/>
           </p14:sldIdLst>
         </p14:section>
-        <p14:section name="Part 01 · 데이터 진단" id="{323D56AF-A49C-491E-8E74-7203C2394003}">
+        <p14:section name="Part 01 · 데이터 진단" id="{AA976821-D92C-4607-89A0-DA0D5D606CEB}">
           <p14:sldIdLst>
             <p14:sldId id="259"/>
             <p14:sldId id="260"/>
             <p14:sldId id="261"/>
           </p14:sldIdLst>
         </p14:section>
-        <p14:section name="Part 02 · 병목 규명" id="{D60FC93A-5654-4E31-A589-5BF9DF757546}">
+        <p14:section name="Part 02 · 병목 규명" id="{23A1E3A2-BF61-478E-A426-D7F5FB103FC0}">
           <p14:sldIdLst>
             <p14:sldId id="262"/>
             <p14:sldId id="263"/>
@@ -152,14 +152,14 @@
             <p14:sldId id="270"/>
           </p14:sldIdLst>
         </p14:section>
-        <p14:section name="Part 03 · 개선 전략" id="{284EFB3E-DCC6-471C-ABB5-52360ACB1CAD}">
+        <p14:section name="Part 03 · 개선 전략" id="{44C1AEC0-1DEA-4511-98BF-679A9DCF6DF7}">
           <p14:sldIdLst>
             <p14:sldId id="271"/>
             <p14:sldId id="272"/>
             <p14:sldId id="273"/>
           </p14:sldIdLst>
         </p14:section>
-        <p14:section name="Part 04 · Q&amp;A" id="{79603B60-C421-4FD9-BFC9-BB037D6FB0DA}">
+        <p14:section name="Part 04 · Q&amp;A" id="{ED9CA1FA-E3C4-40C2-A7FD-F3B0082AE5EC}">
           <p14:sldIdLst>
             <p14:sldId id="274"/>
           </p14:sldIdLst>
@@ -6831,7 +6831,7 @@
                 <a:ea typeface="맑은 고딕"/>
                 <a:cs typeface="맑은 고딕"/>
               </a:rPr>
-              <a:t>접수 지연은 인계 +5.11h·채널 +2.62h가 설명한다</a:t>
+              <a:t>접수 지연 요인: 교차 인계·비실시간 채널, 물량은 무관</a:t>
             </a:r>
           </a:p>
         </p:txBody>

</xml_diff>

<commit_message>
feat(deck): slide 12 title prefixed 현장 지연 요인, takeaway split into two lines
Co-Authored-By: Claude Sonnet 5.5 <noreply@anthropic.com>
</commit_message>
<xml_diff>
--- a/outputs/pptx/puzzledata_repair_report.pptx
+++ b/outputs/pptx/puzzledata_repair_report.pptx
@@ -125,21 +125,21 @@
   <p:extLst>
     <p:ext uri="{521415D9-36F7-43E2-AB2F-B90AF26B5E84}">
       <p14:sectionLst xmlns:p14="http://schemas.microsoft.com/office/powerpoint/2010/main">
-        <p14:section name="Part 00 · 인트로" id="{EC94B381-A53D-4BCB-BEBF-AFEFB8092414}">
+        <p14:section name="Part 00 · 인트로" id="{E148C069-723C-4522-B470-ADA9A32F46CC}">
           <p14:sldIdLst>
             <p14:sldId id="256"/>
             <p14:sldId id="257"/>
             <p14:sldId id="258"/>
           </p14:sldIdLst>
         </p14:section>
-        <p14:section name="Part 01 · 데이터 진단" id="{AA976821-D92C-4607-89A0-DA0D5D606CEB}">
+        <p14:section name="Part 01 · 데이터 진단" id="{F1429599-D794-4CFA-A88A-3C8B0D642B0C}">
           <p14:sldIdLst>
             <p14:sldId id="259"/>
             <p14:sldId id="260"/>
             <p14:sldId id="261"/>
           </p14:sldIdLst>
         </p14:section>
-        <p14:section name="Part 02 · 병목 규명" id="{23A1E3A2-BF61-478E-A426-D7F5FB103FC0}">
+        <p14:section name="Part 02 · 병목 규명" id="{2900711E-1604-408C-BC53-8155C3418774}">
           <p14:sldIdLst>
             <p14:sldId id="262"/>
             <p14:sldId id="263"/>
@@ -152,14 +152,14 @@
             <p14:sldId id="270"/>
           </p14:sldIdLst>
         </p14:section>
-        <p14:section name="Part 03 · 개선 전략" id="{44C1AEC0-1DEA-4511-98BF-679A9DCF6DF7}">
+        <p14:section name="Part 03 · 개선 전략" id="{1872D554-D509-4A79-BB5D-41A0537B3F0B}">
           <p14:sldIdLst>
             <p14:sldId id="271"/>
             <p14:sldId id="272"/>
             <p14:sldId id="273"/>
           </p14:sldIdLst>
         </p14:section>
-        <p14:section name="Part 04 · Q&amp;A" id="{ED9CA1FA-E3C4-40C2-A7FD-F3B0082AE5EC}">
+        <p14:section name="Part 04 · Q&amp;A" id="{3AB5763D-3C22-40A9-92D4-B8AA18CD599F}">
           <p14:sldIdLst>
             <p14:sldId id="274"/>
           </p14:sldIdLst>
@@ -7974,7 +7974,7 @@
                 <a:ea typeface="맑은 고딕"/>
                 <a:cs typeface="맑은 고딕"/>
               </a:rPr>
-              <a:t>현장 98.3h 중 실사 방문 대기가 78.2%</a:t>
+              <a:t>현장 지연 요인: 현장 98.3h 중 실사 방문 대기 78.2%</a:t>
             </a:r>
           </a:p>
         </p:txBody>
@@ -9703,9 +9703,20 @@
                 <a:ea typeface="맑은 고딕"/>
                 <a:cs typeface="맑은 고딕"/>
               </a:rPr>
-              <a:t>. 병목은 기사의</a:t>
-            </a:r>
-            <a:br>
+              <a:t>.</a:t>
+            </a:r>
+          </a:p>
+          <a:p>
+            <a:pPr algn="l">
+              <a:lnSpc>
+                <a:spcPts val="2100"/>
+              </a:lnSpc>
+              <a:spcBef>
+                <a:spcPts val="0"/>
+              </a:spcBef>
+              <a:buNone/>
+            </a:pPr>
+            <a:r>
               <a:rPr lang="ko-KR" sz="1500" b="0" dirty="0">
                 <a:solidFill>
                   <a:srgbClr val="0F172A"/>
@@ -9714,17 +9725,7 @@
                 <a:ea typeface="맑은 고딕"/>
                 <a:cs typeface="맑은 고딕"/>
               </a:rPr>
-            </a:br>
-            <a:r>
-              <a:rPr lang="ko-KR" sz="1500" b="0" dirty="0">
-                <a:solidFill>
-                  <a:srgbClr val="0F172A"/>
-                </a:solidFill>
-                <a:latin typeface="맑은 고딕"/>
-                <a:ea typeface="맑은 고딕"/>
-                <a:cs typeface="맑은 고딕"/>
-              </a:rPr>
-              <a:t>작업 속도가 아니라 방문 전 대기 관리다.</a:t>
+              <a:t>병목은 기사의 작업 속도가 아니라 방문 전 대기 관리다.</a:t>
             </a:r>
           </a:p>
         </p:txBody>

</xml_diff>

<commit_message>
feat(deck): slide 13 title 'Wait 1 원인', takeaway reworded as structure (no blame on field staff)
Co-Authored-By: Claude Sonnet 5.5 <noreply@anthropic.com>
</commit_message>
<xml_diff>
--- a/outputs/pptx/puzzledata_repair_report.pptx
+++ b/outputs/pptx/puzzledata_repair_report.pptx
@@ -125,21 +125,21 @@
   <p:extLst>
     <p:ext uri="{521415D9-36F7-43E2-AB2F-B90AF26B5E84}">
       <p14:sectionLst xmlns:p14="http://schemas.microsoft.com/office/powerpoint/2010/main">
-        <p14:section name="Part 00 · 인트로" id="{E148C069-723C-4522-B470-ADA9A32F46CC}">
+        <p14:section name="Part 00 · 인트로" id="{D346187E-FA92-4EB2-AE61-2D2EB8080ADA}">
           <p14:sldIdLst>
             <p14:sldId id="256"/>
             <p14:sldId id="257"/>
             <p14:sldId id="258"/>
           </p14:sldIdLst>
         </p14:section>
-        <p14:section name="Part 01 · 데이터 진단" id="{F1429599-D794-4CFA-A88A-3C8B0D642B0C}">
+        <p14:section name="Part 01 · 데이터 진단" id="{E2F4C78C-AF02-41B6-B917-FD6AF9F09C36}">
           <p14:sldIdLst>
             <p14:sldId id="259"/>
             <p14:sldId id="260"/>
             <p14:sldId id="261"/>
           </p14:sldIdLst>
         </p14:section>
-        <p14:section name="Part 02 · 병목 규명" id="{2900711E-1604-408C-BC53-8155C3418774}">
+        <p14:section name="Part 02 · 병목 규명" id="{7F577E21-7590-4D6B-8695-B6A0DBB88FC1}">
           <p14:sldIdLst>
             <p14:sldId id="262"/>
             <p14:sldId id="263"/>
@@ -152,14 +152,14 @@
             <p14:sldId id="270"/>
           </p14:sldIdLst>
         </p14:section>
-        <p14:section name="Part 03 · 개선 전략" id="{1872D554-D509-4A79-BB5D-41A0537B3F0B}">
+        <p14:section name="Part 03 · 개선 전략" id="{F40EA0A3-15FA-4C05-A1AA-42F9D20DFC16}">
           <p14:sldIdLst>
             <p14:sldId id="271"/>
             <p14:sldId id="272"/>
             <p14:sldId id="273"/>
           </p14:sldIdLst>
         </p14:section>
-        <p14:section name="Part 04 · Q&amp;A" id="{3AB5763D-3C22-40A9-92D4-B8AA18CD599F}">
+        <p14:section name="Part 04 · Q&amp;A" id="{B38C0CA1-BA30-458E-A4C8-D856088C1BC7}">
           <p14:sldIdLst>
             <p14:sldId id="274"/>
           </p14:sldIdLst>
@@ -9886,7 +9886,7 @@
                 <a:ea typeface="맑은 고딕"/>
                 <a:cs typeface="맑은 고딕"/>
               </a:rPr>
-              <a:t>일 유입 134.3건 vs CAPA 68.0건, 적체 403건</a:t>
+              <a:t>Wait 1 원인: 일 유입 134.3건 vs CAPA 68.0건, 최대 적체 물량 403건</a:t>
             </a:r>
           </a:p>
         </p:txBody>
@@ -10816,6 +10816,17 @@
               <a:buNone/>
             </a:pPr>
             <a:r>
+              <a:rPr lang="ko-KR" sz="1300" b="1" dirty="0">
+                <a:solidFill>
+                  <a:srgbClr val="E11D48"/>
+                </a:solidFill>
+                <a:latin typeface="맑은 고딕"/>
+                <a:ea typeface="맑은 고딕"/>
+                <a:cs typeface="맑은 고딕"/>
+              </a:rPr>
+              <a:t>유입이 실사 처리 용량(CAPA)을 넘는 구조</a:t>
+            </a:r>
+            <a:r>
               <a:rPr lang="ko-KR" sz="1300" b="0" dirty="0">
                 <a:solidFill>
                   <a:srgbClr val="0F172A"/>
@@ -10824,29 +10835,7 @@
                 <a:ea typeface="맑은 고딕"/>
                 <a:cs typeface="맑은 고딕"/>
               </a:rPr>
-              <a:t>기사가 느린 것이 아니라 </a:t>
-            </a:r>
-            <a:r>
-              <a:rPr lang="ko-KR" sz="1300" b="1" dirty="0">
-                <a:solidFill>
-                  <a:srgbClr val="E11D48"/>
-                </a:solidFill>
-                <a:latin typeface="맑은 고딕"/>
-                <a:ea typeface="맑은 고딕"/>
-                <a:cs typeface="맑은 고딕"/>
-              </a:rPr>
-              <a:t>실사 처리 용량(CAPA)을 넘는 유입</a:t>
-            </a:r>
-            <a:r>
-              <a:rPr lang="ko-KR" sz="1300" b="0" dirty="0">
-                <a:solidFill>
-                  <a:srgbClr val="0F172A"/>
-                </a:solidFill>
-                <a:latin typeface="맑은 고딕"/>
-                <a:ea typeface="맑은 고딕"/>
-                <a:cs typeface="맑은 고딕"/>
-              </a:rPr>
-              <a:t>이 적체와 76.8h 대기를 만든다 — 하루 약 66.3건씩 누적.</a:t>
+              <a:t>가 적체와 76.8h 대기의 원인 — 초과분이 하루 약 66.3건씩 누적</a:t>
             </a:r>
           </a:p>
         </p:txBody>

</xml_diff>

<commit_message>
feat(deck): slide 14 title 'Wait 2 요인', replace 하자 wording with 재수리 (chart re-rendered label-only, form unchanged)
Co-Authored-By: Claude Sonnet 5.5 <noreply@anthropic.com>
</commit_message>
<xml_diff>
--- a/outputs/pptx/puzzledata_repair_report.pptx
+++ b/outputs/pptx/puzzledata_repair_report.pptx
@@ -125,21 +125,21 @@
   <p:extLst>
     <p:ext uri="{521415D9-36F7-43E2-AB2F-B90AF26B5E84}">
       <p14:sectionLst xmlns:p14="http://schemas.microsoft.com/office/powerpoint/2010/main">
-        <p14:section name="Part 00 · 인트로" id="{D346187E-FA92-4EB2-AE61-2D2EB8080ADA}">
+        <p14:section name="Part 00 · 인트로" id="{15FF8129-596D-447A-8EB2-3562A6A78E57}">
           <p14:sldIdLst>
             <p14:sldId id="256"/>
             <p14:sldId id="257"/>
             <p14:sldId id="258"/>
           </p14:sldIdLst>
         </p14:section>
-        <p14:section name="Part 01 · 데이터 진단" id="{E2F4C78C-AF02-41B6-B917-FD6AF9F09C36}">
+        <p14:section name="Part 01 · 데이터 진단" id="{18B56A2E-B679-461C-8EBE-704CA83635DA}">
           <p14:sldIdLst>
             <p14:sldId id="259"/>
             <p14:sldId id="260"/>
             <p14:sldId id="261"/>
           </p14:sldIdLst>
         </p14:section>
-        <p14:section name="Part 02 · 병목 규명" id="{7F577E21-7590-4D6B-8695-B6A0DBB88FC1}">
+        <p14:section name="Part 02 · 병목 규명" id="{42929E4A-0720-452F-86C1-5E7000B27188}">
           <p14:sldIdLst>
             <p14:sldId id="262"/>
             <p14:sldId id="263"/>
@@ -152,14 +152,14 @@
             <p14:sldId id="270"/>
           </p14:sldIdLst>
         </p14:section>
-        <p14:section name="Part 03 · 개선 전략" id="{F40EA0A3-15FA-4C05-A1AA-42F9D20DFC16}">
+        <p14:section name="Part 03 · 개선 전략" id="{D3389275-F3EF-4E39-9E65-2176D8BAB50C}">
           <p14:sldIdLst>
             <p14:sldId id="271"/>
             <p14:sldId id="272"/>
             <p14:sldId id="273"/>
           </p14:sldIdLst>
         </p14:section>
-        <p14:section name="Part 04 · Q&amp;A" id="{B38C0CA1-BA30-458E-A4C8-D856088C1BC7}">
+        <p14:section name="Part 04 · Q&amp;A" id="{B9EE34E9-8740-49D4-8628-704CE13D4DA8}">
           <p14:sldIdLst>
             <p14:sldId id="274"/>
           </p14:sldIdLst>
@@ -915,7 +915,7 @@
           <a:lstStyle/>
           <a:p>
             <a:r>
-              <a:t>다음 병목은 수리 착수 단계입니다. 즉시수리와 외주수리는 착수 대기가 0.0시간인데, 사내수리 485건만 부품 조달과 일정 조율로 평균 30.5시간을 기다립니다. 또 사내수리 후 하자로 재방문한 26건은 부품을 다시 조달하느라 평균 32.9시간, 최대 241.6시간(10.1일)을 더 기다렸고, 이 케이스들의 평균 총 리드타임은 171.6시간입니다. 재방문 26건 중 22건(84.6%)이 E-1·E-2 코드에 집중되어 있습니다.</a:t>
+              <a:t>다음 병목은 수리 착수 단계입니다. 즉시수리와 외주수리는 착수 대기가 0.0시간인데, 사내수리 485건만 부품 조달과 일정 조율로 평균 30.5시간을 기다립니다. 또 사내수리 후 재수리가 이어진 26건은 1차 수리 완료 뒤 재수리 착수까지 평균 32.9시간, 최대 241.6시간(10.1일)을 더 기다렸고, 이 케이스들의 평균 총 리드타임은 171.6시간입니다. 재수리 26건 중 22건(84.6%)이 E-1·E-2 코드에 집중되어 있습니다.</a:t>
             </a:r>
           </a:p>
         </p:txBody>
@@ -10996,7 +10996,7 @@
                 <a:ea typeface="맑은 고딕"/>
                 <a:cs typeface="맑은 고딕"/>
               </a:rPr>
-              <a:t>사내수리는 자재 30.5h, 하자는 +32.9h 지연</a:t>
+              <a:t>Wait 2 요인: 사내수리는 자재 조달 30.5h, 재수리 시 +32.9h 지연</a:t>
             </a:r>
           </a:p>
         </p:txBody>
@@ -11041,7 +11041,7 @@
                 <a:ea typeface="맑은 고딕"/>
                 <a:cs typeface="맑은 고딕"/>
               </a:rPr>
-              <a:t>사내 하자 재방문 26건은 평균 총 리드타임 171.6h — 전체 평균의 1.6배</a:t>
+              <a:t>사내 재수리 26건은 평균 총 리드타임 171.6h — 전체 평균의 1.6배</a:t>
             </a:r>
           </a:p>
         </p:txBody>
@@ -11243,7 +11243,7 @@
                 <a:ea typeface="맑은 고딕"/>
                 <a:cs typeface="Consolas"/>
               </a:rPr>
-              <a:t>FIG.13 · 수리 방식별 착수 대기와 하자 재방문 루프</a:t>
+              <a:t>FIG.13 · 수리 방식별 착수 대기와 사내 재수리 루프</a:t>
             </a:r>
           </a:p>
         </p:txBody>
@@ -11550,7 +11550,7 @@
                 <a:ea typeface="맑은 고딕"/>
                 <a:cs typeface="Consolas"/>
               </a:rPr>
-              <a:t>사내 하자 재방문</a:t>
+              <a:t>사내 재수리</a:t>
             </a:r>
           </a:p>
         </p:txBody>
@@ -11934,7 +11934,7 @@
                 <a:ea typeface="맑은 고딕"/>
                 <a:cs typeface="맑은 고딕"/>
               </a:rPr>
-              <a:t>1차 수리 실패 뒤 부품을 다시 조달하는 동안 </a:t>
+              <a:t>1차 수리 완료 뒤 재수리 착수까지 </a:t>
             </a:r>
             <a:r>
               <a:rPr lang="ko-KR" sz="1250" b="1" dirty="0">
@@ -23491,7 +23491,7 @@
                 <a:ea typeface="맑은 고딕"/>
                 <a:cs typeface="맑은 고딕"/>
               </a:rPr>
-              <a:t>하자 재방문 +32.9h</a:t>
+              <a:t>재수리 시 +32.9h</a:t>
             </a:r>
           </a:p>
         </p:txBody>

</xml_diff>

<commit_message>
feat(deck): slide 15 title in terse style (실사 방문 대기 >> 사내수리 배정)
Co-Authored-By: Claude Sonnet 5.5 <noreply@anthropic.com>
</commit_message>
<xml_diff>
--- a/outputs/pptx/puzzledata_repair_report.pptx
+++ b/outputs/pptx/puzzledata_repair_report.pptx
@@ -125,21 +125,21 @@
   <p:extLst>
     <p:ext uri="{521415D9-36F7-43E2-AB2F-B90AF26B5E84}">
       <p14:sectionLst xmlns:p14="http://schemas.microsoft.com/office/powerpoint/2010/main">
-        <p14:section name="Part 00 · 인트로" id="{15FF8129-596D-447A-8EB2-3562A6A78E57}">
+        <p14:section name="Part 00 · 인트로" id="{FE945AEC-EE9A-4EFC-BBE3-A5EB5685A2FE}">
           <p14:sldIdLst>
             <p14:sldId id="256"/>
             <p14:sldId id="257"/>
             <p14:sldId id="258"/>
           </p14:sldIdLst>
         </p14:section>
-        <p14:section name="Part 01 · 데이터 진단" id="{18B56A2E-B679-461C-8EBE-704CA83635DA}">
+        <p14:section name="Part 01 · 데이터 진단" id="{200D1B22-6249-45A4-A4BB-4B9382D38ECB}">
           <p14:sldIdLst>
             <p14:sldId id="259"/>
             <p14:sldId id="260"/>
             <p14:sldId id="261"/>
           </p14:sldIdLst>
         </p14:section>
-        <p14:section name="Part 02 · 병목 규명" id="{42929E4A-0720-452F-86C1-5E7000B27188}">
+        <p14:section name="Part 02 · 병목 규명" id="{117D2AA4-0B94-49CD-9492-106BED019940}">
           <p14:sldIdLst>
             <p14:sldId id="262"/>
             <p14:sldId id="263"/>
@@ -152,14 +152,14 @@
             <p14:sldId id="270"/>
           </p14:sldIdLst>
         </p14:section>
-        <p14:section name="Part 03 · 개선 전략" id="{D3389275-F3EF-4E39-9E65-2176D8BAB50C}">
+        <p14:section name="Part 03 · 개선 전략" id="{1A4B5F4D-D751-4B90-8207-9B33191630EE}">
           <p14:sldIdLst>
             <p14:sldId id="271"/>
             <p14:sldId id="272"/>
             <p14:sldId id="273"/>
           </p14:sldIdLst>
         </p14:section>
-        <p14:section name="Part 04 · Q&amp;A" id="{B9EE34E9-8740-49D4-8628-704CE13D4DA8}">
+        <p14:section name="Part 04 · Q&amp;A" id="{8033193F-C116-4139-B508-D75AD5EAB848}">
           <p14:sldIdLst>
             <p14:sldId id="274"/>
           </p14:sldIdLst>
@@ -12139,7 +12139,7 @@
                 <a:ea typeface="맑은 고딕"/>
                 <a:cs typeface="맑은 고딕"/>
               </a:rPr>
-              <a:t>소요시간은 실사 지연과 사내수리가 좌우한다</a:t>
+              <a:t>E2E 리드타임 영향 요인: 실사 방문 대기 ≫ 사내수리 배정</a:t>
             </a:r>
           </a:p>
         </p:txBody>

</xml_diff>

<commit_message>
feat(deck): slide 15 takeaway split into two lines
Co-Authored-By: Claude Sonnet 5.5 <noreply@anthropic.com>
</commit_message>
<xml_diff>
--- a/outputs/pptx/puzzledata_repair_report.pptx
+++ b/outputs/pptx/puzzledata_repair_report.pptx
@@ -125,21 +125,21 @@
   <p:extLst>
     <p:ext uri="{521415D9-36F7-43E2-AB2F-B90AF26B5E84}">
       <p14:sectionLst xmlns:p14="http://schemas.microsoft.com/office/powerpoint/2010/main">
-        <p14:section name="Part 00 · 인트로" id="{FE945AEC-EE9A-4EFC-BBE3-A5EB5685A2FE}">
+        <p14:section name="Part 00 · 인트로" id="{5938FC4C-9F6C-4D6E-9FE3-A8DA88263294}">
           <p14:sldIdLst>
             <p14:sldId id="256"/>
             <p14:sldId id="257"/>
             <p14:sldId id="258"/>
           </p14:sldIdLst>
         </p14:section>
-        <p14:section name="Part 01 · 데이터 진단" id="{200D1B22-6249-45A4-A4BB-4B9382D38ECB}">
+        <p14:section name="Part 01 · 데이터 진단" id="{CA08B98D-F04A-4FF8-BA9E-4BBF6887B13E}">
           <p14:sldIdLst>
             <p14:sldId id="259"/>
             <p14:sldId id="260"/>
             <p14:sldId id="261"/>
           </p14:sldIdLst>
         </p14:section>
-        <p14:section name="Part 02 · 병목 규명" id="{117D2AA4-0B94-49CD-9492-106BED019940}">
+        <p14:section name="Part 02 · 병목 규명" id="{18958A11-AC04-4D51-BAE6-417351AD8265}">
           <p14:sldIdLst>
             <p14:sldId id="262"/>
             <p14:sldId id="263"/>
@@ -152,14 +152,14 @@
             <p14:sldId id="270"/>
           </p14:sldIdLst>
         </p14:section>
-        <p14:section name="Part 03 · 개선 전략" id="{1A4B5F4D-D751-4B90-8207-9B33191630EE}">
+        <p14:section name="Part 03 · 개선 전략" id="{0E2B13D8-1B53-4948-B1F2-08EBD771A899}">
           <p14:sldIdLst>
             <p14:sldId id="271"/>
             <p14:sldId id="272"/>
             <p14:sldId id="273"/>
           </p14:sldIdLst>
         </p14:section>
-        <p14:section name="Part 04 · Q&amp;A" id="{8033193F-C116-4139-B508-D75AD5EAB848}">
+        <p14:section name="Part 04 · Q&amp;A" id="{F2DE2154-91EB-4770-B665-B357A2737380}">
           <p14:sldIdLst>
             <p14:sldId id="274"/>
           </p14:sldIdLst>
@@ -13099,9 +13099,20 @@
                 <a:ea typeface="맑은 고딕"/>
                 <a:cs typeface="맑은 고딕"/>
               </a:rPr>
-              <a:t>(1.12 × 76.8h)가 사내수리 16.6h(31.75 × 52.3%)보다</a:t>
-            </a:r>
-            <a:br>
+              <a:t>(1.12 × 76.8h)가 사내수리 16.6h(31.75 × 52.3%)보다 훨씬 크다.</a:t>
+            </a:r>
+          </a:p>
+          <a:p>
+            <a:pPr algn="l">
+              <a:lnSpc>
+                <a:spcPts val="1750"/>
+              </a:lnSpc>
+              <a:spcBef>
+                <a:spcPts val="0"/>
+              </a:spcBef>
+              <a:buNone/>
+            </a:pPr>
+            <a:r>
               <a:rPr lang="ko-KR" sz="1250" b="0" dirty="0">
                 <a:solidFill>
                   <a:srgbClr val="0F172A"/>
@@ -13110,17 +13121,7 @@
                 <a:ea typeface="맑은 고딕"/>
                 <a:cs typeface="맑은 고딕"/>
               </a:rPr>
-            </a:br>
-            <a:r>
-              <a:rPr lang="ko-KR" sz="1250" b="0" dirty="0">
-                <a:solidFill>
-                  <a:srgbClr val="0F172A"/>
-                </a:solidFill>
-                <a:latin typeface="맑은 고딕"/>
-                <a:ea typeface="맑은 고딕"/>
-                <a:cs typeface="맑은 고딕"/>
-              </a:rPr>
-              <a:t>훨씬 크다. 2차 에스컬레이션(+5.96h)은 p = 0.079로 비유의.</a:t>
+              <a:t>2차 에스컬레이션(+5.96h)은 p = 0.079로 비유의.</a:t>
             </a:r>
           </a:p>
         </p:txBody>

</xml_diff>

<commit_message>
feat(deck): slide 16 match criterion made explicit (E->intern 100%, P->immediate 83.1%), donut relabeled form-preserving, notes with criterion Q&A
Co-Authored-By: Claude Sonnet 5.5 <noreply@anthropic.com>
</commit_message>
<xml_diff>
--- a/outputs/pptx/puzzledata_repair_report.pptx
+++ b/outputs/pptx/puzzledata_repair_report.pptx
@@ -125,21 +125,21 @@
   <p:extLst>
     <p:ext uri="{521415D9-36F7-43E2-AB2F-B90AF26B5E84}">
       <p14:sectionLst xmlns:p14="http://schemas.microsoft.com/office/powerpoint/2010/main">
-        <p14:section name="Part 00 · 인트로" id="{5938FC4C-9F6C-4D6E-9FE3-A8DA88263294}">
+        <p14:section name="Part 00 · 인트로" id="{E47DA3FD-E6AB-48E7-8024-2C7C8BB6A245}">
           <p14:sldIdLst>
             <p14:sldId id="256"/>
             <p14:sldId id="257"/>
             <p14:sldId id="258"/>
           </p14:sldIdLst>
         </p14:section>
-        <p14:section name="Part 01 · 데이터 진단" id="{CA08B98D-F04A-4FF8-BA9E-4BBF6887B13E}">
+        <p14:section name="Part 01 · 데이터 진단" id="{EA3329E9-E6FC-45A3-BF08-556EED43FBE3}">
           <p14:sldIdLst>
             <p14:sldId id="259"/>
             <p14:sldId id="260"/>
             <p14:sldId id="261"/>
           </p14:sldIdLst>
         </p14:section>
-        <p14:section name="Part 02 · 병목 규명" id="{18958A11-AC04-4D51-BAE6-417351AD8265}">
+        <p14:section name="Part 02 · 병목 규명" id="{9D96DDD9-3D6F-4F39-B77A-418A02803AC7}">
           <p14:sldIdLst>
             <p14:sldId id="262"/>
             <p14:sldId id="263"/>
@@ -152,14 +152,14 @@
             <p14:sldId id="270"/>
           </p14:sldIdLst>
         </p14:section>
-        <p14:section name="Part 03 · 개선 전략" id="{0E2B13D8-1B53-4948-B1F2-08EBD771A899}">
+        <p14:section name="Part 03 · 개선 전략" id="{BDFE8A19-D9CD-478C-A21A-3C311B3EA882}">
           <p14:sldIdLst>
             <p14:sldId id="271"/>
             <p14:sldId id="272"/>
             <p14:sldId id="273"/>
           </p14:sldIdLst>
         </p14:section>
-        <p14:section name="Part 04 · Q&amp;A" id="{F2DE2154-91EB-4770-B665-B357A2737380}">
+        <p14:section name="Part 04 · Q&amp;A" id="{9C4331D8-B396-4DEC-8642-B76EB75B503A}">
           <p14:sldIdLst>
             <p14:sldId id="274"/>
           </p14:sldIdLst>
@@ -1055,7 +1055,7 @@
           <a:lstStyle/>
           <a:p>
             <a:r>
-              <a:t>접수원의 사전 분류는 이미 현장 결과와 83.2~87.3% 일치합니다. 그런데도 모든 건이 방문 실사를 거치는 이유는 정보 해상도 단절입니다. 접수는 B·P·E 알파벳만 수집하고, 현장은 약 40.5분 실사 후 1~4 세부 코드를 판정합니다. 그 결과 채널이 달라도 실사로 가는 줄은 하나입니다. 채널별 실사 대기는 70.1~80.4시간으로 통계적으로 차이가 없습니다(Kruskal p=0.64). 이 한 줄에서 즉시 수리 건(접수 코드 P-1·3, 365건)을 따로 빼자는 것이 제안입니다. 즉시 수리는 건수로는 39.4%이지만, 실사를 시작하면 기사가 수리까지 연속으로 맡아 큐 점유시간은 73.3%입니다(건당 2.75시간, 나머지 0.65시간). 실사에서 수리 착수까지 간격은 0.00시간이고 같은 기사가 100.0% 맡았습니다. 고속도로로 비유하면 큐를 오래 점유하는 화물차만 따로 빼자는 것입니다. [정정] 87.3%는 E+P 전체를 포함한 낙관 상한이고, 외주 전환 위험 P-4(38건)를 뺀 보수 기준은 83.2%입니다. [예상 질문] B형은? → B형 118건은 이미 실사 대기가 평균 0.1시간으로 큐를 사실상 우회하고 있어 분리 대상에서 뺐습니다.</a:t>
+              <a:t>접수원의 사전 분류는 이미 현장 결과와 83.2~87.3% 일치합니다. 그런데도 모든 건이 방문 실사를 거치는 이유는 정보 해상도 단절입니다. 접수는 B·P·E 알파벳만 수집하고, 현장은 약 40.5분 실사 후 1~4 세부 코드를 판정합니다. 그 결과 채널이 달라도 실사로 가는 줄은 하나입니다. 채널별 실사 대기는 70.1~80.4시간으로 통계적으로 차이가 없습니다(Kruskal p=0.64). 이 한 줄에서 즉시 수리 건(접수 코드 P-1·3, 365건)을 따로 빼자는 것이 제안입니다. 즉시 수리는 건수로는 39.4%이지만, 실사를 시작하면 기사가 수리까지 연속으로 맡아 큐 점유시간은 73.3%입니다(건당 2.75시간, 나머지 0.65시간). 실사에서 수리 착수까지 간격은 0.00시간이고 같은 기사가 100.0% 맡았습니다. 고속도로로 비유하면 큐를 오래 점유하는 화물차만 따로 빼자는 것입니다. [적중 기준] 비교 대상은 세부코드가 아니라 접수 알파벳(B·P·E)과 실제 1차 수리 방식입니다. 세부코드 1~4는 현장 실사 후 판정되는 값이라 접수 시점에는 없습니다. E형 370건은 전부 사내수리(100.0%), P형 439건 중 즉시수리는 365건(83.1%)이며 즉시수리 기저율 41.3%의 약 2.0배입니다. 즉시수리 383건 중 P가 잡아낸 비율은 95.3%입니다(놓친 건은 B-1). [정정] 도넛의 87.3%는 E·P로 분류된 비율(809/927건)이지 예측 정확도가 아닙니다. 사내 완결(즉시·사내) 기준으로 외주 P-4(38건)를 빼면 83.2%(771건)지만, 아무 건이나 사내 완결로 찍어도 93.6%라 변별력이 약해 근거로 쓰지 않습니다. 엄격 기준(E→사내, P→즉시)의 일치는 E·P 기준 90.9%, 전체 기준 79.3%(735건)입니다. 주의: 사내 완결 83.2%(전체 기준)와 P 즉시 83.1%(P 기준)는 서로 다른 값입니다. [예상 질문] 알파벳 P·E·B의 의미는? → 원천에 정의서가 없어 실측 수리 방식 분포로 해석했습니다(E 전량 사내, P 대부분 즉시, B 혼합). 세부코드는 (알파벳, 코드) 조합마다 수리 방식이 하나로 정해져 사후 라벨일 수 있어 접수 시점 취득 가능성은 가정입니다. [예상 질문] B형은? → B형 118건은 이미 실사 대기가 평균 0.1시간으로 큐를 사실상 우회하고 있어 분리 대상에서 뺐습니다.</a:t>
             </a:r>
           </a:p>
         </p:txBody>
@@ -13327,7 +13327,7 @@
                 <a:ea typeface="맑은 고딕"/>
                 <a:cs typeface="맑은 고딕"/>
               </a:rPr>
-              <a:t>접수 사전 분류가 이미 현장과 83.2~87.3% 일치하는데도 모든 건이 실사 큐 한 줄에 선다</a:t>
+              <a:t>접수 알파벳 분류가 실제 수리 방식과 맞는데도(E→사내 100.0%, P→즉시 83.1%) 모든 건이 실사 큐 한 줄에 선다</a:t>
             </a:r>
           </a:p>
         </p:txBody>
@@ -13452,7 +13452,7 @@
         <p:spPr>
           <a:xfrm>
             <a:off x="502920" y="1554480"/>
-            <a:ext cx="3606698" cy="3729482"/>
+            <a:ext cx="3606698" cy="3709162"/>
           </a:xfrm>
           <a:prstGeom prst="rect">
             <a:avLst/>
@@ -13595,8 +13595,8 @@
         </p:blipFill>
         <p:spPr>
           <a:xfrm>
-            <a:off x="1082300" y="2290826"/>
-            <a:ext cx="2447937" cy="1965960"/>
+            <a:off x="942226" y="2290826"/>
+            <a:ext cx="2728085" cy="1737360"/>
           </a:xfrm>
           <a:prstGeom prst="rect">
             <a:avLst/>
@@ -13605,48 +13605,59 @@
       </p:pic>
       <p:sp>
         <p:nvSpPr>
-          <p:cNvPr id="13" name="body:L1:n"/>
-          <p:cNvSpPr txBox="1"/>
-          <p:nvPr/>
-        </p:nvSpPr>
-        <p:spPr>
-          <a:xfrm>
-            <a:off x="685800" y="4320794"/>
-            <a:ext cx="3240938" cy="511810"/>
-          </a:xfrm>
-          <a:prstGeom prst="rect">
-            <a:avLst/>
-          </a:prstGeom>
-          <a:noFill/>
-        </p:spPr>
-        <p:txBody>
-          <a:bodyPr wrap="square" lIns="0" tIns="0" rIns="0" bIns="0" anchor="t">
-            <a:noAutofit/>
-          </a:bodyPr>
-          <a:lstStyle/>
-          <a:p>
-            <a:pPr algn="l">
-              <a:lnSpc>
-                <a:spcPts val="4030"/>
-              </a:lnSpc>
-              <a:spcBef>
-                <a:spcPts val="0"/>
-              </a:spcBef>
-              <a:buNone/>
-            </a:pPr>
-            <a:r>
-              <a:rPr lang="ko-KR" sz="3600" b="1" dirty="0">
+          <p:cNvPr id="13" name="body:L2:n"/>
+          <p:cNvSpPr txBox="1"/>
+          <p:nvPr/>
+        </p:nvSpPr>
+        <p:spPr>
+          <a:xfrm>
+            <a:off x="685800" y="4092194"/>
+            <a:ext cx="3240938" cy="533400"/>
+          </a:xfrm>
+          <a:prstGeom prst="rect">
+            <a:avLst/>
+          </a:prstGeom>
+          <a:noFill/>
+        </p:spPr>
+        <p:txBody>
+          <a:bodyPr wrap="square" lIns="0" tIns="0" rIns="0" bIns="0" anchor="t">
+            <a:noAutofit/>
+          </a:bodyPr>
+          <a:lstStyle/>
+          <a:p>
+            <a:pPr algn="l">
+              <a:lnSpc>
+                <a:spcPts val="2100"/>
+              </a:lnSpc>
+              <a:spcBef>
+                <a:spcPts val="0"/>
+              </a:spcBef>
+              <a:buNone/>
+            </a:pPr>
+            <a:r>
+              <a:rPr lang="ko-KR" sz="1500" b="0" dirty="0">
                 <a:solidFill>
                   <a:srgbClr val="0F172A"/>
                 </a:solidFill>
-                <a:latin typeface="Consolas"/>
-                <a:ea typeface="맑은 고딕"/>
-                <a:cs typeface="Consolas"/>
-              </a:rPr>
-              <a:t>87.3</a:t>
-            </a:r>
-            <a:r>
-              <a:rPr lang="ko-KR" sz="1440" b="1" dirty="0">
+                <a:latin typeface="맑은 고딕"/>
+                <a:ea typeface="맑은 고딕"/>
+                <a:cs typeface="맑은 고딕"/>
+              </a:rPr>
+              <a:t>E → 사내수리 </a:t>
+            </a:r>
+            <a:r>
+              <a:rPr lang="ko-KR" sz="1500" b="1" dirty="0">
+                <a:solidFill>
+                  <a:srgbClr val="2563EB"/>
+                </a:solidFill>
+                <a:latin typeface="맑은 고딕"/>
+                <a:ea typeface="맑은 고딕"/>
+                <a:cs typeface="맑은 고딕"/>
+              </a:rPr>
+              <a:t>100.0% </a:t>
+            </a:r>
+            <a:r>
+              <a:rPr lang="ko-KR" sz="1500" b="0" dirty="0">
                 <a:solidFill>
                   <a:srgbClr val="0F172A"/>
                 </a:solidFill>
@@ -13654,44 +13665,88 @@
                 <a:ea typeface="맑은 고딕"/>
                 <a:cs typeface="맑은 고딕"/>
               </a:rPr>
-              <a:t>% (상한)</a:t>
-            </a:r>
-          </a:p>
-        </p:txBody>
-      </p:sp>
-      <p:sp>
-        <p:nvSpPr>
-          <p:cNvPr id="14" name="body:L1:t"/>
-          <p:cNvSpPr txBox="1"/>
-          <p:nvPr/>
-        </p:nvSpPr>
-        <p:spPr>
-          <a:xfrm>
-            <a:off x="685800" y="4896612"/>
-            <a:ext cx="3240938" cy="204470"/>
-          </a:xfrm>
-          <a:prstGeom prst="rect">
-            <a:avLst/>
-          </a:prstGeom>
-          <a:noFill/>
-        </p:spPr>
-        <p:txBody>
-          <a:bodyPr wrap="square" lIns="0" tIns="0" rIns="0" bIns="0" anchor="t">
-            <a:noAutofit/>
-          </a:bodyPr>
-          <a:lstStyle/>
-          <a:p>
-            <a:pPr algn="l">
-              <a:lnSpc>
-                <a:spcPts val="1610"/>
-              </a:lnSpc>
-              <a:spcBef>
-                <a:spcPts val="0"/>
-              </a:spcBef>
-              <a:buNone/>
-            </a:pPr>
-            <a:r>
-              <a:rPr lang="ko-KR" sz="1150" b="0" dirty="0">
+              <a:t>(370/370건)</a:t>
+            </a:r>
+          </a:p>
+          <a:p>
+            <a:pPr algn="l">
+              <a:lnSpc>
+                <a:spcPts val="2100"/>
+              </a:lnSpc>
+              <a:spcBef>
+                <a:spcPts val="0"/>
+              </a:spcBef>
+              <a:buNone/>
+            </a:pPr>
+            <a:r>
+              <a:rPr lang="ko-KR" sz="1500" b="0" dirty="0">
+                <a:solidFill>
+                  <a:srgbClr val="0F172A"/>
+                </a:solidFill>
+                <a:latin typeface="맑은 고딕"/>
+                <a:ea typeface="맑은 고딕"/>
+                <a:cs typeface="맑은 고딕"/>
+              </a:rPr>
+              <a:t>P → 즉시수리 </a:t>
+            </a:r>
+            <a:r>
+              <a:rPr lang="ko-KR" sz="1500" b="1" dirty="0">
+                <a:solidFill>
+                  <a:srgbClr val="2563EB"/>
+                </a:solidFill>
+                <a:latin typeface="맑은 고딕"/>
+                <a:ea typeface="맑은 고딕"/>
+                <a:cs typeface="맑은 고딕"/>
+              </a:rPr>
+              <a:t>83.1% </a:t>
+            </a:r>
+            <a:r>
+              <a:rPr lang="ko-KR" sz="1500" b="0" dirty="0">
+                <a:solidFill>
+                  <a:srgbClr val="0F172A"/>
+                </a:solidFill>
+                <a:latin typeface="맑은 고딕"/>
+                <a:ea typeface="맑은 고딕"/>
+                <a:cs typeface="맑은 고딕"/>
+              </a:rPr>
+              <a:t>(365/439건)</a:t>
+            </a:r>
+          </a:p>
+        </p:txBody>
+      </p:sp>
+      <p:sp>
+        <p:nvSpPr>
+          <p:cNvPr id="14" name="body:L2:bs"/>
+          <p:cNvSpPr txBox="1"/>
+          <p:nvPr/>
+        </p:nvSpPr>
+        <p:spPr>
+          <a:xfrm>
+            <a:off x="685800" y="4689602"/>
+            <a:ext cx="3240938" cy="391160"/>
+          </a:xfrm>
+          <a:prstGeom prst="rect">
+            <a:avLst/>
+          </a:prstGeom>
+          <a:noFill/>
+        </p:spPr>
+        <p:txBody>
+          <a:bodyPr wrap="square" lIns="0" tIns="0" rIns="0" bIns="0" anchor="t">
+            <a:noAutofit/>
+          </a:bodyPr>
+          <a:lstStyle/>
+          <a:p>
+            <a:pPr algn="l">
+              <a:lnSpc>
+                <a:spcPts val="1540"/>
+              </a:lnSpc>
+              <a:spcBef>
+                <a:spcPts val="0"/>
+              </a:spcBef>
+              <a:buNone/>
+            </a:pPr>
+            <a:r>
+              <a:rPr lang="ko-KR" sz="1100" b="0" dirty="0">
                 <a:solidFill>
                   <a:srgbClr val="334155"/>
                 </a:solidFill>
@@ -13699,7 +13754,29 @@
                 <a:ea typeface="맑은 고딕"/>
                 <a:cs typeface="맑은 고딕"/>
               </a:rPr>
-              <a:t>E+P 809/927건 · 보수 기준 83.2%(771건)</a:t>
+              <a:t>즉시 수리 기저율 41.3%의 약 2.0배</a:t>
+            </a:r>
+          </a:p>
+          <a:p>
+            <a:pPr algn="l">
+              <a:lnSpc>
+                <a:spcPts val="1540"/>
+              </a:lnSpc>
+              <a:spcBef>
+                <a:spcPts val="0"/>
+              </a:spcBef>
+              <a:buNone/>
+            </a:pPr>
+            <a:r>
+              <a:rPr lang="ko-KR" sz="1100" b="0" dirty="0">
+                <a:solidFill>
+                  <a:srgbClr val="334155"/>
+                </a:solidFill>
+                <a:latin typeface="맑은 고딕"/>
+                <a:ea typeface="맑은 고딕"/>
+                <a:cs typeface="맑은 고딕"/>
+              </a:rPr>
+              <a:t>기준: 접수 알파벳 vs 실제 1차 수리 방식</a:t>
             </a:r>
           </a:p>
         </p:txBody>
@@ -13713,7 +13790,7 @@
         <p:spPr>
           <a:xfrm>
             <a:off x="4292498" y="1554480"/>
-            <a:ext cx="3606698" cy="3729482"/>
+            <a:ext cx="3606698" cy="3709162"/>
           </a:xfrm>
           <a:prstGeom prst="rect">
             <a:avLst/>
@@ -14251,7 +14328,7 @@
         <p:spPr>
           <a:xfrm>
             <a:off x="8082076" y="1554480"/>
-            <a:ext cx="3606698" cy="3729482"/>
+            <a:ext cx="3606698" cy="3709162"/>
           </a:xfrm>
           <a:prstGeom prst="rect">
             <a:avLst/>
@@ -14583,8 +14660,8 @@
         </p:nvSpPr>
         <p:spPr>
           <a:xfrm>
-            <a:off x="502920" y="5421122"/>
-            <a:ext cx="11185855" cy="888237"/>
+            <a:off x="502920" y="5400802"/>
+            <a:ext cx="11185855" cy="908557"/>
           </a:xfrm>
           <a:prstGeom prst="rect">
             <a:avLst/>
@@ -14629,7 +14706,7 @@
         </p:nvSpPr>
         <p:spPr>
           <a:xfrm>
-            <a:off x="667512" y="5585714"/>
+            <a:off x="667512" y="5565394"/>
             <a:ext cx="10856671" cy="158750"/>
           </a:xfrm>
           <a:prstGeom prst="rect">
@@ -14674,7 +14751,7 @@
         </p:nvSpPr>
         <p:spPr>
           <a:xfrm>
-            <a:off x="667512" y="5790184"/>
+            <a:off x="667512" y="5769864"/>
             <a:ext cx="10856671" cy="266700"/>
           </a:xfrm>
           <a:prstGeom prst="rect">

</xml_diff>

<commit_message>
feat(deck): slide 16 remove baseline footnote, enlarge donut (labels simplified to type+count)
Co-Authored-By: Claude Sonnet 5.5 <noreply@anthropic.com>
</commit_message>
<xml_diff>
--- a/outputs/pptx/puzzledata_repair_report.pptx
+++ b/outputs/pptx/puzzledata_repair_report.pptx
@@ -125,21 +125,21 @@
   <p:extLst>
     <p:ext uri="{521415D9-36F7-43E2-AB2F-B90AF26B5E84}">
       <p14:sectionLst xmlns:p14="http://schemas.microsoft.com/office/powerpoint/2010/main">
-        <p14:section name="Part 00 · 인트로" id="{E47DA3FD-E6AB-48E7-8024-2C7C8BB6A245}">
+        <p14:section name="Part 00 · 인트로" id="{D4C38AC7-7035-4903-8BD2-3FCA2A8C7822}">
           <p14:sldIdLst>
             <p14:sldId id="256"/>
             <p14:sldId id="257"/>
             <p14:sldId id="258"/>
           </p14:sldIdLst>
         </p14:section>
-        <p14:section name="Part 01 · 데이터 진단" id="{EA3329E9-E6FC-45A3-BF08-556EED43FBE3}">
+        <p14:section name="Part 01 · 데이터 진단" id="{B3080735-3791-47AB-B0A4-A98F76AEAF8E}">
           <p14:sldIdLst>
             <p14:sldId id="259"/>
             <p14:sldId id="260"/>
             <p14:sldId id="261"/>
           </p14:sldIdLst>
         </p14:section>
-        <p14:section name="Part 02 · 병목 규명" id="{9D96DDD9-3D6F-4F39-B77A-418A02803AC7}">
+        <p14:section name="Part 02 · 병목 규명" id="{932DC985-CED4-4817-B55E-5D4088D3B845}">
           <p14:sldIdLst>
             <p14:sldId id="262"/>
             <p14:sldId id="263"/>
@@ -152,14 +152,14 @@
             <p14:sldId id="270"/>
           </p14:sldIdLst>
         </p14:section>
-        <p14:section name="Part 03 · 개선 전략" id="{BDFE8A19-D9CD-478C-A21A-3C311B3EA882}">
+        <p14:section name="Part 03 · 개선 전략" id="{AA1AE1D8-54DA-4EC5-8643-F301B29777D2}">
           <p14:sldIdLst>
             <p14:sldId id="271"/>
             <p14:sldId id="272"/>
             <p14:sldId id="273"/>
           </p14:sldIdLst>
         </p14:section>
-        <p14:section name="Part 04 · Q&amp;A" id="{9C4331D8-B396-4DEC-8642-B76EB75B503A}">
+        <p14:section name="Part 04 · Q&amp;A" id="{E3A0DDAB-EFBF-4DC8-8541-EF370D91C246}">
           <p14:sldIdLst>
             <p14:sldId id="274"/>
           </p14:sldIdLst>
@@ -13452,7 +13452,7 @@
         <p:spPr>
           <a:xfrm>
             <a:off x="502920" y="1554480"/>
-            <a:ext cx="3606698" cy="3709162"/>
+            <a:ext cx="3606698" cy="3802634"/>
           </a:xfrm>
           <a:prstGeom prst="rect">
             <a:avLst/>
@@ -13595,8 +13595,8 @@
         </p:blipFill>
         <p:spPr>
           <a:xfrm>
-            <a:off x="942226" y="2290826"/>
-            <a:ext cx="2728085" cy="1737360"/>
+            <a:off x="1079018" y="2290826"/>
+            <a:ext cx="2454501" cy="2286000"/>
           </a:xfrm>
           <a:prstGeom prst="rect">
             <a:avLst/>
@@ -13611,7 +13611,7 @@
         </p:nvSpPr>
         <p:spPr>
           <a:xfrm>
-            <a:off x="685800" y="4092194"/>
+            <a:off x="685800" y="4640834"/>
             <a:ext cx="3240938" cy="533400"/>
           </a:xfrm>
           <a:prstGeom prst="rect">
@@ -13716,81 +13716,14 @@
       </p:sp>
       <p:sp>
         <p:nvSpPr>
-          <p:cNvPr id="14" name="body:L2:bs"/>
-          <p:cNvSpPr txBox="1"/>
-          <p:nvPr/>
-        </p:nvSpPr>
-        <p:spPr>
-          <a:xfrm>
-            <a:off x="685800" y="4689602"/>
-            <a:ext cx="3240938" cy="391160"/>
-          </a:xfrm>
-          <a:prstGeom prst="rect">
-            <a:avLst/>
-          </a:prstGeom>
-          <a:noFill/>
-        </p:spPr>
-        <p:txBody>
-          <a:bodyPr wrap="square" lIns="0" tIns="0" rIns="0" bIns="0" anchor="t">
-            <a:noAutofit/>
-          </a:bodyPr>
-          <a:lstStyle/>
-          <a:p>
-            <a:pPr algn="l">
-              <a:lnSpc>
-                <a:spcPts val="1540"/>
-              </a:lnSpc>
-              <a:spcBef>
-                <a:spcPts val="0"/>
-              </a:spcBef>
-              <a:buNone/>
-            </a:pPr>
-            <a:r>
-              <a:rPr lang="ko-KR" sz="1100" b="0" dirty="0">
-                <a:solidFill>
-                  <a:srgbClr val="334155"/>
-                </a:solidFill>
-                <a:latin typeface="맑은 고딕"/>
-                <a:ea typeface="맑은 고딕"/>
-                <a:cs typeface="맑은 고딕"/>
-              </a:rPr>
-              <a:t>즉시 수리 기저율 41.3%의 약 2.0배</a:t>
-            </a:r>
-          </a:p>
-          <a:p>
-            <a:pPr algn="l">
-              <a:lnSpc>
-                <a:spcPts val="1540"/>
-              </a:lnSpc>
-              <a:spcBef>
-                <a:spcPts val="0"/>
-              </a:spcBef>
-              <a:buNone/>
-            </a:pPr>
-            <a:r>
-              <a:rPr lang="ko-KR" sz="1100" b="0" dirty="0">
-                <a:solidFill>
-                  <a:srgbClr val="334155"/>
-                </a:solidFill>
-                <a:latin typeface="맑은 고딕"/>
-                <a:ea typeface="맑은 고딕"/>
-                <a:cs typeface="맑은 고딕"/>
-              </a:rPr>
-              <a:t>기준: 접수 알파벳 vs 실제 1차 수리 방식</a:t>
-            </a:r>
-          </a:p>
-        </p:txBody>
-      </p:sp>
-      <p:sp>
-        <p:nvSpPr>
-          <p:cNvPr id="15" name="c2"/>
+          <p:cNvPr id="14" name="c2"/>
           <p:cNvSpPr/>
           <p:nvPr/>
         </p:nvSpPr>
         <p:spPr>
           <a:xfrm>
             <a:off x="4292498" y="1554480"/>
-            <a:ext cx="3606698" cy="3709162"/>
+            <a:ext cx="3606698" cy="3802634"/>
           </a:xfrm>
           <a:prstGeom prst="rect">
             <a:avLst/>
@@ -13829,7 +13762,7 @@
       </p:sp>
       <p:sp>
         <p:nvSpPr>
-          <p:cNvPr id="16" name="label:L1:t"/>
+          <p:cNvPr id="15" name="label:L1:t"/>
           <p:cNvSpPr txBox="1"/>
           <p:nvPr/>
         </p:nvSpPr>
@@ -13874,7 +13807,7 @@
       </p:sp>
       <p:sp>
         <p:nvSpPr>
-          <p:cNvPr id="17" name="body:L1:h"/>
+          <p:cNvPr id="16" name="body:L1:h"/>
           <p:cNvSpPr txBox="1"/>
           <p:nvPr/>
         </p:nvSpPr>
@@ -13919,7 +13852,7 @@
       </p:sp>
       <p:sp>
         <p:nvSpPr>
-          <p:cNvPr id="18" name="boxA"/>
+          <p:cNvPr id="17" name="boxA"/>
           <p:cNvSpPr/>
           <p:nvPr/>
         </p:nvSpPr>
@@ -13965,7 +13898,7 @@
       </p:sp>
       <p:sp>
         <p:nvSpPr>
-          <p:cNvPr id="19" name="label:L1:t"/>
+          <p:cNvPr id="18" name="label:L1:t"/>
           <p:cNvSpPr txBox="1"/>
           <p:nvPr/>
         </p:nvSpPr>
@@ -14010,7 +13943,7 @@
       </p:sp>
       <p:sp>
         <p:nvSpPr>
-          <p:cNvPr id="20" name="body:L2:t"/>
+          <p:cNvPr id="19" name="body:L2:t"/>
           <p:cNvSpPr txBox="1"/>
           <p:nvPr/>
         </p:nvSpPr>
@@ -14076,7 +14009,7 @@
       </p:sp>
       <p:sp>
         <p:nvSpPr>
-          <p:cNvPr id="21" name="boxB"/>
+          <p:cNvPr id="20" name="boxB"/>
           <p:cNvSpPr/>
           <p:nvPr/>
         </p:nvSpPr>
@@ -14122,7 +14055,7 @@
       </p:sp>
       <p:sp>
         <p:nvSpPr>
-          <p:cNvPr id="22" name="label:L1:t"/>
+          <p:cNvPr id="21" name="label:L1:t"/>
           <p:cNvSpPr txBox="1"/>
           <p:nvPr/>
         </p:nvSpPr>
@@ -14167,7 +14100,7 @@
       </p:sp>
       <p:sp>
         <p:nvSpPr>
-          <p:cNvPr id="23" name="body:L1:t"/>
+          <p:cNvPr id="22" name="body:L1:t"/>
           <p:cNvSpPr txBox="1"/>
           <p:nvPr/>
         </p:nvSpPr>
@@ -14212,7 +14145,7 @@
       </p:sp>
       <p:sp>
         <p:nvSpPr>
-          <p:cNvPr id="24" name="body:L3:res"/>
+          <p:cNvPr id="23" name="body:L3:res"/>
           <p:cNvSpPr txBox="1"/>
           <p:nvPr/>
         </p:nvSpPr>
@@ -14321,14 +14254,14 @@
       </p:sp>
       <p:sp>
         <p:nvSpPr>
-          <p:cNvPr id="25" name="c3"/>
+          <p:cNvPr id="24" name="c3"/>
           <p:cNvSpPr/>
           <p:nvPr/>
         </p:nvSpPr>
         <p:spPr>
           <a:xfrm>
             <a:off x="8082076" y="1554480"/>
-            <a:ext cx="3606698" cy="3709162"/>
+            <a:ext cx="3606698" cy="3802634"/>
           </a:xfrm>
           <a:prstGeom prst="rect">
             <a:avLst/>
@@ -14367,7 +14300,7 @@
       </p:sp>
       <p:sp>
         <p:nvSpPr>
-          <p:cNvPr id="26" name="label:L1:t"/>
+          <p:cNvPr id="25" name="label:L1:t"/>
           <p:cNvSpPr txBox="1"/>
           <p:nvPr/>
         </p:nvSpPr>
@@ -14412,7 +14345,7 @@
       </p:sp>
       <p:sp>
         <p:nvSpPr>
-          <p:cNvPr id="27" name="body:L1:h"/>
+          <p:cNvPr id="26" name="body:L1:h"/>
           <p:cNvSpPr txBox="1"/>
           <p:nvPr/>
         </p:nvSpPr>
@@ -14457,7 +14390,7 @@
       </p:sp>
       <p:sp>
         <p:nvSpPr>
-          <p:cNvPr id="28" name="body:L1:n"/>
+          <p:cNvPr id="27" name="body:L1:n"/>
           <p:cNvSpPr txBox="1"/>
           <p:nvPr/>
         </p:nvSpPr>
@@ -14513,7 +14446,7 @@
       </p:sp>
       <p:sp>
         <p:nvSpPr>
-          <p:cNvPr id="29" name="body:L2:t"/>
+          <p:cNvPr id="28" name="body:L2:t"/>
           <p:cNvSpPr txBox="1"/>
           <p:nvPr/>
         </p:nvSpPr>
@@ -14579,7 +14512,7 @@
       </p:sp>
       <p:sp>
         <p:nvSpPr>
-          <p:cNvPr id="30" name="body:L2:t"/>
+          <p:cNvPr id="29" name="body:L2:t"/>
           <p:cNvSpPr txBox="1"/>
           <p:nvPr/>
         </p:nvSpPr>
@@ -14654,14 +14587,14 @@
       </p:sp>
       <p:sp>
         <p:nvSpPr>
-          <p:cNvPr id="31" name="sowhat"/>
+          <p:cNvPr id="30" name="sowhat"/>
           <p:cNvSpPr/>
           <p:nvPr/>
         </p:nvSpPr>
         <p:spPr>
           <a:xfrm>
-            <a:off x="502920" y="5400802"/>
-            <a:ext cx="11185855" cy="908557"/>
+            <a:off x="502920" y="5494274"/>
+            <a:ext cx="11185855" cy="815085"/>
           </a:xfrm>
           <a:prstGeom prst="rect">
             <a:avLst/>
@@ -14700,13 +14633,13 @@
       </p:sp>
       <p:sp>
         <p:nvSpPr>
-          <p:cNvPr id="32" name="label:L1:t"/>
-          <p:cNvSpPr txBox="1"/>
-          <p:nvPr/>
-        </p:nvSpPr>
-        <p:spPr>
-          <a:xfrm>
-            <a:off x="667512" y="5565394"/>
+          <p:cNvPr id="31" name="label:L1:t"/>
+          <p:cNvSpPr txBox="1"/>
+          <p:nvPr/>
+        </p:nvSpPr>
+        <p:spPr>
+          <a:xfrm>
+            <a:off x="667512" y="5658866"/>
             <a:ext cx="10856671" cy="158750"/>
           </a:xfrm>
           <a:prstGeom prst="rect">
@@ -14745,13 +14678,13 @@
       </p:sp>
       <p:sp>
         <p:nvSpPr>
-          <p:cNvPr id="33" name="body:L1:sw"/>
-          <p:cNvSpPr txBox="1"/>
-          <p:nvPr/>
-        </p:nvSpPr>
-        <p:spPr>
-          <a:xfrm>
-            <a:off x="667512" y="5769864"/>
+          <p:cNvPr id="32" name="body:L1:sw"/>
+          <p:cNvSpPr txBox="1"/>
+          <p:nvPr/>
+        </p:nvSpPr>
+        <p:spPr>
+          <a:xfrm>
+            <a:off x="667512" y="5863336"/>
             <a:ext cx="10856671" cy="266700"/>
           </a:xfrm>
           <a:prstGeom prst="rect">

</xml_diff>

<commit_message>
feat(deck): slide 16 card 02 closing line simplified to '실사 대기 큐는 한 줄' (centered)
Co-Authored-By: Claude Sonnet 5.5 <noreply@anthropic.com>
</commit_message>
<xml_diff>
--- a/outputs/pptx/puzzledata_repair_report.pptx
+++ b/outputs/pptx/puzzledata_repair_report.pptx
@@ -125,21 +125,21 @@
   <p:extLst>
     <p:ext uri="{521415D9-36F7-43E2-AB2F-B90AF26B5E84}">
       <p14:sectionLst xmlns:p14="http://schemas.microsoft.com/office/powerpoint/2010/main">
-        <p14:section name="Part 00 · 인트로" id="{D4C38AC7-7035-4903-8BD2-3FCA2A8C7822}">
+        <p14:section name="Part 00 · 인트로" id="{5F69424F-1B68-4FA3-B437-049E2AA2A675}">
           <p14:sldIdLst>
             <p14:sldId id="256"/>
             <p14:sldId id="257"/>
             <p14:sldId id="258"/>
           </p14:sldIdLst>
         </p14:section>
-        <p14:section name="Part 01 · 데이터 진단" id="{B3080735-3791-47AB-B0A4-A98F76AEAF8E}">
+        <p14:section name="Part 01 · 데이터 진단" id="{68CA2017-8DC0-44AE-84F0-80181B2A11D1}">
           <p14:sldIdLst>
             <p14:sldId id="259"/>
             <p14:sldId id="260"/>
             <p14:sldId id="261"/>
           </p14:sldIdLst>
         </p14:section>
-        <p14:section name="Part 02 · 병목 규명" id="{932DC985-CED4-4817-B55E-5D4088D3B845}">
+        <p14:section name="Part 02 · 병목 규명" id="{FB2C48D5-4755-4F05-9B93-E86873312AEA}">
           <p14:sldIdLst>
             <p14:sldId id="262"/>
             <p14:sldId id="263"/>
@@ -152,14 +152,14 @@
             <p14:sldId id="270"/>
           </p14:sldIdLst>
         </p14:section>
-        <p14:section name="Part 03 · 개선 전략" id="{AA1AE1D8-54DA-4EC5-8643-F301B29777D2}">
+        <p14:section name="Part 03 · 개선 전략" id="{D7E46F78-FEE4-459D-AAA3-207489A52981}">
           <p14:sldIdLst>
             <p14:sldId id="271"/>
             <p14:sldId id="272"/>
             <p14:sldId id="273"/>
           </p14:sldIdLst>
         </p14:section>
-        <p14:section name="Part 04 · Q&amp;A" id="{E3A0DDAB-EFBF-4DC8-8541-EF370D91C246}">
+        <p14:section name="Part 04 · Q&amp;A" id="{79F4340D-51F2-4F42-BA98-F7C29879DF3D}">
           <p14:sldIdLst>
             <p14:sldId id="274"/>
           </p14:sldIdLst>
@@ -14145,48 +14145,37 @@
       </p:sp>
       <p:sp>
         <p:nvSpPr>
-          <p:cNvPr id="23" name="body:L3:res"/>
+          <p:cNvPr id="23" name="body:L1:res"/>
           <p:cNvSpPr txBox="1"/>
           <p:nvPr/>
         </p:nvSpPr>
         <p:spPr>
           <a:xfrm>
             <a:off x="4475378" y="4081272"/>
-            <a:ext cx="3240938" cy="666750"/>
-          </a:xfrm>
-          <a:prstGeom prst="rect">
-            <a:avLst/>
-          </a:prstGeom>
-          <a:noFill/>
-        </p:spPr>
-        <p:txBody>
-          <a:bodyPr wrap="square" lIns="0" tIns="0" rIns="0" bIns="0" anchor="t">
-            <a:noAutofit/>
-          </a:bodyPr>
-          <a:lstStyle/>
-          <a:p>
-            <a:pPr algn="l">
-              <a:lnSpc>
-                <a:spcPts val="1750"/>
-              </a:lnSpc>
-              <a:spcBef>
-                <a:spcPts val="0"/>
-              </a:spcBef>
-              <a:buNone/>
-            </a:pPr>
-            <a:r>
-              <a:rPr lang="ko-KR" sz="1250" b="0" dirty="0">
-                <a:solidFill>
-                  <a:srgbClr val="0F172A"/>
-                </a:solidFill>
-                <a:latin typeface="맑은 고딕"/>
-                <a:ea typeface="맑은 고딕"/>
-                <a:cs typeface="맑은 고딕"/>
-              </a:rPr>
-              <a:t>→ 채널이 달라도 </a:t>
-            </a:r>
-            <a:r>
-              <a:rPr lang="ko-KR" sz="1250" b="1" dirty="0">
+            <a:ext cx="3240938" cy="266700"/>
+          </a:xfrm>
+          <a:prstGeom prst="rect">
+            <a:avLst/>
+          </a:prstGeom>
+          <a:noFill/>
+        </p:spPr>
+        <p:txBody>
+          <a:bodyPr wrap="square" lIns="0" tIns="0" rIns="0" bIns="0" anchor="t">
+            <a:noAutofit/>
+          </a:bodyPr>
+          <a:lstStyle/>
+          <a:p>
+            <a:pPr algn="ctr">
+              <a:lnSpc>
+                <a:spcPts val="2100"/>
+              </a:lnSpc>
+              <a:spcBef>
+                <a:spcPts val="0"/>
+              </a:spcBef>
+              <a:buNone/>
+            </a:pPr>
+            <a:r>
+              <a:rPr lang="ko-KR" sz="1500" b="1" dirty="0">
                 <a:solidFill>
                   <a:srgbClr val="2563EB"/>
                 </a:solidFill>
@@ -14194,60 +14183,7 @@
                 <a:ea typeface="맑은 고딕"/>
                 <a:cs typeface="맑은 고딕"/>
               </a:rPr>
-              <a:t>실사 큐는 한 줄</a:t>
-            </a:r>
-            <a:r>
-              <a:rPr lang="ko-KR" sz="1250" b="0" dirty="0">
-                <a:solidFill>
-                  <a:srgbClr val="0F172A"/>
-                </a:solidFill>
-                <a:latin typeface="맑은 고딕"/>
-                <a:ea typeface="맑은 고딕"/>
-                <a:cs typeface="맑은 고딕"/>
-              </a:rPr>
-              <a:t>:</a:t>
-            </a:r>
-            <a:br>
-              <a:rPr lang="ko-KR" sz="1250" b="0" dirty="0">
-                <a:solidFill>
-                  <a:srgbClr val="0F172A"/>
-                </a:solidFill>
-                <a:latin typeface="맑은 고딕"/>
-                <a:ea typeface="맑은 고딕"/>
-                <a:cs typeface="맑은 고딕"/>
-              </a:rPr>
-            </a:br>
-            <a:r>
-              <a:rPr lang="ko-KR" sz="1250" b="0" dirty="0">
-                <a:solidFill>
-                  <a:srgbClr val="0F172A"/>
-                </a:solidFill>
-                <a:latin typeface="맑은 고딕"/>
-                <a:ea typeface="맑은 고딕"/>
-                <a:cs typeface="맑은 고딕"/>
-              </a:rPr>
-              <a:t>채널별 실사 대기 70.1~80.4h, 차이</a:t>
-            </a:r>
-            <a:br>
-              <a:rPr lang="ko-KR" sz="1250" b="0" dirty="0">
-                <a:solidFill>
-                  <a:srgbClr val="0F172A"/>
-                </a:solidFill>
-                <a:latin typeface="맑은 고딕"/>
-                <a:ea typeface="맑은 고딕"/>
-                <a:cs typeface="맑은 고딕"/>
-              </a:rPr>
-            </a:br>
-            <a:r>
-              <a:rPr lang="ko-KR" sz="1250" b="0" dirty="0">
-                <a:solidFill>
-                  <a:srgbClr val="0F172A"/>
-                </a:solidFill>
-                <a:latin typeface="맑은 고딕"/>
-                <a:ea typeface="맑은 고딕"/>
-                <a:cs typeface="맑은 고딕"/>
-              </a:rPr>
-              <a:t>유의하지 않음(p=0.64)</a:t>
+              <a:t>실사 대기 큐는 한 줄</a:t>
             </a:r>
           </a:p>
         </p:txBody>

</xml_diff>

<commit_message>
feat(deck): slide 16 card 02 closing line restored with 채널이 달라도, centered in remaining space
Co-Authored-By: Claude Sonnet 5.5 <noreply@anthropic.com>
</commit_message>
<xml_diff>
--- a/outputs/pptx/puzzledata_repair_report.pptx
+++ b/outputs/pptx/puzzledata_repair_report.pptx
@@ -125,21 +125,21 @@
   <p:extLst>
     <p:ext uri="{521415D9-36F7-43E2-AB2F-B90AF26B5E84}">
       <p14:sectionLst xmlns:p14="http://schemas.microsoft.com/office/powerpoint/2010/main">
-        <p14:section name="Part 00 · 인트로" id="{5F69424F-1B68-4FA3-B437-049E2AA2A675}">
+        <p14:section name="Part 00 · 인트로" id="{B1BD703B-9454-4C26-88CC-51E42516F9DE}">
           <p14:sldIdLst>
             <p14:sldId id="256"/>
             <p14:sldId id="257"/>
             <p14:sldId id="258"/>
           </p14:sldIdLst>
         </p14:section>
-        <p14:section name="Part 01 · 데이터 진단" id="{68CA2017-8DC0-44AE-84F0-80181B2A11D1}">
+        <p14:section name="Part 01 · 데이터 진단" id="{8F6D40E8-5FAD-4C7B-9F42-D11326A9327A}">
           <p14:sldIdLst>
             <p14:sldId id="259"/>
             <p14:sldId id="260"/>
             <p14:sldId id="261"/>
           </p14:sldIdLst>
         </p14:section>
-        <p14:section name="Part 02 · 병목 규명" id="{FB2C48D5-4755-4F05-9B93-E86873312AEA}">
+        <p14:section name="Part 02 · 병목 규명" id="{15968FFF-9070-45DC-923A-CC26063A24A9}">
           <p14:sldIdLst>
             <p14:sldId id="262"/>
             <p14:sldId id="263"/>
@@ -152,14 +152,14 @@
             <p14:sldId id="270"/>
           </p14:sldIdLst>
         </p14:section>
-        <p14:section name="Part 03 · 개선 전략" id="{D7E46F78-FEE4-459D-AAA3-207489A52981}">
+        <p14:section name="Part 03 · 개선 전략" id="{8B42122D-8828-4ADD-9DA5-9724695DDFA6}">
           <p14:sldIdLst>
             <p14:sldId id="271"/>
             <p14:sldId id="272"/>
             <p14:sldId id="273"/>
           </p14:sldIdLst>
         </p14:section>
-        <p14:section name="Part 04 · Q&amp;A" id="{79F4340D-51F2-4F42-BA98-F7C29879DF3D}">
+        <p14:section name="Part 04 · Q&amp;A" id="{A0F8C475-B44C-4E5F-9A8B-294C03FB3BED}">
           <p14:sldIdLst>
             <p14:sldId id="274"/>
           </p14:sldIdLst>
@@ -14151,7 +14151,7 @@
         </p:nvSpPr>
         <p:spPr>
           <a:xfrm>
-            <a:off x="4475378" y="4081272"/>
+            <a:off x="4475378" y="4540123"/>
             <a:ext cx="3240938" cy="266700"/>
           </a:xfrm>
           <a:prstGeom prst="rect">
@@ -14174,6 +14174,17 @@
               </a:spcBef>
               <a:buNone/>
             </a:pPr>
+            <a:r>
+              <a:rPr lang="ko-KR" sz="1500" b="0" dirty="0">
+                <a:solidFill>
+                  <a:srgbClr val="0F172A"/>
+                </a:solidFill>
+                <a:latin typeface="맑은 고딕"/>
+                <a:ea typeface="맑은 고딕"/>
+                <a:cs typeface="맑은 고딕"/>
+              </a:rPr>
+              <a:t>채널이 달라도 </a:t>
+            </a:r>
             <a:r>
               <a:rPr lang="ko-KR" sz="1500" b="1" dirty="0">
                 <a:solidFill>

</xml_diff>

<commit_message>
feat(deck): slide 17 TO-BE input row split into three summarized lines
Co-Authored-By: Claude Sonnet 5.5 <noreply@anthropic.com>
</commit_message>
<xml_diff>
--- a/outputs/pptx/puzzledata_repair_report.pptx
+++ b/outputs/pptx/puzzledata_repair_report.pptx
@@ -125,21 +125,21 @@
   <p:extLst>
     <p:ext uri="{521415D9-36F7-43E2-AB2F-B90AF26B5E84}">
       <p14:sectionLst xmlns:p14="http://schemas.microsoft.com/office/powerpoint/2010/main">
-        <p14:section name="Part 00 · 인트로" id="{B1BD703B-9454-4C26-88CC-51E42516F9DE}">
+        <p14:section name="Part 00 · 인트로" id="{730C2C68-89FC-434C-A2EF-960E29129CE8}">
           <p14:sldIdLst>
             <p14:sldId id="256"/>
             <p14:sldId id="257"/>
             <p14:sldId id="258"/>
           </p14:sldIdLst>
         </p14:section>
-        <p14:section name="Part 01 · 데이터 진단" id="{8F6D40E8-5FAD-4C7B-9F42-D11326A9327A}">
+        <p14:section name="Part 01 · 데이터 진단" id="{4EF870C4-C462-4375-A89A-329EAE84C3BA}">
           <p14:sldIdLst>
             <p14:sldId id="259"/>
             <p14:sldId id="260"/>
             <p14:sldId id="261"/>
           </p14:sldIdLst>
         </p14:section>
-        <p14:section name="Part 02 · 병목 규명" id="{15968FFF-9070-45DC-923A-CC26063A24A9}">
+        <p14:section name="Part 02 · 병목 규명" id="{8E3CF8EF-0A44-4DD5-98D2-C2FD1005D491}">
           <p14:sldIdLst>
             <p14:sldId id="262"/>
             <p14:sldId id="263"/>
@@ -152,14 +152,14 @@
             <p14:sldId id="270"/>
           </p14:sldIdLst>
         </p14:section>
-        <p14:section name="Part 03 · 개선 전략" id="{8B42122D-8828-4ADD-9DA5-9724695DDFA6}">
+        <p14:section name="Part 03 · 개선 전략" id="{8A5DFE3E-3A6A-4E6A-9FB2-F3CD4DBB6465}">
           <p14:sldIdLst>
             <p14:sldId id="271"/>
             <p14:sldId id="272"/>
             <p14:sldId id="273"/>
           </p14:sldIdLst>
         </p14:section>
-        <p14:section name="Part 04 · Q&amp;A" id="{A0F8C475-B44C-4E5F-9A8B-294C03FB3BED}">
+        <p14:section name="Part 04 · Q&amp;A" id="{1D64B515-DDC1-4DCF-9A90-04AA0F746781}">
           <p14:sldIdLst>
             <p14:sldId id="274"/>
           </p14:sldIdLst>
@@ -15427,9 +15427,20 @@
                 <a:ea typeface="맑은 고딕"/>
                 <a:cs typeface="맑은 고딕"/>
               </a:rPr>
-              <a:t>구조화 입력 — 웹</a:t>
-            </a:r>
-            <a:br>
+              <a:t>구조화 입력</a:t>
+            </a:r>
+          </a:p>
+          <a:p>
+            <a:pPr algn="l">
+              <a:lnSpc>
+                <a:spcPts val="1610"/>
+              </a:lnSpc>
+              <a:spcBef>
+                <a:spcPts val="0"/>
+              </a:spcBef>
+              <a:buNone/>
+            </a:pPr>
+            <a:r>
               <a:rPr lang="ko-KR" sz="1150" b="0" dirty="0">
                 <a:solidFill>
                   <a:srgbClr val="0F172A"/>
@@ -15438,38 +15449,40 @@
                 <a:ea typeface="맑은 고딕"/>
                 <a:cs typeface="맑은 고딕"/>
               </a:rPr>
-            </a:br>
+              <a:t>웹 양식 포맷을 </a:t>
+            </a:r>
+            <a:r>
+              <a:rPr lang="ko-KR" sz="1150" b="1" dirty="0">
+                <a:solidFill>
+                  <a:srgbClr val="2563EB"/>
+                </a:solidFill>
+                <a:latin typeface="맑은 고딕"/>
+                <a:ea typeface="맑은 고딕"/>
+                <a:cs typeface="맑은 고딕"/>
+              </a:rPr>
+              <a:t>전 채널에 동일 적용</a:t>
+            </a:r>
+          </a:p>
+          <a:p>
+            <a:pPr algn="l">
+              <a:lnSpc>
+                <a:spcPts val="1610"/>
+              </a:lnSpc>
+              <a:spcBef>
+                <a:spcPts val="0"/>
+              </a:spcBef>
+              <a:buNone/>
+            </a:pPr>
             <a:r>
               <a:rPr lang="ko-KR" sz="1150" b="0" dirty="0">
                 <a:solidFill>
-                  <a:srgbClr val="0F172A"/>
-                </a:solidFill>
-                <a:latin typeface="맑은 고딕"/>
-                <a:ea typeface="맑은 고딕"/>
-                <a:cs typeface="맑은 고딕"/>
-              </a:rPr>
-              <a:t>양식(빠른 건 평균 6.8분, 전 채널 최속)</a:t>
-            </a:r>
-            <a:br>
-              <a:rPr lang="ko-KR" sz="1150" b="0" dirty="0">
-                <a:solidFill>
-                  <a:srgbClr val="0F172A"/>
-                </a:solidFill>
-                <a:latin typeface="맑은 고딕"/>
-                <a:ea typeface="맑은 고딕"/>
-                <a:cs typeface="맑은 고딕"/>
-              </a:rPr>
-            </a:br>
-            <a:r>
-              <a:rPr lang="ko-KR" sz="1150" b="0" dirty="0">
-                <a:solidFill>
-                  <a:srgbClr val="0F172A"/>
-                </a:solidFill>
-                <a:latin typeface="맑은 고딕"/>
-                <a:ea typeface="맑은 고딕"/>
-                <a:cs typeface="맑은 고딕"/>
-              </a:rPr>
-              <a:t>포맷을 전 채널에 동일 적용</a:t>
+                  <a:srgbClr val="334155"/>
+                </a:solidFill>
+                <a:latin typeface="맑은 고딕"/>
+                <a:ea typeface="맑은 고딕"/>
+                <a:cs typeface="맑은 고딕"/>
+              </a:rPr>
+              <a:t>(빠른 건 평균 6.8분, 전 채널 최속)</a:t>
             </a:r>
           </a:p>
         </p:txBody>

</xml_diff>

<commit_message>
feat(deck): slide 17 side card replaced with auxiliary plan - repeat rework prevention (E-1/E-2 precision check, P-4/B-4 outsourcing pre-confirmation)
Co-Authored-By: Claude Sonnet 5.5 <noreply@anthropic.com>
</commit_message>
<xml_diff>
--- a/outputs/pptx/puzzledata_repair_report.pptx
+++ b/outputs/pptx/puzzledata_repair_report.pptx
@@ -125,21 +125,21 @@
   <p:extLst>
     <p:ext uri="{521415D9-36F7-43E2-AB2F-B90AF26B5E84}">
       <p14:sectionLst xmlns:p14="http://schemas.microsoft.com/office/powerpoint/2010/main">
-        <p14:section name="Part 00 · 인트로" id="{730C2C68-89FC-434C-A2EF-960E29129CE8}">
+        <p14:section name="Part 00 · 인트로" id="{E5E6DFA5-791A-4C48-9520-117D04C0FE59}">
           <p14:sldIdLst>
             <p14:sldId id="256"/>
             <p14:sldId id="257"/>
             <p14:sldId id="258"/>
           </p14:sldIdLst>
         </p14:section>
-        <p14:section name="Part 01 · 데이터 진단" id="{4EF870C4-C462-4375-A89A-329EAE84C3BA}">
+        <p14:section name="Part 01 · 데이터 진단" id="{8E76EAF9-63B5-4383-840E-8073156B1E9D}">
           <p14:sldIdLst>
             <p14:sldId id="259"/>
             <p14:sldId id="260"/>
             <p14:sldId id="261"/>
           </p14:sldIdLst>
         </p14:section>
-        <p14:section name="Part 02 · 병목 규명" id="{8E3CF8EF-0A44-4DD5-98D2-C2FD1005D491}">
+        <p14:section name="Part 02 · 병목 규명" id="{CBF4CFA0-0BB6-4073-9237-7745558EAA81}">
           <p14:sldIdLst>
             <p14:sldId id="262"/>
             <p14:sldId id="263"/>
@@ -152,14 +152,14 @@
             <p14:sldId id="270"/>
           </p14:sldIdLst>
         </p14:section>
-        <p14:section name="Part 03 · 개선 전략" id="{8A5DFE3E-3A6A-4E6A-9FB2-F3CD4DBB6465}">
+        <p14:section name="Part 03 · 개선 전략" id="{511A4D9E-0018-4BEF-AF5E-4EC095446753}">
           <p14:sldIdLst>
             <p14:sldId id="271"/>
             <p14:sldId id="272"/>
             <p14:sldId id="273"/>
           </p14:sldIdLst>
         </p14:section>
-        <p14:section name="Part 04 · Q&amp;A" id="{1D64B515-DDC1-4DCF-9A90-04AA0F746781}">
+        <p14:section name="Part 04 · Q&amp;A" id="{BEC7B77F-A30B-44DF-8F8E-17F13DAF8924}">
           <p14:sldIdLst>
             <p14:sldId id="274"/>
           </p14:sldIdLst>
@@ -1125,7 +1125,7 @@
           <a:lstStyle/>
           <a:p>
             <a:r>
-              <a:t>개선 전략은 하나입니다. 접수 단계의 사전 필터 신뢰도를 높여 뒤 공정의 시간을 줄이는 것이고, 구체적으로는 Direct Booking입니다. 지금은 채널이 달라도 927건이 전부 실사 큐 한 줄에 서는데, 즉시 수리 건만 따로 뺍니다. 즉시 수리는 실사 도중 기본 키트로 끝낼 수 있는 작업이라 실사 대기줄을 거칠 이유가 없고, 작업 줄로 바로 이관할 수 있습니다. 수리 시간은 평균 1.99시간으로 사내수리 4.25시간의 47% 수준입니다. 분류는 접수 정보의 해상도로 합니다. 현재는 B·P·E 알파벳만 받고 상담원이 기사 일정을 확인해 회신하는 비동기 핑퐁이라 교차 인계가 123건 발생했습니다. 웹 양식은 빠른 건 평균 6.8분으로 정보 추출이 가장 빨라, 이 포맷을 전 채널에 적용하고 세부 코드(1~4) 수준으로 받습니다. 즉시 코드로 확정된 건은 기사 캘린더에서 고객이 슬롯을 직접 고릅니다. 보조 전략은 정밀검사입니다. 복합진단 B형 118건과 외주 전환 59건(P-4 38건 + B-4 21건)은 실사를 유지하고, 재작업 26건 중 22건이 E-1·E-2에 몰려 있어 E형도 정밀검사로 재방문을 막습니다. [정정] 외주는 E형이 아니라 P-4와 B-4에서 나왔고 E형 외주는 0건입니다. [예상 질문] 분류가 틀리면? → 알파벳 P만으로도 83.1%(365/439건)가 즉시 수리였고, 오분류 74건(16.9%)을 세부 코드로 거르는 것이 고도화의 목표이자 파일럿 KPI입니다. [예상 질문] 세부 코드를 접수 시점에 얻을 수 있나? → 로그의 코드는 수리 방식과 100% 일치해 사후 확정 라벨일 수 있고, 접수 시점 취득 가능성은 데이터로 검증할 수 없어 전제로 두었습니다. [예상 질문] 기사 풀이 같은데 줄을 나누면? → 기사 11명이 두 줄을 공유하므로 용량이 늘어나는 것이 아니라 슬롯 배분 정책입니다. 효과는 다음 장에서 가정과 파일럿으로 다룹니다. [예상 질문] 우편은? → 우편 207건은 웹 전환이 전제입니다.</a:t>
+              <a:t>개선 전략은 하나입니다. 접수 단계의 사전 필터 신뢰도를 높여 뒤 공정의 시간을 줄이는 것이고, 구체적으로는 Direct Booking입니다. 지금은 채널이 달라도 927건이 전부 실사 큐 한 줄에 서는데, 즉시 수리 건만 따로 뺍니다. 즉시 수리는 실사 도중 기본 키트로 끝낼 수 있는 작업이라 실사 대기줄을 거칠 이유가 없고, 작업 줄로 바로 이관할 수 있습니다. 수리 시간은 평균 1.99시간으로 사내수리 4.25시간의 47% 수준입니다. 분류는 접수 정보의 해상도로 합니다. 현재는 B·P·E 알파벳만 받고 상담원이 기사 일정을 확인해 회신하는 비동기 핑퐁이라 교차 인계가 123건 발생했습니다. 웹 양식은 빠른 건 평균 6.8분으로 정보 추출이 가장 빨라, 이 포맷을 전 채널에 적용하고 세부 코드(1~4) 수준으로 받습니다. 즉시 코드로 확정된 건은 기사 캘린더에서 고객이 슬롯을 직접 고릅니다. 보조 전략은 정밀검사입니다. 복합진단 B형 118건과 외주 전환 59건(P-4 38건 + B-4 21건)은 실사를 유지하고, 재작업 26건 중 22건이 E-1·E-2에 몰려 있어 E형도 정밀검사로 재방문을 막습니다. [정정] 외주는 E형이 아니라 P-4와 B-4에서 나왔고 E형 외주는 0건입니다. 또한 리워크 지연(+32.9h)은 사내 재수리 26건에서 발생했고 E-1·E-2에 22건이 몰려 있습니다. 외주 위탁 코드 P-4·B-4(59건)는 1차부터 외주로 가서 사내 재수리가 0건이므로, 이 코드의 정밀검사 목적은 리워크 방지가 아니라 외주 사전 확정입니다. [예상 질문] 분류가 틀리면? → 알파벳 P만으로도 83.1%(365/439건)가 즉시 수리였고, 오분류 74건(16.9%)을 세부 코드로 거르는 것이 고도화의 목표이자 파일럿 KPI입니다. [예상 질문] 세부 코드를 접수 시점에 얻을 수 있나? → 로그의 코드는 수리 방식과 100% 일치해 사후 확정 라벨일 수 있고, 접수 시점 취득 가능성은 데이터로 검증할 수 없어 전제로 두었습니다. [예상 질문] 기사 풀이 같은데 줄을 나누면? → 기사 11명이 두 줄을 공유하므로 용량이 늘어나는 것이 아니라 슬롯 배분 정책입니다. 효과는 다음 장에서 가정과 파일럿으로 다룹니다. [예상 질문] 우편은? → 우편 207건은 웹 전환이 전제입니다.</a:t>
             </a:r>
           </a:p>
         </p:txBody>
@@ -16457,7 +16457,7 @@
                 <a:ea typeface="맑은 고딕"/>
                 <a:cs typeface="Consolas"/>
               </a:rPr>
-              <a:t>전제 · 신뢰도</a:t>
+              <a:t>보조 개선안 · 반복 리워크 방지</a:t>
             </a:r>
           </a:p>
         </p:txBody>
@@ -16506,7 +16506,18 @@
                 <a:ea typeface="맑은 고딕"/>
                 <a:cs typeface="맑은 고딕"/>
               </a:rPr>
-              <a:t>알파벳 P만으로 적중 83.1% — 오분류</a:t>
+              <a:t>세부 코드로 </a:t>
+            </a:r>
+            <a:r>
+              <a:rPr lang="ko-KR" sz="1150" b="1" dirty="0">
+                <a:solidFill>
+                  <a:srgbClr val="2563EB"/>
+                </a:solidFill>
+                <a:latin typeface="맑은 고딕"/>
+                <a:ea typeface="맑은 고딕"/>
+                <a:cs typeface="맑은 고딕"/>
+              </a:rPr>
+              <a:t>정밀검사 대상</a:t>
             </a:r>
             <a:br>
               <a:rPr lang="ko-KR" sz="1150" b="0" dirty="0">
@@ -16527,7 +16538,7 @@
                 <a:ea typeface="맑은 고딕"/>
                 <a:cs typeface="맑은 고딕"/>
               </a:rPr>
-              <a:t>74건(16.9%)을 세부 코드로 거름</a:t>
+              <a:t>판별, 실사 유지</a:t>
             </a:r>
           </a:p>
           <a:p>
@@ -16545,6 +16556,17 @@
               <a:buChar char="•"/>
             </a:pPr>
             <a:r>
+              <a:rPr lang="ko-KR" sz="1150" b="1" dirty="0">
+                <a:solidFill>
+                  <a:srgbClr val="2563EB"/>
+                </a:solidFill>
+                <a:latin typeface="맑은 고딕"/>
+                <a:ea typeface="맑은 고딕"/>
+                <a:cs typeface="맑은 고딕"/>
+              </a:rPr>
+              <a:t>E-1·E-2 </a:t>
+            </a:r>
+            <a:r>
               <a:rPr lang="ko-KR" sz="1150" b="0" dirty="0">
                 <a:solidFill>
                   <a:srgbClr val="334155"/>
@@ -16553,7 +16575,7 @@
                 <a:ea typeface="맑은 고딕"/>
                 <a:cs typeface="맑은 고딕"/>
               </a:rPr>
-              <a:t>전제: 접수 시점에 세부 코드를 얻을</a:t>
+              <a:t>(22/26건, 84.6%): 연계 부품</a:t>
             </a:r>
             <a:br>
               <a:rPr lang="ko-KR" sz="1150" b="0" dirty="0">
@@ -16574,7 +16596,7 @@
                 <a:ea typeface="맑은 고딕"/>
                 <a:cs typeface="맑은 고딕"/>
               </a:rPr>
-              <a:t>수 있어야 함 (파일럿에서 측정)</a:t>
+              <a:t>점검, 재수리 +32.9h 방지</a:t>
             </a:r>
           </a:p>
           <a:p>
@@ -16592,6 +16614,17 @@
               <a:buChar char="•"/>
             </a:pPr>
             <a:r>
+              <a:rPr lang="ko-KR" sz="1150" b="1" dirty="0">
+                <a:solidFill>
+                  <a:srgbClr val="2563EB"/>
+                </a:solidFill>
+                <a:latin typeface="맑은 고딕"/>
+                <a:ea typeface="맑은 고딕"/>
+                <a:cs typeface="맑은 고딕"/>
+              </a:rPr>
+              <a:t>P-4·B-4 외주 위탁 </a:t>
+            </a:r>
+            <a:r>
               <a:rPr lang="ko-KR" sz="1150" b="0" dirty="0">
                 <a:solidFill>
                   <a:srgbClr val="334155"/>
@@ -16600,7 +16633,7 @@
                 <a:ea typeface="맑은 고딕"/>
                 <a:cs typeface="맑은 고딕"/>
               </a:rPr>
-              <a:t>한계: 우편 207건은 웹 전환 필요</a:t>
+              <a:t>(59건): 외주 사전 확정</a:t>
             </a:r>
           </a:p>
         </p:txBody>

</xml_diff>

<commit_message>
feat(deck): slide 17 wording - 기존 실사 유지 / 정밀 실사로 변경
Co-Authored-By: Claude Sonnet 5.5 <noreply@anthropic.com>
</commit_message>
<xml_diff>
--- a/outputs/pptx/puzzledata_repair_report.pptx
+++ b/outputs/pptx/puzzledata_repair_report.pptx
@@ -125,21 +125,21 @@
   <p:extLst>
     <p:ext uri="{521415D9-36F7-43E2-AB2F-B90AF26B5E84}">
       <p14:sectionLst xmlns:p14="http://schemas.microsoft.com/office/powerpoint/2010/main">
-        <p14:section name="Part 00 · 인트로" id="{E5E6DFA5-791A-4C48-9520-117D04C0FE59}">
+        <p14:section name="Part 00 · 인트로" id="{2C23A16E-1E89-494A-BD09-8484CA0A10E7}">
           <p14:sldIdLst>
             <p14:sldId id="256"/>
             <p14:sldId id="257"/>
             <p14:sldId id="258"/>
           </p14:sldIdLst>
         </p14:section>
-        <p14:section name="Part 01 · 데이터 진단" id="{8E76EAF9-63B5-4383-840E-8073156B1E9D}">
+        <p14:section name="Part 01 · 데이터 진단" id="{3D3971A6-8413-4462-86FD-D65895E65764}">
           <p14:sldIdLst>
             <p14:sldId id="259"/>
             <p14:sldId id="260"/>
             <p14:sldId id="261"/>
           </p14:sldIdLst>
         </p14:section>
-        <p14:section name="Part 02 · 병목 규명" id="{CBF4CFA0-0BB6-4073-9237-7745558EAA81}">
+        <p14:section name="Part 02 · 병목 규명" id="{D14D805F-0FBF-43B1-BB12-916627A86B28}">
           <p14:sldIdLst>
             <p14:sldId id="262"/>
             <p14:sldId id="263"/>
@@ -152,14 +152,14 @@
             <p14:sldId id="270"/>
           </p14:sldIdLst>
         </p14:section>
-        <p14:section name="Part 03 · 개선 전략" id="{511A4D9E-0018-4BEF-AF5E-4EC095446753}">
+        <p14:section name="Part 03 · 개선 전략" id="{0068E0B7-3550-4113-A0B0-0AEDDB95CB60}">
           <p14:sldIdLst>
             <p14:sldId id="271"/>
             <p14:sldId id="272"/>
             <p14:sldId id="273"/>
           </p14:sldIdLst>
         </p14:section>
-        <p14:section name="Part 04 · Q&amp;A" id="{BEC7B77F-A30B-44DF-8F8E-17F13DAF8924}">
+        <p14:section name="Part 04 · Q&amp;A" id="{7D06BC61-E929-48B7-9D92-2F0AD2C57130}">
           <p14:sldIdLst>
             <p14:sldId id="274"/>
           </p14:sldIdLst>
@@ -16153,7 +16153,7 @@
                 <a:ea typeface="맑은 고딕"/>
                 <a:cs typeface="맑은 고딕"/>
               </a:rPr>
-              <a:t>정밀검사(실사) 유지</a:t>
+              <a:t>기존 실사 유지</a:t>
             </a:r>
           </a:p>
         </p:txBody>
@@ -16517,9 +16517,41 @@
                 <a:ea typeface="맑은 고딕"/>
                 <a:cs typeface="맑은 고딕"/>
               </a:rPr>
-              <a:t>정밀검사 대상</a:t>
+              <a:t>정밀검사 대상 </a:t>
+            </a:r>
+            <a:r>
+              <a:rPr lang="ko-KR" sz="1150" b="0" dirty="0">
+                <a:solidFill>
+                  <a:srgbClr val="334155"/>
+                </a:solidFill>
+                <a:latin typeface="맑은 고딕"/>
+                <a:ea typeface="맑은 고딕"/>
+                <a:cs typeface="맑은 고딕"/>
+              </a:rPr>
+              <a:t>판별,</a:t>
             </a:r>
             <a:br>
+              <a:rPr lang="ko-KR" sz="1150" b="1" dirty="0">
+                <a:solidFill>
+                  <a:srgbClr val="2563EB"/>
+                </a:solidFill>
+                <a:latin typeface="맑은 고딕"/>
+                <a:ea typeface="맑은 고딕"/>
+                <a:cs typeface="맑은 고딕"/>
+              </a:rPr>
+            </a:br>
+            <a:r>
+              <a:rPr lang="ko-KR" sz="1150" b="1" dirty="0">
+                <a:solidFill>
+                  <a:srgbClr val="2563EB"/>
+                </a:solidFill>
+                <a:latin typeface="맑은 고딕"/>
+                <a:ea typeface="맑은 고딕"/>
+                <a:cs typeface="맑은 고딕"/>
+              </a:rPr>
+              <a:t>정밀 실사</a:t>
+            </a:r>
+            <a:r>
               <a:rPr lang="ko-KR" sz="1150" b="0" dirty="0">
                 <a:solidFill>
                   <a:srgbClr val="334155"/>
@@ -16528,17 +16560,7 @@
                 <a:ea typeface="맑은 고딕"/>
                 <a:cs typeface="맑은 고딕"/>
               </a:rPr>
-            </a:br>
-            <a:r>
-              <a:rPr lang="ko-KR" sz="1150" b="0" dirty="0">
-                <a:solidFill>
-                  <a:srgbClr val="334155"/>
-                </a:solidFill>
-                <a:latin typeface="맑은 고딕"/>
-                <a:ea typeface="맑은 고딕"/>
-                <a:cs typeface="맑은 고딕"/>
-              </a:rPr>
-              <a:t>판별, 실사 유지</a:t>
+              <a:t>로 변경</a:t>
             </a:r>
           </a:p>
           <a:p>

</xml_diff>

<commit_message>
feat(deck): slide 18 remove assumptions banner, label chart 실사 대기 단축 20% 가정, replace pilot card with experiment design sketch
Co-Authored-By: Claude Sonnet 5.5 <noreply@anthropic.com>
</commit_message>
<xml_diff>
--- a/outputs/pptx/puzzledata_repair_report.pptx
+++ b/outputs/pptx/puzzledata_repair_report.pptx
@@ -125,21 +125,21 @@
   <p:extLst>
     <p:ext uri="{521415D9-36F7-43E2-AB2F-B90AF26B5E84}">
       <p14:sectionLst xmlns:p14="http://schemas.microsoft.com/office/powerpoint/2010/main">
-        <p14:section name="Part 00 · 인트로" id="{2C23A16E-1E89-494A-BD09-8484CA0A10E7}">
+        <p14:section name="Part 00 · 인트로" id="{B92DEC21-26AA-440D-A133-81F9418989D0}">
           <p14:sldIdLst>
             <p14:sldId id="256"/>
             <p14:sldId id="257"/>
             <p14:sldId id="258"/>
           </p14:sldIdLst>
         </p14:section>
-        <p14:section name="Part 01 · 데이터 진단" id="{3D3971A6-8413-4462-86FD-D65895E65764}">
+        <p14:section name="Part 01 · 데이터 진단" id="{96ACF6E8-13A9-454C-BED4-0F154E1BDCCD}">
           <p14:sldIdLst>
             <p14:sldId id="259"/>
             <p14:sldId id="260"/>
             <p14:sldId id="261"/>
           </p14:sldIdLst>
         </p14:section>
-        <p14:section name="Part 02 · 병목 규명" id="{D14D805F-0FBF-43B1-BB12-916627A86B28}">
+        <p14:section name="Part 02 · 병목 규명" id="{93694719-105F-471E-A3A8-5C1AD97CFA39}">
           <p14:sldIdLst>
             <p14:sldId id="262"/>
             <p14:sldId id="263"/>
@@ -152,14 +152,14 @@
             <p14:sldId id="270"/>
           </p14:sldIdLst>
         </p14:section>
-        <p14:section name="Part 03 · 개선 전략" id="{0068E0B7-3550-4113-A0B0-0AEDDB95CB60}">
+        <p14:section name="Part 03 · 개선 전략" id="{6F994CAB-3805-4F75-8905-967CA3515A91}">
           <p14:sldIdLst>
             <p14:sldId id="271"/>
             <p14:sldId id="272"/>
             <p14:sldId id="273"/>
           </p14:sldIdLst>
         </p14:section>
-        <p14:section name="Part 04 · Q&amp;A" id="{7D06BC61-E929-48B7-9D92-2F0AD2C57130}">
+        <p14:section name="Part 04 · Q&amp;A" id="{A50ED1CD-330E-4B64-B283-608561209159}">
           <p14:sldIdLst>
             <p14:sldId id="274"/>
           </p14:sldIdLst>
@@ -1195,7 +1195,7 @@
           <a:lstStyle/>
           <a:p>
             <a:r>
-              <a:t>효과는 하나의 가정으로만 계산했습니다. 즉시 수리 365건이 실사 줄에서 빠지면 실사 줄 유입이 일 134.3건에서 81.4건으로 39.4% 줄어듭니다. 이 유입 감소의 약 절반만 대기 단축으로 반영해 실사 대기를 20%, 즉 76.8시간에서 61.4시간으로 15.4시간 줄인다고 가정합니다. 실사 대기는 리드타임의 구성요소이므로 1대1로 반영해 105.9시간이 90.5시간, ▼14.5%입니다. 단축률이 10%면 ▼7.3%, 30%면 ▼21.8%입니다. 이 숫자는 예측이 아니라 가정입니다. 기사 11명을 두 줄이 공유하고 관측 데이터에는 줄을 나눈 사례가 없어 순수 효과는 식별되지 않습니다. 그래서 즉시 건만 별도 줄로 운영하는 파일럿을 제안하고, 나머지 줄의 대기와 직행 적중률, 재방문 건수로 판정합니다. 자재 사전 확보, 재방문 방지, 접수 인계 제거는 근거가 부족해 효과에서 제외했고 상방 요인으로 남깁니다. [예상 질문] 20%의 근거는? → 유입 감소율 39.4%의 약 절반이라는 보수 가정입니다. 참고로 일별 대기열 모델에서 실사 단계가 사라져 해방되는 기사 시간 7.2%만 반영해도 평균 대기가 약 18% 줄지만, 기준값이 구성상 항등식이고 부하가 큰 8일 구간이라 상한 참고로만 씁니다. [예상 질문] 줄별 평균(즉시 줄, 나머지 줄)으로 계산하지 않은 이유는? → 두 줄은 지금 하나의 대기열을 공유한 상태의 평균이라 줄을 나눈 뒤의 대기를 대표하지 않고, B형 118건(대기 0.1시간)이 섞여 있어 실제 큐 대기와도 다릅니다.</a:t>
+              <a:t>효과는 하나의 가정으로만 계산했습니다. 즉시 수리 365건이 실사 줄에서 빠지면 실사 줄 유입이 일 134.3건에서 81.4건으로 39.4% 줄어듭니다. 이 유입 감소의 약 절반만 대기 단축으로 반영해 실사 대기를 20%, 즉 76.8시간에서 61.4시간으로 15.4시간 줄인다고 가정합니다. 실사 대기는 리드타임의 구성요소이므로 1대1로 반영해 105.9시간이 90.5시간, ▼14.5%입니다. 단축률이 10%면 ▼7.3%, 30%면 ▼21.8%입니다. 이 숫자는 예측이 아니라 가정입니다. 기사 11명을 두 줄이 공유하고 관측 데이터에는 줄을 나눈 사례가 없어 순수 효과는 식별되지 않습니다. 그래서 실험 설계를 구상했습니다. 대상은 현행 작업 경로 케이스와 통합 경로 케이스이고, 비교는 통합 경로로 빠진 이후 현행 작업 경로의 실사 대기 시간 증감 추이이며, 평가는 통합 경로 유도 적중률, 현행 경로 실사 대기 감소폭, 적체 WIP 부담 등입니다. 자재 사전 확보, 재방문 방지, 접수 인계 제거는 근거가 부족해 효과에서 제외했고 상방 요인으로 남깁니다. [예상 질문] 20%의 근거는? → 유입 감소율 39.4%의 약 절반이라는 보수 가정입니다. 참고로 일별 대기열 모델에서 실사 단계가 사라져 해방되는 기사 시간 7.2%만 반영해도 평균 대기가 약 18% 줄지만, 기준값이 구성상 항등식이고 부하가 큰 8일 구간이라 상한 참고로만 씁니다. [예상 질문] 줄별 평균(즉시 줄, 나머지 줄)으로 계산하지 않은 이유는? → 두 줄은 지금 하나의 대기열을 공유한 상태의 평균이라 줄을 나눈 뒤의 대기를 대표하지 않고, B형 118건(대기 0.1시간)이 섞여 있어 실제 큐 대기와도 다릅니다.</a:t>
             </a:r>
           </a:p>
         </p:txBody>
@@ -17263,7 +17263,7 @@
                 <a:ea typeface="맑은 고딕"/>
                 <a:cs typeface="맑은 고딕"/>
               </a:rPr>
-              <a:t>줄 분리의 순수 효과는 로그로 식별할 수 없어 단축률을 가정하고, 파일럿으로 검증한다</a:t>
+              <a:t>줄 분리의 순수 효과는 로그로 식별할 수 없어 단축률을 가정하고, 실험으로 검증한다</a:t>
             </a:r>
           </a:p>
         </p:txBody>
@@ -17388,7 +17388,7 @@
         <p:spPr>
           <a:xfrm>
             <a:off x="502920" y="1554480"/>
-            <a:ext cx="5669280" cy="3564382"/>
+            <a:ext cx="5669280" cy="4754880"/>
           </a:xfrm>
           <a:prstGeom prst="rect">
             <a:avLst/>
@@ -17459,13 +17459,13 @@
             <a:r>
               <a:rPr lang="ko-KR" sz="950" b="1" dirty="0">
                 <a:solidFill>
-                  <a:srgbClr val="64748B"/>
+                  <a:srgbClr val="2563EB"/>
                 </a:solidFill>
                 <a:latin typeface="Consolas"/>
                 <a:ea typeface="맑은 고딕"/>
                 <a:cs typeface="Consolas"/>
               </a:rPr>
-              <a:t>TO-BE vs AS-IS · 평균 리드타임</a:t>
+              <a:t>실사 대기 단축 20% 가정</a:t>
             </a:r>
           </a:p>
         </p:txBody>
@@ -17478,7 +17478,7 @@
         </p:nvSpPr>
         <p:spPr>
           <a:xfrm>
-            <a:off x="704088" y="2042414"/>
+            <a:off x="704088" y="2133854"/>
             <a:ext cx="566928" cy="158750"/>
           </a:xfrm>
           <a:prstGeom prst="rect">
@@ -17523,8 +17523,8 @@
         </p:nvSpPr>
         <p:spPr>
           <a:xfrm>
-            <a:off x="1344168" y="2005838"/>
-            <a:ext cx="3392424" cy="310896"/>
+            <a:off x="1344168" y="2060702"/>
+            <a:ext cx="3392424" cy="420624"/>
           </a:xfrm>
           <a:prstGeom prst="rect">
             <a:avLst/>
@@ -17567,31 +17567,31 @@
         </p:nvSpPr>
         <p:spPr>
           <a:xfrm>
-            <a:off x="4809744" y="2042414"/>
-            <a:ext cx="1005840" cy="209550"/>
-          </a:xfrm>
-          <a:prstGeom prst="rect">
-            <a:avLst/>
-          </a:prstGeom>
-          <a:noFill/>
-        </p:spPr>
-        <p:txBody>
-          <a:bodyPr wrap="square" lIns="0" tIns="0" rIns="0" bIns="0" anchor="t">
-            <a:noAutofit/>
-          </a:bodyPr>
-          <a:lstStyle/>
-          <a:p>
-            <a:pPr algn="l">
-              <a:lnSpc>
-                <a:spcPts val="1650"/>
-              </a:lnSpc>
-              <a:spcBef>
-                <a:spcPts val="0"/>
-              </a:spcBef>
-              <a:buNone/>
-            </a:pPr>
-            <a:r>
-              <a:rPr lang="ko-KR" sz="1250" b="1" dirty="0">
+            <a:off x="4809744" y="2133854"/>
+            <a:ext cx="1005840" cy="251460"/>
+          </a:xfrm>
+          <a:prstGeom prst="rect">
+            <a:avLst/>
+          </a:prstGeom>
+          <a:noFill/>
+        </p:spPr>
+        <p:txBody>
+          <a:bodyPr wrap="square" lIns="0" tIns="0" rIns="0" bIns="0" anchor="t">
+            <a:noAutofit/>
+          </a:bodyPr>
+          <a:lstStyle/>
+          <a:p>
+            <a:pPr algn="l">
+              <a:lnSpc>
+                <a:spcPts val="1980"/>
+              </a:lnSpc>
+              <a:spcBef>
+                <a:spcPts val="0"/>
+              </a:spcBef>
+              <a:buNone/>
+            </a:pPr>
+            <a:r>
+              <a:rPr lang="ko-KR" sz="1500" b="1" dirty="0">
                 <a:solidFill>
                   <a:srgbClr val="0F172A"/>
                 </a:solidFill>
@@ -17612,7 +17612,7 @@
         </p:nvSpPr>
         <p:spPr>
           <a:xfrm>
-            <a:off x="704088" y="2463038"/>
+            <a:off x="704088" y="2700782"/>
             <a:ext cx="566928" cy="158750"/>
           </a:xfrm>
           <a:prstGeom prst="rect">
@@ -17657,8 +17657,8 @@
         </p:nvSpPr>
         <p:spPr>
           <a:xfrm>
-            <a:off x="1344168" y="2426462"/>
-            <a:ext cx="2899096" cy="310896"/>
+            <a:off x="1344168" y="2627630"/>
+            <a:ext cx="2899096" cy="420624"/>
           </a:xfrm>
           <a:prstGeom prst="rect">
             <a:avLst/>
@@ -17701,31 +17701,31 @@
         </p:nvSpPr>
         <p:spPr>
           <a:xfrm>
-            <a:off x="4316416" y="2463038"/>
-            <a:ext cx="1005840" cy="209550"/>
-          </a:xfrm>
-          <a:prstGeom prst="rect">
-            <a:avLst/>
-          </a:prstGeom>
-          <a:noFill/>
-        </p:spPr>
-        <p:txBody>
-          <a:bodyPr wrap="square" lIns="0" tIns="0" rIns="0" bIns="0" anchor="t">
-            <a:noAutofit/>
-          </a:bodyPr>
-          <a:lstStyle/>
-          <a:p>
-            <a:pPr algn="l">
-              <a:lnSpc>
-                <a:spcPts val="1650"/>
-              </a:lnSpc>
-              <a:spcBef>
-                <a:spcPts val="0"/>
-              </a:spcBef>
-              <a:buNone/>
-            </a:pPr>
-            <a:r>
-              <a:rPr lang="ko-KR" sz="1250" b="1" dirty="0">
+            <a:off x="4316416" y="2700782"/>
+            <a:ext cx="1005840" cy="251460"/>
+          </a:xfrm>
+          <a:prstGeom prst="rect">
+            <a:avLst/>
+          </a:prstGeom>
+          <a:noFill/>
+        </p:spPr>
+        <p:txBody>
+          <a:bodyPr wrap="square" lIns="0" tIns="0" rIns="0" bIns="0" anchor="t">
+            <a:noAutofit/>
+          </a:bodyPr>
+          <a:lstStyle/>
+          <a:p>
+            <a:pPr algn="l">
+              <a:lnSpc>
+                <a:spcPts val="1980"/>
+              </a:lnSpc>
+              <a:spcBef>
+                <a:spcPts val="0"/>
+              </a:spcBef>
+              <a:buNone/>
+            </a:pPr>
+            <a:r>
+              <a:rPr lang="ko-KR" sz="1500" b="1" dirty="0">
                 <a:solidFill>
                   <a:srgbClr val="0F172A"/>
                 </a:solidFill>
@@ -17746,31 +17746,31 @@
         </p:nvSpPr>
         <p:spPr>
           <a:xfrm>
-            <a:off x="1344168" y="2865374"/>
-            <a:ext cx="4626864" cy="251460"/>
-          </a:xfrm>
-          <a:prstGeom prst="rect">
-            <a:avLst/>
-          </a:prstGeom>
-          <a:noFill/>
-        </p:spPr>
-        <p:txBody>
-          <a:bodyPr wrap="square" lIns="0" tIns="0" rIns="0" bIns="0" anchor="t">
-            <a:noAutofit/>
-          </a:bodyPr>
-          <a:lstStyle/>
-          <a:p>
-            <a:pPr algn="l">
-              <a:lnSpc>
-                <a:spcPts val="1980"/>
-              </a:lnSpc>
-              <a:spcBef>
-                <a:spcPts val="0"/>
-              </a:spcBef>
-              <a:buNone/>
-            </a:pPr>
-            <a:r>
-              <a:rPr lang="ko-KR" sz="1500" b="1" dirty="0">
+            <a:off x="1344168" y="3231134"/>
+            <a:ext cx="4626864" cy="302260"/>
+          </a:xfrm>
+          <a:prstGeom prst="rect">
+            <a:avLst/>
+          </a:prstGeom>
+          <a:noFill/>
+        </p:spPr>
+        <p:txBody>
+          <a:bodyPr wrap="square" lIns="0" tIns="0" rIns="0" bIns="0" anchor="t">
+            <a:noAutofit/>
+          </a:bodyPr>
+          <a:lstStyle/>
+          <a:p>
+            <a:pPr algn="l">
+              <a:lnSpc>
+                <a:spcPts val="2380"/>
+              </a:lnSpc>
+              <a:spcBef>
+                <a:spcPts val="0"/>
+              </a:spcBef>
+              <a:buNone/>
+            </a:pPr>
+            <a:r>
+              <a:rPr lang="ko-KR" sz="1800" b="1" dirty="0">
                 <a:solidFill>
                   <a:srgbClr val="059669"/>
                 </a:solidFill>
@@ -17791,7 +17791,7 @@
         </p:nvCxnSpPr>
         <p:spPr>
           <a:xfrm>
-            <a:off x="704088" y="3295142"/>
+            <a:off x="704088" y="3843782"/>
             <a:ext cx="5266943" cy="0"/>
           </a:xfrm>
           <a:prstGeom prst="line">
@@ -17812,7 +17812,7 @@
         </p:nvSpPr>
         <p:spPr>
           <a:xfrm>
-            <a:off x="704088" y="3395726"/>
+            <a:off x="704088" y="3999230"/>
             <a:ext cx="5266944" cy="158750"/>
           </a:xfrm>
           <a:prstGeom prst="rect">
@@ -17857,7 +17857,7 @@
         </p:nvSpPr>
         <p:spPr>
           <a:xfrm>
-            <a:off x="795528" y="3682492"/>
+            <a:off x="795528" y="4340860"/>
             <a:ext cx="1018352" cy="158750"/>
           </a:xfrm>
           <a:prstGeom prst="rect">
@@ -17902,7 +17902,7 @@
         </p:nvSpPr>
         <p:spPr>
           <a:xfrm>
-            <a:off x="1996760" y="3682492"/>
+            <a:off x="1996760" y="4340860"/>
             <a:ext cx="2681598" cy="158750"/>
           </a:xfrm>
           <a:prstGeom prst="rect">
@@ -17947,7 +17947,7 @@
         </p:nvSpPr>
         <p:spPr>
           <a:xfrm>
-            <a:off x="4861239" y="3682492"/>
+            <a:off x="4861239" y="4340860"/>
             <a:ext cx="1018352" cy="158750"/>
           </a:xfrm>
           <a:prstGeom prst="rect">
@@ -17992,7 +17992,7 @@
         </p:nvCxnSpPr>
         <p:spPr>
           <a:xfrm>
-            <a:off x="704088" y="3920236"/>
+            <a:off x="704088" y="4578603"/>
             <a:ext cx="5266943" cy="0"/>
           </a:xfrm>
           <a:prstGeom prst="line">
@@ -18013,7 +18013,7 @@
         </p:nvSpPr>
         <p:spPr>
           <a:xfrm>
-            <a:off x="795528" y="3984244"/>
+            <a:off x="795528" y="4724908"/>
             <a:ext cx="1018352" cy="204470"/>
           </a:xfrm>
           <a:prstGeom prst="rect">
@@ -18058,7 +18058,7 @@
         </p:nvSpPr>
         <p:spPr>
           <a:xfrm>
-            <a:off x="1996760" y="3984244"/>
+            <a:off x="1996760" y="4724908"/>
             <a:ext cx="2681598" cy="193040"/>
           </a:xfrm>
           <a:prstGeom prst="rect">
@@ -18103,7 +18103,7 @@
         </p:nvSpPr>
         <p:spPr>
           <a:xfrm>
-            <a:off x="4861239" y="3984244"/>
+            <a:off x="4861239" y="4724908"/>
             <a:ext cx="1018352" cy="193040"/>
           </a:xfrm>
           <a:prstGeom prst="rect">
@@ -18148,7 +18148,7 @@
         </p:nvCxnSpPr>
         <p:spPr>
           <a:xfrm>
-            <a:off x="704088" y="4252722"/>
+            <a:off x="704088" y="5075681"/>
             <a:ext cx="5266943" cy="0"/>
           </a:xfrm>
           <a:prstGeom prst="line">
@@ -18169,8 +18169,8 @@
         </p:nvSpPr>
         <p:spPr>
           <a:xfrm>
-            <a:off x="704088" y="4261866"/>
-            <a:ext cx="5266944" cy="323342"/>
+            <a:off x="704088" y="5084825"/>
+            <a:ext cx="5266944" cy="487934"/>
           </a:xfrm>
           <a:prstGeom prst="rect">
             <a:avLst/>
@@ -18213,7 +18213,7 @@
         </p:nvSpPr>
         <p:spPr>
           <a:xfrm>
-            <a:off x="795528" y="4316730"/>
+            <a:off x="795528" y="5221985"/>
             <a:ext cx="1018352" cy="204470"/>
           </a:xfrm>
           <a:prstGeom prst="rect">
@@ -18258,7 +18258,7 @@
         </p:nvSpPr>
         <p:spPr>
           <a:xfrm>
-            <a:off x="1996760" y="4316730"/>
+            <a:off x="1996760" y="5221985"/>
             <a:ext cx="2681598" cy="193040"/>
           </a:xfrm>
           <a:prstGeom prst="rect">
@@ -18303,7 +18303,7 @@
         </p:nvSpPr>
         <p:spPr>
           <a:xfrm>
-            <a:off x="4861239" y="4316730"/>
+            <a:off x="4861239" y="5221985"/>
             <a:ext cx="1018352" cy="193040"/>
           </a:xfrm>
           <a:prstGeom prst="rect">
@@ -18348,7 +18348,7 @@
         </p:nvCxnSpPr>
         <p:spPr>
           <a:xfrm>
-            <a:off x="704088" y="4585208"/>
+            <a:off x="704088" y="5572759"/>
             <a:ext cx="5266943" cy="0"/>
           </a:xfrm>
           <a:prstGeom prst="line">
@@ -18369,7 +18369,7 @@
         </p:nvSpPr>
         <p:spPr>
           <a:xfrm>
-            <a:off x="795528" y="4649216"/>
+            <a:off x="795528" y="5719063"/>
             <a:ext cx="1018352" cy="204470"/>
           </a:xfrm>
           <a:prstGeom prst="rect">
@@ -18414,7 +18414,7 @@
         </p:nvSpPr>
         <p:spPr>
           <a:xfrm>
-            <a:off x="1996760" y="4649216"/>
+            <a:off x="1996760" y="5719063"/>
             <a:ext cx="2681598" cy="193040"/>
           </a:xfrm>
           <a:prstGeom prst="rect">
@@ -18459,7 +18459,7 @@
         </p:nvSpPr>
         <p:spPr>
           <a:xfrm>
-            <a:off x="4861239" y="4649216"/>
+            <a:off x="4861239" y="5719063"/>
             <a:ext cx="1018352" cy="193040"/>
           </a:xfrm>
           <a:prstGeom prst="rect">
@@ -18505,7 +18505,7 @@
         <p:spPr>
           <a:xfrm>
             <a:off x="6355080" y="1554480"/>
-            <a:ext cx="5333695" cy="3564382"/>
+            <a:ext cx="5333695" cy="4754880"/>
           </a:xfrm>
           <a:prstGeom prst="rect">
             <a:avLst/>
@@ -18582,7 +18582,7 @@
                 <a:ea typeface="맑은 고딕"/>
                 <a:cs typeface="Consolas"/>
               </a:rPr>
-              <a:t>PILOT · 순수 효과 검증 설계</a:t>
+              <a:t>실험 설계 구상</a:t>
             </a:r>
           </a:p>
         </p:txBody>
@@ -18595,7 +18595,7 @@
         </p:nvSpPr>
         <p:spPr>
           <a:xfrm>
-            <a:off x="6629400" y="2124710"/>
+            <a:off x="6629400" y="2463038"/>
             <a:ext cx="737107" cy="204470"/>
           </a:xfrm>
           <a:prstGeom prst="rect">
@@ -18634,66 +18634,45 @@
       </p:sp>
       <p:sp>
         <p:nvSpPr>
-          <p:cNvPr id="39" name="body:L2:t"/>
-          <p:cNvSpPr txBox="1"/>
-          <p:nvPr/>
-        </p:nvSpPr>
-        <p:spPr>
-          <a:xfrm>
-            <a:off x="7549387" y="2124710"/>
-            <a:ext cx="3865067" cy="391160"/>
-          </a:xfrm>
-          <a:prstGeom prst="rect">
-            <a:avLst/>
-          </a:prstGeom>
-          <a:noFill/>
-        </p:spPr>
-        <p:txBody>
-          <a:bodyPr wrap="square" lIns="0" tIns="0" rIns="0" bIns="0" anchor="t">
-            <a:noAutofit/>
-          </a:bodyPr>
-          <a:lstStyle/>
-          <a:p>
-            <a:pPr algn="l">
-              <a:lnSpc>
-                <a:spcPts val="1540"/>
-              </a:lnSpc>
-              <a:spcBef>
-                <a:spcPts val="0"/>
-              </a:spcBef>
-              <a:buNone/>
-            </a:pPr>
-            <a:r>
-              <a:rPr lang="ko-KR" sz="1100" b="0" dirty="0">
-                <a:solidFill>
-                  <a:srgbClr val="64748B"/>
-                </a:solidFill>
-                <a:latin typeface="맑은 고딕"/>
-                <a:ea typeface="맑은 고딕"/>
-                <a:cs typeface="맑은 고딕"/>
-              </a:rPr>
-              <a:t>즉시 코드 P-1·3 365건만 별도 줄로 분리(예약 슬롯 확보),</a:t>
-            </a:r>
-            <a:br>
-              <a:rPr lang="ko-KR" sz="1100" b="0" dirty="0">
-                <a:solidFill>
-                  <a:srgbClr val="64748B"/>
-                </a:solidFill>
-                <a:latin typeface="맑은 고딕"/>
-                <a:ea typeface="맑은 고딕"/>
-                <a:cs typeface="맑은 고딕"/>
-              </a:rPr>
-            </a:br>
-            <a:r>
-              <a:rPr lang="ko-KR" sz="1100" b="0" dirty="0">
-                <a:solidFill>
-                  <a:srgbClr val="64748B"/>
-                </a:solidFill>
-                <a:latin typeface="맑은 고딕"/>
-                <a:ea typeface="맑은 고딕"/>
-                <a:cs typeface="맑은 고딕"/>
-              </a:rPr>
-              <a:t>나머지는 현행 유지</a:t>
+          <p:cNvPr id="39" name="body:L1:t"/>
+          <p:cNvSpPr txBox="1"/>
+          <p:nvPr/>
+        </p:nvSpPr>
+        <p:spPr>
+          <a:xfrm>
+            <a:off x="7549387" y="2463038"/>
+            <a:ext cx="3865067" cy="240029"/>
+          </a:xfrm>
+          <a:prstGeom prst="rect">
+            <a:avLst/>
+          </a:prstGeom>
+          <a:noFill/>
+        </p:spPr>
+        <p:txBody>
+          <a:bodyPr wrap="square" lIns="0" tIns="0" rIns="0" bIns="0" anchor="t">
+            <a:noAutofit/>
+          </a:bodyPr>
+          <a:lstStyle/>
+          <a:p>
+            <a:pPr algn="l">
+              <a:lnSpc>
+                <a:spcPts val="1890"/>
+              </a:lnSpc>
+              <a:spcBef>
+                <a:spcPts val="0"/>
+              </a:spcBef>
+              <a:buNone/>
+            </a:pPr>
+            <a:r>
+              <a:rPr lang="ko-KR" sz="1350" b="0" dirty="0">
+                <a:solidFill>
+                  <a:srgbClr val="334155"/>
+                </a:solidFill>
+                <a:latin typeface="맑은 고딕"/>
+                <a:ea typeface="맑은 고딕"/>
+                <a:cs typeface="맑은 고딕"/>
+              </a:rPr>
+              <a:t>현행 작업 경로 케이스와 통합 경로 케이스</a:t>
             </a:r>
           </a:p>
         </p:txBody>
@@ -18706,7 +18685,7 @@
         </p:nvCxnSpPr>
         <p:spPr>
           <a:xfrm>
-            <a:off x="6537960" y="2634742"/>
+            <a:off x="6537960" y="3160268"/>
             <a:ext cx="4967935" cy="0"/>
           </a:xfrm>
           <a:prstGeom prst="line">
@@ -18727,7 +18706,7 @@
         </p:nvSpPr>
         <p:spPr>
           <a:xfrm>
-            <a:off x="6629400" y="2753614"/>
+            <a:off x="6629400" y="3617468"/>
             <a:ext cx="737107" cy="204470"/>
           </a:xfrm>
           <a:prstGeom prst="rect">
@@ -18766,45 +18745,66 @@
       </p:sp>
       <p:sp>
         <p:nvSpPr>
-          <p:cNvPr id="42" name="body:L1:t"/>
-          <p:cNvSpPr txBox="1"/>
-          <p:nvPr/>
-        </p:nvSpPr>
-        <p:spPr>
-          <a:xfrm>
-            <a:off x="7549387" y="2753614"/>
-            <a:ext cx="3865067" cy="195580"/>
-          </a:xfrm>
-          <a:prstGeom prst="rect">
-            <a:avLst/>
-          </a:prstGeom>
-          <a:noFill/>
-        </p:spPr>
-        <p:txBody>
-          <a:bodyPr wrap="square" lIns="0" tIns="0" rIns="0" bIns="0" anchor="t">
-            <a:noAutofit/>
-          </a:bodyPr>
-          <a:lstStyle/>
-          <a:p>
-            <a:pPr algn="l">
-              <a:lnSpc>
-                <a:spcPts val="1540"/>
-              </a:lnSpc>
-              <a:spcBef>
-                <a:spcPts val="0"/>
-              </a:spcBef>
-              <a:buNone/>
-            </a:pPr>
-            <a:r>
-              <a:rPr lang="ko-KR" sz="1100" b="0" dirty="0">
-                <a:solidFill>
-                  <a:srgbClr val="64748B"/>
-                </a:solidFill>
-                <a:latin typeface="맑은 고딕"/>
-                <a:ea typeface="맑은 고딕"/>
-                <a:cs typeface="맑은 고딕"/>
-              </a:rPr>
-              <a:t>나머지 실사 줄의 대기(AS-IS 76.8h)와 즉시 줄의 예약 대기</a:t>
+          <p:cNvPr id="42" name="body:L2:t"/>
+          <p:cNvSpPr txBox="1"/>
+          <p:nvPr/>
+        </p:nvSpPr>
+        <p:spPr>
+          <a:xfrm>
+            <a:off x="7549387" y="3617468"/>
+            <a:ext cx="3865067" cy="480059"/>
+          </a:xfrm>
+          <a:prstGeom prst="rect">
+            <a:avLst/>
+          </a:prstGeom>
+          <a:noFill/>
+        </p:spPr>
+        <p:txBody>
+          <a:bodyPr wrap="square" lIns="0" tIns="0" rIns="0" bIns="0" anchor="t">
+            <a:noAutofit/>
+          </a:bodyPr>
+          <a:lstStyle/>
+          <a:p>
+            <a:pPr algn="l">
+              <a:lnSpc>
+                <a:spcPts val="1890"/>
+              </a:lnSpc>
+              <a:spcBef>
+                <a:spcPts val="0"/>
+              </a:spcBef>
+              <a:buNone/>
+            </a:pPr>
+            <a:r>
+              <a:rPr lang="ko-KR" sz="1350" b="0" dirty="0">
+                <a:solidFill>
+                  <a:srgbClr val="334155"/>
+                </a:solidFill>
+                <a:latin typeface="맑은 고딕"/>
+                <a:ea typeface="맑은 고딕"/>
+                <a:cs typeface="맑은 고딕"/>
+              </a:rPr>
+              <a:t>통합 경로로 빠진 이후, 현행 작업 경로의 실사</a:t>
+            </a:r>
+            <a:br>
+              <a:rPr lang="ko-KR" sz="1350" b="0" dirty="0">
+                <a:solidFill>
+                  <a:srgbClr val="334155"/>
+                </a:solidFill>
+                <a:latin typeface="맑은 고딕"/>
+                <a:ea typeface="맑은 고딕"/>
+                <a:cs typeface="맑은 고딕"/>
+              </a:rPr>
+            </a:br>
+            <a:r>
+              <a:rPr lang="ko-KR" sz="1350" b="0" dirty="0">
+                <a:solidFill>
+                  <a:srgbClr val="334155"/>
+                </a:solidFill>
+                <a:latin typeface="맑은 고딕"/>
+                <a:ea typeface="맑은 고딕"/>
+                <a:cs typeface="맑은 고딕"/>
+              </a:rPr>
+              <a:t>대기 시간 증감 추이</a:t>
             </a:r>
           </a:p>
         </p:txBody>
@@ -18817,7 +18817,7 @@
         </p:nvCxnSpPr>
         <p:spPr>
           <a:xfrm>
-            <a:off x="6537960" y="3076956"/>
+            <a:off x="6537960" y="4554728"/>
             <a:ext cx="4967935" cy="0"/>
           </a:xfrm>
           <a:prstGeom prst="line">
@@ -18838,7 +18838,7 @@
         </p:nvSpPr>
         <p:spPr>
           <a:xfrm>
-            <a:off x="6629400" y="3195828"/>
+            <a:off x="6629400" y="5011928"/>
             <a:ext cx="737107" cy="204470"/>
           </a:xfrm>
           <a:prstGeom prst="rect">
@@ -18870,168 +18870,57 @@
                 <a:ea typeface="맑은 고딕"/>
                 <a:cs typeface="맑은 고딕"/>
               </a:rPr>
-              <a:t>품질</a:t>
-            </a:r>
-          </a:p>
-        </p:txBody>
-      </p:sp>
-      <p:sp>
-        <p:nvSpPr>
-          <p:cNvPr id="45" name="body:L1:t"/>
-          <p:cNvSpPr txBox="1"/>
-          <p:nvPr/>
-        </p:nvSpPr>
-        <p:spPr>
-          <a:xfrm>
-            <a:off x="7549387" y="3195828"/>
-            <a:ext cx="3865067" cy="195580"/>
-          </a:xfrm>
-          <a:prstGeom prst="rect">
-            <a:avLst/>
-          </a:prstGeom>
-          <a:noFill/>
-        </p:spPr>
-        <p:txBody>
-          <a:bodyPr wrap="square" lIns="0" tIns="0" rIns="0" bIns="0" anchor="t">
-            <a:noAutofit/>
-          </a:bodyPr>
-          <a:lstStyle/>
-          <a:p>
-            <a:pPr algn="l">
-              <a:lnSpc>
-                <a:spcPts val="1540"/>
-              </a:lnSpc>
-              <a:spcBef>
-                <a:spcPts val="0"/>
-              </a:spcBef>
-              <a:buNone/>
-            </a:pPr>
-            <a:r>
-              <a:rPr lang="ko-KR" sz="1100" b="0" dirty="0">
-                <a:solidFill>
-                  <a:srgbClr val="64748B"/>
-                </a:solidFill>
-                <a:latin typeface="맑은 고딕"/>
-                <a:ea typeface="맑은 고딕"/>
-                <a:cs typeface="맑은 고딕"/>
-              </a:rPr>
-              <a:t>직행 적중률(AS-IS P 83.1%)과 재방문 건수(AS-IS 26건)</a:t>
-            </a:r>
-          </a:p>
-        </p:txBody>
-      </p:sp>
-      <p:cxnSp>
-        <p:nvCxnSpPr>
-          <p:cNvPr id="46" name="rule"/>
-          <p:cNvCxnSpPr/>
-          <p:nvPr/>
-        </p:nvCxnSpPr>
-        <p:spPr>
-          <a:xfrm>
-            <a:off x="6537960" y="3519170"/>
-            <a:ext cx="4967935" cy="0"/>
-          </a:xfrm>
-          <a:prstGeom prst="line">
-            <a:avLst/>
-          </a:prstGeom>
-          <a:ln w="9525">
-            <a:solidFill>
-              <a:srgbClr val="E2E8F0"/>
-            </a:solidFill>
-          </a:ln>
-        </p:spPr>
-      </p:cxnSp>
-      <p:sp>
-        <p:nvSpPr>
-          <p:cNvPr id="47" name="body:L1:t"/>
-          <p:cNvSpPr txBox="1"/>
-          <p:nvPr/>
-        </p:nvSpPr>
-        <p:spPr>
-          <a:xfrm>
-            <a:off x="6629400" y="3638042"/>
-            <a:ext cx="737107" cy="204470"/>
-          </a:xfrm>
-          <a:prstGeom prst="rect">
-            <a:avLst/>
-          </a:prstGeom>
-          <a:noFill/>
-        </p:spPr>
-        <p:txBody>
-          <a:bodyPr wrap="square" lIns="0" tIns="0" rIns="0" bIns="0" anchor="t">
-            <a:noAutofit/>
-          </a:bodyPr>
-          <a:lstStyle/>
-          <a:p>
-            <a:pPr algn="l">
-              <a:lnSpc>
-                <a:spcPts val="1610"/>
-              </a:lnSpc>
-              <a:spcBef>
-                <a:spcPts val="0"/>
-              </a:spcBef>
-              <a:buNone/>
-            </a:pPr>
-            <a:r>
-              <a:rPr lang="ko-KR" sz="1150" b="1" dirty="0">
-                <a:solidFill>
-                  <a:srgbClr val="0F172A"/>
-                </a:solidFill>
-                <a:latin typeface="맑은 고딕"/>
-                <a:ea typeface="맑은 고딕"/>
-                <a:cs typeface="맑은 고딕"/>
-              </a:rPr>
-              <a:t>판정</a:t>
-            </a:r>
-          </a:p>
-        </p:txBody>
-      </p:sp>
-      <p:sp>
-        <p:nvSpPr>
-          <p:cNvPr id="48" name="body:L2:t"/>
-          <p:cNvSpPr txBox="1"/>
-          <p:nvPr/>
-        </p:nvSpPr>
-        <p:spPr>
-          <a:xfrm>
-            <a:off x="7549387" y="3638042"/>
-            <a:ext cx="3865067" cy="391160"/>
-          </a:xfrm>
-          <a:prstGeom prst="rect">
-            <a:avLst/>
-          </a:prstGeom>
-          <a:noFill/>
-        </p:spPr>
-        <p:txBody>
-          <a:bodyPr wrap="square" lIns="0" tIns="0" rIns="0" bIns="0" anchor="t">
-            <a:noAutofit/>
-          </a:bodyPr>
-          <a:lstStyle/>
-          <a:p>
-            <a:pPr algn="l">
-              <a:lnSpc>
-                <a:spcPts val="1540"/>
-              </a:lnSpc>
-              <a:spcBef>
-                <a:spcPts val="0"/>
-              </a:spcBef>
-              <a:buNone/>
-            </a:pPr>
-            <a:r>
-              <a:rPr lang="ko-KR" sz="1100" b="0" dirty="0">
-                <a:solidFill>
-                  <a:srgbClr val="64748B"/>
-                </a:solidFill>
-                <a:latin typeface="맑은 고딕"/>
-                <a:ea typeface="맑은 고딕"/>
-                <a:cs typeface="맑은 고딕"/>
-              </a:rPr>
-              <a:t>실사 대기 단축률이 가정(10·20·30%)의 어느 구간인지 보고</a:t>
+              <a:t>평가</a:t>
+            </a:r>
+          </a:p>
+        </p:txBody>
+      </p:sp>
+      <p:sp>
+        <p:nvSpPr>
+          <p:cNvPr id="45" name="body:L2:t"/>
+          <p:cNvSpPr txBox="1"/>
+          <p:nvPr/>
+        </p:nvSpPr>
+        <p:spPr>
+          <a:xfrm>
+            <a:off x="7549387" y="5011928"/>
+            <a:ext cx="3865067" cy="480059"/>
+          </a:xfrm>
+          <a:prstGeom prst="rect">
+            <a:avLst/>
+          </a:prstGeom>
+          <a:noFill/>
+        </p:spPr>
+        <p:txBody>
+          <a:bodyPr wrap="square" lIns="0" tIns="0" rIns="0" bIns="0" anchor="t">
+            <a:noAutofit/>
+          </a:bodyPr>
+          <a:lstStyle/>
+          <a:p>
+            <a:pPr algn="l">
+              <a:lnSpc>
+                <a:spcPts val="1890"/>
+              </a:lnSpc>
+              <a:spcBef>
+                <a:spcPts val="0"/>
+              </a:spcBef>
+              <a:buNone/>
+            </a:pPr>
+            <a:r>
+              <a:rPr lang="ko-KR" sz="1350" b="0" dirty="0">
+                <a:solidFill>
+                  <a:srgbClr val="334155"/>
+                </a:solidFill>
+                <a:latin typeface="맑은 고딕"/>
+                <a:ea typeface="맑은 고딕"/>
+                <a:cs typeface="맑은 고딕"/>
+              </a:rPr>
+              <a:t>통합 경로 유도 적중률 · 현행 작업 경로의 실사</a:t>
             </a:r>
             <a:br>
-              <a:rPr lang="ko-KR" sz="1100" b="0" dirty="0">
-                <a:solidFill>
-                  <a:srgbClr val="64748B"/>
+              <a:rPr lang="ko-KR" sz="1350" b="0" dirty="0">
+                <a:solidFill>
+                  <a:srgbClr val="334155"/>
                 </a:solidFill>
                 <a:latin typeface="맑은 고딕"/>
                 <a:ea typeface="맑은 고딕"/>
@@ -19039,209 +18928,7 @@
               </a:rPr>
             </a:br>
             <a:r>
-              <a:rPr lang="ko-KR" sz="1100" b="0" dirty="0">
-                <a:solidFill>
-                  <a:srgbClr val="64748B"/>
-                </a:solidFill>
-                <a:latin typeface="맑은 고딕"/>
-                <a:ea typeface="맑은 고딕"/>
-                <a:cs typeface="맑은 고딕"/>
-              </a:rPr>
-              <a:t>확대 여부를 정한다</a:t>
-            </a:r>
-          </a:p>
-        </p:txBody>
-      </p:sp>
-      <p:sp>
-        <p:nvSpPr>
-          <p:cNvPr id="49" name="body:L2:excl"/>
-          <p:cNvSpPr txBox="1"/>
-          <p:nvPr/>
-        </p:nvSpPr>
-        <p:spPr>
-          <a:xfrm>
-            <a:off x="6537960" y="4257802"/>
-            <a:ext cx="4967935" cy="391160"/>
-          </a:xfrm>
-          <a:prstGeom prst="rect">
-            <a:avLst/>
-          </a:prstGeom>
-          <a:noFill/>
-        </p:spPr>
-        <p:txBody>
-          <a:bodyPr wrap="square" lIns="0" tIns="0" rIns="0" bIns="0" anchor="t">
-            <a:noAutofit/>
-          </a:bodyPr>
-          <a:lstStyle/>
-          <a:p>
-            <a:pPr algn="l">
-              <a:lnSpc>
-                <a:spcPts val="1540"/>
-              </a:lnSpc>
-              <a:spcBef>
-                <a:spcPts val="0"/>
-              </a:spcBef>
-              <a:buNone/>
-            </a:pPr>
-            <a:r>
-              <a:rPr lang="ko-KR" sz="1100" b="0" dirty="0">
-                <a:solidFill>
-                  <a:srgbClr val="64748B"/>
-                </a:solidFill>
-                <a:latin typeface="맑은 고딕"/>
-                <a:ea typeface="맑은 고딕"/>
-                <a:cs typeface="맑은 고딕"/>
-              </a:rPr>
-              <a:t>미반영(상방 요인): 자재 사전 확보, 재방문 방지, 접수 인계</a:t>
-            </a:r>
-            <a:br>
-              <a:rPr lang="ko-KR" sz="1100" b="0" dirty="0">
-                <a:solidFill>
-                  <a:srgbClr val="64748B"/>
-                </a:solidFill>
-                <a:latin typeface="맑은 고딕"/>
-                <a:ea typeface="맑은 고딕"/>
-                <a:cs typeface="맑은 고딕"/>
-              </a:rPr>
-            </a:br>
-            <a:r>
-              <a:rPr lang="ko-KR" sz="1100" b="0" dirty="0">
-                <a:solidFill>
-                  <a:srgbClr val="64748B"/>
-                </a:solidFill>
-                <a:latin typeface="맑은 고딕"/>
-                <a:ea typeface="맑은 고딕"/>
-                <a:cs typeface="맑은 고딕"/>
-              </a:rPr>
-              <a:t>제거 — 근거가 부족해 효과에서 제외했습니다.</a:t>
-            </a:r>
-          </a:p>
-        </p:txBody>
-      </p:sp>
-      <p:sp>
-        <p:nvSpPr>
-          <p:cNvPr id="50" name="assump"/>
-          <p:cNvSpPr/>
-          <p:nvPr/>
-        </p:nvSpPr>
-        <p:spPr>
-          <a:xfrm>
-            <a:off x="502920" y="5256022"/>
-            <a:ext cx="11185855" cy="1053337"/>
-          </a:xfrm>
-          <a:prstGeom prst="rect">
-            <a:avLst/>
-          </a:prstGeom>
-          <a:solidFill>
-            <a:srgbClr val="FFFFFF"/>
-          </a:solidFill>
-          <a:ln w="9525">
-            <a:solidFill>
-              <a:srgbClr val="E2E8F0"/>
-            </a:solidFill>
-          </a:ln>
-          <a:effectLst/>
-        </p:spPr>
-        <p:style>
-          <a:lnRef idx="1">
-            <a:schemeClr val="accent1"/>
-          </a:lnRef>
-          <a:fillRef idx="3">
-            <a:schemeClr val="accent1"/>
-          </a:fillRef>
-          <a:effectRef idx="2">
-            <a:schemeClr val="accent1"/>
-          </a:effectRef>
-          <a:fontRef idx="minor">
-            <a:schemeClr val="lt1"/>
-          </a:fontRef>
-        </p:style>
-        <p:txBody>
-          <a:bodyPr rtlCol="0" anchor="ctr"/>
-          <a:lstStyle/>
-          <a:p>
-            <a:pPr algn="ctr"/>
-          </a:p>
-        </p:txBody>
-      </p:sp>
-      <p:sp>
-        <p:nvSpPr>
-          <p:cNvPr id="51" name="label:L1:t"/>
-          <p:cNvSpPr txBox="1"/>
-          <p:nvPr/>
-        </p:nvSpPr>
-        <p:spPr>
-          <a:xfrm>
-            <a:off x="667512" y="5420614"/>
-            <a:ext cx="10856671" cy="158750"/>
-          </a:xfrm>
-          <a:prstGeom prst="rect">
-            <a:avLst/>
-          </a:prstGeom>
-          <a:noFill/>
-        </p:spPr>
-        <p:txBody>
-          <a:bodyPr wrap="square" lIns="0" tIns="0" rIns="0" bIns="0" anchor="t">
-            <a:noAutofit/>
-          </a:bodyPr>
-          <a:lstStyle/>
-          <a:p>
-            <a:pPr algn="l">
-              <a:lnSpc>
-                <a:spcPts val="1250"/>
-              </a:lnSpc>
-              <a:spcBef>
-                <a:spcPts val="0"/>
-              </a:spcBef>
-              <a:buNone/>
-            </a:pPr>
-            <a:r>
-              <a:rPr lang="ko-KR" sz="950" b="1" dirty="0">
-                <a:solidFill>
-                  <a:srgbClr val="2563EB"/>
-                </a:solidFill>
-                <a:latin typeface="Consolas"/>
-                <a:ea typeface="맑은 고딕"/>
-                <a:cs typeface="Consolas"/>
-              </a:rPr>
-              <a:t>ASSUMPTIONS · 읽는 법</a:t>
-            </a:r>
-          </a:p>
-        </p:txBody>
-      </p:sp>
-      <p:sp>
-        <p:nvSpPr>
-          <p:cNvPr id="52" name="body:L2:asm"/>
-          <p:cNvSpPr txBox="1"/>
-          <p:nvPr/>
-        </p:nvSpPr>
-        <p:spPr>
-          <a:xfrm>
-            <a:off x="667512" y="5625084"/>
-            <a:ext cx="10856671" cy="426720"/>
-          </a:xfrm>
-          <a:prstGeom prst="rect">
-            <a:avLst/>
-          </a:prstGeom>
-          <a:noFill/>
-        </p:spPr>
-        <p:txBody>
-          <a:bodyPr wrap="square" lIns="0" tIns="0" rIns="0" bIns="0" anchor="t">
-            <a:noAutofit/>
-          </a:bodyPr>
-          <a:lstStyle/>
-          <a:p>
-            <a:pPr algn="l">
-              <a:lnSpc>
-                <a:spcPts val="1680"/>
-              </a:lnSpc>
-              <a:spcBef>
-                <a:spcPts val="0"/>
-              </a:spcBef>
-              <a:buNone/>
-            </a:pPr>
-            <a:r>
-              <a:rPr lang="ko-KR" sz="1200" b="0" dirty="0">
+              <a:rPr lang="ko-KR" sz="1350" b="0" dirty="0">
                 <a:solidFill>
                   <a:srgbClr val="334155"/>
                 </a:solidFill>
@@ -19249,50 +18936,7 @@
                 <a:ea typeface="맑은 고딕"/>
                 <a:cs typeface="맑은 고딕"/>
               </a:rPr>
-              <a:t>단축률 20%는 </a:t>
-            </a:r>
-            <a:r>
-              <a:rPr lang="ko-KR" sz="1200" b="1" dirty="0">
-                <a:solidFill>
-                  <a:srgbClr val="2563EB"/>
-                </a:solidFill>
-                <a:latin typeface="맑은 고딕"/>
-                <a:ea typeface="맑은 고딕"/>
-                <a:cs typeface="맑은 고딕"/>
-              </a:rPr>
-              <a:t>가정</a:t>
-            </a:r>
-            <a:r>
-              <a:rPr lang="ko-KR" sz="1200" b="0" dirty="0">
-                <a:solidFill>
-                  <a:srgbClr val="334155"/>
-                </a:solidFill>
-                <a:latin typeface="맑은 고딕"/>
-                <a:ea typeface="맑은 고딕"/>
-                <a:cs typeface="맑은 고딕"/>
-              </a:rPr>
-              <a:t>이다. 즉시 건이 빠지면 실사 줄 유입은 39.4% 줄지만 기사 11명을 두 줄이 공유해 줄 분리의 순수 효과는</a:t>
-            </a:r>
-            <a:br>
-              <a:rPr lang="ko-KR" sz="1200" b="0" dirty="0">
-                <a:solidFill>
-                  <a:srgbClr val="334155"/>
-                </a:solidFill>
-                <a:latin typeface="맑은 고딕"/>
-                <a:ea typeface="맑은 고딕"/>
-                <a:cs typeface="맑은 고딕"/>
-              </a:rPr>
-            </a:br>
-            <a:r>
-              <a:rPr lang="ko-KR" sz="1200" b="0" dirty="0">
-                <a:solidFill>
-                  <a:srgbClr val="334155"/>
-                </a:solidFill>
-                <a:latin typeface="맑은 고딕"/>
-                <a:ea typeface="맑은 고딕"/>
-                <a:cs typeface="맑은 고딕"/>
-              </a:rPr>
-              <a:t>로그로 식별되지 않는다. 20%는 유입 감소율의 약 절반만 반영한 보수 가정이며 파일럿으로 검증한다.</a:t>
+              <a:t>대기 시간 감소폭 · 적체(WIP) 부담률 등</a:t>
             </a:r>
           </a:p>
         </p:txBody>

</xml_diff>

<commit_message>
feat(deck): slide 18 experiment design terms unified (Direct Booking 케이스 / 실사 대기 케이스)
Co-Authored-By: Claude Sonnet 5.5 <noreply@anthropic.com>
</commit_message>
<xml_diff>
--- a/outputs/pptx/puzzledata_repair_report.pptx
+++ b/outputs/pptx/puzzledata_repair_report.pptx
@@ -125,21 +125,21 @@
   <p:extLst>
     <p:ext uri="{521415D9-36F7-43E2-AB2F-B90AF26B5E84}">
       <p14:sectionLst xmlns:p14="http://schemas.microsoft.com/office/powerpoint/2010/main">
-        <p14:section name="Part 00 · 인트로" id="{B92DEC21-26AA-440D-A133-81F9418989D0}">
+        <p14:section name="Part 00 · 인트로" id="{B5427831-7495-486C-AC5E-B8D5D2B5CD24}">
           <p14:sldIdLst>
             <p14:sldId id="256"/>
             <p14:sldId id="257"/>
             <p14:sldId id="258"/>
           </p14:sldIdLst>
         </p14:section>
-        <p14:section name="Part 01 · 데이터 진단" id="{96ACF6E8-13A9-454C-BED4-0F154E1BDCCD}">
+        <p14:section name="Part 01 · 데이터 진단" id="{BF46B65C-A4E7-4A84-856B-10BDB35A83AA}">
           <p14:sldIdLst>
             <p14:sldId id="259"/>
             <p14:sldId id="260"/>
             <p14:sldId id="261"/>
           </p14:sldIdLst>
         </p14:section>
-        <p14:section name="Part 02 · 병목 규명" id="{93694719-105F-471E-A3A8-5C1AD97CFA39}">
+        <p14:section name="Part 02 · 병목 규명" id="{5E00061B-6FE2-4988-9F95-217ADD59B60A}">
           <p14:sldIdLst>
             <p14:sldId id="262"/>
             <p14:sldId id="263"/>
@@ -152,14 +152,14 @@
             <p14:sldId id="270"/>
           </p14:sldIdLst>
         </p14:section>
-        <p14:section name="Part 03 · 개선 전략" id="{6F994CAB-3805-4F75-8905-967CA3515A91}">
+        <p14:section name="Part 03 · 개선 전략" id="{AB72E48B-44A9-4F9F-9BDC-2A1AF24BA2E5}">
           <p14:sldIdLst>
             <p14:sldId id="271"/>
             <p14:sldId id="272"/>
             <p14:sldId id="273"/>
           </p14:sldIdLst>
         </p14:section>
-        <p14:section name="Part 04 · Q&amp;A" id="{A50ED1CD-330E-4B64-B283-608561209159}">
+        <p14:section name="Part 04 · Q&amp;A" id="{1AB41519-31DB-4A9B-A5FF-B573F1380520}">
           <p14:sldIdLst>
             <p14:sldId id="274"/>
           </p14:sldIdLst>
@@ -1195,7 +1195,7 @@
           <a:lstStyle/>
           <a:p>
             <a:r>
-              <a:t>효과는 하나의 가정으로만 계산했습니다. 즉시 수리 365건이 실사 줄에서 빠지면 실사 줄 유입이 일 134.3건에서 81.4건으로 39.4% 줄어듭니다. 이 유입 감소의 약 절반만 대기 단축으로 반영해 실사 대기를 20%, 즉 76.8시간에서 61.4시간으로 15.4시간 줄인다고 가정합니다. 실사 대기는 리드타임의 구성요소이므로 1대1로 반영해 105.9시간이 90.5시간, ▼14.5%입니다. 단축률이 10%면 ▼7.3%, 30%면 ▼21.8%입니다. 이 숫자는 예측이 아니라 가정입니다. 기사 11명을 두 줄이 공유하고 관측 데이터에는 줄을 나눈 사례가 없어 순수 효과는 식별되지 않습니다. 그래서 실험 설계를 구상했습니다. 대상은 현행 작업 경로 케이스와 통합 경로 케이스이고, 비교는 통합 경로로 빠진 이후 현행 작업 경로의 실사 대기 시간 증감 추이이며, 평가는 통합 경로 유도 적중률, 현행 경로 실사 대기 감소폭, 적체 WIP 부담 등입니다. 자재 사전 확보, 재방문 방지, 접수 인계 제거는 근거가 부족해 효과에서 제외했고 상방 요인으로 남깁니다. [예상 질문] 20%의 근거는? → 유입 감소율 39.4%의 약 절반이라는 보수 가정입니다. 참고로 일별 대기열 모델에서 실사 단계가 사라져 해방되는 기사 시간 7.2%만 반영해도 평균 대기가 약 18% 줄지만, 기준값이 구성상 항등식이고 부하가 큰 8일 구간이라 상한 참고로만 씁니다. [예상 질문] 줄별 평균(즉시 줄, 나머지 줄)으로 계산하지 않은 이유는? → 두 줄은 지금 하나의 대기열을 공유한 상태의 평균이라 줄을 나눈 뒤의 대기를 대표하지 않고, B형 118건(대기 0.1시간)이 섞여 있어 실제 큐 대기와도 다릅니다.</a:t>
+              <a:t>효과는 하나의 가정으로만 계산했습니다. 즉시 수리 365건이 실사 줄에서 빠지면 실사 줄 유입이 일 134.3건에서 81.4건으로 39.4% 줄어듭니다. 이 유입 감소의 약 절반만 대기 단축으로 반영해 실사 대기를 20%, 즉 76.8시간에서 61.4시간으로 15.4시간 줄인다고 가정합니다. 실사 대기는 리드타임의 구성요소이므로 1대1로 반영해 105.9시간이 90.5시간, ▼14.5%입니다. 단축률이 10%면 ▼7.3%, 30%면 ▼21.8%입니다. 이 숫자는 예측이 아니라 가정입니다. 기사 11명을 두 줄이 공유하고 관측 데이터에는 줄을 나눈 사례가 없어 순수 효과는 식별되지 않습니다. 그래서 실험 설계를 구상했습니다. 대상은 Direct Booking 케이스와 실사 대기 케이스이고, 비교는 Direct Booking으로 빠진 이후 실사 대기 케이스의 실사 대기 시간 증감 추이이며, 평가는 Direct Booking 유도 적중률, 실사 대기 케이스의 실사 대기 시간 감소폭, 적체 WIP 부담 등입니다. 자재 사전 확보, 재방문 방지, 접수 인계 제거는 근거가 부족해 효과에서 제외했고 상방 요인으로 남깁니다. [예상 질문] 20%의 근거는? → 유입 감소율 39.4%의 약 절반이라는 보수 가정입니다. 참고로 일별 대기열 모델에서 실사 단계가 사라져 해방되는 기사 시간 7.2%만 반영해도 평균 대기가 약 18% 줄지만, 기준값이 구성상 항등식이고 부하가 큰 8일 구간이라 상한 참고로만 씁니다. [예상 질문] 줄별 평균(즉시 줄, 나머지 줄)으로 계산하지 않은 이유는? → 두 줄은 지금 하나의 대기열을 공유한 상태의 평균이라 줄을 나눈 뒤의 대기를 대표하지 않고, B형 118건(대기 0.1시간)이 섞여 있어 실제 큐 대기와도 다릅니다.</a:t>
             </a:r>
           </a:p>
         </p:txBody>
@@ -18595,7 +18595,7 @@
         </p:nvSpPr>
         <p:spPr>
           <a:xfrm>
-            <a:off x="6629400" y="2463038"/>
+            <a:off x="6629400" y="2426462"/>
             <a:ext cx="737107" cy="204470"/>
           </a:xfrm>
           <a:prstGeom prst="rect">
@@ -18640,31 +18640,31 @@
         </p:nvSpPr>
         <p:spPr>
           <a:xfrm>
-            <a:off x="7549387" y="2463038"/>
-            <a:ext cx="3865067" cy="240029"/>
-          </a:xfrm>
-          <a:prstGeom prst="rect">
-            <a:avLst/>
-          </a:prstGeom>
-          <a:noFill/>
-        </p:spPr>
-        <p:txBody>
-          <a:bodyPr wrap="square" lIns="0" tIns="0" rIns="0" bIns="0" anchor="t">
-            <a:noAutofit/>
-          </a:bodyPr>
-          <a:lstStyle/>
-          <a:p>
-            <a:pPr algn="l">
-              <a:lnSpc>
-                <a:spcPts val="1890"/>
-              </a:lnSpc>
-              <a:spcBef>
-                <a:spcPts val="0"/>
-              </a:spcBef>
-              <a:buNone/>
-            </a:pPr>
-            <a:r>
-              <a:rPr lang="ko-KR" sz="1350" b="0" dirty="0">
+            <a:off x="7549387" y="2426462"/>
+            <a:ext cx="3865067" cy="222250"/>
+          </a:xfrm>
+          <a:prstGeom prst="rect">
+            <a:avLst/>
+          </a:prstGeom>
+          <a:noFill/>
+        </p:spPr>
+        <p:txBody>
+          <a:bodyPr wrap="square" lIns="0" tIns="0" rIns="0" bIns="0" anchor="t">
+            <a:noAutofit/>
+          </a:bodyPr>
+          <a:lstStyle/>
+          <a:p>
+            <a:pPr algn="l">
+              <a:lnSpc>
+                <a:spcPts val="1750"/>
+              </a:lnSpc>
+              <a:spcBef>
+                <a:spcPts val="0"/>
+              </a:spcBef>
+              <a:buNone/>
+            </a:pPr>
+            <a:r>
+              <a:rPr lang="ko-KR" sz="1250" b="0" dirty="0">
                 <a:solidFill>
                   <a:srgbClr val="334155"/>
                 </a:solidFill>
@@ -18672,7 +18672,7 @@
                 <a:ea typeface="맑은 고딕"/>
                 <a:cs typeface="맑은 고딕"/>
               </a:rPr>
-              <a:t>현행 작업 경로 케이스와 통합 경로 케이스</a:t>
+              <a:t>Direct Booking 케이스와 실사 대기 케이스</a:t>
             </a:r>
           </a:p>
         </p:txBody>
@@ -18685,7 +18685,7 @@
         </p:nvCxnSpPr>
         <p:spPr>
           <a:xfrm>
-            <a:off x="6537960" y="3160268"/>
+            <a:off x="6537960" y="3069336"/>
             <a:ext cx="4967935" cy="0"/>
           </a:xfrm>
           <a:prstGeom prst="line">
@@ -18706,7 +18706,7 @@
         </p:nvSpPr>
         <p:spPr>
           <a:xfrm>
-            <a:off x="6629400" y="3617468"/>
+            <a:off x="6629400" y="3489960"/>
             <a:ext cx="737107" cy="204470"/>
           </a:xfrm>
           <a:prstGeom prst="rect">
@@ -18751,31 +18751,31 @@
         </p:nvSpPr>
         <p:spPr>
           <a:xfrm>
-            <a:off x="7549387" y="3617468"/>
-            <a:ext cx="3865067" cy="480059"/>
-          </a:xfrm>
-          <a:prstGeom prst="rect">
-            <a:avLst/>
-          </a:prstGeom>
-          <a:noFill/>
-        </p:spPr>
-        <p:txBody>
-          <a:bodyPr wrap="square" lIns="0" tIns="0" rIns="0" bIns="0" anchor="t">
-            <a:noAutofit/>
-          </a:bodyPr>
-          <a:lstStyle/>
-          <a:p>
-            <a:pPr algn="l">
-              <a:lnSpc>
-                <a:spcPts val="1890"/>
-              </a:lnSpc>
-              <a:spcBef>
-                <a:spcPts val="0"/>
-              </a:spcBef>
-              <a:buNone/>
-            </a:pPr>
-            <a:r>
-              <a:rPr lang="ko-KR" sz="1350" b="0" dirty="0">
+            <a:off x="7549387" y="3489960"/>
+            <a:ext cx="3865067" cy="444500"/>
+          </a:xfrm>
+          <a:prstGeom prst="rect">
+            <a:avLst/>
+          </a:prstGeom>
+          <a:noFill/>
+        </p:spPr>
+        <p:txBody>
+          <a:bodyPr wrap="square" lIns="0" tIns="0" rIns="0" bIns="0" anchor="t">
+            <a:noAutofit/>
+          </a:bodyPr>
+          <a:lstStyle/>
+          <a:p>
+            <a:pPr algn="l">
+              <a:lnSpc>
+                <a:spcPts val="1750"/>
+              </a:lnSpc>
+              <a:spcBef>
+                <a:spcPts val="0"/>
+              </a:spcBef>
+              <a:buNone/>
+            </a:pPr>
+            <a:r>
+              <a:rPr lang="ko-KR" sz="1250" b="0" dirty="0">
                 <a:solidFill>
                   <a:srgbClr val="334155"/>
                 </a:solidFill>
@@ -18783,10 +18783,10 @@
                 <a:ea typeface="맑은 고딕"/>
                 <a:cs typeface="맑은 고딕"/>
               </a:rPr>
-              <a:t>통합 경로로 빠진 이후, 현행 작업 경로의 실사</a:t>
+              <a:t>Direct Booking으로 빠진 이후, 실사 대기 케이스의</a:t>
             </a:r>
             <a:br>
-              <a:rPr lang="ko-KR" sz="1350" b="0" dirty="0">
+              <a:rPr lang="ko-KR" sz="1250" b="0" dirty="0">
                 <a:solidFill>
                   <a:srgbClr val="334155"/>
                 </a:solidFill>
@@ -18796,7 +18796,7 @@
               </a:rPr>
             </a:br>
             <a:r>
-              <a:rPr lang="ko-KR" sz="1350" b="0" dirty="0">
+              <a:rPr lang="ko-KR" sz="1250" b="0" dirty="0">
                 <a:solidFill>
                   <a:srgbClr val="334155"/>
                 </a:solidFill>
@@ -18804,7 +18804,7 @@
                 <a:ea typeface="맑은 고딕"/>
                 <a:cs typeface="맑은 고딕"/>
               </a:rPr>
-              <a:t>대기 시간 증감 추이</a:t>
+              <a:t>실사 대기 시간 증감 추이</a:t>
             </a:r>
           </a:p>
         </p:txBody>
@@ -18817,7 +18817,7 @@
         </p:nvCxnSpPr>
         <p:spPr>
           <a:xfrm>
-            <a:off x="6537960" y="4554728"/>
+            <a:off x="6537960" y="4355084"/>
             <a:ext cx="4967935" cy="0"/>
           </a:xfrm>
           <a:prstGeom prst="line">
@@ -18838,7 +18838,7 @@
         </p:nvSpPr>
         <p:spPr>
           <a:xfrm>
-            <a:off x="6629400" y="5011928"/>
+            <a:off x="6629400" y="4775708"/>
             <a:ext cx="737107" cy="204470"/>
           </a:xfrm>
           <a:prstGeom prst="rect">
@@ -18883,31 +18883,31 @@
         </p:nvSpPr>
         <p:spPr>
           <a:xfrm>
-            <a:off x="7549387" y="5011928"/>
-            <a:ext cx="3865067" cy="480059"/>
-          </a:xfrm>
-          <a:prstGeom prst="rect">
-            <a:avLst/>
-          </a:prstGeom>
-          <a:noFill/>
-        </p:spPr>
-        <p:txBody>
-          <a:bodyPr wrap="square" lIns="0" tIns="0" rIns="0" bIns="0" anchor="t">
-            <a:noAutofit/>
-          </a:bodyPr>
-          <a:lstStyle/>
-          <a:p>
-            <a:pPr algn="l">
-              <a:lnSpc>
-                <a:spcPts val="1890"/>
-              </a:lnSpc>
-              <a:spcBef>
-                <a:spcPts val="0"/>
-              </a:spcBef>
-              <a:buNone/>
-            </a:pPr>
-            <a:r>
-              <a:rPr lang="ko-KR" sz="1350" b="0" dirty="0">
+            <a:off x="7549387" y="4775708"/>
+            <a:ext cx="3865067" cy="444500"/>
+          </a:xfrm>
+          <a:prstGeom prst="rect">
+            <a:avLst/>
+          </a:prstGeom>
+          <a:noFill/>
+        </p:spPr>
+        <p:txBody>
+          <a:bodyPr wrap="square" lIns="0" tIns="0" rIns="0" bIns="0" anchor="t">
+            <a:noAutofit/>
+          </a:bodyPr>
+          <a:lstStyle/>
+          <a:p>
+            <a:pPr algn="l">
+              <a:lnSpc>
+                <a:spcPts val="1750"/>
+              </a:lnSpc>
+              <a:spcBef>
+                <a:spcPts val="0"/>
+              </a:spcBef>
+              <a:buNone/>
+            </a:pPr>
+            <a:r>
+              <a:rPr lang="ko-KR" sz="1250" b="0" dirty="0">
                 <a:solidFill>
                   <a:srgbClr val="334155"/>
                 </a:solidFill>
@@ -18915,10 +18915,10 @@
                 <a:ea typeface="맑은 고딕"/>
                 <a:cs typeface="맑은 고딕"/>
               </a:rPr>
-              <a:t>통합 경로 유도 적중률 · 현행 작업 경로의 실사</a:t>
+              <a:t>Direct Booking 유도 적중률 · 실사 대기 케이스의</a:t>
             </a:r>
             <a:br>
-              <a:rPr lang="ko-KR" sz="1350" b="0" dirty="0">
+              <a:rPr lang="ko-KR" sz="1250" b="0" dirty="0">
                 <a:solidFill>
                   <a:srgbClr val="334155"/>
                 </a:solidFill>
@@ -18928,7 +18928,7 @@
               </a:rPr>
             </a:br>
             <a:r>
-              <a:rPr lang="ko-KR" sz="1350" b="0" dirty="0">
+              <a:rPr lang="ko-KR" sz="1250" b="0" dirty="0">
                 <a:solidFill>
                   <a:srgbClr val="334155"/>
                 </a:solidFill>
@@ -18936,7 +18936,7 @@
                 <a:ea typeface="맑은 고딕"/>
                 <a:cs typeface="맑은 고딕"/>
               </a:rPr>
-              <a:t>대기 시간 감소폭 · 적체(WIP) 부담률 등</a:t>
+              <a:t>실사 대기 시간 감소폭 · 적체(WIP) 부담률 등</a:t>
             </a:r>
           </a:p>
         </p:txBody>

</xml_diff>

<commit_message>
feat(deck): slide 18 comparison row adds 동일 기간, notes add DID Q&A
Co-Authored-By: Claude Sonnet 5.5 <noreply@anthropic.com>
</commit_message>
<xml_diff>
--- a/outputs/pptx/puzzledata_repair_report.pptx
+++ b/outputs/pptx/puzzledata_repair_report.pptx
@@ -125,21 +125,21 @@
   <p:extLst>
     <p:ext uri="{521415D9-36F7-43E2-AB2F-B90AF26B5E84}">
       <p14:sectionLst xmlns:p14="http://schemas.microsoft.com/office/powerpoint/2010/main">
-        <p14:section name="Part 00 · 인트로" id="{B5427831-7495-486C-AC5E-B8D5D2B5CD24}">
+        <p14:section name="Part 00 · 인트로" id="{B6C2E8EC-86A9-432C-9A31-17E5B6DFD426}">
           <p14:sldIdLst>
             <p14:sldId id="256"/>
             <p14:sldId id="257"/>
             <p14:sldId id="258"/>
           </p14:sldIdLst>
         </p14:section>
-        <p14:section name="Part 01 · 데이터 진단" id="{BF46B65C-A4E7-4A84-856B-10BDB35A83AA}">
+        <p14:section name="Part 01 · 데이터 진단" id="{CEB3CB72-C665-4920-94AC-EAC1D05D0C04}">
           <p14:sldIdLst>
             <p14:sldId id="259"/>
             <p14:sldId id="260"/>
             <p14:sldId id="261"/>
           </p14:sldIdLst>
         </p14:section>
-        <p14:section name="Part 02 · 병목 규명" id="{5E00061B-6FE2-4988-9F95-217ADD59B60A}">
+        <p14:section name="Part 02 · 병목 규명" id="{6A38E976-EEAA-4927-B70B-8E6FD469D265}">
           <p14:sldIdLst>
             <p14:sldId id="262"/>
             <p14:sldId id="263"/>
@@ -152,14 +152,14 @@
             <p14:sldId id="270"/>
           </p14:sldIdLst>
         </p14:section>
-        <p14:section name="Part 03 · 개선 전략" id="{AB72E48B-44A9-4F9F-9BDC-2A1AF24BA2E5}">
+        <p14:section name="Part 03 · 개선 전략" id="{277AF0BF-DF6C-4A86-9A26-3781BEC1C868}">
           <p14:sldIdLst>
             <p14:sldId id="271"/>
             <p14:sldId id="272"/>
             <p14:sldId id="273"/>
           </p14:sldIdLst>
         </p14:section>
-        <p14:section name="Part 04 · Q&amp;A" id="{1AB41519-31DB-4A9B-A5FF-B573F1380520}">
+        <p14:section name="Part 04 · Q&amp;A" id="{813E3598-AD20-4692-A23B-65DDE4127F88}">
           <p14:sldIdLst>
             <p14:sldId id="274"/>
           </p14:sldIdLst>
@@ -1195,7 +1195,7 @@
           <a:lstStyle/>
           <a:p>
             <a:r>
-              <a:t>효과는 하나의 가정으로만 계산했습니다. 즉시 수리 365건이 실사 줄에서 빠지면 실사 줄 유입이 일 134.3건에서 81.4건으로 39.4% 줄어듭니다. 이 유입 감소의 약 절반만 대기 단축으로 반영해 실사 대기를 20%, 즉 76.8시간에서 61.4시간으로 15.4시간 줄인다고 가정합니다. 실사 대기는 리드타임의 구성요소이므로 1대1로 반영해 105.9시간이 90.5시간, ▼14.5%입니다. 단축률이 10%면 ▼7.3%, 30%면 ▼21.8%입니다. 이 숫자는 예측이 아니라 가정입니다. 기사 11명을 두 줄이 공유하고 관측 데이터에는 줄을 나눈 사례가 없어 순수 효과는 식별되지 않습니다. 그래서 실험 설계를 구상했습니다. 대상은 Direct Booking 케이스와 실사 대기 케이스이고, 비교는 Direct Booking으로 빠진 이후 실사 대기 케이스의 실사 대기 시간 증감 추이이며, 평가는 Direct Booking 유도 적중률, 실사 대기 케이스의 실사 대기 시간 감소폭, 적체 WIP 부담 등입니다. 자재 사전 확보, 재방문 방지, 접수 인계 제거는 근거가 부족해 효과에서 제외했고 상방 요인으로 남깁니다. [예상 질문] 20%의 근거는? → 유입 감소율 39.4%의 약 절반이라는 보수 가정입니다. 참고로 일별 대기열 모델에서 실사 단계가 사라져 해방되는 기사 시간 7.2%만 반영해도 평균 대기가 약 18% 줄지만, 기준값이 구성상 항등식이고 부하가 큰 8일 구간이라 상한 참고로만 씁니다. [예상 질문] 줄별 평균(즉시 줄, 나머지 줄)으로 계산하지 않은 이유는? → 두 줄은 지금 하나의 대기열을 공유한 상태의 평균이라 줄을 나눈 뒤의 대기를 대표하지 않고, B형 118건(대기 0.1시간)이 섞여 있어 실제 큐 대기와도 다릅니다.</a:t>
+              <a:t>효과는 하나의 가정으로만 계산했습니다. 즉시 수리 365건이 실사 줄에서 빠지면 실사 줄 유입이 일 134.3건에서 81.4건으로 39.4% 줄어듭니다. 이 유입 감소의 약 절반만 대기 단축으로 반영해 실사 대기를 20%, 즉 76.8시간에서 61.4시간으로 15.4시간 줄인다고 가정합니다. 실사 대기는 리드타임의 구성요소이므로 1대1로 반영해 105.9시간이 90.5시간, ▼14.5%입니다. 단축률이 10%면 ▼7.3%, 30%면 ▼21.8%입니다. 이 숫자는 예측이 아니라 가정입니다. 기사 11명을 두 줄이 공유하고 관측 데이터에는 줄을 나눈 사례가 없어 순수 효과는 식별되지 않습니다. 그래서 실험 설계를 구상했습니다. 대상은 Direct Booking 케이스와 실사 대기 케이스이고, 비교는 동일 기간 내 Direct Booking으로 빠진 이후 실사 대기 케이스의 실사 대기 시간 증감 추이이며(전후와 동시 비교를 결합한 이중차분 DID 형태로 확장 가능), 평가는 Direct Booking 유도 적중률, 실사 대기 케이스의 실사 대기 시간 감소폭, 적체 WIP 부담 등입니다. 자재 사전 확보, 재방문 방지, 접수 인계 제거는 근거가 부족해 효과에서 제외했고 상방 요인으로 남깁니다. [예상 질문] DID를 쓰면 되지 않나? → 동일 기간의 비교군과 전후 변화를 함께 보면 시간 효과를 제거할 수 있습니다. 다만 두 케이스가 기사 11명과 하나의 대기열을 공유해 비교군도 줄 분리의 혜택을 받으므로(파급), 추정치는 건별 효과가 아니라 시스템 효과로 해석하고, 평행 추세 가정과 일 단위 교대 적용을 함께 점검합니다. [예상 질문] 20%의 근거는? → 유입 감소율 39.4%의 약 절반이라는 보수 가정입니다. 참고로 일별 대기열 모델에서 실사 단계가 사라져 해방되는 기사 시간 7.2%만 반영해도 평균 대기가 약 18% 줄지만, 기준값이 구성상 항등식이고 부하가 큰 8일 구간이라 상한 참고로만 씁니다. [예상 질문] 줄별 평균(즉시 줄, 나머지 줄)으로 계산하지 않은 이유는? → 두 줄은 지금 하나의 대기열을 공유한 상태의 평균이라 줄을 나눈 뒤의 대기를 대표하지 않고, B형 118건(대기 0.1시간)이 섞여 있어 실제 큐 대기와도 다릅니다.</a:t>
             </a:r>
           </a:p>
         </p:txBody>
@@ -18783,7 +18783,7 @@
                 <a:ea typeface="맑은 고딕"/>
                 <a:cs typeface="맑은 고딕"/>
               </a:rPr>
-              <a:t>Direct Booking으로 빠진 이후, 실사 대기 케이스의</a:t>
+              <a:t>동일 기간 내 Direct Booking으로 빠진 이후, 실사</a:t>
             </a:r>
             <a:br>
               <a:rPr lang="ko-KR" sz="1250" b="0" dirty="0">
@@ -18804,7 +18804,7 @@
                 <a:ea typeface="맑은 고딕"/>
                 <a:cs typeface="맑은 고딕"/>
               </a:rPr>
-              <a:t>실사 대기 시간 증감 추이</a:t>
+              <a:t>대기 케이스의 실사 대기 시간 증감 추이</a:t>
             </a:r>
           </a:p>
         </p:txBody>

</xml_diff>

<commit_message>
feat(deck): slide 19 retitled 마무리 및 Q&A, summary text and notes synced with latest slides
Co-Authored-By: Claude Sonnet 5.5 <noreply@anthropic.com>
</commit_message>
<xml_diff>
--- a/outputs/pptx/puzzledata_repair_report.pptx
+++ b/outputs/pptx/puzzledata_repair_report.pptx
@@ -125,21 +125,21 @@
   <p:extLst>
     <p:ext uri="{521415D9-36F7-43E2-AB2F-B90AF26B5E84}">
       <p14:sectionLst xmlns:p14="http://schemas.microsoft.com/office/powerpoint/2010/main">
-        <p14:section name="Part 00 · 인트로" id="{B6C2E8EC-86A9-432C-9A31-17E5B6DFD426}">
+        <p14:section name="Part 00 · 인트로" id="{B00303DB-A0A2-4E2C-AACA-B2771CC81E5C}">
           <p14:sldIdLst>
             <p14:sldId id="256"/>
             <p14:sldId id="257"/>
             <p14:sldId id="258"/>
           </p14:sldIdLst>
         </p14:section>
-        <p14:section name="Part 01 · 데이터 진단" id="{CEB3CB72-C665-4920-94AC-EAC1D05D0C04}">
+        <p14:section name="Part 01 · 데이터 진단" id="{AD5A16F0-412E-4482-BC44-D5914EA24217}">
           <p14:sldIdLst>
             <p14:sldId id="259"/>
             <p14:sldId id="260"/>
             <p14:sldId id="261"/>
           </p14:sldIdLst>
         </p14:section>
-        <p14:section name="Part 02 · 병목 규명" id="{6A38E976-EEAA-4927-B70B-8E6FD469D265}">
+        <p14:section name="Part 02 · 병목 규명" id="{597A7EED-6E2F-43AE-8001-B750C1DE56CE}">
           <p14:sldIdLst>
             <p14:sldId id="262"/>
             <p14:sldId id="263"/>
@@ -152,14 +152,14 @@
             <p14:sldId id="270"/>
           </p14:sldIdLst>
         </p14:section>
-        <p14:section name="Part 03 · 개선 전략" id="{277AF0BF-DF6C-4A86-9A26-3781BEC1C868}">
+        <p14:section name="Part 03 · 개선 전략" id="{8A08E7B7-CE60-4690-A91E-EA21B346475C}">
           <p14:sldIdLst>
             <p14:sldId id="271"/>
             <p14:sldId id="272"/>
             <p14:sldId id="273"/>
           </p14:sldIdLst>
         </p14:section>
-        <p14:section name="Part 04 · Q&amp;A" id="{813E3598-AD20-4692-A23B-65DDE4127F88}">
+        <p14:section name="Part 04 · Q&amp;A" id="{32023767-C61E-42A8-9852-BBDB3739FE5D}">
           <p14:sldIdLst>
             <p14:sldId id="274"/>
           </p14:sldIdLst>
@@ -1265,13 +1265,13 @@
           <a:lstStyle/>
           <a:p>
             <a:r>
-              <a:t>이상으로 발표를 마칩니다. 13,262행 전수 보존 전처리, 76.8시간의 실사 대기 병목과 원인 규명, 그리고 가정을 명시하고 파일럿으로 검증하는 TO-BE 시나리오까지 설명드렸습니다. 질문 주시면 답변드리겠습니다. 감사합니다.</a:t>
+              <a:t>이상으로 발표를 마칩니다. 13,262행 전수 보존 전처리, 76.8시간의 실사 대기 병목과 원인 규명, 그리고 가정을 명시하고 실험 설계로 검증하는 TO-BE 시나리오까지 설명드렸습니다. 질문 주시면 답변드리겠습니다. 감사합니다.</a:t>
             </a:r>
           </a:p>
           <a:p/>
           <a:p>
             <a:r>
-              <a:t>[핵심 숫자 치트시트] 리드타임 105.9h · 대기 95.8h(90.5%) · 실사 대기 76.8h · 유입 134.3 vs CAPA 68.0 · 적체 403건 · 인계 6.6배 · OLS 실사 1.12h/h · 사내수리 +31.75h · 자재 30.5h · 재방문 26건 +32.9h · 적중률 87.3/83.2% · 감축 ▼14.5%</a:t>
+              <a:t>[핵심 숫자 치트시트] 리드타임 105.9h · 대기 95.8h(90.5%) · 실사 대기 76.8h · 유입 134.3 vs CAPA 68.0 · 적체 403건 · 인계 6.6배 · OLS 실사 1.12h/h · 사내수리 +31.75h · 자재 30.5h · 재수리 26건 +32.9h · 사전 적중 E→사내 100.0%, P→즉시 83.1% · 감축 ▼14.5%</a:t>
             </a:r>
           </a:p>
         </p:txBody>
@@ -19007,7 +19007,7 @@
                 <a:ea typeface="맑은 고딕"/>
                 <a:cs typeface="Consolas"/>
               </a:rPr>
-              <a:t>[ 19 / Q&amp;A ]</a:t>
+              <a:t>[ 19 / CLOSING &amp; Q&amp;A ]</a:t>
             </a:r>
           </a:p>
         </p:txBody>
@@ -19097,7 +19097,7 @@
                 <a:ea typeface="맑은 고딕"/>
                 <a:cs typeface="맑은 고딕"/>
               </a:rPr>
-              <a:t>질의응답 (Q&amp;A)</a:t>
+              <a:t>마무리 및 Q&amp;A</a:t>
             </a:r>
           </a:p>
         </p:txBody>
@@ -19570,7 +19570,7 @@
                 <a:ea typeface="맑은 고딕"/>
                 <a:cs typeface="맑은 고딕"/>
               </a:rPr>
-              <a:t>일 유입 134.3건 vs CAPA 68.0건 · 소요시간은 실사 지연이 좌우</a:t>
+              <a:t>일 유입 134.3건 vs CAPA 68.0건 · 실사 대기 ≫ 사내수리</a:t>
             </a:r>
           </a:p>
         </p:txBody>

</xml_diff>

<commit_message>
feat(deck): slide 19 closing line for a submitted document (검토해 주셔서 감사합니다)
Co-Authored-By: Claude Sonnet 5.5 <noreply@anthropic.com>
</commit_message>
<xml_diff>
--- a/outputs/pptx/puzzledata_repair_report.pptx
+++ b/outputs/pptx/puzzledata_repair_report.pptx
@@ -125,21 +125,21 @@
   <p:extLst>
     <p:ext uri="{521415D9-36F7-43E2-AB2F-B90AF26B5E84}">
       <p14:sectionLst xmlns:p14="http://schemas.microsoft.com/office/powerpoint/2010/main">
-        <p14:section name="Part 00 · 인트로" id="{B00303DB-A0A2-4E2C-AACA-B2771CC81E5C}">
+        <p14:section name="Part 00 · 인트로" id="{793C7C63-4CD9-440E-ADFF-CC0D392CECC8}">
           <p14:sldIdLst>
             <p14:sldId id="256"/>
             <p14:sldId id="257"/>
             <p14:sldId id="258"/>
           </p14:sldIdLst>
         </p14:section>
-        <p14:section name="Part 01 · 데이터 진단" id="{AD5A16F0-412E-4482-BC44-D5914EA24217}">
+        <p14:section name="Part 01 · 데이터 진단" id="{A076108A-B8CE-4805-9C73-F660AF55E0BD}">
           <p14:sldIdLst>
             <p14:sldId id="259"/>
             <p14:sldId id="260"/>
             <p14:sldId id="261"/>
           </p14:sldIdLst>
         </p14:section>
-        <p14:section name="Part 02 · 병목 규명" id="{597A7EED-6E2F-43AE-8001-B750C1DE56CE}">
+        <p14:section name="Part 02 · 병목 규명" id="{ED335195-741E-4FA4-8F01-C49F2251A51D}">
           <p14:sldIdLst>
             <p14:sldId id="262"/>
             <p14:sldId id="263"/>
@@ -152,14 +152,14 @@
             <p14:sldId id="270"/>
           </p14:sldIdLst>
         </p14:section>
-        <p14:section name="Part 03 · 개선 전략" id="{8A08E7B7-CE60-4690-A91E-EA21B346475C}">
+        <p14:section name="Part 03 · 개선 전략" id="{1499308B-42BF-4835-93BA-0D70AE0C6033}">
           <p14:sldIdLst>
             <p14:sldId id="271"/>
             <p14:sldId id="272"/>
             <p14:sldId id="273"/>
           </p14:sldIdLst>
         </p14:section>
-        <p14:section name="Part 04 · Q&amp;A" id="{32023767-C61E-42A8-9852-BBDB3739FE5D}">
+        <p14:section name="Part 04 · Q&amp;A" id="{D054BC9A-982F-4A75-8C3F-01805FAA2B03}">
           <p14:sldIdLst>
             <p14:sldId id="274"/>
           </p14:sldIdLst>
@@ -19932,7 +19932,7 @@
                 <a:ea typeface="맑은 고딕"/>
                 <a:cs typeface="맑은 고딕"/>
               </a:rPr>
-              <a:t>경청해 주셔서 감사합니다</a:t>
+              <a:t>검토해 주셔서 감사합니다</a:t>
             </a:r>
           </a:p>
         </p:txBody>

</xml_diff>

<commit_message>
feat(deck): slide 9 3-panel chart split into three per-column PNGs aligned with the three cards
Co-Authored-By: Claude Sonnet 5.5 <noreply@anthropic.com>
</commit_message>
<xml_diff>
--- a/outputs/pptx/puzzledata_repair_report.pptx
+++ b/outputs/pptx/puzzledata_repair_report.pptx
@@ -125,21 +125,21 @@
   <p:extLst>
     <p:ext uri="{521415D9-36F7-43E2-AB2F-B90AF26B5E84}">
       <p14:sectionLst xmlns:p14="http://schemas.microsoft.com/office/powerpoint/2010/main">
-        <p14:section name="Part 00 · 인트로" id="{793C7C63-4CD9-440E-ADFF-CC0D392CECC8}">
+        <p14:section name="Part 00 · 인트로" id="{2CAA2A26-A940-4893-A488-49C654628EB2}">
           <p14:sldIdLst>
             <p14:sldId id="256"/>
             <p14:sldId id="257"/>
             <p14:sldId id="258"/>
           </p14:sldIdLst>
         </p14:section>
-        <p14:section name="Part 01 · 데이터 진단" id="{A076108A-B8CE-4805-9C73-F660AF55E0BD}">
+        <p14:section name="Part 01 · 데이터 진단" id="{252D082C-9DBA-48F2-A798-448D5EFA80BC}">
           <p14:sldIdLst>
             <p14:sldId id="259"/>
             <p14:sldId id="260"/>
             <p14:sldId id="261"/>
           </p14:sldIdLst>
         </p14:section>
-        <p14:section name="Part 02 · 병목 규명" id="{ED335195-741E-4FA4-8F01-C49F2251A51D}">
+        <p14:section name="Part 02 · 병목 규명" id="{BDA01902-2A7A-4AD4-8C04-48D4E95040BA}">
           <p14:sldIdLst>
             <p14:sldId id="262"/>
             <p14:sldId id="263"/>
@@ -152,14 +152,14 @@
             <p14:sldId id="270"/>
           </p14:sldIdLst>
         </p14:section>
-        <p14:section name="Part 03 · 개선 전략" id="{1499308B-42BF-4835-93BA-0D70AE0C6033}">
+        <p14:section name="Part 03 · 개선 전략" id="{812F29F8-9AE0-4966-8C6C-FFF9F8D2CA9A}">
           <p14:sldIdLst>
             <p14:sldId id="271"/>
             <p14:sldId id="272"/>
             <p14:sldId id="273"/>
           </p14:sldIdLst>
         </p14:section>
-        <p14:section name="Part 04 · Q&amp;A" id="{D054BC9A-982F-4A75-8C3F-01805FAA2B03}">
+        <p14:section name="Part 04 · Q&amp;A" id="{95555FE5-CAD7-453E-B57A-24E7218F7D79}">
           <p14:sldIdLst>
             <p14:sldId id="274"/>
           </p14:sldIdLst>
@@ -31867,14 +31867,14 @@
       </p:sp>
       <p:sp>
         <p:nvSpPr>
-          <p:cNvPr id="9" name="rec-card"/>
+          <p:cNvPr id="9" name="rec-recA"/>
           <p:cNvSpPr/>
           <p:nvPr/>
         </p:nvSpPr>
         <p:spPr>
           <a:xfrm>
             <a:off x="502920" y="1618488"/>
-            <a:ext cx="11185855" cy="2847086"/>
+            <a:ext cx="3606698" cy="2480045"/>
           </a:xfrm>
           <a:prstGeom prst="rect">
             <a:avLst/>
@@ -31920,7 +31920,7 @@
         <p:spPr>
           <a:xfrm>
             <a:off x="630936" y="1746504"/>
-            <a:ext cx="10929823" cy="158750"/>
+            <a:ext cx="3350666" cy="158750"/>
           </a:xfrm>
           <a:prstGeom prst="rect">
             <a:avLst/>
@@ -31951,14 +31951,14 @@
                 <a:ea typeface="맑은 고딕"/>
                 <a:cs typeface="Consolas"/>
               </a:rPr>
-              <a:t>FIG.09 · 접수 구간 3-Panel (인계 · 채널 · 패스트 트랙(15분 내) 평균)</a:t>
+              <a:t>FIG.09-A · 단독 vs 교차 인계 · 평균 접수시간</a:t>
             </a:r>
           </a:p>
         </p:txBody>
       </p:sp>
       <p:pic>
         <p:nvPicPr>
-          <p:cNvPr id="11" name="pic:rec" descr="slide09_reception_bottleneck_3panel.png"/>
+          <p:cNvPr id="11" name="pic:recA" descr="slide09a_handover.png"/>
           <p:cNvPicPr>
             <a:picLocks noChangeAspect="1"/>
           </p:cNvPicPr>
@@ -31972,8 +31972,8 @@
         </p:blipFill>
         <p:spPr>
           <a:xfrm>
-            <a:off x="1753380" y="1960118"/>
-            <a:ext cx="8684933" cy="2377440"/>
+            <a:off x="630936" y="1960118"/>
+            <a:ext cx="3350666" cy="2010399"/>
           </a:xfrm>
           <a:prstGeom prst="rect">
             <a:avLst/>
@@ -31982,14 +31982,14 @@
       </p:pic>
       <p:sp>
         <p:nvSpPr>
-          <p:cNvPr id="12" name="c1"/>
+          <p:cNvPr id="12" name="rec-recB"/>
           <p:cNvSpPr/>
           <p:nvPr/>
         </p:nvSpPr>
         <p:spPr>
           <a:xfrm>
-            <a:off x="502920" y="4602734"/>
-            <a:ext cx="3606698" cy="1609852"/>
+            <a:off x="4292498" y="1618488"/>
+            <a:ext cx="3606698" cy="2480045"/>
           </a:xfrm>
           <a:prstGeom prst="rect">
             <a:avLst/>
@@ -32034,8 +32034,8 @@
         </p:nvSpPr>
         <p:spPr>
           <a:xfrm>
-            <a:off x="685800" y="4785614"/>
-            <a:ext cx="3240938" cy="158750"/>
+            <a:off x="4420514" y="1746504"/>
+            <a:ext cx="3350666" cy="158750"/>
           </a:xfrm>
           <a:prstGeom prst="rect">
             <a:avLst/>
@@ -32066,143 +32066,45 @@
                 <a:ea typeface="맑은 고딕"/>
                 <a:cs typeface="Consolas"/>
               </a:rPr>
-              <a:t>핵심 원인 · 교차 인계</a:t>
-            </a:r>
-          </a:p>
-        </p:txBody>
-      </p:sp>
-      <p:sp>
-        <p:nvSpPr>
-          <p:cNvPr id="14" name="body:L1:a"/>
-          <p:cNvSpPr txBox="1"/>
-          <p:nvPr/>
-        </p:nvSpPr>
-        <p:spPr>
-          <a:xfrm>
-            <a:off x="685800" y="4999228"/>
-            <a:ext cx="3240938" cy="511810"/>
-          </a:xfrm>
-          <a:prstGeom prst="rect">
-            <a:avLst/>
-          </a:prstGeom>
-          <a:noFill/>
-        </p:spPr>
-        <p:txBody>
-          <a:bodyPr wrap="square" lIns="0" tIns="0" rIns="0" bIns="0" anchor="t">
-            <a:noAutofit/>
-          </a:bodyPr>
-          <a:lstStyle/>
-          <a:p>
-            <a:pPr algn="l">
-              <a:lnSpc>
-                <a:spcPts val="4030"/>
-              </a:lnSpc>
-              <a:spcBef>
-                <a:spcPts val="0"/>
-              </a:spcBef>
-              <a:buNone/>
-            </a:pPr>
-            <a:r>
-              <a:rPr lang="ko-KR" sz="3600" b="1" dirty="0">
-                <a:solidFill>
-                  <a:srgbClr val="E11D48"/>
-                </a:solidFill>
-                <a:latin typeface="Consolas"/>
-                <a:ea typeface="맑은 고딕"/>
-                <a:cs typeface="Consolas"/>
-              </a:rPr>
-              <a:t>6.6</a:t>
-            </a:r>
-            <a:r>
-              <a:rPr lang="ko-KR" sz="1440" b="1" dirty="0">
-                <a:solidFill>
-                  <a:srgbClr val="E11D48"/>
-                </a:solidFill>
-                <a:latin typeface="맑은 고딕"/>
-                <a:ea typeface="맑은 고딕"/>
-                <a:cs typeface="맑은 고딕"/>
-              </a:rPr>
-              <a:t>배</a:t>
-            </a:r>
-          </a:p>
-        </p:txBody>
-      </p:sp>
-      <p:sp>
-        <p:nvSpPr>
-          <p:cNvPr id="15" name="body:L2:t"/>
-          <p:cNvSpPr txBox="1"/>
-          <p:nvPr/>
-        </p:nvSpPr>
-        <p:spPr>
-          <a:xfrm>
-            <a:off x="685800" y="5565902"/>
-            <a:ext cx="3240938" cy="408940"/>
-          </a:xfrm>
-          <a:prstGeom prst="rect">
-            <a:avLst/>
-          </a:prstGeom>
-          <a:noFill/>
-        </p:spPr>
-        <p:txBody>
-          <a:bodyPr wrap="square" lIns="0" tIns="0" rIns="0" bIns="0" anchor="t">
-            <a:noAutofit/>
-          </a:bodyPr>
-          <a:lstStyle/>
-          <a:p>
-            <a:pPr algn="l">
-              <a:lnSpc>
-                <a:spcPts val="1610"/>
-              </a:lnSpc>
-              <a:spcBef>
-                <a:spcPts val="0"/>
-              </a:spcBef>
-              <a:buNone/>
-            </a:pPr>
-            <a:r>
-              <a:rPr lang="ko-KR" sz="1150" b="0" dirty="0">
-                <a:solidFill>
-                  <a:srgbClr val="334155"/>
-                </a:solidFill>
-                <a:latin typeface="맑은 고딕"/>
-                <a:ea typeface="맑은 고딕"/>
-                <a:cs typeface="맑은 고딕"/>
-              </a:rPr>
-              <a:t>단독 804건 1.20h → 인계 123건 7.87h.</a:t>
-            </a:r>
-            <a:br>
-              <a:rPr lang="ko-KR" sz="1150" b="0" dirty="0">
-                <a:solidFill>
-                  <a:srgbClr val="334155"/>
-                </a:solidFill>
-                <a:latin typeface="맑은 고딕"/>
-                <a:ea typeface="맑은 고딕"/>
-                <a:cs typeface="맑은 고딕"/>
-              </a:rPr>
-            </a:br>
-            <a:r>
-              <a:rPr lang="ko-KR" sz="1150" b="0" dirty="0">
-                <a:solidFill>
-                  <a:srgbClr val="334155"/>
-                </a:solidFill>
-                <a:latin typeface="맑은 고딕"/>
-                <a:ea typeface="맑은 고딕"/>
-                <a:cs typeface="맑은 고딕"/>
-              </a:rPr>
-              <a:t>인계는 전부 웹 69 · 우편 54</a:t>
-            </a:r>
-          </a:p>
-        </p:txBody>
-      </p:sp>
-      <p:sp>
-        <p:nvSpPr>
-          <p:cNvPr id="16" name="c2"/>
+              <a:t>FIG.09-B · 채널별 15분 이내 · 60분 초과 비율</a:t>
+            </a:r>
+          </a:p>
+        </p:txBody>
+      </p:sp>
+      <p:pic>
+        <p:nvPicPr>
+          <p:cNvPr id="14" name="pic:recB" descr="slide09b_channel_cohort.png"/>
+          <p:cNvPicPr>
+            <a:picLocks noChangeAspect="1"/>
+          </p:cNvPicPr>
+          <p:nvPr/>
+        </p:nvPicPr>
+        <p:blipFill>
+          <a:blip r:embed="rId3"/>
+          <a:stretch>
+            <a:fillRect/>
+          </a:stretch>
+        </p:blipFill>
+        <p:spPr>
+          <a:xfrm>
+            <a:off x="4420514" y="1960118"/>
+            <a:ext cx="3350666" cy="2010399"/>
+          </a:xfrm>
+          <a:prstGeom prst="rect">
+            <a:avLst/>
+          </a:prstGeom>
+        </p:spPr>
+      </p:pic>
+      <p:sp>
+        <p:nvSpPr>
+          <p:cNvPr id="15" name="rec-recC"/>
           <p:cNvSpPr/>
           <p:nvPr/>
         </p:nvSpPr>
         <p:spPr>
           <a:xfrm>
-            <a:off x="4292498" y="4602734"/>
-            <a:ext cx="3606698" cy="1609852"/>
+            <a:off x="8082076" y="1618488"/>
+            <a:ext cx="3606698" cy="2480045"/>
           </a:xfrm>
           <a:prstGeom prst="rect">
             <a:avLst/>
@@ -32241,14 +32143,14 @@
       </p:sp>
       <p:sp>
         <p:nvSpPr>
-          <p:cNvPr id="17" name="label:L1:t"/>
-          <p:cNvSpPr txBox="1"/>
-          <p:nvPr/>
-        </p:nvSpPr>
-        <p:spPr>
-          <a:xfrm>
-            <a:off x="4475378" y="4785614"/>
-            <a:ext cx="3240938" cy="158750"/>
+          <p:cNvPr id="16" name="label:L1:t"/>
+          <p:cNvSpPr txBox="1"/>
+          <p:nvPr/>
+        </p:nvSpPr>
+        <p:spPr>
+          <a:xfrm>
+            <a:off x="8210092" y="1746504"/>
+            <a:ext cx="3350666" cy="158750"/>
           </a:xfrm>
           <a:prstGeom prst="rect">
             <a:avLst/>
@@ -32279,169 +32181,44 @@
                 <a:ea typeface="맑은 고딕"/>
                 <a:cs typeface="Consolas"/>
               </a:rPr>
-              <a:t>이봉 분포 · 단기 지연이 아니다</a:t>
-            </a:r>
-          </a:p>
-        </p:txBody>
-      </p:sp>
-      <p:sp>
-        <p:nvSpPr>
-          <p:cNvPr id="18" name="body:L4:bi"/>
-          <p:cNvSpPr txBox="1"/>
-          <p:nvPr/>
-        </p:nvSpPr>
-        <p:spPr>
-          <a:xfrm>
-            <a:off x="4475378" y="4999228"/>
-            <a:ext cx="3240938" cy="932180"/>
-          </a:xfrm>
-          <a:prstGeom prst="rect">
-            <a:avLst/>
-          </a:prstGeom>
-          <a:noFill/>
-        </p:spPr>
-        <p:txBody>
-          <a:bodyPr wrap="square" lIns="0" tIns="0" rIns="0" bIns="0" anchor="t">
-            <a:noAutofit/>
-          </a:bodyPr>
-          <a:lstStyle/>
-          <a:p>
-            <a:pPr algn="l" marL="164592" indent="-164592">
-              <a:lnSpc>
-                <a:spcPts val="1610"/>
-              </a:lnSpc>
-              <a:spcBef>
-                <a:spcPts val="0"/>
-              </a:spcBef>
-              <a:buClr>
-                <a:srgbClr val="2563EB"/>
-              </a:buClr>
-              <a:buFont typeface="맑은 고딕"/>
-              <a:buChar char="•"/>
-            </a:pPr>
-            <a:r>
-              <a:rPr lang="ko-KR" sz="1150" b="0" dirty="0">
-                <a:solidFill>
-                  <a:srgbClr val="334155"/>
-                </a:solidFill>
-                <a:latin typeface="맑은 고딕"/>
-                <a:ea typeface="맑은 고딕"/>
-                <a:cs typeface="맑은 고딕"/>
-              </a:rPr>
-              <a:t>웹·우편 </a:t>
-            </a:r>
-            <a:r>
-              <a:rPr lang="ko-KR" sz="1150" b="1" dirty="0">
-                <a:solidFill>
-                  <a:srgbClr val="E11D48"/>
-                </a:solidFill>
-                <a:latin typeface="맑은 고딕"/>
-                <a:ea typeface="맑은 고딕"/>
-                <a:cs typeface="맑은 고딕"/>
-              </a:rPr>
-              <a:t>패스트 트랙(15분 이내) 49.6%</a:t>
-            </a:r>
-          </a:p>
-          <a:p>
-            <a:pPr algn="l" marL="164592" indent="-164592">
-              <a:lnSpc>
-                <a:spcPts val="1610"/>
-              </a:lnSpc>
-              <a:spcBef>
-                <a:spcPts val="300"/>
-              </a:spcBef>
-              <a:buClr>
-                <a:srgbClr val="2563EB"/>
-              </a:buClr>
-              <a:buFont typeface="맑은 고딕"/>
-              <a:buChar char="•"/>
-            </a:pPr>
-            <a:r>
-              <a:rPr lang="ko-KR" sz="1150" b="0" dirty="0">
-                <a:solidFill>
-                  <a:srgbClr val="334155"/>
-                </a:solidFill>
-                <a:latin typeface="맑은 고딕"/>
-                <a:ea typeface="맑은 고딕"/>
-                <a:cs typeface="맑은 고딕"/>
-              </a:rPr>
-              <a:t>웹·우편 </a:t>
-            </a:r>
-            <a:r>
-              <a:rPr lang="ko-KR" sz="1150" b="1" dirty="0">
-                <a:solidFill>
-                  <a:srgbClr val="E11D48"/>
-                </a:solidFill>
-                <a:latin typeface="맑은 고딕"/>
-                <a:ea typeface="맑은 고딕"/>
-                <a:cs typeface="맑은 고딕"/>
-              </a:rPr>
-              <a:t>장기 대기(60분 초과) 50.4%</a:t>
-            </a:r>
-          </a:p>
-          <a:p>
-            <a:pPr algn="l" marL="164592" indent="-164592">
-              <a:lnSpc>
-                <a:spcPts val="1610"/>
-              </a:lnSpc>
-              <a:spcBef>
-                <a:spcPts val="300"/>
-              </a:spcBef>
-              <a:buClr>
-                <a:srgbClr val="2563EB"/>
-              </a:buClr>
-              <a:buFont typeface="맑은 고딕"/>
-              <a:buChar char="•"/>
-            </a:pPr>
-            <a:r>
-              <a:rPr lang="ko-KR" sz="1150" b="0" dirty="0">
-                <a:solidFill>
-                  <a:srgbClr val="334155"/>
-                </a:solidFill>
-                <a:latin typeface="맑은 고딕"/>
-                <a:ea typeface="맑은 고딕"/>
-                <a:cs typeface="맑은 고딕"/>
-              </a:rPr>
-              <a:t>15~60분 구간 0건</a:t>
-            </a:r>
-          </a:p>
-          <a:p>
-            <a:pPr algn="l" marL="164592" indent="-164592">
-              <a:lnSpc>
-                <a:spcPts val="1610"/>
-              </a:lnSpc>
-              <a:spcBef>
-                <a:spcPts val="300"/>
-              </a:spcBef>
-              <a:buClr>
-                <a:srgbClr val="2563EB"/>
-              </a:buClr>
-              <a:buFont typeface="맑은 고딕"/>
-              <a:buChar char="•"/>
-            </a:pPr>
-            <a:r>
-              <a:rPr lang="ko-KR" sz="1150" b="0" dirty="0">
-                <a:solidFill>
-                  <a:srgbClr val="334155"/>
-                </a:solidFill>
-                <a:latin typeface="맑은 고딕"/>
-                <a:ea typeface="맑은 고딕"/>
-                <a:cs typeface="맑은 고딕"/>
-              </a:rPr>
-              <a:t>인계 123건 전부 60분 초과 (최소 72분)</a:t>
-            </a:r>
-          </a:p>
-        </p:txBody>
-      </p:sp>
-      <p:sp>
-        <p:nvSpPr>
-          <p:cNvPr id="19" name="c3"/>
+              <a:t>FIG.09-C · 패스트 트랙(15분 내) 채널별 평균</a:t>
+            </a:r>
+          </a:p>
+        </p:txBody>
+      </p:sp>
+      <p:pic>
+        <p:nvPicPr>
+          <p:cNvPr id="17" name="pic:recC" descr="slide09c_fast_channel.png"/>
+          <p:cNvPicPr>
+            <a:picLocks noChangeAspect="1"/>
+          </p:cNvPicPr>
+          <p:nvPr/>
+        </p:nvPicPr>
+        <p:blipFill>
+          <a:blip r:embed="rId4"/>
+          <a:stretch>
+            <a:fillRect/>
+          </a:stretch>
+        </p:blipFill>
+        <p:spPr>
+          <a:xfrm>
+            <a:off x="8210092" y="1960118"/>
+            <a:ext cx="3350666" cy="2010399"/>
+          </a:xfrm>
+          <a:prstGeom prst="rect">
+            <a:avLst/>
+          </a:prstGeom>
+        </p:spPr>
+      </p:pic>
+      <p:sp>
+        <p:nvSpPr>
+          <p:cNvPr id="18" name="c1"/>
           <p:cNvSpPr/>
           <p:nvPr/>
         </p:nvSpPr>
         <p:spPr>
           <a:xfrm>
-            <a:off x="8082076" y="4602734"/>
+            <a:off x="502920" y="4235693"/>
             <a:ext cx="3606698" cy="1609852"/>
           </a:xfrm>
           <a:prstGeom prst="rect">
@@ -32481,13 +32258,13 @@
       </p:sp>
       <p:sp>
         <p:nvSpPr>
-          <p:cNvPr id="20" name="label:L1:t"/>
-          <p:cNvSpPr txBox="1"/>
-          <p:nvPr/>
-        </p:nvSpPr>
-        <p:spPr>
-          <a:xfrm>
-            <a:off x="8264956" y="4785614"/>
+          <p:cNvPr id="19" name="label:L1:t"/>
+          <p:cNvSpPr txBox="1"/>
+          <p:nvPr/>
+        </p:nvSpPr>
+        <p:spPr>
+          <a:xfrm>
+            <a:off x="685800" y="4418573"/>
             <a:ext cx="3240938" cy="158750"/>
           </a:xfrm>
           <a:prstGeom prst="rect">
@@ -32519,6 +32296,459 @@
                 <a:ea typeface="맑은 고딕"/>
                 <a:cs typeface="Consolas"/>
               </a:rPr>
+              <a:t>핵심 원인 · 교차 인계</a:t>
+            </a:r>
+          </a:p>
+        </p:txBody>
+      </p:sp>
+      <p:sp>
+        <p:nvSpPr>
+          <p:cNvPr id="20" name="body:L1:a"/>
+          <p:cNvSpPr txBox="1"/>
+          <p:nvPr/>
+        </p:nvSpPr>
+        <p:spPr>
+          <a:xfrm>
+            <a:off x="685800" y="4632187"/>
+            <a:ext cx="3240938" cy="511810"/>
+          </a:xfrm>
+          <a:prstGeom prst="rect">
+            <a:avLst/>
+          </a:prstGeom>
+          <a:noFill/>
+        </p:spPr>
+        <p:txBody>
+          <a:bodyPr wrap="square" lIns="0" tIns="0" rIns="0" bIns="0" anchor="t">
+            <a:noAutofit/>
+          </a:bodyPr>
+          <a:lstStyle/>
+          <a:p>
+            <a:pPr algn="l">
+              <a:lnSpc>
+                <a:spcPts val="4030"/>
+              </a:lnSpc>
+              <a:spcBef>
+                <a:spcPts val="0"/>
+              </a:spcBef>
+              <a:buNone/>
+            </a:pPr>
+            <a:r>
+              <a:rPr lang="ko-KR" sz="3600" b="1" dirty="0">
+                <a:solidFill>
+                  <a:srgbClr val="E11D48"/>
+                </a:solidFill>
+                <a:latin typeface="Consolas"/>
+                <a:ea typeface="맑은 고딕"/>
+                <a:cs typeface="Consolas"/>
+              </a:rPr>
+              <a:t>6.6</a:t>
+            </a:r>
+            <a:r>
+              <a:rPr lang="ko-KR" sz="1440" b="1" dirty="0">
+                <a:solidFill>
+                  <a:srgbClr val="E11D48"/>
+                </a:solidFill>
+                <a:latin typeface="맑은 고딕"/>
+                <a:ea typeface="맑은 고딕"/>
+                <a:cs typeface="맑은 고딕"/>
+              </a:rPr>
+              <a:t>배</a:t>
+            </a:r>
+          </a:p>
+        </p:txBody>
+      </p:sp>
+      <p:sp>
+        <p:nvSpPr>
+          <p:cNvPr id="21" name="body:L2:t"/>
+          <p:cNvSpPr txBox="1"/>
+          <p:nvPr/>
+        </p:nvSpPr>
+        <p:spPr>
+          <a:xfrm>
+            <a:off x="685800" y="5198861"/>
+            <a:ext cx="3240938" cy="408940"/>
+          </a:xfrm>
+          <a:prstGeom prst="rect">
+            <a:avLst/>
+          </a:prstGeom>
+          <a:noFill/>
+        </p:spPr>
+        <p:txBody>
+          <a:bodyPr wrap="square" lIns="0" tIns="0" rIns="0" bIns="0" anchor="t">
+            <a:noAutofit/>
+          </a:bodyPr>
+          <a:lstStyle/>
+          <a:p>
+            <a:pPr algn="l">
+              <a:lnSpc>
+                <a:spcPts val="1610"/>
+              </a:lnSpc>
+              <a:spcBef>
+                <a:spcPts val="0"/>
+              </a:spcBef>
+              <a:buNone/>
+            </a:pPr>
+            <a:r>
+              <a:rPr lang="ko-KR" sz="1150" b="0" dirty="0">
+                <a:solidFill>
+                  <a:srgbClr val="334155"/>
+                </a:solidFill>
+                <a:latin typeface="맑은 고딕"/>
+                <a:ea typeface="맑은 고딕"/>
+                <a:cs typeface="맑은 고딕"/>
+              </a:rPr>
+              <a:t>단독 804건 1.20h → 인계 123건 7.87h.</a:t>
+            </a:r>
+            <a:br>
+              <a:rPr lang="ko-KR" sz="1150" b="0" dirty="0">
+                <a:solidFill>
+                  <a:srgbClr val="334155"/>
+                </a:solidFill>
+                <a:latin typeface="맑은 고딕"/>
+                <a:ea typeface="맑은 고딕"/>
+                <a:cs typeface="맑은 고딕"/>
+              </a:rPr>
+            </a:br>
+            <a:r>
+              <a:rPr lang="ko-KR" sz="1150" b="0" dirty="0">
+                <a:solidFill>
+                  <a:srgbClr val="334155"/>
+                </a:solidFill>
+                <a:latin typeface="맑은 고딕"/>
+                <a:ea typeface="맑은 고딕"/>
+                <a:cs typeface="맑은 고딕"/>
+              </a:rPr>
+              <a:t>인계는 전부 웹 69 · 우편 54</a:t>
+            </a:r>
+          </a:p>
+        </p:txBody>
+      </p:sp>
+      <p:sp>
+        <p:nvSpPr>
+          <p:cNvPr id="22" name="c2"/>
+          <p:cNvSpPr/>
+          <p:nvPr/>
+        </p:nvSpPr>
+        <p:spPr>
+          <a:xfrm>
+            <a:off x="4292498" y="4235693"/>
+            <a:ext cx="3606698" cy="1609852"/>
+          </a:xfrm>
+          <a:prstGeom prst="rect">
+            <a:avLst/>
+          </a:prstGeom>
+          <a:solidFill>
+            <a:srgbClr val="FFFFFF"/>
+          </a:solidFill>
+          <a:ln w="9525">
+            <a:solidFill>
+              <a:srgbClr val="E2E8F0"/>
+            </a:solidFill>
+          </a:ln>
+          <a:effectLst/>
+        </p:spPr>
+        <p:style>
+          <a:lnRef idx="1">
+            <a:schemeClr val="accent1"/>
+          </a:lnRef>
+          <a:fillRef idx="3">
+            <a:schemeClr val="accent1"/>
+          </a:fillRef>
+          <a:effectRef idx="2">
+            <a:schemeClr val="accent1"/>
+          </a:effectRef>
+          <a:fontRef idx="minor">
+            <a:schemeClr val="lt1"/>
+          </a:fontRef>
+        </p:style>
+        <p:txBody>
+          <a:bodyPr rtlCol="0" anchor="ctr"/>
+          <a:lstStyle/>
+          <a:p>
+            <a:pPr algn="ctr"/>
+          </a:p>
+        </p:txBody>
+      </p:sp>
+      <p:sp>
+        <p:nvSpPr>
+          <p:cNvPr id="23" name="label:L1:t"/>
+          <p:cNvSpPr txBox="1"/>
+          <p:nvPr/>
+        </p:nvSpPr>
+        <p:spPr>
+          <a:xfrm>
+            <a:off x="4475378" y="4418573"/>
+            <a:ext cx="3240938" cy="158750"/>
+          </a:xfrm>
+          <a:prstGeom prst="rect">
+            <a:avLst/>
+          </a:prstGeom>
+          <a:noFill/>
+        </p:spPr>
+        <p:txBody>
+          <a:bodyPr wrap="square" lIns="0" tIns="0" rIns="0" bIns="0" anchor="t">
+            <a:noAutofit/>
+          </a:bodyPr>
+          <a:lstStyle/>
+          <a:p>
+            <a:pPr algn="l">
+              <a:lnSpc>
+                <a:spcPts val="1250"/>
+              </a:lnSpc>
+              <a:spcBef>
+                <a:spcPts val="0"/>
+              </a:spcBef>
+              <a:buNone/>
+            </a:pPr>
+            <a:r>
+              <a:rPr lang="ko-KR" sz="950" b="1" dirty="0">
+                <a:solidFill>
+                  <a:srgbClr val="64748B"/>
+                </a:solidFill>
+                <a:latin typeface="Consolas"/>
+                <a:ea typeface="맑은 고딕"/>
+                <a:cs typeface="Consolas"/>
+              </a:rPr>
+              <a:t>이봉 분포 · 단기 지연이 아니다</a:t>
+            </a:r>
+          </a:p>
+        </p:txBody>
+      </p:sp>
+      <p:sp>
+        <p:nvSpPr>
+          <p:cNvPr id="24" name="body:L4:bi"/>
+          <p:cNvSpPr txBox="1"/>
+          <p:nvPr/>
+        </p:nvSpPr>
+        <p:spPr>
+          <a:xfrm>
+            <a:off x="4475378" y="4632187"/>
+            <a:ext cx="3240938" cy="932180"/>
+          </a:xfrm>
+          <a:prstGeom prst="rect">
+            <a:avLst/>
+          </a:prstGeom>
+          <a:noFill/>
+        </p:spPr>
+        <p:txBody>
+          <a:bodyPr wrap="square" lIns="0" tIns="0" rIns="0" bIns="0" anchor="t">
+            <a:noAutofit/>
+          </a:bodyPr>
+          <a:lstStyle/>
+          <a:p>
+            <a:pPr algn="l" marL="164592" indent="-164592">
+              <a:lnSpc>
+                <a:spcPts val="1610"/>
+              </a:lnSpc>
+              <a:spcBef>
+                <a:spcPts val="0"/>
+              </a:spcBef>
+              <a:buClr>
+                <a:srgbClr val="2563EB"/>
+              </a:buClr>
+              <a:buFont typeface="맑은 고딕"/>
+              <a:buChar char="•"/>
+            </a:pPr>
+            <a:r>
+              <a:rPr lang="ko-KR" sz="1150" b="0" dirty="0">
+                <a:solidFill>
+                  <a:srgbClr val="334155"/>
+                </a:solidFill>
+                <a:latin typeface="맑은 고딕"/>
+                <a:ea typeface="맑은 고딕"/>
+                <a:cs typeface="맑은 고딕"/>
+              </a:rPr>
+              <a:t>웹·우편 </a:t>
+            </a:r>
+            <a:r>
+              <a:rPr lang="ko-KR" sz="1150" b="1" dirty="0">
+                <a:solidFill>
+                  <a:srgbClr val="E11D48"/>
+                </a:solidFill>
+                <a:latin typeface="맑은 고딕"/>
+                <a:ea typeface="맑은 고딕"/>
+                <a:cs typeface="맑은 고딕"/>
+              </a:rPr>
+              <a:t>패스트 트랙(15분 이내) 49.6%</a:t>
+            </a:r>
+          </a:p>
+          <a:p>
+            <a:pPr algn="l" marL="164592" indent="-164592">
+              <a:lnSpc>
+                <a:spcPts val="1610"/>
+              </a:lnSpc>
+              <a:spcBef>
+                <a:spcPts val="300"/>
+              </a:spcBef>
+              <a:buClr>
+                <a:srgbClr val="2563EB"/>
+              </a:buClr>
+              <a:buFont typeface="맑은 고딕"/>
+              <a:buChar char="•"/>
+            </a:pPr>
+            <a:r>
+              <a:rPr lang="ko-KR" sz="1150" b="0" dirty="0">
+                <a:solidFill>
+                  <a:srgbClr val="334155"/>
+                </a:solidFill>
+                <a:latin typeface="맑은 고딕"/>
+                <a:ea typeface="맑은 고딕"/>
+                <a:cs typeface="맑은 고딕"/>
+              </a:rPr>
+              <a:t>웹·우편 </a:t>
+            </a:r>
+            <a:r>
+              <a:rPr lang="ko-KR" sz="1150" b="1" dirty="0">
+                <a:solidFill>
+                  <a:srgbClr val="E11D48"/>
+                </a:solidFill>
+                <a:latin typeface="맑은 고딕"/>
+                <a:ea typeface="맑은 고딕"/>
+                <a:cs typeface="맑은 고딕"/>
+              </a:rPr>
+              <a:t>장기 대기(60분 초과) 50.4%</a:t>
+            </a:r>
+          </a:p>
+          <a:p>
+            <a:pPr algn="l" marL="164592" indent="-164592">
+              <a:lnSpc>
+                <a:spcPts val="1610"/>
+              </a:lnSpc>
+              <a:spcBef>
+                <a:spcPts val="300"/>
+              </a:spcBef>
+              <a:buClr>
+                <a:srgbClr val="2563EB"/>
+              </a:buClr>
+              <a:buFont typeface="맑은 고딕"/>
+              <a:buChar char="•"/>
+            </a:pPr>
+            <a:r>
+              <a:rPr lang="ko-KR" sz="1150" b="0" dirty="0">
+                <a:solidFill>
+                  <a:srgbClr val="334155"/>
+                </a:solidFill>
+                <a:latin typeface="맑은 고딕"/>
+                <a:ea typeface="맑은 고딕"/>
+                <a:cs typeface="맑은 고딕"/>
+              </a:rPr>
+              <a:t>15~60분 구간 0건</a:t>
+            </a:r>
+          </a:p>
+          <a:p>
+            <a:pPr algn="l" marL="164592" indent="-164592">
+              <a:lnSpc>
+                <a:spcPts val="1610"/>
+              </a:lnSpc>
+              <a:spcBef>
+                <a:spcPts val="300"/>
+              </a:spcBef>
+              <a:buClr>
+                <a:srgbClr val="2563EB"/>
+              </a:buClr>
+              <a:buFont typeface="맑은 고딕"/>
+              <a:buChar char="•"/>
+            </a:pPr>
+            <a:r>
+              <a:rPr lang="ko-KR" sz="1150" b="0" dirty="0">
+                <a:solidFill>
+                  <a:srgbClr val="334155"/>
+                </a:solidFill>
+                <a:latin typeface="맑은 고딕"/>
+                <a:ea typeface="맑은 고딕"/>
+                <a:cs typeface="맑은 고딕"/>
+              </a:rPr>
+              <a:t>인계 123건 전부 60분 초과 (최소 72분)</a:t>
+            </a:r>
+          </a:p>
+        </p:txBody>
+      </p:sp>
+      <p:sp>
+        <p:nvSpPr>
+          <p:cNvPr id="25" name="c3"/>
+          <p:cNvSpPr/>
+          <p:nvPr/>
+        </p:nvSpPr>
+        <p:spPr>
+          <a:xfrm>
+            <a:off x="8082076" y="4235693"/>
+            <a:ext cx="3606698" cy="1609852"/>
+          </a:xfrm>
+          <a:prstGeom prst="rect">
+            <a:avLst/>
+          </a:prstGeom>
+          <a:solidFill>
+            <a:srgbClr val="FFFFFF"/>
+          </a:solidFill>
+          <a:ln w="9525">
+            <a:solidFill>
+              <a:srgbClr val="E2E8F0"/>
+            </a:solidFill>
+          </a:ln>
+          <a:effectLst/>
+        </p:spPr>
+        <p:style>
+          <a:lnRef idx="1">
+            <a:schemeClr val="accent1"/>
+          </a:lnRef>
+          <a:fillRef idx="3">
+            <a:schemeClr val="accent1"/>
+          </a:fillRef>
+          <a:effectRef idx="2">
+            <a:schemeClr val="accent1"/>
+          </a:effectRef>
+          <a:fontRef idx="minor">
+            <a:schemeClr val="lt1"/>
+          </a:fontRef>
+        </p:style>
+        <p:txBody>
+          <a:bodyPr rtlCol="0" anchor="ctr"/>
+          <a:lstStyle/>
+          <a:p>
+            <a:pPr algn="ctr"/>
+          </a:p>
+        </p:txBody>
+      </p:sp>
+      <p:sp>
+        <p:nvSpPr>
+          <p:cNvPr id="26" name="label:L1:t"/>
+          <p:cNvSpPr txBox="1"/>
+          <p:nvPr/>
+        </p:nvSpPr>
+        <p:spPr>
+          <a:xfrm>
+            <a:off x="8264956" y="4418573"/>
+            <a:ext cx="3240938" cy="158750"/>
+          </a:xfrm>
+          <a:prstGeom prst="rect">
+            <a:avLst/>
+          </a:prstGeom>
+          <a:noFill/>
+        </p:spPr>
+        <p:txBody>
+          <a:bodyPr wrap="square" lIns="0" tIns="0" rIns="0" bIns="0" anchor="t">
+            <a:noAutofit/>
+          </a:bodyPr>
+          <a:lstStyle/>
+          <a:p>
+            <a:pPr algn="l">
+              <a:lnSpc>
+                <a:spcPts val="1250"/>
+              </a:lnSpc>
+              <a:spcBef>
+                <a:spcPts val="0"/>
+              </a:spcBef>
+              <a:buNone/>
+            </a:pPr>
+            <a:r>
+              <a:rPr lang="ko-KR" sz="950" b="1" dirty="0">
+                <a:solidFill>
+                  <a:srgbClr val="64748B"/>
+                </a:solidFill>
+                <a:latin typeface="Consolas"/>
+                <a:ea typeface="맑은 고딕"/>
+                <a:cs typeface="Consolas"/>
+              </a:rPr>
               <a:t>반전 · 웹은 느리지 않다</a:t>
             </a:r>
           </a:p>
@@ -32526,13 +32756,13 @@
       </p:sp>
       <p:sp>
         <p:nvSpPr>
-          <p:cNvPr id="21" name="body:L1:c"/>
-          <p:cNvSpPr txBox="1"/>
-          <p:nvPr/>
-        </p:nvSpPr>
-        <p:spPr>
-          <a:xfrm>
-            <a:off x="8264956" y="4999228"/>
+          <p:cNvPr id="27" name="body:L1:c"/>
+          <p:cNvSpPr txBox="1"/>
+          <p:nvPr/>
+        </p:nvSpPr>
+        <p:spPr>
+          <a:xfrm>
+            <a:off x="8264956" y="4632187"/>
             <a:ext cx="3240938" cy="511810"/>
           </a:xfrm>
           <a:prstGeom prst="rect">
@@ -32582,13 +32812,13 @@
       </p:sp>
       <p:sp>
         <p:nvSpPr>
-          <p:cNvPr id="22" name="body:L1:t"/>
-          <p:cNvSpPr txBox="1"/>
-          <p:nvPr/>
-        </p:nvSpPr>
-        <p:spPr>
-          <a:xfrm>
-            <a:off x="8264956" y="5565902"/>
+          <p:cNvPr id="28" name="body:L1:t"/>
+          <p:cNvSpPr txBox="1"/>
+          <p:nvPr/>
+        </p:nvSpPr>
+        <p:spPr>
+          <a:xfrm>
+            <a:off x="8264956" y="5198861"/>
             <a:ext cx="3240938" cy="204470"/>
           </a:xfrm>
           <a:prstGeom prst="rect">
@@ -32627,13 +32857,13 @@
       </p:sp>
       <p:sp>
         <p:nvSpPr>
-          <p:cNvPr id="23" name="body:L1:t"/>
-          <p:cNvSpPr txBox="1"/>
-          <p:nvPr/>
-        </p:nvSpPr>
-        <p:spPr>
-          <a:xfrm>
-            <a:off x="8264956" y="5825236"/>
+          <p:cNvPr id="29" name="body:L1:t"/>
+          <p:cNvSpPr txBox="1"/>
+          <p:nvPr/>
+        </p:nvSpPr>
+        <p:spPr>
+          <a:xfrm>
+            <a:off x="8264956" y="5458195"/>
             <a:ext cx="3240938" cy="204470"/>
           </a:xfrm>
           <a:prstGeom prst="rect">

</xml_diff>

<commit_message>
feat(deck): unified section page tags [ PART · name · page range ] on slides 2-19, agenda bullet synced with slide 16
Co-Authored-By: Claude Sonnet 5.5 <noreply@anthropic.com>
</commit_message>
<xml_diff>
--- a/outputs/pptx/puzzledata_repair_report.pptx
+++ b/outputs/pptx/puzzledata_repair_report.pptx
@@ -125,21 +125,21 @@
   <p:extLst>
     <p:ext uri="{521415D9-36F7-43E2-AB2F-B90AF26B5E84}">
       <p14:sectionLst xmlns:p14="http://schemas.microsoft.com/office/powerpoint/2010/main">
-        <p14:section name="Part 00 · 인트로" id="{2CAA2A26-A940-4893-A488-49C654628EB2}">
+        <p14:section name="Part 00 · 인트로" id="{5C7AC9C7-C5DB-4EA5-8D1D-F27A4825683D}">
           <p14:sldIdLst>
             <p14:sldId id="256"/>
             <p14:sldId id="257"/>
             <p14:sldId id="258"/>
           </p14:sldIdLst>
         </p14:section>
-        <p14:section name="Part 01 · 데이터 진단" id="{252D082C-9DBA-48F2-A798-448D5EFA80BC}">
+        <p14:section name="Part 01 · 데이터 진단" id="{E5A260BE-8A40-441F-96FC-4D84F101FE3D}">
           <p14:sldIdLst>
             <p14:sldId id="259"/>
             <p14:sldId id="260"/>
             <p14:sldId id="261"/>
           </p14:sldIdLst>
         </p14:section>
-        <p14:section name="Part 02 · 병목 규명" id="{BDA01902-2A7A-4AD4-8C04-48D4E95040BA}">
+        <p14:section name="Part 02 · 병목 규명" id="{8D4BA58C-C756-452F-8DE3-F46E624A9FCC}">
           <p14:sldIdLst>
             <p14:sldId id="262"/>
             <p14:sldId id="263"/>
@@ -152,14 +152,14 @@
             <p14:sldId id="270"/>
           </p14:sldIdLst>
         </p14:section>
-        <p14:section name="Part 03 · 개선 전략" id="{812F29F8-9AE0-4966-8C6C-FFF9F8D2CA9A}">
+        <p14:section name="Part 03 · 개선 전략" id="{1D15576D-2640-497C-AF62-64027438391A}">
           <p14:sldIdLst>
             <p14:sldId id="271"/>
             <p14:sldId id="272"/>
             <p14:sldId id="273"/>
           </p14:sldIdLst>
         </p14:section>
-        <p14:section name="Part 04 · Q&amp;A" id="{95555FE5-CAD7-453E-B57A-24E7218F7D79}">
+        <p14:section name="Part 04 · Q&amp;A" id="{B61525E3-BCBF-475F-8D30-96C32C2F4A02}">
           <p14:sldIdLst>
             <p14:sldId id="274"/>
           </p14:sldIdLst>
@@ -5585,7 +5585,7 @@
                 <a:ea typeface="맑은 고딕"/>
                 <a:cs typeface="Consolas"/>
               </a:rPr>
-              <a:t>[ 10 / Q2-3 · RECEPTION DRIVERS ]</a:t>
+              <a:t>[ 02 · AS-IS 심층 분석 · P.07~15 ]</a:t>
             </a:r>
           </a:p>
         </p:txBody>
@@ -6741,7 +6741,7 @@
                 <a:ea typeface="맑은 고딕"/>
                 <a:cs typeface="Consolas"/>
               </a:rPr>
-              <a:t>[ 11 / Q2-3 · RECEPTION OLS ]</a:t>
+              <a:t>[ 02 · AS-IS 심층 분석 · P.07~15 ]</a:t>
             </a:r>
           </a:p>
         </p:txBody>
@@ -7884,7 +7884,7 @@
                 <a:ea typeface="맑은 고딕"/>
                 <a:cs typeface="Consolas"/>
               </a:rPr>
-              <a:t>[ 12 / Q2-2 · BOTTLENECK 2 · FIELD ]</a:t>
+              <a:t>[ 02 · AS-IS 심층 분석 · P.07~15 ]</a:t>
             </a:r>
           </a:p>
         </p:txBody>
@@ -9796,7 +9796,7 @@
                 <a:ea typeface="맑은 고딕"/>
                 <a:cs typeface="Consolas"/>
               </a:rPr>
-              <a:t>[ 13 / Q2-2 · BOTTLENECK 2 · QUEUE ]</a:t>
+              <a:t>[ 02 · AS-IS 심층 분석 · P.07~15 ]</a:t>
             </a:r>
           </a:p>
         </p:txBody>
@@ -10906,7 +10906,7 @@
                 <a:ea typeface="맑은 고딕"/>
                 <a:cs typeface="Consolas"/>
               </a:rPr>
-              <a:t>[ 14 / Q2-2 · BOTTLENECK 3 · REPAIR ]</a:t>
+              <a:t>[ 02 · AS-IS 심층 분석 · P.07~15 ]</a:t>
             </a:r>
           </a:p>
         </p:txBody>
@@ -12049,7 +12049,7 @@
                 <a:ea typeface="맑은 고딕"/>
                 <a:cs typeface="Consolas"/>
               </a:rPr>
-              <a:t>[ 15 / Q2-3 · DRIVERS · OLS ]</a:t>
+              <a:t>[ 02 · AS-IS 심층 분석 · P.07~15 ]</a:t>
             </a:r>
           </a:p>
         </p:txBody>
@@ -13192,7 +13192,7 @@
                 <a:ea typeface="맑은 고딕"/>
                 <a:cs typeface="Consolas"/>
               </a:rPr>
-              <a:t>[ 16 / Q2→Q3 · ROOT CAUSE ]</a:t>
+              <a:t>[ 03 · TO-BE 개선 방안 · P.16~18 ]</a:t>
             </a:r>
           </a:p>
         </p:txBody>
@@ -14767,7 +14767,7 @@
                 <a:ea typeface="맑은 고딕"/>
                 <a:cs typeface="Consolas"/>
               </a:rPr>
-              <a:t>[ 17 / Q3 · TO-BE STRATEGY ]</a:t>
+              <a:t>[ 03 · TO-BE 개선 방안 · P.16~18 ]</a:t>
             </a:r>
           </a:p>
         </p:txBody>
@@ -17106,7 +17106,7 @@
                 <a:ea typeface="맑은 고딕"/>
                 <a:cs typeface="Consolas"/>
               </a:rPr>
-              <a:t>[ 18 / Q3 · EXPECTED IMPACT ]</a:t>
+              <a:t>[ 03 · TO-BE 개선 방안 · P.16~18 ]</a:t>
             </a:r>
           </a:p>
         </p:txBody>
@@ -19007,7 +19007,7 @@
                 <a:ea typeface="맑은 고딕"/>
                 <a:cs typeface="Consolas"/>
               </a:rPr>
-              <a:t>[ 19 / CLOSING &amp; Q&amp;A ]</a:t>
+              <a:t>[ 04 · 마무리 · P.19 ]</a:t>
             </a:r>
           </a:p>
         </p:txBody>
@@ -20135,7 +20135,7 @@
                 <a:ea typeface="맑은 고딕"/>
                 <a:cs typeface="Consolas"/>
               </a:rPr>
-              <a:t>[ 02 / PREVIEW ]</a:t>
+              <a:t>[ 00 · 프리뷰 · P.02~03 ]</a:t>
             </a:r>
           </a:p>
         </p:txBody>
@@ -21449,14 +21449,14 @@
       </p:sp>
       <p:sp>
         <p:nvSpPr>
-          <p:cNvPr id="27" name="body:L5:t"/>
+          <p:cNvPr id="27" name="body:L6:t"/>
           <p:cNvSpPr txBox="1"/>
           <p:nvPr/>
         </p:nvSpPr>
         <p:spPr>
           <a:xfrm>
             <a:off x="6406743" y="3487928"/>
-            <a:ext cx="2220391" cy="1098550"/>
+            <a:ext cx="2220391" cy="1303019"/>
           </a:xfrm>
           <a:prstGeom prst="rect">
             <a:avLst/>
@@ -21491,7 +21491,28 @@
                 <a:ea typeface="맑은 고딕"/>
                 <a:cs typeface="맑은 고딕"/>
               </a:rPr>
-              <a:t>사전 분류 적중률 87.3%와</a:t>
+              <a:t>사전 분류 적중(E→사내</a:t>
+            </a:r>
+            <a:br>
+              <a:rPr lang="ko-KR" sz="1150" b="0" dirty="0">
+                <a:solidFill>
+                  <a:srgbClr val="334155"/>
+                </a:solidFill>
+                <a:latin typeface="맑은 고딕"/>
+                <a:ea typeface="맑은 고딕"/>
+                <a:cs typeface="맑은 고딕"/>
+              </a:rPr>
+            </a:br>
+            <a:r>
+              <a:rPr lang="ko-KR" sz="1150" b="0" dirty="0">
+                <a:solidFill>
+                  <a:srgbClr val="334155"/>
+                </a:solidFill>
+                <a:latin typeface="맑은 고딕"/>
+                <a:ea typeface="맑은 고딕"/>
+                <a:cs typeface="맑은 고딕"/>
+              </a:rPr>
+              <a:t>100.0%, P→즉시 83.1%)과</a:t>
             </a:r>
             <a:br>
               <a:rPr lang="ko-KR" sz="1150" b="0" dirty="0">
@@ -22044,7 +22065,7 @@
                 <a:ea typeface="맑은 고딕"/>
                 <a:cs typeface="Consolas"/>
               </a:rPr>
-              <a:t>[ 03 / EXECUTIVE SUMMARY ]</a:t>
+              <a:t>[ 00 · 프리뷰 · P.02~03 ]</a:t>
             </a:r>
           </a:p>
         </p:txBody>
@@ -23668,7 +23689,7 @@
                 <a:ea typeface="맑은 고딕"/>
                 <a:cs typeface="Consolas"/>
               </a:rPr>
-              <a:t>[ 04 / Q1 · BEFORE PROFILING ]</a:t>
+              <a:t>[ 01 · 데이터 진단 및 전처리 · P.04~06 ]</a:t>
             </a:r>
           </a:p>
         </p:txBody>
@@ -25084,7 +25105,7 @@
                 <a:ea typeface="맑은 고딕"/>
                 <a:cs typeface="Consolas"/>
               </a:rPr>
-              <a:t>[ 05 / Q1 · CASE 1–5 ]</a:t>
+              <a:t>[ 01 · 데이터 진단 및 전처리 · P.04~06 ]</a:t>
             </a:r>
           </a:p>
         </p:txBody>
@@ -27447,7 +27468,7 @@
                 <a:ea typeface="맑은 고딕"/>
                 <a:cs typeface="Consolas"/>
               </a:rPr>
-              <a:t>[ 06 / Q1 · AFTER PROFILING ]</a:t>
+              <a:t>[ 01 · 데이터 진단 및 전처리 · P.04~06 ]</a:t>
             </a:r>
           </a:p>
         </p:txBody>
@@ -29606,7 +29627,7 @@
                 <a:ea typeface="맑은 고딕"/>
                 <a:cs typeface="Consolas"/>
               </a:rPr>
-              <a:t>[ 07 / Q2-1 · AS-IS PROCESS ]</a:t>
+              <a:t>[ 02 · AS-IS 심층 분석 · P.07~15 ]</a:t>
             </a:r>
           </a:p>
         </p:txBody>
@@ -30606,7 +30627,7 @@
                 <a:ea typeface="맑은 고딕"/>
                 <a:cs typeface="Consolas"/>
               </a:rPr>
-              <a:t>[ 08 / Q2-2 · MACRO DECOMPOSITION ]</a:t>
+              <a:t>[ 02 · AS-IS 심층 분석 · P.07~15 ]</a:t>
             </a:r>
           </a:p>
         </p:txBody>
@@ -31614,7 +31635,7 @@
                 <a:ea typeface="맑은 고딕"/>
                 <a:cs typeface="Consolas"/>
               </a:rPr>
-              <a:t>[ 09 / Q2-2 · BOTTLENECK 1 · RECEPTION ]</a:t>
+              <a:t>[ 02 · AS-IS 심층 분석 · P.07~15 ]</a:t>
             </a:r>
           </a:p>
         </p:txBody>

</xml_diff>

<commit_message>
feat(deck): section tag shows current page (e.g. [ 02 · AS-IS 심층 분석 · P.07 ])
Co-Authored-By: Claude Sonnet 5.5 <noreply@anthropic.com>
</commit_message>
<xml_diff>
--- a/outputs/pptx/puzzledata_repair_report.pptx
+++ b/outputs/pptx/puzzledata_repair_report.pptx
@@ -125,21 +125,21 @@
   <p:extLst>
     <p:ext uri="{521415D9-36F7-43E2-AB2F-B90AF26B5E84}">
       <p14:sectionLst xmlns:p14="http://schemas.microsoft.com/office/powerpoint/2010/main">
-        <p14:section name="Part 00 · 인트로" id="{5C7AC9C7-C5DB-4EA5-8D1D-F27A4825683D}">
+        <p14:section name="Part 00 · 인트로" id="{B54C3A6D-64D4-459C-9F9F-D44CBE12E7A0}">
           <p14:sldIdLst>
             <p14:sldId id="256"/>
             <p14:sldId id="257"/>
             <p14:sldId id="258"/>
           </p14:sldIdLst>
         </p14:section>
-        <p14:section name="Part 01 · 데이터 진단" id="{E5A260BE-8A40-441F-96FC-4D84F101FE3D}">
+        <p14:section name="Part 01 · 데이터 진단" id="{7C6D0631-7CEA-4852-90F3-D47F01A8C03B}">
           <p14:sldIdLst>
             <p14:sldId id="259"/>
             <p14:sldId id="260"/>
             <p14:sldId id="261"/>
           </p14:sldIdLst>
         </p14:section>
-        <p14:section name="Part 02 · 병목 규명" id="{8D4BA58C-C756-452F-8DE3-F46E624A9FCC}">
+        <p14:section name="Part 02 · 병목 규명" id="{FF215918-96FF-4BF9-AE69-F4D3718CFCB6}">
           <p14:sldIdLst>
             <p14:sldId id="262"/>
             <p14:sldId id="263"/>
@@ -152,14 +152,14 @@
             <p14:sldId id="270"/>
           </p14:sldIdLst>
         </p14:section>
-        <p14:section name="Part 03 · 개선 전략" id="{1D15576D-2640-497C-AF62-64027438391A}">
+        <p14:section name="Part 03 · 개선 전략" id="{85824352-7988-4445-B6D9-79F3CA01E47E}">
           <p14:sldIdLst>
             <p14:sldId id="271"/>
             <p14:sldId id="272"/>
             <p14:sldId id="273"/>
           </p14:sldIdLst>
         </p14:section>
-        <p14:section name="Part 04 · Q&amp;A" id="{B61525E3-BCBF-475F-8D30-96C32C2F4A02}">
+        <p14:section name="Part 04 · Q&amp;A" id="{C0076D06-1C40-4CAD-8FBB-24ECA56B73C5}">
           <p14:sldIdLst>
             <p14:sldId id="274"/>
           </p14:sldIdLst>
@@ -5585,7 +5585,7 @@
                 <a:ea typeface="맑은 고딕"/>
                 <a:cs typeface="Consolas"/>
               </a:rPr>
-              <a:t>[ 02 · AS-IS 심층 분석 · P.07~15 ]</a:t>
+              <a:t>[ 02 · AS-IS 심층 분석 · P.10 ]</a:t>
             </a:r>
           </a:p>
         </p:txBody>
@@ -6741,7 +6741,7 @@
                 <a:ea typeface="맑은 고딕"/>
                 <a:cs typeface="Consolas"/>
               </a:rPr>
-              <a:t>[ 02 · AS-IS 심층 분석 · P.07~15 ]</a:t>
+              <a:t>[ 02 · AS-IS 심층 분석 · P.11 ]</a:t>
             </a:r>
           </a:p>
         </p:txBody>
@@ -7884,7 +7884,7 @@
                 <a:ea typeface="맑은 고딕"/>
                 <a:cs typeface="Consolas"/>
               </a:rPr>
-              <a:t>[ 02 · AS-IS 심층 분석 · P.07~15 ]</a:t>
+              <a:t>[ 02 · AS-IS 심층 분석 · P.12 ]</a:t>
             </a:r>
           </a:p>
         </p:txBody>
@@ -9796,7 +9796,7 @@
                 <a:ea typeface="맑은 고딕"/>
                 <a:cs typeface="Consolas"/>
               </a:rPr>
-              <a:t>[ 02 · AS-IS 심층 분석 · P.07~15 ]</a:t>
+              <a:t>[ 02 · AS-IS 심층 분석 · P.13 ]</a:t>
             </a:r>
           </a:p>
         </p:txBody>
@@ -10906,7 +10906,7 @@
                 <a:ea typeface="맑은 고딕"/>
                 <a:cs typeface="Consolas"/>
               </a:rPr>
-              <a:t>[ 02 · AS-IS 심층 분석 · P.07~15 ]</a:t>
+              <a:t>[ 02 · AS-IS 심층 분석 · P.14 ]</a:t>
             </a:r>
           </a:p>
         </p:txBody>
@@ -12049,7 +12049,7 @@
                 <a:ea typeface="맑은 고딕"/>
                 <a:cs typeface="Consolas"/>
               </a:rPr>
-              <a:t>[ 02 · AS-IS 심층 분석 · P.07~15 ]</a:t>
+              <a:t>[ 02 · AS-IS 심층 분석 · P.15 ]</a:t>
             </a:r>
           </a:p>
         </p:txBody>
@@ -13192,7 +13192,7 @@
                 <a:ea typeface="맑은 고딕"/>
                 <a:cs typeface="Consolas"/>
               </a:rPr>
-              <a:t>[ 03 · TO-BE 개선 방안 · P.16~18 ]</a:t>
+              <a:t>[ 03 · TO-BE 개선 방안 · P.16 ]</a:t>
             </a:r>
           </a:p>
         </p:txBody>
@@ -14767,7 +14767,7 @@
                 <a:ea typeface="맑은 고딕"/>
                 <a:cs typeface="Consolas"/>
               </a:rPr>
-              <a:t>[ 03 · TO-BE 개선 방안 · P.16~18 ]</a:t>
+              <a:t>[ 03 · TO-BE 개선 방안 · P.17 ]</a:t>
             </a:r>
           </a:p>
         </p:txBody>
@@ -17106,7 +17106,7 @@
                 <a:ea typeface="맑은 고딕"/>
                 <a:cs typeface="Consolas"/>
               </a:rPr>
-              <a:t>[ 03 · TO-BE 개선 방안 · P.16~18 ]</a:t>
+              <a:t>[ 03 · TO-BE 개선 방안 · P.18 ]</a:t>
             </a:r>
           </a:p>
         </p:txBody>
@@ -20135,7 +20135,7 @@
                 <a:ea typeface="맑은 고딕"/>
                 <a:cs typeface="Consolas"/>
               </a:rPr>
-              <a:t>[ 00 · 프리뷰 · P.02~03 ]</a:t>
+              <a:t>[ 00 · 프리뷰 · P.02 ]</a:t>
             </a:r>
           </a:p>
         </p:txBody>
@@ -22065,7 +22065,7 @@
                 <a:ea typeface="맑은 고딕"/>
                 <a:cs typeface="Consolas"/>
               </a:rPr>
-              <a:t>[ 00 · 프리뷰 · P.02~03 ]</a:t>
+              <a:t>[ 00 · 프리뷰 · P.03 ]</a:t>
             </a:r>
           </a:p>
         </p:txBody>
@@ -23689,7 +23689,7 @@
                 <a:ea typeface="맑은 고딕"/>
                 <a:cs typeface="Consolas"/>
               </a:rPr>
-              <a:t>[ 01 · 데이터 진단 및 전처리 · P.04~06 ]</a:t>
+              <a:t>[ 01 · 데이터 진단 및 전처리 · P.04 ]</a:t>
             </a:r>
           </a:p>
         </p:txBody>
@@ -25105,7 +25105,7 @@
                 <a:ea typeface="맑은 고딕"/>
                 <a:cs typeface="Consolas"/>
               </a:rPr>
-              <a:t>[ 01 · 데이터 진단 및 전처리 · P.04~06 ]</a:t>
+              <a:t>[ 01 · 데이터 진단 및 전처리 · P.05 ]</a:t>
             </a:r>
           </a:p>
         </p:txBody>
@@ -27468,7 +27468,7 @@
                 <a:ea typeface="맑은 고딕"/>
                 <a:cs typeface="Consolas"/>
               </a:rPr>
-              <a:t>[ 01 · 데이터 진단 및 전처리 · P.04~06 ]</a:t>
+              <a:t>[ 01 · 데이터 진단 및 전처리 · P.06 ]</a:t>
             </a:r>
           </a:p>
         </p:txBody>
@@ -29627,7 +29627,7 @@
                 <a:ea typeface="맑은 고딕"/>
                 <a:cs typeface="Consolas"/>
               </a:rPr>
-              <a:t>[ 02 · AS-IS 심층 분석 · P.07~15 ]</a:t>
+              <a:t>[ 02 · AS-IS 심층 분석 · P.07 ]</a:t>
             </a:r>
           </a:p>
         </p:txBody>
@@ -30627,7 +30627,7 @@
                 <a:ea typeface="맑은 고딕"/>
                 <a:cs typeface="Consolas"/>
               </a:rPr>
-              <a:t>[ 02 · AS-IS 심층 분석 · P.07~15 ]</a:t>
+              <a:t>[ 02 · AS-IS 심층 분석 · P.08 ]</a:t>
             </a:r>
           </a:p>
         </p:txBody>
@@ -31635,7 +31635,7 @@
                 <a:ea typeface="맑은 고딕"/>
                 <a:cs typeface="Consolas"/>
               </a:rPr>
-              <a:t>[ 02 · AS-IS 심층 분석 · P.07~15 ]</a:t>
+              <a:t>[ 02 · AS-IS 심층 분석 · P.09 ]</a:t>
             </a:r>
           </a:p>
         </p:txBody>

</xml_diff>

<commit_message>
feat(deck): replace em-dash separators with context-appropriate ones (colon, middle dot, arrow, period)
Co-Authored-By: Claude Sonnet 5.5 <noreply@anthropic.com>
</commit_message>
<xml_diff>
--- a/outputs/pptx/puzzledata_repair_report.pptx
+++ b/outputs/pptx/puzzledata_repair_report.pptx
@@ -125,21 +125,21 @@
   <p:extLst>
     <p:ext uri="{521415D9-36F7-43E2-AB2F-B90AF26B5E84}">
       <p14:sectionLst xmlns:p14="http://schemas.microsoft.com/office/powerpoint/2010/main">
-        <p14:section name="Part 00 · 인트로" id="{B54C3A6D-64D4-459C-9F9F-D44CBE12E7A0}">
+        <p14:section name="Part 00 · 인트로" id="{4C0EF149-9DD8-4F66-BE4F-9FF913B0E740}">
           <p14:sldIdLst>
             <p14:sldId id="256"/>
             <p14:sldId id="257"/>
             <p14:sldId id="258"/>
           </p14:sldIdLst>
         </p14:section>
-        <p14:section name="Part 01 · 데이터 진단" id="{7C6D0631-7CEA-4852-90F3-D47F01A8C03B}">
+        <p14:section name="Part 01 · 데이터 진단" id="{7B223B03-BD9A-4351-A737-BB4F020FF8FF}">
           <p14:sldIdLst>
             <p14:sldId id="259"/>
             <p14:sldId id="260"/>
             <p14:sldId id="261"/>
           </p14:sldIdLst>
         </p14:section>
-        <p14:section name="Part 02 · 병목 규명" id="{FF215918-96FF-4BF9-AE69-F4D3718CFCB6}">
+        <p14:section name="Part 02 · 병목 규명" id="{CE91BE87-649A-492F-8F55-04B92ECB7280}">
           <p14:sldIdLst>
             <p14:sldId id="262"/>
             <p14:sldId id="263"/>
@@ -152,14 +152,14 @@
             <p14:sldId id="270"/>
           </p14:sldIdLst>
         </p14:section>
-        <p14:section name="Part 03 · 개선 전략" id="{85824352-7988-4445-B6D9-79F3CA01E47E}">
+        <p14:section name="Part 03 · 개선 전략" id="{F1B02B3C-EC2B-493E-AE2A-CCDB61B87614}">
           <p14:sldIdLst>
             <p14:sldId id="271"/>
             <p14:sldId id="272"/>
             <p14:sldId id="273"/>
           </p14:sldIdLst>
         </p14:section>
-        <p14:section name="Part 04 · Q&amp;A" id="{C0076D06-1C40-4CAD-8FBB-24ECA56B73C5}">
+        <p14:section name="Part 04 · Q&amp;A" id="{09E2135A-3AFE-4A20-8339-375A60C65825}">
           <p14:sldIdLst>
             <p14:sldId id="274"/>
           </p14:sldIdLst>
@@ -5720,7 +5720,7 @@
                 <a:ea typeface="맑은 고딕"/>
                 <a:cs typeface="맑은 고딕"/>
               </a:rPr>
-              <a:t>접수 국면 9개 변수의 피어슨 상관 — 방향을 보여주고, 다음 장의 OLS가 순수 효과를 분리한다</a:t>
+              <a:t>접수 국면 9개 변수의 피어슨 상관: 방향을 보여주고, 다음 장의 OLS가 순수 효과를 분리한다</a:t>
             </a:r>
           </a:p>
         </p:txBody>
@@ -6127,7 +6127,7 @@
                 <a:ea typeface="맑은 고딕"/>
                 <a:cs typeface="맑은 고딕"/>
               </a:rPr>
-              <a:t>양(+)의 상관 — 인계 시 접수가 길어진다 (인계 123건)</a:t>
+              <a:t>양(+)의 상관: 인계 시 접수가 길어진다 (인계 123건)</a:t>
             </a:r>
           </a:p>
         </p:txBody>
@@ -6489,7 +6489,7 @@
                 <a:ea typeface="맑은 고딕"/>
                 <a:cs typeface="맑은 고딕"/>
               </a:rPr>
-              <a:t>물량 무관 — 현장 실사 대기와는 r = 0.17</a:t>
+              <a:t>물량 무관 · 현장 실사 대기와는 r = 0.17</a:t>
             </a:r>
           </a:p>
         </p:txBody>
@@ -6670,7 +6670,7 @@
                 <a:ea typeface="맑은 고딕"/>
                 <a:cs typeface="맑은 고딕"/>
               </a:rPr>
-              <a:t>인계 123건 전부 웹·우편 — 두 변수가 얽혀 OLS로 분리</a:t>
+              <a:t>인계 123건 전부 웹·우편 → 두 변수가 얽혀 OLS로 분리</a:t>
             </a:r>
           </a:p>
         </p:txBody>
@@ -7678,7 +7678,7 @@
                 <a:ea typeface="맑은 고딕"/>
                 <a:cs typeface="맑은 고딕"/>
               </a:rPr>
-              <a:t>p = 0.752 — 기각, 물량 무관</a:t>
+              <a:t>p = 0.752 · 기각, 물량 무관</a:t>
             </a:r>
           </a:p>
         </p:txBody>
@@ -7791,7 +7791,7 @@
                 <a:ea typeface="맑은 고딕"/>
                 <a:cs typeface="맑은 고딕"/>
               </a:rPr>
-              <a:t>를 설명하고 물량은 기여하지 않는다 — 병목은 용량이 아니라 </a:t>
+              <a:t>를 설명하고 물량은 기여하지 않는다. 병목은 용량이 아니라 </a:t>
             </a:r>
             <a:r>
               <a:rPr lang="ko-KR" sz="1250" b="1" dirty="0">
@@ -9931,7 +9931,7 @@
                 <a:ea typeface="맑은 고딕"/>
                 <a:cs typeface="맑은 고딕"/>
               </a:rPr>
-              <a:t>실사 대기의 원인 — 927건 전수가 방문 실사를 거치는 구조 · 소화율 50.6% (같은 구간 기준 52.5%)</a:t>
+              <a:t>실사 대기의 원인: 927건 전수가 방문 실사를 거치는 구조 · 소화율 50.6% (같은 구간 기준 52.5%)</a:t>
             </a:r>
           </a:p>
         </p:txBody>
@@ -10835,7 +10835,7 @@
                 <a:ea typeface="맑은 고딕"/>
                 <a:cs typeface="맑은 고딕"/>
               </a:rPr>
-              <a:t>가 적체와 76.8h 대기의 원인 — 초과분이 하루 약 66.3건씩 누적</a:t>
+              <a:t>가 적체와 76.8h 대기의 원인 · 초과분이 하루 약 66.3건씩 누적</a:t>
             </a:r>
           </a:p>
         </p:txBody>
@@ -11041,7 +11041,7 @@
                 <a:ea typeface="맑은 고딕"/>
                 <a:cs typeface="맑은 고딕"/>
               </a:rPr>
-              <a:t>사내 재수리 26건은 평균 총 리드타임 171.6h — 전체 평균의 1.6배</a:t>
+              <a:t>사내 재수리 26건은 평균 총 리드타임 171.6h · 전체 평균의 1.6배</a:t>
             </a:r>
           </a:p>
         </p:txBody>
@@ -11843,7 +11843,7 @@
                 <a:ea typeface="맑은 고딕"/>
                 <a:cs typeface="맑은 고딕"/>
               </a:rPr>
-              <a:t>E-1 16건 + E-2 6건 — 정밀검사 대상</a:t>
+              <a:t>E-1 16건 + E-2 6건 → 정밀검사 대상</a:t>
             </a:r>
           </a:p>
         </p:txBody>
@@ -13981,7 +13981,7 @@
                 <a:ea typeface="맑은 고딕"/>
                 <a:cs typeface="맑은 고딕"/>
               </a:rPr>
-              <a:t>알파벳 3분류(B·P·E)만 수집 — 즉시</a:t>
+              <a:t>알파벳 3분류(B·P·E)만 수집 → 즉시</a:t>
             </a:r>
             <a:br>
               <a:rPr lang="ko-KR" sz="1150" b="0" dirty="0">
@@ -14431,7 +14431,7 @@
                 <a:ea typeface="맑은 고딕"/>
                 <a:cs typeface="맑은 고딕"/>
               </a:rPr>
-              <a:t>접수 코드 P-1·3 — 건수는 39.4%인데</a:t>
+              <a:t>접수 코드 P-1·3: 건수는 39.4%인데</a:t>
             </a:r>
             <a:br>
               <a:rPr lang="ko-KR" sz="1150" b="0" dirty="0">
@@ -15922,7 +15922,7 @@
                 <a:ea typeface="맑은 고딕"/>
                 <a:cs typeface="맑은 고딕"/>
               </a:rPr>
-              <a:t>선택 — 상담원 개입 0</a:t>
+              <a:t>선택 · 상담원 개입 0</a:t>
             </a:r>
           </a:p>
         </p:txBody>
@@ -16902,7 +16902,7 @@
                 <a:ea typeface="맑은 고딕"/>
                 <a:cs typeface="맑은 고딕"/>
               </a:rPr>
-              <a:t>562건 </a:t>
+              <a:t>562건</a:t>
             </a:r>
             <a:r>
               <a:rPr lang="ko-KR" sz="1150" b="0" dirty="0">
@@ -16913,7 +16913,7 @@
                 <a:ea typeface="맑은 고딕"/>
                 <a:cs typeface="맑은 고딕"/>
               </a:rPr>
-              <a:t>— 일 유입 134.3→81.4건(39.4% 감소)</a:t>
+              <a:t>: 일 유입 134.3→81.4건(39.4% 감소)</a:t>
             </a:r>
           </a:p>
           <a:p>
@@ -17002,7 +17002,7 @@
                 <a:ea typeface="맑은 고딕"/>
                 <a:cs typeface="맑은 고딕"/>
               </a:rPr>
-              <a:t>365건 </a:t>
+              <a:t>365건</a:t>
             </a:r>
             <a:r>
               <a:rPr lang="ko-KR" sz="1150" b="0" dirty="0">
@@ -17013,7 +17013,7 @@
                 <a:ea typeface="맑은 고딕"/>
                 <a:cs typeface="맑은 고딕"/>
               </a:rPr>
-              <a:t>— 기본 키트로 1회 방문</a:t>
+              <a:t>: 기본 키트로 1회 방문</a:t>
             </a:r>
           </a:p>
           <a:p>
@@ -30556,7 +30556,7 @@
                 <a:ea typeface="맑은 고딕"/>
                 <a:cs typeface="맑은 고딕"/>
               </a:rPr>
-              <a:t>0건 — 동시 925건 · 결측 복원 2건(+1분)</a:t>
+              <a:t>0건: 동시 925건 · 결측 복원 2건(+1분)</a:t>
             </a:r>
           </a:p>
         </p:txBody>

</xml_diff>

<commit_message>
chore(deck): unify lane terms (실사 대기 줄 / Direct Booking 줄), agenda tile 04, closing message for a submitted document
Co-Authored-By: Claude Sonnet 5.5 <noreply@anthropic.com>
</commit_message>
<xml_diff>
--- a/outputs/pptx/puzzledata_repair_report.pptx
+++ b/outputs/pptx/puzzledata_repair_report.pptx
@@ -125,21 +125,21 @@
   <p:extLst>
     <p:ext uri="{521415D9-36F7-43E2-AB2F-B90AF26B5E84}">
       <p14:sectionLst xmlns:p14="http://schemas.microsoft.com/office/powerpoint/2010/main">
-        <p14:section name="Part 00 · 인트로" id="{4C0EF149-9DD8-4F66-BE4F-9FF913B0E740}">
+        <p14:section name="Part 00 · 인트로" id="{D34B5BC1-3486-4464-9AA1-54C02F280C16}">
           <p14:sldIdLst>
             <p14:sldId id="256"/>
             <p14:sldId id="257"/>
             <p14:sldId id="258"/>
           </p14:sldIdLst>
         </p14:section>
-        <p14:section name="Part 01 · 데이터 진단" id="{7B223B03-BD9A-4351-A737-BB4F020FF8FF}">
+        <p14:section name="Part 01 · 데이터 진단" id="{9F8BA960-17E7-403F-8965-DED9584A1627}">
           <p14:sldIdLst>
             <p14:sldId id="259"/>
             <p14:sldId id="260"/>
             <p14:sldId id="261"/>
           </p14:sldIdLst>
         </p14:section>
-        <p14:section name="Part 02 · 병목 규명" id="{CE91BE87-649A-492F-8F55-04B92ECB7280}">
+        <p14:section name="Part 02 · 병목 규명" id="{E8CE9907-C83A-4A03-89C3-54ACCA5F5A1D}">
           <p14:sldIdLst>
             <p14:sldId id="262"/>
             <p14:sldId id="263"/>
@@ -152,14 +152,14 @@
             <p14:sldId id="270"/>
           </p14:sldIdLst>
         </p14:section>
-        <p14:section name="Part 03 · 개선 전략" id="{F1B02B3C-EC2B-493E-AE2A-CCDB61B87614}">
+        <p14:section name="Part 03 · 개선 전략" id="{14AE2769-23AB-46FF-966F-2470C9F51530}">
           <p14:sldIdLst>
             <p14:sldId id="271"/>
             <p14:sldId id="272"/>
             <p14:sldId id="273"/>
           </p14:sldIdLst>
         </p14:section>
-        <p14:section name="Part 04 · Q&amp;A" id="{09E2135A-3AFE-4A20-8339-375A60C65825}">
+        <p14:section name="Part 04 · Q&amp;A" id="{64FD1BED-32AC-48DE-BAC0-411390FF7196}">
           <p14:sldIdLst>
             <p14:sldId id="274"/>
           </p14:sldIdLst>
@@ -1265,7 +1265,7 @@
           <a:lstStyle/>
           <a:p>
             <a:r>
-              <a:t>이상으로 발표를 마칩니다. 13,262행 전수 보존 전처리, 76.8시간의 실사 대기 병목과 원인 규명, 그리고 가정을 명시하고 실험 설계로 검증하는 TO-BE 시나리오까지 설명드렸습니다. 질문 주시면 답변드리겠습니다. 감사합니다.</a:t>
+              <a:t>이상으로 보고를 마칩니다. 13,262행 전수 보존 전처리, 76.8시간의 실사 대기 병목과 원인 규명, 그리고 가정을 명시하고 실험 설계로 검증하는 TO-BE 시나리오까지 설명드렸습니다. 질문 주시면 답변드리겠습니다. 감사합니다.</a:t>
             </a:r>
           </a:p>
           <a:p/>
@@ -14902,7 +14902,7 @@
                 <a:ea typeface="맑은 고딕"/>
                 <a:cs typeface="맑은 고딕"/>
               </a:rPr>
-              <a:t>접수 코드를 세분화해 즉시 수리 건을 실사 줄에서 빼고, 기사 캘린더로 바로 예약해 작업 줄로 보낸다</a:t>
+              <a:t>접수 코드를 세분화해 즉시 수리 건을 실사 대기 줄에서 빼고, 기사 캘린더로 바로 예약해 Direct Booking 줄로 보낸다</a:t>
             </a:r>
           </a:p>
         </p:txBody>
@@ -14968,7 +14968,7 @@
                 <a:ea typeface="맑은 고딕"/>
                 <a:cs typeface="Consolas"/>
               </a:rPr>
-              <a:t>출처: analysis.sql L1888~1928(사전 분류) · case_pivot_table.csv 재계산 · UI는 제안이며 효과는 다음 장에서 가정과 파일럿으로 다룸</a:t>
+              <a:t>출처: analysis.sql L1888~1928(사전 분류) · case_pivot_table.csv 재계산 · UI는 제안이며 효과는 다음 장에서 가정과 실험 설계로 다룸</a:t>
             </a:r>
           </a:p>
         </p:txBody>
@@ -15670,7 +15670,7 @@
                 <a:ea typeface="맑은 고딕"/>
                 <a:cs typeface="맑은 고딕"/>
               </a:rPr>
-              <a:t>건은 실사</a:t>
+              <a:t>건은 실사 대기</a:t>
             </a:r>
             <a:br>
               <a:rPr lang="ko-KR" sz="1150" b="0" dirty="0">
@@ -15702,7 +15702,7 @@
                 <a:ea typeface="맑은 고딕"/>
                 <a:cs typeface="맑은 고딕"/>
               </a:rPr>
-              <a:t>작업 줄</a:t>
+              <a:t>Direct Booking 줄</a:t>
             </a:r>
             <a:r>
               <a:rPr lang="ko-KR" sz="1150" b="0" dirty="0">
@@ -16880,7 +16880,7 @@
                 <a:ea typeface="맑은 고딕"/>
                 <a:cs typeface="Consolas"/>
               </a:rPr>
-              <a:t>TO-BE · 실사 줄 (정밀검사)</a:t>
+              <a:t>TO-BE · 실사 대기 줄 (정밀 실사)</a:t>
             </a:r>
           </a:p>
           <a:p>
@@ -16935,7 +16935,7 @@
                 <a:ea typeface="맑은 고딕"/>
                 <a:cs typeface="맑은 고딕"/>
               </a:rPr>
-              <a:t>B형 118건 · 외주 전환 59건 · 재작업 집중 E형</a:t>
+              <a:t>B형 118건 · 외주 전환 59건 · 재수리 집중 E형</a:t>
             </a:r>
           </a:p>
         </p:txBody>
@@ -16980,7 +16980,7 @@
                 <a:ea typeface="맑은 고딕"/>
                 <a:cs typeface="Consolas"/>
               </a:rPr>
-              <a:t>TO-BE · 작업 줄 (즉시)</a:t>
+              <a:t>TO-BE · Direct Booking 줄 (즉시)</a:t>
             </a:r>
           </a:p>
           <a:p>
@@ -19979,7 +19979,18 @@
               </a:rPr>
               <a:t>데이터 진단부터 병목 규명, 실행 전략까지</a:t>
             </a:r>
-            <a:br>
+          </a:p>
+          <a:p>
+            <a:pPr algn="ctr">
+              <a:lnSpc>
+                <a:spcPts val="1750"/>
+              </a:lnSpc>
+              <a:spcBef>
+                <a:spcPts val="0"/>
+              </a:spcBef>
+              <a:buNone/>
+            </a:pPr>
+            <a:r>
               <a:rPr lang="ko-KR" sz="1250" b="0" dirty="0">
                 <a:solidFill>
                   <a:srgbClr val="334155"/>
@@ -19988,17 +19999,7 @@
                 <a:ea typeface="맑은 고딕"/>
                 <a:cs typeface="맑은 고딕"/>
               </a:rPr>
-            </a:br>
-            <a:r>
-              <a:rPr lang="ko-KR" sz="1250" b="0" dirty="0">
-                <a:solidFill>
-                  <a:srgbClr val="334155"/>
-                </a:solidFill>
-                <a:latin typeface="맑은 고딕"/>
-                <a:ea typeface="맑은 고딕"/>
-                <a:cs typeface="맑은 고딕"/>
-              </a:rPr>
-              <a:t>자유롭게 질문해 주십시오.</a:t>
+              <a:t>문의 사항은 언제든지 연락 주십시오.</a:t>
             </a:r>
           </a:p>
         </p:txBody>
@@ -21900,7 +21901,7 @@
                 <a:ea typeface="맑은 고딕"/>
                 <a:cs typeface="맑은 고딕"/>
               </a:rPr>
-              <a:t>핵심 요약</a:t>
+              <a:t>마무리 및 Q&amp;A</a:t>
             </a:r>
           </a:p>
         </p:txBody>
@@ -23526,7 +23527,7 @@
                 <a:ea typeface="맑은 고딕"/>
                 <a:cs typeface="맑은 고딕"/>
               </a:rPr>
-              <a:t>실사 줄 유입 39.4% 감소</a:t>
+              <a:t>실사 대기 줄 유입 39.4% 감소</a:t>
             </a:r>
           </a:p>
           <a:p>

</xml_diff>

<commit_message>
feat(deck): slide 3 thesis drops the '작업자 태만이 아니라' clause
Co-Authored-By: Claude Sonnet 5.5 <noreply@anthropic.com>
</commit_message>
<xml_diff>
--- a/outputs/pptx/puzzledata_repair_report.pptx
+++ b/outputs/pptx/puzzledata_repair_report.pptx
@@ -125,21 +125,21 @@
   <p:extLst>
     <p:ext uri="{521415D9-36F7-43E2-AB2F-B90AF26B5E84}">
       <p14:sectionLst xmlns:p14="http://schemas.microsoft.com/office/powerpoint/2010/main">
-        <p14:section name="Part 00 · 인트로" id="{D34B5BC1-3486-4464-9AA1-54C02F280C16}">
+        <p14:section name="Part 00 · 인트로" id="{7EF64CBD-D6AF-4B4E-9BFE-BF66FF792736}">
           <p14:sldIdLst>
             <p14:sldId id="256"/>
             <p14:sldId id="257"/>
             <p14:sldId id="258"/>
           </p14:sldIdLst>
         </p14:section>
-        <p14:section name="Part 01 · 데이터 진단" id="{9F8BA960-17E7-403F-8965-DED9584A1627}">
+        <p14:section name="Part 01 · 데이터 진단" id="{3CDBDE1A-0AE7-4A10-B55D-409867F22D14}">
           <p14:sldIdLst>
             <p14:sldId id="259"/>
             <p14:sldId id="260"/>
             <p14:sldId id="261"/>
           </p14:sldIdLst>
         </p14:section>
-        <p14:section name="Part 02 · 병목 규명" id="{E8CE9907-C83A-4A03-89C3-54ACCA5F5A1D}">
+        <p14:section name="Part 02 · 병목 규명" id="{1AA19605-7822-4062-9A60-1CA204586D97}">
           <p14:sldIdLst>
             <p14:sldId id="262"/>
             <p14:sldId id="263"/>
@@ -152,14 +152,14 @@
             <p14:sldId id="270"/>
           </p14:sldIdLst>
         </p14:section>
-        <p14:section name="Part 03 · 개선 전략" id="{14AE2769-23AB-46FF-966F-2470C9F51530}">
+        <p14:section name="Part 03 · 개선 전략" id="{4F956ED2-60F6-4865-A897-978D9BC57158}">
           <p14:sldIdLst>
             <p14:sldId id="271"/>
             <p14:sldId id="272"/>
             <p14:sldId id="273"/>
           </p14:sldIdLst>
         </p14:section>
-        <p14:section name="Part 04 · Q&amp;A" id="{64FD1BED-32AC-48DE-BAC0-411390FF7196}">
+        <p14:section name="Part 04 · Q&amp;A" id="{8EB0BE7C-39C2-4BDE-B2FC-8B4D0EE07FBA}">
           <p14:sldIdLst>
             <p14:sldId id="274"/>
           </p14:sldIdLst>
@@ -22281,7 +22281,7 @@
         <p:spPr>
           <a:xfrm>
             <a:off x="502920" y="1527048"/>
-            <a:ext cx="11185855" cy="1132078"/>
+            <a:ext cx="11185855" cy="883158"/>
           </a:xfrm>
           <a:prstGeom prst="rect">
             <a:avLst/>
@@ -22365,14 +22365,14 @@
       </p:sp>
       <p:sp>
         <p:nvSpPr>
-          <p:cNvPr id="10" name="body:L2:thesis"/>
+          <p:cNvPr id="10" name="body:L1:thesis"/>
           <p:cNvSpPr txBox="1"/>
           <p:nvPr/>
         </p:nvSpPr>
         <p:spPr>
           <a:xfrm>
             <a:off x="704088" y="1960118"/>
-            <a:ext cx="10783519" cy="497840"/>
+            <a:ext cx="10783519" cy="248920"/>
           </a:xfrm>
           <a:prstGeom prst="rect">
             <a:avLst/>
@@ -22403,7 +22403,7 @@
                 <a:ea typeface="맑은 고딕"/>
                 <a:cs typeface="맑은 고딕"/>
               </a:rPr>
-              <a:t>수리 지연의 본질은 작업자 태만이 아니라 </a:t>
+              <a:t>수리 지연의 본질은 </a:t>
             </a:r>
             <a:r>
               <a:rPr lang="ko-KR" sz="1400" b="1" dirty="0">
@@ -22447,28 +22447,7 @@
                 <a:ea typeface="맑은 고딕"/>
                 <a:cs typeface="맑은 고딕"/>
               </a:rPr>
-              <a:t>이다.</a:t>
-            </a:r>
-            <a:br>
-              <a:rPr lang="ko-KR" sz="1400" b="0" dirty="0">
-                <a:solidFill>
-                  <a:srgbClr val="0F172A"/>
-                </a:solidFill>
-                <a:latin typeface="맑은 고딕"/>
-                <a:ea typeface="맑은 고딕"/>
-                <a:cs typeface="맑은 고딕"/>
-              </a:rPr>
-            </a:br>
-            <a:r>
-              <a:rPr lang="ko-KR" sz="1400" b="0" dirty="0">
-                <a:solidFill>
-                  <a:srgbClr val="0F172A"/>
-                </a:solidFill>
-                <a:latin typeface="맑은 고딕"/>
-                <a:ea typeface="맑은 고딕"/>
-                <a:cs typeface="맑은 고딕"/>
-              </a:rPr>
-              <a:t>E2E 리드타임 105.9h 중 순수 대기가 95.8h.</a:t>
+              <a:t>이다. E2E 리드타임 105.9h 중 순수 대기가 95.8h.</a:t>
             </a:r>
           </a:p>
         </p:txBody>
@@ -22481,8 +22460,8 @@
         </p:nvSpPr>
         <p:spPr>
           <a:xfrm>
-            <a:off x="502920" y="2842006"/>
-            <a:ext cx="3606698" cy="3357626"/>
+            <a:off x="502920" y="2593086"/>
+            <a:ext cx="3606698" cy="3606546"/>
           </a:xfrm>
           <a:prstGeom prst="rect">
             <a:avLst/>
@@ -22527,7 +22506,7 @@
         </p:nvSpPr>
         <p:spPr>
           <a:xfrm>
-            <a:off x="704088" y="3043174"/>
+            <a:off x="704088" y="2794254"/>
             <a:ext cx="3204362" cy="158750"/>
           </a:xfrm>
           <a:prstGeom prst="rect">
@@ -22572,7 +22551,7 @@
         </p:nvSpPr>
         <p:spPr>
           <a:xfrm>
-            <a:off x="704088" y="3284220"/>
+            <a:off x="704088" y="3035300"/>
             <a:ext cx="3204362" cy="626110"/>
           </a:xfrm>
           <a:prstGeom prst="rect">
@@ -22628,7 +22607,7 @@
         </p:nvSpPr>
         <p:spPr>
           <a:xfrm>
-            <a:off x="704088" y="3992626"/>
+            <a:off x="704088" y="3743706"/>
             <a:ext cx="3204362" cy="213360"/>
           </a:xfrm>
           <a:prstGeom prst="rect">
@@ -22673,7 +22652,7 @@
         </p:nvSpPr>
         <p:spPr>
           <a:xfrm>
-            <a:off x="704088" y="4407154"/>
+            <a:off x="704088" y="4158234"/>
             <a:ext cx="3204362" cy="1143000"/>
           </a:xfrm>
           <a:prstGeom prst="rect">
@@ -22861,8 +22840,8 @@
         </p:nvSpPr>
         <p:spPr>
           <a:xfrm>
-            <a:off x="4292498" y="2842006"/>
-            <a:ext cx="3606698" cy="3357626"/>
+            <a:off x="4292498" y="2593086"/>
+            <a:ext cx="3606698" cy="3606546"/>
           </a:xfrm>
           <a:prstGeom prst="rect">
             <a:avLst/>
@@ -22907,7 +22886,7 @@
         </p:nvSpPr>
         <p:spPr>
           <a:xfrm>
-            <a:off x="4493666" y="3043174"/>
+            <a:off x="4493666" y="2794254"/>
             <a:ext cx="3204362" cy="158750"/>
           </a:xfrm>
           <a:prstGeom prst="rect">
@@ -22952,7 +22931,7 @@
         </p:nvSpPr>
         <p:spPr>
           <a:xfrm>
-            <a:off x="4493666" y="3284220"/>
+            <a:off x="4493666" y="3035300"/>
             <a:ext cx="3204362" cy="626110"/>
           </a:xfrm>
           <a:prstGeom prst="rect">
@@ -23008,7 +22987,7 @@
         </p:nvSpPr>
         <p:spPr>
           <a:xfrm>
-            <a:off x="4493666" y="3992626"/>
+            <a:off x="4493666" y="3743706"/>
             <a:ext cx="3204362" cy="213360"/>
           </a:xfrm>
           <a:prstGeom prst="rect">
@@ -23053,7 +23032,7 @@
         </p:nvSpPr>
         <p:spPr>
           <a:xfrm>
-            <a:off x="4493666" y="4407154"/>
+            <a:off x="4493666" y="4158234"/>
             <a:ext cx="3204362" cy="1143000"/>
           </a:xfrm>
           <a:prstGeom prst="rect">
@@ -23241,8 +23220,8 @@
         </p:nvSpPr>
         <p:spPr>
           <a:xfrm>
-            <a:off x="8082076" y="2842006"/>
-            <a:ext cx="3606698" cy="3357626"/>
+            <a:off x="8082076" y="2593086"/>
+            <a:ext cx="3606698" cy="3606546"/>
           </a:xfrm>
           <a:prstGeom prst="rect">
             <a:avLst/>
@@ -23287,7 +23266,7 @@
         </p:nvSpPr>
         <p:spPr>
           <a:xfrm>
-            <a:off x="8283244" y="3043174"/>
+            <a:off x="8283244" y="2794254"/>
             <a:ext cx="3204362" cy="158750"/>
           </a:xfrm>
           <a:prstGeom prst="rect">
@@ -23332,7 +23311,7 @@
         </p:nvSpPr>
         <p:spPr>
           <a:xfrm>
-            <a:off x="8283244" y="3284220"/>
+            <a:off x="8283244" y="3035300"/>
             <a:ext cx="3204362" cy="626110"/>
           </a:xfrm>
           <a:prstGeom prst="rect">
@@ -23399,7 +23378,7 @@
         </p:nvSpPr>
         <p:spPr>
           <a:xfrm>
-            <a:off x="8283244" y="3992626"/>
+            <a:off x="8283244" y="3743706"/>
             <a:ext cx="3204362" cy="213360"/>
           </a:xfrm>
           <a:prstGeom prst="rect">
@@ -23444,7 +23423,7 @@
         </p:nvSpPr>
         <p:spPr>
           <a:xfrm>
-            <a:off x="8283244" y="4407154"/>
+            <a:off x="8283244" y="4158234"/>
             <a:ext cx="3204362" cy="1143000"/>
           </a:xfrm>
           <a:prstGeom prst="rect">

</xml_diff>

<commit_message>
feat(deck): slide 5 CASE 5 basis reads '앵커타임 기준 역산'
Co-Authored-By: Claude Sonnet 5.5 <noreply@anthropic.com>
</commit_message>
<xml_diff>
--- a/outputs/pptx/puzzledata_repair_report.pptx
+++ b/outputs/pptx/puzzledata_repair_report.pptx
@@ -125,21 +125,21 @@
   <p:extLst>
     <p:ext uri="{521415D9-36F7-43E2-AB2F-B90AF26B5E84}">
       <p14:sectionLst xmlns:p14="http://schemas.microsoft.com/office/powerpoint/2010/main">
-        <p14:section name="Part 00 · 인트로" id="{7EF64CBD-D6AF-4B4E-9BFE-BF66FF792736}">
+        <p14:section name="Part 00 · 인트로" id="{B2148ABA-FA65-45A9-A9FC-3EBDB18698A2}">
           <p14:sldIdLst>
             <p14:sldId id="256"/>
             <p14:sldId id="257"/>
             <p14:sldId id="258"/>
           </p14:sldIdLst>
         </p14:section>
-        <p14:section name="Part 01 · 데이터 진단" id="{3CDBDE1A-0AE7-4A10-B55D-409867F22D14}">
+        <p14:section name="Part 01 · 데이터 진단" id="{AEED452C-01D3-4AAC-8D5C-484F7439B8FA}">
           <p14:sldIdLst>
             <p14:sldId id="259"/>
             <p14:sldId id="260"/>
             <p14:sldId id="261"/>
           </p14:sldIdLst>
         </p14:section>
-        <p14:section name="Part 02 · 병목 규명" id="{1AA19605-7822-4062-9A60-1CA204586D97}">
+        <p14:section name="Part 02 · 병목 규명" id="{07CDFE53-82B9-49A6-8BFC-1A2E20EBEAFE}">
           <p14:sldIdLst>
             <p14:sldId id="262"/>
             <p14:sldId id="263"/>
@@ -152,14 +152,14 @@
             <p14:sldId id="270"/>
           </p14:sldIdLst>
         </p14:section>
-        <p14:section name="Part 03 · 개선 전략" id="{4F956ED2-60F6-4865-A897-978D9BC57158}">
+        <p14:section name="Part 03 · 개선 전략" id="{7B4C3E46-0715-4B73-A18F-BFB26E925BA1}">
           <p14:sldIdLst>
             <p14:sldId id="271"/>
             <p14:sldId id="272"/>
             <p14:sldId id="273"/>
           </p14:sldIdLst>
         </p14:section>
-        <p14:section name="Part 04 · Q&amp;A" id="{8EB0BE7C-39C2-4BDE-B2FC-8B4D0EE07FBA}">
+        <p14:section name="Part 04 · Q&amp;A" id="{EB7D1B14-EAF6-4B9B-8B47-CCB54D949519}">
           <p14:sldIdLst>
             <p14:sldId id="274"/>
           </p14:sldIdLst>
@@ -1551,7 +1551,7 @@
           <a:lstStyle/>
           <a:p>
             <a:r>
-              <a:t>복원 과정에서 단 한 행도 버리지 않았습니다. 시작·완료 담당자의 일치율 100%와 태스크 고유 속성을 근거로 CASE 1~3을 복원했고, 날짜는 시각이 정상인 859행에 순서 제약을 걸어 복원했습니다. 시각은 정상 접수 표본 754케이스의 중앙값 4.0분을 앵커로 역산했습니다. 그 결과 시간 역전이 0건인 데이터셋을 확보했습니다. [예상 질문] 표본 수가 751건이 아닌가? → 현재 노트북(Cell 63) 재실행 기준 754건(기준 케이스 755건)입니다.</a:t>
+              <a:t>복원 과정에서 단 한 행도 버리지 않았습니다. 시작·완료 담당자의 일치율 100%와 태스크 고유 속성을 근거로 CASE 1~3을 복원했고, 날짜는 시각이 정상인 859행에 순서 제약을 걸어 복원했습니다. 시각은 정상 접수 표본 754케이스의 중앙값 4.0분을 앵커타임 기준으로 역산했습니다. 그 결과 시간 역전이 0건인 데이터셋을 확보했습니다. [예상 질문] 표본 수가 751건이 아닌가? → 현재 노트북(Cell 63) 재실행 기준 754건(기준 케이스 755건)입니다.</a:t>
             </a:r>
           </a:p>
         </p:txBody>
@@ -26756,7 +26756,7 @@
                 <a:ea typeface="맑은 고딕"/>
                 <a:cs typeface="맑은 고딕"/>
               </a:rPr>
-              <a:t>4.0분을 앵커로 역산</a:t>
+              <a:t>4.0분 · 앵커타임 기준 역산</a:t>
             </a:r>
           </a:p>
         </p:txBody>

</xml_diff>

<commit_message>
feat(deck): slide 7 process map redrawn as a deck-only version (deck fonts/colors, 9.5pt+ text, Korean labels); slide 13 chart height fitted to regenerated figure
Co-Authored-By: Claude Sonnet 5.5 <noreply@anthropic.com>
</commit_message>
<xml_diff>
--- a/outputs/pptx/puzzledata_repair_report.pptx
+++ b/outputs/pptx/puzzledata_repair_report.pptx
@@ -125,21 +125,21 @@
   <p:extLst>
     <p:ext uri="{521415D9-36F7-43E2-AB2F-B90AF26B5E84}">
       <p14:sectionLst xmlns:p14="http://schemas.microsoft.com/office/powerpoint/2010/main">
-        <p14:section name="Part 00 · 인트로" id="{B2148ABA-FA65-45A9-A9FC-3EBDB18698A2}">
+        <p14:section name="Part 00 · 인트로" id="{1542BB31-012A-45E1-86B8-13B7E501533E}">
           <p14:sldIdLst>
             <p14:sldId id="256"/>
             <p14:sldId id="257"/>
             <p14:sldId id="258"/>
           </p14:sldIdLst>
         </p14:section>
-        <p14:section name="Part 01 · 데이터 진단" id="{AEED452C-01D3-4AAC-8D5C-484F7439B8FA}">
+        <p14:section name="Part 01 · 데이터 진단" id="{AE669E35-6B41-4B2E-A7D8-62C361CEF257}">
           <p14:sldIdLst>
             <p14:sldId id="259"/>
             <p14:sldId id="260"/>
             <p14:sldId id="261"/>
           </p14:sldIdLst>
         </p14:section>
-        <p14:section name="Part 02 · 병목 규명" id="{07CDFE53-82B9-49A6-8BFC-1A2E20EBEAFE}">
+        <p14:section name="Part 02 · 병목 규명" id="{9D0ABAD8-284A-493D-BE0F-9DBA2342BA15}">
           <p14:sldIdLst>
             <p14:sldId id="262"/>
             <p14:sldId id="263"/>
@@ -152,14 +152,14 @@
             <p14:sldId id="270"/>
           </p14:sldIdLst>
         </p14:section>
-        <p14:section name="Part 03 · 개선 전략" id="{7B4C3E46-0715-4B73-A18F-BFB26E925BA1}">
+        <p14:section name="Part 03 · 개선 전략" id="{FBCEFD00-7F71-4482-84EC-58BB59BE7EE6}">
           <p14:sldIdLst>
             <p14:sldId id="271"/>
             <p14:sldId id="272"/>
             <p14:sldId id="273"/>
           </p14:sldIdLst>
         </p14:section>
-        <p14:section name="Part 04 · Q&amp;A" id="{EB7D1B14-EAF6-4B9B-8B47-CCB54D949519}">
+        <p14:section name="Part 04 · Q&amp;A" id="{7A98EB00-5303-41AB-8E03-24F144511369}">
           <p14:sldIdLst>
             <p14:sldId id="274"/>
           </p14:sldIdLst>
@@ -5943,8 +5943,8 @@
         </p:blipFill>
         <p:spPr>
           <a:xfrm>
-            <a:off x="703646" y="1896110"/>
-            <a:ext cx="4856346" cy="4142232"/>
+            <a:off x="843092" y="1896110"/>
+            <a:ext cx="4577454" cy="4142232"/>
           </a:xfrm>
           <a:prstGeom prst="rect">
             <a:avLst/>
@@ -10056,7 +10056,7 @@
         <p:spPr>
           <a:xfrm>
             <a:off x="502920" y="1554480"/>
-            <a:ext cx="7818120" cy="3738077"/>
+            <a:ext cx="7818120" cy="3898646"/>
           </a:xfrm>
           <a:prstGeom prst="rect">
             <a:avLst/>
@@ -10154,8 +10154,8 @@
         </p:blipFill>
         <p:spPr>
           <a:xfrm>
-            <a:off x="630936" y="1896110"/>
-            <a:ext cx="7562088" cy="3268431"/>
+            <a:off x="859591" y="1896110"/>
+            <a:ext cx="7104776" cy="3429000"/>
           </a:xfrm>
           <a:prstGeom prst="rect">
             <a:avLst/>
@@ -10171,7 +10171,7 @@
         <p:spPr>
           <a:xfrm>
             <a:off x="8503920" y="1554480"/>
-            <a:ext cx="3184855" cy="1172873"/>
+            <a:ext cx="3184855" cy="1226396"/>
           </a:xfrm>
           <a:prstGeom prst="rect">
             <a:avLst/>
@@ -10362,8 +10362,8 @@
         </p:nvSpPr>
         <p:spPr>
           <a:xfrm>
-            <a:off x="8503920" y="2837081"/>
-            <a:ext cx="3184855" cy="1172873"/>
+            <a:off x="8503920" y="2890604"/>
+            <a:ext cx="3184855" cy="1226396"/>
           </a:xfrm>
           <a:prstGeom prst="rect">
             <a:avLst/>
@@ -10408,7 +10408,7 @@
         </p:nvSpPr>
         <p:spPr>
           <a:xfrm>
-            <a:off x="8686800" y="3019961"/>
+            <a:off x="8686800" y="3073484"/>
             <a:ext cx="2819095" cy="158750"/>
           </a:xfrm>
           <a:prstGeom prst="rect">
@@ -10453,7 +10453,7 @@
         </p:nvSpPr>
         <p:spPr>
           <a:xfrm>
-            <a:off x="8686800" y="3233575"/>
+            <a:off x="8686800" y="3287098"/>
             <a:ext cx="2819095" cy="341630"/>
           </a:xfrm>
           <a:prstGeom prst="rect">
@@ -10509,7 +10509,7 @@
         </p:nvSpPr>
         <p:spPr>
           <a:xfrm>
-            <a:off x="8686800" y="3630069"/>
+            <a:off x="8686800" y="3683592"/>
             <a:ext cx="2819095" cy="195580"/>
           </a:xfrm>
           <a:prstGeom prst="rect">
@@ -10554,8 +10554,8 @@
         </p:nvSpPr>
         <p:spPr>
           <a:xfrm>
-            <a:off x="8503920" y="4119683"/>
-            <a:ext cx="3184855" cy="1172873"/>
+            <a:off x="8503920" y="4226729"/>
+            <a:ext cx="3184855" cy="1226396"/>
           </a:xfrm>
           <a:prstGeom prst="rect">
             <a:avLst/>
@@ -10600,7 +10600,7 @@
         </p:nvSpPr>
         <p:spPr>
           <a:xfrm>
-            <a:off x="8686800" y="4302563"/>
+            <a:off x="8686800" y="4409609"/>
             <a:ext cx="2819095" cy="158750"/>
           </a:xfrm>
           <a:prstGeom prst="rect">
@@ -10645,7 +10645,7 @@
         </p:nvSpPr>
         <p:spPr>
           <a:xfrm>
-            <a:off x="8686800" y="4516177"/>
+            <a:off x="8686800" y="4623223"/>
             <a:ext cx="2819095" cy="341630"/>
           </a:xfrm>
           <a:prstGeom prst="rect">
@@ -10701,7 +10701,7 @@
         </p:nvSpPr>
         <p:spPr>
           <a:xfrm>
-            <a:off x="8686800" y="4912671"/>
+            <a:off x="8686800" y="5019717"/>
             <a:ext cx="2819095" cy="195580"/>
           </a:xfrm>
           <a:prstGeom prst="rect">
@@ -10746,7 +10746,7 @@
         </p:nvSpPr>
         <p:spPr>
           <a:xfrm>
-            <a:off x="502920" y="5429717"/>
+            <a:off x="502920" y="5590286"/>
             <a:ext cx="11185855" cy="596900"/>
           </a:xfrm>
           <a:prstGeom prst="rect">
@@ -10792,7 +10792,7 @@
         </p:nvSpPr>
         <p:spPr>
           <a:xfrm>
-            <a:off x="685800" y="5612597"/>
+            <a:off x="685800" y="5773166"/>
             <a:ext cx="10820095" cy="231140"/>
           </a:xfrm>
           <a:prstGeom prst="rect">
@@ -29763,7 +29763,7 @@
                 <a:ea typeface="맑은 고딕"/>
                 <a:cs typeface="Consolas"/>
               </a:rPr>
-              <a:t>※ 맵의 '+5.11h'는 채널 통제 OLS 계수, S09의 +6.7h는 단순 평균 차이 · 노드 EV = 이벤트 수</a:t>
+              <a:t>※ 맵의 '+5.11h'는 채널 통제 OLS 계수, S09의 +6.7h는 단순 평균 차이 · 노드 수치는 수리 시작 이벤트 기준</a:t>
             </a:r>
           </a:p>
         </p:txBody>
@@ -29822,7 +29822,7 @@
         <p:spPr>
           <a:xfrm>
             <a:off x="502920" y="1527048"/>
-            <a:ext cx="11185855" cy="3395726"/>
+            <a:ext cx="11185855" cy="3112513"/>
           </a:xfrm>
           <a:prstGeom prst="rect">
             <a:avLst/>
@@ -29906,7 +29906,7 @@
       </p:sp>
       <p:pic>
         <p:nvPicPr>
-          <p:cNvPr id="10" name="pic:map" descr="repair_process_map.png"/>
+          <p:cNvPr id="10" name="pic:map" descr="process_map_deck.png"/>
           <p:cNvPicPr>
             <a:picLocks noChangeAspect="1"/>
           </p:cNvPicPr>
@@ -29920,8 +29920,8 @@
         </p:blipFill>
         <p:spPr>
           <a:xfrm>
-            <a:off x="1315652" y="1868678"/>
-            <a:ext cx="9560390" cy="2926080"/>
+            <a:off x="630936" y="1868678"/>
+            <a:ext cx="10929823" cy="2642867"/>
           </a:xfrm>
           <a:prstGeom prst="rect">
             <a:avLst/>
@@ -29936,7 +29936,7 @@
         </p:nvSpPr>
         <p:spPr>
           <a:xfrm>
-            <a:off x="502920" y="5059934"/>
+            <a:off x="502920" y="4776721"/>
             <a:ext cx="2885358" cy="1230884"/>
           </a:xfrm>
           <a:prstGeom prst="rect">
@@ -29982,7 +29982,7 @@
         </p:nvSpPr>
         <p:spPr>
           <a:xfrm>
-            <a:off x="685800" y="5242814"/>
+            <a:off x="685800" y="4959601"/>
             <a:ext cx="2519598" cy="158750"/>
           </a:xfrm>
           <a:prstGeom prst="rect">
@@ -30027,7 +30027,7 @@
         </p:nvSpPr>
         <p:spPr>
           <a:xfrm>
-            <a:off x="685800" y="5456428"/>
+            <a:off x="685800" y="5173215"/>
             <a:ext cx="2519598" cy="408940"/>
           </a:xfrm>
           <a:prstGeom prst="rect">
@@ -30116,7 +30116,7 @@
         </p:nvSpPr>
         <p:spPr>
           <a:xfrm>
-            <a:off x="3571158" y="5059934"/>
+            <a:off x="3571158" y="4776721"/>
             <a:ext cx="3967368" cy="1230884"/>
           </a:xfrm>
           <a:prstGeom prst="rect">
@@ -30162,7 +30162,7 @@
         </p:nvSpPr>
         <p:spPr>
           <a:xfrm>
-            <a:off x="3754038" y="5242814"/>
+            <a:off x="3754038" y="4959601"/>
             <a:ext cx="3601608" cy="158750"/>
           </a:xfrm>
           <a:prstGeom prst="rect">
@@ -30207,7 +30207,7 @@
         </p:nvSpPr>
         <p:spPr>
           <a:xfrm>
-            <a:off x="3754038" y="5456428"/>
+            <a:off x="3754038" y="5173215"/>
             <a:ext cx="3601608" cy="613410"/>
           </a:xfrm>
           <a:prstGeom prst="rect">
@@ -30318,7 +30318,7 @@
         </p:nvSpPr>
         <p:spPr>
           <a:xfrm>
-            <a:off x="7721406" y="5059934"/>
+            <a:off x="7721406" y="4776721"/>
             <a:ext cx="3967368" cy="1230884"/>
           </a:xfrm>
           <a:prstGeom prst="rect">
@@ -30364,7 +30364,7 @@
         </p:nvSpPr>
         <p:spPr>
           <a:xfrm>
-            <a:off x="7904286" y="5242814"/>
+            <a:off x="7904286" y="4959601"/>
             <a:ext cx="3601608" cy="158750"/>
           </a:xfrm>
           <a:prstGeom prst="rect">
@@ -30409,7 +30409,7 @@
         </p:nvSpPr>
         <p:spPr>
           <a:xfrm>
-            <a:off x="7904286" y="5456428"/>
+            <a:off x="7904286" y="5173215"/>
             <a:ext cx="3601608" cy="651510"/>
           </a:xfrm>
           <a:prstGeom prst="rect">

</xml_diff>

<commit_message>
feat(deck): slide 7 process map reverted to the original design with only font/size tuned for the slide area (deck-only copy)
Co-Authored-By: Claude Sonnet 5.5 <noreply@anthropic.com>
</commit_message>
<xml_diff>
--- a/outputs/pptx/puzzledata_repair_report.pptx
+++ b/outputs/pptx/puzzledata_repair_report.pptx
@@ -125,21 +125,21 @@
   <p:extLst>
     <p:ext uri="{521415D9-36F7-43E2-AB2F-B90AF26B5E84}">
       <p14:sectionLst xmlns:p14="http://schemas.microsoft.com/office/powerpoint/2010/main">
-        <p14:section name="Part 00 · 인트로" id="{1542BB31-012A-45E1-86B8-13B7E501533E}">
+        <p14:section name="Part 00 · 인트로" id="{A61B80BD-90E6-433F-9D43-43FE56B17982}">
           <p14:sldIdLst>
             <p14:sldId id="256"/>
             <p14:sldId id="257"/>
             <p14:sldId id="258"/>
           </p14:sldIdLst>
         </p14:section>
-        <p14:section name="Part 01 · 데이터 진단" id="{AE669E35-6B41-4B2E-A7D8-62C361CEF257}">
+        <p14:section name="Part 01 · 데이터 진단" id="{8230E63B-9ED8-4FE4-B64D-B4903261E8A6}">
           <p14:sldIdLst>
             <p14:sldId id="259"/>
             <p14:sldId id="260"/>
             <p14:sldId id="261"/>
           </p14:sldIdLst>
         </p14:section>
-        <p14:section name="Part 02 · 병목 규명" id="{9D0ABAD8-284A-493D-BE0F-9DBA2342BA15}">
+        <p14:section name="Part 02 · 병목 규명" id="{823FB230-6B2F-4492-9723-EB4EEDCF6F5E}">
           <p14:sldIdLst>
             <p14:sldId id="262"/>
             <p14:sldId id="263"/>
@@ -152,14 +152,14 @@
             <p14:sldId id="270"/>
           </p14:sldIdLst>
         </p14:section>
-        <p14:section name="Part 03 · 개선 전략" id="{FBCEFD00-7F71-4482-84EC-58BB59BE7EE6}">
+        <p14:section name="Part 03 · 개선 전략" id="{C069E015-9E27-493C-859A-F678255D398C}">
           <p14:sldIdLst>
             <p14:sldId id="271"/>
             <p14:sldId id="272"/>
             <p14:sldId id="273"/>
           </p14:sldIdLst>
         </p14:section>
-        <p14:section name="Part 04 · Q&amp;A" id="{7A98EB00-5303-41AB-8E03-24F144511369}">
+        <p14:section name="Part 04 · Q&amp;A" id="{7C197D7F-E718-4B45-B07A-9830F6ED98E6}">
           <p14:sldIdLst>
             <p14:sldId id="274"/>
           </p14:sldIdLst>
@@ -29763,7 +29763,7 @@
                 <a:ea typeface="맑은 고딕"/>
                 <a:cs typeface="Consolas"/>
               </a:rPr>
-              <a:t>※ 맵의 '+5.11h'는 채널 통제 OLS 계수, S09의 +6.7h는 단순 평균 차이 · 노드 수치는 수리 시작 이벤트 기준</a:t>
+              <a:t>※ 맵의 '+5.11h'는 채널 통제 OLS 계수, S09의 +6.7h는 단순 평균 차이 · 노드 EV = 이벤트 수</a:t>
             </a:r>
           </a:p>
         </p:txBody>
@@ -29822,7 +29822,7 @@
         <p:spPr>
           <a:xfrm>
             <a:off x="502920" y="1527048"/>
-            <a:ext cx="11185855" cy="3112513"/>
+            <a:ext cx="11185855" cy="3395726"/>
           </a:xfrm>
           <a:prstGeom prst="rect">
             <a:avLst/>
@@ -29920,8 +29920,8 @@
         </p:blipFill>
         <p:spPr>
           <a:xfrm>
-            <a:off x="630936" y="1868678"/>
-            <a:ext cx="10929823" cy="2642867"/>
+            <a:off x="964266" y="1868678"/>
+            <a:ext cx="10263163" cy="2926080"/>
           </a:xfrm>
           <a:prstGeom prst="rect">
             <a:avLst/>
@@ -29936,7 +29936,7 @@
         </p:nvSpPr>
         <p:spPr>
           <a:xfrm>
-            <a:off x="502920" y="4776721"/>
+            <a:off x="502920" y="5059934"/>
             <a:ext cx="2885358" cy="1230884"/>
           </a:xfrm>
           <a:prstGeom prst="rect">
@@ -29982,7 +29982,7 @@
         </p:nvSpPr>
         <p:spPr>
           <a:xfrm>
-            <a:off x="685800" y="4959601"/>
+            <a:off x="685800" y="5242814"/>
             <a:ext cx="2519598" cy="158750"/>
           </a:xfrm>
           <a:prstGeom prst="rect">
@@ -30027,7 +30027,7 @@
         </p:nvSpPr>
         <p:spPr>
           <a:xfrm>
-            <a:off x="685800" y="5173215"/>
+            <a:off x="685800" y="5456428"/>
             <a:ext cx="2519598" cy="408940"/>
           </a:xfrm>
           <a:prstGeom prst="rect">
@@ -30116,7 +30116,7 @@
         </p:nvSpPr>
         <p:spPr>
           <a:xfrm>
-            <a:off x="3571158" y="4776721"/>
+            <a:off x="3571158" y="5059934"/>
             <a:ext cx="3967368" cy="1230884"/>
           </a:xfrm>
           <a:prstGeom prst="rect">
@@ -30162,7 +30162,7 @@
         </p:nvSpPr>
         <p:spPr>
           <a:xfrm>
-            <a:off x="3754038" y="4959601"/>
+            <a:off x="3754038" y="5242814"/>
             <a:ext cx="3601608" cy="158750"/>
           </a:xfrm>
           <a:prstGeom prst="rect">
@@ -30207,7 +30207,7 @@
         </p:nvSpPr>
         <p:spPr>
           <a:xfrm>
-            <a:off x="3754038" y="5173215"/>
+            <a:off x="3754038" y="5456428"/>
             <a:ext cx="3601608" cy="613410"/>
           </a:xfrm>
           <a:prstGeom prst="rect">
@@ -30318,7 +30318,7 @@
         </p:nvSpPr>
         <p:spPr>
           <a:xfrm>
-            <a:off x="7721406" y="4776721"/>
+            <a:off x="7721406" y="5059934"/>
             <a:ext cx="3967368" cy="1230884"/>
           </a:xfrm>
           <a:prstGeom prst="rect">
@@ -30364,7 +30364,7 @@
         </p:nvSpPr>
         <p:spPr>
           <a:xfrm>
-            <a:off x="7904286" y="4959601"/>
+            <a:off x="7904286" y="5242814"/>
             <a:ext cx="3601608" cy="158750"/>
           </a:xfrm>
           <a:prstGeom prst="rect">
@@ -30409,7 +30409,7 @@
         </p:nvSpPr>
         <p:spPr>
           <a:xfrm>
-            <a:off x="7904286" y="5173215"/>
+            <a:off x="7904286" y="5456428"/>
             <a:ext cx="3601608" cy="651510"/>
           </a:xfrm>
           <a:prstGeom prst="rect">

</xml_diff>

<commit_message>
chore(submission): refresh PPTX (fonts embedded) / PDF / zip with the final 19-slide deck; add embed_fonts.ps1
Co-Authored-By: Claude Sonnet 5.5 <noreply@anthropic.com>
</commit_message>
<xml_diff>
--- a/outputs/pptx/puzzledata_repair_report.pptx
+++ b/outputs/pptx/puzzledata_repair_report.pptx
@@ -1,32 +1,49 @@
 
 <file path=ppt/presentation.xml><?xml version="1.0" encoding="utf-8"?>
-<p:presentation xmlns:a="http://schemas.openxmlformats.org/drawingml/2006/main" xmlns:r="http://schemas.openxmlformats.org/officeDocument/2006/relationships" xmlns:p="http://schemas.openxmlformats.org/presentationml/2006/main" saveSubsetFonts="1" autoCompressPictures="0">
+<p:presentation xmlns:a="http://schemas.openxmlformats.org/drawingml/2006/main" xmlns:r="http://schemas.openxmlformats.org/officeDocument/2006/relationships" xmlns:p="http://schemas.openxmlformats.org/presentationml/2006/main" embedTrueTypeFonts="1" saveSubsetFonts="1" autoCompressPictures="0">
   <p:sldMasterIdLst>
     <p:sldMasterId id="2147483648" r:id="rId1"/>
   </p:sldMasterIdLst>
+  <p:notesMasterIdLst>
+    <p:notesMasterId r:id="rId21"/>
+  </p:notesMasterIdLst>
   <p:sldIdLst>
-    <p:sldId id="256" r:id="rId7"/>
-    <p:sldId id="257" r:id="rId9"/>
-    <p:sldId id="258" r:id="rId10"/>
-    <p:sldId id="259" r:id="rId11"/>
-    <p:sldId id="260" r:id="rId12"/>
-    <p:sldId id="261" r:id="rId13"/>
-    <p:sldId id="262" r:id="rId14"/>
-    <p:sldId id="263" r:id="rId15"/>
-    <p:sldId id="264" r:id="rId16"/>
-    <p:sldId id="265" r:id="rId17"/>
-    <p:sldId id="266" r:id="rId18"/>
-    <p:sldId id="267" r:id="rId19"/>
-    <p:sldId id="268" r:id="rId20"/>
-    <p:sldId id="269" r:id="rId21"/>
-    <p:sldId id="270" r:id="rId22"/>
-    <p:sldId id="271" r:id="rId23"/>
-    <p:sldId id="272" r:id="rId24"/>
-    <p:sldId id="273" r:id="rId25"/>
-    <p:sldId id="274" r:id="rId26"/>
+    <p:sldId id="256" r:id="rId2"/>
+    <p:sldId id="257" r:id="rId3"/>
+    <p:sldId id="258" r:id="rId4"/>
+    <p:sldId id="259" r:id="rId5"/>
+    <p:sldId id="260" r:id="rId6"/>
+    <p:sldId id="261" r:id="rId7"/>
+    <p:sldId id="262" r:id="rId8"/>
+    <p:sldId id="263" r:id="rId9"/>
+    <p:sldId id="264" r:id="rId10"/>
+    <p:sldId id="265" r:id="rId11"/>
+    <p:sldId id="266" r:id="rId12"/>
+    <p:sldId id="267" r:id="rId13"/>
+    <p:sldId id="268" r:id="rId14"/>
+    <p:sldId id="269" r:id="rId15"/>
+    <p:sldId id="270" r:id="rId16"/>
+    <p:sldId id="271" r:id="rId17"/>
+    <p:sldId id="272" r:id="rId18"/>
+    <p:sldId id="273" r:id="rId19"/>
+    <p:sldId id="274" r:id="rId20"/>
   </p:sldIdLst>
-  <p:sldSz cx="12191695" cy="6858000" type="screen4x3"/>
+  <p:sldSz cx="12192000" cy="6858000"/>
   <p:notesSz cx="6858000" cy="9144000"/>
+  <p:embeddedFontLst>
+    <p:embeddedFont>
+      <p:font typeface="맑은 고딕" panose="020B0503020000020004" pitchFamily="50" charset="-127"/>
+      <p:regular r:id="rId22"/>
+      <p:bold r:id="rId23"/>
+    </p:embeddedFont>
+    <p:embeddedFont>
+      <p:font typeface="Consolas" panose="020B0609020204030204" pitchFamily="49" charset="0"/>
+      <p:regular r:id="rId24"/>
+      <p:bold r:id="rId25"/>
+      <p:italic r:id="rId26"/>
+      <p:boldItalic r:id="rId27"/>
+    </p:embeddedFont>
+  </p:embeddedFontLst>
   <p:defaultTextStyle>
     <a:defPPr>
       <a:defRPr lang="en-US"/>
@@ -166,12 +183,26 @@
         </p14:section>
       </p14:sectionLst>
     </p:ext>
+    <p:ext uri="{EFAFB233-063F-42B5-8137-9DF3F51BA10A}">
+      <p15:sldGuideLst xmlns:p15="http://schemas.microsoft.com/office/powerpoint/2012/main">
+        <p15:guide id="1" orient="horz" pos="2160">
+          <p15:clr>
+            <a:srgbClr val="A4A3A4"/>
+          </p15:clr>
+        </p15:guide>
+        <p15:guide id="2" pos="2880">
+          <p15:clr>
+            <a:srgbClr val="A4A3A4"/>
+          </p15:clr>
+        </p15:guide>
+      </p15:sldGuideLst>
+    </p:ext>
   </p:extLst>
 </p:presentation>
 </file>
 
 <file path=ppt/notesMasters/notesMaster1.xml><?xml version="1.0" encoding="utf-8"?>
-<p:notesMaster xmlns:a="http://schemas.openxmlformats.org/drawingml/2006/main" xmlns:p="http://schemas.openxmlformats.org/presentationml/2006/main" xmlns:r="http://schemas.openxmlformats.org/officeDocument/2006/relationships">
+<p:notesMaster xmlns:a="http://schemas.openxmlformats.org/drawingml/2006/main" xmlns:r="http://schemas.openxmlformats.org/officeDocument/2006/relationships" xmlns:p="http://schemas.openxmlformats.org/presentationml/2006/main">
   <p:cSld>
     <p:bg>
       <p:bgRef idx="1001">
@@ -192,241 +223,16 @@
           <a:chExt cx="0" cy="0"/>
         </a:xfrm>
       </p:grpSpPr>
-      <p:sp>
-        <p:nvSpPr>
-          <p:cNvPr id="2" name="Header Placeholder 1"/>
-          <p:cNvSpPr>
-            <a:spLocks noGrp="1"/>
-          </p:cNvSpPr>
-          <p:nvPr>
-            <p:ph type="hdr" sz="quarter"/>
-          </p:nvPr>
-        </p:nvSpPr>
-        <p:spPr>
-          <a:xfrm>
-            <a:off x="0" y="0"/>
-            <a:ext cx="2971800" cy="457200"/>
-          </a:xfrm>
-          <a:prstGeom prst="rect">
-            <a:avLst/>
-          </a:prstGeom>
-        </p:spPr>
-        <p:txBody>
-          <a:bodyPr vert="horz" lIns="91440" tIns="45720" rIns="91440" bIns="45720" rtlCol="0"/>
-          <a:lstStyle>
-            <a:lvl1pPr algn="l">
-              <a:defRPr sz="1200"/>
-            </a:lvl1pPr>
-          </a:lstStyle>
-          <a:p>
-            <a:endParaRPr lang="en-US"/>
-          </a:p>
-        </p:txBody>
-      </p:sp>
-      <p:sp>
-        <p:nvSpPr>
-          <p:cNvPr id="3" name="Date Placeholder 2"/>
-          <p:cNvSpPr>
-            <a:spLocks noGrp="1"/>
-          </p:cNvSpPr>
-          <p:nvPr>
-            <p:ph type="dt" idx="1"/>
-          </p:nvPr>
-        </p:nvSpPr>
-        <p:spPr>
-          <a:xfrm>
-            <a:off x="3884613" y="0"/>
-            <a:ext cx="2971800" cy="457200"/>
-          </a:xfrm>
-          <a:prstGeom prst="rect">
-            <a:avLst/>
-          </a:prstGeom>
-        </p:spPr>
-        <p:txBody>
-          <a:bodyPr vert="horz" lIns="91440" tIns="45720" rIns="91440" bIns="45720" rtlCol="0"/>
-          <a:lstStyle>
-            <a:lvl1pPr algn="r">
-              <a:defRPr sz="1200"/>
-            </a:lvl1pPr>
-          </a:lstStyle>
-          <a:p>
-            <a:fld id="{0F89C1C7-3DCD-1040-A9CF-14679D8B5DDD}" type="datetimeFigureOut">
-              <a:rPr lang="en-US" smtClean="0"/>
-              <a:t>10/17/16</a:t>
-            </a:fld>
-            <a:endParaRPr lang="en-US"/>
-          </a:p>
-        </p:txBody>
-      </p:sp>
-      <p:sp>
-        <p:nvSpPr>
-          <p:cNvPr id="4" name="Slide Image Placeholder 3"/>
-          <p:cNvSpPr>
-            <a:spLocks noGrp="1" noRot="1" noChangeAspect="1"/>
-          </p:cNvSpPr>
-          <p:nvPr>
-            <p:ph type="sldImg" idx="2"/>
-          </p:nvPr>
-        </p:nvSpPr>
-        <p:spPr>
-          <a:xfrm>
-            <a:off x="1143000" y="685800"/>
-            <a:ext cx="4572000" cy="3429000"/>
-          </a:xfrm>
-          <a:prstGeom prst="rect">
-            <a:avLst/>
-          </a:prstGeom>
-          <a:noFill/>
-          <a:ln w="12700">
-            <a:solidFill>
-              <a:prstClr val="black"/>
-            </a:solidFill>
-          </a:ln>
-        </p:spPr>
-        <p:txBody>
-          <a:bodyPr vert="horz" lIns="91440" tIns="45720" rIns="91440" bIns="45720" rtlCol="0" anchor="ctr"/>
-          <a:lstStyle/>
-          <a:p>
-            <a:endParaRPr lang="en-US"/>
-          </a:p>
-        </p:txBody>
-      </p:sp>
-      <p:sp>
-        <p:nvSpPr>
-          <p:cNvPr id="5" name="Notes Placeholder 4"/>
-          <p:cNvSpPr>
-            <a:spLocks noGrp="1"/>
-          </p:cNvSpPr>
-          <p:nvPr>
-            <p:ph type="body" sz="quarter" idx="3"/>
-          </p:nvPr>
-        </p:nvSpPr>
-        <p:spPr>
-          <a:xfrm>
-            <a:off x="685800" y="4343400"/>
-            <a:ext cx="5486400" cy="4114800"/>
-          </a:xfrm>
-          <a:prstGeom prst="rect">
-            <a:avLst/>
-          </a:prstGeom>
-        </p:spPr>
-        <p:txBody>
-          <a:bodyPr vert="horz" lIns="91440" tIns="45720" rIns="91440" bIns="45720" rtlCol="0"/>
-          <a:lstStyle/>
-          <a:p>
-            <a:pPr lvl="0"/>
-            <a:r>
-              <a:rPr lang="en-US" smtClean="0"/>
-              <a:t>Click to edit Master text styles</a:t>
-            </a:r>
-          </a:p>
-          <a:p>
-            <a:pPr lvl="1"/>
-            <a:r>
-              <a:rPr lang="en-US" smtClean="0"/>
-              <a:t>Second level</a:t>
-            </a:r>
-          </a:p>
-          <a:p>
-            <a:pPr lvl="2"/>
-            <a:r>
-              <a:rPr lang="en-US" smtClean="0"/>
-              <a:t>Third level</a:t>
-            </a:r>
-          </a:p>
-          <a:p>
-            <a:pPr lvl="3"/>
-            <a:r>
-              <a:rPr lang="en-US" smtClean="0"/>
-              <a:t>Fourth level</a:t>
-            </a:r>
-          </a:p>
-          <a:p>
-            <a:pPr lvl="4"/>
-            <a:r>
-              <a:rPr lang="en-US" smtClean="0"/>
-              <a:t>Fifth level</a:t>
-            </a:r>
-            <a:endParaRPr lang="en-US"/>
-          </a:p>
-        </p:txBody>
-      </p:sp>
-      <p:sp>
-        <p:nvSpPr>
-          <p:cNvPr id="6" name="Footer Placeholder 5"/>
-          <p:cNvSpPr>
-            <a:spLocks noGrp="1"/>
-          </p:cNvSpPr>
-          <p:nvPr>
-            <p:ph type="ftr" sz="quarter" idx="4"/>
-          </p:nvPr>
-        </p:nvSpPr>
-        <p:spPr>
-          <a:xfrm>
-            <a:off x="0" y="8685213"/>
-            <a:ext cx="2971800" cy="457200"/>
-          </a:xfrm>
-          <a:prstGeom prst="rect">
-            <a:avLst/>
-          </a:prstGeom>
-        </p:spPr>
-        <p:txBody>
-          <a:bodyPr vert="horz" lIns="91440" tIns="45720" rIns="91440" bIns="45720" rtlCol="0" anchor="b"/>
-          <a:lstStyle>
-            <a:lvl1pPr algn="l">
-              <a:defRPr sz="1200"/>
-            </a:lvl1pPr>
-          </a:lstStyle>
-          <a:p>
-            <a:endParaRPr lang="en-US"/>
-          </a:p>
-        </p:txBody>
-      </p:sp>
-      <p:sp>
-        <p:nvSpPr>
-          <p:cNvPr id="7" name="Slide Number Placeholder 6"/>
-          <p:cNvSpPr>
-            <a:spLocks noGrp="1"/>
-          </p:cNvSpPr>
-          <p:nvPr>
-            <p:ph type="sldNum" sz="quarter" idx="5"/>
-          </p:nvPr>
-        </p:nvSpPr>
-        <p:spPr>
-          <a:xfrm>
-            <a:off x="3884613" y="8685213"/>
-            <a:ext cx="2971800" cy="457200"/>
-          </a:xfrm>
-          <a:prstGeom prst="rect">
-            <a:avLst/>
-          </a:prstGeom>
-        </p:spPr>
-        <p:txBody>
-          <a:bodyPr vert="horz" lIns="91440" tIns="45720" rIns="91440" bIns="45720" rtlCol="0" anchor="b"/>
-          <a:lstStyle>
-            <a:lvl1pPr algn="r">
-              <a:defRPr sz="1200"/>
-            </a:lvl1pPr>
-          </a:lstStyle>
-          <a:p>
-            <a:fld id="{BB5E49A5-4136-284D-997B-48E1D791AD67}" type="slidenum">
-              <a:rPr lang="en-US" smtClean="0"/>
-              <a:t>‹#›</a:t>
-            </a:fld>
-            <a:endParaRPr lang="en-US"/>
-          </a:p>
-        </p:txBody>
-      </p:sp>
     </p:spTree>
     <p:extLst>
       <p:ext uri="{BB962C8B-B14F-4D97-AF65-F5344CB8AC3E}">
-        <p14:creationId xmlns:p14="http://schemas.microsoft.com/office/powerpoint/2010/main" val="2623252185"/>
+        <p14:creationId xmlns:p14="http://schemas.microsoft.com/office/powerpoint/2010/main" val="2181044953"/>
       </p:ext>
     </p:extLst>
   </p:cSld>
   <p:clrMap bg1="lt1" tx1="dk1" bg2="lt2" tx2="dk2" accent1="accent1" accent2="accent2" accent3="accent3" accent4="accent4" accent5="accent5" accent6="accent6" hlink="hlink" folHlink="folHlink"/>
   <p:notesStyle>
-    <a:lvl1pPr marL="0" algn="l" defTabSz="457200" rtl="0" eaLnBrk="1" latinLnBrk="0" hangingPunct="1">
+    <a:lvl1pPr marL="0" algn="l" defTabSz="914400" rtl="0" eaLnBrk="1" latinLnBrk="1" hangingPunct="1">
       <a:defRPr sz="1200" kern="1200">
         <a:solidFill>
           <a:schemeClr val="tx1"/>
@@ -436,7 +242,7 @@
         <a:cs typeface="+mn-cs"/>
       </a:defRPr>
     </a:lvl1pPr>
-    <a:lvl2pPr marL="457200" algn="l" defTabSz="457200" rtl="0" eaLnBrk="1" latinLnBrk="0" hangingPunct="1">
+    <a:lvl2pPr marL="457200" algn="l" defTabSz="914400" rtl="0" eaLnBrk="1" latinLnBrk="1" hangingPunct="1">
       <a:defRPr sz="1200" kern="1200">
         <a:solidFill>
           <a:schemeClr val="tx1"/>
@@ -446,7 +252,7 @@
         <a:cs typeface="+mn-cs"/>
       </a:defRPr>
     </a:lvl2pPr>
-    <a:lvl3pPr marL="914400" algn="l" defTabSz="457200" rtl="0" eaLnBrk="1" latinLnBrk="0" hangingPunct="1">
+    <a:lvl3pPr marL="914400" algn="l" defTabSz="914400" rtl="0" eaLnBrk="1" latinLnBrk="1" hangingPunct="1">
       <a:defRPr sz="1200" kern="1200">
         <a:solidFill>
           <a:schemeClr val="tx1"/>
@@ -456,7 +262,7 @@
         <a:cs typeface="+mn-cs"/>
       </a:defRPr>
     </a:lvl3pPr>
-    <a:lvl4pPr marL="1371600" algn="l" defTabSz="457200" rtl="0" eaLnBrk="1" latinLnBrk="0" hangingPunct="1">
+    <a:lvl4pPr marL="1371600" algn="l" defTabSz="914400" rtl="0" eaLnBrk="1" latinLnBrk="1" hangingPunct="1">
       <a:defRPr sz="1200" kern="1200">
         <a:solidFill>
           <a:schemeClr val="tx1"/>
@@ -466,7 +272,7 @@
         <a:cs typeface="+mn-cs"/>
       </a:defRPr>
     </a:lvl4pPr>
-    <a:lvl5pPr marL="1828800" algn="l" defTabSz="457200" rtl="0" eaLnBrk="1" latinLnBrk="0" hangingPunct="1">
+    <a:lvl5pPr marL="1828800" algn="l" defTabSz="914400" rtl="0" eaLnBrk="1" latinLnBrk="1" hangingPunct="1">
       <a:defRPr sz="1200" kern="1200">
         <a:solidFill>
           <a:schemeClr val="tx1"/>
@@ -476,7 +282,7 @@
         <a:cs typeface="+mn-cs"/>
       </a:defRPr>
     </a:lvl5pPr>
-    <a:lvl6pPr marL="2286000" algn="l" defTabSz="457200" rtl="0" eaLnBrk="1" latinLnBrk="0" hangingPunct="1">
+    <a:lvl6pPr marL="2286000" algn="l" defTabSz="914400" rtl="0" eaLnBrk="1" latinLnBrk="1" hangingPunct="1">
       <a:defRPr sz="1200" kern="1200">
         <a:solidFill>
           <a:schemeClr val="tx1"/>
@@ -486,7 +292,7 @@
         <a:cs typeface="+mn-cs"/>
       </a:defRPr>
     </a:lvl6pPr>
-    <a:lvl7pPr marL="2743200" algn="l" defTabSz="457200" rtl="0" eaLnBrk="1" latinLnBrk="0" hangingPunct="1">
+    <a:lvl7pPr marL="2743200" algn="l" defTabSz="914400" rtl="0" eaLnBrk="1" latinLnBrk="1" hangingPunct="1">
       <a:defRPr sz="1200" kern="1200">
         <a:solidFill>
           <a:schemeClr val="tx1"/>
@@ -496,7 +302,7 @@
         <a:cs typeface="+mn-cs"/>
       </a:defRPr>
     </a:lvl7pPr>
-    <a:lvl8pPr marL="3200400" algn="l" defTabSz="457200" rtl="0" eaLnBrk="1" latinLnBrk="0" hangingPunct="1">
+    <a:lvl8pPr marL="3200400" algn="l" defTabSz="914400" rtl="0" eaLnBrk="1" latinLnBrk="1" hangingPunct="1">
       <a:defRPr sz="1200" kern="1200">
         <a:solidFill>
           <a:schemeClr val="tx1"/>
@@ -506,7 +312,7 @@
         <a:cs typeface="+mn-cs"/>
       </a:defRPr>
     </a:lvl8pPr>
-    <a:lvl9pPr marL="3657600" algn="l" defTabSz="457200" rtl="0" eaLnBrk="1" latinLnBrk="0" hangingPunct="1">
+    <a:lvl9pPr marL="3657600" algn="l" defTabSz="914400" rtl="0" eaLnBrk="1" latinLnBrk="1" hangingPunct="1">
       <a:defRPr sz="1200" kern="1200">
         <a:solidFill>
           <a:schemeClr val="tx1"/>
@@ -521,7 +327,7 @@
 </file>
 
 <file path=ppt/notesSlides/notesSlide1.xml><?xml version="1.0" encoding="utf-8"?>
-<p:notes xmlns:a="http://schemas.openxmlformats.org/drawingml/2006/main" xmlns:p="http://schemas.openxmlformats.org/presentationml/2006/main" xmlns:r="http://schemas.openxmlformats.org/officeDocument/2006/relationships">
+<p:notes xmlns:a="http://schemas.openxmlformats.org/drawingml/2006/main" xmlns:r="http://schemas.openxmlformats.org/officeDocument/2006/relationships" xmlns:p="http://schemas.openxmlformats.org/presentationml/2006/main">
   <p:cSld>
     <p:spTree>
       <p:nvGrpSpPr>
@@ -541,7 +347,7 @@
         <p:nvSpPr>
           <p:cNvPr id="2" name="Slide Image Placeholder 1"/>
           <p:cNvSpPr>
-            <a:spLocks noGrp="1"/>
+            <a:spLocks noGrp="1" noRot="1" noChangeAspect="1"/>
           </p:cNvSpPr>
           <p:nvPr>
             <p:ph type="sldImg" idx="2"/>
@@ -556,7 +362,7 @@
             <a:spLocks noGrp="1"/>
           </p:cNvSpPr>
           <p:nvPr>
-            <p:ph type="body" idx="3" sz="quarter"/>
+            <p:ph type="body" sz="quarter" idx="3"/>
           </p:nvPr>
         </p:nvSpPr>
         <p:spPr/>
@@ -577,7 +383,7 @@
             <a:spLocks noGrp="1"/>
           </p:cNvSpPr>
           <p:nvPr>
-            <p:ph type="sldNum" idx="5" sz="quarter"/>
+            <p:ph type="sldNum" sz="quarter" idx="5"/>
           </p:nvPr>
         </p:nvSpPr>
         <p:spPr/>
@@ -591,7 +397,7 @@
 </file>
 
 <file path=ppt/notesSlides/notesSlide10.xml><?xml version="1.0" encoding="utf-8"?>
-<p:notes xmlns:a="http://schemas.openxmlformats.org/drawingml/2006/main" xmlns:p="http://schemas.openxmlformats.org/presentationml/2006/main" xmlns:r="http://schemas.openxmlformats.org/officeDocument/2006/relationships">
+<p:notes xmlns:a="http://schemas.openxmlformats.org/drawingml/2006/main" xmlns:r="http://schemas.openxmlformats.org/officeDocument/2006/relationships" xmlns:p="http://schemas.openxmlformats.org/presentationml/2006/main">
   <p:cSld>
     <p:spTree>
       <p:nvGrpSpPr>
@@ -611,7 +417,7 @@
         <p:nvSpPr>
           <p:cNvPr id="2" name="Slide Image Placeholder 1"/>
           <p:cNvSpPr>
-            <a:spLocks noGrp="1"/>
+            <a:spLocks noGrp="1" noRot="1" noChangeAspect="1"/>
           </p:cNvSpPr>
           <p:nvPr>
             <p:ph type="sldImg" idx="2"/>
@@ -626,7 +432,7 @@
             <a:spLocks noGrp="1"/>
           </p:cNvSpPr>
           <p:nvPr>
-            <p:ph type="body" idx="3" sz="quarter"/>
+            <p:ph type="body" sz="quarter" idx="3"/>
           </p:nvPr>
         </p:nvSpPr>
         <p:spPr/>
@@ -647,7 +453,7 @@
             <a:spLocks noGrp="1"/>
           </p:cNvSpPr>
           <p:nvPr>
-            <p:ph type="sldNum" idx="5" sz="quarter"/>
+            <p:ph type="sldNum" sz="quarter" idx="5"/>
           </p:nvPr>
         </p:nvSpPr>
         <p:spPr/>
@@ -661,7 +467,7 @@
 </file>
 
 <file path=ppt/notesSlides/notesSlide11.xml><?xml version="1.0" encoding="utf-8"?>
-<p:notes xmlns:a="http://schemas.openxmlformats.org/drawingml/2006/main" xmlns:p="http://schemas.openxmlformats.org/presentationml/2006/main" xmlns:r="http://schemas.openxmlformats.org/officeDocument/2006/relationships">
+<p:notes xmlns:a="http://schemas.openxmlformats.org/drawingml/2006/main" xmlns:r="http://schemas.openxmlformats.org/officeDocument/2006/relationships" xmlns:p="http://schemas.openxmlformats.org/presentationml/2006/main">
   <p:cSld>
     <p:spTree>
       <p:nvGrpSpPr>
@@ -681,7 +487,7 @@
         <p:nvSpPr>
           <p:cNvPr id="2" name="Slide Image Placeholder 1"/>
           <p:cNvSpPr>
-            <a:spLocks noGrp="1"/>
+            <a:spLocks noGrp="1" noRot="1" noChangeAspect="1"/>
           </p:cNvSpPr>
           <p:nvPr>
             <p:ph type="sldImg" idx="2"/>
@@ -696,7 +502,7 @@
             <a:spLocks noGrp="1"/>
           </p:cNvSpPr>
           <p:nvPr>
-            <p:ph type="body" idx="3" sz="quarter"/>
+            <p:ph type="body" sz="quarter" idx="3"/>
           </p:nvPr>
         </p:nvSpPr>
         <p:spPr/>
@@ -717,7 +523,7 @@
             <a:spLocks noGrp="1"/>
           </p:cNvSpPr>
           <p:nvPr>
-            <p:ph type="sldNum" idx="5" sz="quarter"/>
+            <p:ph type="sldNum" sz="quarter" idx="5"/>
           </p:nvPr>
         </p:nvSpPr>
         <p:spPr/>
@@ -731,7 +537,7 @@
 </file>
 
 <file path=ppt/notesSlides/notesSlide12.xml><?xml version="1.0" encoding="utf-8"?>
-<p:notes xmlns:a="http://schemas.openxmlformats.org/drawingml/2006/main" xmlns:p="http://schemas.openxmlformats.org/presentationml/2006/main" xmlns:r="http://schemas.openxmlformats.org/officeDocument/2006/relationships">
+<p:notes xmlns:a="http://schemas.openxmlformats.org/drawingml/2006/main" xmlns:r="http://schemas.openxmlformats.org/officeDocument/2006/relationships" xmlns:p="http://schemas.openxmlformats.org/presentationml/2006/main">
   <p:cSld>
     <p:spTree>
       <p:nvGrpSpPr>
@@ -751,7 +557,7 @@
         <p:nvSpPr>
           <p:cNvPr id="2" name="Slide Image Placeholder 1"/>
           <p:cNvSpPr>
-            <a:spLocks noGrp="1"/>
+            <a:spLocks noGrp="1" noRot="1" noChangeAspect="1"/>
           </p:cNvSpPr>
           <p:nvPr>
             <p:ph type="sldImg" idx="2"/>
@@ -766,7 +572,7 @@
             <a:spLocks noGrp="1"/>
           </p:cNvSpPr>
           <p:nvPr>
-            <p:ph type="body" idx="3" sz="quarter"/>
+            <p:ph type="body" sz="quarter" idx="3"/>
           </p:nvPr>
         </p:nvSpPr>
         <p:spPr/>
@@ -787,7 +593,7 @@
             <a:spLocks noGrp="1"/>
           </p:cNvSpPr>
           <p:nvPr>
-            <p:ph type="sldNum" idx="5" sz="quarter"/>
+            <p:ph type="sldNum" sz="quarter" idx="5"/>
           </p:nvPr>
         </p:nvSpPr>
         <p:spPr/>
@@ -801,7 +607,7 @@
 </file>
 
 <file path=ppt/notesSlides/notesSlide13.xml><?xml version="1.0" encoding="utf-8"?>
-<p:notes xmlns:a="http://schemas.openxmlformats.org/drawingml/2006/main" xmlns:p="http://schemas.openxmlformats.org/presentationml/2006/main" xmlns:r="http://schemas.openxmlformats.org/officeDocument/2006/relationships">
+<p:notes xmlns:a="http://schemas.openxmlformats.org/drawingml/2006/main" xmlns:r="http://schemas.openxmlformats.org/officeDocument/2006/relationships" xmlns:p="http://schemas.openxmlformats.org/presentationml/2006/main">
   <p:cSld>
     <p:spTree>
       <p:nvGrpSpPr>
@@ -821,7 +627,7 @@
         <p:nvSpPr>
           <p:cNvPr id="2" name="Slide Image Placeholder 1"/>
           <p:cNvSpPr>
-            <a:spLocks noGrp="1"/>
+            <a:spLocks noGrp="1" noRot="1" noChangeAspect="1"/>
           </p:cNvSpPr>
           <p:nvPr>
             <p:ph type="sldImg" idx="2"/>
@@ -836,7 +642,7 @@
             <a:spLocks noGrp="1"/>
           </p:cNvSpPr>
           <p:nvPr>
-            <p:ph type="body" idx="3" sz="quarter"/>
+            <p:ph type="body" sz="quarter" idx="3"/>
           </p:nvPr>
         </p:nvSpPr>
         <p:spPr/>
@@ -857,7 +663,7 @@
             <a:spLocks noGrp="1"/>
           </p:cNvSpPr>
           <p:nvPr>
-            <p:ph type="sldNum" idx="5" sz="quarter"/>
+            <p:ph type="sldNum" sz="quarter" idx="5"/>
           </p:nvPr>
         </p:nvSpPr>
         <p:spPr/>
@@ -871,7 +677,7 @@
 </file>
 
 <file path=ppt/notesSlides/notesSlide14.xml><?xml version="1.0" encoding="utf-8"?>
-<p:notes xmlns:a="http://schemas.openxmlformats.org/drawingml/2006/main" xmlns:p="http://schemas.openxmlformats.org/presentationml/2006/main" xmlns:r="http://schemas.openxmlformats.org/officeDocument/2006/relationships">
+<p:notes xmlns:a="http://schemas.openxmlformats.org/drawingml/2006/main" xmlns:r="http://schemas.openxmlformats.org/officeDocument/2006/relationships" xmlns:p="http://schemas.openxmlformats.org/presentationml/2006/main">
   <p:cSld>
     <p:spTree>
       <p:nvGrpSpPr>
@@ -891,7 +697,7 @@
         <p:nvSpPr>
           <p:cNvPr id="2" name="Slide Image Placeholder 1"/>
           <p:cNvSpPr>
-            <a:spLocks noGrp="1"/>
+            <a:spLocks noGrp="1" noRot="1" noChangeAspect="1"/>
           </p:cNvSpPr>
           <p:nvPr>
             <p:ph type="sldImg" idx="2"/>
@@ -906,7 +712,7 @@
             <a:spLocks noGrp="1"/>
           </p:cNvSpPr>
           <p:nvPr>
-            <p:ph type="body" idx="3" sz="quarter"/>
+            <p:ph type="body" sz="quarter" idx="3"/>
           </p:nvPr>
         </p:nvSpPr>
         <p:spPr/>
@@ -927,7 +733,7 @@
             <a:spLocks noGrp="1"/>
           </p:cNvSpPr>
           <p:nvPr>
-            <p:ph type="sldNum" idx="5" sz="quarter"/>
+            <p:ph type="sldNum" sz="quarter" idx="5"/>
           </p:nvPr>
         </p:nvSpPr>
         <p:spPr/>
@@ -941,7 +747,7 @@
 </file>
 
 <file path=ppt/notesSlides/notesSlide15.xml><?xml version="1.0" encoding="utf-8"?>
-<p:notes xmlns:a="http://schemas.openxmlformats.org/drawingml/2006/main" xmlns:p="http://schemas.openxmlformats.org/presentationml/2006/main" xmlns:r="http://schemas.openxmlformats.org/officeDocument/2006/relationships">
+<p:notes xmlns:a="http://schemas.openxmlformats.org/drawingml/2006/main" xmlns:r="http://schemas.openxmlformats.org/officeDocument/2006/relationships" xmlns:p="http://schemas.openxmlformats.org/presentationml/2006/main">
   <p:cSld>
     <p:spTree>
       <p:nvGrpSpPr>
@@ -961,7 +767,7 @@
         <p:nvSpPr>
           <p:cNvPr id="2" name="Slide Image Placeholder 1"/>
           <p:cNvSpPr>
-            <a:spLocks noGrp="1"/>
+            <a:spLocks noGrp="1" noRot="1" noChangeAspect="1"/>
           </p:cNvSpPr>
           <p:nvPr>
             <p:ph type="sldImg" idx="2"/>
@@ -976,7 +782,7 @@
             <a:spLocks noGrp="1"/>
           </p:cNvSpPr>
           <p:nvPr>
-            <p:ph type="body" idx="3" sz="quarter"/>
+            <p:ph type="body" sz="quarter" idx="3"/>
           </p:nvPr>
         </p:nvSpPr>
         <p:spPr/>
@@ -997,7 +803,7 @@
             <a:spLocks noGrp="1"/>
           </p:cNvSpPr>
           <p:nvPr>
-            <p:ph type="sldNum" idx="5" sz="quarter"/>
+            <p:ph type="sldNum" sz="quarter" idx="5"/>
           </p:nvPr>
         </p:nvSpPr>
         <p:spPr/>
@@ -1011,7 +817,7 @@
 </file>
 
 <file path=ppt/notesSlides/notesSlide16.xml><?xml version="1.0" encoding="utf-8"?>
-<p:notes xmlns:a="http://schemas.openxmlformats.org/drawingml/2006/main" xmlns:p="http://schemas.openxmlformats.org/presentationml/2006/main" xmlns:r="http://schemas.openxmlformats.org/officeDocument/2006/relationships">
+<p:notes xmlns:a="http://schemas.openxmlformats.org/drawingml/2006/main" xmlns:r="http://schemas.openxmlformats.org/officeDocument/2006/relationships" xmlns:p="http://schemas.openxmlformats.org/presentationml/2006/main">
   <p:cSld>
     <p:spTree>
       <p:nvGrpSpPr>
@@ -1031,7 +837,7 @@
         <p:nvSpPr>
           <p:cNvPr id="2" name="Slide Image Placeholder 1"/>
           <p:cNvSpPr>
-            <a:spLocks noGrp="1"/>
+            <a:spLocks noGrp="1" noRot="1" noChangeAspect="1"/>
           </p:cNvSpPr>
           <p:nvPr>
             <p:ph type="sldImg" idx="2"/>
@@ -1046,7 +852,7 @@
             <a:spLocks noGrp="1"/>
           </p:cNvSpPr>
           <p:nvPr>
-            <p:ph type="body" idx="3" sz="quarter"/>
+            <p:ph type="body" sz="quarter" idx="3"/>
           </p:nvPr>
         </p:nvSpPr>
         <p:spPr/>
@@ -1067,7 +873,7 @@
             <a:spLocks noGrp="1"/>
           </p:cNvSpPr>
           <p:nvPr>
-            <p:ph type="sldNum" idx="5" sz="quarter"/>
+            <p:ph type="sldNum" sz="quarter" idx="5"/>
           </p:nvPr>
         </p:nvSpPr>
         <p:spPr/>
@@ -1081,7 +887,7 @@
 </file>
 
 <file path=ppt/notesSlides/notesSlide17.xml><?xml version="1.0" encoding="utf-8"?>
-<p:notes xmlns:a="http://schemas.openxmlformats.org/drawingml/2006/main" xmlns:p="http://schemas.openxmlformats.org/presentationml/2006/main" xmlns:r="http://schemas.openxmlformats.org/officeDocument/2006/relationships">
+<p:notes xmlns:a="http://schemas.openxmlformats.org/drawingml/2006/main" xmlns:r="http://schemas.openxmlformats.org/officeDocument/2006/relationships" xmlns:p="http://schemas.openxmlformats.org/presentationml/2006/main">
   <p:cSld>
     <p:spTree>
       <p:nvGrpSpPr>
@@ -1101,7 +907,7 @@
         <p:nvSpPr>
           <p:cNvPr id="2" name="Slide Image Placeholder 1"/>
           <p:cNvSpPr>
-            <a:spLocks noGrp="1"/>
+            <a:spLocks noGrp="1" noRot="1" noChangeAspect="1"/>
           </p:cNvSpPr>
           <p:nvPr>
             <p:ph type="sldImg" idx="2"/>
@@ -1116,7 +922,7 @@
             <a:spLocks noGrp="1"/>
           </p:cNvSpPr>
           <p:nvPr>
-            <p:ph type="body" idx="3" sz="quarter"/>
+            <p:ph type="body" sz="quarter" idx="3"/>
           </p:nvPr>
         </p:nvSpPr>
         <p:spPr/>
@@ -1137,7 +943,7 @@
             <a:spLocks noGrp="1"/>
           </p:cNvSpPr>
           <p:nvPr>
-            <p:ph type="sldNum" idx="5" sz="quarter"/>
+            <p:ph type="sldNum" sz="quarter" idx="5"/>
           </p:nvPr>
         </p:nvSpPr>
         <p:spPr/>
@@ -1151,7 +957,7 @@
 </file>
 
 <file path=ppt/notesSlides/notesSlide18.xml><?xml version="1.0" encoding="utf-8"?>
-<p:notes xmlns:a="http://schemas.openxmlformats.org/drawingml/2006/main" xmlns:p="http://schemas.openxmlformats.org/presentationml/2006/main" xmlns:r="http://schemas.openxmlformats.org/officeDocument/2006/relationships">
+<p:notes xmlns:a="http://schemas.openxmlformats.org/drawingml/2006/main" xmlns:r="http://schemas.openxmlformats.org/officeDocument/2006/relationships" xmlns:p="http://schemas.openxmlformats.org/presentationml/2006/main">
   <p:cSld>
     <p:spTree>
       <p:nvGrpSpPr>
@@ -1171,7 +977,7 @@
         <p:nvSpPr>
           <p:cNvPr id="2" name="Slide Image Placeholder 1"/>
           <p:cNvSpPr>
-            <a:spLocks noGrp="1"/>
+            <a:spLocks noGrp="1" noRot="1" noChangeAspect="1"/>
           </p:cNvSpPr>
           <p:nvPr>
             <p:ph type="sldImg" idx="2"/>
@@ -1186,7 +992,7 @@
             <a:spLocks noGrp="1"/>
           </p:cNvSpPr>
           <p:nvPr>
-            <p:ph type="body" idx="3" sz="quarter"/>
+            <p:ph type="body" sz="quarter" idx="3"/>
           </p:nvPr>
         </p:nvSpPr>
         <p:spPr/>
@@ -1207,7 +1013,7 @@
             <a:spLocks noGrp="1"/>
           </p:cNvSpPr>
           <p:nvPr>
-            <p:ph type="sldNum" idx="5" sz="quarter"/>
+            <p:ph type="sldNum" sz="quarter" idx="5"/>
           </p:nvPr>
         </p:nvSpPr>
         <p:spPr/>
@@ -1221,7 +1027,7 @@
 </file>
 
 <file path=ppt/notesSlides/notesSlide19.xml><?xml version="1.0" encoding="utf-8"?>
-<p:notes xmlns:a="http://schemas.openxmlformats.org/drawingml/2006/main" xmlns:p="http://schemas.openxmlformats.org/presentationml/2006/main" xmlns:r="http://schemas.openxmlformats.org/officeDocument/2006/relationships">
+<p:notes xmlns:a="http://schemas.openxmlformats.org/drawingml/2006/main" xmlns:r="http://schemas.openxmlformats.org/officeDocument/2006/relationships" xmlns:p="http://schemas.openxmlformats.org/presentationml/2006/main">
   <p:cSld>
     <p:spTree>
       <p:nvGrpSpPr>
@@ -1241,7 +1047,7 @@
         <p:nvSpPr>
           <p:cNvPr id="2" name="Slide Image Placeholder 1"/>
           <p:cNvSpPr>
-            <a:spLocks noGrp="1"/>
+            <a:spLocks noGrp="1" noRot="1" noChangeAspect="1"/>
           </p:cNvSpPr>
           <p:nvPr>
             <p:ph type="sldImg" idx="2"/>
@@ -1256,7 +1062,7 @@
             <a:spLocks noGrp="1"/>
           </p:cNvSpPr>
           <p:nvPr>
-            <p:ph type="body" idx="3" sz="quarter"/>
+            <p:ph type="body" sz="quarter" idx="3"/>
           </p:nvPr>
         </p:nvSpPr>
         <p:spPr/>
@@ -1268,7 +1074,9 @@
               <a:t>이상으로 보고를 마칩니다. 13,262행 전수 보존 전처리, 76.8시간의 실사 대기 병목과 원인 규명, 그리고 가정을 명시하고 실험 설계로 검증하는 TO-BE 시나리오까지 설명드렸습니다. 질문 주시면 답변드리겠습니다. 감사합니다.</a:t>
             </a:r>
           </a:p>
-          <a:p/>
+          <a:p>
+            <a:endParaRPr/>
+          </a:p>
           <a:p>
             <a:r>
               <a:t>[핵심 숫자 치트시트] 리드타임 105.9h · 대기 95.8h(90.5%) · 실사 대기 76.8h · 유입 134.3 vs CAPA 68.0 · 적체 403건 · 인계 6.6배 · OLS 실사 1.12h/h · 사내수리 +31.75h · 자재 30.5h · 재수리 26건 +32.9h · 사전 적중 E→사내 100.0%, P→즉시 83.1% · 감축 ▼14.5%</a:t>
@@ -1283,7 +1091,7 @@
             <a:spLocks noGrp="1"/>
           </p:cNvSpPr>
           <p:nvPr>
-            <p:ph type="sldNum" idx="5" sz="quarter"/>
+            <p:ph type="sldNum" sz="quarter" idx="5"/>
           </p:nvPr>
         </p:nvSpPr>
         <p:spPr/>
@@ -1297,7 +1105,7 @@
 </file>
 
 <file path=ppt/notesSlides/notesSlide2.xml><?xml version="1.0" encoding="utf-8"?>
-<p:notes xmlns:a="http://schemas.openxmlformats.org/drawingml/2006/main" xmlns:p="http://schemas.openxmlformats.org/presentationml/2006/main" xmlns:r="http://schemas.openxmlformats.org/officeDocument/2006/relationships">
+<p:notes xmlns:a="http://schemas.openxmlformats.org/drawingml/2006/main" xmlns:r="http://schemas.openxmlformats.org/officeDocument/2006/relationships" xmlns:p="http://schemas.openxmlformats.org/presentationml/2006/main">
   <p:cSld>
     <p:spTree>
       <p:nvGrpSpPr>
@@ -1317,7 +1125,7 @@
         <p:nvSpPr>
           <p:cNvPr id="2" name="Slide Image Placeholder 1"/>
           <p:cNvSpPr>
-            <a:spLocks noGrp="1"/>
+            <a:spLocks noGrp="1" noRot="1" noChangeAspect="1"/>
           </p:cNvSpPr>
           <p:nvPr>
             <p:ph type="sldImg" idx="2"/>
@@ -1332,7 +1140,7 @@
             <a:spLocks noGrp="1"/>
           </p:cNvSpPr>
           <p:nvPr>
-            <p:ph type="body" idx="3" sz="quarter"/>
+            <p:ph type="body" sz="quarter" idx="3"/>
           </p:nvPr>
         </p:nvSpPr>
         <p:spPr/>
@@ -1353,7 +1161,7 @@
             <a:spLocks noGrp="1"/>
           </p:cNvSpPr>
           <p:nvPr>
-            <p:ph type="sldNum" idx="5" sz="quarter"/>
+            <p:ph type="sldNum" sz="quarter" idx="5"/>
           </p:nvPr>
         </p:nvSpPr>
         <p:spPr/>
@@ -1367,7 +1175,7 @@
 </file>
 
 <file path=ppt/notesSlides/notesSlide3.xml><?xml version="1.0" encoding="utf-8"?>
-<p:notes xmlns:a="http://schemas.openxmlformats.org/drawingml/2006/main" xmlns:p="http://schemas.openxmlformats.org/presentationml/2006/main" xmlns:r="http://schemas.openxmlformats.org/officeDocument/2006/relationships">
+<p:notes xmlns:a="http://schemas.openxmlformats.org/drawingml/2006/main" xmlns:r="http://schemas.openxmlformats.org/officeDocument/2006/relationships" xmlns:p="http://schemas.openxmlformats.org/presentationml/2006/main">
   <p:cSld>
     <p:spTree>
       <p:nvGrpSpPr>
@@ -1387,7 +1195,7 @@
         <p:nvSpPr>
           <p:cNvPr id="2" name="Slide Image Placeholder 1"/>
           <p:cNvSpPr>
-            <a:spLocks noGrp="1"/>
+            <a:spLocks noGrp="1" noRot="1" noChangeAspect="1"/>
           </p:cNvSpPr>
           <p:nvPr>
             <p:ph type="sldImg" idx="2"/>
@@ -1402,7 +1210,7 @@
             <a:spLocks noGrp="1"/>
           </p:cNvSpPr>
           <p:nvPr>
-            <p:ph type="body" idx="3" sz="quarter"/>
+            <p:ph type="body" sz="quarter" idx="3"/>
           </p:nvPr>
         </p:nvSpPr>
         <p:spPr/>
@@ -1423,7 +1231,7 @@
             <a:spLocks noGrp="1"/>
           </p:cNvSpPr>
           <p:nvPr>
-            <p:ph type="sldNum" idx="5" sz="quarter"/>
+            <p:ph type="sldNum" sz="quarter" idx="5"/>
           </p:nvPr>
         </p:nvSpPr>
         <p:spPr/>
@@ -1437,7 +1245,7 @@
 </file>
 
 <file path=ppt/notesSlides/notesSlide4.xml><?xml version="1.0" encoding="utf-8"?>
-<p:notes xmlns:a="http://schemas.openxmlformats.org/drawingml/2006/main" xmlns:p="http://schemas.openxmlformats.org/presentationml/2006/main" xmlns:r="http://schemas.openxmlformats.org/officeDocument/2006/relationships">
+<p:notes xmlns:a="http://schemas.openxmlformats.org/drawingml/2006/main" xmlns:r="http://schemas.openxmlformats.org/officeDocument/2006/relationships" xmlns:p="http://schemas.openxmlformats.org/presentationml/2006/main">
   <p:cSld>
     <p:spTree>
       <p:nvGrpSpPr>
@@ -1457,7 +1265,7 @@
         <p:nvSpPr>
           <p:cNvPr id="2" name="Slide Image Placeholder 1"/>
           <p:cNvSpPr>
-            <a:spLocks noGrp="1"/>
+            <a:spLocks noGrp="1" noRot="1" noChangeAspect="1"/>
           </p:cNvSpPr>
           <p:nvPr>
             <p:ph type="sldImg" idx="2"/>
@@ -1472,7 +1280,7 @@
             <a:spLocks noGrp="1"/>
           </p:cNvSpPr>
           <p:nvPr>
-            <p:ph type="body" idx="3" sz="quarter"/>
+            <p:ph type="body" sz="quarter" idx="3"/>
           </p:nvPr>
         </p:nvSpPr>
         <p:spPr/>
@@ -1493,7 +1301,7 @@
             <a:spLocks noGrp="1"/>
           </p:cNvSpPr>
           <p:nvPr>
-            <p:ph type="sldNum" idx="5" sz="quarter"/>
+            <p:ph type="sldNum" sz="quarter" idx="5"/>
           </p:nvPr>
         </p:nvSpPr>
         <p:spPr/>
@@ -1507,7 +1315,7 @@
 </file>
 
 <file path=ppt/notesSlides/notesSlide5.xml><?xml version="1.0" encoding="utf-8"?>
-<p:notes xmlns:a="http://schemas.openxmlformats.org/drawingml/2006/main" xmlns:p="http://schemas.openxmlformats.org/presentationml/2006/main" xmlns:r="http://schemas.openxmlformats.org/officeDocument/2006/relationships">
+<p:notes xmlns:a="http://schemas.openxmlformats.org/drawingml/2006/main" xmlns:r="http://schemas.openxmlformats.org/officeDocument/2006/relationships" xmlns:p="http://schemas.openxmlformats.org/presentationml/2006/main">
   <p:cSld>
     <p:spTree>
       <p:nvGrpSpPr>
@@ -1527,7 +1335,7 @@
         <p:nvSpPr>
           <p:cNvPr id="2" name="Slide Image Placeholder 1"/>
           <p:cNvSpPr>
-            <a:spLocks noGrp="1"/>
+            <a:spLocks noGrp="1" noRot="1" noChangeAspect="1"/>
           </p:cNvSpPr>
           <p:nvPr>
             <p:ph type="sldImg" idx="2"/>
@@ -1542,7 +1350,7 @@
             <a:spLocks noGrp="1"/>
           </p:cNvSpPr>
           <p:nvPr>
-            <p:ph type="body" idx="3" sz="quarter"/>
+            <p:ph type="body" sz="quarter" idx="3"/>
           </p:nvPr>
         </p:nvSpPr>
         <p:spPr/>
@@ -1563,7 +1371,7 @@
             <a:spLocks noGrp="1"/>
           </p:cNvSpPr>
           <p:nvPr>
-            <p:ph type="sldNum" idx="5" sz="quarter"/>
+            <p:ph type="sldNum" sz="quarter" idx="5"/>
           </p:nvPr>
         </p:nvSpPr>
         <p:spPr/>
@@ -1577,7 +1385,7 @@
 </file>
 
 <file path=ppt/notesSlides/notesSlide6.xml><?xml version="1.0" encoding="utf-8"?>
-<p:notes xmlns:a="http://schemas.openxmlformats.org/drawingml/2006/main" xmlns:p="http://schemas.openxmlformats.org/presentationml/2006/main" xmlns:r="http://schemas.openxmlformats.org/officeDocument/2006/relationships">
+<p:notes xmlns:a="http://schemas.openxmlformats.org/drawingml/2006/main" xmlns:r="http://schemas.openxmlformats.org/officeDocument/2006/relationships" xmlns:p="http://schemas.openxmlformats.org/presentationml/2006/main">
   <p:cSld>
     <p:spTree>
       <p:nvGrpSpPr>
@@ -1597,7 +1405,7 @@
         <p:nvSpPr>
           <p:cNvPr id="2" name="Slide Image Placeholder 1"/>
           <p:cNvSpPr>
-            <a:spLocks noGrp="1"/>
+            <a:spLocks noGrp="1" noRot="1" noChangeAspect="1"/>
           </p:cNvSpPr>
           <p:nvPr>
             <p:ph type="sldImg" idx="2"/>
@@ -1612,7 +1420,7 @@
             <a:spLocks noGrp="1"/>
           </p:cNvSpPr>
           <p:nvPr>
-            <p:ph type="body" idx="3" sz="quarter"/>
+            <p:ph type="body" sz="quarter" idx="3"/>
           </p:nvPr>
         </p:nvSpPr>
         <p:spPr/>
@@ -1633,7 +1441,7 @@
             <a:spLocks noGrp="1"/>
           </p:cNvSpPr>
           <p:nvPr>
-            <p:ph type="sldNum" idx="5" sz="quarter"/>
+            <p:ph type="sldNum" sz="quarter" idx="5"/>
           </p:nvPr>
         </p:nvSpPr>
         <p:spPr/>
@@ -1647,7 +1455,7 @@
 </file>
 
 <file path=ppt/notesSlides/notesSlide7.xml><?xml version="1.0" encoding="utf-8"?>
-<p:notes xmlns:a="http://schemas.openxmlformats.org/drawingml/2006/main" xmlns:p="http://schemas.openxmlformats.org/presentationml/2006/main" xmlns:r="http://schemas.openxmlformats.org/officeDocument/2006/relationships">
+<p:notes xmlns:a="http://schemas.openxmlformats.org/drawingml/2006/main" xmlns:r="http://schemas.openxmlformats.org/officeDocument/2006/relationships" xmlns:p="http://schemas.openxmlformats.org/presentationml/2006/main">
   <p:cSld>
     <p:spTree>
       <p:nvGrpSpPr>
@@ -1667,7 +1475,7 @@
         <p:nvSpPr>
           <p:cNvPr id="2" name="Slide Image Placeholder 1"/>
           <p:cNvSpPr>
-            <a:spLocks noGrp="1"/>
+            <a:spLocks noGrp="1" noRot="1" noChangeAspect="1"/>
           </p:cNvSpPr>
           <p:nvPr>
             <p:ph type="sldImg" idx="2"/>
@@ -1682,7 +1490,7 @@
             <a:spLocks noGrp="1"/>
           </p:cNvSpPr>
           <p:nvPr>
-            <p:ph type="body" idx="3" sz="quarter"/>
+            <p:ph type="body" sz="quarter" idx="3"/>
           </p:nvPr>
         </p:nvSpPr>
         <p:spPr/>
@@ -1703,7 +1511,7 @@
             <a:spLocks noGrp="1"/>
           </p:cNvSpPr>
           <p:nvPr>
-            <p:ph type="sldNum" idx="5" sz="quarter"/>
+            <p:ph type="sldNum" sz="quarter" idx="5"/>
           </p:nvPr>
         </p:nvSpPr>
         <p:spPr/>
@@ -1717,7 +1525,7 @@
 </file>
 
 <file path=ppt/notesSlides/notesSlide8.xml><?xml version="1.0" encoding="utf-8"?>
-<p:notes xmlns:a="http://schemas.openxmlformats.org/drawingml/2006/main" xmlns:p="http://schemas.openxmlformats.org/presentationml/2006/main" xmlns:r="http://schemas.openxmlformats.org/officeDocument/2006/relationships">
+<p:notes xmlns:a="http://schemas.openxmlformats.org/drawingml/2006/main" xmlns:r="http://schemas.openxmlformats.org/officeDocument/2006/relationships" xmlns:p="http://schemas.openxmlformats.org/presentationml/2006/main">
   <p:cSld>
     <p:spTree>
       <p:nvGrpSpPr>
@@ -1737,7 +1545,7 @@
         <p:nvSpPr>
           <p:cNvPr id="2" name="Slide Image Placeholder 1"/>
           <p:cNvSpPr>
-            <a:spLocks noGrp="1"/>
+            <a:spLocks noGrp="1" noRot="1" noChangeAspect="1"/>
           </p:cNvSpPr>
           <p:nvPr>
             <p:ph type="sldImg" idx="2"/>
@@ -1752,7 +1560,7 @@
             <a:spLocks noGrp="1"/>
           </p:cNvSpPr>
           <p:nvPr>
-            <p:ph type="body" idx="3" sz="quarter"/>
+            <p:ph type="body" sz="quarter" idx="3"/>
           </p:nvPr>
         </p:nvSpPr>
         <p:spPr/>
@@ -1773,7 +1581,7 @@
             <a:spLocks noGrp="1"/>
           </p:cNvSpPr>
           <p:nvPr>
-            <p:ph type="sldNum" idx="5" sz="quarter"/>
+            <p:ph type="sldNum" sz="quarter" idx="5"/>
           </p:nvPr>
         </p:nvSpPr>
         <p:spPr/>
@@ -1787,7 +1595,7 @@
 </file>
 
 <file path=ppt/notesSlides/notesSlide9.xml><?xml version="1.0" encoding="utf-8"?>
-<p:notes xmlns:a="http://schemas.openxmlformats.org/drawingml/2006/main" xmlns:p="http://schemas.openxmlformats.org/presentationml/2006/main" xmlns:r="http://schemas.openxmlformats.org/officeDocument/2006/relationships">
+<p:notes xmlns:a="http://schemas.openxmlformats.org/drawingml/2006/main" xmlns:r="http://schemas.openxmlformats.org/officeDocument/2006/relationships" xmlns:p="http://schemas.openxmlformats.org/presentationml/2006/main">
   <p:cSld>
     <p:spTree>
       <p:nvGrpSpPr>
@@ -1807,7 +1615,7 @@
         <p:nvSpPr>
           <p:cNvPr id="2" name="Slide Image Placeholder 1"/>
           <p:cNvSpPr>
-            <a:spLocks noGrp="1"/>
+            <a:spLocks noGrp="1" noRot="1" noChangeAspect="1"/>
           </p:cNvSpPr>
           <p:nvPr>
             <p:ph type="sldImg" idx="2"/>
@@ -1822,7 +1630,7 @@
             <a:spLocks noGrp="1"/>
           </p:cNvSpPr>
           <p:nvPr>
-            <p:ph type="body" idx="3" sz="quarter"/>
+            <p:ph type="body" sz="quarter" idx="3"/>
           </p:nvPr>
         </p:nvSpPr>
         <p:spPr/>
@@ -1843,7 +1651,7 @@
             <a:spLocks noGrp="1"/>
           </p:cNvSpPr>
           <p:nvPr>
-            <p:ph type="sldNum" idx="5" sz="quarter"/>
+            <p:ph type="sldNum" sz="quarter" idx="5"/>
           </p:nvPr>
         </p:nvSpPr>
         <p:spPr/>
@@ -1894,10 +1702,9 @@
           <a:lstStyle/>
           <a:p>
             <a:r>
-              <a:rPr lang="en-US" smtClean="0"/>
+              <a:rPr lang="en-US"/>
               <a:t>Click to edit Master title style</a:t>
             </a:r>
-            <a:endParaRPr lang="en-US"/>
           </a:p>
         </p:txBody>
       </p:sp>
@@ -2013,10 +1820,9 @@
           </a:lstStyle>
           <a:p>
             <a:r>
-              <a:rPr lang="en-US" smtClean="0"/>
+              <a:rPr lang="en-US"/>
               <a:t>Click to edit Master subtitle style</a:t>
             </a:r>
-            <a:endParaRPr lang="en-US"/>
           </a:p>
         </p:txBody>
       </p:sp>
@@ -2037,7 +1843,7 @@
           <a:p>
             <a:fld id="{5BCAD085-E8A6-8845-BD4E-CB4CCA059FC4}" type="datetimeFigureOut">
               <a:rPr lang="en-US" smtClean="0"/>
-              <a:t>1/27/13</a:t>
+              <a:t>10/27/2026</a:t>
             </a:fld>
             <a:endParaRPr lang="en-US"/>
           </a:p>
@@ -2131,10 +1937,9 @@
           <a:lstStyle/>
           <a:p>
             <a:r>
-              <a:rPr lang="en-US" smtClean="0"/>
+              <a:rPr lang="en-US"/>
               <a:t>Click to edit Master title style</a:t>
             </a:r>
-            <a:endParaRPr lang="en-US"/>
           </a:p>
         </p:txBody>
       </p:sp>
@@ -2155,38 +1960,37 @@
           <a:p>
             <a:pPr lvl="0"/>
             <a:r>
-              <a:rPr lang="en-US" smtClean="0"/>
+              <a:rPr lang="en-US"/>
               <a:t>Click to edit Master text styles</a:t>
             </a:r>
           </a:p>
           <a:p>
             <a:pPr lvl="1"/>
             <a:r>
-              <a:rPr lang="en-US" smtClean="0"/>
+              <a:rPr lang="en-US"/>
               <a:t>Second level</a:t>
             </a:r>
           </a:p>
           <a:p>
             <a:pPr lvl="2"/>
             <a:r>
-              <a:rPr lang="en-US" smtClean="0"/>
+              <a:rPr lang="en-US"/>
               <a:t>Third level</a:t>
             </a:r>
           </a:p>
           <a:p>
             <a:pPr lvl="3"/>
             <a:r>
-              <a:rPr lang="en-US" smtClean="0"/>
+              <a:rPr lang="en-US"/>
               <a:t>Fourth level</a:t>
             </a:r>
           </a:p>
           <a:p>
             <a:pPr lvl="4"/>
             <a:r>
-              <a:rPr lang="en-US" smtClean="0"/>
+              <a:rPr lang="en-US"/>
               <a:t>Fifth level</a:t>
             </a:r>
-            <a:endParaRPr lang="en-US"/>
           </a:p>
         </p:txBody>
       </p:sp>
@@ -2207,7 +2011,7 @@
           <a:p>
             <a:fld id="{5BCAD085-E8A6-8845-BD4E-CB4CCA059FC4}" type="datetimeFigureOut">
               <a:rPr lang="en-US" smtClean="0"/>
-              <a:t>1/27/13</a:t>
+              <a:t>10/27/2026</a:t>
             </a:fld>
             <a:endParaRPr lang="en-US"/>
           </a:p>
@@ -2306,10 +2110,9 @@
           <a:lstStyle/>
           <a:p>
             <a:r>
-              <a:rPr lang="en-US" smtClean="0"/>
+              <a:rPr lang="en-US"/>
               <a:t>Click to edit Master title style</a:t>
             </a:r>
-            <a:endParaRPr lang="en-US"/>
           </a:p>
         </p:txBody>
       </p:sp>
@@ -2335,38 +2138,37 @@
           <a:p>
             <a:pPr lvl="0"/>
             <a:r>
-              <a:rPr lang="en-US" smtClean="0"/>
+              <a:rPr lang="en-US"/>
               <a:t>Click to edit Master text styles</a:t>
             </a:r>
           </a:p>
           <a:p>
             <a:pPr lvl="1"/>
             <a:r>
-              <a:rPr lang="en-US" smtClean="0"/>
+              <a:rPr lang="en-US"/>
               <a:t>Second level</a:t>
             </a:r>
           </a:p>
           <a:p>
             <a:pPr lvl="2"/>
             <a:r>
-              <a:rPr lang="en-US" smtClean="0"/>
+              <a:rPr lang="en-US"/>
               <a:t>Third level</a:t>
             </a:r>
           </a:p>
           <a:p>
             <a:pPr lvl="3"/>
             <a:r>
-              <a:rPr lang="en-US" smtClean="0"/>
+              <a:rPr lang="en-US"/>
               <a:t>Fourth level</a:t>
             </a:r>
           </a:p>
           <a:p>
             <a:pPr lvl="4"/>
             <a:r>
-              <a:rPr lang="en-US" smtClean="0"/>
+              <a:rPr lang="en-US"/>
               <a:t>Fifth level</a:t>
             </a:r>
-            <a:endParaRPr lang="en-US"/>
           </a:p>
         </p:txBody>
       </p:sp>
@@ -2387,7 +2189,7 @@
           <a:p>
             <a:fld id="{5BCAD085-E8A6-8845-BD4E-CB4CCA059FC4}" type="datetimeFigureOut">
               <a:rPr lang="en-US" smtClean="0"/>
-              <a:t>1/27/13</a:t>
+              <a:t>10/27/2026</a:t>
             </a:fld>
             <a:endParaRPr lang="en-US"/>
           </a:p>
@@ -2481,10 +2283,9 @@
           <a:lstStyle/>
           <a:p>
             <a:r>
-              <a:rPr lang="en-US" smtClean="0"/>
+              <a:rPr lang="en-US"/>
               <a:t>Click to edit Master title style</a:t>
             </a:r>
-            <a:endParaRPr lang="en-US"/>
           </a:p>
         </p:txBody>
       </p:sp>
@@ -2505,38 +2306,37 @@
           <a:p>
             <a:pPr lvl="0"/>
             <a:r>
-              <a:rPr lang="en-US" smtClean="0"/>
+              <a:rPr lang="en-US"/>
               <a:t>Click to edit Master text styles</a:t>
             </a:r>
           </a:p>
           <a:p>
             <a:pPr lvl="1"/>
             <a:r>
-              <a:rPr lang="en-US" smtClean="0"/>
+              <a:rPr lang="en-US"/>
               <a:t>Second level</a:t>
             </a:r>
           </a:p>
           <a:p>
             <a:pPr lvl="2"/>
             <a:r>
-              <a:rPr lang="en-US" smtClean="0"/>
+              <a:rPr lang="en-US"/>
               <a:t>Third level</a:t>
             </a:r>
           </a:p>
           <a:p>
             <a:pPr lvl="3"/>
             <a:r>
-              <a:rPr lang="en-US" smtClean="0"/>
+              <a:rPr lang="en-US"/>
               <a:t>Fourth level</a:t>
             </a:r>
           </a:p>
           <a:p>
             <a:pPr lvl="4"/>
             <a:r>
-              <a:rPr lang="en-US" smtClean="0"/>
+              <a:rPr lang="en-US"/>
               <a:t>Fifth level</a:t>
             </a:r>
-            <a:endParaRPr lang="en-US"/>
           </a:p>
         </p:txBody>
       </p:sp>
@@ -2557,7 +2357,7 @@
           <a:p>
             <a:fld id="{5BCAD085-E8A6-8845-BD4E-CB4CCA059FC4}" type="datetimeFigureOut">
               <a:rPr lang="en-US" smtClean="0"/>
-              <a:t>1/27/13</a:t>
+              <a:t>10/27/2026</a:t>
             </a:fld>
             <a:endParaRPr lang="en-US"/>
           </a:p>
@@ -2660,10 +2460,9 @@
           </a:lstStyle>
           <a:p>
             <a:r>
-              <a:rPr lang="en-US" smtClean="0"/>
+              <a:rPr lang="en-US"/>
               <a:t>Click to edit Master title style</a:t>
             </a:r>
-            <a:endParaRPr lang="en-US"/>
           </a:p>
         </p:txBody>
       </p:sp>
@@ -2780,7 +2579,7 @@
           <a:p>
             <a:pPr lvl="0"/>
             <a:r>
-              <a:rPr lang="en-US" smtClean="0"/>
+              <a:rPr lang="en-US"/>
               <a:t>Click to edit Master text styles</a:t>
             </a:r>
           </a:p>
@@ -2803,7 +2602,7 @@
           <a:p>
             <a:fld id="{5BCAD085-E8A6-8845-BD4E-CB4CCA059FC4}" type="datetimeFigureOut">
               <a:rPr lang="en-US" smtClean="0"/>
-              <a:t>1/27/13</a:t>
+              <a:t>10/27/2026</a:t>
             </a:fld>
             <a:endParaRPr lang="en-US"/>
           </a:p>
@@ -2897,10 +2696,9 @@
           <a:lstStyle/>
           <a:p>
             <a:r>
-              <a:rPr lang="en-US" smtClean="0"/>
+              <a:rPr lang="en-US"/>
               <a:t>Click to edit Master title style</a:t>
             </a:r>
-            <a:endParaRPr lang="en-US"/>
           </a:p>
         </p:txBody>
       </p:sp>
@@ -2954,38 +2752,37 @@
           <a:p>
             <a:pPr lvl="0"/>
             <a:r>
-              <a:rPr lang="en-US" smtClean="0"/>
+              <a:rPr lang="en-US"/>
               <a:t>Click to edit Master text styles</a:t>
             </a:r>
           </a:p>
           <a:p>
             <a:pPr lvl="1"/>
             <a:r>
-              <a:rPr lang="en-US" smtClean="0"/>
+              <a:rPr lang="en-US"/>
               <a:t>Second level</a:t>
             </a:r>
           </a:p>
           <a:p>
             <a:pPr lvl="2"/>
             <a:r>
-              <a:rPr lang="en-US" smtClean="0"/>
+              <a:rPr lang="en-US"/>
               <a:t>Third level</a:t>
             </a:r>
           </a:p>
           <a:p>
             <a:pPr lvl="3"/>
             <a:r>
-              <a:rPr lang="en-US" smtClean="0"/>
+              <a:rPr lang="en-US"/>
               <a:t>Fourth level</a:t>
             </a:r>
           </a:p>
           <a:p>
             <a:pPr lvl="4"/>
             <a:r>
-              <a:rPr lang="en-US" smtClean="0"/>
+              <a:rPr lang="en-US"/>
               <a:t>Fifth level</a:t>
             </a:r>
-            <a:endParaRPr lang="en-US"/>
           </a:p>
         </p:txBody>
       </p:sp>
@@ -3039,38 +2836,37 @@
           <a:p>
             <a:pPr lvl="0"/>
             <a:r>
-              <a:rPr lang="en-US" smtClean="0"/>
+              <a:rPr lang="en-US"/>
               <a:t>Click to edit Master text styles</a:t>
             </a:r>
           </a:p>
           <a:p>
             <a:pPr lvl="1"/>
             <a:r>
-              <a:rPr lang="en-US" smtClean="0"/>
+              <a:rPr lang="en-US"/>
               <a:t>Second level</a:t>
             </a:r>
           </a:p>
           <a:p>
             <a:pPr lvl="2"/>
             <a:r>
-              <a:rPr lang="en-US" smtClean="0"/>
+              <a:rPr lang="en-US"/>
               <a:t>Third level</a:t>
             </a:r>
           </a:p>
           <a:p>
             <a:pPr lvl="3"/>
             <a:r>
-              <a:rPr lang="en-US" smtClean="0"/>
+              <a:rPr lang="en-US"/>
               <a:t>Fourth level</a:t>
             </a:r>
           </a:p>
           <a:p>
             <a:pPr lvl="4"/>
             <a:r>
-              <a:rPr lang="en-US" smtClean="0"/>
+              <a:rPr lang="en-US"/>
               <a:t>Fifth level</a:t>
             </a:r>
-            <a:endParaRPr lang="en-US"/>
           </a:p>
         </p:txBody>
       </p:sp>
@@ -3091,7 +2887,7 @@
           <a:p>
             <a:fld id="{5BCAD085-E8A6-8845-BD4E-CB4CCA059FC4}" type="datetimeFigureOut">
               <a:rPr lang="en-US" smtClean="0"/>
-              <a:t>1/27/13</a:t>
+              <a:t>10/27/2026</a:t>
             </a:fld>
             <a:endParaRPr lang="en-US"/>
           </a:p>
@@ -3189,10 +2985,9 @@
           </a:lstStyle>
           <a:p>
             <a:r>
-              <a:rPr lang="en-US" smtClean="0"/>
+              <a:rPr lang="en-US"/>
               <a:t>Click to edit Master title style</a:t>
             </a:r>
-            <a:endParaRPr lang="en-US"/>
           </a:p>
         </p:txBody>
       </p:sp>
@@ -3255,7 +3050,7 @@
           <a:p>
             <a:pPr lvl="0"/>
             <a:r>
-              <a:rPr lang="en-US" smtClean="0"/>
+              <a:rPr lang="en-US"/>
               <a:t>Click to edit Master text styles</a:t>
             </a:r>
           </a:p>
@@ -3311,38 +3106,37 @@
           <a:p>
             <a:pPr lvl="0"/>
             <a:r>
-              <a:rPr lang="en-US" smtClean="0"/>
+              <a:rPr lang="en-US"/>
               <a:t>Click to edit Master text styles</a:t>
             </a:r>
           </a:p>
           <a:p>
             <a:pPr lvl="1"/>
             <a:r>
-              <a:rPr lang="en-US" smtClean="0"/>
+              <a:rPr lang="en-US"/>
               <a:t>Second level</a:t>
             </a:r>
           </a:p>
           <a:p>
             <a:pPr lvl="2"/>
             <a:r>
-              <a:rPr lang="en-US" smtClean="0"/>
+              <a:rPr lang="en-US"/>
               <a:t>Third level</a:t>
             </a:r>
           </a:p>
           <a:p>
             <a:pPr lvl="3"/>
             <a:r>
-              <a:rPr lang="en-US" smtClean="0"/>
+              <a:rPr lang="en-US"/>
               <a:t>Fourth level</a:t>
             </a:r>
           </a:p>
           <a:p>
             <a:pPr lvl="4"/>
             <a:r>
-              <a:rPr lang="en-US" smtClean="0"/>
+              <a:rPr lang="en-US"/>
               <a:t>Fifth level</a:t>
             </a:r>
-            <a:endParaRPr lang="en-US"/>
           </a:p>
         </p:txBody>
       </p:sp>
@@ -3405,7 +3199,7 @@
           <a:p>
             <a:pPr lvl="0"/>
             <a:r>
-              <a:rPr lang="en-US" smtClean="0"/>
+              <a:rPr lang="en-US"/>
               <a:t>Click to edit Master text styles</a:t>
             </a:r>
           </a:p>
@@ -3461,38 +3255,37 @@
           <a:p>
             <a:pPr lvl="0"/>
             <a:r>
-              <a:rPr lang="en-US" smtClean="0"/>
+              <a:rPr lang="en-US"/>
               <a:t>Click to edit Master text styles</a:t>
             </a:r>
           </a:p>
           <a:p>
             <a:pPr lvl="1"/>
             <a:r>
-              <a:rPr lang="en-US" smtClean="0"/>
+              <a:rPr lang="en-US"/>
               <a:t>Second level</a:t>
             </a:r>
           </a:p>
           <a:p>
             <a:pPr lvl="2"/>
             <a:r>
-              <a:rPr lang="en-US" smtClean="0"/>
+              <a:rPr lang="en-US"/>
               <a:t>Third level</a:t>
             </a:r>
           </a:p>
           <a:p>
             <a:pPr lvl="3"/>
             <a:r>
-              <a:rPr lang="en-US" smtClean="0"/>
+              <a:rPr lang="en-US"/>
               <a:t>Fourth level</a:t>
             </a:r>
           </a:p>
           <a:p>
             <a:pPr lvl="4"/>
             <a:r>
-              <a:rPr lang="en-US" smtClean="0"/>
+              <a:rPr lang="en-US"/>
               <a:t>Fifth level</a:t>
             </a:r>
-            <a:endParaRPr lang="en-US"/>
           </a:p>
         </p:txBody>
       </p:sp>
@@ -3513,7 +3306,7 @@
           <a:p>
             <a:fld id="{5BCAD085-E8A6-8845-BD4E-CB4CCA059FC4}" type="datetimeFigureOut">
               <a:rPr lang="en-US" smtClean="0"/>
-              <a:t>1/27/13</a:t>
+              <a:t>10/27/2026</a:t>
             </a:fld>
             <a:endParaRPr lang="en-US"/>
           </a:p>
@@ -3607,10 +3400,9 @@
           <a:lstStyle/>
           <a:p>
             <a:r>
-              <a:rPr lang="en-US" smtClean="0"/>
+              <a:rPr lang="en-US"/>
               <a:t>Click to edit Master title style</a:t>
             </a:r>
-            <a:endParaRPr lang="en-US"/>
           </a:p>
         </p:txBody>
       </p:sp>
@@ -3631,7 +3423,7 @@
           <a:p>
             <a:fld id="{5BCAD085-E8A6-8845-BD4E-CB4CCA059FC4}" type="datetimeFigureOut">
               <a:rPr lang="en-US" smtClean="0"/>
-              <a:t>1/27/13</a:t>
+              <a:t>10/27/2026</a:t>
             </a:fld>
             <a:endParaRPr lang="en-US"/>
           </a:p>
@@ -3726,7 +3518,7 @@
           <a:p>
             <a:fld id="{5BCAD085-E8A6-8845-BD4E-CB4CCA059FC4}" type="datetimeFigureOut">
               <a:rPr lang="en-US" smtClean="0"/>
-              <a:t>1/27/13</a:t>
+              <a:t>10/27/2026</a:t>
             </a:fld>
             <a:endParaRPr lang="en-US"/>
           </a:p>
@@ -3829,10 +3621,9 @@
           </a:lstStyle>
           <a:p>
             <a:r>
-              <a:rPr lang="en-US" smtClean="0"/>
+              <a:rPr lang="en-US"/>
               <a:t>Click to edit Master title style</a:t>
             </a:r>
-            <a:endParaRPr lang="en-US"/>
           </a:p>
         </p:txBody>
       </p:sp>
@@ -3886,38 +3677,37 @@
           <a:p>
             <a:pPr lvl="0"/>
             <a:r>
-              <a:rPr lang="en-US" smtClean="0"/>
+              <a:rPr lang="en-US"/>
               <a:t>Click to edit Master text styles</a:t>
             </a:r>
           </a:p>
           <a:p>
             <a:pPr lvl="1"/>
             <a:r>
-              <a:rPr lang="en-US" smtClean="0"/>
+              <a:rPr lang="en-US"/>
               <a:t>Second level</a:t>
             </a:r>
           </a:p>
           <a:p>
             <a:pPr lvl="2"/>
             <a:r>
-              <a:rPr lang="en-US" smtClean="0"/>
+              <a:rPr lang="en-US"/>
               <a:t>Third level</a:t>
             </a:r>
           </a:p>
           <a:p>
             <a:pPr lvl="3"/>
             <a:r>
-              <a:rPr lang="en-US" smtClean="0"/>
+              <a:rPr lang="en-US"/>
               <a:t>Fourth level</a:t>
             </a:r>
           </a:p>
           <a:p>
             <a:pPr lvl="4"/>
             <a:r>
-              <a:rPr lang="en-US" smtClean="0"/>
+              <a:rPr lang="en-US"/>
               <a:t>Fifth level</a:t>
             </a:r>
-            <a:endParaRPr lang="en-US"/>
           </a:p>
         </p:txBody>
       </p:sp>
@@ -3980,7 +3770,7 @@
           <a:p>
             <a:pPr lvl="0"/>
             <a:r>
-              <a:rPr lang="en-US" smtClean="0"/>
+              <a:rPr lang="en-US"/>
               <a:t>Click to edit Master text styles</a:t>
             </a:r>
           </a:p>
@@ -4003,7 +3793,7 @@
           <a:p>
             <a:fld id="{5BCAD085-E8A6-8845-BD4E-CB4CCA059FC4}" type="datetimeFigureOut">
               <a:rPr lang="en-US" smtClean="0"/>
-              <a:t>1/27/13</a:t>
+              <a:t>10/27/2026</a:t>
             </a:fld>
             <a:endParaRPr lang="en-US"/>
           </a:p>
@@ -4106,10 +3896,9 @@
           </a:lstStyle>
           <a:p>
             <a:r>
-              <a:rPr lang="en-US" smtClean="0"/>
+              <a:rPr lang="en-US"/>
               <a:t>Click to edit Master title style</a:t>
             </a:r>
-            <a:endParaRPr lang="en-US"/>
           </a:p>
         </p:txBody>
       </p:sp>
@@ -4233,7 +4022,7 @@
           <a:p>
             <a:pPr lvl="0"/>
             <a:r>
-              <a:rPr lang="en-US" smtClean="0"/>
+              <a:rPr lang="en-US"/>
               <a:t>Click to edit Master text styles</a:t>
             </a:r>
           </a:p>
@@ -4256,7 +4045,7 @@
           <a:p>
             <a:fld id="{5BCAD085-E8A6-8845-BD4E-CB4CCA059FC4}" type="datetimeFigureOut">
               <a:rPr lang="en-US" smtClean="0"/>
-              <a:t>1/27/13</a:t>
+              <a:t>10/27/2026</a:t>
             </a:fld>
             <a:endParaRPr lang="en-US"/>
           </a:p>
@@ -4365,10 +4154,9 @@
           <a:lstStyle/>
           <a:p>
             <a:r>
-              <a:rPr lang="en-US" smtClean="0"/>
+              <a:rPr lang="en-US"/>
               <a:t>Click to edit Master title style</a:t>
             </a:r>
-            <a:endParaRPr lang="en-US"/>
           </a:p>
         </p:txBody>
       </p:sp>
@@ -4399,38 +4187,37 @@
           <a:p>
             <a:pPr lvl="0"/>
             <a:r>
-              <a:rPr lang="en-US" smtClean="0"/>
+              <a:rPr lang="en-US"/>
               <a:t>Click to edit Master text styles</a:t>
             </a:r>
           </a:p>
           <a:p>
             <a:pPr lvl="1"/>
             <a:r>
-              <a:rPr lang="en-US" smtClean="0"/>
+              <a:rPr lang="en-US"/>
               <a:t>Second level</a:t>
             </a:r>
           </a:p>
           <a:p>
             <a:pPr lvl="2"/>
             <a:r>
-              <a:rPr lang="en-US" smtClean="0"/>
+              <a:rPr lang="en-US"/>
               <a:t>Third level</a:t>
             </a:r>
           </a:p>
           <a:p>
             <a:pPr lvl="3"/>
             <a:r>
-              <a:rPr lang="en-US" smtClean="0"/>
+              <a:rPr lang="en-US"/>
               <a:t>Fourth level</a:t>
             </a:r>
           </a:p>
           <a:p>
             <a:pPr lvl="4"/>
             <a:r>
-              <a:rPr lang="en-US" smtClean="0"/>
+              <a:rPr lang="en-US"/>
               <a:t>Fifth level</a:t>
             </a:r>
-            <a:endParaRPr lang="en-US"/>
           </a:p>
         </p:txBody>
       </p:sp>
@@ -4469,7 +4256,7 @@
           <a:p>
             <a:fld id="{5BCAD085-E8A6-8845-BD4E-CB4CCA059FC4}" type="datetimeFigureOut">
               <a:rPr lang="en-US" smtClean="0"/>
-              <a:t>1/27/13</a:t>
+              <a:t>10/27/2026</a:t>
             </a:fld>
             <a:endParaRPr lang="en-US"/>
           </a:p>
@@ -4828,7 +4615,7 @@
 </file>
 
 <file path=ppt/slides/slide1.xml><?xml version="1.0" encoding="utf-8"?>
-<p:sld xmlns:a="http://schemas.openxmlformats.org/drawingml/2006/main" xmlns:p="http://schemas.openxmlformats.org/presentationml/2006/main" xmlns:r="http://schemas.openxmlformats.org/officeDocument/2006/relationships">
+<p:sld xmlns:a="http://schemas.openxmlformats.org/drawingml/2006/main" xmlns:r="http://schemas.openxmlformats.org/officeDocument/2006/relationships" xmlns:p="http://schemas.openxmlformats.org/presentationml/2006/main">
   <p:cSld>
     <p:bg>
       <p:bgPr>
@@ -4844,7 +4631,14 @@
         <p:cNvGrpSpPr/>
         <p:nvPr/>
       </p:nvGrpSpPr>
-      <p:grpSpPr/>
+      <p:grpSpPr>
+        <a:xfrm>
+          <a:off x="0" y="0"/>
+          <a:ext cx="0" cy="0"/>
+          <a:chOff x="0" y="0"/>
+          <a:chExt cx="0" cy="0"/>
+        </a:xfrm>
+      </p:grpSpPr>
       <p:sp>
         <p:nvSpPr>
           <p:cNvPr id="2" name="tag:L1:tag"/>
@@ -5090,6 +4884,7 @@
           <a:lstStyle/>
           <a:p>
             <a:pPr algn="ctr"/>
+            <a:endParaRPr/>
           </a:p>
         </p:txBody>
       </p:sp>
@@ -5528,7 +5323,7 @@
 </file>
 
 <file path=ppt/slides/slide10.xml><?xml version="1.0" encoding="utf-8"?>
-<p:sld xmlns:a="http://schemas.openxmlformats.org/drawingml/2006/main" xmlns:p="http://schemas.openxmlformats.org/presentationml/2006/main" xmlns:r="http://schemas.openxmlformats.org/officeDocument/2006/relationships">
+<p:sld xmlns:a="http://schemas.openxmlformats.org/drawingml/2006/main" xmlns:r="http://schemas.openxmlformats.org/officeDocument/2006/relationships" xmlns:p="http://schemas.openxmlformats.org/presentationml/2006/main">
   <p:cSld>
     <p:bg>
       <p:bgPr>
@@ -5544,7 +5339,14 @@
         <p:cNvGrpSpPr/>
         <p:nvPr/>
       </p:nvGrpSpPr>
-      <p:grpSpPr/>
+      <p:grpSpPr>
+        <a:xfrm>
+          <a:off x="0" y="0"/>
+          <a:ext cx="0" cy="0"/>
+          <a:chOff x="0" y="0"/>
+          <a:chExt cx="0" cy="0"/>
+        </a:xfrm>
+      </p:grpSpPr>
       <p:sp>
         <p:nvSpPr>
           <p:cNvPr id="2" name="tag:L1:tag"/>
@@ -5879,6 +5681,7 @@
           <a:lstStyle/>
           <a:p>
             <a:pPr algn="ctr"/>
+            <a:endParaRPr/>
           </a:p>
         </p:txBody>
       </p:sp>
@@ -5936,7 +5739,7 @@
           <p:nvPr/>
         </p:nvPicPr>
         <p:blipFill>
-          <a:blip r:embed="rId2"/>
+          <a:blip r:embed="rId3"/>
           <a:stretch>
             <a:fillRect/>
           </a:stretch>
@@ -5994,6 +5797,7 @@
           <a:lstStyle/>
           <a:p>
             <a:pPr algn="ctr"/>
+            <a:endParaRPr/>
           </a:p>
         </p:txBody>
       </p:sp>
@@ -6175,6 +5979,7 @@
           <a:lstStyle/>
           <a:p>
             <a:pPr algn="ctr"/>
+            <a:endParaRPr/>
           </a:p>
         </p:txBody>
       </p:sp>
@@ -6356,6 +6161,7 @@
           <a:lstStyle/>
           <a:p>
             <a:pPr algn="ctr"/>
+            <a:endParaRPr/>
           </a:p>
         </p:txBody>
       </p:sp>
@@ -6537,6 +6343,7 @@
           <a:lstStyle/>
           <a:p>
             <a:pPr algn="ctr"/>
+            <a:endParaRPr/>
           </a:p>
         </p:txBody>
       </p:sp>
@@ -6684,7 +6491,7 @@
 </file>
 
 <file path=ppt/slides/slide11.xml><?xml version="1.0" encoding="utf-8"?>
-<p:sld xmlns:a="http://schemas.openxmlformats.org/drawingml/2006/main" xmlns:p="http://schemas.openxmlformats.org/presentationml/2006/main" xmlns:r="http://schemas.openxmlformats.org/officeDocument/2006/relationships">
+<p:sld xmlns:a="http://schemas.openxmlformats.org/drawingml/2006/main" xmlns:r="http://schemas.openxmlformats.org/officeDocument/2006/relationships" xmlns:p="http://schemas.openxmlformats.org/presentationml/2006/main">
   <p:cSld>
     <p:bg>
       <p:bgPr>
@@ -6700,7 +6507,14 @@
         <p:cNvGrpSpPr/>
         <p:nvPr/>
       </p:nvGrpSpPr>
-      <p:grpSpPr/>
+      <p:grpSpPr>
+        <a:xfrm>
+          <a:off x="0" y="0"/>
+          <a:ext cx="0" cy="0"/>
+          <a:chOff x="0" y="0"/>
+          <a:chExt cx="0" cy="0"/>
+        </a:xfrm>
+      </p:grpSpPr>
       <p:sp>
         <p:nvSpPr>
           <p:cNvPr id="2" name="tag:L1:tag"/>
@@ -7035,6 +6849,7 @@
           <a:lstStyle/>
           <a:p>
             <a:pPr algn="ctr"/>
+            <a:endParaRPr/>
           </a:p>
         </p:txBody>
       </p:sp>
@@ -7092,7 +6907,7 @@
           <p:nvPr/>
         </p:nvPicPr>
         <p:blipFill>
-          <a:blip r:embed="rId2"/>
+          <a:blip r:embed="rId3"/>
           <a:stretch>
             <a:fillRect/>
           </a:stretch>
@@ -7150,6 +6965,7 @@
           <a:lstStyle/>
           <a:p>
             <a:pPr algn="ctr"/>
+            <a:endParaRPr/>
           </a:p>
         </p:txBody>
       </p:sp>
@@ -7342,6 +7158,7 @@
           <a:lstStyle/>
           <a:p>
             <a:pPr algn="ctr"/>
+            <a:endParaRPr/>
           </a:p>
         </p:txBody>
       </p:sp>
@@ -7534,6 +7351,7 @@
           <a:lstStyle/>
           <a:p>
             <a:pPr algn="ctr"/>
+            <a:endParaRPr/>
           </a:p>
         </p:txBody>
       </p:sp>
@@ -7726,6 +7544,7 @@
           <a:lstStyle/>
           <a:p>
             <a:pPr algn="ctr"/>
+            <a:endParaRPr/>
           </a:p>
         </p:txBody>
       </p:sp>
@@ -7827,7 +7646,7 @@
 </file>
 
 <file path=ppt/slides/slide12.xml><?xml version="1.0" encoding="utf-8"?>
-<p:sld xmlns:a="http://schemas.openxmlformats.org/drawingml/2006/main" xmlns:p="http://schemas.openxmlformats.org/presentationml/2006/main" xmlns:r="http://schemas.openxmlformats.org/officeDocument/2006/relationships">
+<p:sld xmlns:a="http://schemas.openxmlformats.org/drawingml/2006/main" xmlns:r="http://schemas.openxmlformats.org/officeDocument/2006/relationships" xmlns:p="http://schemas.openxmlformats.org/presentationml/2006/main">
   <p:cSld>
     <p:bg>
       <p:bgPr>
@@ -7843,7 +7662,14 @@
         <p:cNvGrpSpPr/>
         <p:nvPr/>
       </p:nvGrpSpPr>
-      <p:grpSpPr/>
+      <p:grpSpPr>
+        <a:xfrm>
+          <a:off x="0" y="0"/>
+          <a:ext cx="0" cy="0"/>
+          <a:chOff x="0" y="0"/>
+          <a:chExt cx="0" cy="0"/>
+        </a:xfrm>
+      </p:grpSpPr>
       <p:sp>
         <p:nvSpPr>
           <p:cNvPr id="2" name="tag:L1:tag"/>
@@ -8178,6 +8004,7 @@
           <a:lstStyle/>
           <a:p>
             <a:pPr algn="ctr"/>
+            <a:endParaRPr/>
           </a:p>
         </p:txBody>
       </p:sp>
@@ -8235,7 +8062,7 @@
           <p:nvPr/>
         </p:nvPicPr>
         <p:blipFill>
-          <a:blip r:embed="rId2"/>
+          <a:blip r:embed="rId3"/>
           <a:stretch>
             <a:fillRect/>
           </a:stretch>
@@ -8293,6 +8120,7 @@
           <a:lstStyle/>
           <a:p>
             <a:pPr algn="ctr"/>
+            <a:endParaRPr/>
           </a:p>
         </p:txBody>
       </p:sp>
@@ -8528,6 +8356,7 @@
           <a:lstStyle/>
           <a:p>
             <a:pPr algn="ctr"/>
+            <a:endParaRPr/>
           </a:p>
         </p:txBody>
       </p:sp>
@@ -8572,6 +8401,7 @@
           <a:lstStyle/>
           <a:p>
             <a:pPr algn="ctr"/>
+            <a:endParaRPr/>
           </a:p>
         </p:txBody>
       </p:sp>
@@ -8618,6 +8448,7 @@
           <a:lstStyle/>
           <a:p>
             <a:pPr algn="ctr"/>
+            <a:endParaRPr/>
           </a:p>
         </p:txBody>
       </p:sp>
@@ -8853,6 +8684,7 @@
           <a:lstStyle/>
           <a:p>
             <a:pPr algn="ctr"/>
+            <a:endParaRPr/>
           </a:p>
         </p:txBody>
       </p:sp>
@@ -8897,6 +8729,7 @@
           <a:lstStyle/>
           <a:p>
             <a:pPr algn="ctr"/>
+            <a:endParaRPr/>
           </a:p>
         </p:txBody>
       </p:sp>
@@ -8943,6 +8776,7 @@
           <a:lstStyle/>
           <a:p>
             <a:pPr algn="ctr"/>
+            <a:endParaRPr/>
           </a:p>
         </p:txBody>
       </p:sp>
@@ -9178,6 +9012,7 @@
           <a:lstStyle/>
           <a:p>
             <a:pPr algn="ctr"/>
+            <a:endParaRPr/>
           </a:p>
         </p:txBody>
       </p:sp>
@@ -9222,6 +9057,7 @@
           <a:lstStyle/>
           <a:p>
             <a:pPr algn="ctr"/>
+            <a:endParaRPr/>
           </a:p>
         </p:txBody>
       </p:sp>
@@ -9268,6 +9104,7 @@
           <a:lstStyle/>
           <a:p>
             <a:pPr algn="ctr"/>
+            <a:endParaRPr/>
           </a:p>
         </p:txBody>
       </p:sp>
@@ -9503,6 +9340,7 @@
           <a:lstStyle/>
           <a:p>
             <a:pPr algn="ctr"/>
+            <a:endParaRPr/>
           </a:p>
         </p:txBody>
       </p:sp>
@@ -9547,6 +9385,7 @@
           <a:lstStyle/>
           <a:p>
             <a:pPr algn="ctr"/>
+            <a:endParaRPr/>
           </a:p>
         </p:txBody>
       </p:sp>
@@ -9593,6 +9432,7 @@
           <a:lstStyle/>
           <a:p>
             <a:pPr algn="ctr"/>
+            <a:endParaRPr/>
           </a:p>
         </p:txBody>
       </p:sp>
@@ -9739,7 +9579,7 @@
 </file>
 
 <file path=ppt/slides/slide13.xml><?xml version="1.0" encoding="utf-8"?>
-<p:sld xmlns:a="http://schemas.openxmlformats.org/drawingml/2006/main" xmlns:p="http://schemas.openxmlformats.org/presentationml/2006/main" xmlns:r="http://schemas.openxmlformats.org/officeDocument/2006/relationships">
+<p:sld xmlns:a="http://schemas.openxmlformats.org/drawingml/2006/main" xmlns:r="http://schemas.openxmlformats.org/officeDocument/2006/relationships" xmlns:p="http://schemas.openxmlformats.org/presentationml/2006/main">
   <p:cSld>
     <p:bg>
       <p:bgPr>
@@ -9755,7 +9595,14 @@
         <p:cNvGrpSpPr/>
         <p:nvPr/>
       </p:nvGrpSpPr>
-      <p:grpSpPr/>
+      <p:grpSpPr>
+        <a:xfrm>
+          <a:off x="0" y="0"/>
+          <a:ext cx="0" cy="0"/>
+          <a:chOff x="0" y="0"/>
+          <a:chExt cx="0" cy="0"/>
+        </a:xfrm>
+      </p:grpSpPr>
       <p:sp>
         <p:nvSpPr>
           <p:cNvPr id="2" name="tag:L1:tag"/>
@@ -10090,6 +9937,7 @@
           <a:lstStyle/>
           <a:p>
             <a:pPr algn="ctr"/>
+            <a:endParaRPr/>
           </a:p>
         </p:txBody>
       </p:sp>
@@ -10147,7 +9995,7 @@
           <p:nvPr/>
         </p:nvPicPr>
         <p:blipFill>
-          <a:blip r:embed="rId2"/>
+          <a:blip r:embed="rId3"/>
           <a:stretch>
             <a:fillRect/>
           </a:stretch>
@@ -10205,6 +10053,7 @@
           <a:lstStyle/>
           <a:p>
             <a:pPr algn="ctr"/>
+            <a:endParaRPr/>
           </a:p>
         </p:txBody>
       </p:sp>
@@ -10397,6 +10246,7 @@
           <a:lstStyle/>
           <a:p>
             <a:pPr algn="ctr"/>
+            <a:endParaRPr/>
           </a:p>
         </p:txBody>
       </p:sp>
@@ -10589,6 +10439,7 @@
           <a:lstStyle/>
           <a:p>
             <a:pPr algn="ctr"/>
+            <a:endParaRPr/>
           </a:p>
         </p:txBody>
       </p:sp>
@@ -10781,6 +10632,7 @@
           <a:lstStyle/>
           <a:p>
             <a:pPr algn="ctr"/>
+            <a:endParaRPr/>
           </a:p>
         </p:txBody>
       </p:sp>
@@ -10849,7 +10701,7 @@
 </file>
 
 <file path=ppt/slides/slide14.xml><?xml version="1.0" encoding="utf-8"?>
-<p:sld xmlns:a="http://schemas.openxmlformats.org/drawingml/2006/main" xmlns:p="http://schemas.openxmlformats.org/presentationml/2006/main" xmlns:r="http://schemas.openxmlformats.org/officeDocument/2006/relationships">
+<p:sld xmlns:a="http://schemas.openxmlformats.org/drawingml/2006/main" xmlns:r="http://schemas.openxmlformats.org/officeDocument/2006/relationships" xmlns:p="http://schemas.openxmlformats.org/presentationml/2006/main">
   <p:cSld>
     <p:bg>
       <p:bgPr>
@@ -10865,7 +10717,14 @@
         <p:cNvGrpSpPr/>
         <p:nvPr/>
       </p:nvGrpSpPr>
-      <p:grpSpPr/>
+      <p:grpSpPr>
+        <a:xfrm>
+          <a:off x="0" y="0"/>
+          <a:ext cx="0" cy="0"/>
+          <a:chOff x="0" y="0"/>
+          <a:chExt cx="0" cy="0"/>
+        </a:xfrm>
+      </p:grpSpPr>
       <p:sp>
         <p:nvSpPr>
           <p:cNvPr id="2" name="tag:L1:tag"/>
@@ -11200,6 +11059,7 @@
           <a:lstStyle/>
           <a:p>
             <a:pPr algn="ctr"/>
+            <a:endParaRPr/>
           </a:p>
         </p:txBody>
       </p:sp>
@@ -11257,7 +11117,7 @@
           <p:nvPr/>
         </p:nvPicPr>
         <p:blipFill>
-          <a:blip r:embed="rId2"/>
+          <a:blip r:embed="rId3"/>
           <a:stretch>
             <a:fillRect/>
           </a:stretch>
@@ -11315,6 +11175,7 @@
           <a:lstStyle/>
           <a:p>
             <a:pPr algn="ctr"/>
+            <a:endParaRPr/>
           </a:p>
         </p:txBody>
       </p:sp>
@@ -11507,6 +11368,7 @@
           <a:lstStyle/>
           <a:p>
             <a:pPr algn="ctr"/>
+            <a:endParaRPr/>
           </a:p>
         </p:txBody>
       </p:sp>
@@ -11699,6 +11561,7 @@
           <a:lstStyle/>
           <a:p>
             <a:pPr algn="ctr"/>
+            <a:endParaRPr/>
           </a:p>
         </p:txBody>
       </p:sp>
@@ -11891,6 +11754,7 @@
           <a:lstStyle/>
           <a:p>
             <a:pPr algn="ctr"/>
+            <a:endParaRPr/>
           </a:p>
         </p:txBody>
       </p:sp>
@@ -11992,7 +11856,7 @@
 </file>
 
 <file path=ppt/slides/slide15.xml><?xml version="1.0" encoding="utf-8"?>
-<p:sld xmlns:a="http://schemas.openxmlformats.org/drawingml/2006/main" xmlns:p="http://schemas.openxmlformats.org/presentationml/2006/main" xmlns:r="http://schemas.openxmlformats.org/officeDocument/2006/relationships">
+<p:sld xmlns:a="http://schemas.openxmlformats.org/drawingml/2006/main" xmlns:r="http://schemas.openxmlformats.org/officeDocument/2006/relationships" xmlns:p="http://schemas.openxmlformats.org/presentationml/2006/main">
   <p:cSld>
     <p:bg>
       <p:bgPr>
@@ -12008,7 +11872,14 @@
         <p:cNvGrpSpPr/>
         <p:nvPr/>
       </p:nvGrpSpPr>
-      <p:grpSpPr/>
+      <p:grpSpPr>
+        <a:xfrm>
+          <a:off x="0" y="0"/>
+          <a:ext cx="0" cy="0"/>
+          <a:chOff x="0" y="0"/>
+          <a:chExt cx="0" cy="0"/>
+        </a:xfrm>
+      </p:grpSpPr>
       <p:sp>
         <p:nvSpPr>
           <p:cNvPr id="2" name="tag:L1:tag"/>
@@ -12343,6 +12214,7 @@
           <a:lstStyle/>
           <a:p>
             <a:pPr algn="ctr"/>
+            <a:endParaRPr/>
           </a:p>
         </p:txBody>
       </p:sp>
@@ -12400,7 +12272,7 @@
           <p:nvPr/>
         </p:nvPicPr>
         <p:blipFill>
-          <a:blip r:embed="rId2"/>
+          <a:blip r:embed="rId3"/>
           <a:stretch>
             <a:fillRect/>
           </a:stretch>
@@ -12458,6 +12330,7 @@
           <a:lstStyle/>
           <a:p>
             <a:pPr algn="ctr"/>
+            <a:endParaRPr/>
           </a:p>
         </p:txBody>
       </p:sp>
@@ -12650,6 +12523,7 @@
           <a:lstStyle/>
           <a:p>
             <a:pPr algn="ctr"/>
+            <a:endParaRPr/>
           </a:p>
         </p:txBody>
       </p:sp>
@@ -12842,6 +12716,7 @@
           <a:lstStyle/>
           <a:p>
             <a:pPr algn="ctr"/>
+            <a:endParaRPr/>
           </a:p>
         </p:txBody>
       </p:sp>
@@ -13034,6 +12909,7 @@
           <a:lstStyle/>
           <a:p>
             <a:pPr algn="ctr"/>
+            <a:endParaRPr/>
           </a:p>
         </p:txBody>
       </p:sp>
@@ -13135,7 +13011,7 @@
 </file>
 
 <file path=ppt/slides/slide16.xml><?xml version="1.0" encoding="utf-8"?>
-<p:sld xmlns:a="http://schemas.openxmlformats.org/drawingml/2006/main" xmlns:p="http://schemas.openxmlformats.org/presentationml/2006/main" xmlns:r="http://schemas.openxmlformats.org/officeDocument/2006/relationships">
+<p:sld xmlns:a="http://schemas.openxmlformats.org/drawingml/2006/main" xmlns:r="http://schemas.openxmlformats.org/officeDocument/2006/relationships" xmlns:p="http://schemas.openxmlformats.org/presentationml/2006/main">
   <p:cSld>
     <p:bg>
       <p:bgPr>
@@ -13151,7 +13027,14 @@
         <p:cNvGrpSpPr/>
         <p:nvPr/>
       </p:nvGrpSpPr>
-      <p:grpSpPr/>
+      <p:grpSpPr>
+        <a:xfrm>
+          <a:off x="0" y="0"/>
+          <a:ext cx="0" cy="0"/>
+          <a:chOff x="0" y="0"/>
+          <a:chExt cx="0" cy="0"/>
+        </a:xfrm>
+      </p:grpSpPr>
       <p:sp>
         <p:nvSpPr>
           <p:cNvPr id="2" name="tag:L1:tag"/>
@@ -13486,6 +13369,7 @@
           <a:lstStyle/>
           <a:p>
             <a:pPr algn="ctr"/>
+            <a:endParaRPr/>
           </a:p>
         </p:txBody>
       </p:sp>
@@ -13588,7 +13472,7 @@
           <p:nvPr/>
         </p:nvPicPr>
         <p:blipFill>
-          <a:blip r:embed="rId2"/>
+          <a:blip r:embed="rId3"/>
           <a:stretch>
             <a:fillRect/>
           </a:stretch>
@@ -13757,6 +13641,7 @@
           <a:lstStyle/>
           <a:p>
             <a:pPr algn="ctr"/>
+            <a:endParaRPr/>
           </a:p>
         </p:txBody>
       </p:sp>
@@ -13893,6 +13778,7 @@
           <a:lstStyle/>
           <a:p>
             <a:pPr algn="ctr"/>
+            <a:endParaRPr/>
           </a:p>
         </p:txBody>
       </p:sp>
@@ -14050,6 +13936,7 @@
           <a:lstStyle/>
           <a:p>
             <a:pPr algn="ctr"/>
+            <a:endParaRPr/>
           </a:p>
         </p:txBody>
       </p:sp>
@@ -14242,6 +14129,7 @@
           <a:lstStyle/>
           <a:p>
             <a:pPr algn="ctr"/>
+            <a:endParaRPr/>
           </a:p>
         </p:txBody>
       </p:sp>
@@ -14479,7 +14367,7 @@
           </a:bodyPr>
           <a:lstStyle/>
           <a:p>
-            <a:pPr algn="l" marL="164592" indent="-164592">
+            <a:pPr marL="164592" indent="-164592" algn="l">
               <a:lnSpc>
                 <a:spcPts val="1610"/>
               </a:lnSpc>
@@ -14505,7 +14393,7 @@
             </a:r>
           </a:p>
           <a:p>
-            <a:pPr algn="l" marL="164592" indent="-164592">
+            <a:pPr marL="164592" indent="-164592" algn="l">
               <a:lnSpc>
                 <a:spcPts val="1610"/>
               </a:lnSpc>
@@ -14575,6 +14463,7 @@
           <a:lstStyle/>
           <a:p>
             <a:pPr algn="ctr"/>
+            <a:endParaRPr/>
           </a:p>
         </p:txBody>
       </p:sp>
@@ -14674,18 +14563,7 @@
                 <a:ea typeface="맑은 고딕"/>
                 <a:cs typeface="맑은 고딕"/>
               </a:rPr>
-              <a:t>해상도를 높여 </a:t>
-            </a:r>
-            <a:r>
-              <a:rPr lang="ko-KR" sz="1500" b="1" dirty="0">
-                <a:solidFill>
-                  <a:srgbClr val="2563EB"/>
-                </a:solidFill>
-                <a:latin typeface="맑은 고딕"/>
-                <a:ea typeface="맑은 고딕"/>
-                <a:cs typeface="맑은 고딕"/>
-              </a:rPr>
-              <a:t>실사 대기 적체(WIP) 부담</a:t>
+              <a:t>해상도를 높여 실사 대기 적체(WIP) 부담</a:t>
             </a:r>
             <a:r>
               <a:rPr lang="ko-KR" sz="1500" b="0" dirty="0">
@@ -14710,7 +14588,7 @@
 </file>
 
 <file path=ppt/slides/slide17.xml><?xml version="1.0" encoding="utf-8"?>
-<p:sld xmlns:a="http://schemas.openxmlformats.org/drawingml/2006/main" xmlns:p="http://schemas.openxmlformats.org/presentationml/2006/main" xmlns:r="http://schemas.openxmlformats.org/officeDocument/2006/relationships">
+<p:sld xmlns:a="http://schemas.openxmlformats.org/drawingml/2006/main" xmlns:r="http://schemas.openxmlformats.org/officeDocument/2006/relationships" xmlns:p="http://schemas.openxmlformats.org/presentationml/2006/main">
   <p:cSld>
     <p:bg>
       <p:bgPr>
@@ -14726,7 +14604,14 @@
         <p:cNvGrpSpPr/>
         <p:nvPr/>
       </p:nvGrpSpPr>
-      <p:grpSpPr/>
+      <p:grpSpPr>
+        <a:xfrm>
+          <a:off x="0" y="0"/>
+          <a:ext cx="0" cy="0"/>
+          <a:chOff x="0" y="0"/>
+          <a:chExt cx="0" cy="0"/>
+        </a:xfrm>
+      </p:grpSpPr>
       <p:sp>
         <p:nvSpPr>
           <p:cNvPr id="2" name="tag:L1:tag"/>
@@ -15061,6 +14946,7 @@
           <a:lstStyle/>
           <a:p>
             <a:pPr algn="ctr"/>
+            <a:endParaRPr/>
           </a:p>
         </p:txBody>
       </p:sp>
@@ -16201,6 +16087,7 @@
           <a:lstStyle/>
           <a:p>
             <a:pPr algn="ctr"/>
+            <a:endParaRPr/>
           </a:p>
         </p:txBody>
       </p:sp>
@@ -16414,6 +16301,7 @@
           <a:lstStyle/>
           <a:p>
             <a:pPr algn="ctr"/>
+            <a:endParaRPr/>
           </a:p>
         </p:txBody>
       </p:sp>
@@ -16484,7 +16372,7 @@
           </a:bodyPr>
           <a:lstStyle/>
           <a:p>
-            <a:pPr algn="l" marL="164592" indent="-164592">
+            <a:pPr marL="164592" indent="-164592" algn="l">
               <a:lnSpc>
                 <a:spcPts val="1610"/>
               </a:lnSpc>
@@ -16564,7 +16452,7 @@
             </a:r>
           </a:p>
           <a:p>
-            <a:pPr algn="l" marL="164592" indent="-164592">
+            <a:pPr marL="164592" indent="-164592" algn="l">
               <a:lnSpc>
                 <a:spcPts val="1610"/>
               </a:lnSpc>
@@ -16622,7 +16510,7 @@
             </a:r>
           </a:p>
           <a:p>
-            <a:pPr algn="l" marL="164592" indent="-164592">
+            <a:pPr marL="164592" indent="-164592" algn="l">
               <a:lnSpc>
                 <a:spcPts val="1610"/>
               </a:lnSpc>
@@ -16703,6 +16591,7 @@
           <a:lstStyle/>
           <a:p>
             <a:pPr algn="ctr"/>
+            <a:endParaRPr/>
           </a:p>
         </p:txBody>
       </p:sp>
@@ -17049,7 +16938,7 @@
 </file>
 
 <file path=ppt/slides/slide18.xml><?xml version="1.0" encoding="utf-8"?>
-<p:sld xmlns:a="http://schemas.openxmlformats.org/drawingml/2006/main" xmlns:p="http://schemas.openxmlformats.org/presentationml/2006/main" xmlns:r="http://schemas.openxmlformats.org/officeDocument/2006/relationships">
+<p:sld xmlns:a="http://schemas.openxmlformats.org/drawingml/2006/main" xmlns:r="http://schemas.openxmlformats.org/officeDocument/2006/relationships" xmlns:p="http://schemas.openxmlformats.org/presentationml/2006/main">
   <p:cSld>
     <p:bg>
       <p:bgPr>
@@ -17065,7 +16954,14 @@
         <p:cNvGrpSpPr/>
         <p:nvPr/>
       </p:nvGrpSpPr>
-      <p:grpSpPr/>
+      <p:grpSpPr>
+        <a:xfrm>
+          <a:off x="0" y="0"/>
+          <a:ext cx="0" cy="0"/>
+          <a:chOff x="0" y="0"/>
+          <a:chExt cx="0" cy="0"/>
+        </a:xfrm>
+      </p:grpSpPr>
       <p:sp>
         <p:nvSpPr>
           <p:cNvPr id="2" name="tag:L1:tag"/>
@@ -17422,6 +17318,7 @@
           <a:lstStyle/>
           <a:p>
             <a:pPr algn="ctr"/>
+            <a:endParaRPr/>
           </a:p>
         </p:txBody>
       </p:sp>
@@ -17556,6 +17453,7 @@
           <a:lstStyle/>
           <a:p>
             <a:pPr algn="ctr"/>
+            <a:endParaRPr/>
           </a:p>
         </p:txBody>
       </p:sp>
@@ -17690,6 +17588,7 @@
           <a:lstStyle/>
           <a:p>
             <a:pPr algn="ctr"/>
+            <a:endParaRPr/>
           </a:p>
         </p:txBody>
       </p:sp>
@@ -18202,6 +18101,7 @@
           <a:lstStyle/>
           <a:p>
             <a:pPr algn="ctr"/>
+            <a:endParaRPr/>
           </a:p>
         </p:txBody>
       </p:sp>
@@ -18539,6 +18439,7 @@
           <a:lstStyle/>
           <a:p>
             <a:pPr algn="ctr"/>
+            <a:endParaRPr/>
           </a:p>
         </p:txBody>
       </p:sp>
@@ -18950,7 +18851,7 @@
 </file>
 
 <file path=ppt/slides/slide19.xml><?xml version="1.0" encoding="utf-8"?>
-<p:sld xmlns:a="http://schemas.openxmlformats.org/drawingml/2006/main" xmlns:p="http://schemas.openxmlformats.org/presentationml/2006/main" xmlns:r="http://schemas.openxmlformats.org/officeDocument/2006/relationships">
+<p:sld xmlns:a="http://schemas.openxmlformats.org/drawingml/2006/main" xmlns:r="http://schemas.openxmlformats.org/officeDocument/2006/relationships" xmlns:p="http://schemas.openxmlformats.org/presentationml/2006/main">
   <p:cSld>
     <p:bg>
       <p:bgPr>
@@ -18966,7 +18867,14 @@
         <p:cNvGrpSpPr/>
         <p:nvPr/>
       </p:nvGrpSpPr>
-      <p:grpSpPr/>
+      <p:grpSpPr>
+        <a:xfrm>
+          <a:off x="0" y="0"/>
+          <a:ext cx="0" cy="0"/>
+          <a:chOff x="0" y="0"/>
+          <a:chExt cx="0" cy="0"/>
+        </a:xfrm>
+      </p:grpSpPr>
       <p:sp>
         <p:nvSpPr>
           <p:cNvPr id="2" name="tag:L1:tag"/>
@@ -19256,6 +19164,7 @@
           <a:lstStyle/>
           <a:p>
             <a:pPr algn="ctr"/>
+            <a:endParaRPr/>
           </a:p>
         </p:txBody>
       </p:sp>
@@ -19437,6 +19346,7 @@
           <a:lstStyle/>
           <a:p>
             <a:pPr algn="ctr"/>
+            <a:endParaRPr/>
           </a:p>
         </p:txBody>
       </p:sp>
@@ -19618,6 +19528,7 @@
           <a:lstStyle/>
           <a:p>
             <a:pPr algn="ctr"/>
+            <a:endParaRPr/>
           </a:p>
         </p:txBody>
       </p:sp>
@@ -19799,6 +19710,7 @@
           <a:lstStyle/>
           <a:p>
             <a:pPr algn="ctr"/>
+            <a:endParaRPr/>
           </a:p>
         </p:txBody>
       </p:sp>
@@ -20079,7 +19991,7 @@
 </file>
 
 <file path=ppt/slides/slide2.xml><?xml version="1.0" encoding="utf-8"?>
-<p:sld xmlns:a="http://schemas.openxmlformats.org/drawingml/2006/main" xmlns:p="http://schemas.openxmlformats.org/presentationml/2006/main" xmlns:r="http://schemas.openxmlformats.org/officeDocument/2006/relationships">
+<p:sld xmlns:a="http://schemas.openxmlformats.org/drawingml/2006/main" xmlns:r="http://schemas.openxmlformats.org/officeDocument/2006/relationships" xmlns:p="http://schemas.openxmlformats.org/presentationml/2006/main">
   <p:cSld>
     <p:bg>
       <p:bgPr>
@@ -20095,7 +20007,14 @@
         <p:cNvGrpSpPr/>
         <p:nvPr/>
       </p:nvGrpSpPr>
-      <p:grpSpPr/>
+      <p:grpSpPr>
+        <a:xfrm>
+          <a:off x="0" y="0"/>
+          <a:ext cx="0" cy="0"/>
+          <a:chOff x="0" y="0"/>
+          <a:chExt cx="0" cy="0"/>
+        </a:xfrm>
+      </p:grpSpPr>
       <p:sp>
         <p:nvSpPr>
           <p:cNvPr id="2" name="tag:L1:tag"/>
@@ -20345,7 +20264,7 @@
       <p:sp>
         <p:nvSpPr>
           <p:cNvPr id="8" name="tile-01">
-            <a:hlinkClick action="ppaction://hlinksldjump" r:id="rId3"/>
+            <a:hlinkClick r:id="rId3" action="ppaction://hlinksldjump"/>
           </p:cNvPr>
           <p:cNvSpPr/>
           <p:nvPr/>
@@ -20387,6 +20306,7 @@
           <a:lstStyle/>
           <a:p>
             <a:pPr algn="ctr"/>
+            <a:endParaRPr/>
           </a:p>
         </p:txBody>
       </p:sp>
@@ -20476,6 +20396,7 @@
           <a:lstStyle/>
           <a:p>
             <a:pPr algn="ctr"/>
+            <a:endParaRPr/>
           </a:p>
         </p:txBody>
       </p:sp>
@@ -20591,7 +20512,7 @@
           </a:bodyPr>
           <a:lstStyle/>
           <a:p>
-            <a:pPr algn="l" marL="164592" indent="-164592">
+            <a:pPr marL="164592" indent="-164592" algn="l">
               <a:lnSpc>
                 <a:spcPts val="1610"/>
               </a:lnSpc>
@@ -20638,7 +20559,7 @@
             </a:r>
           </a:p>
           <a:p>
-            <a:pPr algn="l" marL="164592" indent="-164592">
+            <a:pPr marL="164592" indent="-164592" algn="l">
               <a:lnSpc>
                 <a:spcPts val="1610"/>
               </a:lnSpc>
@@ -20664,7 +20585,7 @@
             </a:r>
           </a:p>
           <a:p>
-            <a:pPr algn="l" marL="164592" indent="-164592">
+            <a:pPr marL="164592" indent="-164592" algn="l">
               <a:lnSpc>
                 <a:spcPts val="1610"/>
               </a:lnSpc>
@@ -20782,7 +20703,7 @@
       <p:sp>
         <p:nvSpPr>
           <p:cNvPr id="15" name="tile-02">
-            <a:hlinkClick action="ppaction://hlinksldjump" r:id="rId4"/>
+            <a:hlinkClick r:id="rId4" action="ppaction://hlinksldjump"/>
           </p:cNvPr>
           <p:cNvSpPr/>
           <p:nvPr/>
@@ -20824,6 +20745,7 @@
           <a:lstStyle/>
           <a:p>
             <a:pPr algn="ctr"/>
+            <a:endParaRPr/>
           </a:p>
         </p:txBody>
       </p:sp>
@@ -20913,6 +20835,7 @@
           <a:lstStyle/>
           <a:p>
             <a:pPr algn="ctr"/>
+            <a:endParaRPr/>
           </a:p>
         </p:txBody>
       </p:sp>
@@ -21028,7 +20951,7 @@
           </a:bodyPr>
           <a:lstStyle/>
           <a:p>
-            <a:pPr algn="l" marL="164592" indent="-164592">
+            <a:pPr marL="164592" indent="-164592" algn="l">
               <a:lnSpc>
                 <a:spcPts val="1610"/>
               </a:lnSpc>
@@ -21054,7 +20977,7 @@
             </a:r>
           </a:p>
           <a:p>
-            <a:pPr algn="l" marL="164592" indent="-164592">
+            <a:pPr marL="164592" indent="-164592" algn="l">
               <a:lnSpc>
                 <a:spcPts val="1610"/>
               </a:lnSpc>
@@ -21080,7 +21003,7 @@
             </a:r>
           </a:p>
           <a:p>
-            <a:pPr algn="l" marL="164592" indent="-164592">
+            <a:pPr marL="164592" indent="-164592" algn="l">
               <a:lnSpc>
                 <a:spcPts val="1610"/>
               </a:lnSpc>
@@ -21106,7 +21029,7 @@
             </a:r>
           </a:p>
           <a:p>
-            <a:pPr algn="l" marL="164592" indent="-164592">
+            <a:pPr marL="164592" indent="-164592" algn="l">
               <a:lnSpc>
                 <a:spcPts val="1610"/>
               </a:lnSpc>
@@ -21224,7 +21147,7 @@
       <p:sp>
         <p:nvSpPr>
           <p:cNvPr id="22" name="tile-03">
-            <a:hlinkClick action="ppaction://hlinksldjump" r:id="rId5"/>
+            <a:hlinkClick r:id="rId5" action="ppaction://hlinksldjump"/>
           </p:cNvPr>
           <p:cNvSpPr/>
           <p:nvPr/>
@@ -21266,6 +21189,7 @@
           <a:lstStyle/>
           <a:p>
             <a:pPr algn="ctr"/>
+            <a:endParaRPr/>
           </a:p>
         </p:txBody>
       </p:sp>
@@ -21355,6 +21279,7 @@
           <a:lstStyle/>
           <a:p>
             <a:pPr algn="ctr"/>
+            <a:endParaRPr/>
           </a:p>
         </p:txBody>
       </p:sp>
@@ -21470,7 +21395,7 @@
           </a:bodyPr>
           <a:lstStyle/>
           <a:p>
-            <a:pPr algn="l" marL="164592" indent="-164592">
+            <a:pPr marL="164592" indent="-164592" algn="l">
               <a:lnSpc>
                 <a:spcPts val="1610"/>
               </a:lnSpc>
@@ -21538,7 +21463,7 @@
             </a:r>
           </a:p>
           <a:p>
-            <a:pPr algn="l" marL="164592" indent="-164592">
+            <a:pPr marL="164592" indent="-164592" algn="l">
               <a:lnSpc>
                 <a:spcPts val="1610"/>
               </a:lnSpc>
@@ -21585,7 +21510,7 @@
             </a:r>
           </a:p>
           <a:p>
-            <a:pPr algn="l" marL="164592" indent="-164592">
+            <a:pPr marL="164592" indent="-164592" algn="l">
               <a:lnSpc>
                 <a:spcPts val="1610"/>
               </a:lnSpc>
@@ -21682,7 +21607,7 @@
       <p:sp>
         <p:nvSpPr>
           <p:cNvPr id="29" name="tile-04">
-            <a:hlinkClick action="ppaction://hlinksldjump" r:id="rId6"/>
+            <a:hlinkClick r:id="rId6" action="ppaction://hlinksldjump"/>
           </p:cNvPr>
           <p:cNvSpPr/>
           <p:nvPr/>
@@ -21724,6 +21649,7 @@
           <a:lstStyle/>
           <a:p>
             <a:pPr algn="ctr"/>
+            <a:endParaRPr/>
           </a:p>
         </p:txBody>
       </p:sp>
@@ -21813,6 +21739,7 @@
           <a:lstStyle/>
           <a:p>
             <a:pPr algn="ctr"/>
+            <a:endParaRPr/>
           </a:p>
         </p:txBody>
       </p:sp>
@@ -21928,7 +21855,7 @@
           </a:bodyPr>
           <a:lstStyle/>
           <a:p>
-            <a:pPr algn="l" marL="164592" indent="-164592">
+            <a:pPr marL="164592" indent="-164592" algn="l">
               <a:lnSpc>
                 <a:spcPts val="1610"/>
               </a:lnSpc>
@@ -22009,7 +21936,7 @@
 </file>
 
 <file path=ppt/slides/slide3.xml><?xml version="1.0" encoding="utf-8"?>
-<p:sld xmlns:a="http://schemas.openxmlformats.org/drawingml/2006/main" xmlns:p="http://schemas.openxmlformats.org/presentationml/2006/main" xmlns:r="http://schemas.openxmlformats.org/officeDocument/2006/relationships">
+<p:sld xmlns:a="http://schemas.openxmlformats.org/drawingml/2006/main" xmlns:r="http://schemas.openxmlformats.org/officeDocument/2006/relationships" xmlns:p="http://schemas.openxmlformats.org/presentationml/2006/main">
   <p:cSld>
     <p:bg>
       <p:bgPr>
@@ -22025,7 +21952,14 @@
         <p:cNvGrpSpPr/>
         <p:nvPr/>
       </p:nvGrpSpPr>
-      <p:grpSpPr/>
+      <p:grpSpPr>
+        <a:xfrm>
+          <a:off x="0" y="0"/>
+          <a:ext cx="0" cy="0"/>
+          <a:chOff x="0" y="0"/>
+          <a:chExt cx="0" cy="0"/>
+        </a:xfrm>
+      </p:grpSpPr>
       <p:sp>
         <p:nvSpPr>
           <p:cNvPr id="2" name="tag:L1:tag"/>
@@ -22315,6 +22249,7 @@
           <a:lstStyle/>
           <a:p>
             <a:pPr algn="ctr"/>
+            <a:endParaRPr/>
           </a:p>
         </p:txBody>
       </p:sp>
@@ -22495,6 +22430,7 @@
           <a:lstStyle/>
           <a:p>
             <a:pPr algn="ctr"/>
+            <a:endParaRPr/>
           </a:p>
         </p:txBody>
       </p:sp>
@@ -22666,7 +22602,7 @@
           </a:bodyPr>
           <a:lstStyle/>
           <a:p>
-            <a:pPr algn="l" marL="164592" indent="-164592">
+            <a:pPr marL="164592" indent="-164592" algn="l">
               <a:lnSpc>
                 <a:spcPts val="1680"/>
               </a:lnSpc>
@@ -22692,7 +22628,7 @@
             </a:r>
           </a:p>
           <a:p>
-            <a:pPr algn="l" marL="164592" indent="-164592">
+            <a:pPr marL="164592" indent="-164592" algn="l">
               <a:lnSpc>
                 <a:spcPts val="1680"/>
               </a:lnSpc>
@@ -22739,7 +22675,7 @@
             </a:r>
           </a:p>
           <a:p>
-            <a:pPr algn="l" marL="164592" indent="-164592">
+            <a:pPr marL="164592" indent="-164592" algn="l">
               <a:lnSpc>
                 <a:spcPts val="1680"/>
               </a:lnSpc>
@@ -22875,6 +22811,7 @@
           <a:lstStyle/>
           <a:p>
             <a:pPr algn="ctr"/>
+            <a:endParaRPr/>
           </a:p>
         </p:txBody>
       </p:sp>
@@ -23046,7 +22983,7 @@
           </a:bodyPr>
           <a:lstStyle/>
           <a:p>
-            <a:pPr algn="l" marL="164592" indent="-164592">
+            <a:pPr marL="164592" indent="-164592" algn="l">
               <a:lnSpc>
                 <a:spcPts val="1680"/>
               </a:lnSpc>
@@ -23093,7 +23030,7 @@
             </a:r>
           </a:p>
           <a:p>
-            <a:pPr algn="l" marL="164592" indent="-164592">
+            <a:pPr marL="164592" indent="-164592" algn="l">
               <a:lnSpc>
                 <a:spcPts val="1680"/>
               </a:lnSpc>
@@ -23119,7 +23056,7 @@
             </a:r>
           </a:p>
           <a:p>
-            <a:pPr algn="l" marL="164592" indent="-164592">
+            <a:pPr marL="164592" indent="-164592" algn="l">
               <a:lnSpc>
                 <a:spcPts val="1680"/>
               </a:lnSpc>
@@ -23255,6 +23192,7 @@
           <a:lstStyle/>
           <a:p>
             <a:pPr algn="ctr"/>
+            <a:endParaRPr/>
           </a:p>
         </p:txBody>
       </p:sp>
@@ -23437,7 +23375,7 @@
           </a:bodyPr>
           <a:lstStyle/>
           <a:p>
-            <a:pPr algn="l" marL="164592" indent="-164592">
+            <a:pPr marL="164592" indent="-164592" algn="l">
               <a:lnSpc>
                 <a:spcPts val="1680"/>
               </a:lnSpc>
@@ -23484,7 +23422,7 @@
             </a:r>
           </a:p>
           <a:p>
-            <a:pPr algn="l" marL="164592" indent="-164592">
+            <a:pPr marL="164592" indent="-164592" algn="l">
               <a:lnSpc>
                 <a:spcPts val="1680"/>
               </a:lnSpc>
@@ -23510,7 +23448,7 @@
             </a:r>
           </a:p>
           <a:p>
-            <a:pPr algn="l" marL="164592" indent="-164592">
+            <a:pPr marL="164592" indent="-164592" algn="l">
               <a:lnSpc>
                 <a:spcPts val="1680"/>
               </a:lnSpc>
@@ -23612,7 +23550,7 @@
 </file>
 
 <file path=ppt/slides/slide4.xml><?xml version="1.0" encoding="utf-8"?>
-<p:sld xmlns:a="http://schemas.openxmlformats.org/drawingml/2006/main" xmlns:p="http://schemas.openxmlformats.org/presentationml/2006/main" xmlns:r="http://schemas.openxmlformats.org/officeDocument/2006/relationships">
+<p:sld xmlns:a="http://schemas.openxmlformats.org/drawingml/2006/main" xmlns:r="http://schemas.openxmlformats.org/officeDocument/2006/relationships" xmlns:p="http://schemas.openxmlformats.org/presentationml/2006/main">
   <p:cSld>
     <p:bg>
       <p:bgPr>
@@ -23628,7 +23566,14 @@
         <p:cNvGrpSpPr/>
         <p:nvPr/>
       </p:nvGrpSpPr>
-      <p:grpSpPr/>
+      <p:grpSpPr>
+        <a:xfrm>
+          <a:off x="0" y="0"/>
+          <a:ext cx="0" cy="0"/>
+          <a:chOff x="0" y="0"/>
+          <a:chExt cx="0" cy="0"/>
+        </a:xfrm>
+      </p:grpSpPr>
       <p:sp>
         <p:nvSpPr>
           <p:cNvPr id="2" name="tag:L1:tag"/>
@@ -23963,6 +23908,7 @@
           <a:lstStyle/>
           <a:p>
             <a:pPr algn="ctr"/>
+            <a:endParaRPr/>
           </a:p>
         </p:txBody>
       </p:sp>
@@ -24020,7 +23966,7 @@
           <p:nvPr/>
         </p:nvPicPr>
         <p:blipFill>
-          <a:blip r:embed="rId2"/>
+          <a:blip r:embed="rId3"/>
           <a:stretch>
             <a:fillRect/>
           </a:stretch>
@@ -24078,6 +24024,7 @@
           <a:lstStyle/>
           <a:p>
             <a:pPr algn="ctr"/>
+            <a:endParaRPr/>
           </a:p>
         </p:txBody>
       </p:sp>
@@ -24225,6 +24172,7 @@
           <a:lstStyle/>
           <a:p>
             <a:pPr algn="ctr"/>
+            <a:endParaRPr/>
           </a:p>
         </p:txBody>
       </p:sp>
@@ -24372,6 +24320,7 @@
           <a:lstStyle/>
           <a:p>
             <a:pPr algn="ctr"/>
+            <a:endParaRPr/>
           </a:p>
         </p:txBody>
       </p:sp>
@@ -24519,6 +24468,7 @@
           <a:lstStyle/>
           <a:p>
             <a:pPr algn="ctr"/>
+            <a:endParaRPr/>
           </a:p>
         </p:txBody>
       </p:sp>
@@ -24700,6 +24650,7 @@
           <a:lstStyle/>
           <a:p>
             <a:pPr algn="ctr"/>
+            <a:endParaRPr/>
           </a:p>
         </p:txBody>
       </p:sp>
@@ -24881,6 +24832,7 @@
           <a:lstStyle/>
           <a:p>
             <a:pPr algn="ctr"/>
+            <a:endParaRPr/>
           </a:p>
         </p:txBody>
       </p:sp>
@@ -25028,7 +24980,7 @@
 </file>
 
 <file path=ppt/slides/slide5.xml><?xml version="1.0" encoding="utf-8"?>
-<p:sld xmlns:a="http://schemas.openxmlformats.org/drawingml/2006/main" xmlns:p="http://schemas.openxmlformats.org/presentationml/2006/main" xmlns:r="http://schemas.openxmlformats.org/officeDocument/2006/relationships">
+<p:sld xmlns:a="http://schemas.openxmlformats.org/drawingml/2006/main" xmlns:r="http://schemas.openxmlformats.org/officeDocument/2006/relationships" xmlns:p="http://schemas.openxmlformats.org/presentationml/2006/main">
   <p:cSld>
     <p:bg>
       <p:bgPr>
@@ -25044,7 +24996,14 @@
         <p:cNvGrpSpPr/>
         <p:nvPr/>
       </p:nvGrpSpPr>
-      <p:grpSpPr/>
+      <p:grpSpPr>
+        <a:xfrm>
+          <a:off x="0" y="0"/>
+          <a:ext cx="0" cy="0"/>
+          <a:chOff x="0" y="0"/>
+          <a:chExt cx="0" cy="0"/>
+        </a:xfrm>
+      </p:grpSpPr>
       <p:sp>
         <p:nvSpPr>
           <p:cNvPr id="2" name="tag:L1:tag"/>
@@ -25424,6 +25383,7 @@
           <a:lstStyle/>
           <a:p>
             <a:pPr algn="ctr"/>
+            <a:endParaRPr/>
           </a:p>
         </p:txBody>
       </p:sp>
@@ -26849,6 +26809,7 @@
           <a:lstStyle/>
           <a:p>
             <a:pPr algn="ctr"/>
+            <a:endParaRPr/>
           </a:p>
         </p:txBody>
       </p:sp>
@@ -27041,6 +27002,7 @@
           <a:lstStyle/>
           <a:p>
             <a:pPr algn="ctr"/>
+            <a:endParaRPr/>
           </a:p>
         </p:txBody>
       </p:sp>
@@ -27233,6 +27195,7 @@
           <a:lstStyle/>
           <a:p>
             <a:pPr algn="ctr"/>
+            <a:endParaRPr/>
           </a:p>
         </p:txBody>
       </p:sp>
@@ -27391,7 +27354,7 @@
 </file>
 
 <file path=ppt/slides/slide6.xml><?xml version="1.0" encoding="utf-8"?>
-<p:sld xmlns:a="http://schemas.openxmlformats.org/drawingml/2006/main" xmlns:p="http://schemas.openxmlformats.org/presentationml/2006/main" xmlns:r="http://schemas.openxmlformats.org/officeDocument/2006/relationships">
+<p:sld xmlns:a="http://schemas.openxmlformats.org/drawingml/2006/main" xmlns:r="http://schemas.openxmlformats.org/officeDocument/2006/relationships" xmlns:p="http://schemas.openxmlformats.org/presentationml/2006/main">
   <p:cSld>
     <p:bg>
       <p:bgPr>
@@ -27407,7 +27370,14 @@
         <p:cNvGrpSpPr/>
         <p:nvPr/>
       </p:nvGrpSpPr>
-      <p:grpSpPr/>
+      <p:grpSpPr>
+        <a:xfrm>
+          <a:off x="0" y="0"/>
+          <a:ext cx="0" cy="0"/>
+          <a:chOff x="0" y="0"/>
+          <a:chExt cx="0" cy="0"/>
+        </a:xfrm>
+      </p:grpSpPr>
       <p:sp>
         <p:nvSpPr>
           <p:cNvPr id="2" name="tag:L1:tag"/>
@@ -27697,6 +27667,7 @@
           <a:lstStyle/>
           <a:p>
             <a:pPr algn="ctr"/>
+            <a:endParaRPr/>
           </a:p>
         </p:txBody>
       </p:sp>
@@ -28969,6 +28940,7 @@
           <a:lstStyle/>
           <a:p>
             <a:pPr algn="ctr"/>
+            <a:endParaRPr/>
           </a:p>
         </p:txBody>
       </p:sp>
@@ -29251,6 +29223,7 @@
           <a:lstStyle/>
           <a:p>
             <a:pPr algn="ctr"/>
+            <a:endParaRPr/>
           </a:p>
         </p:txBody>
       </p:sp>
@@ -29467,7 +29440,7 @@
           </a:bodyPr>
           <a:lstStyle/>
           <a:p>
-            <a:pPr algn="l" marL="164592" indent="-164592">
+            <a:pPr marL="164592" indent="-164592" algn="l">
               <a:lnSpc>
                 <a:spcPts val="1540"/>
               </a:lnSpc>
@@ -29493,7 +29466,7 @@
             </a:r>
           </a:p>
           <a:p>
-            <a:pPr algn="l" marL="164592" indent="-164592">
+            <a:pPr marL="164592" indent="-164592" algn="l">
               <a:lnSpc>
                 <a:spcPts val="1540"/>
               </a:lnSpc>
@@ -29550,7 +29523,7 @@
 </file>
 
 <file path=ppt/slides/slide7.xml><?xml version="1.0" encoding="utf-8"?>
-<p:sld xmlns:a="http://schemas.openxmlformats.org/drawingml/2006/main" xmlns:p="http://schemas.openxmlformats.org/presentationml/2006/main" xmlns:r="http://schemas.openxmlformats.org/officeDocument/2006/relationships">
+<p:sld xmlns:a="http://schemas.openxmlformats.org/drawingml/2006/main" xmlns:r="http://schemas.openxmlformats.org/officeDocument/2006/relationships" xmlns:p="http://schemas.openxmlformats.org/presentationml/2006/main">
   <p:cSld>
     <p:bg>
       <p:bgPr>
@@ -29566,7 +29539,14 @@
         <p:cNvGrpSpPr/>
         <p:nvPr/>
       </p:nvGrpSpPr>
-      <p:grpSpPr/>
+      <p:grpSpPr>
+        <a:xfrm>
+          <a:off x="0" y="0"/>
+          <a:ext cx="0" cy="0"/>
+          <a:chOff x="0" y="0"/>
+          <a:chExt cx="0" cy="0"/>
+        </a:xfrm>
+      </p:grpSpPr>
       <p:sp>
         <p:nvSpPr>
           <p:cNvPr id="2" name="tag:L1:tag"/>
@@ -29856,6 +29836,7 @@
           <a:lstStyle/>
           <a:p>
             <a:pPr algn="ctr"/>
+            <a:endParaRPr/>
           </a:p>
         </p:txBody>
       </p:sp>
@@ -29913,7 +29894,7 @@
           <p:nvPr/>
         </p:nvPicPr>
         <p:blipFill>
-          <a:blip r:embed="rId2"/>
+          <a:blip r:embed="rId3"/>
           <a:stretch>
             <a:fillRect/>
           </a:stretch>
@@ -29971,6 +29952,7 @@
           <a:lstStyle/>
           <a:p>
             <a:pPr algn="ctr"/>
+            <a:endParaRPr/>
           </a:p>
         </p:txBody>
       </p:sp>
@@ -30151,6 +30133,7 @@
           <a:lstStyle/>
           <a:p>
             <a:pPr algn="ctr"/>
+            <a:endParaRPr/>
           </a:p>
         </p:txBody>
       </p:sp>
@@ -30353,6 +30336,7 @@
           <a:lstStyle/>
           <a:p>
             <a:pPr algn="ctr"/>
+            <a:endParaRPr/>
           </a:p>
         </p:txBody>
       </p:sp>
@@ -30423,7 +30407,7 @@
           </a:bodyPr>
           <a:lstStyle/>
           <a:p>
-            <a:pPr algn="l" marL="164592" indent="-164592">
+            <a:pPr marL="164592" indent="-164592" algn="l">
               <a:lnSpc>
                 <a:spcPts val="1610"/>
               </a:lnSpc>
@@ -30471,7 +30455,7 @@
             </a:r>
           </a:p>
           <a:p>
-            <a:pPr algn="l" marL="164592" indent="-164592">
+            <a:pPr marL="164592" indent="-164592" algn="l">
               <a:lnSpc>
                 <a:spcPts val="1610"/>
               </a:lnSpc>
@@ -30550,7 +30534,7 @@
 </file>
 
 <file path=ppt/slides/slide8.xml><?xml version="1.0" encoding="utf-8"?>
-<p:sld xmlns:a="http://schemas.openxmlformats.org/drawingml/2006/main" xmlns:p="http://schemas.openxmlformats.org/presentationml/2006/main" xmlns:r="http://schemas.openxmlformats.org/officeDocument/2006/relationships">
+<p:sld xmlns:a="http://schemas.openxmlformats.org/drawingml/2006/main" xmlns:r="http://schemas.openxmlformats.org/officeDocument/2006/relationships" xmlns:p="http://schemas.openxmlformats.org/presentationml/2006/main">
   <p:cSld>
     <p:bg>
       <p:bgPr>
@@ -30566,7 +30550,14 @@
         <p:cNvGrpSpPr/>
         <p:nvPr/>
       </p:nvGrpSpPr>
-      <p:grpSpPr/>
+      <p:grpSpPr>
+        <a:xfrm>
+          <a:off x="0" y="0"/>
+          <a:ext cx="0" cy="0"/>
+          <a:chOff x="0" y="0"/>
+          <a:chExt cx="0" cy="0"/>
+        </a:xfrm>
+      </p:grpSpPr>
       <p:sp>
         <p:nvSpPr>
           <p:cNvPr id="2" name="tag:L1:tag"/>
@@ -30901,6 +30892,7 @@
           <a:lstStyle/>
           <a:p>
             <a:pPr algn="ctr"/>
+            <a:endParaRPr/>
           </a:p>
         </p:txBody>
       </p:sp>
@@ -30958,7 +30950,7 @@
           <p:nvPr/>
         </p:nvPicPr>
         <p:blipFill>
-          <a:blip r:embed="rId2"/>
+          <a:blip r:embed="rId3"/>
           <a:stretch>
             <a:fillRect/>
           </a:stretch>
@@ -31016,6 +31008,7 @@
           <a:lstStyle/>
           <a:p>
             <a:pPr algn="ctr"/>
+            <a:endParaRPr/>
           </a:p>
         </p:txBody>
       </p:sp>
@@ -31208,6 +31201,7 @@
           <a:lstStyle/>
           <a:p>
             <a:pPr algn="ctr"/>
+            <a:endParaRPr/>
           </a:p>
         </p:txBody>
       </p:sp>
@@ -31400,6 +31394,7 @@
           <a:lstStyle/>
           <a:p>
             <a:pPr algn="ctr"/>
+            <a:endParaRPr/>
           </a:p>
         </p:txBody>
       </p:sp>
@@ -31558,7 +31553,7 @@
 </file>
 
 <file path=ppt/slides/slide9.xml><?xml version="1.0" encoding="utf-8"?>
-<p:sld xmlns:a="http://schemas.openxmlformats.org/drawingml/2006/main" xmlns:p="http://schemas.openxmlformats.org/presentationml/2006/main" xmlns:r="http://schemas.openxmlformats.org/officeDocument/2006/relationships">
+<p:sld xmlns:a="http://schemas.openxmlformats.org/drawingml/2006/main" xmlns:r="http://schemas.openxmlformats.org/officeDocument/2006/relationships" xmlns:p="http://schemas.openxmlformats.org/presentationml/2006/main">
   <p:cSld>
     <p:bg>
       <p:bgPr>
@@ -31574,7 +31569,14 @@
         <p:cNvGrpSpPr/>
         <p:nvPr/>
       </p:nvGrpSpPr>
-      <p:grpSpPr/>
+      <p:grpSpPr>
+        <a:xfrm>
+          <a:off x="0" y="0"/>
+          <a:ext cx="0" cy="0"/>
+          <a:chOff x="0" y="0"/>
+          <a:chExt cx="0" cy="0"/>
+        </a:xfrm>
+      </p:grpSpPr>
       <p:sp>
         <p:nvSpPr>
           <p:cNvPr id="2" name="tag:L1:tag"/>
@@ -31909,6 +31911,7 @@
           <a:lstStyle/>
           <a:p>
             <a:pPr algn="ctr"/>
+            <a:endParaRPr/>
           </a:p>
         </p:txBody>
       </p:sp>
@@ -31966,7 +31969,7 @@
           <p:nvPr/>
         </p:nvPicPr>
         <p:blipFill>
-          <a:blip r:embed="rId2"/>
+          <a:blip r:embed="rId3"/>
           <a:stretch>
             <a:fillRect/>
           </a:stretch>
@@ -32024,6 +32027,7 @@
           <a:lstStyle/>
           <a:p>
             <a:pPr algn="ctr"/>
+            <a:endParaRPr/>
           </a:p>
         </p:txBody>
       </p:sp>
@@ -32081,7 +32085,7 @@
           <p:nvPr/>
         </p:nvPicPr>
         <p:blipFill>
-          <a:blip r:embed="rId3"/>
+          <a:blip r:embed="rId4"/>
           <a:stretch>
             <a:fillRect/>
           </a:stretch>
@@ -32139,6 +32143,7 @@
           <a:lstStyle/>
           <a:p>
             <a:pPr algn="ctr"/>
+            <a:endParaRPr/>
           </a:p>
         </p:txBody>
       </p:sp>
@@ -32196,7 +32201,7 @@
           <p:nvPr/>
         </p:nvPicPr>
         <p:blipFill>
-          <a:blip r:embed="rId4"/>
+          <a:blip r:embed="rId5"/>
           <a:stretch>
             <a:fillRect/>
           </a:stretch>
@@ -32254,6 +32259,7 @@
           <a:lstStyle/>
           <a:p>
             <a:pPr algn="ctr"/>
+            <a:endParaRPr/>
           </a:p>
         </p:txBody>
       </p:sp>
@@ -32467,6 +32473,7 @@
           <a:lstStyle/>
           <a:p>
             <a:pPr algn="ctr"/>
+            <a:endParaRPr/>
           </a:p>
         </p:txBody>
       </p:sp>
@@ -32537,7 +32544,7 @@
           </a:bodyPr>
           <a:lstStyle/>
           <a:p>
-            <a:pPr algn="l" marL="164592" indent="-164592">
+            <a:pPr marL="164592" indent="-164592" algn="l">
               <a:lnSpc>
                 <a:spcPts val="1610"/>
               </a:lnSpc>
@@ -32574,7 +32581,7 @@
             </a:r>
           </a:p>
           <a:p>
-            <a:pPr algn="l" marL="164592" indent="-164592">
+            <a:pPr marL="164592" indent="-164592" algn="l">
               <a:lnSpc>
                 <a:spcPts val="1610"/>
               </a:lnSpc>
@@ -32611,7 +32618,7 @@
             </a:r>
           </a:p>
           <a:p>
-            <a:pPr algn="l" marL="164592" indent="-164592">
+            <a:pPr marL="164592" indent="-164592" algn="l">
               <a:lnSpc>
                 <a:spcPts val="1610"/>
               </a:lnSpc>
@@ -32637,7 +32644,7 @@
             </a:r>
           </a:p>
           <a:p>
-            <a:pPr algn="l" marL="164592" indent="-164592">
+            <a:pPr marL="164592" indent="-164592" algn="l">
               <a:lnSpc>
                 <a:spcPts val="1610"/>
               </a:lnSpc>
@@ -32707,6 +32714,7 @@
           <a:lstStyle/>
           <a:p>
             <a:pPr algn="ctr"/>
+            <a:endParaRPr/>
           </a:p>
         </p:txBody>
       </p:sp>
@@ -33230,7 +33238,7 @@
 </file>
 
 <file path=ppt/theme/theme2.xml><?xml version="1.0" encoding="utf-8"?>
-<a:theme xmlns:a="http://schemas.openxmlformats.org/drawingml/2006/main" name="Office Theme">
+<a:theme xmlns:a="http://schemas.openxmlformats.org/drawingml/2006/main" name="Office 테마">
   <a:themeElements>
     <a:clrScheme name="Office">
       <a:dk1>
@@ -33240,44 +33248,44 @@
         <a:sysClr val="window" lastClr="FFFFFF"/>
       </a:lt1>
       <a:dk2>
-        <a:srgbClr val="1F497D"/>
+        <a:srgbClr val="44546A"/>
       </a:dk2>
       <a:lt2>
-        <a:srgbClr val="EEECE1"/>
+        <a:srgbClr val="E7E6E6"/>
       </a:lt2>
       <a:accent1>
-        <a:srgbClr val="4F81BD"/>
+        <a:srgbClr val="4472C4"/>
       </a:accent1>
       <a:accent2>
-        <a:srgbClr val="C0504D"/>
+        <a:srgbClr val="ED7D31"/>
       </a:accent2>
       <a:accent3>
-        <a:srgbClr val="9BBB59"/>
+        <a:srgbClr val="A5A5A5"/>
       </a:accent3>
       <a:accent4>
-        <a:srgbClr val="8064A2"/>
+        <a:srgbClr val="FFC000"/>
       </a:accent4>
       <a:accent5>
-        <a:srgbClr val="4BACC6"/>
+        <a:srgbClr val="5B9BD5"/>
       </a:accent5>
       <a:accent6>
-        <a:srgbClr val="F79646"/>
+        <a:srgbClr val="70AD47"/>
       </a:accent6>
       <a:hlink>
-        <a:srgbClr val="0000FF"/>
+        <a:srgbClr val="0563C1"/>
       </a:hlink>
       <a:folHlink>
-        <a:srgbClr val="800080"/>
+        <a:srgbClr val="954F72"/>
       </a:folHlink>
     </a:clrScheme>
     <a:fontScheme name="Office">
       <a:majorFont>
-        <a:latin typeface="Calibri"/>
+        <a:latin typeface="맑은 고딕" panose="020F0302020204030204"/>
         <a:ea typeface=""/>
         <a:cs typeface=""/>
-        <a:font script="Jpan" typeface="ＭＳ Ｐゴシック"/>
+        <a:font script="Jpan" typeface="游ゴシック Light"/>
         <a:font script="Hang" typeface="맑은 고딕"/>
-        <a:font script="Hans" typeface="宋体"/>
+        <a:font script="Hans" typeface="等线 Light"/>
         <a:font script="Hant" typeface="新細明體"/>
         <a:font script="Arab" typeface="Times New Roman"/>
         <a:font script="Hebr" typeface="Times New Roman"/>
@@ -33305,14 +33313,31 @@
         <a:font script="Viet" typeface="Times New Roman"/>
         <a:font script="Uigh" typeface="Microsoft Uighur"/>
         <a:font script="Geor" typeface="Sylfaen"/>
+        <a:font script="Armn" typeface="Arial"/>
+        <a:font script="Bugi" typeface="Leelawadee UI"/>
+        <a:font script="Bopo" typeface="Microsoft JhengHei"/>
+        <a:font script="Java" typeface="Javanese Text"/>
+        <a:font script="Lisu" typeface="Segoe UI"/>
+        <a:font script="Mymr" typeface="Myanmar Text"/>
+        <a:font script="Nkoo" typeface="Ebrima"/>
+        <a:font script="Olck" typeface="Nirmala UI"/>
+        <a:font script="Osma" typeface="Ebrima"/>
+        <a:font script="Phag" typeface="Phagspa"/>
+        <a:font script="Syrn" typeface="Estrangelo Edessa"/>
+        <a:font script="Syrj" typeface="Estrangelo Edessa"/>
+        <a:font script="Syre" typeface="Estrangelo Edessa"/>
+        <a:font script="Sora" typeface="Nirmala UI"/>
+        <a:font script="Tale" typeface="Microsoft Tai Le"/>
+        <a:font script="Talu" typeface="Microsoft New Tai Lue"/>
+        <a:font script="Tfng" typeface="Ebrima"/>
       </a:majorFont>
       <a:minorFont>
-        <a:latin typeface="Calibri"/>
+        <a:latin typeface="맑은 고딕" panose="020F0502020204030204"/>
         <a:ea typeface=""/>
         <a:cs typeface=""/>
-        <a:font script="Jpan" typeface="ＭＳ Ｐゴシック"/>
+        <a:font script="Jpan" typeface="游ゴシック"/>
         <a:font script="Hang" typeface="맑은 고딕"/>
-        <a:font script="Hans" typeface="宋体"/>
+        <a:font script="Hans" typeface="等线"/>
         <a:font script="Hant" typeface="新細明體"/>
         <a:font script="Arab" typeface="Arial"/>
         <a:font script="Hebr" typeface="Arial"/>
@@ -33340,6 +33365,23 @@
         <a:font script="Viet" typeface="Arial"/>
         <a:font script="Uigh" typeface="Microsoft Uighur"/>
         <a:font script="Geor" typeface="Sylfaen"/>
+        <a:font script="Armn" typeface="Arial"/>
+        <a:font script="Bugi" typeface="Leelawadee UI"/>
+        <a:font script="Bopo" typeface="Microsoft JhengHei"/>
+        <a:font script="Java" typeface="Javanese Text"/>
+        <a:font script="Lisu" typeface="Segoe UI"/>
+        <a:font script="Mymr" typeface="Myanmar Text"/>
+        <a:font script="Nkoo" typeface="Ebrima"/>
+        <a:font script="Olck" typeface="Nirmala UI"/>
+        <a:font script="Osma" typeface="Ebrima"/>
+        <a:font script="Phag" typeface="Phagspa"/>
+        <a:font script="Syrn" typeface="Estrangelo Edessa"/>
+        <a:font script="Syrj" typeface="Estrangelo Edessa"/>
+        <a:font script="Syre" typeface="Estrangelo Edessa"/>
+        <a:font script="Sora" typeface="Nirmala UI"/>
+        <a:font script="Tale" typeface="Microsoft Tai Le"/>
+        <a:font script="Talu" typeface="Microsoft New Tai Lue"/>
+        <a:font script="Tfng" typeface="Ebrima"/>
       </a:minorFont>
     </a:fontScheme>
     <a:fmtScheme name="Office">
@@ -33351,200 +33393,141 @@
           <a:gsLst>
             <a:gs pos="0">
               <a:schemeClr val="phClr">
-                <a:tint val="50000"/>
-                <a:satMod val="300000"/>
+                <a:lumMod val="110000"/>
+                <a:satMod val="105000"/>
+                <a:tint val="67000"/>
               </a:schemeClr>
             </a:gs>
-            <a:gs pos="35000">
+            <a:gs pos="50000">
               <a:schemeClr val="phClr">
-                <a:tint val="37000"/>
-                <a:satMod val="300000"/>
+                <a:lumMod val="105000"/>
+                <a:satMod val="103000"/>
+                <a:tint val="73000"/>
               </a:schemeClr>
             </a:gs>
             <a:gs pos="100000">
               <a:schemeClr val="phClr">
-                <a:tint val="15000"/>
-                <a:satMod val="350000"/>
+                <a:lumMod val="105000"/>
+                <a:satMod val="109000"/>
+                <a:tint val="81000"/>
               </a:schemeClr>
             </a:gs>
           </a:gsLst>
-          <a:lin ang="16200000" scaled="1"/>
+          <a:lin ang="5400000" scaled="0"/>
         </a:gradFill>
         <a:gradFill rotWithShape="1">
           <a:gsLst>
             <a:gs pos="0">
               <a:schemeClr val="phClr">
-                <a:tint val="100000"/>
+                <a:satMod val="103000"/>
+                <a:lumMod val="102000"/>
+                <a:tint val="94000"/>
+              </a:schemeClr>
+            </a:gs>
+            <a:gs pos="50000">
+              <a:schemeClr val="phClr">
+                <a:satMod val="110000"/>
+                <a:lumMod val="100000"/>
                 <a:shade val="100000"/>
-                <a:satMod val="130000"/>
               </a:schemeClr>
             </a:gs>
             <a:gs pos="100000">
               <a:schemeClr val="phClr">
-                <a:tint val="50000"/>
-                <a:shade val="100000"/>
-                <a:satMod val="350000"/>
+                <a:lumMod val="99000"/>
+                <a:satMod val="120000"/>
+                <a:shade val="78000"/>
               </a:schemeClr>
             </a:gs>
           </a:gsLst>
-          <a:lin ang="16200000" scaled="0"/>
+          <a:lin ang="5400000" scaled="0"/>
         </a:gradFill>
       </a:fillStyleLst>
       <a:lnStyleLst>
-        <a:ln w="9525" cap="flat" cmpd="sng" algn="ctr">
-          <a:solidFill>
-            <a:schemeClr val="phClr">
-              <a:shade val="95000"/>
-              <a:satMod val="105000"/>
-            </a:schemeClr>
-          </a:solidFill>
-          <a:prstDash val="solid"/>
-        </a:ln>
-        <a:ln w="25400" cap="flat" cmpd="sng" algn="ctr">
+        <a:ln w="6350" cap="flat" cmpd="sng" algn="ctr">
           <a:solidFill>
             <a:schemeClr val="phClr"/>
           </a:solidFill>
           <a:prstDash val="solid"/>
+          <a:miter lim="800000"/>
         </a:ln>
-        <a:ln w="38100" cap="flat" cmpd="sng" algn="ctr">
+        <a:ln w="12700" cap="flat" cmpd="sng" algn="ctr">
           <a:solidFill>
             <a:schemeClr val="phClr"/>
           </a:solidFill>
           <a:prstDash val="solid"/>
+          <a:miter lim="800000"/>
+        </a:ln>
+        <a:ln w="19050" cap="flat" cmpd="sng" algn="ctr">
+          <a:solidFill>
+            <a:schemeClr val="phClr"/>
+          </a:solidFill>
+          <a:prstDash val="solid"/>
+          <a:miter lim="800000"/>
         </a:ln>
       </a:lnStyleLst>
       <a:effectStyleLst>
         <a:effectStyle>
+          <a:effectLst/>
+        </a:effectStyle>
+        <a:effectStyle>
+          <a:effectLst/>
+        </a:effectStyle>
+        <a:effectStyle>
           <a:effectLst>
-            <a:outerShdw blurRad="40000" dist="20000" dir="5400000" rotWithShape="0">
+            <a:outerShdw blurRad="57150" dist="19050" dir="5400000" algn="ctr" rotWithShape="0">
               <a:srgbClr val="000000">
-                <a:alpha val="38000"/>
+                <a:alpha val="63000"/>
               </a:srgbClr>
             </a:outerShdw>
           </a:effectLst>
-        </a:effectStyle>
-        <a:effectStyle>
-          <a:effectLst>
-            <a:outerShdw blurRad="40000" dist="23000" dir="5400000" rotWithShape="0">
-              <a:srgbClr val="000000">
-                <a:alpha val="35000"/>
-              </a:srgbClr>
-            </a:outerShdw>
-          </a:effectLst>
-        </a:effectStyle>
-        <a:effectStyle>
-          <a:effectLst>
-            <a:outerShdw blurRad="40000" dist="23000" dir="5400000" rotWithShape="0">
-              <a:srgbClr val="000000">
-                <a:alpha val="35000"/>
-              </a:srgbClr>
-            </a:outerShdw>
-          </a:effectLst>
-          <a:scene3d>
-            <a:camera prst="orthographicFront">
-              <a:rot lat="0" lon="0" rev="0"/>
-            </a:camera>
-            <a:lightRig rig="threePt" dir="t">
-              <a:rot lat="0" lon="0" rev="1200000"/>
-            </a:lightRig>
-          </a:scene3d>
-          <a:sp3d>
-            <a:bevelT w="63500" h="25400"/>
-          </a:sp3d>
         </a:effectStyle>
       </a:effectStyleLst>
       <a:bgFillStyleLst>
         <a:solidFill>
           <a:schemeClr val="phClr"/>
         </a:solidFill>
+        <a:solidFill>
+          <a:schemeClr val="phClr">
+            <a:tint val="95000"/>
+            <a:satMod val="170000"/>
+          </a:schemeClr>
+        </a:solidFill>
         <a:gradFill rotWithShape="1">
           <a:gsLst>
             <a:gs pos="0">
               <a:schemeClr val="phClr">
-                <a:tint val="40000"/>
-                <a:satMod val="350000"/>
+                <a:tint val="93000"/>
+                <a:satMod val="150000"/>
+                <a:shade val="98000"/>
+                <a:lumMod val="102000"/>
               </a:schemeClr>
             </a:gs>
-            <a:gs pos="40000">
+            <a:gs pos="50000">
               <a:schemeClr val="phClr">
-                <a:tint val="45000"/>
-                <a:shade val="99000"/>
-                <a:satMod val="350000"/>
+                <a:tint val="98000"/>
+                <a:satMod val="130000"/>
+                <a:shade val="90000"/>
+                <a:lumMod val="103000"/>
               </a:schemeClr>
             </a:gs>
             <a:gs pos="100000">
               <a:schemeClr val="phClr">
-                <a:shade val="20000"/>
-                <a:satMod val="255000"/>
+                <a:shade val="63000"/>
+                <a:satMod val="120000"/>
               </a:schemeClr>
             </a:gs>
           </a:gsLst>
-          <a:path path="circle">
-            <a:fillToRect l="50000" t="-80000" r="50000" b="180000"/>
-          </a:path>
-        </a:gradFill>
-        <a:gradFill rotWithShape="1">
-          <a:gsLst>
-            <a:gs pos="0">
-              <a:schemeClr val="phClr">
-                <a:tint val="80000"/>
-                <a:satMod val="300000"/>
-              </a:schemeClr>
-            </a:gs>
-            <a:gs pos="100000">
-              <a:schemeClr val="phClr">
-                <a:shade val="30000"/>
-                <a:satMod val="200000"/>
-              </a:schemeClr>
-            </a:gs>
-          </a:gsLst>
-          <a:path path="circle">
-            <a:fillToRect l="50000" t="50000" r="50000" b="50000"/>
-          </a:path>
+          <a:lin ang="5400000" scaled="0"/>
         </a:gradFill>
       </a:bgFillStyleLst>
     </a:fmtScheme>
   </a:themeElements>
-  <a:objectDefaults>
-    <a:spDef>
-      <a:spPr/>
-      <a:bodyPr/>
-      <a:lstStyle/>
-      <a:style>
-        <a:lnRef idx="1">
-          <a:schemeClr val="accent1"/>
-        </a:lnRef>
-        <a:fillRef idx="3">
-          <a:schemeClr val="accent1"/>
-        </a:fillRef>
-        <a:effectRef idx="2">
-          <a:schemeClr val="accent1"/>
-        </a:effectRef>
-        <a:fontRef idx="minor">
-          <a:schemeClr val="lt1"/>
-        </a:fontRef>
-      </a:style>
-    </a:spDef>
-    <a:lnDef>
-      <a:spPr/>
-      <a:bodyPr/>
-      <a:lstStyle/>
-      <a:style>
-        <a:lnRef idx="2">
-          <a:schemeClr val="accent1"/>
-        </a:lnRef>
-        <a:fillRef idx="0">
-          <a:schemeClr val="accent1"/>
-        </a:fillRef>
-        <a:effectRef idx="1">
-          <a:schemeClr val="accent1"/>
-        </a:effectRef>
-        <a:fontRef idx="minor">
-          <a:schemeClr val="tx1"/>
-        </a:fontRef>
-      </a:style>
-    </a:lnDef>
-  </a:objectDefaults>
+  <a:objectDefaults/>
   <a:extraClrSchemeLst/>
+  <a:extLst>
+    <a:ext uri="{05A4C25C-085E-4340-85A3-A5531E510DB2}">
+      <thm15:themeFamily xmlns:thm15="http://schemas.microsoft.com/office/thememl/2012/main" name="Office Theme" id="{62F939B6-93AF-4DB8-9C6B-D6C7DFDC589F}" vid="{4A3C46E8-61CC-4603-A589-7422A47A8E4A}"/>
+    </a:ext>
+  </a:extLst>
 </a:theme>
 </file>
</xml_diff>

<commit_message>
style(deck): final design polish - consistent bottom edge across slides, larger chart text on slide 4, slide 9 charts taller; submission copies refreshed
Co-Authored-By: Claude Sonnet 5.5 <noreply@anthropic.com>
</commit_message>
<xml_diff>
--- a/outputs/pptx/puzzledata_repair_report.pptx
+++ b/outputs/pptx/puzzledata_repair_report.pptx
@@ -142,21 +142,21 @@
   <p:extLst>
     <p:ext uri="{521415D9-36F7-43E2-AB2F-B90AF26B5E84}">
       <p14:sectionLst xmlns:p14="http://schemas.microsoft.com/office/powerpoint/2010/main">
-        <p14:section name="Part 00 · 인트로" id="{A61B80BD-90E6-433F-9D43-43FE56B17982}">
+        <p14:section name="Part 00 · 인트로" id="{8375A178-4210-4ED6-B4E4-3C447F628582}">
           <p14:sldIdLst>
             <p14:sldId id="256"/>
             <p14:sldId id="257"/>
             <p14:sldId id="258"/>
           </p14:sldIdLst>
         </p14:section>
-        <p14:section name="Part 01 · 데이터 진단" id="{8230E63B-9ED8-4FE4-B64D-B4903261E8A6}">
+        <p14:section name="Part 01 · 데이터 진단" id="{84B140B5-E073-4557-A968-529A1D184A1E}">
           <p14:sldIdLst>
             <p14:sldId id="259"/>
             <p14:sldId id="260"/>
             <p14:sldId id="261"/>
           </p14:sldIdLst>
         </p14:section>
-        <p14:section name="Part 02 · 병목 규명" id="{823FB230-6B2F-4492-9723-EB4EEDCF6F5E}">
+        <p14:section name="Part 02 · 병목 규명" id="{1567F654-1EA3-4E8A-A219-F36CF8E74EFA}">
           <p14:sldIdLst>
             <p14:sldId id="262"/>
             <p14:sldId id="263"/>
@@ -169,14 +169,14 @@
             <p14:sldId id="270"/>
           </p14:sldIdLst>
         </p14:section>
-        <p14:section name="Part 03 · 개선 전략" id="{C069E015-9E27-493C-859A-F678255D398C}">
+        <p14:section name="Part 03 · 개선 전략" id="{3ECE593B-1BDE-4D00-B46E-B237AB461F22}">
           <p14:sldIdLst>
             <p14:sldId id="271"/>
             <p14:sldId id="272"/>
             <p14:sldId id="273"/>
           </p14:sldIdLst>
         </p14:section>
-        <p14:section name="Part 04 · Q&amp;A" id="{7C197D7F-E718-4B45-B07A-9830F6ED98E6}">
+        <p14:section name="Part 04 · Q&amp;A" id="{AD9E5171-9D45-4796-9B62-2F9A55F1C85E}">
           <p14:sldIdLst>
             <p14:sldId id="274"/>
           </p14:sldIdLst>
@@ -226,7 +226,7 @@
     </p:spTree>
     <p:extLst>
       <p:ext uri="{BB962C8B-B14F-4D97-AF65-F5344CB8AC3E}">
-        <p14:creationId xmlns:p14="http://schemas.microsoft.com/office/powerpoint/2010/main" val="2181044953"/>
+        <p14:creationId xmlns:p14="http://schemas.microsoft.com/office/powerpoint/2010/main" val="635013916"/>
       </p:ext>
     </p:extLst>
   </p:cSld>
@@ -7510,7 +7510,7 @@
         <p:spPr>
           <a:xfrm>
             <a:off x="502920" y="5527687"/>
-            <a:ext cx="11185855" cy="588010"/>
+            <a:ext cx="11185855" cy="763384"/>
           </a:xfrm>
           <a:prstGeom prst="rect">
             <a:avLst/>
@@ -11025,7 +11025,7 @@
         <p:spPr>
           <a:xfrm>
             <a:off x="502920" y="1554480"/>
-            <a:ext cx="7818120" cy="3852926"/>
+            <a:ext cx="7818120" cy="4035806"/>
           </a:xfrm>
           <a:prstGeom prst="rect">
             <a:avLst/>
@@ -11124,8 +11124,8 @@
         </p:blipFill>
         <p:spPr>
           <a:xfrm>
-            <a:off x="873345" y="1896110"/>
-            <a:ext cx="7077269" cy="3383280"/>
+            <a:off x="682067" y="1896110"/>
+            <a:ext cx="7459824" cy="3566160"/>
           </a:xfrm>
           <a:prstGeom prst="rect">
             <a:avLst/>
@@ -11141,7 +11141,7 @@
         <p:spPr>
           <a:xfrm>
             <a:off x="8503920" y="1554480"/>
-            <a:ext cx="3184855" cy="1211156"/>
+            <a:ext cx="3184855" cy="1272116"/>
           </a:xfrm>
           <a:prstGeom prst="rect">
             <a:avLst/>
@@ -11333,8 +11333,8 @@
         </p:nvSpPr>
         <p:spPr>
           <a:xfrm>
-            <a:off x="8503920" y="2875364"/>
-            <a:ext cx="3184855" cy="1211156"/>
+            <a:off x="8503920" y="2936324"/>
+            <a:ext cx="3184855" cy="1272116"/>
           </a:xfrm>
           <a:prstGeom prst="rect">
             <a:avLst/>
@@ -11380,7 +11380,7 @@
         </p:nvSpPr>
         <p:spPr>
           <a:xfrm>
-            <a:off x="8659368" y="3030812"/>
+            <a:off x="8659368" y="3091772"/>
             <a:ext cx="2873959" cy="158750"/>
           </a:xfrm>
           <a:prstGeom prst="rect">
@@ -11425,7 +11425,7 @@
         </p:nvSpPr>
         <p:spPr>
           <a:xfrm>
-            <a:off x="8659368" y="3244426"/>
+            <a:off x="8659368" y="3305386"/>
             <a:ext cx="2873959" cy="341630"/>
           </a:xfrm>
           <a:prstGeom prst="rect">
@@ -11481,7 +11481,7 @@
         </p:nvSpPr>
         <p:spPr>
           <a:xfrm>
-            <a:off x="8659368" y="3640920"/>
+            <a:off x="8659368" y="3701880"/>
             <a:ext cx="2873959" cy="195580"/>
           </a:xfrm>
           <a:prstGeom prst="rect">
@@ -11526,8 +11526,8 @@
         </p:nvSpPr>
         <p:spPr>
           <a:xfrm>
-            <a:off x="8503920" y="4196249"/>
-            <a:ext cx="3184855" cy="1211156"/>
+            <a:off x="8503920" y="4318169"/>
+            <a:ext cx="3184855" cy="1272116"/>
           </a:xfrm>
           <a:prstGeom prst="rect">
             <a:avLst/>
@@ -11573,7 +11573,7 @@
         </p:nvSpPr>
         <p:spPr>
           <a:xfrm>
-            <a:off x="8659368" y="4351697"/>
+            <a:off x="8659368" y="4473617"/>
             <a:ext cx="2873959" cy="158750"/>
           </a:xfrm>
           <a:prstGeom prst="rect">
@@ -11618,7 +11618,7 @@
         </p:nvSpPr>
         <p:spPr>
           <a:xfrm>
-            <a:off x="8659368" y="4565311"/>
+            <a:off x="8659368" y="4687231"/>
             <a:ext cx="2873959" cy="341630"/>
           </a:xfrm>
           <a:prstGeom prst="rect">
@@ -11674,7 +11674,7 @@
         </p:nvSpPr>
         <p:spPr>
           <a:xfrm>
-            <a:off x="8659368" y="4961805"/>
+            <a:off x="8659368" y="5083725"/>
             <a:ext cx="2873959" cy="195580"/>
           </a:xfrm>
           <a:prstGeom prst="rect">
@@ -11719,7 +11719,7 @@
         </p:nvSpPr>
         <p:spPr>
           <a:xfrm>
-            <a:off x="502920" y="5544566"/>
+            <a:off x="502920" y="5727446"/>
             <a:ext cx="11185855" cy="533146"/>
           </a:xfrm>
           <a:prstGeom prst="rect">
@@ -11766,7 +11766,7 @@
         </p:nvSpPr>
         <p:spPr>
           <a:xfrm>
-            <a:off x="658368" y="5700014"/>
+            <a:off x="658368" y="5882894"/>
             <a:ext cx="10874959" cy="222250"/>
           </a:xfrm>
           <a:prstGeom prst="rect">
@@ -12180,7 +12180,7 @@
         <p:spPr>
           <a:xfrm>
             <a:off x="502920" y="1554480"/>
-            <a:ext cx="7818120" cy="3670046"/>
+            <a:ext cx="7818120" cy="3852926"/>
           </a:xfrm>
           <a:prstGeom prst="rect">
             <a:avLst/>
@@ -12279,8 +12279,8 @@
         </p:blipFill>
         <p:spPr>
           <a:xfrm>
-            <a:off x="972094" y="1896110"/>
-            <a:ext cx="6879771" cy="3200400"/>
+            <a:off x="775529" y="1896110"/>
+            <a:ext cx="7272901" cy="3383280"/>
           </a:xfrm>
           <a:prstGeom prst="rect">
             <a:avLst/>
@@ -12296,7 +12296,7 @@
         <p:spPr>
           <a:xfrm>
             <a:off x="8503920" y="1554480"/>
-            <a:ext cx="3184855" cy="1150196"/>
+            <a:ext cx="3184855" cy="1211156"/>
           </a:xfrm>
           <a:prstGeom prst="rect">
             <a:avLst/>
@@ -12488,8 +12488,8 @@
         </p:nvSpPr>
         <p:spPr>
           <a:xfrm>
-            <a:off x="8503920" y="2814404"/>
-            <a:ext cx="3184855" cy="1150196"/>
+            <a:off x="8503920" y="2875364"/>
+            <a:ext cx="3184855" cy="1211156"/>
           </a:xfrm>
           <a:prstGeom prst="rect">
             <a:avLst/>
@@ -12535,7 +12535,7 @@
         </p:nvSpPr>
         <p:spPr>
           <a:xfrm>
-            <a:off x="8659368" y="2969852"/>
+            <a:off x="8659368" y="3030812"/>
             <a:ext cx="2873959" cy="158750"/>
           </a:xfrm>
           <a:prstGeom prst="rect">
@@ -12580,7 +12580,7 @@
         </p:nvSpPr>
         <p:spPr>
           <a:xfrm>
-            <a:off x="8659368" y="3183466"/>
+            <a:off x="8659368" y="3244426"/>
             <a:ext cx="2873959" cy="341630"/>
           </a:xfrm>
           <a:prstGeom prst="rect">
@@ -12636,7 +12636,7 @@
         </p:nvSpPr>
         <p:spPr>
           <a:xfrm>
-            <a:off x="8659368" y="3579960"/>
+            <a:off x="8659368" y="3640920"/>
             <a:ext cx="2873959" cy="195580"/>
           </a:xfrm>
           <a:prstGeom prst="rect">
@@ -12681,8 +12681,8 @@
         </p:nvSpPr>
         <p:spPr>
           <a:xfrm>
-            <a:off x="8503920" y="4074329"/>
-            <a:ext cx="3184855" cy="1150196"/>
+            <a:off x="8503920" y="4196249"/>
+            <a:ext cx="3184855" cy="1211156"/>
           </a:xfrm>
           <a:prstGeom prst="rect">
             <a:avLst/>
@@ -12728,7 +12728,7 @@
         </p:nvSpPr>
         <p:spPr>
           <a:xfrm>
-            <a:off x="8659368" y="4229777"/>
+            <a:off x="8659368" y="4351697"/>
             <a:ext cx="2873959" cy="158750"/>
           </a:xfrm>
           <a:prstGeom prst="rect">
@@ -12773,7 +12773,7 @@
         </p:nvSpPr>
         <p:spPr>
           <a:xfrm>
-            <a:off x="8659368" y="4443391"/>
+            <a:off x="8659368" y="4565311"/>
             <a:ext cx="2873959" cy="341630"/>
           </a:xfrm>
           <a:prstGeom prst="rect">
@@ -12829,7 +12829,7 @@
         </p:nvSpPr>
         <p:spPr>
           <a:xfrm>
-            <a:off x="8659368" y="4839885"/>
+            <a:off x="8659368" y="4961805"/>
             <a:ext cx="2873959" cy="195580"/>
           </a:xfrm>
           <a:prstGeom prst="rect">
@@ -12874,7 +12874,7 @@
         </p:nvSpPr>
         <p:spPr>
           <a:xfrm>
-            <a:off x="502920" y="5361686"/>
+            <a:off x="502920" y="5544566"/>
             <a:ext cx="11185855" cy="755396"/>
           </a:xfrm>
           <a:prstGeom prst="rect">
@@ -12921,7 +12921,7 @@
         </p:nvSpPr>
         <p:spPr>
           <a:xfrm>
-            <a:off x="658368" y="5517134"/>
+            <a:off x="658368" y="5700014"/>
             <a:ext cx="10874959" cy="444500"/>
           </a:xfrm>
           <a:prstGeom prst="rect">
@@ -19130,7 +19130,7 @@
         <p:spPr>
           <a:xfrm>
             <a:off x="502920" y="1554480"/>
-            <a:ext cx="5760720" cy="1362456"/>
+            <a:ext cx="5760720" cy="1484376"/>
           </a:xfrm>
           <a:prstGeom prst="rect">
             <a:avLst/>
@@ -19311,8 +19311,8 @@
         </p:nvSpPr>
         <p:spPr>
           <a:xfrm>
-            <a:off x="502920" y="3044952"/>
-            <a:ext cx="5760720" cy="1362456"/>
+            <a:off x="502920" y="3166872"/>
+            <a:ext cx="5760720" cy="1484376"/>
           </a:xfrm>
           <a:prstGeom prst="rect">
             <a:avLst/>
@@ -19358,7 +19358,7 @@
         </p:nvSpPr>
         <p:spPr>
           <a:xfrm>
-            <a:off x="704088" y="3246120"/>
+            <a:off x="704088" y="3368040"/>
             <a:ext cx="5358383" cy="158750"/>
           </a:xfrm>
           <a:prstGeom prst="rect">
@@ -19403,7 +19403,7 @@
         </p:nvSpPr>
         <p:spPr>
           <a:xfrm>
-            <a:off x="704088" y="3459734"/>
+            <a:off x="704088" y="3581654"/>
             <a:ext cx="5358383" cy="266700"/>
           </a:xfrm>
           <a:prstGeom prst="rect">
@@ -19448,7 +19448,7 @@
         </p:nvSpPr>
         <p:spPr>
           <a:xfrm>
-            <a:off x="704088" y="3781298"/>
+            <a:off x="704088" y="3903218"/>
             <a:ext cx="5358383" cy="213360"/>
           </a:xfrm>
           <a:prstGeom prst="rect">
@@ -19493,8 +19493,8 @@
         </p:nvSpPr>
         <p:spPr>
           <a:xfrm>
-            <a:off x="502920" y="4535424"/>
-            <a:ext cx="5760720" cy="1362456"/>
+            <a:off x="502920" y="4779264"/>
+            <a:ext cx="5760720" cy="1484376"/>
           </a:xfrm>
           <a:prstGeom prst="rect">
             <a:avLst/>
@@ -19540,7 +19540,7 @@
         </p:nvSpPr>
         <p:spPr>
           <a:xfrm>
-            <a:off x="704088" y="4736592"/>
+            <a:off x="704088" y="4980432"/>
             <a:ext cx="5358383" cy="158750"/>
           </a:xfrm>
           <a:prstGeom prst="rect">
@@ -19585,7 +19585,7 @@
         </p:nvSpPr>
         <p:spPr>
           <a:xfrm>
-            <a:off x="704088" y="4950206"/>
+            <a:off x="704088" y="5194046"/>
             <a:ext cx="5358383" cy="266700"/>
           </a:xfrm>
           <a:prstGeom prst="rect">
@@ -19630,7 +19630,7 @@
         </p:nvSpPr>
         <p:spPr>
           <a:xfrm>
-            <a:off x="704088" y="5271770"/>
+            <a:off x="704088" y="5515610"/>
             <a:ext cx="5358383" cy="213360"/>
           </a:xfrm>
           <a:prstGeom prst="rect">
@@ -19676,7 +19676,7 @@
         <p:spPr>
           <a:xfrm>
             <a:off x="6446520" y="1554480"/>
-            <a:ext cx="5242255" cy="4343400"/>
+            <a:ext cx="5242255" cy="4709160"/>
           </a:xfrm>
           <a:prstGeom prst="rect">
             <a:avLst/>
@@ -20272,7 +20272,7 @@
         <p:spPr>
           <a:xfrm>
             <a:off x="502920" y="1600200"/>
-            <a:ext cx="2659303" cy="4297680"/>
+            <a:ext cx="2659303" cy="4617720"/>
           </a:xfrm>
           <a:prstGeom prst="rect">
             <a:avLst/>
@@ -20641,7 +20641,7 @@
         </p:nvSpPr>
         <p:spPr>
           <a:xfrm>
-            <a:off x="722376" y="5084064"/>
+            <a:off x="722376" y="5404103"/>
             <a:ext cx="2220391" cy="594359"/>
           </a:xfrm>
           <a:prstGeom prst="rect">
@@ -20711,7 +20711,7 @@
         <p:spPr>
           <a:xfrm>
             <a:off x="3345103" y="1600200"/>
-            <a:ext cx="2659303" cy="4297680"/>
+            <a:ext cx="2659303" cy="4617720"/>
           </a:xfrm>
           <a:prstGeom prst="rect">
             <a:avLst/>
@@ -21085,7 +21085,7 @@
         </p:nvSpPr>
         <p:spPr>
           <a:xfrm>
-            <a:off x="3564559" y="5084064"/>
+            <a:off x="3564559" y="5404103"/>
             <a:ext cx="2220391" cy="594359"/>
           </a:xfrm>
           <a:prstGeom prst="rect">
@@ -21155,7 +21155,7 @@
         <p:spPr>
           <a:xfrm>
             <a:off x="6187287" y="1600200"/>
-            <a:ext cx="2659303" cy="4297680"/>
+            <a:ext cx="2659303" cy="4617720"/>
           </a:xfrm>
           <a:prstGeom prst="rect">
             <a:avLst/>
@@ -21545,7 +21545,7 @@
         </p:nvSpPr>
         <p:spPr>
           <a:xfrm>
-            <a:off x="6406743" y="5084064"/>
+            <a:off x="6406743" y="5404103"/>
             <a:ext cx="2220391" cy="594359"/>
           </a:xfrm>
           <a:prstGeom prst="rect">
@@ -21615,7 +21615,7 @@
         <p:spPr>
           <a:xfrm>
             <a:off x="9029471" y="1600200"/>
-            <a:ext cx="2659303" cy="4297680"/>
+            <a:ext cx="2659303" cy="4617720"/>
           </a:xfrm>
           <a:prstGeom prst="rect">
             <a:avLst/>
@@ -21890,7 +21890,7 @@
         </p:nvSpPr>
         <p:spPr>
           <a:xfrm>
-            <a:off x="9248927" y="5279644"/>
+            <a:off x="9248927" y="5599684"/>
             <a:ext cx="2220391" cy="398780"/>
           </a:xfrm>
           <a:prstGeom prst="rect">
@@ -23973,8 +23973,8 @@
         </p:blipFill>
         <p:spPr>
           <a:xfrm>
-            <a:off x="1193227" y="1941830"/>
-            <a:ext cx="6757544" cy="3017520"/>
+            <a:off x="1193689" y="1941830"/>
+            <a:ext cx="6756620" cy="3017520"/>
           </a:xfrm>
           <a:prstGeom prst="rect">
             <a:avLst/>
@@ -31877,7 +31877,7 @@
         <p:spPr>
           <a:xfrm>
             <a:off x="502920" y="1618488"/>
-            <a:ext cx="3606698" cy="2480045"/>
+            <a:ext cx="3606698" cy="2784651"/>
           </a:xfrm>
           <a:prstGeom prst="rect">
             <a:avLst/>
@@ -31977,7 +31977,7 @@
         <p:spPr>
           <a:xfrm>
             <a:off x="630936" y="1960118"/>
-            <a:ext cx="3350666" cy="2010399"/>
+            <a:ext cx="3350666" cy="2315005"/>
           </a:xfrm>
           <a:prstGeom prst="rect">
             <a:avLst/>
@@ -31993,7 +31993,7 @@
         <p:spPr>
           <a:xfrm>
             <a:off x="4292498" y="1618488"/>
-            <a:ext cx="3606698" cy="2480045"/>
+            <a:ext cx="3606698" cy="2784651"/>
           </a:xfrm>
           <a:prstGeom prst="rect">
             <a:avLst/>
@@ -32093,7 +32093,7 @@
         <p:spPr>
           <a:xfrm>
             <a:off x="4420514" y="1960118"/>
-            <a:ext cx="3350666" cy="2010399"/>
+            <a:ext cx="3350666" cy="2315005"/>
           </a:xfrm>
           <a:prstGeom prst="rect">
             <a:avLst/>
@@ -32109,7 +32109,7 @@
         <p:spPr>
           <a:xfrm>
             <a:off x="8082076" y="1618488"/>
-            <a:ext cx="3606698" cy="2480045"/>
+            <a:ext cx="3606698" cy="2784651"/>
           </a:xfrm>
           <a:prstGeom prst="rect">
             <a:avLst/>
@@ -32209,7 +32209,7 @@
         <p:spPr>
           <a:xfrm>
             <a:off x="8210092" y="1960118"/>
-            <a:ext cx="3350666" cy="2010399"/>
+            <a:ext cx="3350666" cy="2315005"/>
           </a:xfrm>
           <a:prstGeom prst="rect">
             <a:avLst/>
@@ -32224,8 +32224,8 @@
         </p:nvSpPr>
         <p:spPr>
           <a:xfrm>
-            <a:off x="502920" y="4235693"/>
-            <a:ext cx="3606698" cy="1609852"/>
+            <a:off x="502920" y="4540299"/>
+            <a:ext cx="3606698" cy="1750772"/>
           </a:xfrm>
           <a:prstGeom prst="rect">
             <a:avLst/>
@@ -32271,7 +32271,7 @@
         </p:nvSpPr>
         <p:spPr>
           <a:xfrm>
-            <a:off x="685800" y="4418573"/>
+            <a:off x="685800" y="4723179"/>
             <a:ext cx="3240938" cy="158750"/>
           </a:xfrm>
           <a:prstGeom prst="rect">
@@ -32316,7 +32316,7 @@
         </p:nvSpPr>
         <p:spPr>
           <a:xfrm>
-            <a:off x="685800" y="4632187"/>
+            <a:off x="685800" y="4936793"/>
             <a:ext cx="3240938" cy="511810"/>
           </a:xfrm>
           <a:prstGeom prst="rect">
@@ -32372,7 +32372,7 @@
         </p:nvSpPr>
         <p:spPr>
           <a:xfrm>
-            <a:off x="685800" y="5198861"/>
+            <a:off x="685800" y="5503467"/>
             <a:ext cx="3240938" cy="408940"/>
           </a:xfrm>
           <a:prstGeom prst="rect">
@@ -32438,8 +32438,8 @@
         </p:nvSpPr>
         <p:spPr>
           <a:xfrm>
-            <a:off x="4292498" y="4235693"/>
-            <a:ext cx="3606698" cy="1609852"/>
+            <a:off x="4292498" y="4540299"/>
+            <a:ext cx="3606698" cy="1750772"/>
           </a:xfrm>
           <a:prstGeom prst="rect">
             <a:avLst/>
@@ -32485,7 +32485,7 @@
         </p:nvSpPr>
         <p:spPr>
           <a:xfrm>
-            <a:off x="4475378" y="4418573"/>
+            <a:off x="4475378" y="4723179"/>
             <a:ext cx="3240938" cy="158750"/>
           </a:xfrm>
           <a:prstGeom prst="rect">
@@ -32530,7 +32530,7 @@
         </p:nvSpPr>
         <p:spPr>
           <a:xfrm>
-            <a:off x="4475378" y="4632187"/>
+            <a:off x="4475378" y="4936793"/>
             <a:ext cx="3240938" cy="932180"/>
           </a:xfrm>
           <a:prstGeom prst="rect">
@@ -32679,8 +32679,8 @@
         </p:nvSpPr>
         <p:spPr>
           <a:xfrm>
-            <a:off x="8082076" y="4235693"/>
-            <a:ext cx="3606698" cy="1609852"/>
+            <a:off x="8082076" y="4540299"/>
+            <a:ext cx="3606698" cy="1750772"/>
           </a:xfrm>
           <a:prstGeom prst="rect">
             <a:avLst/>
@@ -32726,7 +32726,7 @@
         </p:nvSpPr>
         <p:spPr>
           <a:xfrm>
-            <a:off x="8264956" y="4418573"/>
+            <a:off x="8264956" y="4723179"/>
             <a:ext cx="3240938" cy="158750"/>
           </a:xfrm>
           <a:prstGeom prst="rect">
@@ -32771,7 +32771,7 @@
         </p:nvSpPr>
         <p:spPr>
           <a:xfrm>
-            <a:off x="8264956" y="4632187"/>
+            <a:off x="8264956" y="4936793"/>
             <a:ext cx="3240938" cy="511810"/>
           </a:xfrm>
           <a:prstGeom prst="rect">
@@ -32827,7 +32827,7 @@
         </p:nvSpPr>
         <p:spPr>
           <a:xfrm>
-            <a:off x="8264956" y="5198861"/>
+            <a:off x="8264956" y="5503467"/>
             <a:ext cx="3240938" cy="204470"/>
           </a:xfrm>
           <a:prstGeom prst="rect">
@@ -32872,7 +32872,7 @@
         </p:nvSpPr>
         <p:spPr>
           <a:xfrm>
-            <a:off x="8264956" y="5458195"/>
+            <a:off x="8264956" y="5762801"/>
             <a:ext cx="3240938" cy="204470"/>
           </a:xfrm>
           <a:prstGeom prst="rect">

</xml_diff>

<commit_message>
fix(deck): slide 11 OLS chart re-rendered (labels no longer cross the axes frame, duplicate title removed, handover bar in deck red); submission copies refreshed
Co-Authored-By: Claude Sonnet 5.5 <noreply@anthropic.com>
</commit_message>
<xml_diff>
--- a/outputs/pptx/puzzledata_repair_report.pptx
+++ b/outputs/pptx/puzzledata_repair_report.pptx
@@ -142,21 +142,21 @@
   <p:extLst>
     <p:ext uri="{521415D9-36F7-43E2-AB2F-B90AF26B5E84}">
       <p14:sectionLst xmlns:p14="http://schemas.microsoft.com/office/powerpoint/2010/main">
-        <p14:section name="Part 00 · 인트로" id="{8375A178-4210-4ED6-B4E4-3C447F628582}">
+        <p14:section name="Part 00 · 인트로" id="{DC30DD41-23B4-4C3A-9C53-77C2A2267E8D}">
           <p14:sldIdLst>
             <p14:sldId id="256"/>
             <p14:sldId id="257"/>
             <p14:sldId id="258"/>
           </p14:sldIdLst>
         </p14:section>
-        <p14:section name="Part 01 · 데이터 진단" id="{84B140B5-E073-4557-A968-529A1D184A1E}">
+        <p14:section name="Part 01 · 데이터 진단" id="{39F1D208-D008-41CD-B216-DC98744287AF}">
           <p14:sldIdLst>
             <p14:sldId id="259"/>
             <p14:sldId id="260"/>
             <p14:sldId id="261"/>
           </p14:sldIdLst>
         </p14:section>
-        <p14:section name="Part 02 · 병목 규명" id="{1567F654-1EA3-4E8A-A219-F36CF8E74EFA}">
+        <p14:section name="Part 02 · 병목 규명" id="{7E277C51-C336-4BC8-B4E9-3E56DFCBB28D}">
           <p14:sldIdLst>
             <p14:sldId id="262"/>
             <p14:sldId id="263"/>
@@ -169,14 +169,14 @@
             <p14:sldId id="270"/>
           </p14:sldIdLst>
         </p14:section>
-        <p14:section name="Part 03 · 개선 전략" id="{3ECE593B-1BDE-4D00-B46E-B237AB461F22}">
+        <p14:section name="Part 03 · 개선 전략" id="{F1A0E16B-872E-4B25-8AAB-22A282DF0F30}">
           <p14:sldIdLst>
             <p14:sldId id="271"/>
             <p14:sldId id="272"/>
             <p14:sldId id="273"/>
           </p14:sldIdLst>
         </p14:section>
-        <p14:section name="Part 04 · Q&amp;A" id="{AD9E5171-9D45-4796-9B62-2F9A55F1C85E}">
+        <p14:section name="Part 04 · Q&amp;A" id="{17B46358-B65F-43A2-9FA9-539D263377B4}">
           <p14:sldIdLst>
             <p14:sldId id="274"/>
           </p14:sldIdLst>
@@ -226,7 +226,7 @@
     </p:spTree>
     <p:extLst>
       <p:ext uri="{BB962C8B-B14F-4D97-AF65-F5344CB8AC3E}">
-        <p14:creationId xmlns:p14="http://schemas.microsoft.com/office/powerpoint/2010/main" val="635013916"/>
+        <p14:creationId xmlns:p14="http://schemas.microsoft.com/office/powerpoint/2010/main" val="1335929262"/>
       </p:ext>
     </p:extLst>
   </p:cSld>
@@ -6815,7 +6815,7 @@
         <p:spPr>
           <a:xfrm>
             <a:off x="502920" y="1554480"/>
-            <a:ext cx="7818120" cy="3836047"/>
+            <a:ext cx="7818120" cy="3876740"/>
           </a:xfrm>
           <a:prstGeom prst="rect">
             <a:avLst/>
@@ -6915,7 +6915,7 @@
         <p:spPr>
           <a:xfrm>
             <a:off x="630936" y="1896110"/>
-            <a:ext cx="7562088" cy="3366401"/>
+            <a:ext cx="7562088" cy="3407094"/>
           </a:xfrm>
           <a:prstGeom prst="rect">
             <a:avLst/>
@@ -6931,7 +6931,7 @@
         <p:spPr>
           <a:xfrm>
             <a:off x="8503920" y="1554480"/>
-            <a:ext cx="3184855" cy="1205530"/>
+            <a:ext cx="3184855" cy="1219094"/>
           </a:xfrm>
           <a:prstGeom prst="rect">
             <a:avLst/>
@@ -7123,8 +7123,8 @@
         </p:nvSpPr>
         <p:spPr>
           <a:xfrm>
-            <a:off x="8503920" y="2869738"/>
-            <a:ext cx="3184855" cy="1205530"/>
+            <a:off x="8503920" y="2883302"/>
+            <a:ext cx="3184855" cy="1219094"/>
           </a:xfrm>
           <a:prstGeom prst="rect">
             <a:avLst/>
@@ -7170,7 +7170,7 @@
         </p:nvSpPr>
         <p:spPr>
           <a:xfrm>
-            <a:off x="8686800" y="3052618"/>
+            <a:off x="8686800" y="3066182"/>
             <a:ext cx="2819095" cy="158750"/>
           </a:xfrm>
           <a:prstGeom prst="rect">
@@ -7215,7 +7215,7 @@
         </p:nvSpPr>
         <p:spPr>
           <a:xfrm>
-            <a:off x="8686800" y="3266232"/>
+            <a:off x="8686800" y="3279796"/>
             <a:ext cx="2819095" cy="341630"/>
           </a:xfrm>
           <a:prstGeom prst="rect">
@@ -7271,7 +7271,7 @@
         </p:nvSpPr>
         <p:spPr>
           <a:xfrm>
-            <a:off x="8686800" y="3662726"/>
+            <a:off x="8686800" y="3676290"/>
             <a:ext cx="2819095" cy="195580"/>
           </a:xfrm>
           <a:prstGeom prst="rect">
@@ -7316,8 +7316,8 @@
         </p:nvSpPr>
         <p:spPr>
           <a:xfrm>
-            <a:off x="8503920" y="4184997"/>
-            <a:ext cx="3184855" cy="1205530"/>
+            <a:off x="8503920" y="4212125"/>
+            <a:ext cx="3184855" cy="1219094"/>
           </a:xfrm>
           <a:prstGeom prst="rect">
             <a:avLst/>
@@ -7363,7 +7363,7 @@
         </p:nvSpPr>
         <p:spPr>
           <a:xfrm>
-            <a:off x="8686800" y="4367877"/>
+            <a:off x="8686800" y="4395005"/>
             <a:ext cx="2819095" cy="158750"/>
           </a:xfrm>
           <a:prstGeom prst="rect">
@@ -7408,7 +7408,7 @@
         </p:nvSpPr>
         <p:spPr>
           <a:xfrm>
-            <a:off x="8686800" y="4581491"/>
+            <a:off x="8686800" y="4608619"/>
             <a:ext cx="2819095" cy="341630"/>
           </a:xfrm>
           <a:prstGeom prst="rect">
@@ -7464,7 +7464,7 @@
         </p:nvSpPr>
         <p:spPr>
           <a:xfrm>
-            <a:off x="8686800" y="4977985"/>
+            <a:off x="8686800" y="5005113"/>
             <a:ext cx="2819095" cy="195580"/>
           </a:xfrm>
           <a:prstGeom prst="rect">
@@ -7509,8 +7509,8 @@
         </p:nvSpPr>
         <p:spPr>
           <a:xfrm>
-            <a:off x="502920" y="5527687"/>
-            <a:ext cx="11185855" cy="763384"/>
+            <a:off x="502920" y="5568380"/>
+            <a:ext cx="11185855" cy="722691"/>
           </a:xfrm>
           <a:prstGeom prst="rect">
             <a:avLst/>
@@ -7556,7 +7556,7 @@
         </p:nvSpPr>
         <p:spPr>
           <a:xfrm>
-            <a:off x="685800" y="5710567"/>
+            <a:off x="685800" y="5751260"/>
             <a:ext cx="10820095" cy="222250"/>
           </a:xfrm>
           <a:prstGeom prst="rect">

</xml_diff>